<commit_message>
Rename tri-binary terminology to Noether braid
</commit_message>
<xml_diff>
--- a/reference/archie/presentations/NPQG Fundamentals - Paths.pptx
+++ b/reference/archie/presentations/NPQG Fundamentals - Paths.pptx
@@ -6,7 +6,7 @@
     <p:sldMasterId id="2147483664" r:id="rId2"/>
   </p:sldMasterIdLst>
   <p:notesMasterIdLst>
-    <p:notesMasterId r:id="rId23"/>
+    <p:notesMasterId r:id="rId21"/>
   </p:notesMasterIdLst>
   <p:sldIdLst>
     <p:sldId id="890" r:id="rId3"/>
@@ -27,8 +27,6 @@
     <p:sldId id="885" r:id="rId18"/>
     <p:sldId id="886" r:id="rId19"/>
     <p:sldId id="887" r:id="rId20"/>
-    <p:sldId id="888" r:id="rId21"/>
-    <p:sldId id="853" r:id="rId22"/>
   </p:sldIdLst>
   <p:sldSz cx="12192000" cy="6858000"/>
   <p:notesSz cx="6858000" cy="9144000"/>
@@ -228,7 +226,7 @@
           <a:p>
             <a:fld id="{BBBDA440-6FDE-5E41-BA40-A3C0E02BAB9F}" type="datetimeFigureOut">
               <a:rPr lang="en-US" smtClean="0"/>
-              <a:t>11/27/24</a:t>
+              <a:t>7/3/26</a:t>
             </a:fld>
             <a:endParaRPr lang="en-US"/>
           </a:p>
@@ -814,7 +812,7 @@
                 <a:ea typeface="Helvetica Neue" panose="02000503000000020004" pitchFamily="2" charset="0"/>
                 <a:cs typeface="Helvetica Neue" panose="02000503000000020004" pitchFamily="2" charset="0"/>
               </a:rPr>
-              <a:t>Essentially every point potential is continuously riding on the wake emitted by every other point potential in the past.  </a:t>
+              <a:t>Essentially every architrino is continuously riding on the wake emitted by every other architrino in the past.  </a:t>
             </a:r>
             <a:br>
               <a:rPr lang="en-US" sz="9600" b="1" dirty="0">
@@ -829,7 +827,7 @@
                 <a:ea typeface="Helvetica Neue" panose="02000503000000020004" pitchFamily="2" charset="0"/>
                 <a:cs typeface="Helvetica Neue" panose="02000503000000020004" pitchFamily="2" charset="0"/>
               </a:rPr>
-              <a:t>They may also be riding on their own wake if v &gt; @. </a:t>
+              <a:t>They may also be riding on their own wake if v &gt; c_f. </a:t>
             </a:r>
             <a:br>
               <a:rPr lang="en-US" sz="9600" b="1" dirty="0">
@@ -844,7 +842,7 @@
                 <a:ea typeface="Helvetica Neue" panose="02000503000000020004" pitchFamily="2" charset="0"/>
                 <a:cs typeface="Helvetica Neue" panose="02000503000000020004" pitchFamily="2" charset="0"/>
               </a:rPr>
-              <a:t>For each partner that has operated at v&gt;@ a point potential may encounter multiple of their wakes or a continuous stretch of wake?  </a:t>
+              <a:t>For each partner that has operated at v&gt;c_f a architrino may encounter multiple of their wakes or a continuous stretch of wake?  </a:t>
             </a:r>
             <a:br>
               <a:rPr lang="en-US" sz="9600" b="1" dirty="0">
@@ -1285,7 +1283,7 @@
                 <a:effectLst/>
                 <a:latin typeface="Helvetica Neue" panose="02000503000000020004" pitchFamily="2" charset="0"/>
               </a:rPr>
-              <a:t>Let's start by looking at the influence that point charge A has on point charge B at time t.</a:t>
+              <a:t>Let's start by looking at the influence that point architrino A has on point architrino B at time t.</a:t>
             </a:r>
           </a:p>
           <a:p>
@@ -1302,7 +1300,7 @@
                 <a:effectLst/>
                 <a:latin typeface="Helvetica Neue" panose="02000503000000020004" pitchFamily="2" charset="0"/>
               </a:rPr>
-              <a:t>What we see is that at time t', point charge A has emitted potential that expands spherically and intersects point charge B at time t.</a:t>
+              <a:t>What we see is that at time t', point architrino A has emitted potential that expands spherically and intersects point architrino B at time t.</a:t>
             </a:r>
           </a:p>
           <a:p>
@@ -1503,7 +1501,7 @@
                 <a:effectLst/>
                 <a:latin typeface="Helvetica Neue" panose="02000503000000020004" pitchFamily="2" charset="0"/>
               </a:rPr>
-              <a:t>In our example, point charge A emitted a potential wave at time t' that resulted in action on point charge B at time t. That action influences B's path. Yet B is also continuously emitting potential. So when B's path changes that will be reflected in the potential wave it emits. This wave then results in action on point charge A when they intersect. This dynamical feedback is continuous between both point charges in our example, and in the universe between all point charges.  </a:t>
+              <a:t>In our example, point architrino A emitted a potential wave at time t' that resulted in action on point architrino B at time t. That action influences B's path. Yet B is also continuously emitting potential. So when B's path changes that will be reflected in the potential wave it emits. This wave then results in action on point architrino A when they intersect. This dynamical feedback is continuous between both point charges in our example, and in the universe between all point charges.  </a:t>
             </a:r>
           </a:p>
           <a:p>
@@ -3205,7 +3203,7 @@
                 <a:effectLst/>
                 <a:latin typeface="Helvetica Neue" panose="02000503000000020004" pitchFamily="2" charset="0"/>
               </a:rPr>
-              <a:t>Let's start by looking at the influence that point charge A has on point charge B at time t.</a:t>
+              <a:t>Let's start by looking at the influence that point architrino A has on point architrino B at time t.</a:t>
             </a:r>
           </a:p>
           <a:p>
@@ -3222,7 +3220,7 @@
                 <a:effectLst/>
                 <a:latin typeface="Helvetica Neue" panose="02000503000000020004" pitchFamily="2" charset="0"/>
               </a:rPr>
-              <a:t>What we see is that at time t', point charge A has emitted potential that expands spherically and intersects point charge B at time t.</a:t>
+              <a:t>What we see is that at time t', point architrino A has emitted potential that expands spherically and intersects point architrino B at time t.</a:t>
             </a:r>
           </a:p>
           <a:p>
@@ -3423,7 +3421,7 @@
                 <a:effectLst/>
                 <a:latin typeface="Helvetica Neue" panose="02000503000000020004" pitchFamily="2" charset="0"/>
               </a:rPr>
-              <a:t>In our example, point charge A emitted a potential wave at time t' that resulted in action on point charge B at time t. That action influences B's path. Yet B is also continuously emitting potential. So when B's path changes that will be reflected in the potential wave it emits. This wave then results in action on point charge A when they intersect. This dynamical feedback is continuous between both point charges in our example, and in the universe between all point charges.  </a:t>
+              <a:t>In our example, point architrino A emitted a potential wave at time t' that resulted in action on point architrino B at time t. That action influences B's path. Yet B is also continuously emitting potential. So when B's path changes that will be reflected in the potential wave it emits. This wave then results in action on point architrino A when they intersect. This dynamical feedback is continuous between both point charges in our example, and in the universe between all point charges.  </a:t>
             </a:r>
           </a:p>
           <a:p>
@@ -3751,7 +3749,7 @@
                 <a:ea typeface="Helvetica Neue" panose="02000503000000020004" pitchFamily="2" charset="0"/>
                 <a:cs typeface="Helvetica Neue" panose="02000503000000020004" pitchFamily="2" charset="0"/>
               </a:rPr>
-              <a:t>Essentially every point potential is continuously riding on the wake emitted by every other point potential in the past.  </a:t>
+              <a:t>Essentially every architrino is continuously riding on the wake emitted by every other architrino in the past.  </a:t>
             </a:r>
             <a:br>
               <a:rPr lang="en-US" sz="9600" b="1" dirty="0">
@@ -3766,7 +3764,7 @@
                 <a:ea typeface="Helvetica Neue" panose="02000503000000020004" pitchFamily="2" charset="0"/>
                 <a:cs typeface="Helvetica Neue" panose="02000503000000020004" pitchFamily="2" charset="0"/>
               </a:rPr>
-              <a:t>They may also be riding on their own wake if v &gt; @. </a:t>
+              <a:t>They may also be riding on their own wake if v &gt; c_f. </a:t>
             </a:r>
             <a:br>
               <a:rPr lang="en-US" sz="9600" b="1" dirty="0">
@@ -3781,7 +3779,7 @@
                 <a:ea typeface="Helvetica Neue" panose="02000503000000020004" pitchFamily="2" charset="0"/>
                 <a:cs typeface="Helvetica Neue" panose="02000503000000020004" pitchFamily="2" charset="0"/>
               </a:rPr>
-              <a:t>For each partner that has operated at v&gt;@ a point potential may encounter multiple of their wakes or a continuous stretch of wake?  </a:t>
+              <a:t>For each partner that has operated at v&gt;c_f a architrino may encounter multiple of their wakes or a continuous stretch of wake?  </a:t>
             </a:r>
             <a:br>
               <a:rPr lang="en-US" sz="9600" b="1" dirty="0">
@@ -4095,7 +4093,7 @@
           <a:p>
             <a:fld id="{CB70D3E6-D921-5B44-AC8D-B7FDAFC8A532}" type="datetimeFigureOut">
               <a:rPr lang="en-US" smtClean="0"/>
-              <a:t>11/27/24</a:t>
+              <a:t>7/3/26</a:t>
             </a:fld>
             <a:endParaRPr lang="en-US"/>
           </a:p>
@@ -4293,7 +4291,7 @@
           <a:p>
             <a:fld id="{CB70D3E6-D921-5B44-AC8D-B7FDAFC8A532}" type="datetimeFigureOut">
               <a:rPr lang="en-US" smtClean="0"/>
-              <a:t>11/27/24</a:t>
+              <a:t>7/3/26</a:t>
             </a:fld>
             <a:endParaRPr lang="en-US"/>
           </a:p>
@@ -4501,7 +4499,7 @@
           <a:p>
             <a:fld id="{CB70D3E6-D921-5B44-AC8D-B7FDAFC8A532}" type="datetimeFigureOut">
               <a:rPr lang="en-US" smtClean="0"/>
-              <a:t>11/27/24</a:t>
+              <a:t>7/3/26</a:t>
             </a:fld>
             <a:endParaRPr lang="en-US"/>
           </a:p>
@@ -4721,7 +4719,7 @@
           <a:p>
             <a:fld id="{B1CFC895-F8E0-4049-8BEE-E5499394E46C}" type="datetime1">
               <a:rPr lang="en-US" smtClean="0"/>
-              <a:t>11/27/24</a:t>
+              <a:t>7/3/26</a:t>
             </a:fld>
             <a:endParaRPr lang="en-US"/>
           </a:p>
@@ -4936,7 +4934,7 @@
           <a:p>
             <a:fld id="{A91F55E2-A889-F24B-B1FE-1E878178F308}" type="datetime1">
               <a:rPr lang="en-US" smtClean="0"/>
-              <a:t>11/27/24</a:t>
+              <a:t>7/3/26</a:t>
             </a:fld>
             <a:endParaRPr lang="en-US"/>
           </a:p>
@@ -5085,7 +5083,7 @@
           <a:p>
             <a:fld id="{C6E8461C-3391-334C-9885-001B32D724C4}" type="datetime1">
               <a:rPr lang="en-US" smtClean="0"/>
-              <a:t>11/27/24</a:t>
+              <a:t>7/3/26</a:t>
             </a:fld>
             <a:endParaRPr lang="en-US"/>
           </a:p>
@@ -5290,7 +5288,7 @@
           <a:p>
             <a:fld id="{CB70D3E6-D921-5B44-AC8D-B7FDAFC8A532}" type="datetimeFigureOut">
               <a:rPr lang="en-US" smtClean="0"/>
-              <a:t>11/27/24</a:t>
+              <a:t>7/3/26</a:t>
             </a:fld>
             <a:endParaRPr lang="en-US"/>
           </a:p>
@@ -5565,7 +5563,7 @@
           <a:p>
             <a:fld id="{CB70D3E6-D921-5B44-AC8D-B7FDAFC8A532}" type="datetimeFigureOut">
               <a:rPr lang="en-US" smtClean="0"/>
-              <a:t>11/27/24</a:t>
+              <a:t>7/3/26</a:t>
             </a:fld>
             <a:endParaRPr lang="en-US"/>
           </a:p>
@@ -5830,7 +5828,7 @@
           <a:p>
             <a:fld id="{CB70D3E6-D921-5B44-AC8D-B7FDAFC8A532}" type="datetimeFigureOut">
               <a:rPr lang="en-US" smtClean="0"/>
-              <a:t>11/27/24</a:t>
+              <a:t>7/3/26</a:t>
             </a:fld>
             <a:endParaRPr lang="en-US"/>
           </a:p>
@@ -6242,7 +6240,7 @@
           <a:p>
             <a:fld id="{CB70D3E6-D921-5B44-AC8D-B7FDAFC8A532}" type="datetimeFigureOut">
               <a:rPr lang="en-US" smtClean="0"/>
-              <a:t>11/27/24</a:t>
+              <a:t>7/3/26</a:t>
             </a:fld>
             <a:endParaRPr lang="en-US"/>
           </a:p>
@@ -6383,7 +6381,7 @@
           <a:p>
             <a:fld id="{CB70D3E6-D921-5B44-AC8D-B7FDAFC8A532}" type="datetimeFigureOut">
               <a:rPr lang="en-US" smtClean="0"/>
-              <a:t>11/27/24</a:t>
+              <a:t>7/3/26</a:t>
             </a:fld>
             <a:endParaRPr lang="en-US"/>
           </a:p>
@@ -6496,7 +6494,7 @@
           <a:p>
             <a:fld id="{CB70D3E6-D921-5B44-AC8D-B7FDAFC8A532}" type="datetimeFigureOut">
               <a:rPr lang="en-US" smtClean="0"/>
-              <a:t>11/27/24</a:t>
+              <a:t>7/3/26</a:t>
             </a:fld>
             <a:endParaRPr lang="en-US"/>
           </a:p>
@@ -6807,7 +6805,7 @@
           <a:p>
             <a:fld id="{CB70D3E6-D921-5B44-AC8D-B7FDAFC8A532}" type="datetimeFigureOut">
               <a:rPr lang="en-US" smtClean="0"/>
-              <a:t>11/27/24</a:t>
+              <a:t>7/3/26</a:t>
             </a:fld>
             <a:endParaRPr lang="en-US"/>
           </a:p>
@@ -7095,7 +7093,7 @@
           <a:p>
             <a:fld id="{CB70D3E6-D921-5B44-AC8D-B7FDAFC8A532}" type="datetimeFigureOut">
               <a:rPr lang="en-US" smtClean="0"/>
-              <a:t>11/27/24</a:t>
+              <a:t>7/3/26</a:t>
             </a:fld>
             <a:endParaRPr lang="en-US"/>
           </a:p>
@@ -7336,7 +7334,7 @@
           <a:p>
             <a:fld id="{CB70D3E6-D921-5B44-AC8D-B7FDAFC8A532}" type="datetimeFigureOut">
               <a:rPr lang="en-US" smtClean="0"/>
-              <a:t>11/27/24</a:t>
+              <a:t>7/3/26</a:t>
             </a:fld>
             <a:endParaRPr lang="en-US"/>
           </a:p>
@@ -7907,7 +7905,7 @@
           <a:p>
             <a:fld id="{2005EE61-3907-C44D-8624-D47E09E871DB}" type="datetime1">
               <a:rPr lang="en-US" smtClean="0"/>
-              <a:t>11/27/24</a:t>
+              <a:t>7/3/26</a:t>
             </a:fld>
             <a:endParaRPr lang="en-US"/>
           </a:p>
@@ -8355,8 +8353,8 @@
         </p:nvSpPr>
         <p:spPr>
           <a:xfrm>
-            <a:off x="0" y="358254"/>
-            <a:ext cx="12191999" cy="4067780"/>
+            <a:off x="0" y="350233"/>
+            <a:ext cx="12191999" cy="5350183"/>
           </a:xfrm>
           <a:prstGeom prst="rect">
             <a:avLst/>
@@ -8386,23 +8384,7 @@
               <a:tabLst/>
               <a:defRPr/>
             </a:pPr>
-            <a:r>
-              <a:rPr kumimoji="0" lang="en-US" sz="11500" b="0" i="0" u="none" strike="noStrike" kern="1200" cap="none" spc="0" normalizeH="0" baseline="0" noProof="0" dirty="0">
-                <a:ln>
-                  <a:noFill/>
-                </a:ln>
-                <a:solidFill>
-                  <a:prstClr val="white"/>
-                </a:solidFill>
-                <a:effectLst/>
-                <a:uLnTx/>
-                <a:uFillTx/>
-                <a:latin typeface="Helvetica Neue UltraLight" panose="02000206000000020004" pitchFamily="2" charset="0"/>
-                <a:ea typeface="Helvetica Neue UltraLight" panose="02000206000000020004" pitchFamily="2" charset="0"/>
-                <a:cs typeface="Helvetica Neue" panose="02000503000000020004" pitchFamily="2" charset="0"/>
-              </a:rPr>
-              <a:t>neoclassical.ai</a:t>
-            </a:r>
+            <a:endParaRPr/>
           </a:p>
           <a:p>
             <a:pPr marL="0" marR="0" lvl="0" indent="0" algn="ctr" defTabSz="914400" rtl="0" eaLnBrk="1" fontAlgn="auto" latinLnBrk="0" hangingPunct="1">
@@ -8437,7 +8419,43 @@
                 <a:ea typeface="Helvetica Neue Condensed Black" panose="02000503000000020004" pitchFamily="2" charset="0"/>
                 <a:cs typeface="Helvetica Neue Condensed Black" panose="02000503000000020004" pitchFamily="2" charset="0"/>
               </a:rPr>
-              <a:t>The Paths of </a:t>
+              <a:t>Architrino Paths</a:t>
+            </a:r>
+          </a:p>
+          <a:p>
+            <a:pPr marL="0" marR="0" lvl="0" indent="0" algn="ctr" defTabSz="914400" rtl="0" eaLnBrk="1" fontAlgn="auto" latinLnBrk="0" hangingPunct="1">
+              <a:lnSpc>
+                <a:spcPts val="10000"/>
+              </a:lnSpc>
+              <a:spcBef>
+                <a:spcPts val="0"/>
+              </a:spcBef>
+              <a:spcAft>
+                <a:spcPts val="0"/>
+              </a:spcAft>
+              <a:buClrTx/>
+              <a:buSzTx/>
+              <a:buFontTx/>
+              <a:buNone/>
+              <a:tabLst/>
+              <a:defRPr/>
+            </a:pPr>
+            <a:r>
+              <a:rPr kumimoji="0" lang="en-US" sz="9600" b="1" i="0" u="none" strike="noStrike" kern="1200" cap="none" spc="0" normalizeH="0" baseline="0" noProof="0" dirty="0">
+                <a:ln>
+                  <a:noFill/>
+                </a:ln>
+                <a:solidFill>
+                  <a:srgbClr val="FFC000"/>
+                </a:solidFill>
+                <a:effectLst/>
+                <a:uLnTx/>
+                <a:uFillTx/>
+                <a:latin typeface="Helvetica Neue Condensed Black" panose="02000503000000020004" pitchFamily="2" charset="0"/>
+                <a:ea typeface="Helvetica Neue Condensed Black" panose="02000503000000020004" pitchFamily="2" charset="0"/>
+                <a:cs typeface="Helvetica Neue Condensed Black" panose="02000503000000020004" pitchFamily="2" charset="0"/>
+              </a:rPr>
+              <a:t>and Causal Wakes</a:t>
             </a:r>
             <a:br>
               <a:rPr kumimoji="0" lang="en-US" sz="9600" b="1" i="0" u="none" strike="noStrike" kern="1200" cap="none" spc="0" normalizeH="0" baseline="0" noProof="0" dirty="0">
@@ -8455,23 +8473,20 @@
                 <a:cs typeface="Helvetica Neue Condensed Black" panose="02000503000000020004" pitchFamily="2" charset="0"/>
               </a:rPr>
             </a:br>
-            <a:r>
-              <a:rPr kumimoji="0" lang="en-US" sz="9600" b="1" i="0" u="none" strike="noStrike" kern="1200" cap="none" spc="0" normalizeH="0" baseline="0" noProof="0" dirty="0">
-                <a:ln>
-                  <a:noFill/>
-                </a:ln>
-                <a:solidFill>
-                  <a:srgbClr val="FFC000"/>
-                </a:solidFill>
-                <a:effectLst/>
-                <a:uLnTx/>
-                <a:uFillTx/>
-                <a:latin typeface="Helvetica Neue Condensed Black" panose="02000503000000020004" pitchFamily="2" charset="0"/>
-                <a:ea typeface="Helvetica Neue Condensed Black" panose="02000503000000020004" pitchFamily="2" charset="0"/>
-                <a:cs typeface="Helvetica Neue Condensed Black" panose="02000503000000020004" pitchFamily="2" charset="0"/>
-              </a:rPr>
-              <a:t>Point Potentials</a:t>
-            </a:r>
+            <a:endParaRPr kumimoji="0" lang="en-US" sz="9600" b="1" i="0" u="none" strike="noStrike" kern="1200" cap="none" spc="0" normalizeH="0" baseline="0" noProof="0" dirty="0">
+              <a:ln>
+                <a:noFill/>
+              </a:ln>
+              <a:solidFill>
+                <a:srgbClr val="FFC000"/>
+              </a:solidFill>
+              <a:effectLst/>
+              <a:uLnTx/>
+              <a:uFillTx/>
+              <a:latin typeface="Helvetica Neue Condensed Black" panose="02000503000000020004" pitchFamily="2" charset="0"/>
+              <a:ea typeface="Helvetica Neue Condensed Black" panose="02000503000000020004" pitchFamily="2" charset="0"/>
+              <a:cs typeface="Helvetica Neue Condensed Black" panose="02000503000000020004" pitchFamily="2" charset="0"/>
+            </a:endParaRPr>
           </a:p>
         </p:txBody>
       </p:sp>
@@ -11112,7 +11127,7 @@
                 <a:ea typeface="Helvetica Neue" panose="02000503000000020004" pitchFamily="2" charset="0"/>
                 <a:cs typeface="Helvetica Neue" panose="02000503000000020004" pitchFamily="2" charset="0"/>
               </a:rPr>
-              <a:t>It is fascinating to conceptualize continuous feedback with a delay.</a:t>
+              <a:t>Causal-delay feedback is continuous.</a:t>
             </a:r>
           </a:p>
           <a:p>
@@ -11137,7 +11152,7 @@
                 <a:ea typeface="Helvetica Neue" panose="02000503000000020004" pitchFamily="2" charset="0"/>
                 <a:cs typeface="Helvetica Neue" panose="02000503000000020004" pitchFamily="2" charset="0"/>
               </a:rPr>
-              <a:t>Action upon A changes A’s path which changes the sphere stream A emits.  </a:t>
+              <a:t>A hit on A changes A's path, which changes the causal wakes A emits.</a:t>
             </a:r>
           </a:p>
           <a:p>
@@ -11162,7 +11177,7 @@
                 <a:ea typeface="Helvetica Neue" panose="02000503000000020004" pitchFamily="2" charset="0"/>
                 <a:cs typeface="Helvetica Neue" panose="02000503000000020004" pitchFamily="2" charset="0"/>
               </a:rPr>
-              <a:t>After a travel time, which is also path dependent, action will occur at B and change B’s path. </a:t>
+              <a:t>After a path-dependent travel time, those wakes can hit B and change B's path.</a:t>
             </a:r>
           </a:p>
           <a:p>
@@ -11187,7 +11202,7 @@
                 <a:ea typeface="Helvetica Neue" panose="02000503000000020004" pitchFamily="2" charset="0"/>
                 <a:cs typeface="Helvetica Neue" panose="02000503000000020004" pitchFamily="2" charset="0"/>
               </a:rPr>
-              <a:t>And so on. This is all continuous feedback.</a:t>
+              <a:t>The coupled result is path-history feedback.</a:t>
             </a:r>
           </a:p>
         </p:txBody>
@@ -11425,7 +11440,7 @@
                 <a:ea typeface="Helvetica Neue" panose="02000503000000020004" pitchFamily="2" charset="0"/>
                 <a:cs typeface="Helvetica Neue" panose="02000503000000020004" pitchFamily="2" charset="0"/>
               </a:rPr>
-              <a:t>Point Potential Path History and Action</a:t>
+              <a:t>Architrino Path History and Wake Hits</a:t>
             </a:r>
             <a:endParaRPr lang="en-US" sz="2800" b="1" baseline="30000" dirty="0">
               <a:solidFill>
@@ -11606,7 +11621,7 @@
                   <a:ea typeface="Helvetica Neue" panose="02000503000000020004" pitchFamily="2" charset="0"/>
                   <a:cs typeface="Helvetica Neue" panose="02000503000000020004" pitchFamily="2" charset="0"/>
                 </a:rPr>
-                <a:t>Absolute Euclidean Time</a:t>
+                <a:t>Absolute Time</a:t>
               </a:r>
             </a:p>
           </p:txBody>
@@ -11638,42 +11653,6 @@
               <a:spAutoFit/>
             </a:bodyPr>
             <a:lstStyle/>
-            <a:p>
-              <a:pPr marL="0" marR="0" lvl="0" indent="0" algn="ctr" defTabSz="914400" rtl="0" eaLnBrk="1" fontAlgn="auto" latinLnBrk="0" hangingPunct="1">
-                <a:lnSpc>
-                  <a:spcPct val="100000"/>
-                </a:lnSpc>
-                <a:spcBef>
-                  <a:spcPts val="0"/>
-                </a:spcBef>
-                <a:spcAft>
-                  <a:spcPts val="0"/>
-                </a:spcAft>
-                <a:buClrTx/>
-                <a:buSzTx/>
-                <a:buFontTx/>
-                <a:buNone/>
-                <a:tabLst/>
-                <a:defRPr/>
-              </a:pPr>
-              <a:r>
-                <a:rPr kumimoji="0" lang="en-US" sz="1800" b="0" i="0" u="none" strike="noStrike" kern="1200" cap="none" spc="0" normalizeH="0" baseline="0" noProof="0" dirty="0">
-                  <a:ln>
-                    <a:noFill/>
-                  </a:ln>
-                  <a:solidFill>
-                    <a:prstClr val="white"/>
-                  </a:solidFill>
-                  <a:effectLst/>
-                  <a:uLnTx/>
-                  <a:uFillTx/>
-                  <a:latin typeface="Helvetica Neue" panose="02000503000000020004" pitchFamily="2" charset="0"/>
-                  <a:ea typeface="Helvetica Neue" panose="02000503000000020004" pitchFamily="2" charset="0"/>
-                  <a:cs typeface="Helvetica Neue" panose="02000503000000020004" pitchFamily="2" charset="0"/>
-                </a:rPr>
-                <a:t>Absolute </a:t>
-              </a:r>
-            </a:p>
             <a:p>
               <a:pPr marL="0" marR="0" lvl="0" indent="0" algn="ctr" defTabSz="914400" rtl="0" eaLnBrk="1" fontAlgn="auto" latinLnBrk="0" hangingPunct="1">
                 <a:lnSpc>
@@ -11743,7 +11722,7 @@
                   <a:ea typeface="Helvetica Neue" panose="02000503000000020004" pitchFamily="2" charset="0"/>
                   <a:cs typeface="Helvetica Neue" panose="02000503000000020004" pitchFamily="2" charset="0"/>
                 </a:rPr>
-                <a:t>3D Space</a:t>
+                <a:t>Void</a:t>
               </a:r>
             </a:p>
           </p:txBody>
@@ -12009,7 +11988,7 @@
                 <a:ea typeface="Helvetica Neue" panose="02000503000000020004" pitchFamily="2" charset="0"/>
                 <a:cs typeface="Helvetica Neue" panose="02000503000000020004" pitchFamily="2" charset="0"/>
               </a:rPr>
-              <a:t>Absolute </a:t>
+              <a:t>Euclidean</a:t>
             </a:r>
           </a:p>
           <a:p>
@@ -12045,43 +12024,7 @@
                 <a:ea typeface="Helvetica Neue" panose="02000503000000020004" pitchFamily="2" charset="0"/>
                 <a:cs typeface="Helvetica Neue" panose="02000503000000020004" pitchFamily="2" charset="0"/>
               </a:rPr>
-              <a:t>Euclidean</a:t>
-            </a:r>
-          </a:p>
-          <a:p>
-            <a:pPr marL="0" marR="0" lvl="0" indent="0" algn="ctr" defTabSz="914400" rtl="0" eaLnBrk="1" fontAlgn="auto" latinLnBrk="0" hangingPunct="1">
-              <a:lnSpc>
-                <a:spcPct val="100000"/>
-              </a:lnSpc>
-              <a:spcBef>
-                <a:spcPts val="0"/>
-              </a:spcBef>
-              <a:spcAft>
-                <a:spcPts val="0"/>
-              </a:spcAft>
-              <a:buClrTx/>
-              <a:buSzTx/>
-              <a:buFontTx/>
-              <a:buNone/>
-              <a:tabLst/>
-              <a:defRPr/>
-            </a:pPr>
-            <a:r>
-              <a:rPr kumimoji="0" lang="en-US" sz="1800" b="0" i="0" u="none" strike="noStrike" kern="1200" cap="none" spc="0" normalizeH="0" baseline="0" noProof="0" dirty="0">
-                <a:ln>
-                  <a:noFill/>
-                </a:ln>
-                <a:solidFill>
-                  <a:prstClr val="white"/>
-                </a:solidFill>
-                <a:effectLst/>
-                <a:uLnTx/>
-                <a:uFillTx/>
-                <a:latin typeface="Helvetica Neue" panose="02000503000000020004" pitchFamily="2" charset="0"/>
-                <a:ea typeface="Helvetica Neue" panose="02000503000000020004" pitchFamily="2" charset="0"/>
-                <a:cs typeface="Helvetica Neue" panose="02000503000000020004" pitchFamily="2" charset="0"/>
-              </a:rPr>
-              <a:t>3D Space</a:t>
+              <a:t>Void</a:t>
             </a:r>
           </a:p>
         </p:txBody>
@@ -14042,7 +13985,7 @@
                 <a:ea typeface="Helvetica Neue" panose="02000503000000020004" pitchFamily="2" charset="0"/>
                 <a:cs typeface="Helvetica Neue" panose="02000503000000020004" pitchFamily="2" charset="0"/>
               </a:rPr>
-              <a:t>The potential  emitted by A at time t’ causes action upon intersecting B at time t.</a:t>
+              <a:t>The causal wake emitted by A at time t' hits B at time t.</a:t>
             </a:r>
             <a:endParaRPr kumimoji="0" lang="en-US" sz="1800" b="0" i="0" u="none" strike="noStrike" kern="1200" cap="none" spc="0" normalizeH="0" baseline="0" noProof="0" dirty="0">
               <a:ln>
@@ -14633,7 +14576,7 @@
                 <a:ea typeface="Helvetica Neue" panose="02000503000000020004" pitchFamily="2" charset="0"/>
                 <a:cs typeface="Helvetica Neue" panose="02000503000000020004" pitchFamily="2" charset="0"/>
               </a:rPr>
-              <a:t>Point Potential Path History and Action</a:t>
+              <a:t>Architrino Path History and Wake Hits</a:t>
             </a:r>
             <a:endParaRPr lang="en-US" sz="2800" b="1" baseline="30000" dirty="0">
               <a:solidFill>
@@ -14814,7 +14757,7 @@
                   <a:ea typeface="Helvetica Neue" panose="02000503000000020004" pitchFamily="2" charset="0"/>
                   <a:cs typeface="Helvetica Neue" panose="02000503000000020004" pitchFamily="2" charset="0"/>
                 </a:rPr>
-                <a:t>Absolute Euclidean Time</a:t>
+                <a:t>Absolute Time</a:t>
               </a:r>
             </a:p>
           </p:txBody>
@@ -14873,7 +14816,7 @@
         <p:spPr>
           <a:xfrm>
             <a:off x="2821353" y="1411102"/>
-            <a:ext cx="9253416" cy="5078313"/>
+            <a:ext cx="9253416" cy="3693319"/>
           </a:xfrm>
           <a:prstGeom prst="rect">
             <a:avLst/>
@@ -14918,33 +14861,24 @@
                 <a:ea typeface="Helvetica Neue" panose="02000503000000020004" pitchFamily="2" charset="0"/>
                 <a:cs typeface="Helvetica Neue" panose="02000503000000020004" pitchFamily="2" charset="0"/>
               </a:rPr>
-              <a:t>A 1D Euclidean line with exactly two (2) point potentials emitters and field speed @</a:t>
+              <a:t>A 1D Euclidean-void line with two architrino emitters and wake speed c_f.</a:t>
             </a:r>
           </a:p>
           <a:p>
-            <a:pPr marL="0" marR="0" lvl="0" indent="0" algn="l" defTabSz="914400" rtl="0" eaLnBrk="1" fontAlgn="auto" latinLnBrk="0" hangingPunct="1">
-              <a:lnSpc>
-                <a:spcPct val="100000"/>
-              </a:lnSpc>
-              <a:spcBef>
-                <a:spcPts val="0"/>
-              </a:spcBef>
-              <a:spcAft>
-                <a:spcPts val="0"/>
-              </a:spcAft>
-              <a:buClrTx/>
-              <a:buSzTx/>
-              <a:buFontTx/>
-              <a:buNone/>
-              <a:tabLst/>
-              <a:defRPr/>
-            </a:pPr>
+            <a:r>
+              <a:rPr>
+                <a:solidFill>
+                  <a:schemeClr val="bg1"/>
+                </a:solidFill>
+              </a:rPr>
+              <a:t>The binary symmetry point occurs when architrino speed |v| = c_f.</a:t>
+            </a:r>
             <a:endParaRPr kumimoji="0" lang="en-US" sz="1800" b="0" i="0" u="none" strike="noStrike" kern="1200" cap="none" spc="0" normalizeH="0" baseline="0" noProof="0" dirty="0">
               <a:ln>
                 <a:noFill/>
               </a:ln>
               <a:solidFill>
-                <a:prstClr val="white"/>
+                <a:schemeClr val="bg1"/>
               </a:solidFill>
               <a:effectLst/>
               <a:uLnTx/>
@@ -14987,24 +14921,7 @@
                 <a:ea typeface="Helvetica Neue" panose="02000503000000020004" pitchFamily="2" charset="0"/>
                 <a:cs typeface="Helvetica Neue" panose="02000503000000020004" pitchFamily="2" charset="0"/>
               </a:rPr>
-              <a:t>The symmetry point in a binary assembly is when point potential speed </a:t>
-            </a:r>
-            <a:r>
-              <a:rPr kumimoji="0" lang="en-US" sz="1800" b="1" i="0" u="none" strike="noStrike" kern="1200" cap="none" spc="0" normalizeH="0" baseline="0" noProof="0" dirty="0">
-                <a:ln>
-                  <a:noFill/>
-                </a:ln>
-                <a:solidFill>
-                  <a:prstClr val="white"/>
-                </a:solidFill>
-                <a:effectLst/>
-                <a:uLnTx/>
-                <a:uFillTx/>
-                <a:latin typeface="Helvetica Neue" panose="02000503000000020004" pitchFamily="2" charset="0"/>
-                <a:ea typeface="Helvetica Neue" panose="02000503000000020004" pitchFamily="2" charset="0"/>
-                <a:cs typeface="Helvetica Neue" panose="02000503000000020004" pitchFamily="2" charset="0"/>
-              </a:rPr>
-              <a:t>|v| = @. </a:t>
+              <a:t>Question: does the binary symmetry point align with the reciprocal 1/r hinge at r = 1?</a:t>
             </a:r>
             <a:endParaRPr kumimoji="0" lang="en-US" sz="1800" b="1" i="1" u="none" strike="noStrike" kern="1200" cap="none" spc="0" normalizeH="0" baseline="0" noProof="0" dirty="0">
               <a:ln>
@@ -15054,7 +14971,7 @@
                 <a:ea typeface="Helvetica Neue" panose="02000503000000020004" pitchFamily="2" charset="0"/>
                 <a:cs typeface="Helvetica Neue" panose="02000503000000020004" pitchFamily="2" charset="0"/>
               </a:rPr>
-              <a:t>Does the binary symmetry point correspond to the 1:1 symmetry point in the 1/r curve as well (x=1/y, y=1/x)? I suspect it may.</a:t>
+              <a:t>One-sided integrals above and below r = 1 appear symmetric in this toy picture.</a:t>
             </a:r>
           </a:p>
           <a:p>
@@ -15090,7 +15007,7 @@
                 <a:ea typeface="Helvetica Neue" panose="02000503000000020004" pitchFamily="2" charset="0"/>
                 <a:cs typeface="Helvetica Neue" panose="02000503000000020004" pitchFamily="2" charset="0"/>
               </a:rPr>
-              <a:t>The one-sided integrals above and below r=1 increase symmetrically. </a:t>
+              <a:t>This may explain why orbit equations scale jointly with |v| and r.</a:t>
             </a:r>
           </a:p>
           <a:p>
@@ -15126,7 +15043,7 @@
                 <a:ea typeface="Helvetica Neue" panose="02000503000000020004" pitchFamily="2" charset="0"/>
                 <a:cs typeface="Helvetica Neue" panose="02000503000000020004" pitchFamily="2" charset="0"/>
               </a:rPr>
-              <a:t>Is this why orbital equations scale with |v| and r?</a:t>
+              <a:t>Opposite-polarity architrinos launched from large r with small speed may approach |v| near c_f at r = 1.</a:t>
             </a:r>
           </a:p>
           <a:p>
@@ -15162,41 +15079,7 @@
                 <a:ea typeface="Helvetica Neue" panose="02000503000000020004" pitchFamily="2" charset="0"/>
                 <a:cs typeface="Helvetica Neue" panose="02000503000000020004" pitchFamily="2" charset="0"/>
               </a:rPr>
-              <a:t>If </a:t>
-            </a:r>
-            <a:r>
-              <a:rPr kumimoji="0" lang="en-US" sz="1800" b="1" i="0" u="none" strike="noStrike" kern="1200" cap="none" spc="0" normalizeH="0" baseline="0" noProof="0" dirty="0">
-                <a:ln>
-                  <a:noFill/>
-                </a:ln>
-                <a:solidFill>
-                  <a:prstClr val="white"/>
-                </a:solidFill>
-                <a:effectLst/>
-                <a:uLnTx/>
-                <a:uFillTx/>
-                <a:latin typeface="Helvetica Neue" panose="02000503000000020004" pitchFamily="2" charset="0"/>
-                <a:ea typeface="Helvetica Neue" panose="02000503000000020004" pitchFamily="2" charset="0"/>
-                <a:cs typeface="Helvetica Neue" panose="02000503000000020004" pitchFamily="2" charset="0"/>
-              </a:rPr>
-              <a:t>trans (opposite polarity)</a:t>
-            </a:r>
-            <a:r>
-              <a:rPr kumimoji="0" lang="en-US" sz="1800" b="0" i="0" u="none" strike="noStrike" kern="1200" cap="none" spc="0" normalizeH="0" baseline="0" noProof="0" dirty="0">
-                <a:ln>
-                  <a:noFill/>
-                </a:ln>
-                <a:solidFill>
-                  <a:prstClr val="white"/>
-                </a:solidFill>
-                <a:effectLst/>
-                <a:uLnTx/>
-                <a:uFillTx/>
-                <a:latin typeface="Helvetica Neue" panose="02000503000000020004" pitchFamily="2" charset="0"/>
-                <a:ea typeface="Helvetica Neue" panose="02000503000000020004" pitchFamily="2" charset="0"/>
-                <a:cs typeface="Helvetica Neue" panose="02000503000000020004" pitchFamily="2" charset="0"/>
-              </a:rPr>
-              <a:t> potentials launch at large r, and speed +delta, delta near 0 </a:t>
+              <a:t>Open calculation: determine the limiting speed after the pair passes through.</a:t>
             </a:r>
           </a:p>
           <a:p>
@@ -15232,7 +15115,7 @@
                 <a:ea typeface="Helvetica Neue" panose="02000503000000020004" pitchFamily="2" charset="0"/>
                 <a:cs typeface="Helvetica Neue" panose="02000503000000020004" pitchFamily="2" charset="0"/>
               </a:rPr>
-              <a:t>Will they reach |v| very near @ at r=1?</a:t>
+              <a:t>Same-polarity architrinos launched toward each other above c_f may reverse or cross depending on initial offset.</a:t>
             </a:r>
           </a:p>
           <a:p>
@@ -15268,7 +15151,7 @@
                 <a:ea typeface="Helvetica Neue" panose="02000503000000020004" pitchFamily="2" charset="0"/>
                 <a:cs typeface="Helvetica Neue" panose="02000503000000020004" pitchFamily="2" charset="0"/>
               </a:rPr>
-              <a:t>What is the ultimate velocity as they pass through each other?</a:t>
+              <a:t>Same-polarity versus opposite-polarity motion is a real asymmetry in the primitive dynamics.</a:t>
             </a:r>
           </a:p>
           <a:p>
@@ -15304,288 +15187,8 @@
                 <a:ea typeface="Helvetica Neue" panose="02000503000000020004" pitchFamily="2" charset="0"/>
                 <a:cs typeface="Helvetica Neue" panose="02000503000000020004" pitchFamily="2" charset="0"/>
               </a:rPr>
-              <a:t>Symmetry with binaries suggests v = @ pi / 2.</a:t>
+              <a:t>Radius and velocity remain coupled through the causal-root ledger.</a:t>
             </a:r>
-          </a:p>
-          <a:p>
-            <a:pPr marL="285750" marR="0" lvl="0" indent="-285750" algn="l" defTabSz="914400" rtl="0" eaLnBrk="1" fontAlgn="auto" latinLnBrk="0" hangingPunct="1">
-              <a:lnSpc>
-                <a:spcPct val="100000"/>
-              </a:lnSpc>
-              <a:spcBef>
-                <a:spcPts val="0"/>
-              </a:spcBef>
-              <a:spcAft>
-                <a:spcPts val="0"/>
-              </a:spcAft>
-              <a:buClrTx/>
-              <a:buSzTx/>
-              <a:buFont typeface="Arial" panose="020B0604020202020204" pitchFamily="34" charset="0"/>
-              <a:buChar char="•"/>
-              <a:tabLst/>
-              <a:defRPr/>
-            </a:pPr>
-            <a:r>
-              <a:rPr kumimoji="0" lang="en-US" sz="1800" b="0" i="0" u="none" strike="noStrike" kern="1200" cap="none" spc="0" normalizeH="0" baseline="0" noProof="0" dirty="0">
-                <a:ln>
-                  <a:noFill/>
-                </a:ln>
-                <a:solidFill>
-                  <a:prstClr val="white"/>
-                </a:solidFill>
-                <a:effectLst/>
-                <a:uLnTx/>
-                <a:uFillTx/>
-                <a:latin typeface="Helvetica Neue" panose="02000503000000020004" pitchFamily="2" charset="0"/>
-                <a:ea typeface="Helvetica Neue" panose="02000503000000020004" pitchFamily="2" charset="0"/>
-                <a:cs typeface="Helvetica Neue" panose="02000503000000020004" pitchFamily="2" charset="0"/>
-              </a:rPr>
-              <a:t>If </a:t>
-            </a:r>
-            <a:r>
-              <a:rPr kumimoji="0" lang="en-US" sz="1800" b="1" i="0" u="none" strike="noStrike" kern="1200" cap="none" spc="0" normalizeH="0" baseline="0" noProof="0" dirty="0">
-                <a:ln>
-                  <a:noFill/>
-                </a:ln>
-                <a:solidFill>
-                  <a:prstClr val="white"/>
-                </a:solidFill>
-                <a:effectLst/>
-                <a:uLnTx/>
-                <a:uFillTx/>
-                <a:latin typeface="Helvetica Neue" panose="02000503000000020004" pitchFamily="2" charset="0"/>
-                <a:ea typeface="Helvetica Neue" panose="02000503000000020004" pitchFamily="2" charset="0"/>
-                <a:cs typeface="Helvetica Neue" panose="02000503000000020004" pitchFamily="2" charset="0"/>
-              </a:rPr>
-              <a:t>cis (same polarity)</a:t>
-            </a:r>
-            <a:r>
-              <a:rPr kumimoji="0" lang="en-US" sz="1800" b="0" i="0" u="none" strike="noStrike" kern="1200" cap="none" spc="0" normalizeH="0" baseline="0" noProof="0" dirty="0">
-                <a:ln>
-                  <a:noFill/>
-                </a:ln>
-                <a:solidFill>
-                  <a:prstClr val="white"/>
-                </a:solidFill>
-                <a:effectLst/>
-                <a:uLnTx/>
-                <a:uFillTx/>
-                <a:latin typeface="Helvetica Neue" panose="02000503000000020004" pitchFamily="2" charset="0"/>
-                <a:ea typeface="Helvetica Neue" panose="02000503000000020004" pitchFamily="2" charset="0"/>
-                <a:cs typeface="Helvetica Neue" panose="02000503000000020004" pitchFamily="2" charset="0"/>
-              </a:rPr>
-              <a:t> potentials launch to each other with a speed &gt;&gt; @ + delta</a:t>
-            </a:r>
-          </a:p>
-          <a:p>
-            <a:pPr marL="742950" marR="0" lvl="1" indent="-285750" algn="l" defTabSz="914400" rtl="0" eaLnBrk="1" fontAlgn="auto" latinLnBrk="0" hangingPunct="1">
-              <a:lnSpc>
-                <a:spcPct val="100000"/>
-              </a:lnSpc>
-              <a:spcBef>
-                <a:spcPts val="0"/>
-              </a:spcBef>
-              <a:spcAft>
-                <a:spcPts val="0"/>
-              </a:spcAft>
-              <a:buClrTx/>
-              <a:buSzTx/>
-              <a:buFont typeface="Arial" panose="020B0604020202020204" pitchFamily="34" charset="0"/>
-              <a:buChar char="•"/>
-              <a:tabLst/>
-              <a:defRPr/>
-            </a:pPr>
-            <a:r>
-              <a:rPr kumimoji="0" lang="en-US" sz="1800" b="0" i="0" u="none" strike="noStrike" kern="1200" cap="none" spc="0" normalizeH="0" baseline="0" noProof="0" dirty="0">
-                <a:ln>
-                  <a:noFill/>
-                </a:ln>
-                <a:solidFill>
-                  <a:prstClr val="white"/>
-                </a:solidFill>
-                <a:effectLst/>
-                <a:uLnTx/>
-                <a:uFillTx/>
-                <a:latin typeface="Helvetica Neue" panose="02000503000000020004" pitchFamily="2" charset="0"/>
-                <a:ea typeface="Helvetica Neue" panose="02000503000000020004" pitchFamily="2" charset="0"/>
-                <a:cs typeface="Helvetica Neue" panose="02000503000000020004" pitchFamily="2" charset="0"/>
-              </a:rPr>
-              <a:t>Is the r = 1 case where they would reverse course or cross depending on delta?</a:t>
-            </a:r>
-          </a:p>
-          <a:p>
-            <a:pPr marL="742950" marR="0" lvl="1" indent="-285750" algn="l" defTabSz="914400" rtl="0" eaLnBrk="1" fontAlgn="auto" latinLnBrk="0" hangingPunct="1">
-              <a:lnSpc>
-                <a:spcPct val="100000"/>
-              </a:lnSpc>
-              <a:spcBef>
-                <a:spcPts val="0"/>
-              </a:spcBef>
-              <a:spcAft>
-                <a:spcPts val="0"/>
-              </a:spcAft>
-              <a:buClrTx/>
-              <a:buSzTx/>
-              <a:buFont typeface="Arial" panose="020B0604020202020204" pitchFamily="34" charset="0"/>
-              <a:buChar char="•"/>
-              <a:tabLst/>
-              <a:defRPr/>
-            </a:pPr>
-            <a:r>
-              <a:rPr kumimoji="0" lang="en-US" sz="1800" b="0" i="0" u="none" strike="noStrike" kern="1200" cap="none" spc="0" normalizeH="0" baseline="0" noProof="0" dirty="0">
-                <a:ln>
-                  <a:noFill/>
-                </a:ln>
-                <a:solidFill>
-                  <a:prstClr val="white"/>
-                </a:solidFill>
-                <a:effectLst/>
-                <a:uLnTx/>
-                <a:uFillTx/>
-                <a:latin typeface="Helvetica Neue" panose="02000503000000020004" pitchFamily="2" charset="0"/>
-                <a:ea typeface="Helvetica Neue" panose="02000503000000020004" pitchFamily="2" charset="0"/>
-                <a:cs typeface="Helvetica Neue" panose="02000503000000020004" pitchFamily="2" charset="0"/>
-              </a:rPr>
-              <a:t>Cis vs. Trans point potentials are a profound asymmetry in nature.</a:t>
-            </a:r>
-          </a:p>
-          <a:p>
-            <a:pPr marL="742950" marR="0" lvl="1" indent="-285750" algn="l" defTabSz="914400" rtl="0" eaLnBrk="1" fontAlgn="auto" latinLnBrk="0" hangingPunct="1">
-              <a:lnSpc>
-                <a:spcPct val="100000"/>
-              </a:lnSpc>
-              <a:spcBef>
-                <a:spcPts val="0"/>
-              </a:spcBef>
-              <a:spcAft>
-                <a:spcPts val="0"/>
-              </a:spcAft>
-              <a:buClrTx/>
-              <a:buSzTx/>
-              <a:buFont typeface="Arial" panose="020B0604020202020204" pitchFamily="34" charset="0"/>
-              <a:buChar char="•"/>
-              <a:tabLst/>
-              <a:defRPr/>
-            </a:pPr>
-            <a:r>
-              <a:rPr kumimoji="0" lang="en-US" sz="1800" b="0" i="0" u="none" strike="noStrike" kern="1200" cap="none" spc="0" normalizeH="0" baseline="0" noProof="0" dirty="0">
-                <a:ln>
-                  <a:noFill/>
-                </a:ln>
-                <a:solidFill>
-                  <a:prstClr val="white"/>
-                </a:solidFill>
-                <a:effectLst/>
-                <a:uLnTx/>
-                <a:uFillTx/>
-                <a:latin typeface="Helvetica Neue" panose="02000503000000020004" pitchFamily="2" charset="0"/>
-                <a:ea typeface="Helvetica Neue" panose="02000503000000020004" pitchFamily="2" charset="0"/>
-                <a:cs typeface="Helvetica Neue" panose="02000503000000020004" pitchFamily="2" charset="0"/>
-              </a:rPr>
-              <a:t>Kinda profound, but if the point potential is boosted it can cross the 1/1 location.</a:t>
-            </a:r>
-          </a:p>
-          <a:p>
-            <a:pPr marL="0" marR="0" lvl="0" indent="0" algn="l" defTabSz="914400" rtl="0" eaLnBrk="1" fontAlgn="auto" latinLnBrk="0" hangingPunct="1">
-              <a:lnSpc>
-                <a:spcPct val="100000"/>
-              </a:lnSpc>
-              <a:spcBef>
-                <a:spcPts val="0"/>
-              </a:spcBef>
-              <a:spcAft>
-                <a:spcPts val="0"/>
-              </a:spcAft>
-              <a:buClrTx/>
-              <a:buSzTx/>
-              <a:buFontTx/>
-              <a:buNone/>
-              <a:tabLst/>
-              <a:defRPr/>
-            </a:pPr>
-            <a:endParaRPr kumimoji="0" lang="en-US" sz="1800" b="0" i="0" u="none" strike="noStrike" kern="1200" cap="none" spc="0" normalizeH="0" baseline="0" noProof="0" dirty="0">
-              <a:ln>
-                <a:noFill/>
-              </a:ln>
-              <a:solidFill>
-                <a:prstClr val="white"/>
-              </a:solidFill>
-              <a:effectLst/>
-              <a:uLnTx/>
-              <a:uFillTx/>
-              <a:latin typeface="Helvetica Neue" panose="02000503000000020004" pitchFamily="2" charset="0"/>
-              <a:ea typeface="Helvetica Neue" panose="02000503000000020004" pitchFamily="2" charset="0"/>
-              <a:cs typeface="Helvetica Neue" panose="02000503000000020004" pitchFamily="2" charset="0"/>
-            </a:endParaRPr>
-          </a:p>
-          <a:p>
-            <a:pPr marL="285750" marR="0" lvl="0" indent="-285750" algn="l" defTabSz="914400" rtl="0" eaLnBrk="1" fontAlgn="auto" latinLnBrk="0" hangingPunct="1">
-              <a:lnSpc>
-                <a:spcPct val="100000"/>
-              </a:lnSpc>
-              <a:spcBef>
-                <a:spcPts val="0"/>
-              </a:spcBef>
-              <a:spcAft>
-                <a:spcPts val="0"/>
-              </a:spcAft>
-              <a:buClrTx/>
-              <a:buSzTx/>
-              <a:buFont typeface="Arial" panose="020B0604020202020204" pitchFamily="34" charset="0"/>
-              <a:buChar char="•"/>
-              <a:tabLst/>
-              <a:defRPr/>
-            </a:pPr>
-            <a:r>
-              <a:rPr kumimoji="0" lang="en-US" sz="1800" b="0" i="0" u="none" strike="noStrike" kern="1200" cap="none" spc="0" normalizeH="0" baseline="0" noProof="0" dirty="0">
-                <a:ln>
-                  <a:noFill/>
-                </a:ln>
-                <a:solidFill>
-                  <a:prstClr val="white"/>
-                </a:solidFill>
-                <a:effectLst/>
-                <a:uLnTx/>
-                <a:uFillTx/>
-                <a:latin typeface="Helvetica Neue" panose="02000503000000020004" pitchFamily="2" charset="0"/>
-                <a:ea typeface="Helvetica Neue" panose="02000503000000020004" pitchFamily="2" charset="0"/>
-                <a:cs typeface="Helvetica Neue" panose="02000503000000020004" pitchFamily="2" charset="0"/>
-              </a:rPr>
-              <a:t>Note: radius and velocity are intertwined.</a:t>
-            </a:r>
-          </a:p>
-          <a:p>
-            <a:pPr marL="285750" marR="0" lvl="0" indent="-285750" algn="l" defTabSz="914400" rtl="0" eaLnBrk="1" fontAlgn="auto" latinLnBrk="0" hangingPunct="1">
-              <a:lnSpc>
-                <a:spcPct val="100000"/>
-              </a:lnSpc>
-              <a:spcBef>
-                <a:spcPts val="0"/>
-              </a:spcBef>
-              <a:spcAft>
-                <a:spcPts val="0"/>
-              </a:spcAft>
-              <a:buClrTx/>
-              <a:buSzTx/>
-              <a:buFont typeface="Arial" panose="020B0604020202020204" pitchFamily="34" charset="0"/>
-              <a:buChar char="•"/>
-              <a:tabLst/>
-              <a:defRPr/>
-            </a:pPr>
-            <a:endParaRPr kumimoji="0" lang="en-US" sz="1800" b="0" i="0" u="none" strike="noStrike" kern="1200" cap="none" spc="0" normalizeH="0" baseline="0" noProof="0" dirty="0">
-              <a:ln>
-                <a:noFill/>
-              </a:ln>
-              <a:solidFill>
-                <a:prstClr val="white"/>
-              </a:solidFill>
-              <a:effectLst/>
-              <a:uLnTx/>
-              <a:uFillTx/>
-              <a:latin typeface="Helvetica Neue" panose="02000503000000020004" pitchFamily="2" charset="0"/>
-              <a:ea typeface="Helvetica Neue" panose="02000503000000020004" pitchFamily="2" charset="0"/>
-              <a:cs typeface="Helvetica Neue" panose="02000503000000020004" pitchFamily="2" charset="0"/>
-            </a:endParaRPr>
           </a:p>
         </p:txBody>
       </p:sp>
@@ -15767,7 +15370,7 @@
                 <a:ea typeface="Helvetica Neue" panose="02000503000000020004" pitchFamily="2" charset="0"/>
                 <a:cs typeface="Helvetica Neue" panose="02000503000000020004" pitchFamily="2" charset="0"/>
               </a:rPr>
-              <a:t>Brainstorming the Radius of Potential</a:t>
+              <a:t>Wake Radius and Binary Symmetry</a:t>
             </a:r>
           </a:p>
         </p:txBody>
@@ -18640,7 +18243,7 @@
                 <a:ea typeface="Helvetica Neue" panose="02000503000000020004" pitchFamily="2" charset="0"/>
                 <a:cs typeface="Helvetica Neue" panose="02000503000000020004" pitchFamily="2" charset="0"/>
               </a:rPr>
-              <a:t>A Model of Nature</a:t>
+              <a:t>Architrino Assembly Architecture</a:t>
             </a:r>
             <a:endParaRPr lang="en-US" sz="2800" b="1" baseline="30000" dirty="0">
               <a:solidFill>
@@ -18803,7 +18406,7 @@
                 <a:ea typeface="Helvetica Neue" panose="02000503000000020004" pitchFamily="2" charset="0"/>
                 <a:cs typeface="Helvetica Neue" panose="02000503000000020004" pitchFamily="2" charset="0"/>
               </a:rPr>
-              <a:t>Absolute Linear Forward Moving Time</a:t>
+              <a:t>Absolute Time</a:t>
             </a:r>
           </a:p>
         </p:txBody>
@@ -18868,7 +18471,7 @@
                 <a:ea typeface="Helvetica Neue" panose="02000503000000020004" pitchFamily="2" charset="0"/>
                 <a:cs typeface="Helvetica Neue" panose="02000503000000020004" pitchFamily="2" charset="0"/>
               </a:rPr>
-              <a:t>Absolute </a:t>
+              <a:t>Euclidean</a:t>
             </a:r>
           </a:p>
           <a:p>
@@ -18904,43 +18507,7 @@
                 <a:ea typeface="Helvetica Neue" panose="02000503000000020004" pitchFamily="2" charset="0"/>
                 <a:cs typeface="Helvetica Neue" panose="02000503000000020004" pitchFamily="2" charset="0"/>
               </a:rPr>
-              <a:t>Euclidean</a:t>
-            </a:r>
-          </a:p>
-          <a:p>
-            <a:pPr marL="0" marR="0" lvl="0" indent="0" algn="ctr" defTabSz="914400" rtl="0" eaLnBrk="1" fontAlgn="auto" latinLnBrk="0" hangingPunct="1">
-              <a:lnSpc>
-                <a:spcPct val="100000"/>
-              </a:lnSpc>
-              <a:spcBef>
-                <a:spcPts val="0"/>
-              </a:spcBef>
-              <a:spcAft>
-                <a:spcPts val="0"/>
-              </a:spcAft>
-              <a:buClrTx/>
-              <a:buSzTx/>
-              <a:buFontTx/>
-              <a:buNone/>
-              <a:tabLst/>
-              <a:defRPr/>
-            </a:pPr>
-            <a:r>
-              <a:rPr kumimoji="0" lang="en-US" sz="1800" b="0" i="0" u="none" strike="noStrike" kern="1200" cap="none" spc="0" normalizeH="0" baseline="0" noProof="0" dirty="0">
-                <a:ln>
-                  <a:noFill/>
-                </a:ln>
-                <a:solidFill>
-                  <a:prstClr val="white"/>
-                </a:solidFill>
-                <a:effectLst/>
-                <a:uLnTx/>
-                <a:uFillTx/>
-                <a:latin typeface="Helvetica Neue" panose="02000503000000020004" pitchFamily="2" charset="0"/>
-                <a:ea typeface="Helvetica Neue" panose="02000503000000020004" pitchFamily="2" charset="0"/>
-                <a:cs typeface="Helvetica Neue" panose="02000503000000020004" pitchFamily="2" charset="0"/>
-              </a:rPr>
-              <a:t>3D Space</a:t>
+              <a:t>Void</a:t>
             </a:r>
           </a:p>
         </p:txBody>
@@ -18999,29 +18566,7 @@
                 <a:ea typeface="Helvetica Neue" panose="02000503000000020004" pitchFamily="2" charset="0"/>
                 <a:cs typeface="Helvetica Neue" panose="02000503000000020004" pitchFamily="2" charset="0"/>
               </a:rPr>
-              <a:t>t = </a:t>
-            </a:r>
-            <a:r>
-              <a:rPr lang="en-US" dirty="0" err="1">
-                <a:solidFill>
-                  <a:prstClr val="white"/>
-                </a:solidFill>
-                <a:latin typeface="Helvetica Neue" panose="02000503000000020004" pitchFamily="2" charset="0"/>
-                <a:ea typeface="Helvetica Neue" panose="02000503000000020004" pitchFamily="2" charset="0"/>
-                <a:cs typeface="Helvetica Neue" panose="02000503000000020004" pitchFamily="2" charset="0"/>
-              </a:rPr>
-              <a:t>t</a:t>
-            </a:r>
-            <a:r>
-              <a:rPr lang="en-US" baseline="-25000" dirty="0" err="1">
-                <a:solidFill>
-                  <a:prstClr val="white"/>
-                </a:solidFill>
-                <a:latin typeface="Helvetica Neue" panose="02000503000000020004" pitchFamily="2" charset="0"/>
-                <a:ea typeface="Helvetica Neue" panose="02000503000000020004" pitchFamily="2" charset="0"/>
-                <a:cs typeface="Helvetica Neue" panose="02000503000000020004" pitchFamily="2" charset="0"/>
-              </a:rPr>
-              <a:t>now</a:t>
+              <a:t>t = t_now</a:t>
             </a:r>
             <a:endParaRPr kumimoji="0" lang="en-US" sz="1800" b="0" i="0" u="none" strike="noStrike" kern="1200" cap="none" spc="0" normalizeH="0" baseline="-25000" noProof="0" dirty="0">
               <a:ln>
@@ -20082,7 +19627,7 @@
                 <a:ea typeface="Helvetica Neue" panose="02000503000000020004" pitchFamily="2" charset="0"/>
                 <a:cs typeface="Helvetica Neue" panose="02000503000000020004" pitchFamily="2" charset="0"/>
               </a:rPr>
-              <a:t>linear (1D)</a:t>
+              <a:t>linear universal parameter</a:t>
             </a:r>
           </a:p>
           <a:p>
@@ -20098,41 +19643,7 @@
                 <a:ea typeface="Helvetica Neue" panose="02000503000000020004" pitchFamily="2" charset="0"/>
                 <a:cs typeface="Helvetica Neue" panose="02000503000000020004" pitchFamily="2" charset="0"/>
               </a:rPr>
-              <a:t>f</a:t>
-            </a:r>
-            <a:r>
-              <a:rPr kumimoji="0" lang="en-US" sz="1200" u="none" strike="noStrike" kern="1200" cap="none" spc="0" normalizeH="0" baseline="0" noProof="0" dirty="0" err="1">
-                <a:ln>
-                  <a:noFill/>
-                </a:ln>
-                <a:solidFill>
-                  <a:prstClr val="white"/>
-                </a:solidFill>
-                <a:effectLst/>
-                <a:uLnTx/>
-                <a:uFillTx/>
-                <a:latin typeface="Helvetica Neue" panose="02000503000000020004" pitchFamily="2" charset="0"/>
-                <a:ea typeface="Helvetica Neue" panose="02000503000000020004" pitchFamily="2" charset="0"/>
-                <a:cs typeface="Helvetica Neue" panose="02000503000000020004" pitchFamily="2" charset="0"/>
-              </a:rPr>
-              <a:t>orward</a:t>
-            </a:r>
-            <a:r>
-              <a:rPr kumimoji="0" lang="en-US" sz="1200" u="none" strike="noStrike" kern="1200" cap="none" spc="0" normalizeH="0" baseline="0" noProof="0" dirty="0">
-                <a:ln>
-                  <a:noFill/>
-                </a:ln>
-                <a:solidFill>
-                  <a:prstClr val="white"/>
-                </a:solidFill>
-                <a:effectLst/>
-                <a:uLnTx/>
-                <a:uFillTx/>
-                <a:latin typeface="Helvetica Neue" panose="02000503000000020004" pitchFamily="2" charset="0"/>
-                <a:ea typeface="Helvetica Neue" panose="02000503000000020004" pitchFamily="2" charset="0"/>
-                <a:cs typeface="Helvetica Neue" panose="02000503000000020004" pitchFamily="2" charset="0"/>
-              </a:rPr>
-              <a:t> moving</a:t>
+              <a:t>Euclidean Void</a:t>
             </a:r>
           </a:p>
           <a:p>
@@ -20160,7 +19671,7 @@
                 <a:ea typeface="Helvetica Neue" panose="02000503000000020004" pitchFamily="2" charset="0"/>
                 <a:cs typeface="Helvetica Neue" panose="02000503000000020004" pitchFamily="2" charset="0"/>
               </a:rPr>
-              <a:t>Absolute Space</a:t>
+              <a:t>fixed 3D container</a:t>
             </a:r>
           </a:p>
           <a:p>
@@ -20176,7 +19687,7 @@
                 <a:ea typeface="Helvetica Neue" panose="02000503000000020004" pitchFamily="2" charset="0"/>
                 <a:cs typeface="Helvetica Neue" panose="02000503000000020004" pitchFamily="2" charset="0"/>
               </a:rPr>
-              <a:t>3D Euclidean</a:t>
+              <a:t>no preferred origin, orientation, or translation</a:t>
             </a:r>
           </a:p>
           <a:p>
@@ -20192,7 +19703,7 @@
                 <a:ea typeface="Helvetica Neue" panose="02000503000000020004" pitchFamily="2" charset="0"/>
                 <a:cs typeface="Helvetica Neue" panose="02000503000000020004" pitchFamily="2" charset="0"/>
               </a:rPr>
-              <a:t>no origin, orientation, translation. </a:t>
+              <a:t>Architrinos</a:t>
             </a:r>
           </a:p>
           <a:p>
@@ -20220,7 +19731,7 @@
                 <a:ea typeface="Helvetica Neue" panose="02000503000000020004" pitchFamily="2" charset="0"/>
                 <a:cs typeface="Helvetica Neue" panose="02000503000000020004" pitchFamily="2" charset="0"/>
               </a:rPr>
-              <a:t>Point Potential Emitter/Receivers</a:t>
+              <a:t>positrino/electrino polarity</a:t>
             </a:r>
           </a:p>
           <a:p>
@@ -20236,7 +19747,7 @@
                 <a:ea typeface="Helvetica Neue" panose="02000503000000020004" pitchFamily="2" charset="0"/>
                 <a:cs typeface="Helvetica Neue" panose="02000503000000020004" pitchFamily="2" charset="0"/>
               </a:rPr>
-              <a:t>equal and opposite</a:t>
+              <a:t>emitters and receivers</a:t>
             </a:r>
           </a:p>
           <a:p>
@@ -20252,7 +19763,7 @@
                 <a:ea typeface="Helvetica Neue" panose="02000503000000020004" pitchFamily="2" charset="0"/>
                 <a:cs typeface="Helvetica Neue" panose="02000503000000020004" pitchFamily="2" charset="0"/>
               </a:rPr>
-              <a:t>constant rate emitters</a:t>
+              <a:t>path history in absolute timespace</a:t>
             </a:r>
           </a:p>
           <a:p>
@@ -20268,7 +19779,7 @@
                 <a:ea typeface="Helvetica Neue" panose="02000503000000020004" pitchFamily="2" charset="0"/>
                 <a:cs typeface="Helvetica Neue" panose="02000503000000020004" pitchFamily="2" charset="0"/>
               </a:rPr>
-              <a:t>potential receivers</a:t>
+              <a:t>can move faster than wake speed</a:t>
             </a:r>
           </a:p>
           <a:p>
@@ -20284,7 +19795,7 @@
                 <a:ea typeface="Helvetica Neue" panose="02000503000000020004" pitchFamily="2" charset="0"/>
                 <a:cs typeface="Helvetica Neue" panose="02000503000000020004" pitchFamily="2" charset="0"/>
               </a:rPr>
-              <a:t>travels establish a path in R4</a:t>
+              <a:t>Architrino Paths</a:t>
             </a:r>
           </a:p>
           <a:p>
@@ -20300,7 +19811,7 @@
                 <a:ea typeface="Helvetica Neue" panose="02000503000000020004" pitchFamily="2" charset="0"/>
                 <a:cs typeface="Helvetica Neue" panose="02000503000000020004" pitchFamily="2" charset="0"/>
               </a:rPr>
-              <a:t>may travel faster than emission</a:t>
+              <a:t>continuous history in time and space</a:t>
             </a:r>
           </a:p>
           <a:p>
@@ -20328,7 +19839,7 @@
                 <a:ea typeface="Helvetica Neue" panose="02000503000000020004" pitchFamily="2" charset="0"/>
                 <a:cs typeface="Helvetica Neue" panose="02000503000000020004" pitchFamily="2" charset="0"/>
               </a:rPr>
-              <a:t>Paths of a Point Potential</a:t>
+              <a:t>path = all [q,t,x,y,z,x',y',z'] for all t &lt; t_now</a:t>
             </a:r>
           </a:p>
           <a:p>
@@ -20344,7 +19855,7 @@
                 <a:ea typeface="Helvetica Neue" panose="02000503000000020004" pitchFamily="2" charset="0"/>
                 <a:cs typeface="Helvetica Neue" panose="02000503000000020004" pitchFamily="2" charset="0"/>
               </a:rPr>
-              <a:t>continuous history in time and space</a:t>
+              <a:t>Causal Wakes</a:t>
             </a:r>
           </a:p>
           <a:p>
@@ -20360,60 +19871,8 @@
                 <a:ea typeface="Helvetica Neue" panose="02000503000000020004" pitchFamily="2" charset="0"/>
                 <a:cs typeface="Helvetica Neue" panose="02000503000000020004" pitchFamily="2" charset="0"/>
               </a:rPr>
-              <a:t>path = all [</a:t>
+              <a:t>emitted from path history</a:t>
             </a:r>
-            <a:r>
-              <a:rPr lang="en-US" sz="1200" dirty="0" err="1">
-                <a:solidFill>
-                  <a:prstClr val="white"/>
-                </a:solidFill>
-                <a:latin typeface="Helvetica Neue" panose="02000503000000020004" pitchFamily="2" charset="0"/>
-                <a:ea typeface="Helvetica Neue" panose="02000503000000020004" pitchFamily="2" charset="0"/>
-                <a:cs typeface="Helvetica Neue" panose="02000503000000020004" pitchFamily="2" charset="0"/>
-              </a:rPr>
-              <a:t>q,t,x,y,z,x’,y’,z</a:t>
-            </a:r>
-            <a:r>
-              <a:rPr lang="en-US" sz="1200" dirty="0">
-                <a:solidFill>
-                  <a:prstClr val="white"/>
-                </a:solidFill>
-                <a:latin typeface="Helvetica Neue" panose="02000503000000020004" pitchFamily="2" charset="0"/>
-                <a:ea typeface="Helvetica Neue" panose="02000503000000020004" pitchFamily="2" charset="0"/>
-                <a:cs typeface="Helvetica Neue" panose="02000503000000020004" pitchFamily="2" charset="0"/>
-              </a:rPr>
-              <a:t>’] for all t &lt; </a:t>
-            </a:r>
-            <a:r>
-              <a:rPr lang="en-US" sz="1200" dirty="0" err="1">
-                <a:solidFill>
-                  <a:prstClr val="white"/>
-                </a:solidFill>
-                <a:latin typeface="Helvetica Neue" panose="02000503000000020004" pitchFamily="2" charset="0"/>
-                <a:ea typeface="Helvetica Neue" panose="02000503000000020004" pitchFamily="2" charset="0"/>
-                <a:cs typeface="Helvetica Neue" panose="02000503000000020004" pitchFamily="2" charset="0"/>
-              </a:rPr>
-              <a:t>t</a:t>
-            </a:r>
-            <a:r>
-              <a:rPr lang="en-US" sz="1200" baseline="-25000" dirty="0" err="1">
-                <a:solidFill>
-                  <a:prstClr val="white"/>
-                </a:solidFill>
-                <a:latin typeface="Helvetica Neue" panose="02000503000000020004" pitchFamily="2" charset="0"/>
-                <a:ea typeface="Helvetica Neue" panose="02000503000000020004" pitchFamily="2" charset="0"/>
-                <a:cs typeface="Helvetica Neue" panose="02000503000000020004" pitchFamily="2" charset="0"/>
-              </a:rPr>
-              <a:t>now</a:t>
-            </a:r>
-            <a:endParaRPr lang="en-US" sz="1200" dirty="0">
-              <a:solidFill>
-                <a:prstClr val="white"/>
-              </a:solidFill>
-              <a:latin typeface="Helvetica Neue" panose="02000503000000020004" pitchFamily="2" charset="0"/>
-              <a:ea typeface="Helvetica Neue" panose="02000503000000020004" pitchFamily="2" charset="0"/>
-              <a:cs typeface="Helvetica Neue" panose="02000503000000020004" pitchFamily="2" charset="0"/>
-            </a:endParaRPr>
           </a:p>
           <a:p>
             <a:pPr>
@@ -20428,7 +19887,7 @@
                 <a:ea typeface="Helvetica Neue" panose="02000503000000020004" pitchFamily="2" charset="0"/>
                 <a:cs typeface="Helvetica Neue" panose="02000503000000020004" pitchFamily="2" charset="0"/>
               </a:rPr>
-              <a:t>Emission</a:t>
+              <a:t>constant polarity-source rate</a:t>
             </a:r>
           </a:p>
           <a:p>
@@ -20444,7 +19903,7 @@
                 <a:ea typeface="Helvetica Neue" panose="02000503000000020004" pitchFamily="2" charset="0"/>
                 <a:cs typeface="Helvetica Neue" panose="02000503000000020004" pitchFamily="2" charset="0"/>
               </a:rPr>
-              <a:t>origin is on path</a:t>
+              <a:t>causal isochron / wake surface</a:t>
             </a:r>
           </a:p>
           <a:p>
@@ -20460,7 +19919,7 @@
                 <a:ea typeface="Helvetica Neue" panose="02000503000000020004" pitchFamily="2" charset="0"/>
                 <a:cs typeface="Helvetica Neue" panose="02000503000000020004" pitchFamily="2" charset="0"/>
               </a:rPr>
-              <a:t>constant rate potential emission</a:t>
+              <a:t>expands at wake speed c_f; r = c_f t</a:t>
             </a:r>
           </a:p>
           <a:p>
@@ -20476,7 +19935,7 @@
                 <a:ea typeface="Helvetica Neue" panose="02000503000000020004" pitchFamily="2" charset="0"/>
                 <a:cs typeface="Helvetica Neue" panose="02000503000000020004" pitchFamily="2" charset="0"/>
               </a:rPr>
-              <a:t>	Dirac delta q/v</a:t>
+              <a:t>Wake Hits</a:t>
             </a:r>
           </a:p>
           <a:p>
@@ -20492,7 +19951,7 @@
                 <a:ea typeface="Helvetica Neue" panose="02000503000000020004" pitchFamily="2" charset="0"/>
                 <a:cs typeface="Helvetica Neue" panose="02000503000000020004" pitchFamily="2" charset="0"/>
               </a:rPr>
-              <a:t>	Dirac sphere stream (1/r curve)</a:t>
+              <a:t>received at t = t_now</a:t>
             </a:r>
           </a:p>
           <a:p>
@@ -20508,7 +19967,7 @@
                 <a:ea typeface="Helvetica Neue" panose="02000503000000020004" pitchFamily="2" charset="0"/>
                 <a:cs typeface="Helvetica Neue" panose="02000503000000020004" pitchFamily="2" charset="0"/>
               </a:rPr>
-              <a:t>expands at field speed @.  r = @t</a:t>
+              <a:t>intersection with wake surface</a:t>
             </a:r>
           </a:p>
           <a:p>
@@ -20524,7 +19983,7 @@
                 <a:ea typeface="Helvetica Neue" panose="02000503000000020004" pitchFamily="2" charset="0"/>
                 <a:cs typeface="Helvetica Neue" panose="02000503000000020004" pitchFamily="2" charset="0"/>
               </a:rPr>
-              <a:t>Action</a:t>
+              <a:t>superposition of received hits</a:t>
             </a:r>
           </a:p>
           <a:p>
@@ -20540,29 +19999,7 @@
                 <a:ea typeface="Helvetica Neue" panose="02000503000000020004" pitchFamily="2" charset="0"/>
                 <a:cs typeface="Helvetica Neue" panose="02000503000000020004" pitchFamily="2" charset="0"/>
               </a:rPr>
-              <a:t>action occurs at t = </a:t>
-            </a:r>
-            <a:r>
-              <a:rPr lang="en-US" sz="1200" dirty="0" err="1">
-                <a:solidFill>
-                  <a:prstClr val="white"/>
-                </a:solidFill>
-                <a:latin typeface="Helvetica Neue" panose="02000503000000020004" pitchFamily="2" charset="0"/>
-                <a:ea typeface="Helvetica Neue" panose="02000503000000020004" pitchFamily="2" charset="0"/>
-                <a:cs typeface="Helvetica Neue" panose="02000503000000020004" pitchFamily="2" charset="0"/>
-              </a:rPr>
-              <a:t>t</a:t>
-            </a:r>
-            <a:r>
-              <a:rPr lang="en-US" sz="1200" baseline="-25000" dirty="0" err="1">
-                <a:solidFill>
-                  <a:prstClr val="white"/>
-                </a:solidFill>
-                <a:latin typeface="Helvetica Neue" panose="02000503000000020004" pitchFamily="2" charset="0"/>
-                <a:ea typeface="Helvetica Neue" panose="02000503000000020004" pitchFamily="2" charset="0"/>
-                <a:cs typeface="Helvetica Neue" panose="02000503000000020004" pitchFamily="2" charset="0"/>
-              </a:rPr>
-              <a:t>now</a:t>
+              <a:t>net response changes path</a:t>
             </a:r>
             <a:endParaRPr kumimoji="0" lang="en-US" sz="1200" u="none" strike="noStrike" kern="1200" cap="none" spc="0" normalizeH="0" baseline="-25000" noProof="0" dirty="0">
               <a:ln>
@@ -20598,41 +20035,7 @@
                 <a:ea typeface="Helvetica Neue" panose="02000503000000020004" pitchFamily="2" charset="0"/>
                 <a:cs typeface="Helvetica Neue" panose="02000503000000020004" pitchFamily="2" charset="0"/>
               </a:rPr>
-              <a:t>[</a:t>
-            </a:r>
-            <a:r>
-              <a:rPr kumimoji="0" lang="en-US" sz="1200" u="none" strike="noStrike" kern="1200" cap="none" spc="0" normalizeH="0" baseline="0" noProof="0" dirty="0" err="1">
-                <a:ln>
-                  <a:noFill/>
-                </a:ln>
-                <a:solidFill>
-                  <a:prstClr val="white"/>
-                </a:solidFill>
-                <a:effectLst/>
-                <a:uLnTx/>
-                <a:uFillTx/>
-                <a:latin typeface="Helvetica Neue" panose="02000503000000020004" pitchFamily="2" charset="0"/>
-                <a:ea typeface="Helvetica Neue" panose="02000503000000020004" pitchFamily="2" charset="0"/>
-                <a:cs typeface="Helvetica Neue" panose="02000503000000020004" pitchFamily="2" charset="0"/>
-              </a:rPr>
-              <a:t>q,t,s,s</a:t>
-            </a:r>
-            <a:r>
-              <a:rPr kumimoji="0" lang="en-US" sz="1200" u="none" strike="noStrike" kern="1200" cap="none" spc="0" normalizeH="0" baseline="0" noProof="0" dirty="0">
-                <a:ln>
-                  <a:noFill/>
-                </a:ln>
-                <a:solidFill>
-                  <a:prstClr val="white"/>
-                </a:solidFill>
-                <a:effectLst/>
-                <a:uLnTx/>
-                <a:uFillTx/>
-                <a:latin typeface="Helvetica Neue" panose="02000503000000020004" pitchFamily="2" charset="0"/>
-                <a:ea typeface="Helvetica Neue" panose="02000503000000020004" pitchFamily="2" charset="0"/>
-                <a:cs typeface="Helvetica Neue" panose="02000503000000020004" pitchFamily="2" charset="0"/>
-              </a:rPr>
-              <a:t>’] intersection with sphere stream</a:t>
+              <a:t>Noether Sea (Large Scale)</a:t>
             </a:r>
           </a:p>
           <a:p>
@@ -20648,7 +20051,7 @@
                 <a:ea typeface="Helvetica Neue" panose="02000503000000020004" pitchFamily="2" charset="0"/>
                 <a:cs typeface="Helvetica Neue" panose="02000503000000020004" pitchFamily="2" charset="0"/>
               </a:rPr>
-              <a:t>superposition</a:t>
+              <a:t>population per volume</a:t>
             </a:r>
           </a:p>
           <a:p>
@@ -20670,35 +20073,7 @@
                 <a:ea typeface="Helvetica Neue" panose="02000503000000020004" pitchFamily="2" charset="0"/>
                 <a:cs typeface="Helvetica Neue" panose="02000503000000020004" pitchFamily="2" charset="0"/>
               </a:rPr>
-              <a:t>net action </a:t>
-            </a:r>
-            <a:r>
-              <a:rPr lang="en-US" sz="1200" dirty="0">
-                <a:solidFill>
-                  <a:prstClr val="white"/>
-                </a:solidFill>
-                <a:latin typeface="Helvetica Neue" panose="02000503000000020004" pitchFamily="2" charset="0"/>
-                <a:ea typeface="Helvetica Neue" panose="02000503000000020004" pitchFamily="2" charset="0"/>
-                <a:cs typeface="Helvetica Neue" panose="02000503000000020004" pitchFamily="2" charset="0"/>
-              </a:rPr>
-              <a:t>determines </a:t>
-            </a:r>
-            <a:r>
-              <a:rPr kumimoji="0" lang="en-US" sz="1200" u="none" strike="noStrike" kern="1200" cap="none" spc="0" normalizeH="0" baseline="0" noProof="0" dirty="0">
-                <a:ln>
-                  <a:noFill/>
-                </a:ln>
-                <a:solidFill>
-                  <a:prstClr val="white"/>
-                </a:solidFill>
-                <a:effectLst/>
-                <a:uLnTx/>
-                <a:uFillTx/>
-                <a:latin typeface="Helvetica Neue" panose="02000503000000020004" pitchFamily="2" charset="0"/>
-                <a:ea typeface="Helvetica Neue" panose="02000503000000020004" pitchFamily="2" charset="0"/>
-                <a:cs typeface="Helvetica Neue" panose="02000503000000020004" pitchFamily="2" charset="0"/>
-              </a:rPr>
-              <a:t>path change</a:t>
+              <a:t>energy carried by architrino assemblies</a:t>
             </a:r>
           </a:p>
           <a:p>
@@ -20732,67 +20107,7 @@
                 <a:ea typeface="Helvetica Neue" panose="02000503000000020004" pitchFamily="2" charset="0"/>
                 <a:cs typeface="Helvetica Neue" panose="02000503000000020004" pitchFamily="2" charset="0"/>
               </a:rPr>
-              <a:t>Point Potential Densities (Large Scale)</a:t>
-            </a:r>
-          </a:p>
-          <a:p>
-            <a:pPr lvl="1">
-              <a:defRPr/>
-            </a:pPr>
-            <a:r>
-              <a:rPr kumimoji="0" lang="en-US" sz="1200" u="none" strike="noStrike" kern="1200" cap="none" spc="0" normalizeH="0" baseline="0" noProof="0" dirty="0">
-                <a:ln>
-                  <a:noFill/>
-                </a:ln>
-                <a:solidFill>
-                  <a:prstClr val="white"/>
-                </a:solidFill>
-                <a:effectLst/>
-                <a:uLnTx/>
-                <a:uFillTx/>
-                <a:latin typeface="Helvetica Neue" panose="02000503000000020004" pitchFamily="2" charset="0"/>
-                <a:ea typeface="Helvetica Neue" panose="02000503000000020004" pitchFamily="2" charset="0"/>
-                <a:cs typeface="Helvetica Neue" panose="02000503000000020004" pitchFamily="2" charset="0"/>
-              </a:rPr>
-              <a:t>population per volume</a:t>
-            </a:r>
-          </a:p>
-          <a:p>
-            <a:pPr lvl="1">
-              <a:defRPr/>
-            </a:pPr>
-            <a:r>
-              <a:rPr lang="en-US" sz="1200" dirty="0">
-                <a:solidFill>
-                  <a:prstClr val="white"/>
-                </a:solidFill>
-                <a:latin typeface="Helvetica Neue" panose="02000503000000020004" pitchFamily="2" charset="0"/>
-                <a:ea typeface="Helvetica Neue" panose="02000503000000020004" pitchFamily="2" charset="0"/>
-                <a:cs typeface="Helvetica Neue" panose="02000503000000020004" pitchFamily="2" charset="0"/>
-              </a:rPr>
-              <a:t>energy carried by point potentials</a:t>
-            </a:r>
-          </a:p>
-          <a:p>
-            <a:pPr lvl="1">
-              <a:defRPr/>
-            </a:pPr>
-            <a:r>
-              <a:rPr kumimoji="0" lang="en-US" sz="1200" u="none" strike="noStrike" kern="1200" cap="none" spc="0" normalizeH="0" baseline="0" noProof="0" dirty="0">
-                <a:ln>
-                  <a:noFill/>
-                </a:ln>
-                <a:solidFill>
-                  <a:prstClr val="white"/>
-                </a:solidFill>
-                <a:effectLst/>
-                <a:uLnTx/>
-                <a:uFillTx/>
-                <a:latin typeface="Helvetica Neue" panose="02000503000000020004" pitchFamily="2" charset="0"/>
-                <a:ea typeface="Helvetica Neue" panose="02000503000000020004" pitchFamily="2" charset="0"/>
-                <a:cs typeface="Helvetica Neue" panose="02000503000000020004" pitchFamily="2" charset="0"/>
-              </a:rPr>
-              <a:t>population distribution (50/50)</a:t>
+              <a:t>locally neutral polarity distribution</a:t>
             </a:r>
           </a:p>
         </p:txBody>
@@ -21213,7 +20528,7 @@
                 <a:ea typeface="Helvetica Neue" panose="02000503000000020004" pitchFamily="2" charset="0"/>
                 <a:cs typeface="Helvetica Neue" panose="02000503000000020004" pitchFamily="2" charset="0"/>
               </a:rPr>
-              <a:t>J Mark Morris - Model of Nature</a:t>
+              <a:t>J Mark Morris - Architrino Assembly Architecture</a:t>
             </a:r>
           </a:p>
         </p:txBody>
@@ -21307,23 +20622,7 @@
               <a:tabLst/>
               <a:defRPr/>
             </a:pPr>
-            <a:r>
-              <a:rPr kumimoji="0" lang="en-US" sz="11500" b="0" i="0" u="none" strike="noStrike" kern="1200" cap="none" spc="0" normalizeH="0" baseline="0" noProof="0" dirty="0">
-                <a:ln>
-                  <a:noFill/>
-                </a:ln>
-                <a:solidFill>
-                  <a:prstClr val="white"/>
-                </a:solidFill>
-                <a:effectLst/>
-                <a:uLnTx/>
-                <a:uFillTx/>
-                <a:latin typeface="Helvetica Neue UltraLight" panose="02000206000000020004" pitchFamily="2" charset="0"/>
-                <a:ea typeface="Helvetica Neue UltraLight" panose="02000206000000020004" pitchFamily="2" charset="0"/>
-                <a:cs typeface="Helvetica Neue" panose="02000503000000020004" pitchFamily="2" charset="0"/>
-              </a:rPr>
-              <a:t>neoclassical.ai</a:t>
-            </a:r>
+            <a:endParaRPr/>
           </a:p>
           <a:p>
             <a:pPr marL="0" marR="0" lvl="0" indent="0" algn="ctr" defTabSz="914400" rtl="0" eaLnBrk="1" fontAlgn="auto" latinLnBrk="0" hangingPunct="1">
@@ -21358,7 +20657,7 @@
                 <a:ea typeface="Helvetica Neue Condensed Black" panose="02000503000000020004" pitchFamily="2" charset="0"/>
                 <a:cs typeface="Helvetica Neue Condensed Black" panose="02000503000000020004" pitchFamily="2" charset="0"/>
               </a:rPr>
-              <a:t>Solving Zeno’s Paradox</a:t>
+              <a:t>Causal Wakes and Zeno's Paradox</a:t>
             </a:r>
             <a:endParaRPr kumimoji="0" lang="en-US" sz="8000" b="1" i="0" u="none" strike="noStrike" kern="1200" cap="none" spc="0" normalizeH="0" baseline="0" noProof="0" dirty="0">
               <a:ln>
@@ -21643,7 +20942,7 @@
                 <a:ea typeface="Helvetica Neue" panose="02000503000000020004" pitchFamily="2" charset="0"/>
                 <a:cs typeface="Helvetica Neue" panose="02000503000000020004" pitchFamily="2" charset="0"/>
               </a:rPr>
-              <a:t>Nature’s Solution to Zeno’s Paradox and the 1/r Potential Curve</a:t>
+              <a:t>Causal Wakes and the 1/r Curve</a:t>
             </a:r>
           </a:p>
         </p:txBody>
@@ -21708,7 +21007,7 @@
                 <a:ea typeface="Helvetica Neue" panose="02000503000000020004" pitchFamily="2" charset="0"/>
                 <a:cs typeface="Helvetica Neue" panose="02000503000000020004" pitchFamily="2" charset="0"/>
               </a:rPr>
-              <a:t>Nature is a pure geometry defined by continuous paths of equal and opposite point potentials. It’s a path theory! </a:t>
+              <a:t>Nature is modeled as geometry in absolute time and the Euclidean void, populated by equal-and-opposite architrinos.</a:t>
             </a:r>
           </a:p>
           <a:p>
@@ -21732,41 +21031,7 @@
                 <a:ea typeface="Helvetica Neue" panose="02000503000000020004" pitchFamily="2" charset="0"/>
                 <a:cs typeface="Helvetica Neue" panose="02000503000000020004" pitchFamily="2" charset="0"/>
               </a:rPr>
-              <a:t>Each path is an open ended string headed by a point potential emitter/receiver. (Nature </a:t>
-            </a:r>
-            <a:r>
-              <a:rPr kumimoji="0" lang="en-US" sz="1600" b="0" i="0" u="none" strike="noStrike" kern="1200" cap="none" spc="0" normalizeH="0" baseline="0" noProof="0" dirty="0" err="1">
-                <a:ln>
-                  <a:noFill/>
-                </a:ln>
-                <a:solidFill>
-                  <a:prstClr val="white"/>
-                </a:solidFill>
-                <a:effectLst/>
-                <a:uLnTx/>
-                <a:uFillTx/>
-                <a:latin typeface="Helvetica Neue" panose="02000503000000020004" pitchFamily="2" charset="0"/>
-                <a:ea typeface="Helvetica Neue" panose="02000503000000020004" pitchFamily="2" charset="0"/>
-                <a:cs typeface="Helvetica Neue" panose="02000503000000020004" pitchFamily="2" charset="0"/>
-              </a:rPr>
-              <a:t>echos</a:t>
-            </a:r>
-            <a:r>
-              <a:rPr kumimoji="0" lang="en-US" sz="1600" b="0" i="0" u="none" strike="noStrike" kern="1200" cap="none" spc="0" normalizeH="0" baseline="0" noProof="0" dirty="0">
-                <a:ln>
-                  <a:noFill/>
-                </a:ln>
-                <a:solidFill>
-                  <a:prstClr val="white"/>
-                </a:solidFill>
-                <a:effectLst/>
-                <a:uLnTx/>
-                <a:uFillTx/>
-                <a:latin typeface="Helvetica Neue" panose="02000503000000020004" pitchFamily="2" charset="0"/>
-                <a:ea typeface="Helvetica Neue" panose="02000503000000020004" pitchFamily="2" charset="0"/>
-                <a:cs typeface="Helvetica Neue" panose="02000503000000020004" pitchFamily="2" charset="0"/>
-              </a:rPr>
-              <a:t> at many scales)</a:t>
+              <a:t>Each architrino is a polarity-bearing emitter/receiver; its continuous path emits causal wake surfaces.</a:t>
             </a:r>
           </a:p>
           <a:p>
@@ -21790,7 +21055,7 @@
                 <a:ea typeface="Helvetica Neue" panose="02000503000000020004" pitchFamily="2" charset="0"/>
                 <a:cs typeface="Helvetica Neue" panose="02000503000000020004" pitchFamily="2" charset="0"/>
               </a:rPr>
-              <a:t>Emission is constant q/t</a:t>
+              <a:t>A received hit occurs when a receiver intersects a causal wake surface; superposition determines the net response.</a:t>
             </a:r>
           </a:p>
           <a:p>
@@ -21814,7 +21079,7 @@
                 <a:ea typeface="Helvetica Neue" panose="02000503000000020004" pitchFamily="2" charset="0"/>
                 <a:cs typeface="Helvetica Neue" panose="02000503000000020004" pitchFamily="2" charset="0"/>
               </a:rPr>
-              <a:t>Action occurs when a receiver intersects a sphere stream. (superposition applies)</a:t>
+              <a:t>Because an architrino can move faster than wake speed, v = c_f marks a self-hit onset boundary rather than an observer-level speed limit.</a:t>
             </a:r>
           </a:p>
           <a:p>
@@ -21838,252 +21103,8 @@
                 <a:ea typeface="Helvetica Neue" panose="02000503000000020004" pitchFamily="2" charset="0"/>
                 <a:cs typeface="Helvetica Neue" panose="02000503000000020004" pitchFamily="2" charset="0"/>
               </a:rPr>
-              <a:t>t=now of curvy paths in s (graph).</a:t>
+              <a:t>Ideal binaries must be tested through causal-root ledgers, path-history feedback, and branch stability, not through an instantaneous 1/r curve alone.</a:t>
             </a:r>
-          </a:p>
-          <a:p>
-            <a:pPr marL="914400" lvl="1" indent="-457200">
-              <a:buFont typeface="Arial" panose="020B0604020202020204" pitchFamily="34" charset="0"/>
-              <a:buChar char="•"/>
-              <a:defRPr/>
-            </a:pPr>
-            <a:r>
-              <a:rPr kumimoji="0" lang="en-US" sz="1600" b="0" i="0" u="none" strike="noStrike" kern="1200" cap="none" spc="0" normalizeH="0" baseline="0" noProof="0" dirty="0">
-                <a:ln>
-                  <a:noFill/>
-                </a:ln>
-                <a:solidFill>
-                  <a:prstClr val="white"/>
-                </a:solidFill>
-                <a:effectLst/>
-                <a:uLnTx/>
-                <a:uFillTx/>
-                <a:latin typeface="Helvetica Neue" panose="02000503000000020004" pitchFamily="2" charset="0"/>
-                <a:ea typeface="Helvetica Neue" panose="02000503000000020004" pitchFamily="2" charset="0"/>
-                <a:cs typeface="Helvetica Neue" panose="02000503000000020004" pitchFamily="2" charset="0"/>
-              </a:rPr>
-              <a:t>because point potentials can exceed their own field speed, we have a symmetry breaking point between two regions, as a bonus we get a maximum curvature in a binary (or orbiting/translating binary)</a:t>
-            </a:r>
-          </a:p>
-          <a:p>
-            <a:pPr marL="914400" lvl="1" indent="-457200">
-              <a:buFont typeface="Arial" panose="020B0604020202020204" pitchFamily="34" charset="0"/>
-              <a:buChar char="•"/>
-              <a:defRPr/>
-            </a:pPr>
-            <a:r>
-              <a:rPr kumimoji="0" lang="en-US" sz="1600" b="0" i="0" u="none" strike="noStrike" kern="1200" cap="none" spc="0" normalizeH="0" baseline="0" noProof="0" dirty="0">
-                <a:ln>
-                  <a:noFill/>
-                </a:ln>
-                <a:solidFill>
-                  <a:prstClr val="white"/>
-                </a:solidFill>
-                <a:effectLst/>
-                <a:uLnTx/>
-                <a:uFillTx/>
-                <a:latin typeface="Helvetica Neue" panose="02000503000000020004" pitchFamily="2" charset="0"/>
-                <a:ea typeface="Helvetica Neue" panose="02000503000000020004" pitchFamily="2" charset="0"/>
-                <a:cs typeface="Helvetica Neue" panose="02000503000000020004" pitchFamily="2" charset="0"/>
-              </a:rPr>
-              <a:t>An ideal binary (and ideal elliptical?) has symmetry such that the point potentials must experience the equivalent action. When v=0 and no axial rotation (holy cow now we also have to compute the effects of a rotation of the binary around one other dimension.</a:t>
-            </a:r>
-          </a:p>
-          <a:p>
-            <a:pPr marL="914400" lvl="1" indent="-457200">
-              <a:buFont typeface="Arial" panose="020B0604020202020204" pitchFamily="34" charset="0"/>
-              <a:buChar char="•"/>
-              <a:defRPr/>
-            </a:pPr>
-            <a:r>
-              <a:rPr kumimoji="0" lang="en-US" sz="1600" b="0" i="0" u="none" strike="noStrike" kern="1200" cap="none" spc="0" normalizeH="0" baseline="0" noProof="0" dirty="0">
-                <a:ln>
-                  <a:noFill/>
-                </a:ln>
-                <a:solidFill>
-                  <a:prstClr val="white"/>
-                </a:solidFill>
-                <a:effectLst/>
-                <a:uLnTx/>
-                <a:uFillTx/>
-                <a:latin typeface="Helvetica Neue" panose="02000503000000020004" pitchFamily="2" charset="0"/>
-                <a:ea typeface="Helvetica Neue" panose="02000503000000020004" pitchFamily="2" charset="0"/>
-                <a:cs typeface="Helvetica Neue" panose="02000503000000020004" pitchFamily="2" charset="0"/>
-              </a:rPr>
-              <a:t>There may be equivalent geometrical models. Or models that express these concepts in more abstract mathematical terms. That itself is kind of </a:t>
-            </a:r>
-            <a:r>
-              <a:rPr kumimoji="0" lang="en-US" sz="1600" b="0" i="0" u="none" strike="noStrike" kern="1200" cap="none" spc="0" normalizeH="0" baseline="0" noProof="0" dirty="0" err="1">
-                <a:ln>
-                  <a:noFill/>
-                </a:ln>
-                <a:solidFill>
-                  <a:prstClr val="white"/>
-                </a:solidFill>
-                <a:effectLst/>
-                <a:uLnTx/>
-                <a:uFillTx/>
-                <a:latin typeface="Helvetica Neue" panose="02000503000000020004" pitchFamily="2" charset="0"/>
-                <a:ea typeface="Helvetica Neue" panose="02000503000000020004" pitchFamily="2" charset="0"/>
-                <a:cs typeface="Helvetica Neue" panose="02000503000000020004" pitchFamily="2" charset="0"/>
-              </a:rPr>
-              <a:t>mindblowing</a:t>
-            </a:r>
-            <a:r>
-              <a:rPr kumimoji="0" lang="en-US" sz="1600" b="0" i="0" u="none" strike="noStrike" kern="1200" cap="none" spc="0" normalizeH="0" baseline="0" noProof="0" dirty="0">
-                <a:ln>
-                  <a:noFill/>
-                </a:ln>
-                <a:solidFill>
-                  <a:prstClr val="white"/>
-                </a:solidFill>
-                <a:effectLst/>
-                <a:uLnTx/>
-                <a:uFillTx/>
-                <a:latin typeface="Helvetica Neue" panose="02000503000000020004" pitchFamily="2" charset="0"/>
-                <a:ea typeface="Helvetica Neue" panose="02000503000000020004" pitchFamily="2" charset="0"/>
-                <a:cs typeface="Helvetica Neue" panose="02000503000000020004" pitchFamily="2" charset="0"/>
-              </a:rPr>
-              <a:t>. We think we are reality. In a sense we are a simulation of reality.</a:t>
-            </a:r>
-          </a:p>
-          <a:p>
-            <a:pPr marL="914400" lvl="1" indent="-457200">
-              <a:buFont typeface="Arial" panose="020B0604020202020204" pitchFamily="34" charset="0"/>
-              <a:buChar char="•"/>
-              <a:defRPr/>
-            </a:pPr>
-            <a:endParaRPr lang="en-US" sz="1600" dirty="0">
-              <a:solidFill>
-                <a:prstClr val="white"/>
-              </a:solidFill>
-              <a:latin typeface="Helvetica Neue" panose="02000503000000020004" pitchFamily="2" charset="0"/>
-              <a:ea typeface="Helvetica Neue" panose="02000503000000020004" pitchFamily="2" charset="0"/>
-              <a:cs typeface="Helvetica Neue" panose="02000503000000020004" pitchFamily="2" charset="0"/>
-            </a:endParaRPr>
-          </a:p>
-          <a:p>
-            <a:pPr marL="914400" lvl="1" indent="-457200">
-              <a:buFont typeface="Arial" panose="020B0604020202020204" pitchFamily="34" charset="0"/>
-              <a:buChar char="•"/>
-              <a:defRPr/>
-            </a:pPr>
-            <a:r>
-              <a:rPr kumimoji="0" lang="en-US" sz="1600" b="0" i="0" u="none" strike="noStrike" kern="1200" cap="none" spc="0" normalizeH="0" baseline="0" noProof="0" dirty="0">
-                <a:ln>
-                  <a:noFill/>
-                </a:ln>
-                <a:solidFill>
-                  <a:prstClr val="white"/>
-                </a:solidFill>
-                <a:effectLst/>
-                <a:uLnTx/>
-                <a:uFillTx/>
-                <a:latin typeface="Helvetica Neue" panose="02000503000000020004" pitchFamily="2" charset="0"/>
-                <a:ea typeface="Helvetica Neue" panose="02000503000000020004" pitchFamily="2" charset="0"/>
-                <a:cs typeface="Helvetica Neue" panose="02000503000000020004" pitchFamily="2" charset="0"/>
-              </a:rPr>
-              <a:t>Put these points on copies of my new this is nature slide in this deck.</a:t>
-            </a:r>
-          </a:p>
-          <a:p>
-            <a:pPr marL="457200" marR="0" lvl="0" indent="-457200" algn="l" defTabSz="914400" rtl="0" eaLnBrk="1" fontAlgn="auto" latinLnBrk="0" hangingPunct="1">
-              <a:lnSpc>
-                <a:spcPct val="100000"/>
-              </a:lnSpc>
-              <a:spcBef>
-                <a:spcPts val="0"/>
-              </a:spcBef>
-              <a:spcAft>
-                <a:spcPts val="0"/>
-              </a:spcAft>
-              <a:buClrTx/>
-              <a:buSzTx/>
-              <a:buFont typeface="Arial" panose="020B0604020202020204" pitchFamily="34" charset="0"/>
-              <a:buChar char="•"/>
-              <a:tabLst/>
-              <a:defRPr/>
-            </a:pPr>
-            <a:endParaRPr kumimoji="0" lang="en-US" sz="1400" b="0" i="0" u="none" strike="noStrike" kern="1200" cap="none" spc="0" normalizeH="0" baseline="0" noProof="0" dirty="0">
-              <a:ln>
-                <a:noFill/>
-              </a:ln>
-              <a:solidFill>
-                <a:srgbClr val="FF0000"/>
-              </a:solidFill>
-              <a:effectLst/>
-              <a:uLnTx/>
-              <a:uFillTx/>
-              <a:latin typeface="Helvetica Neue" panose="02000503000000020004" pitchFamily="2" charset="0"/>
-              <a:ea typeface="Helvetica Neue" panose="02000503000000020004" pitchFamily="2" charset="0"/>
-              <a:cs typeface="Helvetica Neue" panose="02000503000000020004" pitchFamily="2" charset="0"/>
-            </a:endParaRPr>
-          </a:p>
-          <a:p>
-            <a:pPr marL="457200" marR="0" lvl="0" indent="-457200" algn="l" defTabSz="914400" rtl="0" eaLnBrk="1" fontAlgn="auto" latinLnBrk="0" hangingPunct="1">
-              <a:lnSpc>
-                <a:spcPct val="100000"/>
-              </a:lnSpc>
-              <a:spcBef>
-                <a:spcPts val="0"/>
-              </a:spcBef>
-              <a:spcAft>
-                <a:spcPts val="0"/>
-              </a:spcAft>
-              <a:buClrTx/>
-              <a:buSzTx/>
-              <a:buFont typeface="Arial" panose="020B0604020202020204" pitchFamily="34" charset="0"/>
-              <a:buChar char="•"/>
-              <a:tabLst/>
-              <a:defRPr/>
-            </a:pPr>
-            <a:endParaRPr kumimoji="0" lang="en-US" sz="1200" b="0" i="0" u="none" strike="noStrike" kern="1200" cap="none" spc="0" normalizeH="0" baseline="0" noProof="0" dirty="0">
-              <a:ln>
-                <a:noFill/>
-              </a:ln>
-              <a:solidFill>
-                <a:srgbClr val="FF0000"/>
-              </a:solidFill>
-              <a:effectLst/>
-              <a:uLnTx/>
-              <a:uFillTx/>
-              <a:latin typeface="Calibri" panose="020F0502020204030204"/>
-              <a:ea typeface="+mn-ea"/>
-              <a:cs typeface="+mn-cs"/>
-            </a:endParaRPr>
-          </a:p>
-          <a:p>
-            <a:pPr marL="457200" marR="0" lvl="0" indent="-457200" algn="l" defTabSz="914400" rtl="0" eaLnBrk="1" fontAlgn="auto" latinLnBrk="0" hangingPunct="1">
-              <a:lnSpc>
-                <a:spcPct val="100000"/>
-              </a:lnSpc>
-              <a:spcBef>
-                <a:spcPts val="0"/>
-              </a:spcBef>
-              <a:spcAft>
-                <a:spcPts val="0"/>
-              </a:spcAft>
-              <a:buClrTx/>
-              <a:buSzTx/>
-              <a:buFont typeface="Arial" panose="020B0604020202020204" pitchFamily="34" charset="0"/>
-              <a:buChar char="•"/>
-              <a:tabLst/>
-              <a:defRPr/>
-            </a:pPr>
-            <a:endParaRPr kumimoji="0" lang="en-US" sz="1200" b="0" i="0" u="none" strike="noStrike" kern="1200" cap="none" spc="0" normalizeH="0" baseline="0" noProof="0" dirty="0">
-              <a:ln>
-                <a:noFill/>
-              </a:ln>
-              <a:solidFill>
-                <a:prstClr val="black"/>
-              </a:solidFill>
-              <a:effectLst/>
-              <a:uLnTx/>
-              <a:uFillTx/>
-              <a:latin typeface="Calibri" panose="020F0502020204030204"/>
-              <a:ea typeface="+mn-ea"/>
-              <a:cs typeface="+mn-cs"/>
-            </a:endParaRPr>
           </a:p>
         </p:txBody>
       </p:sp>
@@ -22353,7 +21374,7 @@
                 <a:ea typeface="Helvetica Neue" panose="02000503000000020004" pitchFamily="2" charset="0"/>
                 <a:cs typeface="Helvetica Neue" panose="02000503000000020004" pitchFamily="2" charset="0"/>
               </a:rPr>
-              <a:t>Nature’s Solution to Zeno’s Paradox and the 1/r Potential Curve</a:t>
+              <a:t>Causal Wakes and the 1/r Curve</a:t>
             </a:r>
           </a:p>
         </p:txBody>
@@ -22418,7 +21439,7 @@
                 <a:ea typeface="Helvetica Neue" panose="02000503000000020004" pitchFamily="2" charset="0"/>
                 <a:cs typeface="Helvetica Neue" panose="02000503000000020004" pitchFamily="2" charset="0"/>
               </a:rPr>
-              <a:t>The 1/r curve is how the geometry of potential works in nature.</a:t>
+              <a:t>The 1/r curve is an effective trace of wake geometry, not a constraint that every architrino pair must remain on one static curve.</a:t>
             </a:r>
           </a:p>
           <a:p>
@@ -22454,7 +21475,7 @@
                 <a:ea typeface="Helvetica Neue" panose="02000503000000020004" pitchFamily="2" charset="0"/>
                 <a:cs typeface="Helvetica Neue" panose="02000503000000020004" pitchFamily="2" charset="0"/>
               </a:rPr>
-              <a:t>The reason Zeno’s Paradox is solved is that nature is not constrained so that every point potential relationship be on a 1/r potential curve.</a:t>
+              <a:t>A receiver can pass through many wake surfaces while its path is determined by the superposed causal-root ledger.</a:t>
             </a:r>
           </a:p>
           <a:p>
@@ -22490,7 +21511,7 @@
                 <a:ea typeface="Helvetica Neue" panose="02000503000000020004" pitchFamily="2" charset="0"/>
                 <a:cs typeface="Helvetica Neue" panose="02000503000000020004" pitchFamily="2" charset="0"/>
               </a:rPr>
-              <a:t>Point potentials routinely pass through 1/r potential curves on a per relationship basis.</a:t>
+              <a:t>In the super-field-speed regime, same-source roots can appear: an architrino may intercept its own earlier wake.</a:t>
             </a:r>
           </a:p>
           <a:p>
@@ -22526,395 +21547,8 @@
                 <a:ea typeface="Helvetica Neue" panose="02000503000000020004" pitchFamily="2" charset="0"/>
                 <a:cs typeface="Helvetica Neue" panose="02000503000000020004" pitchFamily="2" charset="0"/>
               </a:rPr>
-              <a:t>Argument via superposition: the receiver point potential has infinite (check) solutions on the vector line defined by E&gt;A.</a:t>
+              <a:t>The open calculation is to integrate that self-hit feedback and determine whether it approaches a finite branch, a divergence, or a rejected chart.</a:t>
             </a:r>
-          </a:p>
-          <a:p>
-            <a:pPr marL="914400" marR="0" lvl="1" indent="-457200" algn="l" defTabSz="914400" rtl="0" eaLnBrk="1" fontAlgn="auto" latinLnBrk="0" hangingPunct="1">
-              <a:lnSpc>
-                <a:spcPct val="100000"/>
-              </a:lnSpc>
-              <a:spcBef>
-                <a:spcPts val="0"/>
-              </a:spcBef>
-              <a:spcAft>
-                <a:spcPts val="0"/>
-              </a:spcAft>
-              <a:buClrTx/>
-              <a:buSzTx/>
-              <a:buFont typeface="Arial" panose="020B0604020202020204" pitchFamily="34" charset="0"/>
-              <a:buChar char="•"/>
-              <a:tabLst/>
-              <a:defRPr/>
-            </a:pPr>
-            <a:r>
-              <a:rPr kumimoji="0" lang="en-US" sz="1600" b="0" i="0" u="none" strike="noStrike" kern="1200" cap="none" spc="0" normalizeH="0" baseline="0" noProof="0" dirty="0">
-                <a:ln>
-                  <a:noFill/>
-                </a:ln>
-                <a:solidFill>
-                  <a:prstClr val="white"/>
-                </a:solidFill>
-                <a:effectLst/>
-                <a:uLnTx/>
-                <a:uFillTx/>
-                <a:latin typeface="Helvetica Neue" panose="02000503000000020004" pitchFamily="2" charset="0"/>
-                <a:ea typeface="Helvetica Neue" panose="02000503000000020004" pitchFamily="2" charset="0"/>
-                <a:cs typeface="Helvetica Neue" panose="02000503000000020004" pitchFamily="2" charset="0"/>
-              </a:rPr>
-              <a:t>And that is only one relationship. There are a countable infinity of relationships.</a:t>
-            </a:r>
-          </a:p>
-          <a:p>
-            <a:pPr marL="457200" marR="0" lvl="0" indent="-457200" algn="l" defTabSz="914400" rtl="0" eaLnBrk="1" fontAlgn="auto" latinLnBrk="0" hangingPunct="1">
-              <a:lnSpc>
-                <a:spcPct val="100000"/>
-              </a:lnSpc>
-              <a:spcBef>
-                <a:spcPts val="0"/>
-              </a:spcBef>
-              <a:spcAft>
-                <a:spcPts val="0"/>
-              </a:spcAft>
-              <a:buClrTx/>
-              <a:buSzTx/>
-              <a:buFont typeface="Arial" panose="020B0604020202020204" pitchFamily="34" charset="0"/>
-              <a:buChar char="•"/>
-              <a:tabLst/>
-              <a:defRPr/>
-            </a:pPr>
-            <a:r>
-              <a:rPr kumimoji="0" lang="en-US" sz="1600" b="0" i="0" u="none" strike="noStrike" kern="1200" cap="none" spc="0" normalizeH="0" baseline="0" noProof="0" dirty="0">
-                <a:ln>
-                  <a:noFill/>
-                </a:ln>
-                <a:solidFill>
-                  <a:prstClr val="white"/>
-                </a:solidFill>
-                <a:effectLst/>
-                <a:uLnTx/>
-                <a:uFillTx/>
-                <a:latin typeface="Helvetica Neue" panose="02000503000000020004" pitchFamily="2" charset="0"/>
-                <a:ea typeface="Helvetica Neue" panose="02000503000000020004" pitchFamily="2" charset="0"/>
-                <a:cs typeface="Helvetica Neue" panose="02000503000000020004" pitchFamily="2" charset="0"/>
-              </a:rPr>
-              <a:t>what about v&gt;@.  If it became isolated and all potential was it’s own repelling potential, well then what?  It would accelerate to some limit or infinite? Have to calculate the force from the 1/r curve given the energy just somehow edged v &gt; @.</a:t>
-            </a:r>
-          </a:p>
-          <a:p>
-            <a:pPr marL="457200" marR="0" lvl="0" indent="-457200" algn="l" defTabSz="914400" rtl="0" eaLnBrk="1" fontAlgn="auto" latinLnBrk="0" hangingPunct="1">
-              <a:lnSpc>
-                <a:spcPct val="100000"/>
-              </a:lnSpc>
-              <a:spcBef>
-                <a:spcPts val="0"/>
-              </a:spcBef>
-              <a:spcAft>
-                <a:spcPts val="0"/>
-              </a:spcAft>
-              <a:buClrTx/>
-              <a:buSzTx/>
-              <a:buFont typeface="Arial" panose="020B0604020202020204" pitchFamily="34" charset="0"/>
-              <a:buChar char="•"/>
-              <a:tabLst/>
-              <a:defRPr/>
-            </a:pPr>
-            <a:r>
-              <a:rPr kumimoji="0" lang="en-US" sz="1600" b="0" i="0" u="none" strike="noStrike" kern="1200" cap="none" spc="0" normalizeH="0" baseline="0" noProof="0" dirty="0">
-                <a:ln>
-                  <a:noFill/>
-                </a:ln>
-                <a:solidFill>
-                  <a:prstClr val="white"/>
-                </a:solidFill>
-                <a:effectLst/>
-                <a:uLnTx/>
-                <a:uFillTx/>
-                <a:latin typeface="Helvetica Neue" panose="02000503000000020004" pitchFamily="2" charset="0"/>
-                <a:ea typeface="Helvetica Neue" panose="02000503000000020004" pitchFamily="2" charset="0"/>
-                <a:cs typeface="Helvetica Neue" panose="02000503000000020004" pitchFamily="2" charset="0"/>
-              </a:rPr>
-              <a:t>It’s sort of like it would ride it’s own surf, continuously accelerating but by smaller amounts. what is the integral of 1/r?  ln(r)?</a:t>
-            </a:r>
-          </a:p>
-          <a:p>
-            <a:pPr marL="457200" marR="0" lvl="0" indent="-457200" algn="l" defTabSz="914400" rtl="0" eaLnBrk="1" fontAlgn="auto" latinLnBrk="0" hangingPunct="1">
-              <a:lnSpc>
-                <a:spcPct val="100000"/>
-              </a:lnSpc>
-              <a:spcBef>
-                <a:spcPts val="0"/>
-              </a:spcBef>
-              <a:spcAft>
-                <a:spcPts val="0"/>
-              </a:spcAft>
-              <a:buClrTx/>
-              <a:buSzTx/>
-              <a:buFont typeface="Arial" panose="020B0604020202020204" pitchFamily="34" charset="0"/>
-              <a:buChar char="•"/>
-              <a:tabLst/>
-              <a:defRPr/>
-            </a:pPr>
-            <a:r>
-              <a:rPr kumimoji="0" lang="en-US" sz="1600" b="0" i="0" u="none" strike="noStrike" kern="1200" cap="none" spc="0" normalizeH="0" baseline="0" noProof="0" dirty="0">
-                <a:ln>
-                  <a:noFill/>
-                </a:ln>
-                <a:solidFill>
-                  <a:prstClr val="white"/>
-                </a:solidFill>
-                <a:effectLst/>
-                <a:uLnTx/>
-                <a:uFillTx/>
-                <a:latin typeface="Helvetica Neue" panose="02000503000000020004" pitchFamily="2" charset="0"/>
-                <a:ea typeface="Helvetica Neue" panose="02000503000000020004" pitchFamily="2" charset="0"/>
-                <a:cs typeface="Helvetica Neue" panose="02000503000000020004" pitchFamily="2" charset="0"/>
-              </a:rPr>
-              <a:t>Point potentials can move through Dirac sphere streams and vice versa</a:t>
-            </a:r>
-          </a:p>
-          <a:p>
-            <a:pPr marL="457200" marR="0" lvl="0" indent="-457200" algn="l" defTabSz="914400" rtl="0" eaLnBrk="1" fontAlgn="auto" latinLnBrk="0" hangingPunct="1">
-              <a:lnSpc>
-                <a:spcPct val="100000"/>
-              </a:lnSpc>
-              <a:spcBef>
-                <a:spcPts val="0"/>
-              </a:spcBef>
-              <a:spcAft>
-                <a:spcPts val="0"/>
-              </a:spcAft>
-              <a:buClrTx/>
-              <a:buSzTx/>
-              <a:buFont typeface="Arial" panose="020B0604020202020204" pitchFamily="34" charset="0"/>
-              <a:buChar char="•"/>
-              <a:tabLst/>
-              <a:defRPr/>
-            </a:pPr>
-            <a:r>
-              <a:rPr kumimoji="0" lang="en-US" sz="1600" b="0" i="0" u="none" strike="noStrike" kern="1200" cap="none" spc="0" normalizeH="0" baseline="0" noProof="0" dirty="0">
-                <a:ln>
-                  <a:noFill/>
-                </a:ln>
-                <a:solidFill>
-                  <a:prstClr val="white"/>
-                </a:solidFill>
-                <a:effectLst/>
-                <a:uLnTx/>
-                <a:uFillTx/>
-                <a:latin typeface="Helvetica Neue" panose="02000503000000020004" pitchFamily="2" charset="0"/>
-                <a:ea typeface="Helvetica Neue" panose="02000503000000020004" pitchFamily="2" charset="0"/>
-                <a:cs typeface="Helvetica Neue" panose="02000503000000020004" pitchFamily="2" charset="0"/>
-              </a:rPr>
-              <a:t>A point potential is always intersecting at least one Dirac sphere from all other point potentials</a:t>
-            </a:r>
-          </a:p>
-          <a:p>
-            <a:pPr marL="457200" marR="0" lvl="0" indent="-457200" algn="l" defTabSz="914400" rtl="0" eaLnBrk="1" fontAlgn="auto" latinLnBrk="0" hangingPunct="1">
-              <a:lnSpc>
-                <a:spcPct val="100000"/>
-              </a:lnSpc>
-              <a:spcBef>
-                <a:spcPts val="0"/>
-              </a:spcBef>
-              <a:spcAft>
-                <a:spcPts val="0"/>
-              </a:spcAft>
-              <a:buClrTx/>
-              <a:buSzTx/>
-              <a:buFont typeface="Arial" panose="020B0604020202020204" pitchFamily="34" charset="0"/>
-              <a:buChar char="•"/>
-              <a:tabLst/>
-              <a:defRPr/>
-            </a:pPr>
-            <a:r>
-              <a:rPr kumimoji="0" lang="en-US" sz="1600" b="0" i="0" u="none" strike="noStrike" kern="1200" cap="none" spc="0" normalizeH="0" baseline="0" noProof="0" dirty="0">
-                <a:ln>
-                  <a:noFill/>
-                </a:ln>
-                <a:solidFill>
-                  <a:prstClr val="white"/>
-                </a:solidFill>
-                <a:effectLst/>
-                <a:uLnTx/>
-                <a:uFillTx/>
-                <a:latin typeface="Helvetica Neue" panose="02000503000000020004" pitchFamily="2" charset="0"/>
-                <a:ea typeface="Helvetica Neue" panose="02000503000000020004" pitchFamily="2" charset="0"/>
-                <a:cs typeface="Helvetica Neue" panose="02000503000000020004" pitchFamily="2" charset="0"/>
-              </a:rPr>
-              <a:t>Each point potential has vector velocities a) on the geodesic and b) on the line to the point of emission of each intersecting sphere stream.</a:t>
-            </a:r>
-          </a:p>
-          <a:p>
-            <a:pPr marL="457200" marR="0" lvl="0" indent="-457200" algn="l" defTabSz="914400" rtl="0" eaLnBrk="1" fontAlgn="auto" latinLnBrk="0" hangingPunct="1">
-              <a:lnSpc>
-                <a:spcPct val="100000"/>
-              </a:lnSpc>
-              <a:spcBef>
-                <a:spcPts val="0"/>
-              </a:spcBef>
-              <a:spcAft>
-                <a:spcPts val="0"/>
-              </a:spcAft>
-              <a:buClrTx/>
-              <a:buSzTx/>
-              <a:buFont typeface="Arial" panose="020B0604020202020204" pitchFamily="34" charset="0"/>
-              <a:buChar char="•"/>
-              <a:tabLst/>
-              <a:defRPr/>
-            </a:pPr>
-            <a:r>
-              <a:rPr kumimoji="0" lang="en-US" sz="1600" b="0" i="0" u="none" strike="noStrike" kern="1200" cap="none" spc="0" normalizeH="0" baseline="0" noProof="0" dirty="0">
-                <a:ln>
-                  <a:noFill/>
-                </a:ln>
-                <a:solidFill>
-                  <a:prstClr val="white"/>
-                </a:solidFill>
-                <a:effectLst/>
-                <a:uLnTx/>
-                <a:uFillTx/>
-                <a:latin typeface="Helvetica Neue" panose="02000503000000020004" pitchFamily="2" charset="0"/>
-                <a:ea typeface="Helvetica Neue" panose="02000503000000020004" pitchFamily="2" charset="0"/>
-                <a:cs typeface="Helvetica Neue" panose="02000503000000020004" pitchFamily="2" charset="0"/>
-              </a:rPr>
-              <a:t>And as your velocity adjusts, you are either surfing farther away in time, steady time, or closer in time to the point of emission.</a:t>
-            </a:r>
-          </a:p>
-          <a:p>
-            <a:pPr marL="457200" marR="0" lvl="0" indent="-457200" algn="l" defTabSz="914400" rtl="0" eaLnBrk="1" fontAlgn="auto" latinLnBrk="0" hangingPunct="1">
-              <a:lnSpc>
-                <a:spcPct val="100000"/>
-              </a:lnSpc>
-              <a:spcBef>
-                <a:spcPts val="0"/>
-              </a:spcBef>
-              <a:spcAft>
-                <a:spcPts val="0"/>
-              </a:spcAft>
-              <a:buClrTx/>
-              <a:buSzTx/>
-              <a:buFont typeface="Arial" panose="020B0604020202020204" pitchFamily="34" charset="0"/>
-              <a:buChar char="•"/>
-              <a:tabLst/>
-              <a:defRPr/>
-            </a:pPr>
-            <a:r>
-              <a:rPr kumimoji="0" lang="en-US" sz="1600" b="0" i="0" u="none" strike="noStrike" kern="1200" cap="none" spc="0" normalizeH="0" baseline="0" noProof="0" dirty="0">
-                <a:ln>
-                  <a:noFill/>
-                </a:ln>
-                <a:solidFill>
-                  <a:prstClr val="white"/>
-                </a:solidFill>
-                <a:effectLst/>
-                <a:uLnTx/>
-                <a:uFillTx/>
-                <a:latin typeface="Helvetica Neue" panose="02000503000000020004" pitchFamily="2" charset="0"/>
-                <a:ea typeface="Helvetica Neue" panose="02000503000000020004" pitchFamily="2" charset="0"/>
-                <a:cs typeface="Helvetica Neue" panose="02000503000000020004" pitchFamily="2" charset="0"/>
-              </a:rPr>
-              <a:t>hmm, that’s interesting. the surfer doesn’t really see a 1/r curve.</a:t>
-            </a:r>
-          </a:p>
-          <a:p>
-            <a:pPr marL="457200" marR="0" lvl="0" indent="-457200" algn="l" defTabSz="914400" rtl="0" eaLnBrk="1" fontAlgn="auto" latinLnBrk="0" hangingPunct="1">
-              <a:lnSpc>
-                <a:spcPct val="100000"/>
-              </a:lnSpc>
-              <a:spcBef>
-                <a:spcPts val="0"/>
-              </a:spcBef>
-              <a:spcAft>
-                <a:spcPts val="0"/>
-              </a:spcAft>
-              <a:buClrTx/>
-              <a:buSzTx/>
-              <a:buFont typeface="Arial" panose="020B0604020202020204" pitchFamily="34" charset="0"/>
-              <a:buChar char="•"/>
-              <a:tabLst/>
-              <a:defRPr/>
-            </a:pPr>
-            <a:endParaRPr kumimoji="0" lang="en-US" sz="1400" b="0" i="0" u="none" strike="noStrike" kern="1200" cap="none" spc="0" normalizeH="0" baseline="0" noProof="0" dirty="0">
-              <a:ln>
-                <a:noFill/>
-              </a:ln>
-              <a:solidFill>
-                <a:srgbClr val="FF0000"/>
-              </a:solidFill>
-              <a:effectLst/>
-              <a:uLnTx/>
-              <a:uFillTx/>
-              <a:latin typeface="Helvetica Neue" panose="02000503000000020004" pitchFamily="2" charset="0"/>
-              <a:ea typeface="Helvetica Neue" panose="02000503000000020004" pitchFamily="2" charset="0"/>
-              <a:cs typeface="Helvetica Neue" panose="02000503000000020004" pitchFamily="2" charset="0"/>
-            </a:endParaRPr>
-          </a:p>
-          <a:p>
-            <a:pPr marL="457200" marR="0" lvl="0" indent="-457200" algn="l" defTabSz="914400" rtl="0" eaLnBrk="1" fontAlgn="auto" latinLnBrk="0" hangingPunct="1">
-              <a:lnSpc>
-                <a:spcPct val="100000"/>
-              </a:lnSpc>
-              <a:spcBef>
-                <a:spcPts val="0"/>
-              </a:spcBef>
-              <a:spcAft>
-                <a:spcPts val="0"/>
-              </a:spcAft>
-              <a:buClrTx/>
-              <a:buSzTx/>
-              <a:buFont typeface="Arial" panose="020B0604020202020204" pitchFamily="34" charset="0"/>
-              <a:buChar char="•"/>
-              <a:tabLst/>
-              <a:defRPr/>
-            </a:pPr>
-            <a:endParaRPr kumimoji="0" lang="en-US" sz="1200" b="0" i="0" u="none" strike="noStrike" kern="1200" cap="none" spc="0" normalizeH="0" baseline="0" noProof="0" dirty="0">
-              <a:ln>
-                <a:noFill/>
-              </a:ln>
-              <a:solidFill>
-                <a:srgbClr val="FF0000"/>
-              </a:solidFill>
-              <a:effectLst/>
-              <a:uLnTx/>
-              <a:uFillTx/>
-              <a:latin typeface="Calibri" panose="020F0502020204030204"/>
-              <a:ea typeface="+mn-ea"/>
-              <a:cs typeface="+mn-cs"/>
-            </a:endParaRPr>
-          </a:p>
-          <a:p>
-            <a:pPr marL="457200" marR="0" lvl="0" indent="-457200" algn="l" defTabSz="914400" rtl="0" eaLnBrk="1" fontAlgn="auto" latinLnBrk="0" hangingPunct="1">
-              <a:lnSpc>
-                <a:spcPct val="100000"/>
-              </a:lnSpc>
-              <a:spcBef>
-                <a:spcPts val="0"/>
-              </a:spcBef>
-              <a:spcAft>
-                <a:spcPts val="0"/>
-              </a:spcAft>
-              <a:buClrTx/>
-              <a:buSzTx/>
-              <a:buFont typeface="Arial" panose="020B0604020202020204" pitchFamily="34" charset="0"/>
-              <a:buChar char="•"/>
-              <a:tabLst/>
-              <a:defRPr/>
-            </a:pPr>
-            <a:endParaRPr kumimoji="0" lang="en-US" sz="1200" b="0" i="0" u="none" strike="noStrike" kern="1200" cap="none" spc="0" normalizeH="0" baseline="0" noProof="0" dirty="0">
-              <a:ln>
-                <a:noFill/>
-              </a:ln>
-              <a:solidFill>
-                <a:prstClr val="black"/>
-              </a:solidFill>
-              <a:effectLst/>
-              <a:uLnTx/>
-              <a:uFillTx/>
-              <a:latin typeface="Calibri" panose="020F0502020204030204"/>
-              <a:ea typeface="+mn-ea"/>
-              <a:cs typeface="+mn-cs"/>
-            </a:endParaRPr>
           </a:p>
         </p:txBody>
       </p:sp>
@@ -23184,7 +21818,7 @@
                 <a:ea typeface="Helvetica Neue" panose="02000503000000020004" pitchFamily="2" charset="0"/>
                 <a:cs typeface="Helvetica Neue" panose="02000503000000020004" pitchFamily="2" charset="0"/>
               </a:rPr>
-              <a:t>Nature’s Solution to Zeno’s Paradox and the 1/r Potential Curve</a:t>
+              <a:t>Causal Wakes and the 1/r Curve</a:t>
             </a:r>
           </a:p>
         </p:txBody>
@@ -23249,107 +21883,8 @@
                 <a:ea typeface="Helvetica Neue" panose="02000503000000020004" pitchFamily="2" charset="0"/>
                 <a:cs typeface="Helvetica Neue" panose="02000503000000020004" pitchFamily="2" charset="0"/>
               </a:rPr>
-              <a:t>Zeno’s paradox</a:t>
+              <a:t>Zeno's paradox becomes a causal-root ledger problem: finite wake speed, continuous paths, and received hits replace infinite subdivision as the controlling geometry.</a:t>
             </a:r>
-          </a:p>
-          <a:p>
-            <a:pPr marL="457200" marR="0" lvl="0" indent="-457200" algn="l" defTabSz="914400" rtl="0" eaLnBrk="1" fontAlgn="auto" latinLnBrk="0" hangingPunct="1">
-              <a:lnSpc>
-                <a:spcPct val="100000"/>
-              </a:lnSpc>
-              <a:spcBef>
-                <a:spcPts val="0"/>
-              </a:spcBef>
-              <a:spcAft>
-                <a:spcPts val="0"/>
-              </a:spcAft>
-              <a:buClrTx/>
-              <a:buSzTx/>
-              <a:buFont typeface="Arial" panose="020B0604020202020204" pitchFamily="34" charset="0"/>
-              <a:buChar char="•"/>
-              <a:tabLst/>
-              <a:defRPr/>
-            </a:pPr>
-            <a:endParaRPr kumimoji="0" lang="en-US" sz="1400" b="0" i="0" u="none" strike="noStrike" kern="1200" cap="none" spc="0" normalizeH="0" baseline="0" noProof="0" dirty="0">
-              <a:ln>
-                <a:noFill/>
-              </a:ln>
-              <a:solidFill>
-                <a:srgbClr val="FF0000"/>
-              </a:solidFill>
-              <a:effectLst/>
-              <a:uLnTx/>
-              <a:uFillTx/>
-              <a:latin typeface="Helvetica Neue" panose="02000503000000020004" pitchFamily="2" charset="0"/>
-              <a:ea typeface="Helvetica Neue" panose="02000503000000020004" pitchFamily="2" charset="0"/>
-              <a:cs typeface="Helvetica Neue" panose="02000503000000020004" pitchFamily="2" charset="0"/>
-            </a:endParaRPr>
-          </a:p>
-          <a:p>
-            <a:pPr marL="457200" marR="0" lvl="0" indent="-457200" algn="l" defTabSz="914400" rtl="0" eaLnBrk="1" fontAlgn="auto" latinLnBrk="0" hangingPunct="1">
-              <a:lnSpc>
-                <a:spcPct val="100000"/>
-              </a:lnSpc>
-              <a:spcBef>
-                <a:spcPts val="0"/>
-              </a:spcBef>
-              <a:spcAft>
-                <a:spcPts val="0"/>
-              </a:spcAft>
-              <a:buClrTx/>
-              <a:buSzTx/>
-              <a:buFont typeface="Arial" panose="020B0604020202020204" pitchFamily="34" charset="0"/>
-              <a:buChar char="•"/>
-              <a:tabLst/>
-              <a:defRPr/>
-            </a:pPr>
-            <a:endParaRPr kumimoji="0" lang="en-US" sz="1200" b="0" i="0" u="none" strike="noStrike" kern="1200" cap="none" spc="0" normalizeH="0" baseline="0" noProof="0" dirty="0">
-              <a:ln>
-                <a:noFill/>
-              </a:ln>
-              <a:solidFill>
-                <a:srgbClr val="FF0000"/>
-              </a:solidFill>
-              <a:effectLst/>
-              <a:uLnTx/>
-              <a:uFillTx/>
-              <a:latin typeface="Calibri" panose="020F0502020204030204"/>
-              <a:ea typeface="+mn-ea"/>
-              <a:cs typeface="+mn-cs"/>
-            </a:endParaRPr>
-          </a:p>
-          <a:p>
-            <a:pPr marL="457200" marR="0" lvl="0" indent="-457200" algn="l" defTabSz="914400" rtl="0" eaLnBrk="1" fontAlgn="auto" latinLnBrk="0" hangingPunct="1">
-              <a:lnSpc>
-                <a:spcPct val="100000"/>
-              </a:lnSpc>
-              <a:spcBef>
-                <a:spcPts val="0"/>
-              </a:spcBef>
-              <a:spcAft>
-                <a:spcPts val="0"/>
-              </a:spcAft>
-              <a:buClrTx/>
-              <a:buSzTx/>
-              <a:buFont typeface="Arial" panose="020B0604020202020204" pitchFamily="34" charset="0"/>
-              <a:buChar char="•"/>
-              <a:tabLst/>
-              <a:defRPr/>
-            </a:pPr>
-            <a:endParaRPr kumimoji="0" lang="en-US" sz="1200" b="0" i="0" u="none" strike="noStrike" kern="1200" cap="none" spc="0" normalizeH="0" baseline="0" noProof="0" dirty="0">
-              <a:ln>
-                <a:noFill/>
-              </a:ln>
-              <a:solidFill>
-                <a:prstClr val="black"/>
-              </a:solidFill>
-              <a:effectLst/>
-              <a:uLnTx/>
-              <a:uFillTx/>
-              <a:latin typeface="Calibri" panose="020F0502020204030204"/>
-              <a:ea typeface="+mn-ea"/>
-              <a:cs typeface="+mn-cs"/>
-            </a:endParaRPr>
           </a:p>
         </p:txBody>
       </p:sp>
@@ -23375,7 +21910,7 @@
         </p:blipFill>
         <p:spPr>
           <a:xfrm>
-            <a:off x="5353693" y="1155560"/>
+            <a:off x="3120632" y="1544892"/>
             <a:ext cx="6572599" cy="5004080"/>
           </a:xfrm>
           <a:prstGeom prst="rect">
@@ -23387,619 +21922,6 @@
     <p:extLst>
       <p:ext uri="{BB962C8B-B14F-4D97-AF65-F5344CB8AC3E}">
         <p14:creationId xmlns:p14="http://schemas.microsoft.com/office/powerpoint/2010/main" val="1428032534"/>
-      </p:ext>
-    </p:extLst>
-  </p:cSld>
-  <p:clrMapOvr>
-    <a:masterClrMapping/>
-  </p:clrMapOvr>
-</p:sld>
-</file>
-
-<file path=ppt/slides/slide19.xml><?xml version="1.0" encoding="utf-8"?>
-<p:sld xmlns:a="http://schemas.openxmlformats.org/drawingml/2006/main" xmlns:r="http://schemas.openxmlformats.org/officeDocument/2006/relationships" xmlns:p="http://schemas.openxmlformats.org/presentationml/2006/main">
-  <p:cSld>
-    <p:bg>
-      <p:bgPr>
-        <a:solidFill>
-          <a:srgbClr val="7030A0"/>
-        </a:solidFill>
-        <a:effectLst/>
-      </p:bgPr>
-    </p:bg>
-    <p:spTree>
-      <p:nvGrpSpPr>
-        <p:cNvPr id="1" name="">
-          <a:extLst>
-            <a:ext uri="{FF2B5EF4-FFF2-40B4-BE49-F238E27FC236}">
-              <a16:creationId xmlns:a16="http://schemas.microsoft.com/office/drawing/2014/main" id="{94461D54-C3D4-6173-7074-88B839FAD340}"/>
-            </a:ext>
-          </a:extLst>
-        </p:cNvPr>
-        <p:cNvGrpSpPr/>
-        <p:nvPr/>
-      </p:nvGrpSpPr>
-      <p:grpSpPr>
-        <a:xfrm>
-          <a:off x="0" y="0"/>
-          <a:ext cx="0" cy="0"/>
-          <a:chOff x="0" y="0"/>
-          <a:chExt cx="0" cy="0"/>
-        </a:xfrm>
-      </p:grpSpPr>
-      <p:sp>
-        <p:nvSpPr>
-          <p:cNvPr id="5" name="Footer Placeholder 3">
-            <a:extLst>
-              <a:ext uri="{FF2B5EF4-FFF2-40B4-BE49-F238E27FC236}">
-                <a16:creationId xmlns:a16="http://schemas.microsoft.com/office/drawing/2014/main" id="{9BBE5192-E5D5-0FFC-28EA-A41B850A703E}"/>
-              </a:ext>
-            </a:extLst>
-          </p:cNvPr>
-          <p:cNvSpPr txBox="1">
-            <a:spLocks/>
-          </p:cNvSpPr>
-          <p:nvPr/>
-        </p:nvSpPr>
-        <p:spPr>
-          <a:xfrm>
-            <a:off x="10924248" y="6388602"/>
-            <a:ext cx="1142262" cy="365125"/>
-          </a:xfrm>
-          <a:prstGeom prst="rect">
-            <a:avLst/>
-          </a:prstGeom>
-        </p:spPr>
-        <p:txBody>
-          <a:bodyPr vert="horz" lIns="91440" tIns="45720" rIns="91440" bIns="45720" rtlCol="0" anchor="ctr"/>
-          <a:lstStyle>
-            <a:defPPr>
-              <a:defRPr lang="en-US"/>
-            </a:defPPr>
-            <a:lvl1pPr marL="0" algn="ctr" defTabSz="914400" rtl="0" eaLnBrk="1" latinLnBrk="0" hangingPunct="1">
-              <a:defRPr sz="1200" kern="1200">
-                <a:solidFill>
-                  <a:schemeClr val="tx1">
-                    <a:tint val="75000"/>
-                  </a:schemeClr>
-                </a:solidFill>
-                <a:latin typeface="+mn-lt"/>
-                <a:ea typeface="+mn-ea"/>
-                <a:cs typeface="+mn-cs"/>
-              </a:defRPr>
-            </a:lvl1pPr>
-            <a:lvl2pPr marL="457200" algn="l" defTabSz="914400" rtl="0" eaLnBrk="1" latinLnBrk="0" hangingPunct="1">
-              <a:defRPr sz="1800" kern="1200">
-                <a:solidFill>
-                  <a:schemeClr val="tx1"/>
-                </a:solidFill>
-                <a:latin typeface="+mn-lt"/>
-                <a:ea typeface="+mn-ea"/>
-                <a:cs typeface="+mn-cs"/>
-              </a:defRPr>
-            </a:lvl2pPr>
-            <a:lvl3pPr marL="914400" algn="l" defTabSz="914400" rtl="0" eaLnBrk="1" latinLnBrk="0" hangingPunct="1">
-              <a:defRPr sz="1800" kern="1200">
-                <a:solidFill>
-                  <a:schemeClr val="tx1"/>
-                </a:solidFill>
-                <a:latin typeface="+mn-lt"/>
-                <a:ea typeface="+mn-ea"/>
-                <a:cs typeface="+mn-cs"/>
-              </a:defRPr>
-            </a:lvl3pPr>
-            <a:lvl4pPr marL="1371600" algn="l" defTabSz="914400" rtl="0" eaLnBrk="1" latinLnBrk="0" hangingPunct="1">
-              <a:defRPr sz="1800" kern="1200">
-                <a:solidFill>
-                  <a:schemeClr val="tx1"/>
-                </a:solidFill>
-                <a:latin typeface="+mn-lt"/>
-                <a:ea typeface="+mn-ea"/>
-                <a:cs typeface="+mn-cs"/>
-              </a:defRPr>
-            </a:lvl4pPr>
-            <a:lvl5pPr marL="1828800" algn="l" defTabSz="914400" rtl="0" eaLnBrk="1" latinLnBrk="0" hangingPunct="1">
-              <a:defRPr sz="1800" kern="1200">
-                <a:solidFill>
-                  <a:schemeClr val="tx1"/>
-                </a:solidFill>
-                <a:latin typeface="+mn-lt"/>
-                <a:ea typeface="+mn-ea"/>
-                <a:cs typeface="+mn-cs"/>
-              </a:defRPr>
-            </a:lvl5pPr>
-            <a:lvl6pPr marL="2286000" algn="l" defTabSz="914400" rtl="0" eaLnBrk="1" latinLnBrk="0" hangingPunct="1">
-              <a:defRPr sz="1800" kern="1200">
-                <a:solidFill>
-                  <a:schemeClr val="tx1"/>
-                </a:solidFill>
-                <a:latin typeface="+mn-lt"/>
-                <a:ea typeface="+mn-ea"/>
-                <a:cs typeface="+mn-cs"/>
-              </a:defRPr>
-            </a:lvl6pPr>
-            <a:lvl7pPr marL="2743200" algn="l" defTabSz="914400" rtl="0" eaLnBrk="1" latinLnBrk="0" hangingPunct="1">
-              <a:defRPr sz="1800" kern="1200">
-                <a:solidFill>
-                  <a:schemeClr val="tx1"/>
-                </a:solidFill>
-                <a:latin typeface="+mn-lt"/>
-                <a:ea typeface="+mn-ea"/>
-                <a:cs typeface="+mn-cs"/>
-              </a:defRPr>
-            </a:lvl7pPr>
-            <a:lvl8pPr marL="3200400" algn="l" defTabSz="914400" rtl="0" eaLnBrk="1" latinLnBrk="0" hangingPunct="1">
-              <a:defRPr sz="1800" kern="1200">
-                <a:solidFill>
-                  <a:schemeClr val="tx1"/>
-                </a:solidFill>
-                <a:latin typeface="+mn-lt"/>
-                <a:ea typeface="+mn-ea"/>
-                <a:cs typeface="+mn-cs"/>
-              </a:defRPr>
-            </a:lvl8pPr>
-            <a:lvl9pPr marL="3657600" algn="l" defTabSz="914400" rtl="0" eaLnBrk="1" latinLnBrk="0" hangingPunct="1">
-              <a:defRPr sz="1800" kern="1200">
-                <a:solidFill>
-                  <a:schemeClr val="tx1"/>
-                </a:solidFill>
-                <a:latin typeface="+mn-lt"/>
-                <a:ea typeface="+mn-ea"/>
-                <a:cs typeface="+mn-cs"/>
-              </a:defRPr>
-            </a:lvl9pPr>
-          </a:lstStyle>
-          <a:p>
-            <a:pPr marL="0" marR="0" lvl="0" indent="0" algn="ctr" defTabSz="914400" rtl="0" eaLnBrk="1" fontAlgn="auto" latinLnBrk="0" hangingPunct="1">
-              <a:lnSpc>
-                <a:spcPct val="100000"/>
-              </a:lnSpc>
-              <a:spcBef>
-                <a:spcPts val="0"/>
-              </a:spcBef>
-              <a:spcAft>
-                <a:spcPts val="0"/>
-              </a:spcAft>
-              <a:buClrTx/>
-              <a:buSzTx/>
-              <a:buFontTx/>
-              <a:buNone/>
-              <a:tabLst/>
-              <a:defRPr/>
-            </a:pPr>
-            <a:r>
-              <a:rPr kumimoji="0" lang="en-US" sz="1200" b="0" i="0" u="none" strike="noStrike" kern="1200" cap="none" spc="0" normalizeH="0" baseline="0" noProof="0" dirty="0">
-                <a:ln>
-                  <a:noFill/>
-                </a:ln>
-                <a:solidFill>
-                  <a:prstClr val="black">
-                    <a:tint val="75000"/>
-                  </a:prstClr>
-                </a:solidFill>
-                <a:effectLst/>
-                <a:uLnTx/>
-                <a:uFillTx/>
-                <a:latin typeface="Helvetica Neue" panose="02000503000000020004" pitchFamily="2" charset="0"/>
-                <a:ea typeface="Helvetica Neue" panose="02000503000000020004" pitchFamily="2" charset="0"/>
-                <a:cs typeface="Helvetica Neue" panose="02000503000000020004" pitchFamily="2" charset="0"/>
-              </a:rPr>
-              <a:t>J Mark Morris</a:t>
-            </a:r>
-          </a:p>
-        </p:txBody>
-      </p:sp>
-      <p:sp>
-        <p:nvSpPr>
-          <p:cNvPr id="19" name="Rectangle 18">
-            <a:extLst>
-              <a:ext uri="{FF2B5EF4-FFF2-40B4-BE49-F238E27FC236}">
-                <a16:creationId xmlns:a16="http://schemas.microsoft.com/office/drawing/2014/main" id="{93EAC0C0-7BBE-0357-9019-856A0FC9E286}"/>
-              </a:ext>
-            </a:extLst>
-          </p:cNvPr>
-          <p:cNvSpPr/>
-          <p:nvPr/>
-        </p:nvSpPr>
-        <p:spPr>
-          <a:xfrm>
-            <a:off x="680197" y="309028"/>
-            <a:ext cx="11009488" cy="523220"/>
-          </a:xfrm>
-          <a:prstGeom prst="rect">
-            <a:avLst/>
-          </a:prstGeom>
-          <a:noFill/>
-        </p:spPr>
-        <p:txBody>
-          <a:bodyPr wrap="none">
-            <a:spAutoFit/>
-          </a:bodyPr>
-          <a:lstStyle/>
-          <a:p>
-            <a:pPr marL="0" marR="0" lvl="0" indent="0" algn="ctr" defTabSz="914400" rtl="0" eaLnBrk="1" fontAlgn="auto" latinLnBrk="0" hangingPunct="1">
-              <a:lnSpc>
-                <a:spcPct val="100000"/>
-              </a:lnSpc>
-              <a:spcBef>
-                <a:spcPts val="0"/>
-              </a:spcBef>
-              <a:spcAft>
-                <a:spcPts val="0"/>
-              </a:spcAft>
-              <a:buClrTx/>
-              <a:buSzTx/>
-              <a:buFontTx/>
-              <a:buNone/>
-              <a:tabLst/>
-              <a:defRPr/>
-            </a:pPr>
-            <a:r>
-              <a:rPr kumimoji="0" lang="en-US" sz="2800" b="1" i="0" u="none" strike="noStrike" kern="1200" cap="none" spc="0" normalizeH="0" baseline="0" noProof="0" dirty="0">
-                <a:ln>
-                  <a:noFill/>
-                </a:ln>
-                <a:solidFill>
-                  <a:prstClr val="white"/>
-                </a:solidFill>
-                <a:effectLst/>
-                <a:uLnTx/>
-                <a:uFillTx/>
-                <a:latin typeface="Helvetica Neue" panose="02000503000000020004" pitchFamily="2" charset="0"/>
-                <a:ea typeface="Helvetica Neue" panose="02000503000000020004" pitchFamily="2" charset="0"/>
-                <a:cs typeface="Helvetica Neue" panose="02000503000000020004" pitchFamily="2" charset="0"/>
-              </a:rPr>
-              <a:t>Nature’s Solution to Zeno’s Paradox and the 1/r Potential Curve</a:t>
-            </a:r>
-          </a:p>
-        </p:txBody>
-      </p:sp>
-      <p:sp>
-        <p:nvSpPr>
-          <p:cNvPr id="2" name="TextBox 1">
-            <a:extLst>
-              <a:ext uri="{FF2B5EF4-FFF2-40B4-BE49-F238E27FC236}">
-                <a16:creationId xmlns:a16="http://schemas.microsoft.com/office/drawing/2014/main" id="{F8E0EEDC-0BCA-3889-91A4-77BD378C2B04}"/>
-              </a:ext>
-            </a:extLst>
-          </p:cNvPr>
-          <p:cNvSpPr txBox="1"/>
-          <p:nvPr/>
-        </p:nvSpPr>
-        <p:spPr>
-          <a:xfrm>
-            <a:off x="337206" y="907318"/>
-            <a:ext cx="11695463" cy="1754326"/>
-          </a:xfrm>
-          <a:prstGeom prst="rect">
-            <a:avLst/>
-          </a:prstGeom>
-          <a:noFill/>
-        </p:spPr>
-        <p:txBody>
-          <a:bodyPr wrap="square" rtlCol="0">
-            <a:spAutoFit/>
-          </a:bodyPr>
-          <a:lstStyle/>
-          <a:p>
-            <a:pPr marL="457200" marR="0" lvl="0" indent="-457200" algn="l" defTabSz="914400" rtl="0" eaLnBrk="1" fontAlgn="auto" latinLnBrk="0" hangingPunct="1">
-              <a:lnSpc>
-                <a:spcPct val="100000"/>
-              </a:lnSpc>
-              <a:spcBef>
-                <a:spcPts val="0"/>
-              </a:spcBef>
-              <a:spcAft>
-                <a:spcPts val="0"/>
-              </a:spcAft>
-              <a:buClrTx/>
-              <a:buSzTx/>
-              <a:buFont typeface="Arial" panose="020B0604020202020204" pitchFamily="34" charset="0"/>
-              <a:buChar char="•"/>
-              <a:tabLst/>
-              <a:defRPr/>
-            </a:pPr>
-            <a:endParaRPr kumimoji="0" lang="en-US" sz="1400" b="0" i="0" u="none" strike="noStrike" kern="1200" cap="none" spc="0" normalizeH="0" baseline="0" noProof="0" dirty="0">
-              <a:ln>
-                <a:noFill/>
-              </a:ln>
-              <a:solidFill>
-                <a:srgbClr val="FF0000"/>
-              </a:solidFill>
-              <a:effectLst/>
-              <a:uLnTx/>
-              <a:uFillTx/>
-              <a:latin typeface="Helvetica Neue" panose="02000503000000020004" pitchFamily="2" charset="0"/>
-              <a:ea typeface="Helvetica Neue" panose="02000503000000020004" pitchFamily="2" charset="0"/>
-              <a:cs typeface="Helvetica Neue" panose="02000503000000020004" pitchFamily="2" charset="0"/>
-            </a:endParaRPr>
-          </a:p>
-          <a:p>
-            <a:pPr marL="457200" marR="0" lvl="0" indent="-457200" algn="l" defTabSz="914400" rtl="0" eaLnBrk="1" fontAlgn="auto" latinLnBrk="0" hangingPunct="1">
-              <a:lnSpc>
-                <a:spcPct val="100000"/>
-              </a:lnSpc>
-              <a:spcBef>
-                <a:spcPts val="0"/>
-              </a:spcBef>
-              <a:spcAft>
-                <a:spcPts val="0"/>
-              </a:spcAft>
-              <a:buClrTx/>
-              <a:buSzTx/>
-              <a:buFont typeface="Arial" panose="020B0604020202020204" pitchFamily="34" charset="0"/>
-              <a:buChar char="•"/>
-              <a:tabLst/>
-              <a:defRPr/>
-            </a:pPr>
-            <a:r>
-              <a:rPr kumimoji="0" lang="en-US" sz="1400" b="0" i="0" u="none" strike="noStrike" kern="1200" cap="none" spc="0" normalizeH="0" baseline="0" noProof="0" dirty="0">
-                <a:ln>
-                  <a:noFill/>
-                </a:ln>
-                <a:solidFill>
-                  <a:srgbClr val="FF0000"/>
-                </a:solidFill>
-                <a:effectLst/>
-                <a:uLnTx/>
-                <a:uFillTx/>
-                <a:latin typeface="Helvetica Neue" panose="02000503000000020004" pitchFamily="2" charset="0"/>
-                <a:ea typeface="Helvetica Neue" panose="02000503000000020004" pitchFamily="2" charset="0"/>
-                <a:cs typeface="Helvetica Neue" panose="02000503000000020004" pitchFamily="2" charset="0"/>
-              </a:rPr>
-              <a:t>add a 1/r curve – positive and negative</a:t>
-            </a:r>
-          </a:p>
-          <a:p>
-            <a:pPr marL="457200" marR="0" lvl="0" indent="-457200" algn="l" defTabSz="914400" rtl="0" eaLnBrk="1" fontAlgn="auto" latinLnBrk="0" hangingPunct="1">
-              <a:lnSpc>
-                <a:spcPct val="100000"/>
-              </a:lnSpc>
-              <a:spcBef>
-                <a:spcPts val="0"/>
-              </a:spcBef>
-              <a:spcAft>
-                <a:spcPts val="0"/>
-              </a:spcAft>
-              <a:buClrTx/>
-              <a:buSzTx/>
-              <a:buFont typeface="Arial" panose="020B0604020202020204" pitchFamily="34" charset="0"/>
-              <a:buChar char="•"/>
-              <a:tabLst/>
-              <a:defRPr/>
-            </a:pPr>
-            <a:r>
-              <a:rPr kumimoji="0" lang="en-US" sz="1400" b="0" i="0" u="none" strike="noStrike" kern="1200" cap="none" spc="0" normalizeH="0" baseline="0" noProof="0" dirty="0">
-                <a:ln>
-                  <a:noFill/>
-                </a:ln>
-                <a:solidFill>
-                  <a:srgbClr val="FF0000"/>
-                </a:solidFill>
-                <a:effectLst/>
-                <a:uLnTx/>
-                <a:uFillTx/>
-                <a:latin typeface="Helvetica Neue" panose="02000503000000020004" pitchFamily="2" charset="0"/>
-                <a:ea typeface="Helvetica Neue" panose="02000503000000020004" pitchFamily="2" charset="0"/>
-                <a:cs typeface="Helvetica Neue" panose="02000503000000020004" pitchFamily="2" charset="0"/>
-              </a:rPr>
-              <a:t>expand this into a set of slides</a:t>
-            </a:r>
-          </a:p>
-          <a:p>
-            <a:pPr marL="457200" marR="0" lvl="0" indent="-457200" algn="l" defTabSz="914400" rtl="0" eaLnBrk="1" fontAlgn="auto" latinLnBrk="0" hangingPunct="1">
-              <a:lnSpc>
-                <a:spcPct val="100000"/>
-              </a:lnSpc>
-              <a:spcBef>
-                <a:spcPts val="0"/>
-              </a:spcBef>
-              <a:spcAft>
-                <a:spcPts val="0"/>
-              </a:spcAft>
-              <a:buClrTx/>
-              <a:buSzTx/>
-              <a:buFont typeface="Arial" panose="020B0604020202020204" pitchFamily="34" charset="0"/>
-              <a:buChar char="•"/>
-              <a:tabLst/>
-              <a:defRPr/>
-            </a:pPr>
-            <a:r>
-              <a:rPr kumimoji="0" lang="en-US" sz="1400" b="0" i="0" u="none" strike="noStrike" kern="1200" cap="none" spc="0" normalizeH="0" baseline="0" noProof="0" dirty="0">
-                <a:ln>
-                  <a:noFill/>
-                </a:ln>
-                <a:solidFill>
-                  <a:srgbClr val="FF0000"/>
-                </a:solidFill>
-                <a:effectLst/>
-                <a:uLnTx/>
-                <a:uFillTx/>
-                <a:latin typeface="Helvetica Neue" panose="02000503000000020004" pitchFamily="2" charset="0"/>
-                <a:ea typeface="Helvetica Neue" panose="02000503000000020004" pitchFamily="2" charset="0"/>
-                <a:cs typeface="Helvetica Neue" panose="02000503000000020004" pitchFamily="2" charset="0"/>
-              </a:rPr>
-              <a:t>search for meme’s.</a:t>
-            </a:r>
-          </a:p>
-          <a:p>
-            <a:pPr marL="457200" marR="0" lvl="0" indent="-457200" algn="l" defTabSz="914400" rtl="0" eaLnBrk="1" fontAlgn="auto" latinLnBrk="0" hangingPunct="1">
-              <a:lnSpc>
-                <a:spcPct val="100000"/>
-              </a:lnSpc>
-              <a:spcBef>
-                <a:spcPts val="0"/>
-              </a:spcBef>
-              <a:spcAft>
-                <a:spcPts val="0"/>
-              </a:spcAft>
-              <a:buClrTx/>
-              <a:buSzTx/>
-              <a:buFont typeface="Arial" panose="020B0604020202020204" pitchFamily="34" charset="0"/>
-              <a:buChar char="•"/>
-              <a:tabLst/>
-              <a:defRPr/>
-            </a:pPr>
-            <a:r>
-              <a:rPr kumimoji="0" lang="en-US" sz="1400" b="0" i="0" u="none" strike="noStrike" kern="1200" cap="none" spc="0" normalizeH="0" baseline="0" noProof="0" dirty="0">
-                <a:ln>
-                  <a:noFill/>
-                </a:ln>
-                <a:solidFill>
-                  <a:srgbClr val="FF0000"/>
-                </a:solidFill>
-                <a:effectLst/>
-                <a:uLnTx/>
-                <a:uFillTx/>
-                <a:latin typeface="Helvetica Neue" panose="02000503000000020004" pitchFamily="2" charset="0"/>
-                <a:ea typeface="Helvetica Neue" panose="02000503000000020004" pitchFamily="2" charset="0"/>
-                <a:cs typeface="Helvetica Neue" panose="02000503000000020004" pitchFamily="2" charset="0"/>
-              </a:rPr>
-              <a:t>check references</a:t>
-            </a:r>
-          </a:p>
-          <a:p>
-            <a:pPr marL="457200" marR="0" lvl="0" indent="-457200" algn="l" defTabSz="914400" rtl="0" eaLnBrk="1" fontAlgn="auto" latinLnBrk="0" hangingPunct="1">
-              <a:lnSpc>
-                <a:spcPct val="100000"/>
-              </a:lnSpc>
-              <a:spcBef>
-                <a:spcPts val="0"/>
-              </a:spcBef>
-              <a:spcAft>
-                <a:spcPts val="0"/>
-              </a:spcAft>
-              <a:buClrTx/>
-              <a:buSzTx/>
-              <a:buFont typeface="Arial" panose="020B0604020202020204" pitchFamily="34" charset="0"/>
-              <a:buChar char="•"/>
-              <a:tabLst/>
-              <a:defRPr/>
-            </a:pPr>
-            <a:r>
-              <a:rPr kumimoji="0" lang="en-US" sz="1400" b="0" i="0" u="none" strike="noStrike" kern="1200" cap="none" spc="0" normalizeH="0" baseline="0" noProof="0" dirty="0">
-                <a:ln>
-                  <a:noFill/>
-                </a:ln>
-                <a:solidFill>
-                  <a:srgbClr val="FF0000"/>
-                </a:solidFill>
-                <a:effectLst/>
-                <a:uLnTx/>
-                <a:uFillTx/>
-                <a:latin typeface="Helvetica Neue" panose="02000503000000020004" pitchFamily="2" charset="0"/>
-                <a:ea typeface="Helvetica Neue" panose="02000503000000020004" pitchFamily="2" charset="0"/>
-                <a:cs typeface="Helvetica Neue" panose="02000503000000020004" pitchFamily="2" charset="0"/>
-              </a:rPr>
-              <a:t>aha – I had this idea in my geometry of nature </a:t>
-            </a:r>
-            <a:r>
-              <a:rPr kumimoji="0" lang="en-US" sz="1400" b="0" i="0" u="none" strike="noStrike" kern="1200" cap="none" spc="0" normalizeH="0" baseline="0" noProof="0" dirty="0" err="1">
-                <a:ln>
-                  <a:noFill/>
-                </a:ln>
-                <a:solidFill>
-                  <a:srgbClr val="FF0000"/>
-                </a:solidFill>
-                <a:effectLst/>
-                <a:uLnTx/>
-                <a:uFillTx/>
-                <a:latin typeface="Helvetica Neue" panose="02000503000000020004" pitchFamily="2" charset="0"/>
-                <a:ea typeface="Helvetica Neue" panose="02000503000000020004" pitchFamily="2" charset="0"/>
-                <a:cs typeface="Helvetica Neue" panose="02000503000000020004" pitchFamily="2" charset="0"/>
-              </a:rPr>
-              <a:t>mindmap</a:t>
-            </a:r>
-            <a:r>
-              <a:rPr kumimoji="0" lang="en-US" sz="1400" b="0" i="0" u="none" strike="noStrike" kern="1200" cap="none" spc="0" normalizeH="0" baseline="0" noProof="0" dirty="0">
-                <a:ln>
-                  <a:noFill/>
-                </a:ln>
-                <a:solidFill>
-                  <a:srgbClr val="FF0000"/>
-                </a:solidFill>
-                <a:effectLst/>
-                <a:uLnTx/>
-                <a:uFillTx/>
-                <a:latin typeface="Helvetica Neue" panose="02000503000000020004" pitchFamily="2" charset="0"/>
-                <a:ea typeface="Helvetica Neue" panose="02000503000000020004" pitchFamily="2" charset="0"/>
-                <a:cs typeface="Helvetica Neue" panose="02000503000000020004" pitchFamily="2" charset="0"/>
-              </a:rPr>
-              <a:t>!</a:t>
-            </a:r>
-          </a:p>
-          <a:p>
-            <a:pPr marL="457200" marR="0" lvl="0" indent="-457200" algn="l" defTabSz="914400" rtl="0" eaLnBrk="1" fontAlgn="auto" latinLnBrk="0" hangingPunct="1">
-              <a:lnSpc>
-                <a:spcPct val="100000"/>
-              </a:lnSpc>
-              <a:spcBef>
-                <a:spcPts val="0"/>
-              </a:spcBef>
-              <a:spcAft>
-                <a:spcPts val="0"/>
-              </a:spcAft>
-              <a:buClrTx/>
-              <a:buSzTx/>
-              <a:buFont typeface="Arial" panose="020B0604020202020204" pitchFamily="34" charset="0"/>
-              <a:buChar char="•"/>
-              <a:tabLst/>
-              <a:defRPr/>
-            </a:pPr>
-            <a:endParaRPr kumimoji="0" lang="en-US" sz="1200" b="0" i="0" u="none" strike="noStrike" kern="1200" cap="none" spc="0" normalizeH="0" baseline="0" noProof="0" dirty="0">
-              <a:ln>
-                <a:noFill/>
-              </a:ln>
-              <a:solidFill>
-                <a:srgbClr val="FF0000"/>
-              </a:solidFill>
-              <a:effectLst/>
-              <a:uLnTx/>
-              <a:uFillTx/>
-              <a:latin typeface="Calibri" panose="020F0502020204030204"/>
-              <a:ea typeface="+mn-ea"/>
-              <a:cs typeface="+mn-cs"/>
-            </a:endParaRPr>
-          </a:p>
-          <a:p>
-            <a:pPr marL="457200" marR="0" lvl="0" indent="-457200" algn="l" defTabSz="914400" rtl="0" eaLnBrk="1" fontAlgn="auto" latinLnBrk="0" hangingPunct="1">
-              <a:lnSpc>
-                <a:spcPct val="100000"/>
-              </a:lnSpc>
-              <a:spcBef>
-                <a:spcPts val="0"/>
-              </a:spcBef>
-              <a:spcAft>
-                <a:spcPts val="0"/>
-              </a:spcAft>
-              <a:buClrTx/>
-              <a:buSzTx/>
-              <a:buFont typeface="Arial" panose="020B0604020202020204" pitchFamily="34" charset="0"/>
-              <a:buChar char="•"/>
-              <a:tabLst/>
-              <a:defRPr/>
-            </a:pPr>
-            <a:endParaRPr kumimoji="0" lang="en-US" sz="1200" b="0" i="0" u="none" strike="noStrike" kern="1200" cap="none" spc="0" normalizeH="0" baseline="0" noProof="0" dirty="0">
-              <a:ln>
-                <a:noFill/>
-              </a:ln>
-              <a:solidFill>
-                <a:prstClr val="black"/>
-              </a:solidFill>
-              <a:effectLst/>
-              <a:uLnTx/>
-              <a:uFillTx/>
-              <a:latin typeface="Calibri" panose="020F0502020204030204"/>
-              <a:ea typeface="+mn-ea"/>
-              <a:cs typeface="+mn-cs"/>
-            </a:endParaRPr>
-          </a:p>
-        </p:txBody>
-      </p:sp>
-    </p:spTree>
-    <p:extLst>
-      <p:ext uri="{BB962C8B-B14F-4D97-AF65-F5344CB8AC3E}">
-        <p14:creationId xmlns:p14="http://schemas.microsoft.com/office/powerpoint/2010/main" val="3173366973"/>
       </p:ext>
     </p:extLst>
   </p:cSld>
@@ -24364,7 +22286,7 @@
                   <a:ea typeface="Helvetica Neue" panose="02000503000000020004" pitchFamily="2" charset="0"/>
                   <a:cs typeface="Helvetica Neue" panose="02000503000000020004" pitchFamily="2" charset="0"/>
                 </a:rPr>
-                <a:t>Absolute Euclidean Time</a:t>
+                <a:t>Absolute Time</a:t>
               </a:r>
             </a:p>
           </p:txBody>
@@ -24396,42 +22318,6 @@
               <a:spAutoFit/>
             </a:bodyPr>
             <a:lstStyle/>
-            <a:p>
-              <a:pPr marL="0" marR="0" lvl="0" indent="0" algn="ctr" defTabSz="914400" rtl="0" eaLnBrk="1" fontAlgn="auto" latinLnBrk="0" hangingPunct="1">
-                <a:lnSpc>
-                  <a:spcPct val="100000"/>
-                </a:lnSpc>
-                <a:spcBef>
-                  <a:spcPts val="0"/>
-                </a:spcBef>
-                <a:spcAft>
-                  <a:spcPts val="0"/>
-                </a:spcAft>
-                <a:buClrTx/>
-                <a:buSzTx/>
-                <a:buFontTx/>
-                <a:buNone/>
-                <a:tabLst/>
-                <a:defRPr/>
-              </a:pPr>
-              <a:r>
-                <a:rPr kumimoji="0" lang="en-US" sz="1800" b="0" i="0" u="none" strike="noStrike" kern="1200" cap="none" spc="0" normalizeH="0" baseline="0" noProof="0" dirty="0">
-                  <a:ln>
-                    <a:noFill/>
-                  </a:ln>
-                  <a:solidFill>
-                    <a:prstClr val="white"/>
-                  </a:solidFill>
-                  <a:effectLst/>
-                  <a:uLnTx/>
-                  <a:uFillTx/>
-                  <a:latin typeface="Helvetica Neue" panose="02000503000000020004" pitchFamily="2" charset="0"/>
-                  <a:ea typeface="Helvetica Neue" panose="02000503000000020004" pitchFamily="2" charset="0"/>
-                  <a:cs typeface="Helvetica Neue" panose="02000503000000020004" pitchFamily="2" charset="0"/>
-                </a:rPr>
-                <a:t>Absolute </a:t>
-              </a:r>
-            </a:p>
             <a:p>
               <a:pPr marL="0" marR="0" lvl="0" indent="0" algn="ctr" defTabSz="914400" rtl="0" eaLnBrk="1" fontAlgn="auto" latinLnBrk="0" hangingPunct="1">
                 <a:lnSpc>
@@ -24501,7 +22387,7 @@
                   <a:ea typeface="Helvetica Neue" panose="02000503000000020004" pitchFamily="2" charset="0"/>
                   <a:cs typeface="Helvetica Neue" panose="02000503000000020004" pitchFamily="2" charset="0"/>
                 </a:rPr>
-                <a:t>3D Space</a:t>
+                <a:t>Void</a:t>
               </a:r>
             </a:p>
           </p:txBody>
@@ -25073,7 +22959,7 @@
                 <a:ea typeface="Helvetica Neue" panose="02000503000000020004" pitchFamily="2" charset="0"/>
                 <a:cs typeface="Helvetica Neue" panose="02000503000000020004" pitchFamily="2" charset="0"/>
               </a:rPr>
-              <a:t>r = @t</a:t>
+              <a:t>r = c_f t</a:t>
             </a:r>
           </a:p>
         </p:txBody>
@@ -25141,7 +23027,7 @@
                 <a:ea typeface="Helvetica Neue" panose="02000503000000020004" pitchFamily="2" charset="0"/>
                 <a:cs typeface="Helvetica Neue" panose="02000503000000020004" pitchFamily="2" charset="0"/>
               </a:rPr>
-              <a:t>Electric Potential Field Tracers</a:t>
+              <a:t>Causal Wake Tracers</a:t>
             </a:r>
             <a:endParaRPr kumimoji="0" lang="en-US" sz="1100" b="0" i="1" u="none" strike="noStrike" kern="1200" cap="none" spc="0" normalizeH="0" baseline="0" noProof="0" dirty="0">
               <a:ln>
@@ -25264,7 +23150,7 @@
         <p:spPr>
           <a:xfrm>
             <a:off x="8965473" y="1654209"/>
-            <a:ext cx="2558673" cy="707886"/>
+            <a:ext cx="2726994" cy="707886"/>
           </a:xfrm>
           <a:prstGeom prst="rect">
             <a:avLst/>
@@ -25313,7 +23199,7 @@
                 <a:ea typeface="Helvetica Neue" panose="02000503000000020004" pitchFamily="2" charset="0"/>
                 <a:cs typeface="Helvetica Neue" panose="02000503000000020004" pitchFamily="2" charset="0"/>
               </a:rPr>
-              <a:t>Field Speed @ is a Universal Constant</a:t>
+              <a:t>Wake Speed c_f is a Primitive Constant</a:t>
             </a:r>
           </a:p>
         </p:txBody>
@@ -25378,7 +23264,7 @@
                 <a:ea typeface="Helvetica Neue" panose="02000503000000020004" pitchFamily="2" charset="0"/>
                 <a:cs typeface="Helvetica Neue" panose="02000503000000020004" pitchFamily="2" charset="0"/>
               </a:rPr>
-              <a:t>A point potential with velocity = 0 emits potential spheres, all with the same origin.</a:t>
+              <a:t>An architrino at rest emits causal wake surfaces from a common position.</a:t>
             </a:r>
           </a:p>
         </p:txBody>
@@ -25443,33 +23329,8 @@
                 <a:ea typeface="Helvetica Neue" panose="02000503000000020004" pitchFamily="2" charset="0"/>
                 <a:cs typeface="Helvetica Neue" panose="02000503000000020004" pitchFamily="2" charset="0"/>
               </a:rPr>
-              <a:t>Point Potential on Linear Path with Velocity v = </a:t>
+              <a:t>Architrino on Linear Path with Velocity v = 0</a:t>
             </a:r>
-            <a:r>
-              <a:rPr lang="en-US" sz="3200" b="1" dirty="0">
-                <a:solidFill>
-                  <a:prstClr val="white"/>
-                </a:solidFill>
-                <a:latin typeface="Helvetica Neue" panose="02000503000000020004" pitchFamily="2" charset="0"/>
-                <a:ea typeface="Helvetica Neue" panose="02000503000000020004" pitchFamily="2" charset="0"/>
-                <a:cs typeface="Helvetica Neue" panose="02000503000000020004" pitchFamily="2" charset="0"/>
-              </a:rPr>
-              <a:t>0</a:t>
-            </a:r>
-            <a:endParaRPr kumimoji="0" lang="en-US" sz="3200" b="1" i="0" u="none" strike="noStrike" kern="1200" cap="none" spc="0" normalizeH="0" baseline="0" noProof="0" dirty="0">
-              <a:ln>
-                <a:noFill/>
-              </a:ln>
-              <a:solidFill>
-                <a:prstClr val="white"/>
-              </a:solidFill>
-              <a:effectLst/>
-              <a:uLnTx/>
-              <a:uFillTx/>
-              <a:latin typeface="Helvetica Neue" panose="02000503000000020004" pitchFamily="2" charset="0"/>
-              <a:ea typeface="Helvetica Neue" panose="02000503000000020004" pitchFamily="2" charset="0"/>
-              <a:cs typeface="Helvetica Neue" panose="02000503000000020004" pitchFamily="2" charset="0"/>
-            </a:endParaRPr>
           </a:p>
         </p:txBody>
       </p:sp>
@@ -25482,447 +23343,6 @@
   </p:cSld>
   <p:clrMapOvr>
     <a:masterClrMapping/>
-  </p:clrMapOvr>
-</p:sld>
-</file>
-
-<file path=ppt/slides/slide20.xml><?xml version="1.0" encoding="utf-8"?>
-<p:sld xmlns:a="http://schemas.openxmlformats.org/drawingml/2006/main" xmlns:r="http://schemas.openxmlformats.org/officeDocument/2006/relationships" xmlns:p="http://schemas.openxmlformats.org/presentationml/2006/main">
-  <p:cSld>
-    <p:bg>
-      <p:bgPr>
-        <a:solidFill>
-          <a:schemeClr val="tx1"/>
-        </a:solidFill>
-        <a:effectLst/>
-      </p:bgPr>
-    </p:bg>
-    <p:spTree>
-      <p:nvGrpSpPr>
-        <p:cNvPr id="1" name="">
-          <a:extLst>
-            <a:ext uri="{FF2B5EF4-FFF2-40B4-BE49-F238E27FC236}">
-              <a16:creationId xmlns:a16="http://schemas.microsoft.com/office/drawing/2014/main" id="{C39B5145-C7CC-4CCE-487E-4254D67A4F72}"/>
-            </a:ext>
-          </a:extLst>
-        </p:cNvPr>
-        <p:cNvGrpSpPr/>
-        <p:nvPr/>
-      </p:nvGrpSpPr>
-      <p:grpSpPr>
-        <a:xfrm>
-          <a:off x="0" y="0"/>
-          <a:ext cx="0" cy="0"/>
-          <a:chOff x="0" y="0"/>
-          <a:chExt cx="0" cy="0"/>
-        </a:xfrm>
-      </p:grpSpPr>
-      <p:sp>
-        <p:nvSpPr>
-          <p:cNvPr id="9" name="Rectangle 8">
-            <a:extLst>
-              <a:ext uri="{FF2B5EF4-FFF2-40B4-BE49-F238E27FC236}">
-                <a16:creationId xmlns:a16="http://schemas.microsoft.com/office/drawing/2014/main" id="{6CFBDE84-924A-E8FB-3BA9-FBAA104E768F}"/>
-              </a:ext>
-              <a:ext uri="{C183D7F6-B498-43B3-948B-1728B52AA6E4}">
-                <adec:decorative xmlns:adec="http://schemas.microsoft.com/office/drawing/2017/decorative" val="1"/>
-              </a:ext>
-            </a:extLst>
-          </p:cNvPr>
-          <p:cNvSpPr>
-            <a:spLocks noGrp="1" noRot="1" noChangeAspect="1" noMove="1" noResize="1" noEditPoints="1" noAdjustHandles="1" noChangeArrowheads="1" noChangeShapeType="1" noTextEdit="1"/>
-          </p:cNvSpPr>
-          <p:nvPr>
-            <p:extLst>
-              <p:ext uri="{386F3935-93C4-4BCD-93E2-E3B085C9AB24}">
-                <p16:designElem xmlns:p16="http://schemas.microsoft.com/office/powerpoint/2015/main" val="1"/>
-              </p:ext>
-            </p:extLst>
-          </p:nvPr>
-        </p:nvSpPr>
-        <p:spPr>
-          <a:xfrm>
-            <a:off x="0" y="-3324"/>
-            <a:ext cx="12192000" cy="6861324"/>
-          </a:xfrm>
-          <a:prstGeom prst="rect">
-            <a:avLst/>
-          </a:prstGeom>
-          <a:solidFill>
-            <a:schemeClr val="tx1"/>
-          </a:solidFill>
-          <a:ln>
-            <a:noFill/>
-          </a:ln>
-        </p:spPr>
-        <p:style>
-          <a:lnRef idx="2">
-            <a:schemeClr val="accent1">
-              <a:shade val="50000"/>
-            </a:schemeClr>
-          </a:lnRef>
-          <a:fillRef idx="1">
-            <a:schemeClr val="accent1"/>
-          </a:fillRef>
-          <a:effectRef idx="0">
-            <a:schemeClr val="accent1"/>
-          </a:effectRef>
-          <a:fontRef idx="minor">
-            <a:schemeClr val="lt1"/>
-          </a:fontRef>
-        </p:style>
-        <p:txBody>
-          <a:bodyPr rtlCol="0" anchor="ctr"/>
-          <a:lstStyle/>
-          <a:p>
-            <a:pPr marL="0" marR="0" lvl="0" indent="0" algn="ctr" defTabSz="914400" rtl="0" eaLnBrk="1" fontAlgn="auto" latinLnBrk="0" hangingPunct="1">
-              <a:lnSpc>
-                <a:spcPct val="100000"/>
-              </a:lnSpc>
-              <a:spcBef>
-                <a:spcPts val="0"/>
-              </a:spcBef>
-              <a:spcAft>
-                <a:spcPts val="0"/>
-              </a:spcAft>
-              <a:buClrTx/>
-              <a:buSzTx/>
-              <a:buFontTx/>
-              <a:buNone/>
-              <a:tabLst/>
-              <a:defRPr/>
-            </a:pPr>
-            <a:endParaRPr kumimoji="0" lang="en-US" sz="1800" b="0" i="0" u="none" strike="noStrike" kern="1200" cap="none" spc="0" normalizeH="0" baseline="0" noProof="0">
-              <a:ln>
-                <a:noFill/>
-              </a:ln>
-              <a:solidFill>
-                <a:prstClr val="white"/>
-              </a:solidFill>
-              <a:effectLst/>
-              <a:uLnTx/>
-              <a:uFillTx/>
-              <a:latin typeface="Calibri" panose="020F0502020204030204"/>
-              <a:ea typeface="+mn-ea"/>
-              <a:cs typeface="+mn-cs"/>
-            </a:endParaRPr>
-          </a:p>
-        </p:txBody>
-      </p:sp>
-      <p:sp>
-        <p:nvSpPr>
-          <p:cNvPr id="11" name="Rectangle 10">
-            <a:extLst>
-              <a:ext uri="{FF2B5EF4-FFF2-40B4-BE49-F238E27FC236}">
-                <a16:creationId xmlns:a16="http://schemas.microsoft.com/office/drawing/2014/main" id="{256E144F-032B-6022-3543-526B3E6F1E8D}"/>
-              </a:ext>
-              <a:ext uri="{C183D7F6-B498-43B3-948B-1728B52AA6E4}">
-                <adec:decorative xmlns:adec="http://schemas.microsoft.com/office/drawing/2017/decorative" val="1"/>
-              </a:ext>
-            </a:extLst>
-          </p:cNvPr>
-          <p:cNvSpPr>
-            <a:spLocks noGrp="1" noRot="1" noChangeAspect="1" noMove="1" noResize="1" noEditPoints="1" noAdjustHandles="1" noChangeArrowheads="1" noChangeShapeType="1" noTextEdit="1"/>
-          </p:cNvSpPr>
-          <p:nvPr>
-            <p:extLst>
-              <p:ext uri="{386F3935-93C4-4BCD-93E2-E3B085C9AB24}">
-                <p16:designElem xmlns:p16="http://schemas.microsoft.com/office/powerpoint/2015/main" val="1"/>
-              </p:ext>
-            </p:extLst>
-          </p:nvPr>
-        </p:nvSpPr>
-        <p:spPr bwMode="ltGray">
-          <a:xfrm>
-            <a:off x="321734" y="321733"/>
-            <a:ext cx="11573488" cy="6214534"/>
-          </a:xfrm>
-          <a:prstGeom prst="rect">
-            <a:avLst/>
-          </a:prstGeom>
-          <a:solidFill>
-            <a:schemeClr val="bg1">
-              <a:lumMod val="75000"/>
-              <a:lumOff val="25000"/>
-            </a:schemeClr>
-          </a:solidFill>
-          <a:ln w="127000" cap="sq" cmpd="thinThick">
-            <a:solidFill>
-              <a:schemeClr val="bg1">
-                <a:lumMod val="75000"/>
-                <a:lumOff val="25000"/>
-              </a:schemeClr>
-            </a:solidFill>
-          </a:ln>
-        </p:spPr>
-        <p:style>
-          <a:lnRef idx="2">
-            <a:schemeClr val="accent1">
-              <a:shade val="50000"/>
-            </a:schemeClr>
-          </a:lnRef>
-          <a:fillRef idx="1">
-            <a:schemeClr val="accent1"/>
-          </a:fillRef>
-          <a:effectRef idx="0">
-            <a:schemeClr val="accent1"/>
-          </a:effectRef>
-          <a:fontRef idx="minor">
-            <a:schemeClr val="lt1"/>
-          </a:fontRef>
-        </p:style>
-        <p:txBody>
-          <a:bodyPr rtlCol="0" anchor="ctr"/>
-          <a:lstStyle/>
-          <a:p>
-            <a:pPr marL="0" marR="0" lvl="0" indent="0" algn="ctr" defTabSz="914400" rtl="0" eaLnBrk="1" fontAlgn="auto" latinLnBrk="0" hangingPunct="1">
-              <a:lnSpc>
-                <a:spcPct val="100000"/>
-              </a:lnSpc>
-              <a:spcBef>
-                <a:spcPts val="0"/>
-              </a:spcBef>
-              <a:spcAft>
-                <a:spcPts val="0"/>
-              </a:spcAft>
-              <a:buClrTx/>
-              <a:buSzTx/>
-              <a:buFontTx/>
-              <a:buNone/>
-              <a:tabLst/>
-              <a:defRPr/>
-            </a:pPr>
-            <a:endParaRPr kumimoji="0" lang="en-US" sz="1800" b="0" i="0" u="none" strike="noStrike" kern="1200" cap="none" spc="0" normalizeH="0" baseline="0" noProof="0">
-              <a:ln>
-                <a:noFill/>
-              </a:ln>
-              <a:solidFill>
-                <a:prstClr val="white"/>
-              </a:solidFill>
-              <a:effectLst/>
-              <a:uLnTx/>
-              <a:uFillTx/>
-              <a:latin typeface="Calibri" panose="020F0502020204030204"/>
-              <a:ea typeface="+mn-ea"/>
-              <a:cs typeface="+mn-cs"/>
-            </a:endParaRPr>
-          </a:p>
-        </p:txBody>
-      </p:sp>
-      <p:sp>
-        <p:nvSpPr>
-          <p:cNvPr id="2" name="Title 1">
-            <a:extLst>
-              <a:ext uri="{FF2B5EF4-FFF2-40B4-BE49-F238E27FC236}">
-                <a16:creationId xmlns:a16="http://schemas.microsoft.com/office/drawing/2014/main" id="{B444DE0F-0C17-6919-233B-D98BD654A0DB}"/>
-              </a:ext>
-            </a:extLst>
-          </p:cNvPr>
-          <p:cNvSpPr>
-            <a:spLocks noGrp="1"/>
-          </p:cNvSpPr>
-          <p:nvPr>
-            <p:ph type="ctrTitle"/>
-          </p:nvPr>
-        </p:nvSpPr>
-        <p:spPr>
-          <a:xfrm>
-            <a:off x="1524000" y="1122362"/>
-            <a:ext cx="9144000" cy="2840037"/>
-          </a:xfrm>
-        </p:spPr>
-        <p:txBody>
-          <a:bodyPr>
-            <a:normAutofit/>
-          </a:bodyPr>
-          <a:lstStyle/>
-          <a:p>
-            <a:r>
-              <a:rPr lang="en-US" sz="5800" dirty="0"/>
-              <a:t>Imagine. </a:t>
-            </a:r>
-            <a:br>
-              <a:rPr lang="en-US" sz="5800" dirty="0"/>
-            </a:br>
-            <a:r>
-              <a:rPr lang="en-US" sz="5800" dirty="0"/>
-              <a:t>Visualize. </a:t>
-            </a:r>
-            <a:br>
-              <a:rPr lang="en-US" sz="5800" dirty="0"/>
-            </a:br>
-            <a:r>
-              <a:rPr lang="en-US" sz="5800" dirty="0"/>
-              <a:t>Represent.</a:t>
-            </a:r>
-          </a:p>
-        </p:txBody>
-      </p:sp>
-      <p:cxnSp>
-        <p:nvCxnSpPr>
-          <p:cNvPr id="13" name="Straight Connector 12">
-            <a:extLst>
-              <a:ext uri="{FF2B5EF4-FFF2-40B4-BE49-F238E27FC236}">
-                <a16:creationId xmlns:a16="http://schemas.microsoft.com/office/drawing/2014/main" id="{99EC64F2-D776-BF3D-FBD9-93D13C26D996}"/>
-              </a:ext>
-              <a:ext uri="{C183D7F6-B498-43B3-948B-1728B52AA6E4}">
-                <adec:decorative xmlns:adec="http://schemas.microsoft.com/office/drawing/2017/decorative" val="1"/>
-              </a:ext>
-            </a:extLst>
-          </p:cNvPr>
-          <p:cNvCxnSpPr>
-            <a:cxnSpLocks noGrp="1" noRot="1" noChangeAspect="1" noMove="1" noResize="1" noEditPoints="1" noAdjustHandles="1" noChangeArrowheads="1" noChangeShapeType="1"/>
-          </p:cNvCxnSpPr>
-          <p:nvPr>
-            <p:extLst>
-              <p:ext uri="{386F3935-93C4-4BCD-93E2-E3B085C9AB24}">
-                <p16:designElem xmlns:p16="http://schemas.microsoft.com/office/powerpoint/2015/main" val="1"/>
-              </p:ext>
-            </p:extLst>
-          </p:nvPr>
-        </p:nvCxnSpPr>
-        <p:spPr>
-          <a:xfrm>
-            <a:off x="4724400" y="4109417"/>
-            <a:ext cx="2743200" cy="0"/>
-          </a:xfrm>
-          <a:prstGeom prst="line">
-            <a:avLst/>
-          </a:prstGeom>
-          <a:ln w="12700">
-            <a:solidFill>
-              <a:schemeClr val="tx1">
-                <a:lumMod val="85000"/>
-              </a:schemeClr>
-            </a:solidFill>
-          </a:ln>
-        </p:spPr>
-        <p:style>
-          <a:lnRef idx="1">
-            <a:schemeClr val="accent1"/>
-          </a:lnRef>
-          <a:fillRef idx="0">
-            <a:schemeClr val="accent1"/>
-          </a:fillRef>
-          <a:effectRef idx="0">
-            <a:schemeClr val="accent1"/>
-          </a:effectRef>
-          <a:fontRef idx="minor">
-            <a:schemeClr val="tx1"/>
-          </a:fontRef>
-        </p:style>
-      </p:cxnSp>
-      <p:sp>
-        <p:nvSpPr>
-          <p:cNvPr id="4" name="Footer Placeholder 3">
-            <a:extLst>
-              <a:ext uri="{FF2B5EF4-FFF2-40B4-BE49-F238E27FC236}">
-                <a16:creationId xmlns:a16="http://schemas.microsoft.com/office/drawing/2014/main" id="{8927F93D-7588-EB6D-94E1-96EFF9F59E48}"/>
-              </a:ext>
-            </a:extLst>
-          </p:cNvPr>
-          <p:cNvSpPr>
-            <a:spLocks noGrp="1"/>
-          </p:cNvSpPr>
-          <p:nvPr>
-            <p:ph type="ftr" sz="quarter" idx="11"/>
-          </p:nvPr>
-        </p:nvSpPr>
-        <p:spPr>
-          <a:xfrm>
-            <a:off x="4038600" y="6159710"/>
-            <a:ext cx="4114800" cy="365125"/>
-          </a:xfrm>
-        </p:spPr>
-        <p:txBody>
-          <a:bodyPr>
-            <a:normAutofit/>
-          </a:bodyPr>
-          <a:lstStyle/>
-          <a:p>
-            <a:pPr marL="0" marR="0" lvl="0" indent="0" algn="ctr" defTabSz="914400" rtl="0" eaLnBrk="1" fontAlgn="auto" latinLnBrk="0" hangingPunct="1">
-              <a:lnSpc>
-                <a:spcPct val="100000"/>
-              </a:lnSpc>
-              <a:spcBef>
-                <a:spcPts val="0"/>
-              </a:spcBef>
-              <a:spcAft>
-                <a:spcPts val="600"/>
-              </a:spcAft>
-              <a:buClrTx/>
-              <a:buSzTx/>
-              <a:buFontTx/>
-              <a:buNone/>
-              <a:tabLst/>
-              <a:defRPr/>
-            </a:pPr>
-            <a:r>
-              <a:rPr kumimoji="0" lang="en-US" sz="1200" b="0" i="0" u="none" strike="noStrike" kern="1200" cap="none" spc="0" normalizeH="0" baseline="0" noProof="0" dirty="0">
-                <a:ln>
-                  <a:noFill/>
-                </a:ln>
-                <a:solidFill>
-                  <a:prstClr val="white">
-                    <a:tint val="75000"/>
-                  </a:prstClr>
-                </a:solidFill>
-                <a:effectLst/>
-                <a:uLnTx/>
-                <a:uFillTx/>
-                <a:latin typeface="Helvetica Neue" panose="02000503000000020004" pitchFamily="2" charset="0"/>
-                <a:ea typeface="Helvetica Neue" panose="02000503000000020004" pitchFamily="2" charset="0"/>
-                <a:cs typeface="Helvetica Neue" panose="02000503000000020004" pitchFamily="2" charset="0"/>
-              </a:rPr>
-              <a:t>J Mark Morris – n</a:t>
-            </a:r>
-            <a:r>
-              <a:rPr kumimoji="0" lang="en-US" sz="1200" b="0" i="0" u="none" strike="noStrike" kern="1200" cap="none" spc="0" normalizeH="0" baseline="0" noProof="0" dirty="0" err="1">
-                <a:ln>
-                  <a:noFill/>
-                </a:ln>
-                <a:solidFill>
-                  <a:prstClr val="white">
-                    <a:tint val="75000"/>
-                  </a:prstClr>
-                </a:solidFill>
-                <a:effectLst/>
-                <a:uLnTx/>
-                <a:uFillTx/>
-                <a:latin typeface="Helvetica Neue" panose="02000503000000020004" pitchFamily="2" charset="0"/>
-                <a:ea typeface="Helvetica Neue" panose="02000503000000020004" pitchFamily="2" charset="0"/>
-                <a:cs typeface="Helvetica Neue" panose="02000503000000020004" pitchFamily="2" charset="0"/>
-              </a:rPr>
-              <a:t>eoclassical.ai</a:t>
-            </a:r>
-            <a:endParaRPr kumimoji="0" lang="en-US" sz="1200" b="0" i="0" u="none" strike="noStrike" kern="1200" cap="none" spc="0" normalizeH="0" baseline="0" noProof="0" dirty="0">
-              <a:ln>
-                <a:noFill/>
-              </a:ln>
-              <a:solidFill>
-                <a:prstClr val="white">
-                  <a:tint val="75000"/>
-                </a:prstClr>
-              </a:solidFill>
-              <a:effectLst/>
-              <a:uLnTx/>
-              <a:uFillTx/>
-              <a:latin typeface="Helvetica Neue" panose="02000503000000020004" pitchFamily="2" charset="0"/>
-              <a:ea typeface="Helvetica Neue" panose="02000503000000020004" pitchFamily="2" charset="0"/>
-              <a:cs typeface="Helvetica Neue" panose="02000503000000020004" pitchFamily="2" charset="0"/>
-            </a:endParaRPr>
-          </a:p>
-        </p:txBody>
-      </p:sp>
-    </p:spTree>
-    <p:extLst>
-      <p:ext uri="{BB962C8B-B14F-4D97-AF65-F5344CB8AC3E}">
-        <p14:creationId xmlns:p14="http://schemas.microsoft.com/office/powerpoint/2010/main" val="2530850193"/>
-      </p:ext>
-    </p:extLst>
-  </p:cSld>
-  <p:clrMapOvr>
-    <a:overrideClrMapping bg1="dk1" tx1="lt1" bg2="dk2" tx2="lt2" accent1="accent1" accent2="accent2" accent3="accent3" accent4="accent4" accent5="accent5" accent6="accent6" hlink="hlink" folHlink="folHlink"/>
   </p:clrMapOvr>
 </p:sld>
 </file>
@@ -26288,7 +23708,7 @@
                   <a:ea typeface="Helvetica Neue" panose="02000503000000020004" pitchFamily="2" charset="0"/>
                   <a:cs typeface="Helvetica Neue" panose="02000503000000020004" pitchFamily="2" charset="0"/>
                 </a:rPr>
-                <a:t>Absolute Euclidean Time</a:t>
+                <a:t>Absolute Time</a:t>
               </a:r>
             </a:p>
           </p:txBody>
@@ -26320,42 +23740,6 @@
               <a:spAutoFit/>
             </a:bodyPr>
             <a:lstStyle/>
-            <a:p>
-              <a:pPr marL="0" marR="0" lvl="0" indent="0" algn="ctr" defTabSz="914400" rtl="0" eaLnBrk="1" fontAlgn="auto" latinLnBrk="0" hangingPunct="1">
-                <a:lnSpc>
-                  <a:spcPct val="100000"/>
-                </a:lnSpc>
-                <a:spcBef>
-                  <a:spcPts val="0"/>
-                </a:spcBef>
-                <a:spcAft>
-                  <a:spcPts val="0"/>
-                </a:spcAft>
-                <a:buClrTx/>
-                <a:buSzTx/>
-                <a:buFontTx/>
-                <a:buNone/>
-                <a:tabLst/>
-                <a:defRPr/>
-              </a:pPr>
-              <a:r>
-                <a:rPr kumimoji="0" lang="en-US" sz="1800" b="0" i="0" u="none" strike="noStrike" kern="1200" cap="none" spc="0" normalizeH="0" baseline="0" noProof="0" dirty="0">
-                  <a:ln>
-                    <a:noFill/>
-                  </a:ln>
-                  <a:solidFill>
-                    <a:prstClr val="white"/>
-                  </a:solidFill>
-                  <a:effectLst/>
-                  <a:uLnTx/>
-                  <a:uFillTx/>
-                  <a:latin typeface="Helvetica Neue" panose="02000503000000020004" pitchFamily="2" charset="0"/>
-                  <a:ea typeface="Helvetica Neue" panose="02000503000000020004" pitchFamily="2" charset="0"/>
-                  <a:cs typeface="Helvetica Neue" panose="02000503000000020004" pitchFamily="2" charset="0"/>
-                </a:rPr>
-                <a:t>Absolute </a:t>
-              </a:r>
-            </a:p>
             <a:p>
               <a:pPr marL="0" marR="0" lvl="0" indent="0" algn="ctr" defTabSz="914400" rtl="0" eaLnBrk="1" fontAlgn="auto" latinLnBrk="0" hangingPunct="1">
                 <a:lnSpc>
@@ -26425,7 +23809,7 @@
                   <a:ea typeface="Helvetica Neue" panose="02000503000000020004" pitchFamily="2" charset="0"/>
                   <a:cs typeface="Helvetica Neue" panose="02000503000000020004" pitchFamily="2" charset="0"/>
                 </a:rPr>
-                <a:t>3D Space</a:t>
+                <a:t>Void</a:t>
               </a:r>
             </a:p>
           </p:txBody>
@@ -27102,7 +24486,7 @@
                   <a:ea typeface="Helvetica Neue" panose="02000503000000020004" pitchFamily="2" charset="0"/>
                   <a:cs typeface="Helvetica Neue" panose="02000503000000020004" pitchFamily="2" charset="0"/>
                 </a:rPr>
-                <a:t>v &lt; @</a:t>
+                <a:t>v &lt; c_f</a:t>
               </a:r>
             </a:p>
           </p:txBody>
@@ -27171,7 +24555,7 @@
                 <a:ea typeface="Helvetica Neue" panose="02000503000000020004" pitchFamily="2" charset="0"/>
                 <a:cs typeface="Helvetica Neue" panose="02000503000000020004" pitchFamily="2" charset="0"/>
               </a:rPr>
-              <a:t>r = @t</a:t>
+              <a:t>r = c_f t</a:t>
             </a:r>
           </a:p>
         </p:txBody>
@@ -27239,7 +24623,7 @@
                 <a:ea typeface="Helvetica Neue" panose="02000503000000020004" pitchFamily="2" charset="0"/>
                 <a:cs typeface="Helvetica Neue" panose="02000503000000020004" pitchFamily="2" charset="0"/>
               </a:rPr>
-              <a:t>Electric Potential Field Tracers</a:t>
+              <a:t>Causal Wake Tracers</a:t>
             </a:r>
             <a:endParaRPr kumimoji="0" lang="en-US" sz="1100" b="0" i="1" u="none" strike="noStrike" kern="1200" cap="none" spc="0" normalizeH="0" baseline="0" noProof="0" dirty="0">
               <a:ln>
@@ -27594,7 +24978,7 @@
                 <a:ea typeface="Helvetica Neue" panose="02000503000000020004" pitchFamily="2" charset="0"/>
                 <a:cs typeface="Helvetica Neue" panose="02000503000000020004" pitchFamily="2" charset="0"/>
               </a:rPr>
-              <a:t>Point Potential Path</a:t>
+              <a:t>Architrino Path</a:t>
             </a:r>
             <a:endParaRPr kumimoji="0" lang="en-US" sz="1100" b="0" i="1" u="none" strike="noStrike" kern="1200" cap="none" spc="0" normalizeH="0" baseline="0" noProof="0" dirty="0">
               <a:ln>
@@ -27628,7 +25012,7 @@
         <p:spPr>
           <a:xfrm>
             <a:off x="8965473" y="1654209"/>
-            <a:ext cx="2558673" cy="707886"/>
+            <a:ext cx="2726994" cy="707886"/>
           </a:xfrm>
           <a:prstGeom prst="rect">
             <a:avLst/>
@@ -27677,7 +25061,7 @@
                 <a:ea typeface="Helvetica Neue" panose="02000503000000020004" pitchFamily="2" charset="0"/>
                 <a:cs typeface="Helvetica Neue" panose="02000503000000020004" pitchFamily="2" charset="0"/>
               </a:rPr>
-              <a:t>Field Speed @ is a Universal Constant</a:t>
+              <a:t>Wake Speed c_f is a Primitive Constant</a:t>
             </a:r>
           </a:p>
         </p:txBody>
@@ -27742,7 +25126,7 @@
                 <a:ea typeface="Helvetica Neue" panose="02000503000000020004" pitchFamily="2" charset="0"/>
                 <a:cs typeface="Helvetica Neue" panose="02000503000000020004" pitchFamily="2" charset="0"/>
               </a:rPr>
-              <a:t>Point Potential on Linear Path with Velocity v &lt; @</a:t>
+              <a:t>Architrino on Linear Path with Velocity v &lt; c_f</a:t>
             </a:r>
           </a:p>
         </p:txBody>
@@ -27807,7 +25191,7 @@
                 <a:ea typeface="Helvetica Neue" panose="02000503000000020004" pitchFamily="2" charset="0"/>
                 <a:cs typeface="Helvetica Neue" panose="02000503000000020004" pitchFamily="2" charset="0"/>
               </a:rPr>
-              <a:t>Each point potential continuously emits an electric potential field.</a:t>
+              <a:t>Each architrino continuously emits a causal wake.</a:t>
             </a:r>
           </a:p>
           <a:p>
@@ -27843,41 +25227,7 @@
                 <a:ea typeface="Helvetica Neue" panose="02000503000000020004" pitchFamily="2" charset="0"/>
                 <a:cs typeface="Helvetica Neue" panose="02000503000000020004" pitchFamily="2" charset="0"/>
               </a:rPr>
-              <a:t>The electric potential is q/v at r=0 and a spherical Dirac delta q/</a:t>
-            </a:r>
-            <a:r>
-              <a:rPr kumimoji="0" lang="en-US" sz="1600" b="0" i="0" u="none" strike="noStrike" kern="1200" cap="none" spc="0" normalizeH="0" baseline="0" noProof="0" dirty="0" err="1">
-                <a:ln>
-                  <a:noFill/>
-                </a:ln>
-                <a:solidFill>
-                  <a:prstClr val="white"/>
-                </a:solidFill>
-                <a:effectLst/>
-                <a:uLnTx/>
-                <a:uFillTx/>
-                <a:latin typeface="Helvetica Neue" panose="02000503000000020004" pitchFamily="2" charset="0"/>
-                <a:ea typeface="Helvetica Neue" panose="02000503000000020004" pitchFamily="2" charset="0"/>
-                <a:cs typeface="Helvetica Neue" panose="02000503000000020004" pitchFamily="2" charset="0"/>
-              </a:rPr>
-              <a:t>vr</a:t>
-            </a:r>
-            <a:r>
-              <a:rPr kumimoji="0" lang="en-US" sz="1600" b="0" i="0" u="none" strike="noStrike" kern="1200" cap="none" spc="0" normalizeH="0" baseline="0" noProof="0" dirty="0">
-                <a:ln>
-                  <a:noFill/>
-                </a:ln>
-                <a:solidFill>
-                  <a:prstClr val="white"/>
-                </a:solidFill>
-                <a:effectLst/>
-                <a:uLnTx/>
-                <a:uFillTx/>
-                <a:latin typeface="Helvetica Neue" panose="02000503000000020004" pitchFamily="2" charset="0"/>
-                <a:ea typeface="Helvetica Neue" panose="02000503000000020004" pitchFamily="2" charset="0"/>
-                <a:cs typeface="Helvetica Neue" panose="02000503000000020004" pitchFamily="2" charset="0"/>
-              </a:rPr>
-              <a:t> as a linear function of time.</a:t>
+              <a:t>The wake is sourced by polarity and spreads over causal isochrons with 1/r^2 surface density.</a:t>
             </a:r>
           </a:p>
           <a:p>
@@ -27913,7 +25263,7 @@
                 <a:ea typeface="Helvetica Neue" panose="02000503000000020004" pitchFamily="2" charset="0"/>
                 <a:cs typeface="Helvetica Neue" panose="02000503000000020004" pitchFamily="2" charset="0"/>
               </a:rPr>
-              <a:t>When v &lt; @ the point potential does not experience its own field and there is no self action.</a:t>
+              <a:t>When v &lt; c_f the architrino does not intercept its own wake, so this is the partner-only regime.</a:t>
             </a:r>
           </a:p>
         </p:txBody>
@@ -28292,7 +25642,7 @@
                   <a:ea typeface="Helvetica Neue" panose="02000503000000020004" pitchFamily="2" charset="0"/>
                   <a:cs typeface="Helvetica Neue" panose="02000503000000020004" pitchFamily="2" charset="0"/>
                 </a:rPr>
-                <a:t>Absolute Euclidean Time</a:t>
+                <a:t>Absolute Time</a:t>
               </a:r>
             </a:p>
           </p:txBody>
@@ -28324,42 +25674,6 @@
               <a:spAutoFit/>
             </a:bodyPr>
             <a:lstStyle/>
-            <a:p>
-              <a:pPr marL="0" marR="0" lvl="0" indent="0" algn="ctr" defTabSz="914400" rtl="0" eaLnBrk="1" fontAlgn="auto" latinLnBrk="0" hangingPunct="1">
-                <a:lnSpc>
-                  <a:spcPct val="100000"/>
-                </a:lnSpc>
-                <a:spcBef>
-                  <a:spcPts val="0"/>
-                </a:spcBef>
-                <a:spcAft>
-                  <a:spcPts val="0"/>
-                </a:spcAft>
-                <a:buClrTx/>
-                <a:buSzTx/>
-                <a:buFontTx/>
-                <a:buNone/>
-                <a:tabLst/>
-                <a:defRPr/>
-              </a:pPr>
-              <a:r>
-                <a:rPr kumimoji="0" lang="en-US" sz="1800" b="0" i="0" u="none" strike="noStrike" kern="1200" cap="none" spc="0" normalizeH="0" baseline="0" noProof="0" dirty="0">
-                  <a:ln>
-                    <a:noFill/>
-                  </a:ln>
-                  <a:solidFill>
-                    <a:prstClr val="white"/>
-                  </a:solidFill>
-                  <a:effectLst/>
-                  <a:uLnTx/>
-                  <a:uFillTx/>
-                  <a:latin typeface="Helvetica Neue" panose="02000503000000020004" pitchFamily="2" charset="0"/>
-                  <a:ea typeface="Helvetica Neue" panose="02000503000000020004" pitchFamily="2" charset="0"/>
-                  <a:cs typeface="Helvetica Neue" panose="02000503000000020004" pitchFamily="2" charset="0"/>
-                </a:rPr>
-                <a:t>Absolute </a:t>
-              </a:r>
-            </a:p>
             <a:p>
               <a:pPr marL="0" marR="0" lvl="0" indent="0" algn="ctr" defTabSz="914400" rtl="0" eaLnBrk="1" fontAlgn="auto" latinLnBrk="0" hangingPunct="1">
                 <a:lnSpc>
@@ -28429,7 +25743,7 @@
                   <a:ea typeface="Helvetica Neue" panose="02000503000000020004" pitchFamily="2" charset="0"/>
                   <a:cs typeface="Helvetica Neue" panose="02000503000000020004" pitchFamily="2" charset="0"/>
                 </a:rPr>
-                <a:t>3D Space</a:t>
+                <a:t>Void</a:t>
               </a:r>
             </a:p>
           </p:txBody>
@@ -29106,7 +26420,7 @@
                   <a:ea typeface="Helvetica Neue" panose="02000503000000020004" pitchFamily="2" charset="0"/>
                   <a:cs typeface="Helvetica Neue" panose="02000503000000020004" pitchFamily="2" charset="0"/>
                 </a:rPr>
-                <a:t>v &lt; @</a:t>
+                <a:t>v &lt; c_f</a:t>
               </a:r>
             </a:p>
           </p:txBody>
@@ -29175,7 +26489,7 @@
                 <a:ea typeface="Helvetica Neue" panose="02000503000000020004" pitchFamily="2" charset="0"/>
                 <a:cs typeface="Helvetica Neue" panose="02000503000000020004" pitchFamily="2" charset="0"/>
               </a:rPr>
-              <a:t>r = @t</a:t>
+              <a:t>r = c_f t</a:t>
             </a:r>
           </a:p>
         </p:txBody>
@@ -29243,7 +26557,7 @@
                 <a:ea typeface="Helvetica Neue" panose="02000503000000020004" pitchFamily="2" charset="0"/>
                 <a:cs typeface="Helvetica Neue" panose="02000503000000020004" pitchFamily="2" charset="0"/>
               </a:rPr>
-              <a:t>Electric Potential Field Tracers</a:t>
+              <a:t>Causal Wake Tracers</a:t>
             </a:r>
             <a:endParaRPr kumimoji="0" lang="en-US" sz="1100" b="0" i="1" u="none" strike="noStrike" kern="1200" cap="none" spc="0" normalizeH="0" baseline="0" noProof="0" dirty="0">
               <a:ln>
@@ -29384,7 +26698,7 @@
                 <a:ea typeface="Helvetica Neue" panose="02000503000000020004" pitchFamily="2" charset="0"/>
                 <a:cs typeface="Helvetica Neue" panose="02000503000000020004" pitchFamily="2" charset="0"/>
               </a:rPr>
-              <a:t>Spherical Emissions Expand at v = @</a:t>
+              <a:t>Causal Wake Surfaces Expand at v = c_f</a:t>
             </a:r>
           </a:p>
         </p:txBody>
@@ -29448,7 +26762,7 @@
                 <a:ea typeface="Helvetica Neue" panose="02000503000000020004" pitchFamily="2" charset="0"/>
                 <a:cs typeface="Helvetica Neue" panose="02000503000000020004" pitchFamily="2" charset="0"/>
               </a:rPr>
-              <a:t>Each Dirac Sphere Expands from the Point of Emission</a:t>
+              <a:t>Each Causal Isochron Expands from the Emission Point</a:t>
             </a:r>
           </a:p>
         </p:txBody>
@@ -29746,7 +27060,7 @@
                 <a:ea typeface="Helvetica Neue" panose="02000503000000020004" pitchFamily="2" charset="0"/>
                 <a:cs typeface="Helvetica Neue" panose="02000503000000020004" pitchFamily="2" charset="0"/>
               </a:rPr>
-              <a:t>Point Potential Path</a:t>
+              <a:t>Architrino Path</a:t>
             </a:r>
             <a:endParaRPr kumimoji="0" lang="en-US" sz="1100" b="0" i="1" u="none" strike="noStrike" kern="1200" cap="none" spc="0" normalizeH="0" baseline="0" noProof="0" dirty="0">
               <a:ln>
@@ -29779,8 +27093,8 @@
         </p:nvSpPr>
         <p:spPr>
           <a:xfrm>
-            <a:off x="8965473" y="2254500"/>
-            <a:ext cx="2558673" cy="707886"/>
+            <a:off x="8881235" y="2344577"/>
+            <a:ext cx="2811232" cy="707886"/>
           </a:xfrm>
           <a:prstGeom prst="rect">
             <a:avLst/>
@@ -29829,7 +27143,41 @@
                 <a:ea typeface="Helvetica Neue" panose="02000503000000020004" pitchFamily="2" charset="0"/>
                 <a:cs typeface="Helvetica Neue" panose="02000503000000020004" pitchFamily="2" charset="0"/>
               </a:rPr>
-              <a:t>Field Speed @ is a Universal Constant</a:t>
+              <a:t>Wake Speed c</a:t>
+            </a:r>
+            <a:r>
+              <a:rPr kumimoji="0" lang="en-US" sz="2000" b="1" i="0" u="none" strike="noStrike" kern="1200" cap="none" spc="0" normalizeH="0" baseline="-25000" noProof="0" dirty="0">
+                <a:ln>
+                  <a:noFill/>
+                </a:ln>
+                <a:solidFill>
+                  <a:srgbClr val="FF85FF"/>
+                </a:solidFill>
+                <a:effectLst/>
+                <a:uLnTx/>
+                <a:uFillTx/>
+                <a:latin typeface="Helvetica Neue" panose="02000503000000020004" pitchFamily="2" charset="0"/>
+                <a:ea typeface="Helvetica Neue" panose="02000503000000020004" pitchFamily="2" charset="0"/>
+                <a:cs typeface="Helvetica Neue" panose="02000503000000020004" pitchFamily="2" charset="0"/>
+              </a:rPr>
+              <a:t>f</a:t>
+            </a:r>
+            <a:r>
+              <a:rPr kumimoji="0" lang="en-US" sz="2000" b="1" i="0" u="none" strike="noStrike" kern="1200" cap="none" spc="0" normalizeH="0" baseline="0" noProof="0" dirty="0">
+                <a:ln>
+                  <a:noFill/>
+                </a:ln>
+                <a:solidFill>
+                  <a:srgbClr val="FF85FF"/>
+                </a:solidFill>
+                <a:effectLst/>
+                <a:uLnTx/>
+                <a:uFillTx/>
+                <a:latin typeface="Helvetica Neue" panose="02000503000000020004" pitchFamily="2" charset="0"/>
+                <a:ea typeface="Helvetica Neue" panose="02000503000000020004" pitchFamily="2" charset="0"/>
+                <a:cs typeface="Helvetica Neue" panose="02000503000000020004" pitchFamily="2" charset="0"/>
+              </a:rPr>
+              <a:t> is a Primitive Constant</a:t>
             </a:r>
           </a:p>
         </p:txBody>
@@ -30182,7 +27530,7 @@
                 <a:ea typeface="Helvetica Neue" panose="02000503000000020004" pitchFamily="2" charset="0"/>
                 <a:cs typeface="Helvetica Neue" panose="02000503000000020004" pitchFamily="2" charset="0"/>
               </a:rPr>
-              <a:t>Absolute Euclidean Time</a:t>
+              <a:t>Absolute Time</a:t>
             </a:r>
           </a:p>
         </p:txBody>
@@ -30247,7 +27595,7 @@
                 <a:ea typeface="Helvetica Neue" panose="02000503000000020004" pitchFamily="2" charset="0"/>
                 <a:cs typeface="Helvetica Neue" panose="02000503000000020004" pitchFamily="2" charset="0"/>
               </a:rPr>
-              <a:t>Absolute </a:t>
+              <a:t>Euclidean</a:t>
             </a:r>
           </a:p>
           <a:p>
@@ -30283,43 +27631,7 @@
                 <a:ea typeface="Helvetica Neue" panose="02000503000000020004" pitchFamily="2" charset="0"/>
                 <a:cs typeface="Helvetica Neue" panose="02000503000000020004" pitchFamily="2" charset="0"/>
               </a:rPr>
-              <a:t>Euclidean</a:t>
-            </a:r>
-          </a:p>
-          <a:p>
-            <a:pPr marL="0" marR="0" lvl="0" indent="0" algn="ctr" defTabSz="914400" rtl="0" eaLnBrk="1" fontAlgn="auto" latinLnBrk="0" hangingPunct="1">
-              <a:lnSpc>
-                <a:spcPct val="100000"/>
-              </a:lnSpc>
-              <a:spcBef>
-                <a:spcPts val="0"/>
-              </a:spcBef>
-              <a:spcAft>
-                <a:spcPts val="0"/>
-              </a:spcAft>
-              <a:buClrTx/>
-              <a:buSzTx/>
-              <a:buFontTx/>
-              <a:buNone/>
-              <a:tabLst/>
-              <a:defRPr/>
-            </a:pPr>
-            <a:r>
-              <a:rPr kumimoji="0" lang="en-US" sz="1800" b="0" i="0" u="none" strike="noStrike" kern="1200" cap="none" spc="0" normalizeH="0" baseline="0" noProof="0" dirty="0">
-                <a:ln>
-                  <a:noFill/>
-                </a:ln>
-                <a:solidFill>
-                  <a:prstClr val="white"/>
-                </a:solidFill>
-                <a:effectLst/>
-                <a:uLnTx/>
-                <a:uFillTx/>
-                <a:latin typeface="Helvetica Neue" panose="02000503000000020004" pitchFamily="2" charset="0"/>
-                <a:ea typeface="Helvetica Neue" panose="02000503000000020004" pitchFamily="2" charset="0"/>
-                <a:cs typeface="Helvetica Neue" panose="02000503000000020004" pitchFamily="2" charset="0"/>
-              </a:rPr>
-              <a:t>3D Space</a:t>
+              <a:t>Void</a:t>
             </a:r>
           </a:p>
         </p:txBody>
@@ -30995,7 +28307,7 @@
                   <a:ea typeface="Helvetica Neue" panose="02000503000000020004" pitchFamily="2" charset="0"/>
                   <a:cs typeface="Helvetica Neue" panose="02000503000000020004" pitchFamily="2" charset="0"/>
                 </a:rPr>
-                <a:t>v &lt; @</a:t>
+                <a:t>v &lt; c_f</a:t>
               </a:r>
             </a:p>
           </p:txBody>
@@ -31064,7 +28376,7 @@
                 <a:ea typeface="Helvetica Neue" panose="02000503000000020004" pitchFamily="2" charset="0"/>
                 <a:cs typeface="Helvetica Neue" panose="02000503000000020004" pitchFamily="2" charset="0"/>
               </a:rPr>
-              <a:t>r = @t</a:t>
+              <a:t>r = c_f t</a:t>
             </a:r>
           </a:p>
         </p:txBody>
@@ -31132,7 +28444,7 @@
                 <a:ea typeface="Helvetica Neue" panose="02000503000000020004" pitchFamily="2" charset="0"/>
                 <a:cs typeface="Helvetica Neue" panose="02000503000000020004" pitchFamily="2" charset="0"/>
               </a:rPr>
-              <a:t>Action = Force along Radius to Emission Point</a:t>
+              <a:t>Hit = radial intersection of wake from emission point</a:t>
             </a:r>
             <a:endParaRPr kumimoji="0" lang="en-US" sz="2400" b="1" i="1" u="none" strike="noStrike" kern="1200" cap="none" spc="0" normalizeH="0" baseline="0" noProof="0" dirty="0">
               <a:ln>
@@ -31210,7 +28522,7 @@
                 <a:ea typeface="Helvetica Neue" panose="02000503000000020004" pitchFamily="2" charset="0"/>
                 <a:cs typeface="Helvetica Neue" panose="02000503000000020004" pitchFamily="2" charset="0"/>
               </a:rPr>
-              <a:t>Action Occurs when a Potential Sphere Intersects a Point Potential</a:t>
+              <a:t>A Wake Hit Occurs when a Wake Surface Intersects an Architrino</a:t>
             </a:r>
           </a:p>
         </p:txBody>
@@ -31508,7 +28820,7 @@
                 <a:ea typeface="Helvetica Neue" panose="02000503000000020004" pitchFamily="2" charset="0"/>
                 <a:cs typeface="Helvetica Neue" panose="02000503000000020004" pitchFamily="2" charset="0"/>
               </a:rPr>
-              <a:t>Point Potential Path</a:t>
+              <a:t>Architrino Path</a:t>
             </a:r>
             <a:endParaRPr kumimoji="0" lang="en-US" sz="1100" b="0" i="1" u="none" strike="noStrike" kern="1200" cap="none" spc="0" normalizeH="0" baseline="0" noProof="0" dirty="0">
               <a:ln>
@@ -31636,7 +28948,8 @@
             <a:solidFill>
               <a:srgbClr val="00B0F0"/>
             </a:solidFill>
-            <a:tailEnd type="triangle"/>
+            <a:headEnd type="triangle"/>
+            <a:tailEnd type="none"/>
           </a:ln>
         </p:spPr>
         <p:style>
@@ -31763,7 +29076,8 @@
             <a:solidFill>
               <a:srgbClr val="00B0F0"/>
             </a:solidFill>
-            <a:tailEnd type="triangle"/>
+            <a:headEnd type="triangle"/>
+            <a:tailEnd type="none"/>
           </a:ln>
         </p:spPr>
         <p:style>
@@ -32041,7 +29355,7 @@
                 <a:ea typeface="Helvetica Neue" panose="02000503000000020004" pitchFamily="2" charset="0"/>
                 <a:cs typeface="Helvetica Neue" panose="02000503000000020004" pitchFamily="2" charset="0"/>
               </a:rPr>
-              <a:t>Imagine a point potential with linear velocity v = @, the electric potential field speed.</a:t>
+              <a:t>At v = c_f, an architrino is at the wake-speed threshold.</a:t>
             </a:r>
           </a:p>
           <a:p>
@@ -32077,7 +29391,7 @@
                 <a:ea typeface="Helvetica Neue" panose="02000503000000020004" pitchFamily="2" charset="0"/>
                 <a:cs typeface="Helvetica Neue" panose="02000503000000020004" pitchFamily="2" charset="0"/>
               </a:rPr>
-              <a:t>The point potential does not experience self action.</a:t>
+              <a:t>It does not yet retain a self-hit.</a:t>
             </a:r>
           </a:p>
           <a:p>
@@ -32113,7 +29427,7 @@
                 <a:ea typeface="Helvetica Neue" panose="02000503000000020004" pitchFamily="2" charset="0"/>
                 <a:cs typeface="Helvetica Neue" panose="02000503000000020004" pitchFamily="2" charset="0"/>
               </a:rPr>
-              <a:t>This symmetry breaking point is related to quantum mechanics symmetry breaking.</a:t>
+              <a:t>This threshold is the symmetry-breaking point.</a:t>
             </a:r>
           </a:p>
           <a:p>
@@ -32149,7 +29463,7 @@
                 <a:ea typeface="Helvetica Neue" panose="02000503000000020004" pitchFamily="2" charset="0"/>
                 <a:cs typeface="Helvetica Neue" panose="02000503000000020004" pitchFamily="2" charset="0"/>
               </a:rPr>
-              <a:t>Symmetry breaking at Wien’s peak occurs when the binary potential velocities are v = @.</a:t>
+              <a:t>It separates partner-only from self-hit-capable regimes in binary reductions.</a:t>
             </a:r>
           </a:p>
           <a:p>
@@ -32185,7 +29499,7 @@
                 <a:ea typeface="Helvetica Neue" panose="02000503000000020004" pitchFamily="2" charset="0"/>
                 <a:cs typeface="Helvetica Neue" panose="02000503000000020004" pitchFamily="2" charset="0"/>
               </a:rPr>
-              <a:t>There may be a relation or duality with a black hole event horizon.</a:t>
+              <a:t>Horizon language remains a comparison, not a closed derivation.</a:t>
             </a:r>
           </a:p>
         </p:txBody>
@@ -33064,7 +30378,7 @@
                 <a:ea typeface="Helvetica Neue" panose="02000503000000020004" pitchFamily="2" charset="0"/>
                 <a:cs typeface="Helvetica Neue" panose="02000503000000020004" pitchFamily="2" charset="0"/>
               </a:rPr>
-              <a:t>v = @</a:t>
+              <a:t>v = c_f</a:t>
             </a:r>
           </a:p>
         </p:txBody>
@@ -33129,7 +30443,7 @@
                 <a:ea typeface="Helvetica Neue" panose="02000503000000020004" pitchFamily="2" charset="0"/>
                 <a:cs typeface="Helvetica Neue" panose="02000503000000020004" pitchFamily="2" charset="0"/>
               </a:rPr>
-              <a:t>@</a:t>
+              <a:t>c_f</a:t>
             </a:r>
           </a:p>
         </p:txBody>
@@ -33194,7 +30508,7 @@
                 <a:ea typeface="Helvetica Neue" panose="02000503000000020004" pitchFamily="2" charset="0"/>
                 <a:cs typeface="Helvetica Neue" panose="02000503000000020004" pitchFamily="2" charset="0"/>
               </a:rPr>
-              <a:t>Electric Potential Field Tracers</a:t>
+              <a:t>Causal Wake Tracers</a:t>
             </a:r>
             <a:endParaRPr kumimoji="0" lang="en-US" sz="1100" b="0" i="1" u="none" strike="noStrike" kern="1200" cap="none" spc="0" normalizeH="0" baseline="0" noProof="0" dirty="0">
               <a:ln>
@@ -33316,7 +30630,7 @@
                 <a:ea typeface="Helvetica Neue" panose="02000503000000020004" pitchFamily="2" charset="0"/>
                 <a:cs typeface="Helvetica Neue" panose="02000503000000020004" pitchFamily="2" charset="0"/>
               </a:rPr>
-              <a:t>Point Potential on Linear Path with Velocity v = @</a:t>
+              <a:t>Architrino on Linear Path with Velocity v = c_f</a:t>
             </a:r>
           </a:p>
         </p:txBody>
@@ -33489,7 +30803,7 @@
                   <a:ea typeface="Helvetica Neue" panose="02000503000000020004" pitchFamily="2" charset="0"/>
                   <a:cs typeface="Helvetica Neue" panose="02000503000000020004" pitchFamily="2" charset="0"/>
                 </a:rPr>
-                <a:t>Absolute Euclidean Time</a:t>
+                <a:t>Absolute Time</a:t>
               </a:r>
             </a:p>
           </p:txBody>
@@ -33521,42 +30835,6 @@
               <a:spAutoFit/>
             </a:bodyPr>
             <a:lstStyle/>
-            <a:p>
-              <a:pPr marL="0" marR="0" lvl="0" indent="0" algn="ctr" defTabSz="914400" rtl="0" eaLnBrk="1" fontAlgn="auto" latinLnBrk="0" hangingPunct="1">
-                <a:lnSpc>
-                  <a:spcPct val="100000"/>
-                </a:lnSpc>
-                <a:spcBef>
-                  <a:spcPts val="0"/>
-                </a:spcBef>
-                <a:spcAft>
-                  <a:spcPts val="0"/>
-                </a:spcAft>
-                <a:buClrTx/>
-                <a:buSzTx/>
-                <a:buFontTx/>
-                <a:buNone/>
-                <a:tabLst/>
-                <a:defRPr/>
-              </a:pPr>
-              <a:r>
-                <a:rPr kumimoji="0" lang="en-US" sz="1800" b="0" i="0" u="none" strike="noStrike" kern="1200" cap="none" spc="0" normalizeH="0" baseline="0" noProof="0" dirty="0">
-                  <a:ln>
-                    <a:noFill/>
-                  </a:ln>
-                  <a:solidFill>
-                    <a:prstClr val="white"/>
-                  </a:solidFill>
-                  <a:effectLst/>
-                  <a:uLnTx/>
-                  <a:uFillTx/>
-                  <a:latin typeface="Helvetica Neue" panose="02000503000000020004" pitchFamily="2" charset="0"/>
-                  <a:ea typeface="Helvetica Neue" panose="02000503000000020004" pitchFamily="2" charset="0"/>
-                  <a:cs typeface="Helvetica Neue" panose="02000503000000020004" pitchFamily="2" charset="0"/>
-                </a:rPr>
-                <a:t>Absolute </a:t>
-              </a:r>
-            </a:p>
             <a:p>
               <a:pPr marL="0" marR="0" lvl="0" indent="0" algn="ctr" defTabSz="914400" rtl="0" eaLnBrk="1" fontAlgn="auto" latinLnBrk="0" hangingPunct="1">
                 <a:lnSpc>
@@ -33626,7 +30904,7 @@
                   <a:ea typeface="Helvetica Neue" panose="02000503000000020004" pitchFamily="2" charset="0"/>
                   <a:cs typeface="Helvetica Neue" panose="02000503000000020004" pitchFamily="2" charset="0"/>
                 </a:rPr>
-                <a:t>3D Space</a:t>
+                <a:t>Void</a:t>
               </a:r>
             </a:p>
           </p:txBody>
@@ -33892,7 +31170,7 @@
                 <a:ea typeface="Helvetica Neue" panose="02000503000000020004" pitchFamily="2" charset="0"/>
                 <a:cs typeface="Helvetica Neue" panose="02000503000000020004" pitchFamily="2" charset="0"/>
               </a:rPr>
-              <a:t>Imagine a point potential with linear velocity v &gt; @, the electric potential field speed.</a:t>
+              <a:t>Imagine an architrino with linear velocity v &gt; c_f, above wake speed.</a:t>
             </a:r>
           </a:p>
           <a:p>
@@ -33928,7 +31206,7 @@
                 <a:ea typeface="Helvetica Neue" panose="02000503000000020004" pitchFamily="2" charset="0"/>
                 <a:cs typeface="Helvetica Neue" panose="02000503000000020004" pitchFamily="2" charset="0"/>
               </a:rPr>
-              <a:t>The point potential outpaces its own potential field.</a:t>
+              <a:t>The source can outrun earlier wake surfaces.</a:t>
             </a:r>
           </a:p>
           <a:p>
@@ -33964,41 +31242,8 @@
                 <a:ea typeface="Helvetica Neue" panose="02000503000000020004" pitchFamily="2" charset="0"/>
                 <a:cs typeface="Helvetica Neue" panose="02000503000000020004" pitchFamily="2" charset="0"/>
               </a:rPr>
-              <a:t>When v &gt; @ the point potential experiences its own field and there is self action.</a:t>
+              <a:t>When a same-source causal root exists, the architrino can receive self-hit feedback.</a:t>
             </a:r>
-          </a:p>
-          <a:p>
-            <a:pPr marL="285750" marR="0" lvl="0" indent="-285750" algn="l" defTabSz="914400" rtl="0" eaLnBrk="1" fontAlgn="auto" latinLnBrk="0" hangingPunct="1">
-              <a:lnSpc>
-                <a:spcPct val="100000"/>
-              </a:lnSpc>
-              <a:spcBef>
-                <a:spcPts val="0"/>
-              </a:spcBef>
-              <a:spcAft>
-                <a:spcPts val="0"/>
-              </a:spcAft>
-              <a:buClrTx/>
-              <a:buSzTx/>
-              <a:buFont typeface="Arial" panose="020B0604020202020204" pitchFamily="34" charset="0"/>
-              <a:buChar char="•"/>
-              <a:tabLst/>
-              <a:defRPr/>
-            </a:pPr>
-            <a:endParaRPr kumimoji="0" lang="en-US" sz="1600" b="0" i="0" u="none" strike="noStrike" kern="1200" cap="none" spc="0" normalizeH="0" baseline="0" noProof="0" dirty="0">
-              <a:ln>
-                <a:noFill/>
-              </a:ln>
-              <a:solidFill>
-                <a:prstClr val="black"/>
-              </a:solidFill>
-              <a:effectLst/>
-              <a:uLnTx/>
-              <a:uFillTx/>
-              <a:latin typeface="Calibri" panose="020F0502020204030204"/>
-              <a:ea typeface="+mn-ea"/>
-              <a:cs typeface="+mn-cs"/>
-            </a:endParaRPr>
           </a:p>
         </p:txBody>
       </p:sp>
@@ -34881,7 +32126,7 @@
                 <a:ea typeface="Helvetica Neue" panose="02000503000000020004" pitchFamily="2" charset="0"/>
                 <a:cs typeface="Helvetica Neue" panose="02000503000000020004" pitchFamily="2" charset="0"/>
               </a:rPr>
-              <a:t>v &gt; @</a:t>
+              <a:t>v &gt; c_f</a:t>
             </a:r>
           </a:p>
         </p:txBody>
@@ -34949,7 +32194,7 @@
                 <a:ea typeface="Helvetica Neue" panose="02000503000000020004" pitchFamily="2" charset="0"/>
                 <a:cs typeface="Helvetica Neue" panose="02000503000000020004" pitchFamily="2" charset="0"/>
               </a:rPr>
-              <a:t>@</a:t>
+              <a:t>c_f</a:t>
             </a:r>
           </a:p>
         </p:txBody>
@@ -35017,7 +32262,7 @@
                 <a:ea typeface="Helvetica Neue" panose="02000503000000020004" pitchFamily="2" charset="0"/>
                 <a:cs typeface="Helvetica Neue" panose="02000503000000020004" pitchFamily="2" charset="0"/>
               </a:rPr>
-              <a:t>Electric Potential Field Tracers</a:t>
+              <a:t>Causal Wake Tracers</a:t>
             </a:r>
             <a:endParaRPr kumimoji="0" lang="en-US" sz="1100" b="0" i="1" u="none" strike="noStrike" kern="1200" cap="none" spc="0" normalizeH="0" baseline="0" noProof="0" dirty="0">
               <a:ln>
@@ -35139,7 +32384,7 @@
                 <a:ea typeface="Helvetica Neue" panose="02000503000000020004" pitchFamily="2" charset="0"/>
                 <a:cs typeface="Helvetica Neue" panose="02000503000000020004" pitchFamily="2" charset="0"/>
               </a:rPr>
-              <a:t>Point Potential on Linear Path with Velocity v &gt; @</a:t>
+              <a:t>Architrino on Linear Path with Velocity v &gt; c_f</a:t>
             </a:r>
           </a:p>
         </p:txBody>
@@ -35292,7 +32537,7 @@
                 <a:ea typeface="Helvetica Neue" panose="02000503000000020004" pitchFamily="2" charset="0"/>
                 <a:cs typeface="Helvetica Neue" panose="02000503000000020004" pitchFamily="2" charset="0"/>
               </a:rPr>
-              <a:t>Absolute Euclidean Time</a:t>
+              <a:t>Absolute Time</a:t>
             </a:r>
           </a:p>
         </p:txBody>
@@ -35357,7 +32602,7 @@
                 <a:ea typeface="Helvetica Neue" panose="02000503000000020004" pitchFamily="2" charset="0"/>
                 <a:cs typeface="Helvetica Neue" panose="02000503000000020004" pitchFamily="2" charset="0"/>
               </a:rPr>
-              <a:t>Absolute </a:t>
+              <a:t>Euclidean</a:t>
             </a:r>
           </a:p>
           <a:p>
@@ -35393,43 +32638,7 @@
                 <a:ea typeface="Helvetica Neue" panose="02000503000000020004" pitchFamily="2" charset="0"/>
                 <a:cs typeface="Helvetica Neue" panose="02000503000000020004" pitchFamily="2" charset="0"/>
               </a:rPr>
-              <a:t>Euclidean</a:t>
-            </a:r>
-          </a:p>
-          <a:p>
-            <a:pPr marL="0" marR="0" lvl="0" indent="0" algn="ctr" defTabSz="914400" rtl="0" eaLnBrk="1" fontAlgn="auto" latinLnBrk="0" hangingPunct="1">
-              <a:lnSpc>
-                <a:spcPct val="100000"/>
-              </a:lnSpc>
-              <a:spcBef>
-                <a:spcPts val="0"/>
-              </a:spcBef>
-              <a:spcAft>
-                <a:spcPts val="0"/>
-              </a:spcAft>
-              <a:buClrTx/>
-              <a:buSzTx/>
-              <a:buFontTx/>
-              <a:buNone/>
-              <a:tabLst/>
-              <a:defRPr/>
-            </a:pPr>
-            <a:r>
-              <a:rPr kumimoji="0" lang="en-US" sz="1800" b="0" i="0" u="none" strike="noStrike" kern="1200" cap="none" spc="0" normalizeH="0" baseline="0" noProof="0" dirty="0">
-                <a:ln>
-                  <a:noFill/>
-                </a:ln>
-                <a:solidFill>
-                  <a:prstClr val="white"/>
-                </a:solidFill>
-                <a:effectLst/>
-                <a:uLnTx/>
-                <a:uFillTx/>
-                <a:latin typeface="Helvetica Neue" panose="02000503000000020004" pitchFamily="2" charset="0"/>
-                <a:ea typeface="Helvetica Neue" panose="02000503000000020004" pitchFamily="2" charset="0"/>
-                <a:cs typeface="Helvetica Neue" panose="02000503000000020004" pitchFamily="2" charset="0"/>
-              </a:rPr>
-              <a:t>3D Space</a:t>
+              <a:t>Void</a:t>
             </a:r>
           </a:p>
         </p:txBody>
@@ -36107,7 +33316,7 @@
                 <a:ea typeface="Helvetica Neue" panose="02000503000000020004" pitchFamily="2" charset="0"/>
                 <a:cs typeface="Helvetica Neue" panose="02000503000000020004" pitchFamily="2" charset="0"/>
               </a:rPr>
-              <a:t>Emission Magnitude Depends on Path</a:t>
+              <a:t>Wake Strength Depends on Path</a:t>
             </a:r>
           </a:p>
         </p:txBody>
@@ -36172,7 +33381,7 @@
                 <a:ea typeface="Helvetica Neue" panose="02000503000000020004" pitchFamily="2" charset="0"/>
                 <a:cs typeface="Helvetica Neue" panose="02000503000000020004" pitchFamily="2" charset="0"/>
               </a:rPr>
-              <a:t>Paths are continuous through time and space.</a:t>
+              <a:t>Paths are continuous in absolute time and the Euclidean void.</a:t>
             </a:r>
           </a:p>
           <a:p>
@@ -36208,41 +33417,7 @@
                 <a:ea typeface="Helvetica Neue" panose="02000503000000020004" pitchFamily="2" charset="0"/>
                 <a:cs typeface="Helvetica Neue" panose="02000503000000020004" pitchFamily="2" charset="0"/>
               </a:rPr>
-              <a:t>Emission rate is a constant </a:t>
-            </a:r>
-            <a:r>
-              <a:rPr kumimoji="0" lang="en-US" sz="1800" b="1" i="0" u="none" strike="noStrike" kern="1200" cap="none" spc="0" normalizeH="0" baseline="0" noProof="0" dirty="0" err="1">
-                <a:ln>
-                  <a:noFill/>
-                </a:ln>
-                <a:solidFill>
-                  <a:prstClr val="white"/>
-                </a:solidFill>
-                <a:effectLst/>
-                <a:uLnTx/>
-                <a:uFillTx/>
-                <a:latin typeface="Helvetica Neue" panose="02000503000000020004" pitchFamily="2" charset="0"/>
-                <a:ea typeface="Helvetica Neue" panose="02000503000000020004" pitchFamily="2" charset="0"/>
-                <a:cs typeface="Helvetica Neue" panose="02000503000000020004" pitchFamily="2" charset="0"/>
-              </a:rPr>
-              <a:t>dq</a:t>
-            </a:r>
-            <a:r>
-              <a:rPr kumimoji="0" lang="en-US" sz="1800" b="1" i="0" u="none" strike="noStrike" kern="1200" cap="none" spc="0" normalizeH="0" baseline="0" noProof="0" dirty="0">
-                <a:ln>
-                  <a:noFill/>
-                </a:ln>
-                <a:solidFill>
-                  <a:prstClr val="white"/>
-                </a:solidFill>
-                <a:effectLst/>
-                <a:uLnTx/>
-                <a:uFillTx/>
-                <a:latin typeface="Helvetica Neue" panose="02000503000000020004" pitchFamily="2" charset="0"/>
-                <a:ea typeface="Helvetica Neue" panose="02000503000000020004" pitchFamily="2" charset="0"/>
-                <a:cs typeface="Helvetica Neue" panose="02000503000000020004" pitchFamily="2" charset="0"/>
-              </a:rPr>
-              <a:t>/dt</a:t>
+              <a:t>Emission rate is modeled as a constant polarity-source rate.</a:t>
             </a:r>
           </a:p>
           <a:p>
@@ -36278,7 +33453,7 @@
                 <a:ea typeface="Helvetica Neue" panose="02000503000000020004" pitchFamily="2" charset="0"/>
                 <a:cs typeface="Helvetica Neue" panose="02000503000000020004" pitchFamily="2" charset="0"/>
               </a:rPr>
-              <a:t>At v = 0, emission magnitude is q</a:t>
+              <a:t>At v = 0, wake strength is q.</a:t>
             </a:r>
           </a:p>
           <a:p>
@@ -36314,7 +33489,7 @@
                 <a:ea typeface="Helvetica Neue" panose="02000503000000020004" pitchFamily="2" charset="0"/>
                 <a:cs typeface="Helvetica Neue" panose="02000503000000020004" pitchFamily="2" charset="0"/>
               </a:rPr>
-              <a:t>At v &gt; 0, emission magnitude is q/v</a:t>
+              <a:t>For v &gt; 0, received strength depends on source motion and causal-root geometry.</a:t>
             </a:r>
           </a:p>
           <a:p>
@@ -36350,76 +33525,9 @@
                 <a:ea typeface="Helvetica Neue" panose="02000503000000020004" pitchFamily="2" charset="0"/>
                 <a:cs typeface="Helvetica Neue" panose="02000503000000020004" pitchFamily="2" charset="0"/>
               </a:rPr>
-              <a:t>The potential magnitude at the surface of each Dirac sphere decreases as 1/r</a:t>
-            </a:r>
-            <a:r>
-              <a:rPr kumimoji="0" lang="en-US" sz="1800" b="1" i="0" u="none" strike="noStrike" kern="1200" cap="none" spc="0" normalizeH="0" baseline="30000" noProof="0" dirty="0">
-                <a:ln>
-                  <a:noFill/>
-                </a:ln>
-                <a:solidFill>
-                  <a:prstClr val="white"/>
-                </a:solidFill>
-                <a:effectLst/>
-                <a:uLnTx/>
-                <a:uFillTx/>
-                <a:latin typeface="Helvetica Neue" panose="02000503000000020004" pitchFamily="2" charset="0"/>
-                <a:ea typeface="Helvetica Neue" panose="02000503000000020004" pitchFamily="2" charset="0"/>
-                <a:cs typeface="Helvetica Neue" panose="02000503000000020004" pitchFamily="2" charset="0"/>
-              </a:rPr>
-              <a:t>2</a:t>
-            </a:r>
-            <a:r>
-              <a:rPr kumimoji="0" lang="en-US" sz="1800" b="1" i="0" u="none" strike="noStrike" kern="1200" cap="none" spc="0" normalizeH="0" baseline="0" noProof="0" dirty="0">
-                <a:ln>
-                  <a:noFill/>
-                </a:ln>
-                <a:solidFill>
-                  <a:prstClr val="white"/>
-                </a:solidFill>
-                <a:effectLst/>
-                <a:uLnTx/>
-                <a:uFillTx/>
-                <a:latin typeface="Helvetica Neue" panose="02000503000000020004" pitchFamily="2" charset="0"/>
-                <a:ea typeface="Helvetica Neue" panose="02000503000000020004" pitchFamily="2" charset="0"/>
-                <a:cs typeface="Helvetica Neue" panose="02000503000000020004" pitchFamily="2" charset="0"/>
-              </a:rPr>
-              <a:t>, where r is the radius to the emission point, the sphere center</a:t>
+              <a:t>Wake-surface density decreases as 1/r^2 with radius from the emission point.</a:t>
             </a:r>
             <a:endParaRPr kumimoji="0" lang="en-US" sz="1800" b="1" i="0" u="none" strike="noStrike" kern="1200" cap="none" spc="0" normalizeH="0" baseline="30000" noProof="0" dirty="0">
-              <a:ln>
-                <a:noFill/>
-              </a:ln>
-              <a:solidFill>
-                <a:prstClr val="white"/>
-              </a:solidFill>
-              <a:effectLst/>
-              <a:uLnTx/>
-              <a:uFillTx/>
-              <a:latin typeface="Helvetica Neue" panose="02000503000000020004" pitchFamily="2" charset="0"/>
-              <a:ea typeface="Helvetica Neue" panose="02000503000000020004" pitchFamily="2" charset="0"/>
-              <a:cs typeface="Helvetica Neue" panose="02000503000000020004" pitchFamily="2" charset="0"/>
-            </a:endParaRPr>
-          </a:p>
-          <a:p>
-            <a:pPr marL="285750" marR="0" lvl="0" indent="-285750" algn="l" defTabSz="914400" rtl="0" eaLnBrk="1" fontAlgn="auto" latinLnBrk="0" hangingPunct="1">
-              <a:lnSpc>
-                <a:spcPct val="150000"/>
-              </a:lnSpc>
-              <a:spcBef>
-                <a:spcPts val="0"/>
-              </a:spcBef>
-              <a:spcAft>
-                <a:spcPts val="0"/>
-              </a:spcAft>
-              <a:buClrTx/>
-              <a:buSzTx/>
-              <a:buFont typeface="Arial" panose="020B0604020202020204" pitchFamily="34" charset="0"/>
-              <a:buChar char="•"/>
-              <a:tabLst/>
-              <a:defRPr/>
-            </a:pPr>
-            <a:endParaRPr kumimoji="0" lang="en-US" sz="1800" b="1" i="0" u="none" strike="noStrike" kern="1200" cap="none" spc="0" normalizeH="0" baseline="0" noProof="0" dirty="0">
               <a:ln>
                 <a:noFill/>
               </a:ln>
@@ -38360,7 +35468,7 @@
                 <a:ea typeface="Helvetica Neue" panose="02000503000000020004" pitchFamily="2" charset="0"/>
                 <a:cs typeface="Helvetica Neue" panose="02000503000000020004" pitchFamily="2" charset="0"/>
               </a:rPr>
-              <a:t>The potential emitted by charge A at time t’ expands spherically at field speed @. </a:t>
+              <a:t>The causal wake emitted by architrino A at time t' expands at wake speed c_f.</a:t>
             </a:r>
           </a:p>
           <a:p>
@@ -38373,7 +35481,7 @@
                 <a:ea typeface="Helvetica Neue" panose="02000503000000020004" pitchFamily="2" charset="0"/>
                 <a:cs typeface="Helvetica Neue" panose="02000503000000020004" pitchFamily="2" charset="0"/>
               </a:rPr>
-              <a:t>Action occurs when the potential sphere intersects charge B at time t.</a:t>
+              <a:t>A hit occurs when that wake surface intersects architrino B at time t.</a:t>
             </a:r>
             <a:endParaRPr lang="en-US" dirty="0">
               <a:solidFill>
@@ -38658,7 +35766,7 @@
                 <a:ea typeface="Helvetica Neue" panose="02000503000000020004" pitchFamily="2" charset="0"/>
                 <a:cs typeface="Helvetica Neue" panose="02000503000000020004" pitchFamily="2" charset="0"/>
               </a:rPr>
-              <a:t>Point Potential Path History and Action</a:t>
+              <a:t>Architrino Path History and Wake Hits</a:t>
             </a:r>
             <a:endParaRPr lang="en-US" sz="2800" b="1" baseline="30000" dirty="0">
               <a:solidFill>
@@ -38839,7 +35947,7 @@
                   <a:ea typeface="Helvetica Neue" panose="02000503000000020004" pitchFamily="2" charset="0"/>
                   <a:cs typeface="Helvetica Neue" panose="02000503000000020004" pitchFamily="2" charset="0"/>
                 </a:rPr>
-                <a:t>Absolute Euclidean Time</a:t>
+                <a:t>Absolute Time</a:t>
               </a:r>
             </a:p>
           </p:txBody>
@@ -38871,42 +35979,6 @@
               <a:spAutoFit/>
             </a:bodyPr>
             <a:lstStyle/>
-            <a:p>
-              <a:pPr marL="0" marR="0" lvl="0" indent="0" algn="ctr" defTabSz="914400" rtl="0" eaLnBrk="1" fontAlgn="auto" latinLnBrk="0" hangingPunct="1">
-                <a:lnSpc>
-                  <a:spcPct val="100000"/>
-                </a:lnSpc>
-                <a:spcBef>
-                  <a:spcPts val="0"/>
-                </a:spcBef>
-                <a:spcAft>
-                  <a:spcPts val="0"/>
-                </a:spcAft>
-                <a:buClrTx/>
-                <a:buSzTx/>
-                <a:buFontTx/>
-                <a:buNone/>
-                <a:tabLst/>
-                <a:defRPr/>
-              </a:pPr>
-              <a:r>
-                <a:rPr kumimoji="0" lang="en-US" sz="1800" b="0" i="0" u="none" strike="noStrike" kern="1200" cap="none" spc="0" normalizeH="0" baseline="0" noProof="0" dirty="0">
-                  <a:ln>
-                    <a:noFill/>
-                  </a:ln>
-                  <a:solidFill>
-                    <a:prstClr val="white"/>
-                  </a:solidFill>
-                  <a:effectLst/>
-                  <a:uLnTx/>
-                  <a:uFillTx/>
-                  <a:latin typeface="Helvetica Neue" panose="02000503000000020004" pitchFamily="2" charset="0"/>
-                  <a:ea typeface="Helvetica Neue" panose="02000503000000020004" pitchFamily="2" charset="0"/>
-                  <a:cs typeface="Helvetica Neue" panose="02000503000000020004" pitchFamily="2" charset="0"/>
-                </a:rPr>
-                <a:t>Absolute </a:t>
-              </a:r>
-            </a:p>
             <a:p>
               <a:pPr marL="0" marR="0" lvl="0" indent="0" algn="ctr" defTabSz="914400" rtl="0" eaLnBrk="1" fontAlgn="auto" latinLnBrk="0" hangingPunct="1">
                 <a:lnSpc>
@@ -38976,7 +36048,7 @@
                   <a:ea typeface="Helvetica Neue" panose="02000503000000020004" pitchFamily="2" charset="0"/>
                   <a:cs typeface="Helvetica Neue" panose="02000503000000020004" pitchFamily="2" charset="0"/>
                 </a:rPr>
-                <a:t>3D Space</a:t>
+                <a:t>Void</a:t>
               </a:r>
             </a:p>
           </p:txBody>

</xml_diff>

<commit_message>
Refactor architrino theory and content pipelines
</commit_message>
<xml_diff>
--- a/reference/archie/presentations/NPQG Fundamentals - Paths.pptx
+++ b/reference/archie/presentations/NPQG Fundamentals - Paths.pptx
@@ -494,14 +494,14 @@
 </file>
 
 <file path=ppt/notesSlides/notesSlide1.xml><?xml version="1.0" encoding="utf-8"?>
-<p:notes xmlns:a="http://schemas.openxmlformats.org/drawingml/2006/main" xmlns:r="http://schemas.openxmlformats.org/officeDocument/2006/relationships" xmlns:p="http://schemas.openxmlformats.org/presentationml/2006/main">
+<p:notes xmlns:a="http://schemas.openxmlformats.org/drawingml/2006/main" xmlns:ns2="http://schemas.microsoft.com/office/drawing/2014/main" xmlns:ns3="http://schemas.microsoft.com/office/powerpoint/2010/main" xmlns:p="http://schemas.openxmlformats.org/presentationml/2006/main">
   <p:cSld>
     <p:spTree>
       <p:nvGrpSpPr>
         <p:cNvPr id="1" name="">
           <a:extLst>
             <a:ext uri="{FF2B5EF4-FFF2-40B4-BE49-F238E27FC236}">
-              <a16:creationId xmlns:a16="http://schemas.microsoft.com/office/drawing/2014/main" id="{72B4FD5E-E4A1-869A-87AC-4D8560C3AA3A}"/>
+              <ns2:creationId id="{72B4FD5E-E4A1-869A-87AC-4D8560C3AA3A}"/>
             </a:ext>
           </a:extLst>
         </p:cNvPr>
@@ -521,7 +521,7 @@
           <p:cNvPr id="2" name="Slide Image Placeholder 1">
             <a:extLst>
               <a:ext uri="{FF2B5EF4-FFF2-40B4-BE49-F238E27FC236}">
-                <a16:creationId xmlns:a16="http://schemas.microsoft.com/office/drawing/2014/main" id="{5BE4D260-7D14-DF6F-8DA8-28937DE9D0A3}"/>
+                <ns2:creationId id="{5BE4D260-7D14-DF6F-8DA8-28937DE9D0A3}"/>
               </a:ext>
             </a:extLst>
           </p:cNvPr>
@@ -539,7 +539,7 @@
           <p:cNvPr id="3" name="Notes Placeholder 2">
             <a:extLst>
               <a:ext uri="{FF2B5EF4-FFF2-40B4-BE49-F238E27FC236}">
-                <a16:creationId xmlns:a16="http://schemas.microsoft.com/office/drawing/2014/main" id="{4A5A7B81-68A0-4528-3EA2-B6C48D555A49}"/>
+                <ns2:creationId id="{4A5A7B81-68A0-4528-3EA2-B6C48D555A49}"/>
               </a:ext>
             </a:extLst>
           </p:cNvPr>
@@ -618,7 +618,7 @@
           <p:cNvPr id="4" name="Slide Number Placeholder 3">
             <a:extLst>
               <a:ext uri="{FF2B5EF4-FFF2-40B4-BE49-F238E27FC236}">
-                <a16:creationId xmlns:a16="http://schemas.microsoft.com/office/drawing/2014/main" id="{273AC267-9E54-7CAF-A5D8-FE3E621ED2C2}"/>
+                <ns2:creationId id="{273AC267-9E54-7CAF-A5D8-FE3E621ED2C2}"/>
               </a:ext>
             </a:extLst>
           </p:cNvPr>
@@ -705,7 +705,7 @@
     </p:spTree>
     <p:extLst>
       <p:ext uri="{BB962C8B-B14F-4D97-AF65-F5344CB8AC3E}">
-        <p14:creationId xmlns:p14="http://schemas.microsoft.com/office/powerpoint/2010/main" val="1162151565"/>
+        <ns3:creationId val="1162151565"/>
       </p:ext>
     </p:extLst>
   </p:cSld>
@@ -716,7 +716,7 @@
 </file>
 
 <file path=ppt/notesSlides/notesSlide10.xml><?xml version="1.0" encoding="utf-8"?>
-<p:notes xmlns:a="http://schemas.openxmlformats.org/drawingml/2006/main" xmlns:r="http://schemas.openxmlformats.org/officeDocument/2006/relationships" xmlns:p="http://schemas.openxmlformats.org/presentationml/2006/main">
+<p:notes xmlns:a="http://schemas.openxmlformats.org/drawingml/2006/main" xmlns:ns2="http://schemas.microsoft.com/office/powerpoint/2010/main" xmlns:p="http://schemas.openxmlformats.org/presentationml/2006/main">
   <p:cSld>
     <p:spTree>
       <p:nvGrpSpPr>
@@ -822,12 +822,36 @@
               </a:rPr>
             </a:br>
             <a:r>
-              <a:rPr lang="en-US" sz="9600" b="1" dirty="0">
+              <a:rPr lang="en-US" sz="9600" b="1" dirty="0" baseline="0">
                 <a:latin typeface="Helvetica Neue" panose="02000503000000020004" pitchFamily="2" charset="0"/>
                 <a:ea typeface="Helvetica Neue" panose="02000503000000020004" pitchFamily="2" charset="0"/>
                 <a:cs typeface="Helvetica Neue" panose="02000503000000020004" pitchFamily="2" charset="0"/>
               </a:rPr>
-              <a:t>They may also be riding on their own wake if v &gt; c_f. </a:t>
+              <a:t xml:space="preserve">They may also be riding on their own wake if v &gt; </a:t>
+            </a:r>
+            <a:r>
+              <a:rPr lang="en-US" sz="9600" b="1" dirty="0" baseline="0">
+                <a:latin typeface="Helvetica Neue" panose="02000503000000020004" pitchFamily="2" charset="0"/>
+                <a:ea typeface="Helvetica Neue" panose="02000503000000020004" pitchFamily="2" charset="0"/>
+                <a:cs typeface="Helvetica Neue" panose="02000503000000020004" pitchFamily="2" charset="0"/>
+              </a:rPr>
+              <a:t>c</a:t>
+            </a:r>
+            <a:r>
+              <a:rPr lang="en-US" sz="6720" b="1" dirty="0" baseline="-25000">
+                <a:latin typeface="Helvetica Neue" panose="02000503000000020004" pitchFamily="2" charset="0"/>
+                <a:ea typeface="Helvetica Neue" panose="02000503000000020004" pitchFamily="2" charset="0"/>
+                <a:cs typeface="Helvetica Neue" panose="02000503000000020004" pitchFamily="2" charset="0"/>
+              </a:rPr>
+              <a:t>f</a:t>
+            </a:r>
+            <a:r>
+              <a:rPr lang="en-US" sz="9600" b="1" dirty="0" baseline="0">
+                <a:latin typeface="Helvetica Neue" panose="02000503000000020004" pitchFamily="2" charset="0"/>
+                <a:ea typeface="Helvetica Neue" panose="02000503000000020004" pitchFamily="2" charset="0"/>
+                <a:cs typeface="Helvetica Neue" panose="02000503000000020004" pitchFamily="2" charset="0"/>
+              </a:rPr>
+              <a:t xml:space="preserve">. </a:t>
             </a:r>
             <a:br>
               <a:rPr lang="en-US" sz="9600" b="1" dirty="0">
@@ -837,12 +861,36 @@
               </a:rPr>
             </a:br>
             <a:r>
-              <a:rPr lang="en-US" sz="9600" b="1" dirty="0">
+              <a:rPr lang="en-US" sz="9600" b="1" dirty="0" baseline="0">
                 <a:latin typeface="Helvetica Neue" panose="02000503000000020004" pitchFamily="2" charset="0"/>
                 <a:ea typeface="Helvetica Neue" panose="02000503000000020004" pitchFamily="2" charset="0"/>
                 <a:cs typeface="Helvetica Neue" panose="02000503000000020004" pitchFamily="2" charset="0"/>
               </a:rPr>
-              <a:t>For each partner that has operated at v&gt;c_f a architrino may encounter multiple of their wakes or a continuous stretch of wake?  </a:t>
+              <a:t>For each partner that has operated at v&gt;</a:t>
+            </a:r>
+            <a:r>
+              <a:rPr lang="en-US" sz="9600" b="1" dirty="0" baseline="0">
+                <a:latin typeface="Helvetica Neue" panose="02000503000000020004" pitchFamily="2" charset="0"/>
+                <a:ea typeface="Helvetica Neue" panose="02000503000000020004" pitchFamily="2" charset="0"/>
+                <a:cs typeface="Helvetica Neue" panose="02000503000000020004" pitchFamily="2" charset="0"/>
+              </a:rPr>
+              <a:t>c</a:t>
+            </a:r>
+            <a:r>
+              <a:rPr lang="en-US" sz="6720" b="1" dirty="0" baseline="-25000">
+                <a:latin typeface="Helvetica Neue" panose="02000503000000020004" pitchFamily="2" charset="0"/>
+                <a:ea typeface="Helvetica Neue" panose="02000503000000020004" pitchFamily="2" charset="0"/>
+                <a:cs typeface="Helvetica Neue" panose="02000503000000020004" pitchFamily="2" charset="0"/>
+              </a:rPr>
+              <a:t>f</a:t>
+            </a:r>
+            <a:r>
+              <a:rPr lang="en-US" sz="9600" b="1" dirty="0" baseline="0">
+                <a:latin typeface="Helvetica Neue" panose="02000503000000020004" pitchFamily="2" charset="0"/>
+                <a:ea typeface="Helvetica Neue" panose="02000503000000020004" pitchFamily="2" charset="0"/>
+                <a:cs typeface="Helvetica Neue" panose="02000503000000020004" pitchFamily="2" charset="0"/>
+              </a:rPr>
+              <a:t xml:space="preserve"> a architrino may encounter multiple of their wakes or a continuous stretch of wake?  </a:t>
             </a:r>
             <a:br>
               <a:rPr lang="en-US" sz="9600" b="1" dirty="0">
@@ -948,7 +996,7 @@
     </p:spTree>
     <p:extLst>
       <p:ext uri="{BB962C8B-B14F-4D97-AF65-F5344CB8AC3E}">
-        <p14:creationId xmlns:p14="http://schemas.microsoft.com/office/powerpoint/2010/main" val="3496708072"/>
+        <ns2:creationId val="3496708072"/>
       </p:ext>
     </p:extLst>
   </p:cSld>
@@ -959,7 +1007,7 @@
 </file>
 
 <file path=ppt/notesSlides/notesSlide11.xml><?xml version="1.0" encoding="utf-8"?>
-<p:notes xmlns:a="http://schemas.openxmlformats.org/drawingml/2006/main" xmlns:r="http://schemas.openxmlformats.org/officeDocument/2006/relationships" xmlns:p="http://schemas.openxmlformats.org/presentationml/2006/main">
+<p:notes xmlns:a="http://schemas.openxmlformats.org/drawingml/2006/main" xmlns:ns2="http://schemas.microsoft.com/office/powerpoint/2010/main" xmlns:p="http://schemas.openxmlformats.org/presentationml/2006/main">
   <p:cSld>
     <p:spTree>
       <p:nvGrpSpPr>
@@ -1092,7 +1140,7 @@
     </p:spTree>
     <p:extLst>
       <p:ext uri="{BB962C8B-B14F-4D97-AF65-F5344CB8AC3E}">
-        <p14:creationId xmlns:p14="http://schemas.microsoft.com/office/powerpoint/2010/main" val="2550177487"/>
+        <ns2:creationId val="2550177487"/>
       </p:ext>
     </p:extLst>
   </p:cSld>
@@ -1103,14 +1151,14 @@
 </file>
 
 <file path=ppt/notesSlides/notesSlide12.xml><?xml version="1.0" encoding="utf-8"?>
-<p:notes xmlns:a="http://schemas.openxmlformats.org/drawingml/2006/main" xmlns:r="http://schemas.openxmlformats.org/officeDocument/2006/relationships" xmlns:p="http://schemas.openxmlformats.org/presentationml/2006/main">
+<p:notes xmlns:a="http://schemas.openxmlformats.org/drawingml/2006/main" xmlns:ns2="http://schemas.microsoft.com/office/drawing/2014/main" xmlns:ns3="http://schemas.microsoft.com/office/powerpoint/2010/main" xmlns:p="http://schemas.openxmlformats.org/presentationml/2006/main">
   <p:cSld>
     <p:spTree>
       <p:nvGrpSpPr>
         <p:cNvPr id="1" name="">
           <a:extLst>
             <a:ext uri="{FF2B5EF4-FFF2-40B4-BE49-F238E27FC236}">
-              <a16:creationId xmlns:a16="http://schemas.microsoft.com/office/drawing/2014/main" id="{5ED7CF9D-0276-52CE-9E2D-3C0D97E2BE37}"/>
+              <ns2:creationId id="{5ED7CF9D-0276-52CE-9E2D-3C0D97E2BE37}"/>
             </a:ext>
           </a:extLst>
         </p:cNvPr>
@@ -1130,7 +1178,7 @@
           <p:cNvPr id="2" name="Slide Image Placeholder 1">
             <a:extLst>
               <a:ext uri="{FF2B5EF4-FFF2-40B4-BE49-F238E27FC236}">
-                <a16:creationId xmlns:a16="http://schemas.microsoft.com/office/drawing/2014/main" id="{3C0A8E7F-6A6D-EE24-EAAB-15ABD0132A48}"/>
+                <ns2:creationId id="{3C0A8E7F-6A6D-EE24-EAAB-15ABD0132A48}"/>
               </a:ext>
             </a:extLst>
           </p:cNvPr>
@@ -1148,7 +1196,7 @@
           <p:cNvPr id="3" name="Notes Placeholder 2">
             <a:extLst>
               <a:ext uri="{FF2B5EF4-FFF2-40B4-BE49-F238E27FC236}">
-                <a16:creationId xmlns:a16="http://schemas.microsoft.com/office/drawing/2014/main" id="{AC4CCC5C-360D-F97E-6352-C9212CC36C75}"/>
+                <ns2:creationId id="{AC4CCC5C-360D-F97E-6352-C9212CC36C75}"/>
               </a:ext>
             </a:extLst>
           </p:cNvPr>
@@ -1701,7 +1749,7 @@
           <p:cNvPr id="4" name="Slide Number Placeholder 3">
             <a:extLst>
               <a:ext uri="{FF2B5EF4-FFF2-40B4-BE49-F238E27FC236}">
-                <a16:creationId xmlns:a16="http://schemas.microsoft.com/office/drawing/2014/main" id="{9BE5A30E-C814-C737-0E87-764F58719305}"/>
+                <ns2:creationId id="{9BE5A30E-C814-C737-0E87-764F58719305}"/>
               </a:ext>
             </a:extLst>
           </p:cNvPr>
@@ -1728,7 +1776,7 @@
     </p:spTree>
     <p:extLst>
       <p:ext uri="{BB962C8B-B14F-4D97-AF65-F5344CB8AC3E}">
-        <p14:creationId xmlns:p14="http://schemas.microsoft.com/office/powerpoint/2010/main" val="1879055837"/>
+        <ns3:creationId val="1879055837"/>
       </p:ext>
     </p:extLst>
   </p:cSld>
@@ -1739,14 +1787,14 @@
 </file>
 
 <file path=ppt/notesSlides/notesSlide13.xml><?xml version="1.0" encoding="utf-8"?>
-<p:notes xmlns:a="http://schemas.openxmlformats.org/drawingml/2006/main" xmlns:r="http://schemas.openxmlformats.org/officeDocument/2006/relationships" xmlns:p="http://schemas.openxmlformats.org/presentationml/2006/main">
+<p:notes xmlns:a="http://schemas.openxmlformats.org/drawingml/2006/main" xmlns:ns2="http://schemas.microsoft.com/office/drawing/2014/main" xmlns:ns3="http://schemas.microsoft.com/office/powerpoint/2010/main" xmlns:p="http://schemas.openxmlformats.org/presentationml/2006/main">
   <p:cSld>
     <p:spTree>
       <p:nvGrpSpPr>
         <p:cNvPr id="1" name="">
           <a:extLst>
             <a:ext uri="{FF2B5EF4-FFF2-40B4-BE49-F238E27FC236}">
-              <a16:creationId xmlns:a16="http://schemas.microsoft.com/office/drawing/2014/main" id="{F4B2594E-083A-33B0-1887-4D75961D8DFC}"/>
+              <ns2:creationId id="{F4B2594E-083A-33B0-1887-4D75961D8DFC}"/>
             </a:ext>
           </a:extLst>
         </p:cNvPr>
@@ -1766,7 +1814,7 @@
           <p:cNvPr id="2" name="Slide Image Placeholder 1">
             <a:extLst>
               <a:ext uri="{FF2B5EF4-FFF2-40B4-BE49-F238E27FC236}">
-                <a16:creationId xmlns:a16="http://schemas.microsoft.com/office/drawing/2014/main" id="{649C972F-8115-0086-8D46-F43BA6CB6AFD}"/>
+                <ns2:creationId id="{649C972F-8115-0086-8D46-F43BA6CB6AFD}"/>
               </a:ext>
             </a:extLst>
           </p:cNvPr>
@@ -1784,7 +1832,7 @@
           <p:cNvPr id="3" name="Notes Placeholder 2">
             <a:extLst>
               <a:ext uri="{FF2B5EF4-FFF2-40B4-BE49-F238E27FC236}">
-                <a16:creationId xmlns:a16="http://schemas.microsoft.com/office/drawing/2014/main" id="{7ECA05C0-C97B-9722-138D-940A0126F522}"/>
+                <ns2:creationId id="{7ECA05C0-C97B-9722-138D-940A0126F522}"/>
               </a:ext>
             </a:extLst>
           </p:cNvPr>
@@ -1863,7 +1911,7 @@
           <p:cNvPr id="4" name="Slide Number Placeholder 3">
             <a:extLst>
               <a:ext uri="{FF2B5EF4-FFF2-40B4-BE49-F238E27FC236}">
-                <a16:creationId xmlns:a16="http://schemas.microsoft.com/office/drawing/2014/main" id="{49D93F59-9C10-56A8-29DB-C5BD61D5AF10}"/>
+                <ns2:creationId id="{49D93F59-9C10-56A8-29DB-C5BD61D5AF10}"/>
               </a:ext>
             </a:extLst>
           </p:cNvPr>
@@ -1950,7 +1998,7 @@
     </p:spTree>
     <p:extLst>
       <p:ext uri="{BB962C8B-B14F-4D97-AF65-F5344CB8AC3E}">
-        <p14:creationId xmlns:p14="http://schemas.microsoft.com/office/powerpoint/2010/main" val="1734577285"/>
+        <ns3:creationId val="1734577285"/>
       </p:ext>
     </p:extLst>
   </p:cSld>
@@ -1961,7 +2009,7 @@
 </file>
 
 <file path=ppt/notesSlides/notesSlide2.xml><?xml version="1.0" encoding="utf-8"?>
-<p:notes xmlns:a="http://schemas.openxmlformats.org/drawingml/2006/main" xmlns:r="http://schemas.openxmlformats.org/officeDocument/2006/relationships" xmlns:p="http://schemas.openxmlformats.org/presentationml/2006/main">
+<p:notes xmlns:a="http://schemas.openxmlformats.org/drawingml/2006/main" xmlns:ns2="http://schemas.microsoft.com/office/powerpoint/2010/main" xmlns:p="http://schemas.openxmlformats.org/presentationml/2006/main">
   <p:cSld>
     <p:spTree>
       <p:nvGrpSpPr>
@@ -2122,7 +2170,7 @@
     </p:spTree>
     <p:extLst>
       <p:ext uri="{BB962C8B-B14F-4D97-AF65-F5344CB8AC3E}">
-        <p14:creationId xmlns:p14="http://schemas.microsoft.com/office/powerpoint/2010/main" val="860550296"/>
+        <ns2:creationId val="860550296"/>
       </p:ext>
     </p:extLst>
   </p:cSld>
@@ -2133,14 +2181,14 @@
 </file>
 
 <file path=ppt/notesSlides/notesSlide3.xml><?xml version="1.0" encoding="utf-8"?>
-<p:notes xmlns:a="http://schemas.openxmlformats.org/drawingml/2006/main" xmlns:r="http://schemas.openxmlformats.org/officeDocument/2006/relationships" xmlns:p="http://schemas.openxmlformats.org/presentationml/2006/main">
+<p:notes xmlns:a="http://schemas.openxmlformats.org/drawingml/2006/main" xmlns:ns2="http://schemas.microsoft.com/office/drawing/2014/main" xmlns:ns3="http://schemas.microsoft.com/office/powerpoint/2010/main" xmlns:p="http://schemas.openxmlformats.org/presentationml/2006/main">
   <p:cSld>
     <p:spTree>
       <p:nvGrpSpPr>
         <p:cNvPr id="1" name="">
           <a:extLst>
             <a:ext uri="{FF2B5EF4-FFF2-40B4-BE49-F238E27FC236}">
-              <a16:creationId xmlns:a16="http://schemas.microsoft.com/office/drawing/2014/main" id="{93C7B214-35E5-40E6-ED8E-2D7C6DAB00FD}"/>
+              <ns2:creationId id="{93C7B214-35E5-40E6-ED8E-2D7C6DAB00FD}"/>
             </a:ext>
           </a:extLst>
         </p:cNvPr>
@@ -2160,7 +2208,7 @@
           <p:cNvPr id="2" name="Slide Image Placeholder 1">
             <a:extLst>
               <a:ext uri="{FF2B5EF4-FFF2-40B4-BE49-F238E27FC236}">
-                <a16:creationId xmlns:a16="http://schemas.microsoft.com/office/drawing/2014/main" id="{B69B170F-C727-57B1-1343-0F8509F3ABE8}"/>
+                <ns2:creationId id="{B69B170F-C727-57B1-1343-0F8509F3ABE8}"/>
               </a:ext>
             </a:extLst>
           </p:cNvPr>
@@ -2178,7 +2226,7 @@
           <p:cNvPr id="3" name="Notes Placeholder 2">
             <a:extLst>
               <a:ext uri="{FF2B5EF4-FFF2-40B4-BE49-F238E27FC236}">
-                <a16:creationId xmlns:a16="http://schemas.microsoft.com/office/drawing/2014/main" id="{7981E51D-982C-C58E-5C9D-E60D1957190A}"/>
+                <ns2:creationId id="{7981E51D-982C-C58E-5C9D-E60D1957190A}"/>
               </a:ext>
             </a:extLst>
           </p:cNvPr>
@@ -2231,7 +2279,7 @@
           <p:cNvPr id="4" name="Slide Number Placeholder 3">
             <a:extLst>
               <a:ext uri="{FF2B5EF4-FFF2-40B4-BE49-F238E27FC236}">
-                <a16:creationId xmlns:a16="http://schemas.microsoft.com/office/drawing/2014/main" id="{3694923C-44A0-8AF2-498D-3125889DDCB4}"/>
+                <ns2:creationId id="{3694923C-44A0-8AF2-498D-3125889DDCB4}"/>
               </a:ext>
             </a:extLst>
           </p:cNvPr>
@@ -2318,7 +2366,7 @@
     </p:spTree>
     <p:extLst>
       <p:ext uri="{BB962C8B-B14F-4D97-AF65-F5344CB8AC3E}">
-        <p14:creationId xmlns:p14="http://schemas.microsoft.com/office/powerpoint/2010/main" val="131822489"/>
+        <ns3:creationId val="131822489"/>
       </p:ext>
     </p:extLst>
   </p:cSld>
@@ -2329,14 +2377,14 @@
 </file>
 
 <file path=ppt/notesSlides/notesSlide4.xml><?xml version="1.0" encoding="utf-8"?>
-<p:notes xmlns:a="http://schemas.openxmlformats.org/drawingml/2006/main" xmlns:r="http://schemas.openxmlformats.org/officeDocument/2006/relationships" xmlns:p="http://schemas.openxmlformats.org/presentationml/2006/main">
+<p:notes xmlns:a="http://schemas.openxmlformats.org/drawingml/2006/main" xmlns:ns2="http://schemas.microsoft.com/office/drawing/2014/main" xmlns:ns3="http://schemas.microsoft.com/office/powerpoint/2010/main" xmlns:p="http://schemas.openxmlformats.org/presentationml/2006/main">
   <p:cSld>
     <p:spTree>
       <p:nvGrpSpPr>
         <p:cNvPr id="1" name="">
           <a:extLst>
             <a:ext uri="{FF2B5EF4-FFF2-40B4-BE49-F238E27FC236}">
-              <a16:creationId xmlns:a16="http://schemas.microsoft.com/office/drawing/2014/main" id="{95E231E5-42FD-4E85-EE2F-519914DCAD49}"/>
+              <ns2:creationId id="{95E231E5-42FD-4E85-EE2F-519914DCAD49}"/>
             </a:ext>
           </a:extLst>
         </p:cNvPr>
@@ -2356,7 +2404,7 @@
           <p:cNvPr id="2" name="Slide Image Placeholder 1">
             <a:extLst>
               <a:ext uri="{FF2B5EF4-FFF2-40B4-BE49-F238E27FC236}">
-                <a16:creationId xmlns:a16="http://schemas.microsoft.com/office/drawing/2014/main" id="{C4F49BD2-3448-0850-3F07-5ABBD141E54F}"/>
+                <ns2:creationId id="{C4F49BD2-3448-0850-3F07-5ABBD141E54F}"/>
               </a:ext>
             </a:extLst>
           </p:cNvPr>
@@ -2374,7 +2422,7 @@
           <p:cNvPr id="3" name="Notes Placeholder 2">
             <a:extLst>
               <a:ext uri="{FF2B5EF4-FFF2-40B4-BE49-F238E27FC236}">
-                <a16:creationId xmlns:a16="http://schemas.microsoft.com/office/drawing/2014/main" id="{4164BDE8-5673-C9F6-F2F2-B5547A5D45FE}"/>
+                <ns2:creationId id="{4164BDE8-5673-C9F6-F2F2-B5547A5D45FE}"/>
               </a:ext>
             </a:extLst>
           </p:cNvPr>
@@ -2427,7 +2475,7 @@
           <p:cNvPr id="4" name="Slide Number Placeholder 3">
             <a:extLst>
               <a:ext uri="{FF2B5EF4-FFF2-40B4-BE49-F238E27FC236}">
-                <a16:creationId xmlns:a16="http://schemas.microsoft.com/office/drawing/2014/main" id="{C189F22E-58E9-2143-1D57-A988438B2164}"/>
+                <ns2:creationId id="{C189F22E-58E9-2143-1D57-A988438B2164}"/>
               </a:ext>
             </a:extLst>
           </p:cNvPr>
@@ -2514,7 +2562,7 @@
     </p:spTree>
     <p:extLst>
       <p:ext uri="{BB962C8B-B14F-4D97-AF65-F5344CB8AC3E}">
-        <p14:creationId xmlns:p14="http://schemas.microsoft.com/office/powerpoint/2010/main" val="185871443"/>
+        <ns3:creationId val="185871443"/>
       </p:ext>
     </p:extLst>
   </p:cSld>
@@ -2525,7 +2573,7 @@
 </file>
 
 <file path=ppt/notesSlides/notesSlide5.xml><?xml version="1.0" encoding="utf-8"?>
-<p:notes xmlns:a="http://schemas.openxmlformats.org/drawingml/2006/main" xmlns:r="http://schemas.openxmlformats.org/officeDocument/2006/relationships" xmlns:p="http://schemas.openxmlformats.org/presentationml/2006/main">
+<p:notes xmlns:a="http://schemas.openxmlformats.org/drawingml/2006/main" xmlns:ns2="http://schemas.microsoft.com/office/powerpoint/2010/main" xmlns:p="http://schemas.openxmlformats.org/presentationml/2006/main">
   <p:cSld>
     <p:spTree>
       <p:nvGrpSpPr>
@@ -2686,7 +2734,7 @@
     </p:spTree>
     <p:extLst>
       <p:ext uri="{BB962C8B-B14F-4D97-AF65-F5344CB8AC3E}">
-        <p14:creationId xmlns:p14="http://schemas.microsoft.com/office/powerpoint/2010/main" val="3756986641"/>
+        <ns2:creationId val="3756986641"/>
       </p:ext>
     </p:extLst>
   </p:cSld>
@@ -2697,7 +2745,7 @@
 </file>
 
 <file path=ppt/notesSlides/notesSlide6.xml><?xml version="1.0" encoding="utf-8"?>
-<p:notes xmlns:a="http://schemas.openxmlformats.org/drawingml/2006/main" xmlns:r="http://schemas.openxmlformats.org/officeDocument/2006/relationships" xmlns:p="http://schemas.openxmlformats.org/presentationml/2006/main">
+<p:notes xmlns:a="http://schemas.openxmlformats.org/drawingml/2006/main" xmlns:ns2="http://schemas.microsoft.com/office/powerpoint/2010/main" xmlns:p="http://schemas.openxmlformats.org/presentationml/2006/main">
   <p:cSld>
     <p:spTree>
       <p:nvGrpSpPr>
@@ -2858,7 +2906,7 @@
     </p:spTree>
     <p:extLst>
       <p:ext uri="{BB962C8B-B14F-4D97-AF65-F5344CB8AC3E}">
-        <p14:creationId xmlns:p14="http://schemas.microsoft.com/office/powerpoint/2010/main" val="4143754227"/>
+        <ns2:creationId val="4143754227"/>
       </p:ext>
     </p:extLst>
   </p:cSld>
@@ -2869,7 +2917,7 @@
 </file>
 
 <file path=ppt/notesSlides/notesSlide7.xml><?xml version="1.0" encoding="utf-8"?>
-<p:notes xmlns:a="http://schemas.openxmlformats.org/drawingml/2006/main" xmlns:r="http://schemas.openxmlformats.org/officeDocument/2006/relationships" xmlns:p="http://schemas.openxmlformats.org/presentationml/2006/main">
+<p:notes xmlns:a="http://schemas.openxmlformats.org/drawingml/2006/main" xmlns:ns2="http://schemas.microsoft.com/office/powerpoint/2010/main" xmlns:p="http://schemas.openxmlformats.org/presentationml/2006/main">
   <p:cSld>
     <p:spTree>
       <p:nvGrpSpPr>
@@ -3030,7 +3078,7 @@
     </p:spTree>
     <p:extLst>
       <p:ext uri="{BB962C8B-B14F-4D97-AF65-F5344CB8AC3E}">
-        <p14:creationId xmlns:p14="http://schemas.microsoft.com/office/powerpoint/2010/main" val="1972911739"/>
+        <ns2:creationId val="1972911739"/>
       </p:ext>
     </p:extLst>
   </p:cSld>
@@ -3041,7 +3089,7 @@
 </file>
 
 <file path=ppt/notesSlides/notesSlide8.xml><?xml version="1.0" encoding="utf-8"?>
-<p:notes xmlns:a="http://schemas.openxmlformats.org/drawingml/2006/main" xmlns:r="http://schemas.openxmlformats.org/officeDocument/2006/relationships" xmlns:p="http://schemas.openxmlformats.org/presentationml/2006/main">
+<p:notes xmlns:a="http://schemas.openxmlformats.org/drawingml/2006/main" xmlns:ns2="http://schemas.microsoft.com/office/powerpoint/2010/main" xmlns:p="http://schemas.openxmlformats.org/presentationml/2006/main">
   <p:cSld>
     <p:spTree>
       <p:nvGrpSpPr>
@@ -3642,7 +3690,7 @@
     </p:spTree>
     <p:extLst>
       <p:ext uri="{BB962C8B-B14F-4D97-AF65-F5344CB8AC3E}">
-        <p14:creationId xmlns:p14="http://schemas.microsoft.com/office/powerpoint/2010/main" val="1191104622"/>
+        <ns2:creationId val="1191104622"/>
       </p:ext>
     </p:extLst>
   </p:cSld>
@@ -3653,7 +3701,7 @@
 </file>
 
 <file path=ppt/notesSlides/notesSlide9.xml><?xml version="1.0" encoding="utf-8"?>
-<p:notes xmlns:a="http://schemas.openxmlformats.org/drawingml/2006/main" xmlns:r="http://schemas.openxmlformats.org/officeDocument/2006/relationships" xmlns:p="http://schemas.openxmlformats.org/presentationml/2006/main">
+<p:notes xmlns:a="http://schemas.openxmlformats.org/drawingml/2006/main" xmlns:ns2="http://schemas.microsoft.com/office/powerpoint/2010/main" xmlns:p="http://schemas.openxmlformats.org/presentationml/2006/main">
   <p:cSld>
     <p:spTree>
       <p:nvGrpSpPr>
@@ -3759,12 +3807,36 @@
               </a:rPr>
             </a:br>
             <a:r>
-              <a:rPr lang="en-US" sz="9600" b="1" dirty="0">
+              <a:rPr lang="en-US" sz="9600" b="1" dirty="0" baseline="0">
                 <a:latin typeface="Helvetica Neue" panose="02000503000000020004" pitchFamily="2" charset="0"/>
                 <a:ea typeface="Helvetica Neue" panose="02000503000000020004" pitchFamily="2" charset="0"/>
                 <a:cs typeface="Helvetica Neue" panose="02000503000000020004" pitchFamily="2" charset="0"/>
               </a:rPr>
-              <a:t>They may also be riding on their own wake if v &gt; c_f. </a:t>
+              <a:t xml:space="preserve">They may also be riding on their own wake if v &gt; </a:t>
+            </a:r>
+            <a:r>
+              <a:rPr lang="en-US" sz="9600" b="1" dirty="0" baseline="0">
+                <a:latin typeface="Helvetica Neue" panose="02000503000000020004" pitchFamily="2" charset="0"/>
+                <a:ea typeface="Helvetica Neue" panose="02000503000000020004" pitchFamily="2" charset="0"/>
+                <a:cs typeface="Helvetica Neue" panose="02000503000000020004" pitchFamily="2" charset="0"/>
+              </a:rPr>
+              <a:t>c</a:t>
+            </a:r>
+            <a:r>
+              <a:rPr lang="en-US" sz="6720" b="1" dirty="0" baseline="-25000">
+                <a:latin typeface="Helvetica Neue" panose="02000503000000020004" pitchFamily="2" charset="0"/>
+                <a:ea typeface="Helvetica Neue" panose="02000503000000020004" pitchFamily="2" charset="0"/>
+                <a:cs typeface="Helvetica Neue" panose="02000503000000020004" pitchFamily="2" charset="0"/>
+              </a:rPr>
+              <a:t>f</a:t>
+            </a:r>
+            <a:r>
+              <a:rPr lang="en-US" sz="9600" b="1" dirty="0" baseline="0">
+                <a:latin typeface="Helvetica Neue" panose="02000503000000020004" pitchFamily="2" charset="0"/>
+                <a:ea typeface="Helvetica Neue" panose="02000503000000020004" pitchFamily="2" charset="0"/>
+                <a:cs typeface="Helvetica Neue" panose="02000503000000020004" pitchFamily="2" charset="0"/>
+              </a:rPr>
+              <a:t xml:space="preserve">. </a:t>
             </a:r>
             <a:br>
               <a:rPr lang="en-US" sz="9600" b="1" dirty="0">
@@ -3774,12 +3846,36 @@
               </a:rPr>
             </a:br>
             <a:r>
-              <a:rPr lang="en-US" sz="9600" b="1" dirty="0">
+              <a:rPr lang="en-US" sz="9600" b="1" dirty="0" baseline="0">
                 <a:latin typeface="Helvetica Neue" panose="02000503000000020004" pitchFamily="2" charset="0"/>
                 <a:ea typeface="Helvetica Neue" panose="02000503000000020004" pitchFamily="2" charset="0"/>
                 <a:cs typeface="Helvetica Neue" panose="02000503000000020004" pitchFamily="2" charset="0"/>
               </a:rPr>
-              <a:t>For each partner that has operated at v&gt;c_f a architrino may encounter multiple of their wakes or a continuous stretch of wake?  </a:t>
+              <a:t>For each partner that has operated at v&gt;</a:t>
+            </a:r>
+            <a:r>
+              <a:rPr lang="en-US" sz="9600" b="1" dirty="0" baseline="0">
+                <a:latin typeface="Helvetica Neue" panose="02000503000000020004" pitchFamily="2" charset="0"/>
+                <a:ea typeface="Helvetica Neue" panose="02000503000000020004" pitchFamily="2" charset="0"/>
+                <a:cs typeface="Helvetica Neue" panose="02000503000000020004" pitchFamily="2" charset="0"/>
+              </a:rPr>
+              <a:t>c</a:t>
+            </a:r>
+            <a:r>
+              <a:rPr lang="en-US" sz="6720" b="1" dirty="0" baseline="-25000">
+                <a:latin typeface="Helvetica Neue" panose="02000503000000020004" pitchFamily="2" charset="0"/>
+                <a:ea typeface="Helvetica Neue" panose="02000503000000020004" pitchFamily="2" charset="0"/>
+                <a:cs typeface="Helvetica Neue" panose="02000503000000020004" pitchFamily="2" charset="0"/>
+              </a:rPr>
+              <a:t>f</a:t>
+            </a:r>
+            <a:r>
+              <a:rPr lang="en-US" sz="9600" b="1" dirty="0" baseline="0">
+                <a:latin typeface="Helvetica Neue" panose="02000503000000020004" pitchFamily="2" charset="0"/>
+                <a:ea typeface="Helvetica Neue" panose="02000503000000020004" pitchFamily="2" charset="0"/>
+                <a:cs typeface="Helvetica Neue" panose="02000503000000020004" pitchFamily="2" charset="0"/>
+              </a:rPr>
+              <a:t xml:space="preserve"> a architrino may encounter multiple of their wakes or a continuous stretch of wake?  </a:t>
             </a:r>
             <a:br>
               <a:rPr lang="en-US" sz="9600" b="1" dirty="0">
@@ -3936,7 +4032,7 @@
     </p:spTree>
     <p:extLst>
       <p:ext uri="{BB962C8B-B14F-4D97-AF65-F5344CB8AC3E}">
-        <p14:creationId xmlns:p14="http://schemas.microsoft.com/office/powerpoint/2010/main" val="596825902"/>
+        <ns2:creationId val="596825902"/>
       </p:ext>
     </p:extLst>
   </p:cSld>
@@ -8309,7 +8405,7 @@
 </file>
 
 <file path=ppt/slides/slide1.xml><?xml version="1.0" encoding="utf-8"?>
-<p:sld xmlns:a="http://schemas.openxmlformats.org/drawingml/2006/main" xmlns:r="http://schemas.openxmlformats.org/officeDocument/2006/relationships" xmlns:p="http://schemas.openxmlformats.org/presentationml/2006/main">
+<p:sld xmlns:a="http://schemas.openxmlformats.org/drawingml/2006/main" xmlns:ns2="http://schemas.microsoft.com/office/drawing/2014/main" xmlns:ns3="http://schemas.microsoft.com/office/powerpoint/2010/main" xmlns:p="http://schemas.openxmlformats.org/presentationml/2006/main">
   <p:cSld>
     <p:bg>
       <p:bgPr>
@@ -8324,7 +8420,7 @@
         <p:cNvPr id="1" name="">
           <a:extLst>
             <a:ext uri="{FF2B5EF4-FFF2-40B4-BE49-F238E27FC236}">
-              <a16:creationId xmlns:a16="http://schemas.microsoft.com/office/drawing/2014/main" id="{F12CB3D1-0CE0-632F-6109-64380C884133}"/>
+              <ns2:creationId id="{F12CB3D1-0CE0-632F-6109-64380C884133}"/>
             </a:ext>
           </a:extLst>
         </p:cNvPr>
@@ -8344,7 +8440,7 @@
           <p:cNvPr id="2" name="TextBox 1">
             <a:extLst>
               <a:ext uri="{FF2B5EF4-FFF2-40B4-BE49-F238E27FC236}">
-                <a16:creationId xmlns:a16="http://schemas.microsoft.com/office/drawing/2014/main" id="{4BD4ABB3-A2D3-D440-CAE2-3FE090A98AD7}"/>
+                <ns2:creationId id="{4BD4ABB3-A2D3-D440-CAE2-3FE090A98AD7}"/>
               </a:ext>
             </a:extLst>
           </p:cNvPr>
@@ -8493,7 +8589,7 @@
     </p:spTree>
     <p:extLst>
       <p:ext uri="{BB962C8B-B14F-4D97-AF65-F5344CB8AC3E}">
-        <p14:creationId xmlns:p14="http://schemas.microsoft.com/office/powerpoint/2010/main" val="3704261708"/>
+        <ns3:creationId val="3704261708"/>
       </p:ext>
     </p:extLst>
   </p:cSld>
@@ -8504,7 +8600,7 @@
 </file>
 
 <file path=ppt/slides/slide10.xml><?xml version="1.0" encoding="utf-8"?>
-<p:sld xmlns:a="http://schemas.openxmlformats.org/drawingml/2006/main" xmlns:r="http://schemas.openxmlformats.org/officeDocument/2006/relationships" xmlns:p="http://schemas.openxmlformats.org/presentationml/2006/main">
+<p:sld xmlns:a="http://schemas.openxmlformats.org/drawingml/2006/main" xmlns:ns2="http://schemas.microsoft.com/office/drawing/2014/main" xmlns:ns3="http://schemas.microsoft.com/office/powerpoint/2010/main" xmlns:p="http://schemas.openxmlformats.org/presentationml/2006/main">
   <p:cSld>
     <p:bg>
       <p:bgPr>
@@ -8533,7 +8629,7 @@
           <p:cNvPr id="4" name="Freeform 3">
             <a:extLst>
               <a:ext uri="{FF2B5EF4-FFF2-40B4-BE49-F238E27FC236}">
-                <a16:creationId xmlns:a16="http://schemas.microsoft.com/office/drawing/2014/main" id="{557E8D0E-7530-B118-1DC6-82906B4F6D15}"/>
+                <ns2:creationId id="{557E8D0E-7530-B118-1DC6-82906B4F6D15}"/>
               </a:ext>
             </a:extLst>
           </p:cNvPr>
@@ -9497,7 +9593,7 @@
           <p:cNvPr id="5" name="Footer Placeholder 3">
             <a:extLst>
               <a:ext uri="{FF2B5EF4-FFF2-40B4-BE49-F238E27FC236}">
-                <a16:creationId xmlns:a16="http://schemas.microsoft.com/office/drawing/2014/main" id="{668F77D6-DFDA-5A46-8DF1-47F6A167C2B1}"/>
+                <ns2:creationId id="{668F77D6-DFDA-5A46-8DF1-47F6A167C2B1}"/>
               </a:ext>
             </a:extLst>
           </p:cNvPr>
@@ -9659,7 +9755,7 @@
           <p:cNvPr id="16" name="Freeform 15">
             <a:extLst>
               <a:ext uri="{FF2B5EF4-FFF2-40B4-BE49-F238E27FC236}">
-                <a16:creationId xmlns:a16="http://schemas.microsoft.com/office/drawing/2014/main" id="{226B2D26-F692-894E-9B09-F57FBB5CB2A3}"/>
+                <ns2:creationId id="{226B2D26-F692-894E-9B09-F57FBB5CB2A3}"/>
               </a:ext>
             </a:extLst>
           </p:cNvPr>
@@ -10542,7 +10638,7 @@
           <p:cNvPr id="19" name="Oval 18">
             <a:extLst>
               <a:ext uri="{FF2B5EF4-FFF2-40B4-BE49-F238E27FC236}">
-                <a16:creationId xmlns:a16="http://schemas.microsoft.com/office/drawing/2014/main" id="{0592434B-85D0-0A41-95DD-A29D1D3E92A7}"/>
+                <ns2:creationId id="{0592434B-85D0-0A41-95DD-A29D1D3E92A7}"/>
               </a:ext>
             </a:extLst>
           </p:cNvPr>
@@ -10623,7 +10719,7 @@
           <p:cNvPr id="22" name="TextBox 21">
             <a:extLst>
               <a:ext uri="{FF2B5EF4-FFF2-40B4-BE49-F238E27FC236}">
-                <a16:creationId xmlns:a16="http://schemas.microsoft.com/office/drawing/2014/main" id="{32F7BF73-EB2C-9D42-97FB-D39FDCC924EB}"/>
+                <ns2:creationId id="{32F7BF73-EB2C-9D42-97FB-D39FDCC924EB}"/>
               </a:ext>
             </a:extLst>
           </p:cNvPr>
@@ -10702,7 +10798,7 @@
           <p:cNvPr id="32" name="Group 31">
             <a:extLst>
               <a:ext uri="{FF2B5EF4-FFF2-40B4-BE49-F238E27FC236}">
-                <a16:creationId xmlns:a16="http://schemas.microsoft.com/office/drawing/2014/main" id="{A120AE69-6043-195E-40C7-43C019B9D3A9}"/>
+                <ns2:creationId id="{A120AE69-6043-195E-40C7-43C019B9D3A9}"/>
               </a:ext>
             </a:extLst>
           </p:cNvPr>
@@ -10722,7 +10818,7 @@
             <p:cNvPr id="24" name="Straight Connector 23">
               <a:extLst>
                 <a:ext uri="{FF2B5EF4-FFF2-40B4-BE49-F238E27FC236}">
-                  <a16:creationId xmlns:a16="http://schemas.microsoft.com/office/drawing/2014/main" id="{3A19E039-1667-254C-809A-972BBA46D65C}"/>
+                  <ns2:creationId id="{3A19E039-1667-254C-809A-972BBA46D65C}"/>
                 </a:ext>
               </a:extLst>
             </p:cNvPr>
@@ -10768,7 +10864,7 @@
             <p:cNvPr id="2" name="Oval 1">
               <a:extLst>
                 <a:ext uri="{FF2B5EF4-FFF2-40B4-BE49-F238E27FC236}">
-                  <a16:creationId xmlns:a16="http://schemas.microsoft.com/office/drawing/2014/main" id="{38418338-F1E6-81D9-6A8C-D7EB7AA9DDA2}"/>
+                  <ns2:creationId id="{38418338-F1E6-81D9-6A8C-D7EB7AA9DDA2}"/>
                 </a:ext>
               </a:extLst>
             </p:cNvPr>
@@ -10853,7 +10949,7 @@
           <p:cNvPr id="29" name="TextBox 28">
             <a:extLst>
               <a:ext uri="{FF2B5EF4-FFF2-40B4-BE49-F238E27FC236}">
-                <a16:creationId xmlns:a16="http://schemas.microsoft.com/office/drawing/2014/main" id="{2C329E1C-5E54-9E3C-A6FA-AE50E16EEB85}"/>
+                <ns2:creationId id="{2C329E1C-5E54-9E3C-A6FA-AE50E16EEB85}"/>
               </a:ext>
             </a:extLst>
           </p:cNvPr>
@@ -10932,7 +11028,7 @@
           <p:cNvPr id="40" name="Group 39">
             <a:extLst>
               <a:ext uri="{FF2B5EF4-FFF2-40B4-BE49-F238E27FC236}">
-                <a16:creationId xmlns:a16="http://schemas.microsoft.com/office/drawing/2014/main" id="{C105AAA1-FA00-79D8-70E9-DB832351B5E2}"/>
+                <ns2:creationId id="{C105AAA1-FA00-79D8-70E9-DB832351B5E2}"/>
               </a:ext>
             </a:extLst>
           </p:cNvPr>
@@ -10952,7 +11048,7 @@
             <p:cNvPr id="41" name="Straight Connector 40">
               <a:extLst>
                 <a:ext uri="{FF2B5EF4-FFF2-40B4-BE49-F238E27FC236}">
-                  <a16:creationId xmlns:a16="http://schemas.microsoft.com/office/drawing/2014/main" id="{48D05E5C-4059-6EC7-1299-E52A65F46E3D}"/>
+                  <ns2:creationId id="{48D05E5C-4059-6EC7-1299-E52A65F46E3D}"/>
                 </a:ext>
               </a:extLst>
             </p:cNvPr>
@@ -10998,7 +11094,7 @@
             <p:cNvPr id="42" name="Oval 41">
               <a:extLst>
                 <a:ext uri="{FF2B5EF4-FFF2-40B4-BE49-F238E27FC236}">
-                  <a16:creationId xmlns:a16="http://schemas.microsoft.com/office/drawing/2014/main" id="{8174E055-9EC2-40B6-B317-43A23011EC49}"/>
+                  <ns2:creationId id="{8174E055-9EC2-40B6-B317-43A23011EC49}"/>
                 </a:ext>
               </a:extLst>
             </p:cNvPr>
@@ -11083,7 +11179,7 @@
           <p:cNvPr id="28" name="TextBox 27">
             <a:extLst>
               <a:ext uri="{FF2B5EF4-FFF2-40B4-BE49-F238E27FC236}">
-                <a16:creationId xmlns:a16="http://schemas.microsoft.com/office/drawing/2014/main" id="{B86BBAD0-86F6-0D58-180C-6EA1BDCC33FE}"/>
+                <ns2:creationId id="{B86BBAD0-86F6-0D58-180C-6EA1BDCC33FE}"/>
               </a:ext>
             </a:extLst>
           </p:cNvPr>
@@ -11212,7 +11308,7 @@
           <p:cNvPr id="6" name="Oval 5">
             <a:extLst>
               <a:ext uri="{FF2B5EF4-FFF2-40B4-BE49-F238E27FC236}">
-                <a16:creationId xmlns:a16="http://schemas.microsoft.com/office/drawing/2014/main" id="{AC0CFD16-199C-C379-61A7-C2D95EDE2034}"/>
+                <ns2:creationId id="{AC0CFD16-199C-C379-61A7-C2D95EDE2034}"/>
               </a:ext>
             </a:extLst>
           </p:cNvPr>
@@ -11264,7 +11360,7 @@
           <p:cNvPr id="7" name="TextBox 6">
             <a:extLst>
               <a:ext uri="{FF2B5EF4-FFF2-40B4-BE49-F238E27FC236}">
-                <a16:creationId xmlns:a16="http://schemas.microsoft.com/office/drawing/2014/main" id="{74832E6C-887E-D39B-AAC8-6B87F8F0377B}"/>
+                <ns2:creationId id="{74832E6C-887E-D39B-AAC8-6B87F8F0377B}"/>
               </a:ext>
             </a:extLst>
           </p:cNvPr>
@@ -11311,7 +11407,7 @@
           <p:cNvPr id="9" name="TextBox 8">
             <a:extLst>
               <a:ext uri="{FF2B5EF4-FFF2-40B4-BE49-F238E27FC236}">
-                <a16:creationId xmlns:a16="http://schemas.microsoft.com/office/drawing/2014/main" id="{3FBBB3C0-9EF9-2269-F804-566738A12135}"/>
+                <ns2:creationId id="{3FBBB3C0-9EF9-2269-F804-566738A12135}"/>
               </a:ext>
             </a:extLst>
           </p:cNvPr>
@@ -11358,7 +11454,7 @@
           <p:cNvPr id="10" name="TextBox 9">
             <a:extLst>
               <a:ext uri="{FF2B5EF4-FFF2-40B4-BE49-F238E27FC236}">
-                <a16:creationId xmlns:a16="http://schemas.microsoft.com/office/drawing/2014/main" id="{5AD88C91-2B9D-6C66-4521-C91A0EBE16F1}"/>
+                <ns2:creationId id="{5AD88C91-2B9D-6C66-4521-C91A0EBE16F1}"/>
               </a:ext>
             </a:extLst>
           </p:cNvPr>
@@ -11405,7 +11501,7 @@
           <p:cNvPr id="11" name="Rectangle 10">
             <a:extLst>
               <a:ext uri="{FF2B5EF4-FFF2-40B4-BE49-F238E27FC236}">
-                <a16:creationId xmlns:a16="http://schemas.microsoft.com/office/drawing/2014/main" id="{408E88E8-1AC1-3859-ED6E-998C354C18AF}"/>
+                <ns2:creationId id="{408E88E8-1AC1-3859-ED6E-998C354C18AF}"/>
               </a:ext>
             </a:extLst>
           </p:cNvPr>
@@ -11458,7 +11554,7 @@
           <p:cNvPr id="14" name="Group 13">
             <a:extLst>
               <a:ext uri="{FF2B5EF4-FFF2-40B4-BE49-F238E27FC236}">
-                <a16:creationId xmlns:a16="http://schemas.microsoft.com/office/drawing/2014/main" id="{7A05C4D2-699B-5F84-92AE-09238BDBF4E8}"/>
+                <ns2:creationId id="{7A05C4D2-699B-5F84-92AE-09238BDBF4E8}"/>
               </a:ext>
             </a:extLst>
           </p:cNvPr>
@@ -11478,7 +11574,7 @@
             <p:cNvPr id="15" name="Straight Arrow Connector 14">
               <a:extLst>
                 <a:ext uri="{FF2B5EF4-FFF2-40B4-BE49-F238E27FC236}">
-                  <a16:creationId xmlns:a16="http://schemas.microsoft.com/office/drawing/2014/main" id="{6F7FA685-0220-0300-5C81-7977AB43778D}"/>
+                  <ns2:creationId id="{6F7FA685-0220-0300-5C81-7977AB43778D}"/>
                 </a:ext>
               </a:extLst>
             </p:cNvPr>
@@ -11522,7 +11618,7 @@
             <p:cNvPr id="17" name="Straight Arrow Connector 16">
               <a:extLst>
                 <a:ext uri="{FF2B5EF4-FFF2-40B4-BE49-F238E27FC236}">
-                  <a16:creationId xmlns:a16="http://schemas.microsoft.com/office/drawing/2014/main" id="{8DAAADDE-3685-65B3-881A-0143943C0267}"/>
+                  <ns2:creationId id="{8DAAADDE-3685-65B3-881A-0143943C0267}"/>
                 </a:ext>
               </a:extLst>
             </p:cNvPr>
@@ -11566,7 +11662,7 @@
             <p:cNvPr id="18" name="TextBox 17">
               <a:extLst>
                 <a:ext uri="{FF2B5EF4-FFF2-40B4-BE49-F238E27FC236}">
-                  <a16:creationId xmlns:a16="http://schemas.microsoft.com/office/drawing/2014/main" id="{BAA0C0F5-147D-A6B2-DBB6-6DCB0FFF6BAE}"/>
+                  <ns2:creationId id="{BAA0C0F5-147D-A6B2-DBB6-6DCB0FFF6BAE}"/>
                 </a:ext>
               </a:extLst>
             </p:cNvPr>
@@ -11631,7 +11727,7 @@
             <p:cNvPr id="20" name="TextBox 19">
               <a:extLst>
                 <a:ext uri="{FF2B5EF4-FFF2-40B4-BE49-F238E27FC236}">
-                  <a16:creationId xmlns:a16="http://schemas.microsoft.com/office/drawing/2014/main" id="{84C36D57-9425-3680-6F8D-295F2518BF54}"/>
+                  <ns2:creationId id="{84C36D57-9425-3680-6F8D-295F2518BF54}"/>
                 </a:ext>
               </a:extLst>
             </p:cNvPr>
@@ -11731,7 +11827,7 @@
     </p:spTree>
     <p:extLst>
       <p:ext uri="{BB962C8B-B14F-4D97-AF65-F5344CB8AC3E}">
-        <p14:creationId xmlns:p14="http://schemas.microsoft.com/office/powerpoint/2010/main" val="1541260098"/>
+        <ns3:creationId val="1541260098"/>
       </p:ext>
     </p:extLst>
   </p:cSld>
@@ -11742,7 +11838,7 @@
 </file>
 
 <file path=ppt/slides/slide11.xml><?xml version="1.0" encoding="utf-8"?>
-<p:sld xmlns:a="http://schemas.openxmlformats.org/drawingml/2006/main" xmlns:r="http://schemas.openxmlformats.org/officeDocument/2006/relationships" xmlns:p="http://schemas.openxmlformats.org/presentationml/2006/main">
+<p:sld xmlns:a="http://schemas.openxmlformats.org/drawingml/2006/main" xmlns:ns2="http://schemas.microsoft.com/office/drawing/2014/main" xmlns:ns3="http://schemas.microsoft.com/office/powerpoint/2010/main" xmlns:p="http://schemas.openxmlformats.org/presentationml/2006/main">
   <p:cSld>
     <p:bg>
       <p:bgPr>
@@ -11771,7 +11867,7 @@
           <p:cNvPr id="5" name="Footer Placeholder 3">
             <a:extLst>
               <a:ext uri="{FF2B5EF4-FFF2-40B4-BE49-F238E27FC236}">
-                <a16:creationId xmlns:a16="http://schemas.microsoft.com/office/drawing/2014/main" id="{668F77D6-DFDA-5A46-8DF1-47F6A167C2B1}"/>
+                <ns2:creationId id="{668F77D6-DFDA-5A46-8DF1-47F6A167C2B1}"/>
               </a:ext>
             </a:extLst>
           </p:cNvPr>
@@ -11933,7 +12029,7 @@
           <p:cNvPr id="13" name="TextBox 12">
             <a:extLst>
               <a:ext uri="{FF2B5EF4-FFF2-40B4-BE49-F238E27FC236}">
-                <a16:creationId xmlns:a16="http://schemas.microsoft.com/office/drawing/2014/main" id="{2C3F4604-6C2F-0E4E-9DD3-4F5C89FF51AB}"/>
+                <ns2:creationId id="{2C3F4604-6C2F-0E4E-9DD3-4F5C89FF51AB}"/>
               </a:ext>
             </a:extLst>
           </p:cNvPr>
@@ -12034,7 +12130,7 @@
           <p:cNvPr id="14" name="Freeform 13">
             <a:extLst>
               <a:ext uri="{FF2B5EF4-FFF2-40B4-BE49-F238E27FC236}">
-                <a16:creationId xmlns:a16="http://schemas.microsoft.com/office/drawing/2014/main" id="{6D478F86-6608-8240-A60F-2B5B4B14CE42}"/>
+                <ns2:creationId id="{6D478F86-6608-8240-A60F-2B5B4B14CE42}"/>
               </a:ext>
             </a:extLst>
           </p:cNvPr>
@@ -12575,7 +12671,7 @@
           <p:cNvPr id="16" name="Freeform 15">
             <a:extLst>
               <a:ext uri="{FF2B5EF4-FFF2-40B4-BE49-F238E27FC236}">
-                <a16:creationId xmlns:a16="http://schemas.microsoft.com/office/drawing/2014/main" id="{226B2D26-F692-894E-9B09-F57FBB5CB2A3}"/>
+                <ns2:creationId id="{226B2D26-F692-894E-9B09-F57FBB5CB2A3}"/>
               </a:ext>
             </a:extLst>
           </p:cNvPr>
@@ -13458,7 +13554,7 @@
           <p:cNvPr id="18" name="Oval 17">
             <a:extLst>
               <a:ext uri="{FF2B5EF4-FFF2-40B4-BE49-F238E27FC236}">
-                <a16:creationId xmlns:a16="http://schemas.microsoft.com/office/drawing/2014/main" id="{BE4CDC90-4B2E-BE41-BB9D-A84675F3A2FE}"/>
+                <ns2:creationId id="{BE4CDC90-4B2E-BE41-BB9D-A84675F3A2FE}"/>
               </a:ext>
             </a:extLst>
           </p:cNvPr>
@@ -13539,7 +13635,7 @@
           <p:cNvPr id="19" name="Oval 18">
             <a:extLst>
               <a:ext uri="{FF2B5EF4-FFF2-40B4-BE49-F238E27FC236}">
-                <a16:creationId xmlns:a16="http://schemas.microsoft.com/office/drawing/2014/main" id="{0592434B-85D0-0A41-95DD-A29D1D3E92A7}"/>
+                <ns2:creationId id="{0592434B-85D0-0A41-95DD-A29D1D3E92A7}"/>
               </a:ext>
             </a:extLst>
           </p:cNvPr>
@@ -13620,7 +13716,7 @@
           <p:cNvPr id="21" name="TextBox 20">
             <a:extLst>
               <a:ext uri="{FF2B5EF4-FFF2-40B4-BE49-F238E27FC236}">
-                <a16:creationId xmlns:a16="http://schemas.microsoft.com/office/drawing/2014/main" id="{7B549753-C2CD-8744-8435-2E08FD32BDEB}"/>
+                <ns2:creationId id="{7B549753-C2CD-8744-8435-2E08FD32BDEB}"/>
               </a:ext>
             </a:extLst>
           </p:cNvPr>
@@ -13699,7 +13795,7 @@
           <p:cNvPr id="22" name="TextBox 21">
             <a:extLst>
               <a:ext uri="{FF2B5EF4-FFF2-40B4-BE49-F238E27FC236}">
-                <a16:creationId xmlns:a16="http://schemas.microsoft.com/office/drawing/2014/main" id="{32F7BF73-EB2C-9D42-97FB-D39FDCC924EB}"/>
+                <ns2:creationId id="{32F7BF73-EB2C-9D42-97FB-D39FDCC924EB}"/>
               </a:ext>
             </a:extLst>
           </p:cNvPr>
@@ -13778,7 +13874,7 @@
           <p:cNvPr id="32" name="Group 31">
             <a:extLst>
               <a:ext uri="{FF2B5EF4-FFF2-40B4-BE49-F238E27FC236}">
-                <a16:creationId xmlns:a16="http://schemas.microsoft.com/office/drawing/2014/main" id="{A120AE69-6043-195E-40C7-43C019B9D3A9}"/>
+                <ns2:creationId id="{A120AE69-6043-195E-40C7-43C019B9D3A9}"/>
               </a:ext>
             </a:extLst>
           </p:cNvPr>
@@ -13798,7 +13894,7 @@
             <p:cNvPr id="24" name="Straight Connector 23">
               <a:extLst>
                 <a:ext uri="{FF2B5EF4-FFF2-40B4-BE49-F238E27FC236}">
-                  <a16:creationId xmlns:a16="http://schemas.microsoft.com/office/drawing/2014/main" id="{3A19E039-1667-254C-809A-972BBA46D65C}"/>
+                  <ns2:creationId id="{3A19E039-1667-254C-809A-972BBA46D65C}"/>
                 </a:ext>
               </a:extLst>
             </p:cNvPr>
@@ -13845,7 +13941,7 @@
             <p:cNvPr id="2" name="Oval 1">
               <a:extLst>
                 <a:ext uri="{FF2B5EF4-FFF2-40B4-BE49-F238E27FC236}">
-                  <a16:creationId xmlns:a16="http://schemas.microsoft.com/office/drawing/2014/main" id="{38418338-F1E6-81D9-6A8C-D7EB7AA9DDA2}"/>
+                  <ns2:creationId id="{38418338-F1E6-81D9-6A8C-D7EB7AA9DDA2}"/>
                 </a:ext>
               </a:extLst>
             </p:cNvPr>
@@ -13930,7 +14026,7 @@
           <p:cNvPr id="28" name="TextBox 27">
             <a:extLst>
               <a:ext uri="{FF2B5EF4-FFF2-40B4-BE49-F238E27FC236}">
-                <a16:creationId xmlns:a16="http://schemas.microsoft.com/office/drawing/2014/main" id="{B86BBAD0-86F6-0D58-180C-6EA1BDCC33FE}"/>
+                <ns2:creationId id="{B86BBAD0-86F6-0D58-180C-6EA1BDCC33FE}"/>
               </a:ext>
             </a:extLst>
           </p:cNvPr>
@@ -14009,7 +14105,7 @@
           <p:cNvPr id="29" name="TextBox 28">
             <a:extLst>
               <a:ext uri="{FF2B5EF4-FFF2-40B4-BE49-F238E27FC236}">
-                <a16:creationId xmlns:a16="http://schemas.microsoft.com/office/drawing/2014/main" id="{2C329E1C-5E54-9E3C-A6FA-AE50E16EEB85}"/>
+                <ns2:creationId id="{2C329E1C-5E54-9E3C-A6FA-AE50E16EEB85}"/>
               </a:ext>
             </a:extLst>
           </p:cNvPr>
@@ -14088,7 +14184,7 @@
           <p:cNvPr id="33" name="Group 32">
             <a:extLst>
               <a:ext uri="{FF2B5EF4-FFF2-40B4-BE49-F238E27FC236}">
-                <a16:creationId xmlns:a16="http://schemas.microsoft.com/office/drawing/2014/main" id="{1D286D70-C171-9F97-4EF6-3BE92F6BF451}"/>
+                <ns2:creationId id="{1D286D70-C171-9F97-4EF6-3BE92F6BF451}"/>
               </a:ext>
             </a:extLst>
           </p:cNvPr>
@@ -14108,7 +14204,7 @@
             <p:cNvPr id="34" name="Straight Connector 33">
               <a:extLst>
                 <a:ext uri="{FF2B5EF4-FFF2-40B4-BE49-F238E27FC236}">
-                  <a16:creationId xmlns:a16="http://schemas.microsoft.com/office/drawing/2014/main" id="{8592FA4B-D9A7-6E33-AB7A-56BCD3E75DEC}"/>
+                  <ns2:creationId id="{8592FA4B-D9A7-6E33-AB7A-56BCD3E75DEC}"/>
                 </a:ext>
               </a:extLst>
             </p:cNvPr>
@@ -14154,7 +14250,7 @@
             <p:cNvPr id="35" name="Oval 34">
               <a:extLst>
                 <a:ext uri="{FF2B5EF4-FFF2-40B4-BE49-F238E27FC236}">
-                  <a16:creationId xmlns:a16="http://schemas.microsoft.com/office/drawing/2014/main" id="{D1C61822-C414-6D43-5771-23FAB0629304}"/>
+                  <ns2:creationId id="{D1C61822-C414-6D43-5771-23FAB0629304}"/>
                 </a:ext>
               </a:extLst>
             </p:cNvPr>
@@ -14239,7 +14335,7 @@
           <p:cNvPr id="36" name="Group 35">
             <a:extLst>
               <a:ext uri="{FF2B5EF4-FFF2-40B4-BE49-F238E27FC236}">
-                <a16:creationId xmlns:a16="http://schemas.microsoft.com/office/drawing/2014/main" id="{C03937C6-921F-C709-6C11-E769E0AA1568}"/>
+                <ns2:creationId id="{C03937C6-921F-C709-6C11-E769E0AA1568}"/>
               </a:ext>
             </a:extLst>
           </p:cNvPr>
@@ -14259,7 +14355,7 @@
             <p:cNvPr id="37" name="Straight Connector 36">
               <a:extLst>
                 <a:ext uri="{FF2B5EF4-FFF2-40B4-BE49-F238E27FC236}">
-                  <a16:creationId xmlns:a16="http://schemas.microsoft.com/office/drawing/2014/main" id="{BA8BF2BD-3FCE-A586-601D-1E4026152CB6}"/>
+                  <ns2:creationId id="{BA8BF2BD-3FCE-A586-601D-1E4026152CB6}"/>
                 </a:ext>
               </a:extLst>
             </p:cNvPr>
@@ -14305,7 +14401,7 @@
             <p:cNvPr id="38" name="Oval 37">
               <a:extLst>
                 <a:ext uri="{FF2B5EF4-FFF2-40B4-BE49-F238E27FC236}">
-                  <a16:creationId xmlns:a16="http://schemas.microsoft.com/office/drawing/2014/main" id="{9DC53165-740B-C795-C0DF-F1A1A73F6F36}"/>
+                  <ns2:creationId id="{9DC53165-740B-C795-C0DF-F1A1A73F6F36}"/>
                 </a:ext>
               </a:extLst>
             </p:cNvPr>
@@ -14390,7 +14486,7 @@
           <p:cNvPr id="40" name="Group 39">
             <a:extLst>
               <a:ext uri="{FF2B5EF4-FFF2-40B4-BE49-F238E27FC236}">
-                <a16:creationId xmlns:a16="http://schemas.microsoft.com/office/drawing/2014/main" id="{C105AAA1-FA00-79D8-70E9-DB832351B5E2}"/>
+                <ns2:creationId id="{C105AAA1-FA00-79D8-70E9-DB832351B5E2}"/>
               </a:ext>
             </a:extLst>
           </p:cNvPr>
@@ -14410,7 +14506,7 @@
             <p:cNvPr id="41" name="Straight Connector 40">
               <a:extLst>
                 <a:ext uri="{FF2B5EF4-FFF2-40B4-BE49-F238E27FC236}">
-                  <a16:creationId xmlns:a16="http://schemas.microsoft.com/office/drawing/2014/main" id="{48D05E5C-4059-6EC7-1299-E52A65F46E3D}"/>
+                  <ns2:creationId id="{48D05E5C-4059-6EC7-1299-E52A65F46E3D}"/>
                 </a:ext>
               </a:extLst>
             </p:cNvPr>
@@ -14456,7 +14552,7 @@
             <p:cNvPr id="42" name="Oval 41">
               <a:extLst>
                 <a:ext uri="{FF2B5EF4-FFF2-40B4-BE49-F238E27FC236}">
-                  <a16:creationId xmlns:a16="http://schemas.microsoft.com/office/drawing/2014/main" id="{8174E055-9EC2-40B6-B317-43A23011EC49}"/>
+                  <ns2:creationId id="{8174E055-9EC2-40B6-B317-43A23011EC49}"/>
                 </a:ext>
               </a:extLst>
             </p:cNvPr>
@@ -14541,7 +14637,7 @@
           <p:cNvPr id="4" name="Rectangle 3">
             <a:extLst>
               <a:ext uri="{FF2B5EF4-FFF2-40B4-BE49-F238E27FC236}">
-                <a16:creationId xmlns:a16="http://schemas.microsoft.com/office/drawing/2014/main" id="{ADBBA491-EC7F-B7A8-024F-1F1EB3434C26}"/>
+                <ns2:creationId id="{ADBBA491-EC7F-B7A8-024F-1F1EB3434C26}"/>
               </a:ext>
             </a:extLst>
           </p:cNvPr>
@@ -14594,7 +14690,7 @@
           <p:cNvPr id="6" name="Group 5">
             <a:extLst>
               <a:ext uri="{FF2B5EF4-FFF2-40B4-BE49-F238E27FC236}">
-                <a16:creationId xmlns:a16="http://schemas.microsoft.com/office/drawing/2014/main" id="{99AA8219-E43E-724C-056B-B18383E44D07}"/>
+                <ns2:creationId id="{99AA8219-E43E-724C-056B-B18383E44D07}"/>
               </a:ext>
             </a:extLst>
           </p:cNvPr>
@@ -14614,7 +14710,7 @@
             <p:cNvPr id="7" name="Straight Arrow Connector 6">
               <a:extLst>
                 <a:ext uri="{FF2B5EF4-FFF2-40B4-BE49-F238E27FC236}">
-                  <a16:creationId xmlns:a16="http://schemas.microsoft.com/office/drawing/2014/main" id="{D656FE40-D181-9F96-4B12-1D4A1600D94D}"/>
+                  <ns2:creationId id="{D656FE40-D181-9F96-4B12-1D4A1600D94D}"/>
                 </a:ext>
               </a:extLst>
             </p:cNvPr>
@@ -14658,7 +14754,7 @@
             <p:cNvPr id="9" name="Straight Arrow Connector 8">
               <a:extLst>
                 <a:ext uri="{FF2B5EF4-FFF2-40B4-BE49-F238E27FC236}">
-                  <a16:creationId xmlns:a16="http://schemas.microsoft.com/office/drawing/2014/main" id="{A8B296C3-B87D-78ED-4E26-EC9E5A291FD0}"/>
+                  <ns2:creationId id="{A8B296C3-B87D-78ED-4E26-EC9E5A291FD0}"/>
                 </a:ext>
               </a:extLst>
             </p:cNvPr>
@@ -14702,7 +14798,7 @@
             <p:cNvPr id="10" name="TextBox 9">
               <a:extLst>
                 <a:ext uri="{FF2B5EF4-FFF2-40B4-BE49-F238E27FC236}">
-                  <a16:creationId xmlns:a16="http://schemas.microsoft.com/office/drawing/2014/main" id="{F49CBD38-2A34-BF6B-7AF0-E9DF4ADD0FDF}"/>
+                  <ns2:creationId id="{F49CBD38-2A34-BF6B-7AF0-E9DF4ADD0FDF}"/>
                 </a:ext>
               </a:extLst>
             </p:cNvPr>
@@ -14766,7 +14862,7 @@
     </p:spTree>
     <p:extLst>
       <p:ext uri="{BB962C8B-B14F-4D97-AF65-F5344CB8AC3E}">
-        <p14:creationId xmlns:p14="http://schemas.microsoft.com/office/powerpoint/2010/main" val="3036832815"/>
+        <ns3:creationId val="3036832815"/>
       </p:ext>
     </p:extLst>
   </p:cSld>
@@ -14777,7 +14873,7 @@
 </file>
 
 <file path=ppt/slides/slide12.xml><?xml version="1.0" encoding="utf-8"?>
-<p:sld xmlns:a="http://schemas.openxmlformats.org/drawingml/2006/main" xmlns:r="http://schemas.openxmlformats.org/officeDocument/2006/relationships" xmlns:p="http://schemas.openxmlformats.org/presentationml/2006/main">
+<p:sld xmlns:a="http://schemas.openxmlformats.org/drawingml/2006/main" xmlns:ns2="http://schemas.microsoft.com/office/drawing/2014/main" xmlns:ns4="http://schemas.microsoft.com/office/powerpoint/2010/main" xmlns:p="http://schemas.openxmlformats.org/presentationml/2006/main" xmlns:r="http://schemas.openxmlformats.org/officeDocument/2006/relationships">
   <p:cSld>
     <p:bg>
       <p:bgPr>
@@ -14806,7 +14902,7 @@
           <p:cNvPr id="4" name="TextBox 3">
             <a:extLst>
               <a:ext uri="{FF2B5EF4-FFF2-40B4-BE49-F238E27FC236}">
-                <a16:creationId xmlns:a16="http://schemas.microsoft.com/office/drawing/2014/main" id="{04089B0C-3E0D-1D7D-7623-E8C4B9A7F9B0}"/>
+                <ns2:creationId id="{04089B0C-3E0D-1D7D-7623-E8C4B9A7F9B0}"/>
               </a:ext>
             </a:extLst>
           </p:cNvPr>
@@ -14861,17 +14957,92 @@
                 <a:ea typeface="Helvetica Neue" panose="02000503000000020004" pitchFamily="2" charset="0"/>
                 <a:cs typeface="Helvetica Neue" panose="02000503000000020004" pitchFamily="2" charset="0"/>
               </a:rPr>
-              <a:t>A 1D Euclidean-void line with two architrino emitters and wake speed c_f.</a:t>
-            </a:r>
-          </a:p>
-          <a:p>
-            <a:r>
-              <a:rPr>
+              <a:t xml:space="preserve">A 1D Euclidean-void line with two architrino emitters and wake speed </a:t>
+            </a:r>
+            <a:r>
+              <a:rPr kumimoji="0" lang="en-US" sz="1800" b="0" i="0" u="none" strike="noStrike" kern="1200" cap="none" spc="0" normalizeH="0" baseline="0" noProof="0" dirty="0">
+                <a:ln>
+                  <a:noFill/>
+                </a:ln>
+                <a:solidFill>
+                  <a:prstClr val="white"/>
+                </a:solidFill>
+                <a:effectLst/>
+                <a:uLnTx/>
+                <a:uFillTx/>
+                <a:latin typeface="Helvetica Neue" panose="02000503000000020004" pitchFamily="2" charset="0"/>
+                <a:ea typeface="Helvetica Neue" panose="02000503000000020004" pitchFamily="2" charset="0"/>
+                <a:cs typeface="Helvetica Neue" panose="02000503000000020004" pitchFamily="2" charset="0"/>
+              </a:rPr>
+              <a:t>c</a:t>
+            </a:r>
+            <a:r>
+              <a:rPr kumimoji="0" lang="en-US" sz="1260" b="0" i="0" u="none" strike="noStrike" kern="1200" cap="none" spc="0" normalizeH="0" baseline="-25000" noProof="0" dirty="0">
+                <a:ln>
+                  <a:noFill/>
+                </a:ln>
+                <a:solidFill>
+                  <a:prstClr val="white"/>
+                </a:solidFill>
+                <a:effectLst/>
+                <a:uLnTx/>
+                <a:uFillTx/>
+                <a:latin typeface="Helvetica Neue" panose="02000503000000020004" pitchFamily="2" charset="0"/>
+                <a:ea typeface="Helvetica Neue" panose="02000503000000020004" pitchFamily="2" charset="0"/>
+                <a:cs typeface="Helvetica Neue" panose="02000503000000020004" pitchFamily="2" charset="0"/>
+              </a:rPr>
+              <a:t>f</a:t>
+            </a:r>
+            <a:r>
+              <a:rPr kumimoji="0" lang="en-US" sz="1800" b="0" i="0" u="none" strike="noStrike" kern="1200" cap="none" spc="0" normalizeH="0" baseline="0" noProof="0" dirty="0">
+                <a:ln>
+                  <a:noFill/>
+                </a:ln>
+                <a:solidFill>
+                  <a:prstClr val="white"/>
+                </a:solidFill>
+                <a:effectLst/>
+                <a:uLnTx/>
+                <a:uFillTx/>
+                <a:latin typeface="Helvetica Neue" panose="02000503000000020004" pitchFamily="2" charset="0"/>
+                <a:ea typeface="Helvetica Neue" panose="02000503000000020004" pitchFamily="2" charset="0"/>
+                <a:cs typeface="Helvetica Neue" panose="02000503000000020004" pitchFamily="2" charset="0"/>
+              </a:rPr>
+              <a:t>.</a:t>
+            </a:r>
+          </a:p>
+          <a:p>
+            <a:r>
+              <a:rPr baseline="0">
                 <a:solidFill>
                   <a:schemeClr val="bg1"/>
                 </a:solidFill>
               </a:rPr>
-              <a:t>The binary symmetry point occurs when architrino speed |v| = c_f.</a:t>
+              <a:t xml:space="preserve">The binary symmetry point occurs when architrino speed |v| = </a:t>
+            </a:r>
+            <a:r>
+              <a:rPr baseline="0">
+                <a:solidFill>
+                  <a:schemeClr val="bg1"/>
+                </a:solidFill>
+              </a:rPr>
+              <a:t>c</a:t>
+            </a:r>
+            <a:r>
+              <a:rPr baseline="-25000" sz="1260">
+                <a:solidFill>
+                  <a:schemeClr val="bg1"/>
+                </a:solidFill>
+              </a:rPr>
+              <a:t>f</a:t>
+            </a:r>
+            <a:r>
+              <a:rPr baseline="0">
+                <a:solidFill>
+                  <a:schemeClr val="bg1"/>
+                </a:solidFill>
+              </a:rPr>
+              <a:t>.</a:t>
             </a:r>
             <a:endParaRPr kumimoji="0" lang="en-US" sz="1800" b="0" i="0" u="none" strike="noStrike" kern="1200" cap="none" spc="0" normalizeH="0" baseline="0" noProof="0" dirty="0">
               <a:ln>
@@ -15043,7 +15214,58 @@
                 <a:ea typeface="Helvetica Neue" panose="02000503000000020004" pitchFamily="2" charset="0"/>
                 <a:cs typeface="Helvetica Neue" panose="02000503000000020004" pitchFamily="2" charset="0"/>
               </a:rPr>
-              <a:t>Opposite-polarity architrinos launched from large r with small speed may approach |v| near c_f at r = 1.</a:t>
+              <a:t xml:space="preserve">Opposite-polarity architrinos launched from large r with small speed may approach |v| near </a:t>
+            </a:r>
+            <a:r>
+              <a:rPr kumimoji="0" lang="en-US" sz="1800" b="0" i="1" u="none" strike="noStrike" kern="1200" cap="none" spc="0" normalizeH="0" baseline="0" noProof="0" dirty="0">
+                <a:ln>
+                  <a:noFill/>
+                </a:ln>
+                <a:solidFill>
+                  <a:prstClr val="white"/>
+                </a:solidFill>
+                <a:effectLst/>
+                <a:uLnTx/>
+                <a:uFillTx/>
+                <a:latin typeface="Helvetica Neue" panose="02000503000000020004" pitchFamily="2" charset="0"/>
+                <a:ea typeface="Helvetica Neue" panose="02000503000000020004" pitchFamily="2" charset="0"/>
+                <a:cs typeface="Helvetica Neue" panose="02000503000000020004" pitchFamily="2" charset="0"/>
+              </a:rPr>
+              <a:t>c</a:t>
+            </a:r>
+            <a:r>
+              <a:rPr kumimoji="0" lang="en-US" sz="1260" b="0" i="1" u="none" strike="noStrike" kern="1200" cap="none" spc="0" normalizeH="0" baseline="-25000" noProof="0" dirty="0">
+                <a:ln>
+                  <a:noFill/>
+                </a:ln>
+                <a:solidFill>
+                  <a:prstClr val="white"/>
+                </a:solidFill>
+                <a:effectLst/>
+                <a:uLnTx/>
+                <a:uFillTx/>
+                <a:latin typeface="Helvetica Neue" panose="02000503000000020004" pitchFamily="2" charset="0"/>
+                <a:ea typeface="Helvetica Neue" panose="02000503000000020004" pitchFamily="2" charset="0"/>
+                <a:cs typeface="Helvetica Neue" panose="02000503000000020004" pitchFamily="2" charset="0"/>
+              </a:rPr>
+              <a:t>f</a:t>
+            </a:r>
+            <a:r>
+              <a:rPr kumimoji="0" lang="en-US" sz="1800" b="0" i="1" u="none" strike="noStrike" kern="1200" cap="none" spc="0" normalizeH="0" baseline="0" noProof="0" dirty="0">
+                <a:ln>
+                  <a:noFill/>
+                </a:ln>
+                <a:solidFill>
+                  <a:prstClr val="white"/>
+                </a:solidFill>
+                <a:effectLst/>
+                <a:uLnTx/>
+                <a:uFillTx/>
+                <a:latin typeface="Helvetica Neue" panose="02000503000000020004" pitchFamily="2" charset="0"/>
+                <a:ea typeface="Helvetica Neue" panose="02000503000000020004" pitchFamily="2" charset="0"/>
+                <a:cs typeface="Helvetica Neue" panose="02000503000000020004" pitchFamily="2" charset="0"/>
+              </a:rPr>
+              <a:t xml:space="preserve"> at r = 1.</a:t>
             </a:r>
           </a:p>
           <a:p>
@@ -15115,7 +15337,58 @@
                 <a:ea typeface="Helvetica Neue" panose="02000503000000020004" pitchFamily="2" charset="0"/>
                 <a:cs typeface="Helvetica Neue" panose="02000503000000020004" pitchFamily="2" charset="0"/>
               </a:rPr>
-              <a:t>Same-polarity architrinos launched toward each other above c_f may reverse or cross depending on initial offset.</a:t>
+              <a:t xml:space="preserve">Same-polarity architrinos launched toward each other above </a:t>
+            </a:r>
+            <a:r>
+              <a:rPr kumimoji="0" lang="en-US" sz="1800" b="0" i="0" u="none" strike="noStrike" kern="1200" cap="none" spc="0" normalizeH="0" baseline="0" noProof="0" dirty="0">
+                <a:ln>
+                  <a:noFill/>
+                </a:ln>
+                <a:solidFill>
+                  <a:prstClr val="white"/>
+                </a:solidFill>
+                <a:effectLst/>
+                <a:uLnTx/>
+                <a:uFillTx/>
+                <a:latin typeface="Helvetica Neue" panose="02000503000000020004" pitchFamily="2" charset="0"/>
+                <a:ea typeface="Helvetica Neue" panose="02000503000000020004" pitchFamily="2" charset="0"/>
+                <a:cs typeface="Helvetica Neue" panose="02000503000000020004" pitchFamily="2" charset="0"/>
+              </a:rPr>
+              <a:t>c</a:t>
+            </a:r>
+            <a:r>
+              <a:rPr kumimoji="0" lang="en-US" sz="1260" b="0" i="0" u="none" strike="noStrike" kern="1200" cap="none" spc="0" normalizeH="0" baseline="-25000" noProof="0" dirty="0">
+                <a:ln>
+                  <a:noFill/>
+                </a:ln>
+                <a:solidFill>
+                  <a:prstClr val="white"/>
+                </a:solidFill>
+                <a:effectLst/>
+                <a:uLnTx/>
+                <a:uFillTx/>
+                <a:latin typeface="Helvetica Neue" panose="02000503000000020004" pitchFamily="2" charset="0"/>
+                <a:ea typeface="Helvetica Neue" panose="02000503000000020004" pitchFamily="2" charset="0"/>
+                <a:cs typeface="Helvetica Neue" panose="02000503000000020004" pitchFamily="2" charset="0"/>
+              </a:rPr>
+              <a:t>f</a:t>
+            </a:r>
+            <a:r>
+              <a:rPr kumimoji="0" lang="en-US" sz="1800" b="0" i="0" u="none" strike="noStrike" kern="1200" cap="none" spc="0" normalizeH="0" baseline="0" noProof="0" dirty="0">
+                <a:ln>
+                  <a:noFill/>
+                </a:ln>
+                <a:solidFill>
+                  <a:prstClr val="white"/>
+                </a:solidFill>
+                <a:effectLst/>
+                <a:uLnTx/>
+                <a:uFillTx/>
+                <a:latin typeface="Helvetica Neue" panose="02000503000000020004" pitchFamily="2" charset="0"/>
+                <a:ea typeface="Helvetica Neue" panose="02000503000000020004" pitchFamily="2" charset="0"/>
+                <a:cs typeface="Helvetica Neue" panose="02000503000000020004" pitchFamily="2" charset="0"/>
+              </a:rPr>
+              <a:t xml:space="preserve"> may reverse or cross depending on initial offset.</a:t>
             </a:r>
           </a:p>
           <a:p>
@@ -15197,7 +15470,7 @@
           <p:cNvPr id="5" name="Group 4">
             <a:extLst>
               <a:ext uri="{FF2B5EF4-FFF2-40B4-BE49-F238E27FC236}">
-                <a16:creationId xmlns:a16="http://schemas.microsoft.com/office/drawing/2014/main" id="{28EB18A8-8B6A-033D-A4AD-86FBADCB4D4A}"/>
+                <ns2:creationId id="{28EB18A8-8B6A-033D-A4AD-86FBADCB4D4A}"/>
               </a:ext>
             </a:extLst>
           </p:cNvPr>
@@ -15217,7 +15490,7 @@
             <p:cNvPr id="3" name="Picture 2">
               <a:extLst>
                 <a:ext uri="{FF2B5EF4-FFF2-40B4-BE49-F238E27FC236}">
-                  <a16:creationId xmlns:a16="http://schemas.microsoft.com/office/drawing/2014/main" id="{13746C96-5BF1-B22B-CA42-106D1B63333F}"/>
+                  <ns2:creationId id="{13746C96-5BF1-B22B-CA42-106D1B63333F}"/>
                 </a:ext>
               </a:extLst>
             </p:cNvPr>
@@ -15247,7 +15520,7 @@
             <p:cNvPr id="6" name="Straight Connector 5">
               <a:extLst>
                 <a:ext uri="{FF2B5EF4-FFF2-40B4-BE49-F238E27FC236}">
-                  <a16:creationId xmlns:a16="http://schemas.microsoft.com/office/drawing/2014/main" id="{EE364915-3AF3-C9A5-4E25-440B57D56073}"/>
+                  <ns2:creationId id="{EE364915-3AF3-C9A5-4E25-440B57D56073}"/>
                 </a:ext>
               </a:extLst>
             </p:cNvPr>
@@ -15290,7 +15563,7 @@
           <p:cNvPr id="7" name="Title 4">
             <a:extLst>
               <a:ext uri="{FF2B5EF4-FFF2-40B4-BE49-F238E27FC236}">
-                <a16:creationId xmlns:a16="http://schemas.microsoft.com/office/drawing/2014/main" id="{82AADF08-A238-0E6D-347B-D5A2BAE919D0}"/>
+                <ns2:creationId id="{82AADF08-A238-0E6D-347B-D5A2BAE919D0}"/>
               </a:ext>
             </a:extLst>
           </p:cNvPr>
@@ -15378,7 +15651,7 @@
     </p:spTree>
     <p:extLst>
       <p:ext uri="{BB962C8B-B14F-4D97-AF65-F5344CB8AC3E}">
-        <p14:creationId xmlns:p14="http://schemas.microsoft.com/office/powerpoint/2010/main" val="3190063365"/>
+        <ns4:creationId val="3190063365"/>
       </p:ext>
     </p:extLst>
   </p:cSld>
@@ -15389,7 +15662,7 @@
 </file>
 
 <file path=ppt/slides/slide13.xml><?xml version="1.0" encoding="utf-8"?>
-<p:sld xmlns:a="http://schemas.openxmlformats.org/drawingml/2006/main" xmlns:r="http://schemas.openxmlformats.org/officeDocument/2006/relationships" xmlns:p="http://schemas.openxmlformats.org/presentationml/2006/main">
+<p:sld xmlns:a="http://schemas.openxmlformats.org/drawingml/2006/main" xmlns:ns2="http://schemas.microsoft.com/office/drawing/2014/main" xmlns:ns3="http://schemas.microsoft.com/office/powerpoint/2010/main" xmlns:p="http://schemas.openxmlformats.org/presentationml/2006/main">
   <p:cSld>
     <p:bg>
       <p:bgPr>
@@ -15404,7 +15677,7 @@
         <p:cNvPr id="1" name="">
           <a:extLst>
             <a:ext uri="{FF2B5EF4-FFF2-40B4-BE49-F238E27FC236}">
-              <a16:creationId xmlns:a16="http://schemas.microsoft.com/office/drawing/2014/main" id="{96E919E2-812D-C716-7A6E-78657A604D1E}"/>
+              <ns2:creationId id="{96E919E2-812D-C716-7A6E-78657A604D1E}"/>
             </a:ext>
           </a:extLst>
         </p:cNvPr>
@@ -15424,7 +15697,7 @@
           <p:cNvPr id="34" name="Freeform 33">
             <a:extLst>
               <a:ext uri="{FF2B5EF4-FFF2-40B4-BE49-F238E27FC236}">
-                <a16:creationId xmlns:a16="http://schemas.microsoft.com/office/drawing/2014/main" id="{9FEB1C17-EE9E-6374-14E0-DF4B04BB34CC}"/>
+                <ns2:creationId id="{9FEB1C17-EE9E-6374-14E0-DF4B04BB34CC}"/>
               </a:ext>
             </a:extLst>
           </p:cNvPr>
@@ -16462,7 +16735,7 @@
           <p:cNvPr id="23" name="Straight Connector 22">
             <a:extLst>
               <a:ext uri="{FF2B5EF4-FFF2-40B4-BE49-F238E27FC236}">
-                <a16:creationId xmlns:a16="http://schemas.microsoft.com/office/drawing/2014/main" id="{33DF3D55-999F-17C8-E647-A925ABFD4B29}"/>
+                <ns2:creationId id="{33DF3D55-999F-17C8-E647-A925ABFD4B29}"/>
               </a:ext>
             </a:extLst>
           </p:cNvPr>
@@ -16508,7 +16781,7 @@
           <p:cNvPr id="11" name="Footer Placeholder 3">
             <a:extLst>
               <a:ext uri="{FF2B5EF4-FFF2-40B4-BE49-F238E27FC236}">
-                <a16:creationId xmlns:a16="http://schemas.microsoft.com/office/drawing/2014/main" id="{27AA374C-C403-AE7C-8C5A-C9260FD31350}"/>
+                <ns2:creationId id="{27AA374C-C403-AE7C-8C5A-C9260FD31350}"/>
               </a:ext>
             </a:extLst>
           </p:cNvPr>
@@ -16642,7 +16915,7 @@
           <p:cNvPr id="6" name="Freeform 5">
             <a:extLst>
               <a:ext uri="{FF2B5EF4-FFF2-40B4-BE49-F238E27FC236}">
-                <a16:creationId xmlns:a16="http://schemas.microsoft.com/office/drawing/2014/main" id="{58C91A8E-32A3-E6C9-3B21-6258314CE1E0}"/>
+                <ns2:creationId id="{58C91A8E-32A3-E6C9-3B21-6258314CE1E0}"/>
               </a:ext>
             </a:extLst>
           </p:cNvPr>
@@ -17238,7 +17511,7 @@
           <p:cNvPr id="7" name="Freeform 6">
             <a:extLst>
               <a:ext uri="{FF2B5EF4-FFF2-40B4-BE49-F238E27FC236}">
-                <a16:creationId xmlns:a16="http://schemas.microsoft.com/office/drawing/2014/main" id="{510BA2CB-DE8D-42AC-CE1A-16118C17D521}"/>
+                <ns2:creationId id="{510BA2CB-DE8D-42AC-CE1A-16118C17D521}"/>
               </a:ext>
             </a:extLst>
           </p:cNvPr>
@@ -18100,7 +18373,7 @@
           <p:cNvPr id="9" name="Oval 8">
             <a:extLst>
               <a:ext uri="{FF2B5EF4-FFF2-40B4-BE49-F238E27FC236}">
-                <a16:creationId xmlns:a16="http://schemas.microsoft.com/office/drawing/2014/main" id="{568F11F0-CD68-B68F-145C-42747F6BA3CB}"/>
+                <ns2:creationId id="{568F11F0-CD68-B68F-145C-42747F6BA3CB}"/>
               </a:ext>
             </a:extLst>
           </p:cNvPr>
@@ -18154,7 +18427,7 @@
           <p:cNvPr id="10" name="Oval 9">
             <a:extLst>
               <a:ext uri="{FF2B5EF4-FFF2-40B4-BE49-F238E27FC236}">
-                <a16:creationId xmlns:a16="http://schemas.microsoft.com/office/drawing/2014/main" id="{6BC2B4CC-1274-7B5E-9B1C-D914D507A56F}"/>
+                <ns2:creationId id="{6BC2B4CC-1274-7B5E-9B1C-D914D507A56F}"/>
               </a:ext>
             </a:extLst>
           </p:cNvPr>
@@ -18208,7 +18481,7 @@
           <p:cNvPr id="25" name="Rectangle 24">
             <a:extLst>
               <a:ext uri="{FF2B5EF4-FFF2-40B4-BE49-F238E27FC236}">
-                <a16:creationId xmlns:a16="http://schemas.microsoft.com/office/drawing/2014/main" id="{79427490-B6E9-7801-97EB-47C4A21F9FE6}"/>
+                <ns2:creationId id="{79427490-B6E9-7801-97EB-47C4A21F9FE6}"/>
               </a:ext>
             </a:extLst>
           </p:cNvPr>
@@ -18261,7 +18534,7 @@
           <p:cNvPr id="3" name="Straight Arrow Connector 2">
             <a:extLst>
               <a:ext uri="{FF2B5EF4-FFF2-40B4-BE49-F238E27FC236}">
-                <a16:creationId xmlns:a16="http://schemas.microsoft.com/office/drawing/2014/main" id="{EB763B1F-F575-913F-DB72-76ED511A0D0B}"/>
+                <ns2:creationId id="{EB763B1F-F575-913F-DB72-76ED511A0D0B}"/>
               </a:ext>
             </a:extLst>
           </p:cNvPr>
@@ -18306,7 +18579,7 @@
           <p:cNvPr id="4" name="Straight Arrow Connector 3">
             <a:extLst>
               <a:ext uri="{FF2B5EF4-FFF2-40B4-BE49-F238E27FC236}">
-                <a16:creationId xmlns:a16="http://schemas.microsoft.com/office/drawing/2014/main" id="{A90A4078-7CAB-D43F-FE11-DE676579B333}"/>
+                <ns2:creationId id="{A90A4078-7CAB-D43F-FE11-DE676579B333}"/>
               </a:ext>
             </a:extLst>
           </p:cNvPr>
@@ -18351,7 +18624,7 @@
           <p:cNvPr id="5" name="TextBox 4">
             <a:extLst>
               <a:ext uri="{FF2B5EF4-FFF2-40B4-BE49-F238E27FC236}">
-                <a16:creationId xmlns:a16="http://schemas.microsoft.com/office/drawing/2014/main" id="{93EE6640-E2D5-2697-152F-1AC92ACF6299}"/>
+                <ns2:creationId id="{93EE6640-E2D5-2697-152F-1AC92ACF6299}"/>
               </a:ext>
             </a:extLst>
           </p:cNvPr>
@@ -18416,7 +18689,7 @@
           <p:cNvPr id="8" name="TextBox 7">
             <a:extLst>
               <a:ext uri="{FF2B5EF4-FFF2-40B4-BE49-F238E27FC236}">
-                <a16:creationId xmlns:a16="http://schemas.microsoft.com/office/drawing/2014/main" id="{C7F4CB60-409A-DA93-8D6D-DBB74A32F30C}"/>
+                <ns2:creationId id="{C7F4CB60-409A-DA93-8D6D-DBB74A32F30C}"/>
               </a:ext>
             </a:extLst>
           </p:cNvPr>
@@ -18517,7 +18790,7 @@
           <p:cNvPr id="17" name="TextBox 16">
             <a:extLst>
               <a:ext uri="{FF2B5EF4-FFF2-40B4-BE49-F238E27FC236}">
-                <a16:creationId xmlns:a16="http://schemas.microsoft.com/office/drawing/2014/main" id="{F4E68F9E-0E13-E904-E4B5-DEC42C339288}"/>
+                <ns2:creationId id="{F4E68F9E-0E13-E904-E4B5-DEC42C339288}"/>
               </a:ext>
             </a:extLst>
           </p:cNvPr>
@@ -18590,7 +18863,7 @@
           <p:cNvPr id="31" name="Freeform 30">
             <a:extLst>
               <a:ext uri="{FF2B5EF4-FFF2-40B4-BE49-F238E27FC236}">
-                <a16:creationId xmlns:a16="http://schemas.microsoft.com/office/drawing/2014/main" id="{EBDD718E-B038-498A-81E1-4720CA22C4E4}"/>
+                <ns2:creationId id="{EBDD718E-B038-498A-81E1-4720CA22C4E4}"/>
               </a:ext>
             </a:extLst>
           </p:cNvPr>
@@ -19450,7 +19723,7 @@
           <p:cNvPr id="32" name="Oval 31">
             <a:extLst>
               <a:ext uri="{FF2B5EF4-FFF2-40B4-BE49-F238E27FC236}">
-                <a16:creationId xmlns:a16="http://schemas.microsoft.com/office/drawing/2014/main" id="{852BC428-A99B-91EE-DF01-3864DEC4D4BF}"/>
+                <ns2:creationId id="{852BC428-A99B-91EE-DF01-3864DEC4D4BF}"/>
               </a:ext>
             </a:extLst>
           </p:cNvPr>
@@ -19504,7 +19777,7 @@
           <p:cNvPr id="33" name="Oval 32">
             <a:extLst>
               <a:ext uri="{FF2B5EF4-FFF2-40B4-BE49-F238E27FC236}">
-                <a16:creationId xmlns:a16="http://schemas.microsoft.com/office/drawing/2014/main" id="{EFBFF3EA-59F3-C535-EFC4-37E6E9B87AAA}"/>
+                <ns2:creationId id="{EFBFF3EA-59F3-C535-EFC4-37E6E9B87AAA}"/>
               </a:ext>
             </a:extLst>
           </p:cNvPr>
@@ -19558,7 +19831,7 @@
           <p:cNvPr id="35" name="TextBox 34">
             <a:extLst>
               <a:ext uri="{FF2B5EF4-FFF2-40B4-BE49-F238E27FC236}">
-                <a16:creationId xmlns:a16="http://schemas.microsoft.com/office/drawing/2014/main" id="{2A61F73B-4578-41C1-C8EB-DAA0E81D6643}"/>
+                <ns2:creationId id="{2A61F73B-4578-41C1-C8EB-DAA0E81D6643}"/>
               </a:ext>
             </a:extLst>
           </p:cNvPr>
@@ -19911,7 +20184,7 @@
               <a:defRPr/>
             </a:pPr>
             <a:r>
-              <a:rPr lang="en-US" sz="1200" dirty="0">
+              <a:rPr lang="en-US" sz="1200" dirty="0" baseline="0">
                 <a:solidFill>
                   <a:prstClr val="white"/>
                 </a:solidFill>
@@ -19919,7 +20192,73 @@
                 <a:ea typeface="Helvetica Neue" panose="02000503000000020004" pitchFamily="2" charset="0"/>
                 <a:cs typeface="Helvetica Neue" panose="02000503000000020004" pitchFamily="2" charset="0"/>
               </a:rPr>
-              <a:t>expands at wake speed c_f; r = c_f t</a:t>
+              <a:t xml:space="preserve">expands at wake speed </a:t>
+            </a:r>
+            <a:r>
+              <a:rPr lang="en-US" sz="1200" dirty="0" baseline="0">
+                <a:solidFill>
+                  <a:prstClr val="white"/>
+                </a:solidFill>
+                <a:latin typeface="Helvetica Neue" panose="02000503000000020004" pitchFamily="2" charset="0"/>
+                <a:ea typeface="Helvetica Neue" panose="02000503000000020004" pitchFamily="2" charset="0"/>
+                <a:cs typeface="Helvetica Neue" panose="02000503000000020004" pitchFamily="2" charset="0"/>
+              </a:rPr>
+              <a:t>c</a:t>
+            </a:r>
+            <a:r>
+              <a:rPr lang="en-US" sz="840" dirty="0" baseline="-25000">
+                <a:solidFill>
+                  <a:prstClr val="white"/>
+                </a:solidFill>
+                <a:latin typeface="Helvetica Neue" panose="02000503000000020004" pitchFamily="2" charset="0"/>
+                <a:ea typeface="Helvetica Neue" panose="02000503000000020004" pitchFamily="2" charset="0"/>
+                <a:cs typeface="Helvetica Neue" panose="02000503000000020004" pitchFamily="2" charset="0"/>
+              </a:rPr>
+              <a:t>f</a:t>
+            </a:r>
+            <a:r>
+              <a:rPr lang="en-US" sz="1200" dirty="0" baseline="0">
+                <a:solidFill>
+                  <a:prstClr val="white"/>
+                </a:solidFill>
+                <a:latin typeface="Helvetica Neue" panose="02000503000000020004" pitchFamily="2" charset="0"/>
+                <a:ea typeface="Helvetica Neue" panose="02000503000000020004" pitchFamily="2" charset="0"/>
+                <a:cs typeface="Helvetica Neue" panose="02000503000000020004" pitchFamily="2" charset="0"/>
+              </a:rPr>
+              <a:t xml:space="preserve">; r = </a:t>
+            </a:r>
+            <a:r>
+              <a:rPr lang="en-US" sz="1200" dirty="0" baseline="0">
+                <a:solidFill>
+                  <a:prstClr val="white"/>
+                </a:solidFill>
+                <a:latin typeface="Helvetica Neue" panose="02000503000000020004" pitchFamily="2" charset="0"/>
+                <a:ea typeface="Helvetica Neue" panose="02000503000000020004" pitchFamily="2" charset="0"/>
+                <a:cs typeface="Helvetica Neue" panose="02000503000000020004" pitchFamily="2" charset="0"/>
+              </a:rPr>
+              <a:t>c</a:t>
+            </a:r>
+            <a:r>
+              <a:rPr lang="en-US" sz="840" dirty="0" baseline="-25000">
+                <a:solidFill>
+                  <a:prstClr val="white"/>
+                </a:solidFill>
+                <a:latin typeface="Helvetica Neue" panose="02000503000000020004" pitchFamily="2" charset="0"/>
+                <a:ea typeface="Helvetica Neue" panose="02000503000000020004" pitchFamily="2" charset="0"/>
+                <a:cs typeface="Helvetica Neue" panose="02000503000000020004" pitchFamily="2" charset="0"/>
+              </a:rPr>
+              <a:t>f</a:t>
+            </a:r>
+            <a:r>
+              <a:rPr lang="en-US" sz="1200" dirty="0" baseline="0">
+                <a:solidFill>
+                  <a:prstClr val="white"/>
+                </a:solidFill>
+                <a:latin typeface="Helvetica Neue" panose="02000503000000020004" pitchFamily="2" charset="0"/>
+                <a:ea typeface="Helvetica Neue" panose="02000503000000020004" pitchFamily="2" charset="0"/>
+                <a:cs typeface="Helvetica Neue" panose="02000503000000020004" pitchFamily="2" charset="0"/>
+              </a:rPr>
+              <a:t xml:space="preserve"> t</a:t>
             </a:r>
           </a:p>
           <a:p>
@@ -20115,7 +20454,7 @@
     </p:spTree>
     <p:extLst>
       <p:ext uri="{BB962C8B-B14F-4D97-AF65-F5344CB8AC3E}">
-        <p14:creationId xmlns:p14="http://schemas.microsoft.com/office/powerpoint/2010/main" val="3144987668"/>
+        <ns3:creationId val="3144987668"/>
       </p:ext>
     </p:extLst>
   </p:cSld>
@@ -20126,7 +20465,7 @@
 </file>
 
 <file path=ppt/slides/slide14.xml><?xml version="1.0" encoding="utf-8"?>
-<p:sld xmlns:a="http://schemas.openxmlformats.org/drawingml/2006/main" xmlns:r="http://schemas.openxmlformats.org/officeDocument/2006/relationships" xmlns:p="http://schemas.openxmlformats.org/presentationml/2006/main">
+<p:sld xmlns:a="http://schemas.openxmlformats.org/drawingml/2006/main" xmlns:ns2="http://schemas.microsoft.com/office/drawing/2014/main" xmlns:ns3="http://schemas.microsoft.com/office/drawing/2017/decorative" xmlns:ns4="http://schemas.microsoft.com/office/powerpoint/2015/main" xmlns:ns5="http://schemas.microsoft.com/office/powerpoint/2010/main" xmlns:p="http://schemas.openxmlformats.org/presentationml/2006/main">
   <p:cSld>
     <p:bg>
       <p:bgPr>
@@ -20155,10 +20494,10 @@
           <p:cNvPr id="9" name="Rectangle 8">
             <a:extLst>
               <a:ext uri="{FF2B5EF4-FFF2-40B4-BE49-F238E27FC236}">
-                <a16:creationId xmlns:a16="http://schemas.microsoft.com/office/drawing/2014/main" id="{2A8AA5BC-4F7A-4226-8F99-6D824B226A97}"/>
+                <ns2:creationId id="{2A8AA5BC-4F7A-4226-8F99-6D824B226A97}"/>
               </a:ext>
               <a:ext uri="{C183D7F6-B498-43B3-948B-1728B52AA6E4}">
-                <adec:decorative xmlns:adec="http://schemas.microsoft.com/office/drawing/2017/decorative" val="1"/>
+                <ns3:decorative val="1"/>
               </a:ext>
             </a:extLst>
           </p:cNvPr>
@@ -20168,7 +20507,7 @@
           <p:nvPr>
             <p:extLst>
               <p:ext uri="{386F3935-93C4-4BCD-93E2-E3B085C9AB24}">
-                <p16:designElem xmlns:p16="http://schemas.microsoft.com/office/powerpoint/2015/main" val="1"/>
+                <ns4:designElem val="1"/>
               </p:ext>
             </p:extLst>
           </p:nvPr>
@@ -20247,10 +20586,10 @@
           <p:cNvPr id="11" name="Rectangle 10">
             <a:extLst>
               <a:ext uri="{FF2B5EF4-FFF2-40B4-BE49-F238E27FC236}">
-                <a16:creationId xmlns:a16="http://schemas.microsoft.com/office/drawing/2014/main" id="{3E5445C6-DD42-4979-86FF-03730E8C6DB0}"/>
+                <ns2:creationId id="{3E5445C6-DD42-4979-86FF-03730E8C6DB0}"/>
               </a:ext>
               <a:ext uri="{C183D7F6-B498-43B3-948B-1728B52AA6E4}">
-                <adec:decorative xmlns:adec="http://schemas.microsoft.com/office/drawing/2017/decorative" val="1"/>
+                <ns3:decorative val="1"/>
               </a:ext>
             </a:extLst>
           </p:cNvPr>
@@ -20260,7 +20599,7 @@
           <p:nvPr>
             <p:extLst>
               <p:ext uri="{386F3935-93C4-4BCD-93E2-E3B085C9AB24}">
-                <p16:designElem xmlns:p16="http://schemas.microsoft.com/office/powerpoint/2015/main" val="1"/>
+                <ns4:designElem val="1"/>
               </p:ext>
             </p:extLst>
           </p:nvPr>
@@ -20347,7 +20686,7 @@
           <p:cNvPr id="2" name="Title 1">
             <a:extLst>
               <a:ext uri="{FF2B5EF4-FFF2-40B4-BE49-F238E27FC236}">
-                <a16:creationId xmlns:a16="http://schemas.microsoft.com/office/drawing/2014/main" id="{7710B119-EC53-BA46-BAA3-CB758CDEDAF5}"/>
+                <ns2:creationId id="{7710B119-EC53-BA46-BAA3-CB758CDEDAF5}"/>
               </a:ext>
             </a:extLst>
           </p:cNvPr>
@@ -20382,7 +20721,7 @@
           <p:cNvPr id="3" name="Subtitle 2">
             <a:extLst>
               <a:ext uri="{FF2B5EF4-FFF2-40B4-BE49-F238E27FC236}">
-                <a16:creationId xmlns:a16="http://schemas.microsoft.com/office/drawing/2014/main" id="{44E6BC0E-0DB7-C346-A0CC-E3CB36C29A54}"/>
+                <ns2:creationId id="{44E6BC0E-0DB7-C346-A0CC-E3CB36C29A54}"/>
               </a:ext>
             </a:extLst>
           </p:cNvPr>
@@ -20417,10 +20756,10 @@
           <p:cNvPr id="13" name="Straight Connector 12">
             <a:extLst>
               <a:ext uri="{FF2B5EF4-FFF2-40B4-BE49-F238E27FC236}">
-                <a16:creationId xmlns:a16="http://schemas.microsoft.com/office/drawing/2014/main" id="{45000665-DFC7-417E-8FD7-516A0F15C975}"/>
+                <ns2:creationId id="{45000665-DFC7-417E-8FD7-516A0F15C975}"/>
               </a:ext>
               <a:ext uri="{C183D7F6-B498-43B3-948B-1728B52AA6E4}">
-                <adec:decorative xmlns:adec="http://schemas.microsoft.com/office/drawing/2017/decorative" val="1"/>
+                <ns3:decorative val="1"/>
               </a:ext>
             </a:extLst>
           </p:cNvPr>
@@ -20430,7 +20769,7 @@
           <p:nvPr>
             <p:extLst>
               <p:ext uri="{386F3935-93C4-4BCD-93E2-E3B085C9AB24}">
-                <p16:designElem xmlns:p16="http://schemas.microsoft.com/office/powerpoint/2015/main" val="1"/>
+                <ns4:designElem val="1"/>
               </p:ext>
             </p:extLst>
           </p:nvPr>
@@ -20471,7 +20810,7 @@
           <p:cNvPr id="4" name="Footer Placeholder 3">
             <a:extLst>
               <a:ext uri="{FF2B5EF4-FFF2-40B4-BE49-F238E27FC236}">
-                <a16:creationId xmlns:a16="http://schemas.microsoft.com/office/drawing/2014/main" id="{9E726E67-7B90-B642-8D26-6DDF890C4785}"/>
+                <ns2:creationId id="{9E726E67-7B90-B642-8D26-6DDF890C4785}"/>
               </a:ext>
             </a:extLst>
           </p:cNvPr>
@@ -20536,7 +20875,7 @@
     </p:spTree>
     <p:extLst>
       <p:ext uri="{BB962C8B-B14F-4D97-AF65-F5344CB8AC3E}">
-        <p14:creationId xmlns:p14="http://schemas.microsoft.com/office/powerpoint/2010/main" val="3747833275"/>
+        <ns5:creationId val="3747833275"/>
       </p:ext>
     </p:extLst>
   </p:cSld>
@@ -20547,7 +20886,7 @@
 </file>
 
 <file path=ppt/slides/slide15.xml><?xml version="1.0" encoding="utf-8"?>
-<p:sld xmlns:a="http://schemas.openxmlformats.org/drawingml/2006/main" xmlns:r="http://schemas.openxmlformats.org/officeDocument/2006/relationships" xmlns:p="http://schemas.openxmlformats.org/presentationml/2006/main">
+<p:sld xmlns:a="http://schemas.openxmlformats.org/drawingml/2006/main" xmlns:ns2="http://schemas.microsoft.com/office/drawing/2014/main" xmlns:ns3="http://schemas.microsoft.com/office/powerpoint/2010/main" xmlns:p="http://schemas.openxmlformats.org/presentationml/2006/main">
   <p:cSld>
     <p:bg>
       <p:bgPr>
@@ -20562,7 +20901,7 @@
         <p:cNvPr id="1" name="">
           <a:extLst>
             <a:ext uri="{FF2B5EF4-FFF2-40B4-BE49-F238E27FC236}">
-              <a16:creationId xmlns:a16="http://schemas.microsoft.com/office/drawing/2014/main" id="{804AC981-79ED-95B2-006C-1F07F7D1021C}"/>
+              <ns2:creationId id="{804AC981-79ED-95B2-006C-1F07F7D1021C}"/>
             </a:ext>
           </a:extLst>
         </p:cNvPr>
@@ -20582,7 +20921,7 @@
           <p:cNvPr id="2" name="TextBox 1">
             <a:extLst>
               <a:ext uri="{FF2B5EF4-FFF2-40B4-BE49-F238E27FC236}">
-                <a16:creationId xmlns:a16="http://schemas.microsoft.com/office/drawing/2014/main" id="{25D5C38C-76F4-C791-A566-84A8B395A016}"/>
+                <ns2:creationId id="{25D5C38C-76F4-C791-A566-84A8B395A016}"/>
               </a:ext>
             </a:extLst>
           </p:cNvPr>
@@ -20679,7 +21018,7 @@
     </p:spTree>
     <p:extLst>
       <p:ext uri="{BB962C8B-B14F-4D97-AF65-F5344CB8AC3E}">
-        <p14:creationId xmlns:p14="http://schemas.microsoft.com/office/powerpoint/2010/main" val="3464736619"/>
+        <ns3:creationId val="3464736619"/>
       </p:ext>
     </p:extLst>
   </p:cSld>
@@ -20690,7 +21029,7 @@
 </file>
 
 <file path=ppt/slides/slide16.xml><?xml version="1.0" encoding="utf-8"?>
-<p:sld xmlns:a="http://schemas.openxmlformats.org/drawingml/2006/main" xmlns:r="http://schemas.openxmlformats.org/officeDocument/2006/relationships" xmlns:p="http://schemas.openxmlformats.org/presentationml/2006/main">
+<p:sld xmlns:a="http://schemas.openxmlformats.org/drawingml/2006/main" xmlns:ns2="http://schemas.microsoft.com/office/drawing/2014/main" xmlns:ns3="http://schemas.microsoft.com/office/powerpoint/2010/main" xmlns:p="http://schemas.openxmlformats.org/presentationml/2006/main">
   <p:cSld>
     <p:bg>
       <p:bgPr>
@@ -20705,7 +21044,7 @@
         <p:cNvPr id="1" name="">
           <a:extLst>
             <a:ext uri="{FF2B5EF4-FFF2-40B4-BE49-F238E27FC236}">
-              <a16:creationId xmlns:a16="http://schemas.microsoft.com/office/drawing/2014/main" id="{2CB0C588-8647-6C8C-8DC7-F162DDF8BF26}"/>
+              <ns2:creationId id="{2CB0C588-8647-6C8C-8DC7-F162DDF8BF26}"/>
             </a:ext>
           </a:extLst>
         </p:cNvPr>
@@ -20725,7 +21064,7 @@
           <p:cNvPr id="5" name="Footer Placeholder 3">
             <a:extLst>
               <a:ext uri="{FF2B5EF4-FFF2-40B4-BE49-F238E27FC236}">
-                <a16:creationId xmlns:a16="http://schemas.microsoft.com/office/drawing/2014/main" id="{D8055493-6465-E03D-4E0E-CA86B923D2DB}"/>
+                <ns2:creationId id="{D8055493-6465-E03D-4E0E-CA86B923D2DB}"/>
               </a:ext>
             </a:extLst>
           </p:cNvPr>
@@ -20887,7 +21226,7 @@
           <p:cNvPr id="19" name="Rectangle 18">
             <a:extLst>
               <a:ext uri="{FF2B5EF4-FFF2-40B4-BE49-F238E27FC236}">
-                <a16:creationId xmlns:a16="http://schemas.microsoft.com/office/drawing/2014/main" id="{232D04D3-E71C-CAE2-097F-314B5E11C0F3}"/>
+                <ns2:creationId id="{232D04D3-E71C-CAE2-097F-314B5E11C0F3}"/>
               </a:ext>
             </a:extLst>
           </p:cNvPr>
@@ -20952,7 +21291,7 @@
           <p:cNvPr id="2" name="TextBox 1">
             <a:extLst>
               <a:ext uri="{FF2B5EF4-FFF2-40B4-BE49-F238E27FC236}">
-                <a16:creationId xmlns:a16="http://schemas.microsoft.com/office/drawing/2014/main" id="{5B66C1A2-52BD-EA60-BE8F-C5D3C8F732D2}"/>
+                <ns2:creationId id="{5B66C1A2-52BD-EA60-BE8F-C5D3C8F732D2}"/>
               </a:ext>
             </a:extLst>
           </p:cNvPr>
@@ -21079,7 +21418,58 @@
                 <a:ea typeface="Helvetica Neue" panose="02000503000000020004" pitchFamily="2" charset="0"/>
                 <a:cs typeface="Helvetica Neue" panose="02000503000000020004" pitchFamily="2" charset="0"/>
               </a:rPr>
-              <a:t>Because an architrino can move faster than wake speed, v = c_f marks a self-hit onset boundary rather than an observer-level speed limit.</a:t>
+              <a:t xml:space="preserve">Because an architrino can move faster than wake speed, v = </a:t>
+            </a:r>
+            <a:r>
+              <a:rPr kumimoji="0" lang="en-US" sz="1600" b="0" i="0" u="none" strike="noStrike" kern="1200" cap="none" spc="0" normalizeH="0" baseline="0" noProof="0" dirty="0">
+                <a:ln>
+                  <a:noFill/>
+                </a:ln>
+                <a:solidFill>
+                  <a:prstClr val="white"/>
+                </a:solidFill>
+                <a:effectLst/>
+                <a:uLnTx/>
+                <a:uFillTx/>
+                <a:latin typeface="Helvetica Neue" panose="02000503000000020004" pitchFamily="2" charset="0"/>
+                <a:ea typeface="Helvetica Neue" panose="02000503000000020004" pitchFamily="2" charset="0"/>
+                <a:cs typeface="Helvetica Neue" panose="02000503000000020004" pitchFamily="2" charset="0"/>
+              </a:rPr>
+              <a:t>c</a:t>
+            </a:r>
+            <a:r>
+              <a:rPr kumimoji="0" lang="en-US" sz="1120" b="0" i="0" u="none" strike="noStrike" kern="1200" cap="none" spc="0" normalizeH="0" baseline="-25000" noProof="0" dirty="0">
+                <a:ln>
+                  <a:noFill/>
+                </a:ln>
+                <a:solidFill>
+                  <a:prstClr val="white"/>
+                </a:solidFill>
+                <a:effectLst/>
+                <a:uLnTx/>
+                <a:uFillTx/>
+                <a:latin typeface="Helvetica Neue" panose="02000503000000020004" pitchFamily="2" charset="0"/>
+                <a:ea typeface="Helvetica Neue" panose="02000503000000020004" pitchFamily="2" charset="0"/>
+                <a:cs typeface="Helvetica Neue" panose="02000503000000020004" pitchFamily="2" charset="0"/>
+              </a:rPr>
+              <a:t>f</a:t>
+            </a:r>
+            <a:r>
+              <a:rPr kumimoji="0" lang="en-US" sz="1600" b="0" i="0" u="none" strike="noStrike" kern="1200" cap="none" spc="0" normalizeH="0" baseline="0" noProof="0" dirty="0">
+                <a:ln>
+                  <a:noFill/>
+                </a:ln>
+                <a:solidFill>
+                  <a:prstClr val="white"/>
+                </a:solidFill>
+                <a:effectLst/>
+                <a:uLnTx/>
+                <a:uFillTx/>
+                <a:latin typeface="Helvetica Neue" panose="02000503000000020004" pitchFamily="2" charset="0"/>
+                <a:ea typeface="Helvetica Neue" panose="02000503000000020004" pitchFamily="2" charset="0"/>
+                <a:cs typeface="Helvetica Neue" panose="02000503000000020004" pitchFamily="2" charset="0"/>
+              </a:rPr>
+              <a:t xml:space="preserve"> marks a self-hit onset boundary rather than an observer-level speed limit.</a:t>
             </a:r>
           </a:p>
           <a:p>
@@ -21111,7 +21501,7 @@
     </p:spTree>
     <p:extLst>
       <p:ext uri="{BB962C8B-B14F-4D97-AF65-F5344CB8AC3E}">
-        <p14:creationId xmlns:p14="http://schemas.microsoft.com/office/powerpoint/2010/main" val="3670680207"/>
+        <ns3:creationId val="3670680207"/>
       </p:ext>
     </p:extLst>
   </p:cSld>
@@ -21122,7 +21512,7 @@
 </file>
 
 <file path=ppt/slides/slide17.xml><?xml version="1.0" encoding="utf-8"?>
-<p:sld xmlns:a="http://schemas.openxmlformats.org/drawingml/2006/main" xmlns:r="http://schemas.openxmlformats.org/officeDocument/2006/relationships" xmlns:p="http://schemas.openxmlformats.org/presentationml/2006/main">
+<p:sld xmlns:a="http://schemas.openxmlformats.org/drawingml/2006/main" xmlns:ns2="http://schemas.microsoft.com/office/drawing/2014/main" xmlns:ns3="http://schemas.microsoft.com/office/powerpoint/2010/main" xmlns:p="http://schemas.openxmlformats.org/presentationml/2006/main">
   <p:cSld>
     <p:bg>
       <p:bgPr>
@@ -21137,7 +21527,7 @@
         <p:cNvPr id="1" name="">
           <a:extLst>
             <a:ext uri="{FF2B5EF4-FFF2-40B4-BE49-F238E27FC236}">
-              <a16:creationId xmlns:a16="http://schemas.microsoft.com/office/drawing/2014/main" id="{8B3A6F17-EFE6-B51A-A63A-3B70333495A1}"/>
+              <ns2:creationId id="{8B3A6F17-EFE6-B51A-A63A-3B70333495A1}"/>
             </a:ext>
           </a:extLst>
         </p:cNvPr>
@@ -21157,7 +21547,7 @@
           <p:cNvPr id="5" name="Footer Placeholder 3">
             <a:extLst>
               <a:ext uri="{FF2B5EF4-FFF2-40B4-BE49-F238E27FC236}">
-                <a16:creationId xmlns:a16="http://schemas.microsoft.com/office/drawing/2014/main" id="{68EB2D01-BE54-DC86-BCD1-1E32DA2C4000}"/>
+                <ns2:creationId id="{68EB2D01-BE54-DC86-BCD1-1E32DA2C4000}"/>
               </a:ext>
             </a:extLst>
           </p:cNvPr>
@@ -21319,7 +21709,7 @@
           <p:cNvPr id="19" name="Rectangle 18">
             <a:extLst>
               <a:ext uri="{FF2B5EF4-FFF2-40B4-BE49-F238E27FC236}">
-                <a16:creationId xmlns:a16="http://schemas.microsoft.com/office/drawing/2014/main" id="{F2D335EE-90BE-310F-3F30-68D612074B92}"/>
+                <ns2:creationId id="{F2D335EE-90BE-310F-3F30-68D612074B92}"/>
               </a:ext>
             </a:extLst>
           </p:cNvPr>
@@ -21384,7 +21774,7 @@
           <p:cNvPr id="2" name="TextBox 1">
             <a:extLst>
               <a:ext uri="{FF2B5EF4-FFF2-40B4-BE49-F238E27FC236}">
-                <a16:creationId xmlns:a16="http://schemas.microsoft.com/office/drawing/2014/main" id="{CBF92790-EC27-682A-21D0-5C88069D4333}"/>
+                <ns2:creationId id="{CBF92790-EC27-682A-21D0-5C88069D4333}"/>
               </a:ext>
             </a:extLst>
           </p:cNvPr>
@@ -21555,7 +21945,7 @@
     </p:spTree>
     <p:extLst>
       <p:ext uri="{BB962C8B-B14F-4D97-AF65-F5344CB8AC3E}">
-        <p14:creationId xmlns:p14="http://schemas.microsoft.com/office/powerpoint/2010/main" val="653966555"/>
+        <ns3:creationId val="653966555"/>
       </p:ext>
     </p:extLst>
   </p:cSld>
@@ -21566,7 +21956,7 @@
 </file>
 
 <file path=ppt/slides/slide18.xml><?xml version="1.0" encoding="utf-8"?>
-<p:sld xmlns:a="http://schemas.openxmlformats.org/drawingml/2006/main" xmlns:r="http://schemas.openxmlformats.org/officeDocument/2006/relationships" xmlns:p="http://schemas.openxmlformats.org/presentationml/2006/main">
+<p:sld xmlns:a="http://schemas.openxmlformats.org/drawingml/2006/main" xmlns:ns2="http://schemas.microsoft.com/office/drawing/2014/main" xmlns:ns4="http://schemas.microsoft.com/office/powerpoint/2010/main" xmlns:p="http://schemas.openxmlformats.org/presentationml/2006/main" xmlns:r="http://schemas.openxmlformats.org/officeDocument/2006/relationships">
   <p:cSld>
     <p:bg>
       <p:bgPr>
@@ -21581,7 +21971,7 @@
         <p:cNvPr id="1" name="">
           <a:extLst>
             <a:ext uri="{FF2B5EF4-FFF2-40B4-BE49-F238E27FC236}">
-              <a16:creationId xmlns:a16="http://schemas.microsoft.com/office/drawing/2014/main" id="{764AD85F-4248-DE78-FCB4-518C065121A3}"/>
+              <ns2:creationId id="{764AD85F-4248-DE78-FCB4-518C065121A3}"/>
             </a:ext>
           </a:extLst>
         </p:cNvPr>
@@ -21601,7 +21991,7 @@
           <p:cNvPr id="5" name="Footer Placeholder 3">
             <a:extLst>
               <a:ext uri="{FF2B5EF4-FFF2-40B4-BE49-F238E27FC236}">
-                <a16:creationId xmlns:a16="http://schemas.microsoft.com/office/drawing/2014/main" id="{0464A0FC-8CE3-207B-0E49-C582E93BE77D}"/>
+                <ns2:creationId id="{0464A0FC-8CE3-207B-0E49-C582E93BE77D}"/>
               </a:ext>
             </a:extLst>
           </p:cNvPr>
@@ -21763,7 +22153,7 @@
           <p:cNvPr id="19" name="Rectangle 18">
             <a:extLst>
               <a:ext uri="{FF2B5EF4-FFF2-40B4-BE49-F238E27FC236}">
-                <a16:creationId xmlns:a16="http://schemas.microsoft.com/office/drawing/2014/main" id="{59C47AE8-E40E-D333-CCEE-591287A99ACE}"/>
+                <ns2:creationId id="{59C47AE8-E40E-D333-CCEE-591287A99ACE}"/>
               </a:ext>
             </a:extLst>
           </p:cNvPr>
@@ -21828,7 +22218,7 @@
           <p:cNvPr id="2" name="TextBox 1">
             <a:extLst>
               <a:ext uri="{FF2B5EF4-FFF2-40B4-BE49-F238E27FC236}">
-                <a16:creationId xmlns:a16="http://schemas.microsoft.com/office/drawing/2014/main" id="{C4927378-5D67-46E3-234B-AEB36EE62C4E}"/>
+                <ns2:creationId id="{C4927378-5D67-46E3-234B-AEB36EE62C4E}"/>
               </a:ext>
             </a:extLst>
           </p:cNvPr>
@@ -21893,7 +22283,7 @@
           <p:cNvPr id="3" name="Picture 2">
             <a:extLst>
               <a:ext uri="{FF2B5EF4-FFF2-40B4-BE49-F238E27FC236}">
-                <a16:creationId xmlns:a16="http://schemas.microsoft.com/office/drawing/2014/main" id="{77DA6E5F-7441-6233-DACB-330BCC7593FF}"/>
+                <ns2:creationId id="{77DA6E5F-7441-6233-DACB-330BCC7593FF}"/>
               </a:ext>
             </a:extLst>
           </p:cNvPr>
@@ -21921,7 +22311,7 @@
     </p:spTree>
     <p:extLst>
       <p:ext uri="{BB962C8B-B14F-4D97-AF65-F5344CB8AC3E}">
-        <p14:creationId xmlns:p14="http://schemas.microsoft.com/office/powerpoint/2010/main" val="1428032534"/>
+        <ns4:creationId val="1428032534"/>
       </p:ext>
     </p:extLst>
   </p:cSld>
@@ -21932,7 +22322,7 @@
 </file>
 
 <file path=ppt/slides/slide2.xml><?xml version="1.0" encoding="utf-8"?>
-<p:sld xmlns:a="http://schemas.openxmlformats.org/drawingml/2006/main" xmlns:r="http://schemas.openxmlformats.org/officeDocument/2006/relationships" xmlns:p="http://schemas.openxmlformats.org/presentationml/2006/main">
+<p:sld xmlns:a="http://schemas.openxmlformats.org/drawingml/2006/main" xmlns:ns2="http://schemas.microsoft.com/office/drawing/2014/main" xmlns:ns3="http://schemas.microsoft.com/office/powerpoint/2010/main" xmlns:p="http://schemas.openxmlformats.org/presentationml/2006/main">
   <p:cSld>
     <p:bg>
       <p:bgPr>
@@ -21961,7 +22351,7 @@
           <p:cNvPr id="5" name="Footer Placeholder 3">
             <a:extLst>
               <a:ext uri="{FF2B5EF4-FFF2-40B4-BE49-F238E27FC236}">
-                <a16:creationId xmlns:a16="http://schemas.microsoft.com/office/drawing/2014/main" id="{668F77D6-DFDA-5A46-8DF1-47F6A167C2B1}"/>
+                <ns2:creationId id="{668F77D6-DFDA-5A46-8DF1-47F6A167C2B1}"/>
               </a:ext>
             </a:extLst>
           </p:cNvPr>
@@ -22123,7 +22513,7 @@
           <p:cNvPr id="6" name="Group 5">
             <a:extLst>
               <a:ext uri="{FF2B5EF4-FFF2-40B4-BE49-F238E27FC236}">
-                <a16:creationId xmlns:a16="http://schemas.microsoft.com/office/drawing/2014/main" id="{CB214E5A-63A5-5C6B-3D5B-75FF74FA3E5A}"/>
+                <ns2:creationId id="{CB214E5A-63A5-5C6B-3D5B-75FF74FA3E5A}"/>
               </a:ext>
             </a:extLst>
           </p:cNvPr>
@@ -22143,7 +22533,7 @@
             <p:cNvPr id="3" name="Straight Arrow Connector 2">
               <a:extLst>
                 <a:ext uri="{FF2B5EF4-FFF2-40B4-BE49-F238E27FC236}">
-                  <a16:creationId xmlns:a16="http://schemas.microsoft.com/office/drawing/2014/main" id="{2EF0199F-22F4-BA42-9B75-8A8183BCDA9B}"/>
+                  <ns2:creationId id="{2EF0199F-22F4-BA42-9B75-8A8183BCDA9B}"/>
                 </a:ext>
               </a:extLst>
             </p:cNvPr>
@@ -22187,7 +22577,7 @@
             <p:cNvPr id="8" name="Straight Arrow Connector 7">
               <a:extLst>
                 <a:ext uri="{FF2B5EF4-FFF2-40B4-BE49-F238E27FC236}">
-                  <a16:creationId xmlns:a16="http://schemas.microsoft.com/office/drawing/2014/main" id="{49AB5343-55D0-6041-8627-E08A73F83930}"/>
+                  <ns2:creationId id="{49AB5343-55D0-6041-8627-E08A73F83930}"/>
                 </a:ext>
               </a:extLst>
             </p:cNvPr>
@@ -22231,7 +22621,7 @@
             <p:cNvPr id="12" name="TextBox 11">
               <a:extLst>
                 <a:ext uri="{FF2B5EF4-FFF2-40B4-BE49-F238E27FC236}">
-                  <a16:creationId xmlns:a16="http://schemas.microsoft.com/office/drawing/2014/main" id="{BF8D86A2-D083-024A-BC90-6BD938C23243}"/>
+                  <ns2:creationId id="{BF8D86A2-D083-024A-BC90-6BD938C23243}"/>
                 </a:ext>
               </a:extLst>
             </p:cNvPr>
@@ -22296,7 +22686,7 @@
             <p:cNvPr id="13" name="TextBox 12">
               <a:extLst>
                 <a:ext uri="{FF2B5EF4-FFF2-40B4-BE49-F238E27FC236}">
-                  <a16:creationId xmlns:a16="http://schemas.microsoft.com/office/drawing/2014/main" id="{2C3F4604-6C2F-0E4E-9DD3-4F5C89FF51AB}"/>
+                  <ns2:creationId id="{2C3F4604-6C2F-0E4E-9DD3-4F5C89FF51AB}"/>
                 </a:ext>
               </a:extLst>
             </p:cNvPr>
@@ -22398,7 +22788,7 @@
           <p:cNvPr id="23" name="Oval 22">
             <a:extLst>
               <a:ext uri="{FF2B5EF4-FFF2-40B4-BE49-F238E27FC236}">
-                <a16:creationId xmlns:a16="http://schemas.microsoft.com/office/drawing/2014/main" id="{0112617B-A1D5-1E41-BF92-E67D4E046E39}"/>
+                <ns2:creationId id="{0112617B-A1D5-1E41-BF92-E67D4E046E39}"/>
               </a:ext>
             </a:extLst>
           </p:cNvPr>
@@ -22482,7 +22872,7 @@
           <p:cNvPr id="27" name="Oval 26">
             <a:extLst>
               <a:ext uri="{FF2B5EF4-FFF2-40B4-BE49-F238E27FC236}">
-                <a16:creationId xmlns:a16="http://schemas.microsoft.com/office/drawing/2014/main" id="{6EF0F7DA-5E70-8348-A200-F59A10FF7C55}"/>
+                <ns2:creationId id="{6EF0F7DA-5E70-8348-A200-F59A10FF7C55}"/>
               </a:ext>
             </a:extLst>
           </p:cNvPr>
@@ -22566,7 +22956,7 @@
           <p:cNvPr id="28" name="Oval 27">
             <a:extLst>
               <a:ext uri="{FF2B5EF4-FFF2-40B4-BE49-F238E27FC236}">
-                <a16:creationId xmlns:a16="http://schemas.microsoft.com/office/drawing/2014/main" id="{552F58D0-F613-674A-B294-C894E5FB1683}"/>
+                <ns2:creationId id="{552F58D0-F613-674A-B294-C894E5FB1683}"/>
               </a:ext>
             </a:extLst>
           </p:cNvPr>
@@ -22650,7 +23040,7 @@
           <p:cNvPr id="29" name="Oval 28">
             <a:extLst>
               <a:ext uri="{FF2B5EF4-FFF2-40B4-BE49-F238E27FC236}">
-                <a16:creationId xmlns:a16="http://schemas.microsoft.com/office/drawing/2014/main" id="{9CA7A721-D3BD-744E-9306-85BBED5F74BC}"/>
+                <ns2:creationId id="{9CA7A721-D3BD-744E-9306-85BBED5F74BC}"/>
               </a:ext>
             </a:extLst>
           </p:cNvPr>
@@ -22734,7 +23124,7 @@
           <p:cNvPr id="30" name="Oval 29">
             <a:extLst>
               <a:ext uri="{FF2B5EF4-FFF2-40B4-BE49-F238E27FC236}">
-                <a16:creationId xmlns:a16="http://schemas.microsoft.com/office/drawing/2014/main" id="{F97F1A02-C0C7-3C45-9790-847C152D159A}"/>
+                <ns2:creationId id="{F97F1A02-C0C7-3C45-9790-847C152D159A}"/>
               </a:ext>
             </a:extLst>
           </p:cNvPr>
@@ -22818,7 +23208,7 @@
           <p:cNvPr id="18" name="Oval 17">
             <a:extLst>
               <a:ext uri="{FF2B5EF4-FFF2-40B4-BE49-F238E27FC236}">
-                <a16:creationId xmlns:a16="http://schemas.microsoft.com/office/drawing/2014/main" id="{BE4CDC90-4B2E-BE41-BB9D-A84675F3A2FE}"/>
+                <ns2:creationId id="{BE4CDC90-4B2E-BE41-BB9D-A84675F3A2FE}"/>
               </a:ext>
             </a:extLst>
           </p:cNvPr>
@@ -22901,7 +23291,7 @@
           <p:cNvPr id="31" name="TextBox 30">
             <a:extLst>
               <a:ext uri="{FF2B5EF4-FFF2-40B4-BE49-F238E27FC236}">
-                <a16:creationId xmlns:a16="http://schemas.microsoft.com/office/drawing/2014/main" id="{713B9ACE-B673-2D48-BEF2-2A133C31B527}"/>
+                <ns2:creationId id="{713B9ACE-B673-2D48-BEF2-2A133C31B527}"/>
               </a:ext>
             </a:extLst>
           </p:cNvPr>
@@ -22959,7 +23349,58 @@
                 <a:ea typeface="Helvetica Neue" panose="02000503000000020004" pitchFamily="2" charset="0"/>
                 <a:cs typeface="Helvetica Neue" panose="02000503000000020004" pitchFamily="2" charset="0"/>
               </a:rPr>
-              <a:t>r = c_f t</a:t>
+              <a:t xml:space="preserve">r = </a:t>
+            </a:r>
+            <a:r>
+              <a:rPr kumimoji="0" lang="en-US" sz="1400" b="0" i="1" u="none" strike="noStrike" kern="1200" cap="none" spc="0" normalizeH="0" baseline="0" noProof="0" dirty="0">
+                <a:ln>
+                  <a:noFill/>
+                </a:ln>
+                <a:solidFill>
+                  <a:srgbClr val="FFC000"/>
+                </a:solidFill>
+                <a:effectLst/>
+                <a:uLnTx/>
+                <a:uFillTx/>
+                <a:latin typeface="Helvetica Neue" panose="02000503000000020004" pitchFamily="2" charset="0"/>
+                <a:ea typeface="Helvetica Neue" panose="02000503000000020004" pitchFamily="2" charset="0"/>
+                <a:cs typeface="Helvetica Neue" panose="02000503000000020004" pitchFamily="2" charset="0"/>
+              </a:rPr>
+              <a:t>c</a:t>
+            </a:r>
+            <a:r>
+              <a:rPr kumimoji="0" lang="en-US" sz="980" b="0" i="1" u="none" strike="noStrike" kern="1200" cap="none" spc="0" normalizeH="0" baseline="-25000" noProof="0" dirty="0">
+                <a:ln>
+                  <a:noFill/>
+                </a:ln>
+                <a:solidFill>
+                  <a:srgbClr val="FFC000"/>
+                </a:solidFill>
+                <a:effectLst/>
+                <a:uLnTx/>
+                <a:uFillTx/>
+                <a:latin typeface="Helvetica Neue" panose="02000503000000020004" pitchFamily="2" charset="0"/>
+                <a:ea typeface="Helvetica Neue" panose="02000503000000020004" pitchFamily="2" charset="0"/>
+                <a:cs typeface="Helvetica Neue" panose="02000503000000020004" pitchFamily="2" charset="0"/>
+              </a:rPr>
+              <a:t>f</a:t>
+            </a:r>
+            <a:r>
+              <a:rPr kumimoji="0" lang="en-US" sz="1400" b="0" i="1" u="none" strike="noStrike" kern="1200" cap="none" spc="0" normalizeH="0" baseline="0" noProof="0" dirty="0">
+                <a:ln>
+                  <a:noFill/>
+                </a:ln>
+                <a:solidFill>
+                  <a:srgbClr val="FFC000"/>
+                </a:solidFill>
+                <a:effectLst/>
+                <a:uLnTx/>
+                <a:uFillTx/>
+                <a:latin typeface="Helvetica Neue" panose="02000503000000020004" pitchFamily="2" charset="0"/>
+                <a:ea typeface="Helvetica Neue" panose="02000503000000020004" pitchFamily="2" charset="0"/>
+                <a:cs typeface="Helvetica Neue" panose="02000503000000020004" pitchFamily="2" charset="0"/>
+              </a:rPr>
+              <a:t xml:space="preserve"> t</a:t>
             </a:r>
           </a:p>
         </p:txBody>
@@ -22969,7 +23410,7 @@
           <p:cNvPr id="36" name="TextBox 35">
             <a:extLst>
               <a:ext uri="{FF2B5EF4-FFF2-40B4-BE49-F238E27FC236}">
-                <a16:creationId xmlns:a16="http://schemas.microsoft.com/office/drawing/2014/main" id="{3A81A480-EF64-094E-825A-8592DAA4C672}"/>
+                <ns2:creationId id="{3A81A480-EF64-094E-825A-8592DAA4C672}"/>
               </a:ext>
             </a:extLst>
           </p:cNvPr>
@@ -23051,7 +23492,7 @@
           <p:cNvPr id="22" name="Straight Connector 21">
             <a:extLst>
               <a:ext uri="{FF2B5EF4-FFF2-40B4-BE49-F238E27FC236}">
-                <a16:creationId xmlns:a16="http://schemas.microsoft.com/office/drawing/2014/main" id="{0C67DA45-6876-7942-9996-48CA0A1696FE}"/>
+                <ns2:creationId id="{0C67DA45-6876-7942-9996-48CA0A1696FE}"/>
               </a:ext>
             </a:extLst>
           </p:cNvPr>
@@ -23094,7 +23535,7 @@
           <p:cNvPr id="15" name="Straight Arrow Connector 14">
             <a:extLst>
               <a:ext uri="{FF2B5EF4-FFF2-40B4-BE49-F238E27FC236}">
-                <a16:creationId xmlns:a16="http://schemas.microsoft.com/office/drawing/2014/main" id="{05289ED1-4679-6543-A669-B23443FD0CD8}"/>
+                <ns2:creationId id="{05289ED1-4679-6543-A669-B23443FD0CD8}"/>
               </a:ext>
             </a:extLst>
           </p:cNvPr>
@@ -23140,7 +23581,7 @@
           <p:cNvPr id="14" name="Rectangle 13">
             <a:extLst>
               <a:ext uri="{FF2B5EF4-FFF2-40B4-BE49-F238E27FC236}">
-                <a16:creationId xmlns:a16="http://schemas.microsoft.com/office/drawing/2014/main" id="{24DFEA8B-B2CC-4557-5832-83CBF458C62D}"/>
+                <ns2:creationId id="{24DFEA8B-B2CC-4557-5832-83CBF458C62D}"/>
               </a:ext>
             </a:extLst>
           </p:cNvPr>
@@ -23199,7 +23640,58 @@
                 <a:ea typeface="Helvetica Neue" panose="02000503000000020004" pitchFamily="2" charset="0"/>
                 <a:cs typeface="Helvetica Neue" panose="02000503000000020004" pitchFamily="2" charset="0"/>
               </a:rPr>
-              <a:t>Wake Speed c_f is a Primitive Constant</a:t>
+              <a:t xml:space="preserve">Wake Speed </a:t>
+            </a:r>
+            <a:r>
+              <a:rPr kumimoji="0" lang="en-US" sz="2000" b="1" i="0" u="none" strike="noStrike" kern="1200" cap="none" spc="0" normalizeH="0" baseline="0" noProof="0" dirty="0">
+                <a:ln>
+                  <a:noFill/>
+                </a:ln>
+                <a:solidFill>
+                  <a:srgbClr val="FF85FF"/>
+                </a:solidFill>
+                <a:effectLst/>
+                <a:uLnTx/>
+                <a:uFillTx/>
+                <a:latin typeface="Helvetica Neue" panose="02000503000000020004" pitchFamily="2" charset="0"/>
+                <a:ea typeface="Helvetica Neue" panose="02000503000000020004" pitchFamily="2" charset="0"/>
+                <a:cs typeface="Helvetica Neue" panose="02000503000000020004" pitchFamily="2" charset="0"/>
+              </a:rPr>
+              <a:t>c</a:t>
+            </a:r>
+            <a:r>
+              <a:rPr kumimoji="0" lang="en-US" sz="1400" b="1" i="0" u="none" strike="noStrike" kern="1200" cap="none" spc="0" normalizeH="0" baseline="-25000" noProof="0" dirty="0">
+                <a:ln>
+                  <a:noFill/>
+                </a:ln>
+                <a:solidFill>
+                  <a:srgbClr val="FF85FF"/>
+                </a:solidFill>
+                <a:effectLst/>
+                <a:uLnTx/>
+                <a:uFillTx/>
+                <a:latin typeface="Helvetica Neue" panose="02000503000000020004" pitchFamily="2" charset="0"/>
+                <a:ea typeface="Helvetica Neue" panose="02000503000000020004" pitchFamily="2" charset="0"/>
+                <a:cs typeface="Helvetica Neue" panose="02000503000000020004" pitchFamily="2" charset="0"/>
+              </a:rPr>
+              <a:t>f</a:t>
+            </a:r>
+            <a:r>
+              <a:rPr kumimoji="0" lang="en-US" sz="2000" b="1" i="0" u="none" strike="noStrike" kern="1200" cap="none" spc="0" normalizeH="0" baseline="0" noProof="0" dirty="0">
+                <a:ln>
+                  <a:noFill/>
+                </a:ln>
+                <a:solidFill>
+                  <a:srgbClr val="FF85FF"/>
+                </a:solidFill>
+                <a:effectLst/>
+                <a:uLnTx/>
+                <a:uFillTx/>
+                <a:latin typeface="Helvetica Neue" panose="02000503000000020004" pitchFamily="2" charset="0"/>
+                <a:ea typeface="Helvetica Neue" panose="02000503000000020004" pitchFamily="2" charset="0"/>
+                <a:cs typeface="Helvetica Neue" panose="02000503000000020004" pitchFamily="2" charset="0"/>
+              </a:rPr>
+              <a:t xml:space="preserve"> is a Primitive Constant</a:t>
             </a:r>
           </a:p>
         </p:txBody>
@@ -23209,7 +23701,7 @@
           <p:cNvPr id="17" name="TextBox 16">
             <a:extLst>
               <a:ext uri="{FF2B5EF4-FFF2-40B4-BE49-F238E27FC236}">
-                <a16:creationId xmlns:a16="http://schemas.microsoft.com/office/drawing/2014/main" id="{F6A93B37-78E4-125D-E0BF-C1EC32C24D2E}"/>
+                <ns2:creationId id="{F6A93B37-78E4-125D-E0BF-C1EC32C24D2E}"/>
               </a:ext>
             </a:extLst>
           </p:cNvPr>
@@ -23274,7 +23766,7 @@
           <p:cNvPr id="19" name="TextBox 18">
             <a:extLst>
               <a:ext uri="{FF2B5EF4-FFF2-40B4-BE49-F238E27FC236}">
-                <a16:creationId xmlns:a16="http://schemas.microsoft.com/office/drawing/2014/main" id="{D1F40738-506F-EAAF-7EBE-CFC9B4FE4D03}"/>
+                <ns2:creationId id="{D1F40738-506F-EAAF-7EBE-CFC9B4FE4D03}"/>
               </a:ext>
             </a:extLst>
           </p:cNvPr>
@@ -23337,7 +23829,7 @@
     </p:spTree>
     <p:extLst>
       <p:ext uri="{BB962C8B-B14F-4D97-AF65-F5344CB8AC3E}">
-        <p14:creationId xmlns:p14="http://schemas.microsoft.com/office/powerpoint/2010/main" val="4241975687"/>
+        <ns3:creationId val="4241975687"/>
       </p:ext>
     </p:extLst>
   </p:cSld>
@@ -23348,7 +23840,7 @@
 </file>
 
 <file path=ppt/slides/slide3.xml><?xml version="1.0" encoding="utf-8"?>
-<p:sld xmlns:a="http://schemas.openxmlformats.org/drawingml/2006/main" xmlns:r="http://schemas.openxmlformats.org/officeDocument/2006/relationships" xmlns:p="http://schemas.openxmlformats.org/presentationml/2006/main">
+<p:sld xmlns:a="http://schemas.openxmlformats.org/drawingml/2006/main" xmlns:ns2="http://schemas.microsoft.com/office/drawing/2014/main" xmlns:ns3="http://schemas.microsoft.com/office/powerpoint/2010/main" xmlns:p="http://schemas.openxmlformats.org/presentationml/2006/main">
   <p:cSld>
     <p:bg>
       <p:bgPr>
@@ -23363,7 +23855,7 @@
         <p:cNvPr id="1" name="">
           <a:extLst>
             <a:ext uri="{FF2B5EF4-FFF2-40B4-BE49-F238E27FC236}">
-              <a16:creationId xmlns:a16="http://schemas.microsoft.com/office/drawing/2014/main" id="{618D555D-7286-B241-E144-DDEC77AD45E3}"/>
+              <ns2:creationId id="{618D555D-7286-B241-E144-DDEC77AD45E3}"/>
             </a:ext>
           </a:extLst>
         </p:cNvPr>
@@ -23383,7 +23875,7 @@
           <p:cNvPr id="5" name="Footer Placeholder 3">
             <a:extLst>
               <a:ext uri="{FF2B5EF4-FFF2-40B4-BE49-F238E27FC236}">
-                <a16:creationId xmlns:a16="http://schemas.microsoft.com/office/drawing/2014/main" id="{614DBC08-8858-F579-1B95-86C501AB042B}"/>
+                <ns2:creationId id="{614DBC08-8858-F579-1B95-86C501AB042B}"/>
               </a:ext>
             </a:extLst>
           </p:cNvPr>
@@ -23545,7 +24037,7 @@
           <p:cNvPr id="6" name="Group 5">
             <a:extLst>
               <a:ext uri="{FF2B5EF4-FFF2-40B4-BE49-F238E27FC236}">
-                <a16:creationId xmlns:a16="http://schemas.microsoft.com/office/drawing/2014/main" id="{17811428-EDBA-0366-BE63-E3E25023C8EC}"/>
+                <ns2:creationId id="{17811428-EDBA-0366-BE63-E3E25023C8EC}"/>
               </a:ext>
             </a:extLst>
           </p:cNvPr>
@@ -23565,7 +24057,7 @@
             <p:cNvPr id="3" name="Straight Arrow Connector 2">
               <a:extLst>
                 <a:ext uri="{FF2B5EF4-FFF2-40B4-BE49-F238E27FC236}">
-                  <a16:creationId xmlns:a16="http://schemas.microsoft.com/office/drawing/2014/main" id="{D482C6FD-3801-AF2C-0D9C-BDC9F781A9F9}"/>
+                  <ns2:creationId id="{D482C6FD-3801-AF2C-0D9C-BDC9F781A9F9}"/>
                 </a:ext>
               </a:extLst>
             </p:cNvPr>
@@ -23609,7 +24101,7 @@
             <p:cNvPr id="8" name="Straight Arrow Connector 7">
               <a:extLst>
                 <a:ext uri="{FF2B5EF4-FFF2-40B4-BE49-F238E27FC236}">
-                  <a16:creationId xmlns:a16="http://schemas.microsoft.com/office/drawing/2014/main" id="{F8DD0551-F57F-FC8B-CDFA-54E4DF3D076B}"/>
+                  <ns2:creationId id="{F8DD0551-F57F-FC8B-CDFA-54E4DF3D076B}"/>
                 </a:ext>
               </a:extLst>
             </p:cNvPr>
@@ -23653,7 +24145,7 @@
             <p:cNvPr id="12" name="TextBox 11">
               <a:extLst>
                 <a:ext uri="{FF2B5EF4-FFF2-40B4-BE49-F238E27FC236}">
-                  <a16:creationId xmlns:a16="http://schemas.microsoft.com/office/drawing/2014/main" id="{2419E9DF-2DD3-3506-BE3B-E485BF80EDAC}"/>
+                  <ns2:creationId id="{2419E9DF-2DD3-3506-BE3B-E485BF80EDAC}"/>
                 </a:ext>
               </a:extLst>
             </p:cNvPr>
@@ -23718,7 +24210,7 @@
             <p:cNvPr id="13" name="TextBox 12">
               <a:extLst>
                 <a:ext uri="{FF2B5EF4-FFF2-40B4-BE49-F238E27FC236}">
-                  <a16:creationId xmlns:a16="http://schemas.microsoft.com/office/drawing/2014/main" id="{93B24559-A789-4B90-E180-1E0D72CE317E}"/>
+                  <ns2:creationId id="{93B24559-A789-4B90-E180-1E0D72CE317E}"/>
                 </a:ext>
               </a:extLst>
             </p:cNvPr>
@@ -23820,7 +24312,7 @@
           <p:cNvPr id="23" name="Oval 22">
             <a:extLst>
               <a:ext uri="{FF2B5EF4-FFF2-40B4-BE49-F238E27FC236}">
-                <a16:creationId xmlns:a16="http://schemas.microsoft.com/office/drawing/2014/main" id="{61A13369-24B9-E21B-05B9-329B5FF74DB7}"/>
+                <ns2:creationId id="{61A13369-24B9-E21B-05B9-329B5FF74DB7}"/>
               </a:ext>
             </a:extLst>
           </p:cNvPr>
@@ -23904,7 +24396,7 @@
           <p:cNvPr id="27" name="Oval 26">
             <a:extLst>
               <a:ext uri="{FF2B5EF4-FFF2-40B4-BE49-F238E27FC236}">
-                <a16:creationId xmlns:a16="http://schemas.microsoft.com/office/drawing/2014/main" id="{F2B3E963-4F4B-8173-AE7C-E7942A9E266B}"/>
+                <ns2:creationId id="{F2B3E963-4F4B-8173-AE7C-E7942A9E266B}"/>
               </a:ext>
             </a:extLst>
           </p:cNvPr>
@@ -23988,7 +24480,7 @@
           <p:cNvPr id="28" name="Oval 27">
             <a:extLst>
               <a:ext uri="{FF2B5EF4-FFF2-40B4-BE49-F238E27FC236}">
-                <a16:creationId xmlns:a16="http://schemas.microsoft.com/office/drawing/2014/main" id="{9ADB633C-4072-1C73-DADA-398777D0A7CD}"/>
+                <ns2:creationId id="{9ADB633C-4072-1C73-DADA-398777D0A7CD}"/>
               </a:ext>
             </a:extLst>
           </p:cNvPr>
@@ -24072,7 +24564,7 @@
           <p:cNvPr id="29" name="Oval 28">
             <a:extLst>
               <a:ext uri="{FF2B5EF4-FFF2-40B4-BE49-F238E27FC236}">
-                <a16:creationId xmlns:a16="http://schemas.microsoft.com/office/drawing/2014/main" id="{F82B7B38-EA39-2CF9-201C-54B73DBBD4EA}"/>
+                <ns2:creationId id="{F82B7B38-EA39-2CF9-201C-54B73DBBD4EA}"/>
               </a:ext>
             </a:extLst>
           </p:cNvPr>
@@ -24156,7 +24648,7 @@
           <p:cNvPr id="30" name="Oval 29">
             <a:extLst>
               <a:ext uri="{FF2B5EF4-FFF2-40B4-BE49-F238E27FC236}">
-                <a16:creationId xmlns:a16="http://schemas.microsoft.com/office/drawing/2014/main" id="{686BDBE9-0138-6C28-BFAF-00EA8DCD973D}"/>
+                <ns2:creationId id="{686BDBE9-0138-6C28-BFAF-00EA8DCD973D}"/>
               </a:ext>
             </a:extLst>
           </p:cNvPr>
@@ -24240,7 +24732,7 @@
           <p:cNvPr id="4" name="Straight Connector 3">
             <a:extLst>
               <a:ext uri="{FF2B5EF4-FFF2-40B4-BE49-F238E27FC236}">
-                <a16:creationId xmlns:a16="http://schemas.microsoft.com/office/drawing/2014/main" id="{D0AC705D-BF37-4542-CD33-8265C0D398AC}"/>
+                <ns2:creationId id="{D0AC705D-BF37-4542-CD33-8265C0D398AC}"/>
               </a:ext>
             </a:extLst>
           </p:cNvPr>
@@ -24283,7 +24775,7 @@
           <p:cNvPr id="18" name="Oval 17">
             <a:extLst>
               <a:ext uri="{FF2B5EF4-FFF2-40B4-BE49-F238E27FC236}">
-                <a16:creationId xmlns:a16="http://schemas.microsoft.com/office/drawing/2014/main" id="{5CEE4D57-2D48-3E46-8211-494134A5C094}"/>
+                <ns2:creationId id="{5CEE4D57-2D48-3E46-8211-494134A5C094}"/>
               </a:ext>
             </a:extLst>
           </p:cNvPr>
@@ -24366,7 +24858,7 @@
           <p:cNvPr id="11" name="Group 10">
             <a:extLst>
               <a:ext uri="{FF2B5EF4-FFF2-40B4-BE49-F238E27FC236}">
-                <a16:creationId xmlns:a16="http://schemas.microsoft.com/office/drawing/2014/main" id="{D24EBF2A-B7A3-E7EB-6313-BB50CF2D3A83}"/>
+                <ns2:creationId id="{D24EBF2A-B7A3-E7EB-6313-BB50CF2D3A83}"/>
               </a:ext>
             </a:extLst>
           </p:cNvPr>
@@ -24386,7 +24878,7 @@
             <p:cNvPr id="24" name="Straight Arrow Connector 23">
               <a:extLst>
                 <a:ext uri="{FF2B5EF4-FFF2-40B4-BE49-F238E27FC236}">
-                  <a16:creationId xmlns:a16="http://schemas.microsoft.com/office/drawing/2014/main" id="{9C627068-AD0C-E2DC-60AF-7257BB046983}"/>
+                  <ns2:creationId id="{9C627068-AD0C-E2DC-60AF-7257BB046983}"/>
                 </a:ext>
               </a:extLst>
             </p:cNvPr>
@@ -24431,7 +24923,7 @@
             <p:cNvPr id="10" name="TextBox 9">
               <a:extLst>
                 <a:ext uri="{FF2B5EF4-FFF2-40B4-BE49-F238E27FC236}">
-                  <a16:creationId xmlns:a16="http://schemas.microsoft.com/office/drawing/2014/main" id="{D692B828-D19F-3AA3-05F9-AF2DE3D5C9FC}"/>
+                  <ns2:creationId id="{D692B828-D19F-3AA3-05F9-AF2DE3D5C9FC}"/>
                 </a:ext>
               </a:extLst>
             </p:cNvPr>
@@ -24486,7 +24978,41 @@
                   <a:ea typeface="Helvetica Neue" panose="02000503000000020004" pitchFamily="2" charset="0"/>
                   <a:cs typeface="Helvetica Neue" panose="02000503000000020004" pitchFamily="2" charset="0"/>
                 </a:rPr>
-                <a:t>v &lt; c_f</a:t>
+                <a:t xml:space="preserve">v &lt; </a:t>
+              </a:r>
+              <a:r>
+                <a:rPr kumimoji="0" lang="en-US" sz="1400" b="0" i="1" u="none" strike="noStrike" kern="1200" cap="none" spc="0" normalizeH="0" baseline="0" noProof="0" dirty="0">
+                  <a:ln>
+                    <a:noFill/>
+                  </a:ln>
+                  <a:solidFill>
+                    <a:prstClr val="white"/>
+                  </a:solidFill>
+                  <a:effectLst/>
+                  <a:uLnTx/>
+                  <a:uFillTx/>
+                  <a:latin typeface="Helvetica Neue" panose="02000503000000020004" pitchFamily="2" charset="0"/>
+                  <a:ea typeface="Helvetica Neue" panose="02000503000000020004" pitchFamily="2" charset="0"/>
+                  <a:cs typeface="Helvetica Neue" panose="02000503000000020004" pitchFamily="2" charset="0"/>
+                </a:rPr>
+                <a:t>c</a:t>
+              </a:r>
+              <a:r>
+                <a:rPr kumimoji="0" lang="en-US" sz="980" b="0" i="1" u="none" strike="noStrike" kern="1200" cap="none" spc="0" normalizeH="0" baseline="-25000" noProof="0" dirty="0">
+                  <a:ln>
+                    <a:noFill/>
+                  </a:ln>
+                  <a:solidFill>
+                    <a:prstClr val="white"/>
+                  </a:solidFill>
+                  <a:effectLst/>
+                  <a:uLnTx/>
+                  <a:uFillTx/>
+                  <a:latin typeface="Helvetica Neue" panose="02000503000000020004" pitchFamily="2" charset="0"/>
+                  <a:ea typeface="Helvetica Neue" panose="02000503000000020004" pitchFamily="2" charset="0"/>
+                  <a:cs typeface="Helvetica Neue" panose="02000503000000020004" pitchFamily="2" charset="0"/>
+                </a:rPr>
+                <a:t>f</a:t>
               </a:r>
             </a:p>
           </p:txBody>
@@ -24497,7 +25023,7 @@
           <p:cNvPr id="31" name="TextBox 30">
             <a:extLst>
               <a:ext uri="{FF2B5EF4-FFF2-40B4-BE49-F238E27FC236}">
-                <a16:creationId xmlns:a16="http://schemas.microsoft.com/office/drawing/2014/main" id="{12D2397C-9CE3-3A8A-1558-56A5A0738C36}"/>
+                <ns2:creationId id="{12D2397C-9CE3-3A8A-1558-56A5A0738C36}"/>
               </a:ext>
             </a:extLst>
           </p:cNvPr>
@@ -24555,7 +25081,58 @@
                 <a:ea typeface="Helvetica Neue" panose="02000503000000020004" pitchFamily="2" charset="0"/>
                 <a:cs typeface="Helvetica Neue" panose="02000503000000020004" pitchFamily="2" charset="0"/>
               </a:rPr>
-              <a:t>r = c_f t</a:t>
+              <a:t xml:space="preserve">r = </a:t>
+            </a:r>
+            <a:r>
+              <a:rPr kumimoji="0" lang="en-US" sz="1400" b="0" i="1" u="none" strike="noStrike" kern="1200" cap="none" spc="0" normalizeH="0" baseline="0" noProof="0" dirty="0">
+                <a:ln>
+                  <a:noFill/>
+                </a:ln>
+                <a:solidFill>
+                  <a:srgbClr val="FFC000"/>
+                </a:solidFill>
+                <a:effectLst/>
+                <a:uLnTx/>
+                <a:uFillTx/>
+                <a:latin typeface="Helvetica Neue" panose="02000503000000020004" pitchFamily="2" charset="0"/>
+                <a:ea typeface="Helvetica Neue" panose="02000503000000020004" pitchFamily="2" charset="0"/>
+                <a:cs typeface="Helvetica Neue" panose="02000503000000020004" pitchFamily="2" charset="0"/>
+              </a:rPr>
+              <a:t>c</a:t>
+            </a:r>
+            <a:r>
+              <a:rPr kumimoji="0" lang="en-US" sz="980" b="0" i="1" u="none" strike="noStrike" kern="1200" cap="none" spc="0" normalizeH="0" baseline="-25000" noProof="0" dirty="0">
+                <a:ln>
+                  <a:noFill/>
+                </a:ln>
+                <a:solidFill>
+                  <a:srgbClr val="FFC000"/>
+                </a:solidFill>
+                <a:effectLst/>
+                <a:uLnTx/>
+                <a:uFillTx/>
+                <a:latin typeface="Helvetica Neue" panose="02000503000000020004" pitchFamily="2" charset="0"/>
+                <a:ea typeface="Helvetica Neue" panose="02000503000000020004" pitchFamily="2" charset="0"/>
+                <a:cs typeface="Helvetica Neue" panose="02000503000000020004" pitchFamily="2" charset="0"/>
+              </a:rPr>
+              <a:t>f</a:t>
+            </a:r>
+            <a:r>
+              <a:rPr kumimoji="0" lang="en-US" sz="1400" b="0" i="1" u="none" strike="noStrike" kern="1200" cap="none" spc="0" normalizeH="0" baseline="0" noProof="0" dirty="0">
+                <a:ln>
+                  <a:noFill/>
+                </a:ln>
+                <a:solidFill>
+                  <a:srgbClr val="FFC000"/>
+                </a:solidFill>
+                <a:effectLst/>
+                <a:uLnTx/>
+                <a:uFillTx/>
+                <a:latin typeface="Helvetica Neue" panose="02000503000000020004" pitchFamily="2" charset="0"/>
+                <a:ea typeface="Helvetica Neue" panose="02000503000000020004" pitchFamily="2" charset="0"/>
+                <a:cs typeface="Helvetica Neue" panose="02000503000000020004" pitchFamily="2" charset="0"/>
+              </a:rPr>
+              <a:t xml:space="preserve"> t</a:t>
             </a:r>
           </a:p>
         </p:txBody>
@@ -24565,7 +25142,7 @@
           <p:cNvPr id="36" name="TextBox 35">
             <a:extLst>
               <a:ext uri="{FF2B5EF4-FFF2-40B4-BE49-F238E27FC236}">
-                <a16:creationId xmlns:a16="http://schemas.microsoft.com/office/drawing/2014/main" id="{2FFE4CF6-AAAC-06EA-8AB8-998E05647728}"/>
+                <ns2:creationId id="{2FFE4CF6-AAAC-06EA-8AB8-998E05647728}"/>
               </a:ext>
             </a:extLst>
           </p:cNvPr>
@@ -24647,7 +25224,7 @@
           <p:cNvPr id="22" name="Straight Connector 21">
             <a:extLst>
               <a:ext uri="{FF2B5EF4-FFF2-40B4-BE49-F238E27FC236}">
-                <a16:creationId xmlns:a16="http://schemas.microsoft.com/office/drawing/2014/main" id="{2F9013F0-6C27-F3C3-FDE3-FF0AA12CA620}"/>
+                <ns2:creationId id="{2F9013F0-6C27-F3C3-FDE3-FF0AA12CA620}"/>
               </a:ext>
             </a:extLst>
           </p:cNvPr>
@@ -24690,7 +25267,7 @@
           <p:cNvPr id="15" name="Straight Arrow Connector 14">
             <a:extLst>
               <a:ext uri="{FF2B5EF4-FFF2-40B4-BE49-F238E27FC236}">
-                <a16:creationId xmlns:a16="http://schemas.microsoft.com/office/drawing/2014/main" id="{59CD0CED-2A06-8AB7-8A69-21FAC5EC4A4F}"/>
+                <ns2:creationId id="{59CD0CED-2A06-8AB7-8A69-21FAC5EC4A4F}"/>
               </a:ext>
             </a:extLst>
           </p:cNvPr>
@@ -24736,7 +25313,7 @@
           <p:cNvPr id="32" name="Straight Arrow Connector 31">
             <a:extLst>
               <a:ext uri="{FF2B5EF4-FFF2-40B4-BE49-F238E27FC236}">
-                <a16:creationId xmlns:a16="http://schemas.microsoft.com/office/drawing/2014/main" id="{BCC5A9F1-9339-0CF6-A18E-4B7BE46AB529}"/>
+                <ns2:creationId id="{BCC5A9F1-9339-0CF6-A18E-4B7BE46AB529}"/>
               </a:ext>
             </a:extLst>
           </p:cNvPr>
@@ -24782,7 +25359,7 @@
           <p:cNvPr id="35" name="Straight Arrow Connector 34">
             <a:extLst>
               <a:ext uri="{FF2B5EF4-FFF2-40B4-BE49-F238E27FC236}">
-                <a16:creationId xmlns:a16="http://schemas.microsoft.com/office/drawing/2014/main" id="{8E4A4C4F-C09E-5B89-67FD-259D584337FE}"/>
+                <ns2:creationId id="{8E4A4C4F-C09E-5B89-67FD-259D584337FE}"/>
               </a:ext>
             </a:extLst>
           </p:cNvPr>
@@ -24828,7 +25405,7 @@
           <p:cNvPr id="39" name="Straight Arrow Connector 38">
             <a:extLst>
               <a:ext uri="{FF2B5EF4-FFF2-40B4-BE49-F238E27FC236}">
-                <a16:creationId xmlns:a16="http://schemas.microsoft.com/office/drawing/2014/main" id="{D4742DE8-0901-2B65-C6B7-3A1BE131F28D}"/>
+                <ns2:creationId id="{D4742DE8-0901-2B65-C6B7-3A1BE131F28D}"/>
               </a:ext>
             </a:extLst>
           </p:cNvPr>
@@ -24874,7 +25451,7 @@
           <p:cNvPr id="47" name="Straight Arrow Connector 46">
             <a:extLst>
               <a:ext uri="{FF2B5EF4-FFF2-40B4-BE49-F238E27FC236}">
-                <a16:creationId xmlns:a16="http://schemas.microsoft.com/office/drawing/2014/main" id="{1D9F791F-D5A7-688F-041A-11963370907B}"/>
+                <ns2:creationId id="{1D9F791F-D5A7-688F-041A-11963370907B}"/>
               </a:ext>
             </a:extLst>
           </p:cNvPr>
@@ -24920,7 +25497,7 @@
           <p:cNvPr id="9" name="TextBox 8">
             <a:extLst>
               <a:ext uri="{FF2B5EF4-FFF2-40B4-BE49-F238E27FC236}">
-                <a16:creationId xmlns:a16="http://schemas.microsoft.com/office/drawing/2014/main" id="{349C01A4-7FD7-1FD3-430A-5950B62E2AB0}"/>
+                <ns2:creationId id="{349C01A4-7FD7-1FD3-430A-5950B62E2AB0}"/>
               </a:ext>
             </a:extLst>
           </p:cNvPr>
@@ -25002,7 +25579,7 @@
           <p:cNvPr id="14" name="Rectangle 13">
             <a:extLst>
               <a:ext uri="{FF2B5EF4-FFF2-40B4-BE49-F238E27FC236}">
-                <a16:creationId xmlns:a16="http://schemas.microsoft.com/office/drawing/2014/main" id="{55CC6FCD-E4CC-D5E1-7E8F-917869655222}"/>
+                <ns2:creationId id="{55CC6FCD-E4CC-D5E1-7E8F-917869655222}"/>
               </a:ext>
             </a:extLst>
           </p:cNvPr>
@@ -25061,7 +25638,58 @@
                 <a:ea typeface="Helvetica Neue" panose="02000503000000020004" pitchFamily="2" charset="0"/>
                 <a:cs typeface="Helvetica Neue" panose="02000503000000020004" pitchFamily="2" charset="0"/>
               </a:rPr>
-              <a:t>Wake Speed c_f is a Primitive Constant</a:t>
+              <a:t xml:space="preserve">Wake Speed </a:t>
+            </a:r>
+            <a:r>
+              <a:rPr kumimoji="0" lang="en-US" sz="2000" b="1" i="0" u="none" strike="noStrike" kern="1200" cap="none" spc="0" normalizeH="0" baseline="0" noProof="0" dirty="0">
+                <a:ln>
+                  <a:noFill/>
+                </a:ln>
+                <a:solidFill>
+                  <a:srgbClr val="FF85FF"/>
+                </a:solidFill>
+                <a:effectLst/>
+                <a:uLnTx/>
+                <a:uFillTx/>
+                <a:latin typeface="Helvetica Neue" panose="02000503000000020004" pitchFamily="2" charset="0"/>
+                <a:ea typeface="Helvetica Neue" panose="02000503000000020004" pitchFamily="2" charset="0"/>
+                <a:cs typeface="Helvetica Neue" panose="02000503000000020004" pitchFamily="2" charset="0"/>
+              </a:rPr>
+              <a:t>c</a:t>
+            </a:r>
+            <a:r>
+              <a:rPr kumimoji="0" lang="en-US" sz="1400" b="1" i="0" u="none" strike="noStrike" kern="1200" cap="none" spc="0" normalizeH="0" baseline="-25000" noProof="0" dirty="0">
+                <a:ln>
+                  <a:noFill/>
+                </a:ln>
+                <a:solidFill>
+                  <a:srgbClr val="FF85FF"/>
+                </a:solidFill>
+                <a:effectLst/>
+                <a:uLnTx/>
+                <a:uFillTx/>
+                <a:latin typeface="Helvetica Neue" panose="02000503000000020004" pitchFamily="2" charset="0"/>
+                <a:ea typeface="Helvetica Neue" panose="02000503000000020004" pitchFamily="2" charset="0"/>
+                <a:cs typeface="Helvetica Neue" panose="02000503000000020004" pitchFamily="2" charset="0"/>
+              </a:rPr>
+              <a:t>f</a:t>
+            </a:r>
+            <a:r>
+              <a:rPr kumimoji="0" lang="en-US" sz="2000" b="1" i="0" u="none" strike="noStrike" kern="1200" cap="none" spc="0" normalizeH="0" baseline="0" noProof="0" dirty="0">
+                <a:ln>
+                  <a:noFill/>
+                </a:ln>
+                <a:solidFill>
+                  <a:srgbClr val="FF85FF"/>
+                </a:solidFill>
+                <a:effectLst/>
+                <a:uLnTx/>
+                <a:uFillTx/>
+                <a:latin typeface="Helvetica Neue" panose="02000503000000020004" pitchFamily="2" charset="0"/>
+                <a:ea typeface="Helvetica Neue" panose="02000503000000020004" pitchFamily="2" charset="0"/>
+                <a:cs typeface="Helvetica Neue" panose="02000503000000020004" pitchFamily="2" charset="0"/>
+              </a:rPr>
+              <a:t xml:space="preserve"> is a Primitive Constant</a:t>
             </a:r>
           </a:p>
         </p:txBody>
@@ -25071,7 +25699,7 @@
           <p:cNvPr id="16" name="TextBox 15">
             <a:extLst>
               <a:ext uri="{FF2B5EF4-FFF2-40B4-BE49-F238E27FC236}">
-                <a16:creationId xmlns:a16="http://schemas.microsoft.com/office/drawing/2014/main" id="{165EF7AF-4C2A-3413-7653-A4678D7A12B0}"/>
+                <ns2:creationId id="{165EF7AF-4C2A-3413-7653-A4678D7A12B0}"/>
               </a:ext>
             </a:extLst>
           </p:cNvPr>
@@ -25126,7 +25754,41 @@
                 <a:ea typeface="Helvetica Neue" panose="02000503000000020004" pitchFamily="2" charset="0"/>
                 <a:cs typeface="Helvetica Neue" panose="02000503000000020004" pitchFamily="2" charset="0"/>
               </a:rPr>
-              <a:t>Architrino on Linear Path with Velocity v &lt; c_f</a:t>
+              <a:t xml:space="preserve">Architrino on Linear Path with Velocity v &lt; </a:t>
+            </a:r>
+            <a:r>
+              <a:rPr kumimoji="0" lang="en-US" sz="3200" b="1" i="0" u="none" strike="noStrike" kern="1200" cap="none" spc="0" normalizeH="0" baseline="0" noProof="0" dirty="0">
+                <a:ln>
+                  <a:noFill/>
+                </a:ln>
+                <a:solidFill>
+                  <a:prstClr val="white"/>
+                </a:solidFill>
+                <a:effectLst/>
+                <a:uLnTx/>
+                <a:uFillTx/>
+                <a:latin typeface="Helvetica Neue" panose="02000503000000020004" pitchFamily="2" charset="0"/>
+                <a:ea typeface="Helvetica Neue" panose="02000503000000020004" pitchFamily="2" charset="0"/>
+                <a:cs typeface="Helvetica Neue" panose="02000503000000020004" pitchFamily="2" charset="0"/>
+              </a:rPr>
+              <a:t>c</a:t>
+            </a:r>
+            <a:r>
+              <a:rPr kumimoji="0" lang="en-US" sz="2240" b="1" i="0" u="none" strike="noStrike" kern="1200" cap="none" spc="0" normalizeH="0" baseline="-25000" noProof="0" dirty="0">
+                <a:ln>
+                  <a:noFill/>
+                </a:ln>
+                <a:solidFill>
+                  <a:prstClr val="white"/>
+                </a:solidFill>
+                <a:effectLst/>
+                <a:uLnTx/>
+                <a:uFillTx/>
+                <a:latin typeface="Helvetica Neue" panose="02000503000000020004" pitchFamily="2" charset="0"/>
+                <a:ea typeface="Helvetica Neue" panose="02000503000000020004" pitchFamily="2" charset="0"/>
+                <a:cs typeface="Helvetica Neue" panose="02000503000000020004" pitchFamily="2" charset="0"/>
+              </a:rPr>
+              <a:t>f</a:t>
             </a:r>
           </a:p>
         </p:txBody>
@@ -25136,7 +25798,7 @@
           <p:cNvPr id="17" name="TextBox 16">
             <a:extLst>
               <a:ext uri="{FF2B5EF4-FFF2-40B4-BE49-F238E27FC236}">
-                <a16:creationId xmlns:a16="http://schemas.microsoft.com/office/drawing/2014/main" id="{8221C174-AABC-987E-E052-795F476EAF22}"/>
+                <ns2:creationId id="{8221C174-AABC-987E-E052-795F476EAF22}"/>
               </a:ext>
             </a:extLst>
           </p:cNvPr>
@@ -25263,7 +25925,58 @@
                 <a:ea typeface="Helvetica Neue" panose="02000503000000020004" pitchFamily="2" charset="0"/>
                 <a:cs typeface="Helvetica Neue" panose="02000503000000020004" pitchFamily="2" charset="0"/>
               </a:rPr>
-              <a:t>When v &lt; c_f the architrino does not intercept its own wake, so this is the partner-only regime.</a:t>
+              <a:t xml:space="preserve">When v &lt; </a:t>
+            </a:r>
+            <a:r>
+              <a:rPr kumimoji="0" lang="en-US" sz="1600" b="0" i="0" u="none" strike="noStrike" kern="1200" cap="none" spc="0" normalizeH="0" baseline="0" noProof="0" dirty="0">
+                <a:ln>
+                  <a:noFill/>
+                </a:ln>
+                <a:solidFill>
+                  <a:prstClr val="white"/>
+                </a:solidFill>
+                <a:effectLst/>
+                <a:uLnTx/>
+                <a:uFillTx/>
+                <a:latin typeface="Helvetica Neue" panose="02000503000000020004" pitchFamily="2" charset="0"/>
+                <a:ea typeface="Helvetica Neue" panose="02000503000000020004" pitchFamily="2" charset="0"/>
+                <a:cs typeface="Helvetica Neue" panose="02000503000000020004" pitchFamily="2" charset="0"/>
+              </a:rPr>
+              <a:t>c</a:t>
+            </a:r>
+            <a:r>
+              <a:rPr kumimoji="0" lang="en-US" sz="1120" b="0" i="0" u="none" strike="noStrike" kern="1200" cap="none" spc="0" normalizeH="0" baseline="-25000" noProof="0" dirty="0">
+                <a:ln>
+                  <a:noFill/>
+                </a:ln>
+                <a:solidFill>
+                  <a:prstClr val="white"/>
+                </a:solidFill>
+                <a:effectLst/>
+                <a:uLnTx/>
+                <a:uFillTx/>
+                <a:latin typeface="Helvetica Neue" panose="02000503000000020004" pitchFamily="2" charset="0"/>
+                <a:ea typeface="Helvetica Neue" panose="02000503000000020004" pitchFamily="2" charset="0"/>
+                <a:cs typeface="Helvetica Neue" panose="02000503000000020004" pitchFamily="2" charset="0"/>
+              </a:rPr>
+              <a:t>f</a:t>
+            </a:r>
+            <a:r>
+              <a:rPr kumimoji="0" lang="en-US" sz="1600" b="0" i="0" u="none" strike="noStrike" kern="1200" cap="none" spc="0" normalizeH="0" baseline="0" noProof="0" dirty="0">
+                <a:ln>
+                  <a:noFill/>
+                </a:ln>
+                <a:solidFill>
+                  <a:prstClr val="white"/>
+                </a:solidFill>
+                <a:effectLst/>
+                <a:uLnTx/>
+                <a:uFillTx/>
+                <a:latin typeface="Helvetica Neue" panose="02000503000000020004" pitchFamily="2" charset="0"/>
+                <a:ea typeface="Helvetica Neue" panose="02000503000000020004" pitchFamily="2" charset="0"/>
+                <a:cs typeface="Helvetica Neue" panose="02000503000000020004" pitchFamily="2" charset="0"/>
+              </a:rPr>
+              <a:t xml:space="preserve"> the architrino does not intercept its own wake, so this is the partner-only regime.</a:t>
             </a:r>
           </a:p>
         </p:txBody>
@@ -25271,7 +25984,7 @@
     </p:spTree>
     <p:extLst>
       <p:ext uri="{BB962C8B-B14F-4D97-AF65-F5344CB8AC3E}">
-        <p14:creationId xmlns:p14="http://schemas.microsoft.com/office/powerpoint/2010/main" val="1156335298"/>
+        <ns3:creationId val="1156335298"/>
       </p:ext>
     </p:extLst>
   </p:cSld>
@@ -25282,7 +25995,7 @@
 </file>
 
 <file path=ppt/slides/slide4.xml><?xml version="1.0" encoding="utf-8"?>
-<p:sld xmlns:a="http://schemas.openxmlformats.org/drawingml/2006/main" xmlns:r="http://schemas.openxmlformats.org/officeDocument/2006/relationships" xmlns:p="http://schemas.openxmlformats.org/presentationml/2006/main">
+<p:sld xmlns:a="http://schemas.openxmlformats.org/drawingml/2006/main" xmlns:ns2="http://schemas.microsoft.com/office/drawing/2014/main" xmlns:ns3="http://schemas.microsoft.com/office/powerpoint/2010/main" xmlns:p="http://schemas.openxmlformats.org/presentationml/2006/main">
   <p:cSld>
     <p:bg>
       <p:bgPr>
@@ -25297,7 +26010,7 @@
         <p:cNvPr id="1" name="">
           <a:extLst>
             <a:ext uri="{FF2B5EF4-FFF2-40B4-BE49-F238E27FC236}">
-              <a16:creationId xmlns:a16="http://schemas.microsoft.com/office/drawing/2014/main" id="{14568406-B066-AEBE-C74B-068160974652}"/>
+              <ns2:creationId id="{14568406-B066-AEBE-C74B-068160974652}"/>
             </a:ext>
           </a:extLst>
         </p:cNvPr>
@@ -25317,7 +26030,7 @@
           <p:cNvPr id="5" name="Footer Placeholder 3">
             <a:extLst>
               <a:ext uri="{FF2B5EF4-FFF2-40B4-BE49-F238E27FC236}">
-                <a16:creationId xmlns:a16="http://schemas.microsoft.com/office/drawing/2014/main" id="{27CEA6F2-4AF1-97D8-38AC-41B557BE51CF}"/>
+                <ns2:creationId id="{27CEA6F2-4AF1-97D8-38AC-41B557BE51CF}"/>
               </a:ext>
             </a:extLst>
           </p:cNvPr>
@@ -25479,7 +26192,7 @@
           <p:cNvPr id="6" name="Group 5">
             <a:extLst>
               <a:ext uri="{FF2B5EF4-FFF2-40B4-BE49-F238E27FC236}">
-                <a16:creationId xmlns:a16="http://schemas.microsoft.com/office/drawing/2014/main" id="{C81263DC-661D-BD50-5933-E8227696F8DE}"/>
+                <ns2:creationId id="{C81263DC-661D-BD50-5933-E8227696F8DE}"/>
               </a:ext>
             </a:extLst>
           </p:cNvPr>
@@ -25499,7 +26212,7 @@
             <p:cNvPr id="3" name="Straight Arrow Connector 2">
               <a:extLst>
                 <a:ext uri="{FF2B5EF4-FFF2-40B4-BE49-F238E27FC236}">
-                  <a16:creationId xmlns:a16="http://schemas.microsoft.com/office/drawing/2014/main" id="{8B149F79-E249-261E-9112-BF1D70D76419}"/>
+                  <ns2:creationId id="{8B149F79-E249-261E-9112-BF1D70D76419}"/>
                 </a:ext>
               </a:extLst>
             </p:cNvPr>
@@ -25543,7 +26256,7 @@
             <p:cNvPr id="8" name="Straight Arrow Connector 7">
               <a:extLst>
                 <a:ext uri="{FF2B5EF4-FFF2-40B4-BE49-F238E27FC236}">
-                  <a16:creationId xmlns:a16="http://schemas.microsoft.com/office/drawing/2014/main" id="{259C9B9C-0329-E856-17CB-C966D0778D39}"/>
+                  <ns2:creationId id="{259C9B9C-0329-E856-17CB-C966D0778D39}"/>
                 </a:ext>
               </a:extLst>
             </p:cNvPr>
@@ -25587,7 +26300,7 @@
             <p:cNvPr id="12" name="TextBox 11">
               <a:extLst>
                 <a:ext uri="{FF2B5EF4-FFF2-40B4-BE49-F238E27FC236}">
-                  <a16:creationId xmlns:a16="http://schemas.microsoft.com/office/drawing/2014/main" id="{7C27133D-1A03-8C4F-53C4-564B9AE5C189}"/>
+                  <ns2:creationId id="{7C27133D-1A03-8C4F-53C4-564B9AE5C189}"/>
                 </a:ext>
               </a:extLst>
             </p:cNvPr>
@@ -25652,7 +26365,7 @@
             <p:cNvPr id="13" name="TextBox 12">
               <a:extLst>
                 <a:ext uri="{FF2B5EF4-FFF2-40B4-BE49-F238E27FC236}">
-                  <a16:creationId xmlns:a16="http://schemas.microsoft.com/office/drawing/2014/main" id="{0F3C3A2E-72E6-5B26-7E8C-2A2E59D8C3F6}"/>
+                  <ns2:creationId id="{0F3C3A2E-72E6-5B26-7E8C-2A2E59D8C3F6}"/>
                 </a:ext>
               </a:extLst>
             </p:cNvPr>
@@ -25754,7 +26467,7 @@
           <p:cNvPr id="23" name="Oval 22">
             <a:extLst>
               <a:ext uri="{FF2B5EF4-FFF2-40B4-BE49-F238E27FC236}">
-                <a16:creationId xmlns:a16="http://schemas.microsoft.com/office/drawing/2014/main" id="{F069ACCF-49B1-2004-B9BA-C32EA1E82492}"/>
+                <ns2:creationId id="{F069ACCF-49B1-2004-B9BA-C32EA1E82492}"/>
               </a:ext>
             </a:extLst>
           </p:cNvPr>
@@ -25838,7 +26551,7 @@
           <p:cNvPr id="27" name="Oval 26">
             <a:extLst>
               <a:ext uri="{FF2B5EF4-FFF2-40B4-BE49-F238E27FC236}">
-                <a16:creationId xmlns:a16="http://schemas.microsoft.com/office/drawing/2014/main" id="{A2120CF2-66F6-E863-1722-E1EBC99EB320}"/>
+                <ns2:creationId id="{A2120CF2-66F6-E863-1722-E1EBC99EB320}"/>
               </a:ext>
             </a:extLst>
           </p:cNvPr>
@@ -25922,7 +26635,7 @@
           <p:cNvPr id="28" name="Oval 27">
             <a:extLst>
               <a:ext uri="{FF2B5EF4-FFF2-40B4-BE49-F238E27FC236}">
-                <a16:creationId xmlns:a16="http://schemas.microsoft.com/office/drawing/2014/main" id="{2CF23E24-ED96-772A-8248-1491441DB146}"/>
+                <ns2:creationId id="{2CF23E24-ED96-772A-8248-1491441DB146}"/>
               </a:ext>
             </a:extLst>
           </p:cNvPr>
@@ -26006,7 +26719,7 @@
           <p:cNvPr id="29" name="Oval 28">
             <a:extLst>
               <a:ext uri="{FF2B5EF4-FFF2-40B4-BE49-F238E27FC236}">
-                <a16:creationId xmlns:a16="http://schemas.microsoft.com/office/drawing/2014/main" id="{25A0A0B3-E20A-4CC2-79D9-E97020D601A7}"/>
+                <ns2:creationId id="{25A0A0B3-E20A-4CC2-79D9-E97020D601A7}"/>
               </a:ext>
             </a:extLst>
           </p:cNvPr>
@@ -26090,7 +26803,7 @@
           <p:cNvPr id="30" name="Oval 29">
             <a:extLst>
               <a:ext uri="{FF2B5EF4-FFF2-40B4-BE49-F238E27FC236}">
-                <a16:creationId xmlns:a16="http://schemas.microsoft.com/office/drawing/2014/main" id="{7969DEBF-EEB6-634C-020A-385E24FBF8E1}"/>
+                <ns2:creationId id="{7969DEBF-EEB6-634C-020A-385E24FBF8E1}"/>
               </a:ext>
             </a:extLst>
           </p:cNvPr>
@@ -26174,7 +26887,7 @@
           <p:cNvPr id="4" name="Straight Connector 3">
             <a:extLst>
               <a:ext uri="{FF2B5EF4-FFF2-40B4-BE49-F238E27FC236}">
-                <a16:creationId xmlns:a16="http://schemas.microsoft.com/office/drawing/2014/main" id="{2C66513A-9085-17C4-C9C2-3742BE2C33D7}"/>
+                <ns2:creationId id="{2C66513A-9085-17C4-C9C2-3742BE2C33D7}"/>
               </a:ext>
             </a:extLst>
           </p:cNvPr>
@@ -26217,7 +26930,7 @@
           <p:cNvPr id="18" name="Oval 17">
             <a:extLst>
               <a:ext uri="{FF2B5EF4-FFF2-40B4-BE49-F238E27FC236}">
-                <a16:creationId xmlns:a16="http://schemas.microsoft.com/office/drawing/2014/main" id="{9E30E225-012D-EE67-96E9-8843E769C6E1}"/>
+                <ns2:creationId id="{9E30E225-012D-EE67-96E9-8843E769C6E1}"/>
               </a:ext>
             </a:extLst>
           </p:cNvPr>
@@ -26300,7 +27013,7 @@
           <p:cNvPr id="11" name="Group 10">
             <a:extLst>
               <a:ext uri="{FF2B5EF4-FFF2-40B4-BE49-F238E27FC236}">
-                <a16:creationId xmlns:a16="http://schemas.microsoft.com/office/drawing/2014/main" id="{CE7A3B85-FDA3-45E2-9BB3-D32BED764091}"/>
+                <ns2:creationId id="{CE7A3B85-FDA3-45E2-9BB3-D32BED764091}"/>
               </a:ext>
             </a:extLst>
           </p:cNvPr>
@@ -26320,7 +27033,7 @@
             <p:cNvPr id="24" name="Straight Arrow Connector 23">
               <a:extLst>
                 <a:ext uri="{FF2B5EF4-FFF2-40B4-BE49-F238E27FC236}">
-                  <a16:creationId xmlns:a16="http://schemas.microsoft.com/office/drawing/2014/main" id="{5AAF8464-4AF0-1ED4-EC84-883D9DCBAE2E}"/>
+                  <ns2:creationId id="{5AAF8464-4AF0-1ED4-EC84-883D9DCBAE2E}"/>
                 </a:ext>
               </a:extLst>
             </p:cNvPr>
@@ -26365,7 +27078,7 @@
             <p:cNvPr id="10" name="TextBox 9">
               <a:extLst>
                 <a:ext uri="{FF2B5EF4-FFF2-40B4-BE49-F238E27FC236}">
-                  <a16:creationId xmlns:a16="http://schemas.microsoft.com/office/drawing/2014/main" id="{D4526506-8D04-242E-625D-A7D78BFFEE82}"/>
+                  <ns2:creationId id="{D4526506-8D04-242E-625D-A7D78BFFEE82}"/>
                 </a:ext>
               </a:extLst>
             </p:cNvPr>
@@ -26420,7 +27133,41 @@
                   <a:ea typeface="Helvetica Neue" panose="02000503000000020004" pitchFamily="2" charset="0"/>
                   <a:cs typeface="Helvetica Neue" panose="02000503000000020004" pitchFamily="2" charset="0"/>
                 </a:rPr>
-                <a:t>v &lt; c_f</a:t>
+                <a:t xml:space="preserve">v &lt; </a:t>
+              </a:r>
+              <a:r>
+                <a:rPr kumimoji="0" lang="en-US" sz="1400" b="0" i="1" u="none" strike="noStrike" kern="1200" cap="none" spc="0" normalizeH="0" baseline="0" noProof="0" dirty="0">
+                  <a:ln>
+                    <a:noFill/>
+                  </a:ln>
+                  <a:solidFill>
+                    <a:prstClr val="white"/>
+                  </a:solidFill>
+                  <a:effectLst/>
+                  <a:uLnTx/>
+                  <a:uFillTx/>
+                  <a:latin typeface="Helvetica Neue" panose="02000503000000020004" pitchFamily="2" charset="0"/>
+                  <a:ea typeface="Helvetica Neue" panose="02000503000000020004" pitchFamily="2" charset="0"/>
+                  <a:cs typeface="Helvetica Neue" panose="02000503000000020004" pitchFamily="2" charset="0"/>
+                </a:rPr>
+                <a:t>c</a:t>
+              </a:r>
+              <a:r>
+                <a:rPr kumimoji="0" lang="en-US" sz="980" b="0" i="1" u="none" strike="noStrike" kern="1200" cap="none" spc="0" normalizeH="0" baseline="-25000" noProof="0" dirty="0">
+                  <a:ln>
+                    <a:noFill/>
+                  </a:ln>
+                  <a:solidFill>
+                    <a:prstClr val="white"/>
+                  </a:solidFill>
+                  <a:effectLst/>
+                  <a:uLnTx/>
+                  <a:uFillTx/>
+                  <a:latin typeface="Helvetica Neue" panose="02000503000000020004" pitchFamily="2" charset="0"/>
+                  <a:ea typeface="Helvetica Neue" panose="02000503000000020004" pitchFamily="2" charset="0"/>
+                  <a:cs typeface="Helvetica Neue" panose="02000503000000020004" pitchFamily="2" charset="0"/>
+                </a:rPr>
+                <a:t>f</a:t>
               </a:r>
             </a:p>
           </p:txBody>
@@ -26431,7 +27178,7 @@
           <p:cNvPr id="31" name="TextBox 30">
             <a:extLst>
               <a:ext uri="{FF2B5EF4-FFF2-40B4-BE49-F238E27FC236}">
-                <a16:creationId xmlns:a16="http://schemas.microsoft.com/office/drawing/2014/main" id="{0715B65B-EE48-6433-EFA6-8AFF4BF52B13}"/>
+                <ns2:creationId id="{0715B65B-EE48-6433-EFA6-8AFF4BF52B13}"/>
               </a:ext>
             </a:extLst>
           </p:cNvPr>
@@ -26489,7 +27236,58 @@
                 <a:ea typeface="Helvetica Neue" panose="02000503000000020004" pitchFamily="2" charset="0"/>
                 <a:cs typeface="Helvetica Neue" panose="02000503000000020004" pitchFamily="2" charset="0"/>
               </a:rPr>
-              <a:t>r = c_f t</a:t>
+              <a:t xml:space="preserve">r = </a:t>
+            </a:r>
+            <a:r>
+              <a:rPr kumimoji="0" lang="en-US" sz="1400" b="0" i="1" u="none" strike="noStrike" kern="1200" cap="none" spc="0" normalizeH="0" baseline="0" noProof="0" dirty="0">
+                <a:ln>
+                  <a:noFill/>
+                </a:ln>
+                <a:solidFill>
+                  <a:srgbClr val="FFC000"/>
+                </a:solidFill>
+                <a:effectLst/>
+                <a:uLnTx/>
+                <a:uFillTx/>
+                <a:latin typeface="Helvetica Neue" panose="02000503000000020004" pitchFamily="2" charset="0"/>
+                <a:ea typeface="Helvetica Neue" panose="02000503000000020004" pitchFamily="2" charset="0"/>
+                <a:cs typeface="Helvetica Neue" panose="02000503000000020004" pitchFamily="2" charset="0"/>
+              </a:rPr>
+              <a:t>c</a:t>
+            </a:r>
+            <a:r>
+              <a:rPr kumimoji="0" lang="en-US" sz="980" b="0" i="1" u="none" strike="noStrike" kern="1200" cap="none" spc="0" normalizeH="0" baseline="-25000" noProof="0" dirty="0">
+                <a:ln>
+                  <a:noFill/>
+                </a:ln>
+                <a:solidFill>
+                  <a:srgbClr val="FFC000"/>
+                </a:solidFill>
+                <a:effectLst/>
+                <a:uLnTx/>
+                <a:uFillTx/>
+                <a:latin typeface="Helvetica Neue" panose="02000503000000020004" pitchFamily="2" charset="0"/>
+                <a:ea typeface="Helvetica Neue" panose="02000503000000020004" pitchFamily="2" charset="0"/>
+                <a:cs typeface="Helvetica Neue" panose="02000503000000020004" pitchFamily="2" charset="0"/>
+              </a:rPr>
+              <a:t>f</a:t>
+            </a:r>
+            <a:r>
+              <a:rPr kumimoji="0" lang="en-US" sz="1400" b="0" i="1" u="none" strike="noStrike" kern="1200" cap="none" spc="0" normalizeH="0" baseline="0" noProof="0" dirty="0">
+                <a:ln>
+                  <a:noFill/>
+                </a:ln>
+                <a:solidFill>
+                  <a:srgbClr val="FFC000"/>
+                </a:solidFill>
+                <a:effectLst/>
+                <a:uLnTx/>
+                <a:uFillTx/>
+                <a:latin typeface="Helvetica Neue" panose="02000503000000020004" pitchFamily="2" charset="0"/>
+                <a:ea typeface="Helvetica Neue" panose="02000503000000020004" pitchFamily="2" charset="0"/>
+                <a:cs typeface="Helvetica Neue" panose="02000503000000020004" pitchFamily="2" charset="0"/>
+              </a:rPr>
+              <a:t xml:space="preserve"> t</a:t>
             </a:r>
           </a:p>
         </p:txBody>
@@ -26499,7 +27297,7 @@
           <p:cNvPr id="36" name="TextBox 35">
             <a:extLst>
               <a:ext uri="{FF2B5EF4-FFF2-40B4-BE49-F238E27FC236}">
-                <a16:creationId xmlns:a16="http://schemas.microsoft.com/office/drawing/2014/main" id="{2639C71E-8510-A47A-CB6E-BD88DBD2D9D2}"/>
+                <ns2:creationId id="{2639C71E-8510-A47A-CB6E-BD88DBD2D9D2}"/>
               </a:ext>
             </a:extLst>
           </p:cNvPr>
@@ -26581,7 +27379,7 @@
           <p:cNvPr id="22" name="Straight Connector 21">
             <a:extLst>
               <a:ext uri="{FF2B5EF4-FFF2-40B4-BE49-F238E27FC236}">
-                <a16:creationId xmlns:a16="http://schemas.microsoft.com/office/drawing/2014/main" id="{48D6CF27-A191-E604-D02B-B71D144C595B}"/>
+                <ns2:creationId id="{48D6CF27-A191-E604-D02B-B71D144C595B}"/>
               </a:ext>
             </a:extLst>
           </p:cNvPr>
@@ -26624,7 +27422,7 @@
           <p:cNvPr id="2" name="Title 1">
             <a:extLst>
               <a:ext uri="{FF2B5EF4-FFF2-40B4-BE49-F238E27FC236}">
-                <a16:creationId xmlns:a16="http://schemas.microsoft.com/office/drawing/2014/main" id="{62407ED0-1A7F-69F0-224E-34E3BAB4AEB7}"/>
+                <ns2:creationId id="{62407ED0-1A7F-69F0-224E-34E3BAB4AEB7}"/>
               </a:ext>
             </a:extLst>
           </p:cNvPr>
@@ -26698,7 +27496,41 @@
                 <a:ea typeface="Helvetica Neue" panose="02000503000000020004" pitchFamily="2" charset="0"/>
                 <a:cs typeface="Helvetica Neue" panose="02000503000000020004" pitchFamily="2" charset="0"/>
               </a:rPr>
-              <a:t>Causal Wake Surfaces Expand at v = c_f</a:t>
+              <a:t xml:space="preserve">Causal Wake Surfaces Expand at v = </a:t>
+            </a:r>
+            <a:r>
+              <a:rPr kumimoji="0" lang="en-US" sz="3600" b="1" i="0" u="none" strike="noStrike" kern="1200" cap="none" spc="0" normalizeH="0" baseline="0" noProof="0" dirty="0">
+                <a:ln>
+                  <a:noFill/>
+                </a:ln>
+                <a:solidFill>
+                  <a:prstClr val="white"/>
+                </a:solidFill>
+                <a:effectLst/>
+                <a:uLnTx/>
+                <a:uFillTx/>
+                <a:latin typeface="Helvetica Neue" panose="02000503000000020004" pitchFamily="2" charset="0"/>
+                <a:ea typeface="Helvetica Neue" panose="02000503000000020004" pitchFamily="2" charset="0"/>
+                <a:cs typeface="Helvetica Neue" panose="02000503000000020004" pitchFamily="2" charset="0"/>
+              </a:rPr>
+              <a:t>c</a:t>
+            </a:r>
+            <a:r>
+              <a:rPr kumimoji="0" lang="en-US" sz="2520" b="1" i="0" u="none" strike="noStrike" kern="1200" cap="none" spc="0" normalizeH="0" baseline="-25000" noProof="0" dirty="0">
+                <a:ln>
+                  <a:noFill/>
+                </a:ln>
+                <a:solidFill>
+                  <a:prstClr val="white"/>
+                </a:solidFill>
+                <a:effectLst/>
+                <a:uLnTx/>
+                <a:uFillTx/>
+                <a:latin typeface="Helvetica Neue" panose="02000503000000020004" pitchFamily="2" charset="0"/>
+                <a:ea typeface="Helvetica Neue" panose="02000503000000020004" pitchFamily="2" charset="0"/>
+                <a:cs typeface="Helvetica Neue" panose="02000503000000020004" pitchFamily="2" charset="0"/>
+              </a:rPr>
+              <a:t>f</a:t>
             </a:r>
           </a:p>
         </p:txBody>
@@ -26708,7 +27540,7 @@
           <p:cNvPr id="7" name="Rectangle 6">
             <a:extLst>
               <a:ext uri="{FF2B5EF4-FFF2-40B4-BE49-F238E27FC236}">
-                <a16:creationId xmlns:a16="http://schemas.microsoft.com/office/drawing/2014/main" id="{E63833BB-E257-5DD8-D2DC-4EDC10C1D9B0}"/>
+                <ns2:creationId id="{E63833BB-E257-5DD8-D2DC-4EDC10C1D9B0}"/>
               </a:ext>
             </a:extLst>
           </p:cNvPr>
@@ -26772,7 +27604,7 @@
           <p:cNvPr id="15" name="Straight Arrow Connector 14">
             <a:extLst>
               <a:ext uri="{FF2B5EF4-FFF2-40B4-BE49-F238E27FC236}">
-                <a16:creationId xmlns:a16="http://schemas.microsoft.com/office/drawing/2014/main" id="{F4A7F80E-6EB4-D3A1-C496-DA676D8B14B8}"/>
+                <ns2:creationId id="{F4A7F80E-6EB4-D3A1-C496-DA676D8B14B8}"/>
               </a:ext>
             </a:extLst>
           </p:cNvPr>
@@ -26818,7 +27650,7 @@
           <p:cNvPr id="32" name="Straight Arrow Connector 31">
             <a:extLst>
               <a:ext uri="{FF2B5EF4-FFF2-40B4-BE49-F238E27FC236}">
-                <a16:creationId xmlns:a16="http://schemas.microsoft.com/office/drawing/2014/main" id="{E4BBFD59-613F-87DB-D8CE-C4CD0658E65A}"/>
+                <ns2:creationId id="{E4BBFD59-613F-87DB-D8CE-C4CD0658E65A}"/>
               </a:ext>
             </a:extLst>
           </p:cNvPr>
@@ -26864,7 +27696,7 @@
           <p:cNvPr id="35" name="Straight Arrow Connector 34">
             <a:extLst>
               <a:ext uri="{FF2B5EF4-FFF2-40B4-BE49-F238E27FC236}">
-                <a16:creationId xmlns:a16="http://schemas.microsoft.com/office/drawing/2014/main" id="{6170C482-A85C-519C-1C68-E52F3D321552}"/>
+                <ns2:creationId id="{6170C482-A85C-519C-1C68-E52F3D321552}"/>
               </a:ext>
             </a:extLst>
           </p:cNvPr>
@@ -26910,7 +27742,7 @@
           <p:cNvPr id="39" name="Straight Arrow Connector 38">
             <a:extLst>
               <a:ext uri="{FF2B5EF4-FFF2-40B4-BE49-F238E27FC236}">
-                <a16:creationId xmlns:a16="http://schemas.microsoft.com/office/drawing/2014/main" id="{4230761A-8EDF-2FA3-7DBE-AF384628B09E}"/>
+                <ns2:creationId id="{4230761A-8EDF-2FA3-7DBE-AF384628B09E}"/>
               </a:ext>
             </a:extLst>
           </p:cNvPr>
@@ -26956,7 +27788,7 @@
           <p:cNvPr id="47" name="Straight Arrow Connector 46">
             <a:extLst>
               <a:ext uri="{FF2B5EF4-FFF2-40B4-BE49-F238E27FC236}">
-                <a16:creationId xmlns:a16="http://schemas.microsoft.com/office/drawing/2014/main" id="{D3EF506B-E81E-4405-B45C-DFB8F9DA0D65}"/>
+                <ns2:creationId id="{D3EF506B-E81E-4405-B45C-DFB8F9DA0D65}"/>
               </a:ext>
             </a:extLst>
           </p:cNvPr>
@@ -27002,7 +27834,7 @@
           <p:cNvPr id="9" name="TextBox 8">
             <a:extLst>
               <a:ext uri="{FF2B5EF4-FFF2-40B4-BE49-F238E27FC236}">
-                <a16:creationId xmlns:a16="http://schemas.microsoft.com/office/drawing/2014/main" id="{9B5DCDDF-276B-4F6E-7066-014AE9A59CCC}"/>
+                <ns2:creationId id="{9B5DCDDF-276B-4F6E-7066-014AE9A59CCC}"/>
               </a:ext>
             </a:extLst>
           </p:cNvPr>
@@ -27084,7 +27916,7 @@
           <p:cNvPr id="14" name="Rectangle 13">
             <a:extLst>
               <a:ext uri="{FF2B5EF4-FFF2-40B4-BE49-F238E27FC236}">
-                <a16:creationId xmlns:a16="http://schemas.microsoft.com/office/drawing/2014/main" id="{99560D5F-868F-8968-4ED0-12355714D7FF}"/>
+                <ns2:creationId id="{99560D5F-868F-8968-4ED0-12355714D7FF}"/>
               </a:ext>
             </a:extLst>
           </p:cNvPr>
@@ -27185,7 +28017,7 @@
     </p:spTree>
     <p:extLst>
       <p:ext uri="{BB962C8B-B14F-4D97-AF65-F5344CB8AC3E}">
-        <p14:creationId xmlns:p14="http://schemas.microsoft.com/office/powerpoint/2010/main" val="3801198229"/>
+        <ns3:creationId val="3801198229"/>
       </p:ext>
     </p:extLst>
   </p:cSld>
@@ -27196,7 +28028,7 @@
 </file>
 
 <file path=ppt/slides/slide5.xml><?xml version="1.0" encoding="utf-8"?>
-<p:sld xmlns:a="http://schemas.openxmlformats.org/drawingml/2006/main" xmlns:r="http://schemas.openxmlformats.org/officeDocument/2006/relationships" xmlns:p="http://schemas.openxmlformats.org/presentationml/2006/main">
+<p:sld xmlns:a="http://schemas.openxmlformats.org/drawingml/2006/main" xmlns:ns2="http://schemas.microsoft.com/office/drawing/2014/main" xmlns:ns3="http://schemas.microsoft.com/office/powerpoint/2010/main" xmlns:p="http://schemas.openxmlformats.org/presentationml/2006/main">
   <p:cSld>
     <p:bg>
       <p:bgPr>
@@ -27225,7 +28057,7 @@
           <p:cNvPr id="5" name="Footer Placeholder 3">
             <a:extLst>
               <a:ext uri="{FF2B5EF4-FFF2-40B4-BE49-F238E27FC236}">
-                <a16:creationId xmlns:a16="http://schemas.microsoft.com/office/drawing/2014/main" id="{668F77D6-DFDA-5A46-8DF1-47F6A167C2B1}"/>
+                <ns2:creationId id="{668F77D6-DFDA-5A46-8DF1-47F6A167C2B1}"/>
               </a:ext>
             </a:extLst>
           </p:cNvPr>
@@ -27387,7 +28219,7 @@
           <p:cNvPr id="3" name="Straight Arrow Connector 2">
             <a:extLst>
               <a:ext uri="{FF2B5EF4-FFF2-40B4-BE49-F238E27FC236}">
-                <a16:creationId xmlns:a16="http://schemas.microsoft.com/office/drawing/2014/main" id="{2EF0199F-22F4-BA42-9B75-8A8183BCDA9B}"/>
+                <ns2:creationId id="{2EF0199F-22F4-BA42-9B75-8A8183BCDA9B}"/>
               </a:ext>
             </a:extLst>
           </p:cNvPr>
@@ -27431,7 +28263,7 @@
           <p:cNvPr id="8" name="Straight Arrow Connector 7">
             <a:extLst>
               <a:ext uri="{FF2B5EF4-FFF2-40B4-BE49-F238E27FC236}">
-                <a16:creationId xmlns:a16="http://schemas.microsoft.com/office/drawing/2014/main" id="{49AB5343-55D0-6041-8627-E08A73F83930}"/>
+                <ns2:creationId id="{49AB5343-55D0-6041-8627-E08A73F83930}"/>
               </a:ext>
             </a:extLst>
           </p:cNvPr>
@@ -27475,7 +28307,7 @@
           <p:cNvPr id="12" name="TextBox 11">
             <a:extLst>
               <a:ext uri="{FF2B5EF4-FFF2-40B4-BE49-F238E27FC236}">
-                <a16:creationId xmlns:a16="http://schemas.microsoft.com/office/drawing/2014/main" id="{BF8D86A2-D083-024A-BC90-6BD938C23243}"/>
+                <ns2:creationId id="{BF8D86A2-D083-024A-BC90-6BD938C23243}"/>
               </a:ext>
             </a:extLst>
           </p:cNvPr>
@@ -27540,7 +28372,7 @@
           <p:cNvPr id="13" name="TextBox 12">
             <a:extLst>
               <a:ext uri="{FF2B5EF4-FFF2-40B4-BE49-F238E27FC236}">
-                <a16:creationId xmlns:a16="http://schemas.microsoft.com/office/drawing/2014/main" id="{2C3F4604-6C2F-0E4E-9DD3-4F5C89FF51AB}"/>
+                <ns2:creationId id="{2C3F4604-6C2F-0E4E-9DD3-4F5C89FF51AB}"/>
               </a:ext>
             </a:extLst>
           </p:cNvPr>
@@ -27641,7 +28473,7 @@
           <p:cNvPr id="23" name="Oval 22">
             <a:extLst>
               <a:ext uri="{FF2B5EF4-FFF2-40B4-BE49-F238E27FC236}">
-                <a16:creationId xmlns:a16="http://schemas.microsoft.com/office/drawing/2014/main" id="{0112617B-A1D5-1E41-BF92-E67D4E046E39}"/>
+                <ns2:creationId id="{0112617B-A1D5-1E41-BF92-E67D4E046E39}"/>
               </a:ext>
             </a:extLst>
           </p:cNvPr>
@@ -27725,7 +28557,7 @@
           <p:cNvPr id="27" name="Oval 26">
             <a:extLst>
               <a:ext uri="{FF2B5EF4-FFF2-40B4-BE49-F238E27FC236}">
-                <a16:creationId xmlns:a16="http://schemas.microsoft.com/office/drawing/2014/main" id="{6EF0F7DA-5E70-8348-A200-F59A10FF7C55}"/>
+                <ns2:creationId id="{6EF0F7DA-5E70-8348-A200-F59A10FF7C55}"/>
               </a:ext>
             </a:extLst>
           </p:cNvPr>
@@ -27809,7 +28641,7 @@
           <p:cNvPr id="28" name="Oval 27">
             <a:extLst>
               <a:ext uri="{FF2B5EF4-FFF2-40B4-BE49-F238E27FC236}">
-                <a16:creationId xmlns:a16="http://schemas.microsoft.com/office/drawing/2014/main" id="{552F58D0-F613-674A-B294-C894E5FB1683}"/>
+                <ns2:creationId id="{552F58D0-F613-674A-B294-C894E5FB1683}"/>
               </a:ext>
             </a:extLst>
           </p:cNvPr>
@@ -27893,7 +28725,7 @@
           <p:cNvPr id="29" name="Oval 28">
             <a:extLst>
               <a:ext uri="{FF2B5EF4-FFF2-40B4-BE49-F238E27FC236}">
-                <a16:creationId xmlns:a16="http://schemas.microsoft.com/office/drawing/2014/main" id="{9CA7A721-D3BD-744E-9306-85BBED5F74BC}"/>
+                <ns2:creationId id="{9CA7A721-D3BD-744E-9306-85BBED5F74BC}"/>
               </a:ext>
             </a:extLst>
           </p:cNvPr>
@@ -27977,7 +28809,7 @@
           <p:cNvPr id="30" name="Oval 29">
             <a:extLst>
               <a:ext uri="{FF2B5EF4-FFF2-40B4-BE49-F238E27FC236}">
-                <a16:creationId xmlns:a16="http://schemas.microsoft.com/office/drawing/2014/main" id="{F97F1A02-C0C7-3C45-9790-847C152D159A}"/>
+                <ns2:creationId id="{F97F1A02-C0C7-3C45-9790-847C152D159A}"/>
               </a:ext>
             </a:extLst>
           </p:cNvPr>
@@ -28061,7 +28893,7 @@
           <p:cNvPr id="4" name="Straight Connector 3">
             <a:extLst>
               <a:ext uri="{FF2B5EF4-FFF2-40B4-BE49-F238E27FC236}">
-                <a16:creationId xmlns:a16="http://schemas.microsoft.com/office/drawing/2014/main" id="{9890CC23-4ADC-D744-AF2D-1C8A936F07FC}"/>
+                <ns2:creationId id="{9890CC23-4ADC-D744-AF2D-1C8A936F07FC}"/>
               </a:ext>
             </a:extLst>
           </p:cNvPr>
@@ -28104,7 +28936,7 @@
           <p:cNvPr id="18" name="Oval 17">
             <a:extLst>
               <a:ext uri="{FF2B5EF4-FFF2-40B4-BE49-F238E27FC236}">
-                <a16:creationId xmlns:a16="http://schemas.microsoft.com/office/drawing/2014/main" id="{BE4CDC90-4B2E-BE41-BB9D-A84675F3A2FE}"/>
+                <ns2:creationId id="{BE4CDC90-4B2E-BE41-BB9D-A84675F3A2FE}"/>
               </a:ext>
             </a:extLst>
           </p:cNvPr>
@@ -28187,7 +29019,7 @@
           <p:cNvPr id="11" name="Group 10">
             <a:extLst>
               <a:ext uri="{FF2B5EF4-FFF2-40B4-BE49-F238E27FC236}">
-                <a16:creationId xmlns:a16="http://schemas.microsoft.com/office/drawing/2014/main" id="{33483591-0E05-544C-B822-43CF81B12E63}"/>
+                <ns2:creationId id="{33483591-0E05-544C-B822-43CF81B12E63}"/>
               </a:ext>
             </a:extLst>
           </p:cNvPr>
@@ -28207,7 +29039,7 @@
             <p:cNvPr id="24" name="Straight Arrow Connector 23">
               <a:extLst>
                 <a:ext uri="{FF2B5EF4-FFF2-40B4-BE49-F238E27FC236}">
-                  <a16:creationId xmlns:a16="http://schemas.microsoft.com/office/drawing/2014/main" id="{7BCF22C9-C9AE-324D-B157-A9536FCAF3B6}"/>
+                  <ns2:creationId id="{7BCF22C9-C9AE-324D-B157-A9536FCAF3B6}"/>
                 </a:ext>
               </a:extLst>
             </p:cNvPr>
@@ -28252,7 +29084,7 @@
             <p:cNvPr id="10" name="TextBox 9">
               <a:extLst>
                 <a:ext uri="{FF2B5EF4-FFF2-40B4-BE49-F238E27FC236}">
-                  <a16:creationId xmlns:a16="http://schemas.microsoft.com/office/drawing/2014/main" id="{01A59953-657F-C641-8F36-E48E8EDB0DF1}"/>
+                  <ns2:creationId id="{01A59953-657F-C641-8F36-E48E8EDB0DF1}"/>
                 </a:ext>
               </a:extLst>
             </p:cNvPr>
@@ -28307,7 +29139,41 @@
                   <a:ea typeface="Helvetica Neue" panose="02000503000000020004" pitchFamily="2" charset="0"/>
                   <a:cs typeface="Helvetica Neue" panose="02000503000000020004" pitchFamily="2" charset="0"/>
                 </a:rPr>
-                <a:t>v &lt; c_f</a:t>
+                <a:t xml:space="preserve">v &lt; </a:t>
+              </a:r>
+              <a:r>
+                <a:rPr kumimoji="0" lang="en-US" sz="1400" b="0" i="1" u="none" strike="noStrike" kern="1200" cap="none" spc="0" normalizeH="0" baseline="0" noProof="0" dirty="0">
+                  <a:ln>
+                    <a:noFill/>
+                  </a:ln>
+                  <a:solidFill>
+                    <a:prstClr val="white"/>
+                  </a:solidFill>
+                  <a:effectLst/>
+                  <a:uLnTx/>
+                  <a:uFillTx/>
+                  <a:latin typeface="Helvetica Neue" panose="02000503000000020004" pitchFamily="2" charset="0"/>
+                  <a:ea typeface="Helvetica Neue" panose="02000503000000020004" pitchFamily="2" charset="0"/>
+                  <a:cs typeface="Helvetica Neue" panose="02000503000000020004" pitchFamily="2" charset="0"/>
+                </a:rPr>
+                <a:t>c</a:t>
+              </a:r>
+              <a:r>
+                <a:rPr kumimoji="0" lang="en-US" sz="980" b="0" i="1" u="none" strike="noStrike" kern="1200" cap="none" spc="0" normalizeH="0" baseline="-25000" noProof="0" dirty="0">
+                  <a:ln>
+                    <a:noFill/>
+                  </a:ln>
+                  <a:solidFill>
+                    <a:prstClr val="white"/>
+                  </a:solidFill>
+                  <a:effectLst/>
+                  <a:uLnTx/>
+                  <a:uFillTx/>
+                  <a:latin typeface="Helvetica Neue" panose="02000503000000020004" pitchFamily="2" charset="0"/>
+                  <a:ea typeface="Helvetica Neue" panose="02000503000000020004" pitchFamily="2" charset="0"/>
+                  <a:cs typeface="Helvetica Neue" panose="02000503000000020004" pitchFamily="2" charset="0"/>
+                </a:rPr>
+                <a:t>f</a:t>
               </a:r>
             </a:p>
           </p:txBody>
@@ -28318,7 +29184,7 @@
           <p:cNvPr id="31" name="TextBox 30">
             <a:extLst>
               <a:ext uri="{FF2B5EF4-FFF2-40B4-BE49-F238E27FC236}">
-                <a16:creationId xmlns:a16="http://schemas.microsoft.com/office/drawing/2014/main" id="{713B9ACE-B673-2D48-BEF2-2A133C31B527}"/>
+                <ns2:creationId id="{713B9ACE-B673-2D48-BEF2-2A133C31B527}"/>
               </a:ext>
             </a:extLst>
           </p:cNvPr>
@@ -28376,7 +29242,58 @@
                 <a:ea typeface="Helvetica Neue" panose="02000503000000020004" pitchFamily="2" charset="0"/>
                 <a:cs typeface="Helvetica Neue" panose="02000503000000020004" pitchFamily="2" charset="0"/>
               </a:rPr>
-              <a:t>r = c_f t</a:t>
+              <a:t xml:space="preserve">r = </a:t>
+            </a:r>
+            <a:r>
+              <a:rPr kumimoji="0" lang="en-US" sz="1400" b="0" i="1" u="none" strike="noStrike" kern="1200" cap="none" spc="0" normalizeH="0" baseline="0" noProof="0" dirty="0">
+                <a:ln>
+                  <a:noFill/>
+                </a:ln>
+                <a:solidFill>
+                  <a:srgbClr val="FFC000"/>
+                </a:solidFill>
+                <a:effectLst/>
+                <a:uLnTx/>
+                <a:uFillTx/>
+                <a:latin typeface="Helvetica Neue" panose="02000503000000020004" pitchFamily="2" charset="0"/>
+                <a:ea typeface="Helvetica Neue" panose="02000503000000020004" pitchFamily="2" charset="0"/>
+                <a:cs typeface="Helvetica Neue" panose="02000503000000020004" pitchFamily="2" charset="0"/>
+              </a:rPr>
+              <a:t>c</a:t>
+            </a:r>
+            <a:r>
+              <a:rPr kumimoji="0" lang="en-US" sz="980" b="0" i="1" u="none" strike="noStrike" kern="1200" cap="none" spc="0" normalizeH="0" baseline="-25000" noProof="0" dirty="0">
+                <a:ln>
+                  <a:noFill/>
+                </a:ln>
+                <a:solidFill>
+                  <a:srgbClr val="FFC000"/>
+                </a:solidFill>
+                <a:effectLst/>
+                <a:uLnTx/>
+                <a:uFillTx/>
+                <a:latin typeface="Helvetica Neue" panose="02000503000000020004" pitchFamily="2" charset="0"/>
+                <a:ea typeface="Helvetica Neue" panose="02000503000000020004" pitchFamily="2" charset="0"/>
+                <a:cs typeface="Helvetica Neue" panose="02000503000000020004" pitchFamily="2" charset="0"/>
+              </a:rPr>
+              <a:t>f</a:t>
+            </a:r>
+            <a:r>
+              <a:rPr kumimoji="0" lang="en-US" sz="1400" b="0" i="1" u="none" strike="noStrike" kern="1200" cap="none" spc="0" normalizeH="0" baseline="0" noProof="0" dirty="0">
+                <a:ln>
+                  <a:noFill/>
+                </a:ln>
+                <a:solidFill>
+                  <a:srgbClr val="FFC000"/>
+                </a:solidFill>
+                <a:effectLst/>
+                <a:uLnTx/>
+                <a:uFillTx/>
+                <a:latin typeface="Helvetica Neue" panose="02000503000000020004" pitchFamily="2" charset="0"/>
+                <a:ea typeface="Helvetica Neue" panose="02000503000000020004" pitchFamily="2" charset="0"/>
+                <a:cs typeface="Helvetica Neue" panose="02000503000000020004" pitchFamily="2" charset="0"/>
+              </a:rPr>
+              <a:t xml:space="preserve"> t</a:t>
             </a:r>
           </a:p>
         </p:txBody>
@@ -28386,7 +29303,7 @@
           <p:cNvPr id="36" name="TextBox 35">
             <a:extLst>
               <a:ext uri="{FF2B5EF4-FFF2-40B4-BE49-F238E27FC236}">
-                <a16:creationId xmlns:a16="http://schemas.microsoft.com/office/drawing/2014/main" id="{3A81A480-EF64-094E-825A-8592DAA4C672}"/>
+                <ns2:creationId id="{3A81A480-EF64-094E-825A-8592DAA4C672}"/>
               </a:ext>
             </a:extLst>
           </p:cNvPr>
@@ -28468,7 +29385,7 @@
           <p:cNvPr id="7" name="Rectangle 6">
             <a:extLst>
               <a:ext uri="{FF2B5EF4-FFF2-40B4-BE49-F238E27FC236}">
-                <a16:creationId xmlns:a16="http://schemas.microsoft.com/office/drawing/2014/main" id="{BED67AD4-F230-35A0-28FB-DE984573A446}"/>
+                <ns2:creationId id="{BED67AD4-F230-35A0-28FB-DE984573A446}"/>
               </a:ext>
             </a:extLst>
           </p:cNvPr>
@@ -28532,7 +29449,7 @@
           <p:cNvPr id="15" name="Straight Arrow Connector 14">
             <a:extLst>
               <a:ext uri="{FF2B5EF4-FFF2-40B4-BE49-F238E27FC236}">
-                <a16:creationId xmlns:a16="http://schemas.microsoft.com/office/drawing/2014/main" id="{05289ED1-4679-6543-A669-B23443FD0CD8}"/>
+                <ns2:creationId id="{05289ED1-4679-6543-A669-B23443FD0CD8}"/>
               </a:ext>
             </a:extLst>
           </p:cNvPr>
@@ -28578,7 +29495,7 @@
           <p:cNvPr id="32" name="Straight Arrow Connector 31">
             <a:extLst>
               <a:ext uri="{FF2B5EF4-FFF2-40B4-BE49-F238E27FC236}">
-                <a16:creationId xmlns:a16="http://schemas.microsoft.com/office/drawing/2014/main" id="{A9F8BF55-7F79-854D-84AD-A730BF43B39C}"/>
+                <ns2:creationId id="{A9F8BF55-7F79-854D-84AD-A730BF43B39C}"/>
               </a:ext>
             </a:extLst>
           </p:cNvPr>
@@ -28624,7 +29541,7 @@
           <p:cNvPr id="35" name="Straight Arrow Connector 34">
             <a:extLst>
               <a:ext uri="{FF2B5EF4-FFF2-40B4-BE49-F238E27FC236}">
-                <a16:creationId xmlns:a16="http://schemas.microsoft.com/office/drawing/2014/main" id="{0415B495-590C-0049-92E6-8AE7464CC78A}"/>
+                <ns2:creationId id="{0415B495-590C-0049-92E6-8AE7464CC78A}"/>
               </a:ext>
             </a:extLst>
           </p:cNvPr>
@@ -28670,7 +29587,7 @@
           <p:cNvPr id="39" name="Straight Arrow Connector 38">
             <a:extLst>
               <a:ext uri="{FF2B5EF4-FFF2-40B4-BE49-F238E27FC236}">
-                <a16:creationId xmlns:a16="http://schemas.microsoft.com/office/drawing/2014/main" id="{E4879E96-726B-4F42-BD7C-09F8D0B14E9A}"/>
+                <ns2:creationId id="{E4879E96-726B-4F42-BD7C-09F8D0B14E9A}"/>
               </a:ext>
             </a:extLst>
           </p:cNvPr>
@@ -28716,7 +29633,7 @@
           <p:cNvPr id="47" name="Straight Arrow Connector 46">
             <a:extLst>
               <a:ext uri="{FF2B5EF4-FFF2-40B4-BE49-F238E27FC236}">
-                <a16:creationId xmlns:a16="http://schemas.microsoft.com/office/drawing/2014/main" id="{0F119609-4333-414A-B8E4-E2447D7E1C10}"/>
+                <ns2:creationId id="{0F119609-4333-414A-B8E4-E2447D7E1C10}"/>
               </a:ext>
             </a:extLst>
           </p:cNvPr>
@@ -28762,7 +29679,7 @@
           <p:cNvPr id="9" name="TextBox 8">
             <a:extLst>
               <a:ext uri="{FF2B5EF4-FFF2-40B4-BE49-F238E27FC236}">
-                <a16:creationId xmlns:a16="http://schemas.microsoft.com/office/drawing/2014/main" id="{F869BF73-0970-4AD4-4DCD-712A77055671}"/>
+                <ns2:creationId id="{F869BF73-0970-4AD4-4DCD-712A77055671}"/>
               </a:ext>
             </a:extLst>
           </p:cNvPr>
@@ -28844,7 +29761,7 @@
           <p:cNvPr id="16" name="Oval 15">
             <a:extLst>
               <a:ext uri="{FF2B5EF4-FFF2-40B4-BE49-F238E27FC236}">
-                <a16:creationId xmlns:a16="http://schemas.microsoft.com/office/drawing/2014/main" id="{47B844F6-2777-F09D-48E3-752AD4A1C08E}"/>
+                <ns2:creationId id="{47B844F6-2777-F09D-48E3-752AD4A1C08E}"/>
               </a:ext>
             </a:extLst>
           </p:cNvPr>
@@ -28927,7 +29844,7 @@
           <p:cNvPr id="17" name="Straight Connector 16">
             <a:extLst>
               <a:ext uri="{FF2B5EF4-FFF2-40B4-BE49-F238E27FC236}">
-                <a16:creationId xmlns:a16="http://schemas.microsoft.com/office/drawing/2014/main" id="{7AC80066-19A2-40E6-CB32-8D867099AEC0}"/>
+                <ns2:creationId id="{7AC80066-19A2-40E6-CB32-8D867099AEC0}"/>
               </a:ext>
             </a:extLst>
           </p:cNvPr>
@@ -28972,7 +29889,7 @@
           <p:cNvPr id="33" name="Oval 32">
             <a:extLst>
               <a:ext uri="{FF2B5EF4-FFF2-40B4-BE49-F238E27FC236}">
-                <a16:creationId xmlns:a16="http://schemas.microsoft.com/office/drawing/2014/main" id="{E44B2491-CAC8-31F5-74F1-2F5E82758D29}"/>
+                <ns2:creationId id="{E44B2491-CAC8-31F5-74F1-2F5E82758D29}"/>
               </a:ext>
             </a:extLst>
           </p:cNvPr>
@@ -29055,7 +29972,7 @@
           <p:cNvPr id="34" name="Straight Connector 33">
             <a:extLst>
               <a:ext uri="{FF2B5EF4-FFF2-40B4-BE49-F238E27FC236}">
-                <a16:creationId xmlns:a16="http://schemas.microsoft.com/office/drawing/2014/main" id="{39925079-57E3-C749-66BE-49320C7E84EA}"/>
+                <ns2:creationId id="{39925079-57E3-C749-66BE-49320C7E84EA}"/>
               </a:ext>
             </a:extLst>
           </p:cNvPr>
@@ -29098,7 +30015,7 @@
     </p:spTree>
     <p:extLst>
       <p:ext uri="{BB962C8B-B14F-4D97-AF65-F5344CB8AC3E}">
-        <p14:creationId xmlns:p14="http://schemas.microsoft.com/office/powerpoint/2010/main" val="155428920"/>
+        <ns3:creationId val="155428920"/>
       </p:ext>
     </p:extLst>
   </p:cSld>
@@ -29109,7 +30026,7 @@
 </file>
 
 <file path=ppt/slides/slide6.xml><?xml version="1.0" encoding="utf-8"?>
-<p:sld xmlns:a="http://schemas.openxmlformats.org/drawingml/2006/main" xmlns:r="http://schemas.openxmlformats.org/officeDocument/2006/relationships" xmlns:p="http://schemas.openxmlformats.org/presentationml/2006/main">
+<p:sld xmlns:a="http://schemas.openxmlformats.org/drawingml/2006/main" xmlns:ns2="http://schemas.microsoft.com/office/drawing/2014/main" xmlns:ns3="http://schemas.microsoft.com/office/powerpoint/2010/main" xmlns:p="http://schemas.openxmlformats.org/presentationml/2006/main">
   <p:cSld>
     <p:bg>
       <p:bgPr>
@@ -29138,7 +30055,7 @@
           <p:cNvPr id="5" name="Footer Placeholder 3">
             <a:extLst>
               <a:ext uri="{FF2B5EF4-FFF2-40B4-BE49-F238E27FC236}">
-                <a16:creationId xmlns:a16="http://schemas.microsoft.com/office/drawing/2014/main" id="{668F77D6-DFDA-5A46-8DF1-47F6A167C2B1}"/>
+                <ns2:creationId id="{668F77D6-DFDA-5A46-8DF1-47F6A167C2B1}"/>
               </a:ext>
             </a:extLst>
           </p:cNvPr>
@@ -29300,7 +30217,7 @@
           <p:cNvPr id="26" name="TextBox 25">
             <a:extLst>
               <a:ext uri="{FF2B5EF4-FFF2-40B4-BE49-F238E27FC236}">
-                <a16:creationId xmlns:a16="http://schemas.microsoft.com/office/drawing/2014/main" id="{FA5E13D2-A15E-F54D-9507-CAD768919361}"/>
+                <ns2:creationId id="{FA5E13D2-A15E-F54D-9507-CAD768919361}"/>
               </a:ext>
             </a:extLst>
           </p:cNvPr>
@@ -29355,7 +30272,58 @@
                 <a:ea typeface="Helvetica Neue" panose="02000503000000020004" pitchFamily="2" charset="0"/>
                 <a:cs typeface="Helvetica Neue" panose="02000503000000020004" pitchFamily="2" charset="0"/>
               </a:rPr>
-              <a:t>At v = c_f, an architrino is at the wake-speed threshold.</a:t>
+              <a:t xml:space="preserve">At v = </a:t>
+            </a:r>
+            <a:r>
+              <a:rPr kumimoji="0" lang="en-US" b="0" i="0" u="none" strike="noStrike" kern="1200" cap="none" spc="0" normalizeH="0" baseline="0" noProof="0" dirty="0">
+                <a:ln>
+                  <a:noFill/>
+                </a:ln>
+                <a:solidFill>
+                  <a:prstClr val="white"/>
+                </a:solidFill>
+                <a:effectLst/>
+                <a:uLnTx/>
+                <a:uFillTx/>
+                <a:latin typeface="Helvetica Neue" panose="02000503000000020004" pitchFamily="2" charset="0"/>
+                <a:ea typeface="Helvetica Neue" panose="02000503000000020004" pitchFamily="2" charset="0"/>
+                <a:cs typeface="Helvetica Neue" panose="02000503000000020004" pitchFamily="2" charset="0"/>
+              </a:rPr>
+              <a:t>c</a:t>
+            </a:r>
+            <a:r>
+              <a:rPr kumimoji="0" lang="en-US" b="0" i="0" u="none" strike="noStrike" kern="1200" cap="none" spc="0" normalizeH="0" baseline="-25000" noProof="0" dirty="0" sz="1960">
+                <a:ln>
+                  <a:noFill/>
+                </a:ln>
+                <a:solidFill>
+                  <a:prstClr val="white"/>
+                </a:solidFill>
+                <a:effectLst/>
+                <a:uLnTx/>
+                <a:uFillTx/>
+                <a:latin typeface="Helvetica Neue" panose="02000503000000020004" pitchFamily="2" charset="0"/>
+                <a:ea typeface="Helvetica Neue" panose="02000503000000020004" pitchFamily="2" charset="0"/>
+                <a:cs typeface="Helvetica Neue" panose="02000503000000020004" pitchFamily="2" charset="0"/>
+              </a:rPr>
+              <a:t>f</a:t>
+            </a:r>
+            <a:r>
+              <a:rPr kumimoji="0" lang="en-US" b="0" i="0" u="none" strike="noStrike" kern="1200" cap="none" spc="0" normalizeH="0" baseline="0" noProof="0" dirty="0">
+                <a:ln>
+                  <a:noFill/>
+                </a:ln>
+                <a:solidFill>
+                  <a:prstClr val="white"/>
+                </a:solidFill>
+                <a:effectLst/>
+                <a:uLnTx/>
+                <a:uFillTx/>
+                <a:latin typeface="Helvetica Neue" panose="02000503000000020004" pitchFamily="2" charset="0"/>
+                <a:ea typeface="Helvetica Neue" panose="02000503000000020004" pitchFamily="2" charset="0"/>
+                <a:cs typeface="Helvetica Neue" panose="02000503000000020004" pitchFamily="2" charset="0"/>
+              </a:rPr>
+              <a:t>, an architrino is at the wake-speed threshold.</a:t>
             </a:r>
           </a:p>
           <a:p>
@@ -29509,7 +30477,7 @@
           <p:cNvPr id="23" name="Oval 22">
             <a:extLst>
               <a:ext uri="{FF2B5EF4-FFF2-40B4-BE49-F238E27FC236}">
-                <a16:creationId xmlns:a16="http://schemas.microsoft.com/office/drawing/2014/main" id="{0112617B-A1D5-1E41-BF92-E67D4E046E39}"/>
+                <ns2:creationId id="{0112617B-A1D5-1E41-BF92-E67D4E046E39}"/>
               </a:ext>
             </a:extLst>
           </p:cNvPr>
@@ -29593,7 +30561,7 @@
           <p:cNvPr id="27" name="Oval 26">
             <a:extLst>
               <a:ext uri="{FF2B5EF4-FFF2-40B4-BE49-F238E27FC236}">
-                <a16:creationId xmlns:a16="http://schemas.microsoft.com/office/drawing/2014/main" id="{6EF0F7DA-5E70-8348-A200-F59A10FF7C55}"/>
+                <ns2:creationId id="{6EF0F7DA-5E70-8348-A200-F59A10FF7C55}"/>
               </a:ext>
             </a:extLst>
           </p:cNvPr>
@@ -29677,7 +30645,7 @@
           <p:cNvPr id="28" name="Oval 27">
             <a:extLst>
               <a:ext uri="{FF2B5EF4-FFF2-40B4-BE49-F238E27FC236}">
-                <a16:creationId xmlns:a16="http://schemas.microsoft.com/office/drawing/2014/main" id="{552F58D0-F613-674A-B294-C894E5FB1683}"/>
+                <ns2:creationId id="{552F58D0-F613-674A-B294-C894E5FB1683}"/>
               </a:ext>
             </a:extLst>
           </p:cNvPr>
@@ -29761,7 +30729,7 @@
           <p:cNvPr id="29" name="Oval 28">
             <a:extLst>
               <a:ext uri="{FF2B5EF4-FFF2-40B4-BE49-F238E27FC236}">
-                <a16:creationId xmlns:a16="http://schemas.microsoft.com/office/drawing/2014/main" id="{9CA7A721-D3BD-744E-9306-85BBED5F74BC}"/>
+                <ns2:creationId id="{9CA7A721-D3BD-744E-9306-85BBED5F74BC}"/>
               </a:ext>
             </a:extLst>
           </p:cNvPr>
@@ -29845,7 +30813,7 @@
           <p:cNvPr id="30" name="Oval 29">
             <a:extLst>
               <a:ext uri="{FF2B5EF4-FFF2-40B4-BE49-F238E27FC236}">
-                <a16:creationId xmlns:a16="http://schemas.microsoft.com/office/drawing/2014/main" id="{F97F1A02-C0C7-3C45-9790-847C152D159A}"/>
+                <ns2:creationId id="{F97F1A02-C0C7-3C45-9790-847C152D159A}"/>
               </a:ext>
             </a:extLst>
           </p:cNvPr>
@@ -29929,7 +30897,7 @@
           <p:cNvPr id="15" name="Straight Arrow Connector 14">
             <a:extLst>
               <a:ext uri="{FF2B5EF4-FFF2-40B4-BE49-F238E27FC236}">
-                <a16:creationId xmlns:a16="http://schemas.microsoft.com/office/drawing/2014/main" id="{05289ED1-4679-6543-A669-B23443FD0CD8}"/>
+                <ns2:creationId id="{05289ED1-4679-6543-A669-B23443FD0CD8}"/>
               </a:ext>
             </a:extLst>
           </p:cNvPr>
@@ -29974,7 +30942,7 @@
           <p:cNvPr id="32" name="Straight Arrow Connector 31">
             <a:extLst>
               <a:ext uri="{FF2B5EF4-FFF2-40B4-BE49-F238E27FC236}">
-                <a16:creationId xmlns:a16="http://schemas.microsoft.com/office/drawing/2014/main" id="{A9F8BF55-7F79-854D-84AD-A730BF43B39C}"/>
+                <ns2:creationId id="{A9F8BF55-7F79-854D-84AD-A730BF43B39C}"/>
               </a:ext>
             </a:extLst>
           </p:cNvPr>
@@ -30019,7 +30987,7 @@
           <p:cNvPr id="35" name="Straight Arrow Connector 34">
             <a:extLst>
               <a:ext uri="{FF2B5EF4-FFF2-40B4-BE49-F238E27FC236}">
-                <a16:creationId xmlns:a16="http://schemas.microsoft.com/office/drawing/2014/main" id="{0415B495-590C-0049-92E6-8AE7464CC78A}"/>
+                <ns2:creationId id="{0415B495-590C-0049-92E6-8AE7464CC78A}"/>
               </a:ext>
             </a:extLst>
           </p:cNvPr>
@@ -30064,7 +31032,7 @@
           <p:cNvPr id="39" name="Straight Arrow Connector 38">
             <a:extLst>
               <a:ext uri="{FF2B5EF4-FFF2-40B4-BE49-F238E27FC236}">
-                <a16:creationId xmlns:a16="http://schemas.microsoft.com/office/drawing/2014/main" id="{E4879E96-726B-4F42-BD7C-09F8D0B14E9A}"/>
+                <ns2:creationId id="{E4879E96-726B-4F42-BD7C-09F8D0B14E9A}"/>
               </a:ext>
             </a:extLst>
           </p:cNvPr>
@@ -30109,7 +31077,7 @@
           <p:cNvPr id="47" name="Straight Arrow Connector 46">
             <a:extLst>
               <a:ext uri="{FF2B5EF4-FFF2-40B4-BE49-F238E27FC236}">
-                <a16:creationId xmlns:a16="http://schemas.microsoft.com/office/drawing/2014/main" id="{0F119609-4333-414A-B8E4-E2447D7E1C10}"/>
+                <ns2:creationId id="{0F119609-4333-414A-B8E4-E2447D7E1C10}"/>
               </a:ext>
             </a:extLst>
           </p:cNvPr>
@@ -30154,7 +31122,7 @@
           <p:cNvPr id="4" name="Straight Connector 3">
             <a:extLst>
               <a:ext uri="{FF2B5EF4-FFF2-40B4-BE49-F238E27FC236}">
-                <a16:creationId xmlns:a16="http://schemas.microsoft.com/office/drawing/2014/main" id="{9890CC23-4ADC-D744-AF2D-1C8A936F07FC}"/>
+                <ns2:creationId id="{9890CC23-4ADC-D744-AF2D-1C8A936F07FC}"/>
               </a:ext>
             </a:extLst>
           </p:cNvPr>
@@ -30197,7 +31165,7 @@
           <p:cNvPr id="18" name="Oval 17">
             <a:extLst>
               <a:ext uri="{FF2B5EF4-FFF2-40B4-BE49-F238E27FC236}">
-                <a16:creationId xmlns:a16="http://schemas.microsoft.com/office/drawing/2014/main" id="{BE4CDC90-4B2E-BE41-BB9D-A84675F3A2FE}"/>
+                <ns2:creationId id="{BE4CDC90-4B2E-BE41-BB9D-A84675F3A2FE}"/>
               </a:ext>
             </a:extLst>
           </p:cNvPr>
@@ -30278,7 +31246,7 @@
           <p:cNvPr id="24" name="Straight Arrow Connector 23">
             <a:extLst>
               <a:ext uri="{FF2B5EF4-FFF2-40B4-BE49-F238E27FC236}">
-                <a16:creationId xmlns:a16="http://schemas.microsoft.com/office/drawing/2014/main" id="{7BCF22C9-C9AE-324D-B157-A9536FCAF3B6}"/>
+                <ns2:creationId id="{7BCF22C9-C9AE-324D-B157-A9536FCAF3B6}"/>
               </a:ext>
             </a:extLst>
           </p:cNvPr>
@@ -30323,7 +31291,7 @@
           <p:cNvPr id="10" name="TextBox 9">
             <a:extLst>
               <a:ext uri="{FF2B5EF4-FFF2-40B4-BE49-F238E27FC236}">
-                <a16:creationId xmlns:a16="http://schemas.microsoft.com/office/drawing/2014/main" id="{01A59953-657F-C641-8F36-E48E8EDB0DF1}"/>
+                <ns2:creationId id="{01A59953-657F-C641-8F36-E48E8EDB0DF1}"/>
               </a:ext>
             </a:extLst>
           </p:cNvPr>
@@ -30378,7 +31346,41 @@
                 <a:ea typeface="Helvetica Neue" panose="02000503000000020004" pitchFamily="2" charset="0"/>
                 <a:cs typeface="Helvetica Neue" panose="02000503000000020004" pitchFamily="2" charset="0"/>
               </a:rPr>
-              <a:t>v = c_f</a:t>
+              <a:t xml:space="preserve">v = </a:t>
+            </a:r>
+            <a:r>
+              <a:rPr kumimoji="0" lang="en-US" sz="1400" b="0" i="1" u="none" strike="noStrike" kern="1200" cap="none" spc="0" normalizeH="0" baseline="0" noProof="0" dirty="0">
+                <a:ln>
+                  <a:noFill/>
+                </a:ln>
+                <a:solidFill>
+                  <a:prstClr val="white"/>
+                </a:solidFill>
+                <a:effectLst/>
+                <a:uLnTx/>
+                <a:uFillTx/>
+                <a:latin typeface="Helvetica Neue" panose="02000503000000020004" pitchFamily="2" charset="0"/>
+                <a:ea typeface="Helvetica Neue" panose="02000503000000020004" pitchFamily="2" charset="0"/>
+                <a:cs typeface="Helvetica Neue" panose="02000503000000020004" pitchFamily="2" charset="0"/>
+              </a:rPr>
+              <a:t>c</a:t>
+            </a:r>
+            <a:r>
+              <a:rPr kumimoji="0" lang="en-US" sz="980" b="0" i="1" u="none" strike="noStrike" kern="1200" cap="none" spc="0" normalizeH="0" baseline="-25000" noProof="0" dirty="0">
+                <a:ln>
+                  <a:noFill/>
+                </a:ln>
+                <a:solidFill>
+                  <a:prstClr val="white"/>
+                </a:solidFill>
+                <a:effectLst/>
+                <a:uLnTx/>
+                <a:uFillTx/>
+                <a:latin typeface="Helvetica Neue" panose="02000503000000020004" pitchFamily="2" charset="0"/>
+                <a:ea typeface="Helvetica Neue" panose="02000503000000020004" pitchFamily="2" charset="0"/>
+                <a:cs typeface="Helvetica Neue" panose="02000503000000020004" pitchFamily="2" charset="0"/>
+              </a:rPr>
+              <a:t>f</a:t>
             </a:r>
           </a:p>
         </p:txBody>
@@ -30388,7 +31390,7 @@
           <p:cNvPr id="31" name="TextBox 30">
             <a:extLst>
               <a:ext uri="{FF2B5EF4-FFF2-40B4-BE49-F238E27FC236}">
-                <a16:creationId xmlns:a16="http://schemas.microsoft.com/office/drawing/2014/main" id="{713B9ACE-B673-2D48-BEF2-2A133C31B527}"/>
+                <ns2:creationId id="{713B9ACE-B673-2D48-BEF2-2A133C31B527}"/>
               </a:ext>
             </a:extLst>
           </p:cNvPr>
@@ -30443,7 +31445,24 @@
                 <a:ea typeface="Helvetica Neue" panose="02000503000000020004" pitchFamily="2" charset="0"/>
                 <a:cs typeface="Helvetica Neue" panose="02000503000000020004" pitchFamily="2" charset="0"/>
               </a:rPr>
-              <a:t>c_f</a:t>
+              <a:t>c</a:t>
+            </a:r>
+            <a:r>
+              <a:rPr kumimoji="0" lang="en-US" sz="980" b="0" i="1" u="none" strike="noStrike" kern="1200" cap="none" spc="0" normalizeH="0" baseline="-25000" noProof="0" dirty="0">
+                <a:ln>
+                  <a:noFill/>
+                </a:ln>
+                <a:solidFill>
+                  <a:prstClr val="white"/>
+                </a:solidFill>
+                <a:effectLst/>
+                <a:uLnTx/>
+                <a:uFillTx/>
+                <a:latin typeface="Helvetica Neue" panose="02000503000000020004" pitchFamily="2" charset="0"/>
+                <a:ea typeface="Helvetica Neue" panose="02000503000000020004" pitchFamily="2" charset="0"/>
+                <a:cs typeface="Helvetica Neue" panose="02000503000000020004" pitchFamily="2" charset="0"/>
+              </a:rPr>
+              <a:t>f</a:t>
             </a:r>
           </a:p>
         </p:txBody>
@@ -30453,7 +31472,7 @@
           <p:cNvPr id="36" name="TextBox 35">
             <a:extLst>
               <a:ext uri="{FF2B5EF4-FFF2-40B4-BE49-F238E27FC236}">
-                <a16:creationId xmlns:a16="http://schemas.microsoft.com/office/drawing/2014/main" id="{3A81A480-EF64-094E-825A-8592DAA4C672}"/>
+                <ns2:creationId id="{3A81A480-EF64-094E-825A-8592DAA4C672}"/>
               </a:ext>
             </a:extLst>
           </p:cNvPr>
@@ -30532,7 +31551,7 @@
           <p:cNvPr id="22" name="Straight Connector 21">
             <a:extLst>
               <a:ext uri="{FF2B5EF4-FFF2-40B4-BE49-F238E27FC236}">
-                <a16:creationId xmlns:a16="http://schemas.microsoft.com/office/drawing/2014/main" id="{0C67DA45-6876-7942-9996-48CA0A1696FE}"/>
+                <ns2:creationId id="{0C67DA45-6876-7942-9996-48CA0A1696FE}"/>
               </a:ext>
             </a:extLst>
           </p:cNvPr>
@@ -30575,7 +31594,7 @@
           <p:cNvPr id="7" name="TextBox 6">
             <a:extLst>
               <a:ext uri="{FF2B5EF4-FFF2-40B4-BE49-F238E27FC236}">
-                <a16:creationId xmlns:a16="http://schemas.microsoft.com/office/drawing/2014/main" id="{FE7A6F30-9D38-0B1B-2076-531827EE9F50}"/>
+                <ns2:creationId id="{FE7A6F30-9D38-0B1B-2076-531827EE9F50}"/>
               </a:ext>
             </a:extLst>
           </p:cNvPr>
@@ -30630,7 +31649,41 @@
                 <a:ea typeface="Helvetica Neue" panose="02000503000000020004" pitchFamily="2" charset="0"/>
                 <a:cs typeface="Helvetica Neue" panose="02000503000000020004" pitchFamily="2" charset="0"/>
               </a:rPr>
-              <a:t>Architrino on Linear Path with Velocity v = c_f</a:t>
+              <a:t xml:space="preserve">Architrino on Linear Path with Velocity v = </a:t>
+            </a:r>
+            <a:r>
+              <a:rPr kumimoji="0" lang="en-US" sz="3200" b="1" i="0" u="none" strike="noStrike" kern="1200" cap="none" spc="0" normalizeH="0" baseline="0" noProof="0" dirty="0">
+                <a:ln>
+                  <a:noFill/>
+                </a:ln>
+                <a:solidFill>
+                  <a:prstClr val="white"/>
+                </a:solidFill>
+                <a:effectLst/>
+                <a:uLnTx/>
+                <a:uFillTx/>
+                <a:latin typeface="Helvetica Neue" panose="02000503000000020004" pitchFamily="2" charset="0"/>
+                <a:ea typeface="Helvetica Neue" panose="02000503000000020004" pitchFamily="2" charset="0"/>
+                <a:cs typeface="Helvetica Neue" panose="02000503000000020004" pitchFamily="2" charset="0"/>
+              </a:rPr>
+              <a:t>c</a:t>
+            </a:r>
+            <a:r>
+              <a:rPr kumimoji="0" lang="en-US" sz="2240" b="1" i="0" u="none" strike="noStrike" kern="1200" cap="none" spc="0" normalizeH="0" baseline="-25000" noProof="0" dirty="0">
+                <a:ln>
+                  <a:noFill/>
+                </a:ln>
+                <a:solidFill>
+                  <a:prstClr val="white"/>
+                </a:solidFill>
+                <a:effectLst/>
+                <a:uLnTx/>
+                <a:uFillTx/>
+                <a:latin typeface="Helvetica Neue" panose="02000503000000020004" pitchFamily="2" charset="0"/>
+                <a:ea typeface="Helvetica Neue" panose="02000503000000020004" pitchFamily="2" charset="0"/>
+                <a:cs typeface="Helvetica Neue" panose="02000503000000020004" pitchFamily="2" charset="0"/>
+              </a:rPr>
+              <a:t>f</a:t>
             </a:r>
           </a:p>
         </p:txBody>
@@ -30640,7 +31693,7 @@
           <p:cNvPr id="2" name="Group 1">
             <a:extLst>
               <a:ext uri="{FF2B5EF4-FFF2-40B4-BE49-F238E27FC236}">
-                <a16:creationId xmlns:a16="http://schemas.microsoft.com/office/drawing/2014/main" id="{B98AD1F2-987D-71EB-A470-E4A41A905EDF}"/>
+                <ns2:creationId id="{B98AD1F2-987D-71EB-A470-E4A41A905EDF}"/>
               </a:ext>
             </a:extLst>
           </p:cNvPr>
@@ -30660,7 +31713,7 @@
             <p:cNvPr id="6" name="Straight Arrow Connector 5">
               <a:extLst>
                 <a:ext uri="{FF2B5EF4-FFF2-40B4-BE49-F238E27FC236}">
-                  <a16:creationId xmlns:a16="http://schemas.microsoft.com/office/drawing/2014/main" id="{836C1A95-A13A-0EE6-733B-6B2D96A15332}"/>
+                  <ns2:creationId id="{836C1A95-A13A-0EE6-733B-6B2D96A15332}"/>
                 </a:ext>
               </a:extLst>
             </p:cNvPr>
@@ -30704,7 +31757,7 @@
             <p:cNvPr id="9" name="Straight Arrow Connector 8">
               <a:extLst>
                 <a:ext uri="{FF2B5EF4-FFF2-40B4-BE49-F238E27FC236}">
-                  <a16:creationId xmlns:a16="http://schemas.microsoft.com/office/drawing/2014/main" id="{8AA9E325-051B-BE4A-55F2-7CFF0AFD3797}"/>
+                  <ns2:creationId id="{8AA9E325-051B-BE4A-55F2-7CFF0AFD3797}"/>
                 </a:ext>
               </a:extLst>
             </p:cNvPr>
@@ -30748,7 +31801,7 @@
             <p:cNvPr id="11" name="TextBox 10">
               <a:extLst>
                 <a:ext uri="{FF2B5EF4-FFF2-40B4-BE49-F238E27FC236}">
-                  <a16:creationId xmlns:a16="http://schemas.microsoft.com/office/drawing/2014/main" id="{DF6E9CDB-4ADF-E626-B2A4-DEA60E4A02F0}"/>
+                  <ns2:creationId id="{DF6E9CDB-4ADF-E626-B2A4-DEA60E4A02F0}"/>
                 </a:ext>
               </a:extLst>
             </p:cNvPr>
@@ -30813,7 +31866,7 @@
             <p:cNvPr id="14" name="TextBox 13">
               <a:extLst>
                 <a:ext uri="{FF2B5EF4-FFF2-40B4-BE49-F238E27FC236}">
-                  <a16:creationId xmlns:a16="http://schemas.microsoft.com/office/drawing/2014/main" id="{01E78D1F-323F-0A4F-4B30-4CE146D0EB63}"/>
+                  <ns2:creationId id="{01E78D1F-323F-0A4F-4B30-4CE146D0EB63}"/>
                 </a:ext>
               </a:extLst>
             </p:cNvPr>
@@ -30913,7 +31966,7 @@
     </p:spTree>
     <p:extLst>
       <p:ext uri="{BB962C8B-B14F-4D97-AF65-F5344CB8AC3E}">
-        <p14:creationId xmlns:p14="http://schemas.microsoft.com/office/powerpoint/2010/main" val="4081239535"/>
+        <ns3:creationId val="4081239535"/>
       </p:ext>
     </p:extLst>
   </p:cSld>
@@ -30924,7 +31977,7 @@
 </file>
 
 <file path=ppt/slides/slide7.xml><?xml version="1.0" encoding="utf-8"?>
-<p:sld xmlns:a="http://schemas.openxmlformats.org/drawingml/2006/main" xmlns:r="http://schemas.openxmlformats.org/officeDocument/2006/relationships" xmlns:p="http://schemas.openxmlformats.org/presentationml/2006/main">
+<p:sld xmlns:a="http://schemas.openxmlformats.org/drawingml/2006/main" xmlns:ns2="http://schemas.microsoft.com/office/drawing/2014/main" xmlns:ns3="http://schemas.microsoft.com/office/powerpoint/2010/main" xmlns:p="http://schemas.openxmlformats.org/presentationml/2006/main">
   <p:cSld>
     <p:bg>
       <p:bgPr>
@@ -30953,7 +32006,7 @@
           <p:cNvPr id="5" name="Footer Placeholder 3">
             <a:extLst>
               <a:ext uri="{FF2B5EF4-FFF2-40B4-BE49-F238E27FC236}">
-                <a16:creationId xmlns:a16="http://schemas.microsoft.com/office/drawing/2014/main" id="{668F77D6-DFDA-5A46-8DF1-47F6A167C2B1}"/>
+                <ns2:creationId id="{668F77D6-DFDA-5A46-8DF1-47F6A167C2B1}"/>
               </a:ext>
             </a:extLst>
           </p:cNvPr>
@@ -31115,7 +32168,7 @@
           <p:cNvPr id="26" name="TextBox 25">
             <a:extLst>
               <a:ext uri="{FF2B5EF4-FFF2-40B4-BE49-F238E27FC236}">
-                <a16:creationId xmlns:a16="http://schemas.microsoft.com/office/drawing/2014/main" id="{FA5E13D2-A15E-F54D-9507-CAD768919361}"/>
+                <ns2:creationId id="{FA5E13D2-A15E-F54D-9507-CAD768919361}"/>
               </a:ext>
             </a:extLst>
           </p:cNvPr>
@@ -31170,7 +32223,58 @@
                 <a:ea typeface="Helvetica Neue" panose="02000503000000020004" pitchFamily="2" charset="0"/>
                 <a:cs typeface="Helvetica Neue" panose="02000503000000020004" pitchFamily="2" charset="0"/>
               </a:rPr>
-              <a:t>Imagine an architrino with linear velocity v &gt; c_f, above wake speed.</a:t>
+              <a:t xml:space="preserve">Imagine an architrino with linear velocity v &gt; </a:t>
+            </a:r>
+            <a:r>
+              <a:rPr kumimoji="0" lang="en-US" sz="1600" b="0" i="0" u="none" strike="noStrike" kern="1200" cap="none" spc="0" normalizeH="0" baseline="0" noProof="0" dirty="0">
+                <a:ln>
+                  <a:noFill/>
+                </a:ln>
+                <a:solidFill>
+                  <a:prstClr val="white"/>
+                </a:solidFill>
+                <a:effectLst/>
+                <a:uLnTx/>
+                <a:uFillTx/>
+                <a:latin typeface="Helvetica Neue" panose="02000503000000020004" pitchFamily="2" charset="0"/>
+                <a:ea typeface="Helvetica Neue" panose="02000503000000020004" pitchFamily="2" charset="0"/>
+                <a:cs typeface="Helvetica Neue" panose="02000503000000020004" pitchFamily="2" charset="0"/>
+              </a:rPr>
+              <a:t>c</a:t>
+            </a:r>
+            <a:r>
+              <a:rPr kumimoji="0" lang="en-US" sz="1120" b="0" i="0" u="none" strike="noStrike" kern="1200" cap="none" spc="0" normalizeH="0" baseline="-25000" noProof="0" dirty="0">
+                <a:ln>
+                  <a:noFill/>
+                </a:ln>
+                <a:solidFill>
+                  <a:prstClr val="white"/>
+                </a:solidFill>
+                <a:effectLst/>
+                <a:uLnTx/>
+                <a:uFillTx/>
+                <a:latin typeface="Helvetica Neue" panose="02000503000000020004" pitchFamily="2" charset="0"/>
+                <a:ea typeface="Helvetica Neue" panose="02000503000000020004" pitchFamily="2" charset="0"/>
+                <a:cs typeface="Helvetica Neue" panose="02000503000000020004" pitchFamily="2" charset="0"/>
+              </a:rPr>
+              <a:t>f</a:t>
+            </a:r>
+            <a:r>
+              <a:rPr kumimoji="0" lang="en-US" sz="1600" b="0" i="0" u="none" strike="noStrike" kern="1200" cap="none" spc="0" normalizeH="0" baseline="0" noProof="0" dirty="0">
+                <a:ln>
+                  <a:noFill/>
+                </a:ln>
+                <a:solidFill>
+                  <a:prstClr val="white"/>
+                </a:solidFill>
+                <a:effectLst/>
+                <a:uLnTx/>
+                <a:uFillTx/>
+                <a:latin typeface="Helvetica Neue" panose="02000503000000020004" pitchFamily="2" charset="0"/>
+                <a:ea typeface="Helvetica Neue" panose="02000503000000020004" pitchFamily="2" charset="0"/>
+                <a:cs typeface="Helvetica Neue" panose="02000503000000020004" pitchFamily="2" charset="0"/>
+              </a:rPr>
+              <a:t>, above wake speed.</a:t>
             </a:r>
           </a:p>
           <a:p>
@@ -31252,7 +32356,7 @@
           <p:cNvPr id="23" name="Oval 22">
             <a:extLst>
               <a:ext uri="{FF2B5EF4-FFF2-40B4-BE49-F238E27FC236}">
-                <a16:creationId xmlns:a16="http://schemas.microsoft.com/office/drawing/2014/main" id="{0112617B-A1D5-1E41-BF92-E67D4E046E39}"/>
+                <ns2:creationId id="{0112617B-A1D5-1E41-BF92-E67D4E046E39}"/>
               </a:ext>
             </a:extLst>
           </p:cNvPr>
@@ -31336,7 +32440,7 @@
           <p:cNvPr id="27" name="Oval 26">
             <a:extLst>
               <a:ext uri="{FF2B5EF4-FFF2-40B4-BE49-F238E27FC236}">
-                <a16:creationId xmlns:a16="http://schemas.microsoft.com/office/drawing/2014/main" id="{6EF0F7DA-5E70-8348-A200-F59A10FF7C55}"/>
+                <ns2:creationId id="{6EF0F7DA-5E70-8348-A200-F59A10FF7C55}"/>
               </a:ext>
             </a:extLst>
           </p:cNvPr>
@@ -31420,7 +32524,7 @@
           <p:cNvPr id="28" name="Oval 27">
             <a:extLst>
               <a:ext uri="{FF2B5EF4-FFF2-40B4-BE49-F238E27FC236}">
-                <a16:creationId xmlns:a16="http://schemas.microsoft.com/office/drawing/2014/main" id="{552F58D0-F613-674A-B294-C894E5FB1683}"/>
+                <ns2:creationId id="{552F58D0-F613-674A-B294-C894E5FB1683}"/>
               </a:ext>
             </a:extLst>
           </p:cNvPr>
@@ -31504,7 +32608,7 @@
           <p:cNvPr id="29" name="Oval 28">
             <a:extLst>
               <a:ext uri="{FF2B5EF4-FFF2-40B4-BE49-F238E27FC236}">
-                <a16:creationId xmlns:a16="http://schemas.microsoft.com/office/drawing/2014/main" id="{9CA7A721-D3BD-744E-9306-85BBED5F74BC}"/>
+                <ns2:creationId id="{9CA7A721-D3BD-744E-9306-85BBED5F74BC}"/>
               </a:ext>
             </a:extLst>
           </p:cNvPr>
@@ -31588,7 +32692,7 @@
           <p:cNvPr id="30" name="Oval 29">
             <a:extLst>
               <a:ext uri="{FF2B5EF4-FFF2-40B4-BE49-F238E27FC236}">
-                <a16:creationId xmlns:a16="http://schemas.microsoft.com/office/drawing/2014/main" id="{F97F1A02-C0C7-3C45-9790-847C152D159A}"/>
+                <ns2:creationId id="{F97F1A02-C0C7-3C45-9790-847C152D159A}"/>
               </a:ext>
             </a:extLst>
           </p:cNvPr>
@@ -31672,7 +32776,7 @@
           <p:cNvPr id="15" name="Straight Arrow Connector 14">
             <a:extLst>
               <a:ext uri="{FF2B5EF4-FFF2-40B4-BE49-F238E27FC236}">
-                <a16:creationId xmlns:a16="http://schemas.microsoft.com/office/drawing/2014/main" id="{05289ED1-4679-6543-A669-B23443FD0CD8}"/>
+                <ns2:creationId id="{05289ED1-4679-6543-A669-B23443FD0CD8}"/>
               </a:ext>
             </a:extLst>
           </p:cNvPr>
@@ -31717,7 +32821,7 @@
           <p:cNvPr id="32" name="Straight Arrow Connector 31">
             <a:extLst>
               <a:ext uri="{FF2B5EF4-FFF2-40B4-BE49-F238E27FC236}">
-                <a16:creationId xmlns:a16="http://schemas.microsoft.com/office/drawing/2014/main" id="{A9F8BF55-7F79-854D-84AD-A730BF43B39C}"/>
+                <ns2:creationId id="{A9F8BF55-7F79-854D-84AD-A730BF43B39C}"/>
               </a:ext>
             </a:extLst>
           </p:cNvPr>
@@ -31762,7 +32866,7 @@
           <p:cNvPr id="35" name="Straight Arrow Connector 34">
             <a:extLst>
               <a:ext uri="{FF2B5EF4-FFF2-40B4-BE49-F238E27FC236}">
-                <a16:creationId xmlns:a16="http://schemas.microsoft.com/office/drawing/2014/main" id="{0415B495-590C-0049-92E6-8AE7464CC78A}"/>
+                <ns2:creationId id="{0415B495-590C-0049-92E6-8AE7464CC78A}"/>
               </a:ext>
             </a:extLst>
           </p:cNvPr>
@@ -31807,7 +32911,7 @@
           <p:cNvPr id="39" name="Straight Arrow Connector 38">
             <a:extLst>
               <a:ext uri="{FF2B5EF4-FFF2-40B4-BE49-F238E27FC236}">
-                <a16:creationId xmlns:a16="http://schemas.microsoft.com/office/drawing/2014/main" id="{E4879E96-726B-4F42-BD7C-09F8D0B14E9A}"/>
+                <ns2:creationId id="{E4879E96-726B-4F42-BD7C-09F8D0B14E9A}"/>
               </a:ext>
             </a:extLst>
           </p:cNvPr>
@@ -31852,7 +32956,7 @@
           <p:cNvPr id="47" name="Straight Arrow Connector 46">
             <a:extLst>
               <a:ext uri="{FF2B5EF4-FFF2-40B4-BE49-F238E27FC236}">
-                <a16:creationId xmlns:a16="http://schemas.microsoft.com/office/drawing/2014/main" id="{0F119609-4333-414A-B8E4-E2447D7E1C10}"/>
+                <ns2:creationId id="{0F119609-4333-414A-B8E4-E2447D7E1C10}"/>
               </a:ext>
             </a:extLst>
           </p:cNvPr>
@@ -31897,7 +33001,7 @@
           <p:cNvPr id="4" name="Straight Connector 3">
             <a:extLst>
               <a:ext uri="{FF2B5EF4-FFF2-40B4-BE49-F238E27FC236}">
-                <a16:creationId xmlns:a16="http://schemas.microsoft.com/office/drawing/2014/main" id="{9890CC23-4ADC-D744-AF2D-1C8A936F07FC}"/>
+                <ns2:creationId id="{9890CC23-4ADC-D744-AF2D-1C8A936F07FC}"/>
               </a:ext>
             </a:extLst>
           </p:cNvPr>
@@ -31940,7 +33044,7 @@
           <p:cNvPr id="18" name="Oval 17">
             <a:extLst>
               <a:ext uri="{FF2B5EF4-FFF2-40B4-BE49-F238E27FC236}">
-                <a16:creationId xmlns:a16="http://schemas.microsoft.com/office/drawing/2014/main" id="{BE4CDC90-4B2E-BE41-BB9D-A84675F3A2FE}"/>
+                <ns2:creationId id="{BE4CDC90-4B2E-BE41-BB9D-A84675F3A2FE}"/>
               </a:ext>
             </a:extLst>
           </p:cNvPr>
@@ -32023,7 +33127,7 @@
           <p:cNvPr id="24" name="Straight Arrow Connector 23">
             <a:extLst>
               <a:ext uri="{FF2B5EF4-FFF2-40B4-BE49-F238E27FC236}">
-                <a16:creationId xmlns:a16="http://schemas.microsoft.com/office/drawing/2014/main" id="{7BCF22C9-C9AE-324D-B157-A9536FCAF3B6}"/>
+                <ns2:creationId id="{7BCF22C9-C9AE-324D-B157-A9536FCAF3B6}"/>
               </a:ext>
             </a:extLst>
           </p:cNvPr>
@@ -32068,7 +33172,7 @@
           <p:cNvPr id="10" name="TextBox 9">
             <a:extLst>
               <a:ext uri="{FF2B5EF4-FFF2-40B4-BE49-F238E27FC236}">
-                <a16:creationId xmlns:a16="http://schemas.microsoft.com/office/drawing/2014/main" id="{01A59953-657F-C641-8F36-E48E8EDB0DF1}"/>
+                <ns2:creationId id="{01A59953-657F-C641-8F36-E48E8EDB0DF1}"/>
               </a:ext>
             </a:extLst>
           </p:cNvPr>
@@ -32126,7 +33230,41 @@
                 <a:ea typeface="Helvetica Neue" panose="02000503000000020004" pitchFamily="2" charset="0"/>
                 <a:cs typeface="Helvetica Neue" panose="02000503000000020004" pitchFamily="2" charset="0"/>
               </a:rPr>
-              <a:t>v &gt; c_f</a:t>
+              <a:t xml:space="preserve">v &gt; </a:t>
+            </a:r>
+            <a:r>
+              <a:rPr kumimoji="0" lang="en-US" sz="1400" b="0" i="1" u="none" strike="noStrike" kern="1200" cap="none" spc="0" normalizeH="0" baseline="0" noProof="0" dirty="0">
+                <a:ln>
+                  <a:noFill/>
+                </a:ln>
+                <a:solidFill>
+                  <a:prstClr val="white"/>
+                </a:solidFill>
+                <a:effectLst/>
+                <a:uLnTx/>
+                <a:uFillTx/>
+                <a:latin typeface="Helvetica Neue" panose="02000503000000020004" pitchFamily="2" charset="0"/>
+                <a:ea typeface="Helvetica Neue" panose="02000503000000020004" pitchFamily="2" charset="0"/>
+                <a:cs typeface="Helvetica Neue" panose="02000503000000020004" pitchFamily="2" charset="0"/>
+              </a:rPr>
+              <a:t>c</a:t>
+            </a:r>
+            <a:r>
+              <a:rPr kumimoji="0" lang="en-US" sz="980" b="0" i="1" u="none" strike="noStrike" kern="1200" cap="none" spc="0" normalizeH="0" baseline="-25000" noProof="0" dirty="0">
+                <a:ln>
+                  <a:noFill/>
+                </a:ln>
+                <a:solidFill>
+                  <a:prstClr val="white"/>
+                </a:solidFill>
+                <a:effectLst/>
+                <a:uLnTx/>
+                <a:uFillTx/>
+                <a:latin typeface="Helvetica Neue" panose="02000503000000020004" pitchFamily="2" charset="0"/>
+                <a:ea typeface="Helvetica Neue" panose="02000503000000020004" pitchFamily="2" charset="0"/>
+                <a:cs typeface="Helvetica Neue" panose="02000503000000020004" pitchFamily="2" charset="0"/>
+              </a:rPr>
+              <a:t>f</a:t>
             </a:r>
           </a:p>
         </p:txBody>
@@ -32136,7 +33274,7 @@
           <p:cNvPr id="31" name="TextBox 30">
             <a:extLst>
               <a:ext uri="{FF2B5EF4-FFF2-40B4-BE49-F238E27FC236}">
-                <a16:creationId xmlns:a16="http://schemas.microsoft.com/office/drawing/2014/main" id="{713B9ACE-B673-2D48-BEF2-2A133C31B527}"/>
+                <ns2:creationId id="{713B9ACE-B673-2D48-BEF2-2A133C31B527}"/>
               </a:ext>
             </a:extLst>
           </p:cNvPr>
@@ -32194,7 +33332,24 @@
                 <a:ea typeface="Helvetica Neue" panose="02000503000000020004" pitchFamily="2" charset="0"/>
                 <a:cs typeface="Helvetica Neue" panose="02000503000000020004" pitchFamily="2" charset="0"/>
               </a:rPr>
-              <a:t>c_f</a:t>
+              <a:t>c</a:t>
+            </a:r>
+            <a:r>
+              <a:rPr kumimoji="0" lang="en-US" sz="980" b="0" i="1" u="none" strike="noStrike" kern="1200" cap="none" spc="0" normalizeH="0" baseline="-25000" noProof="0" dirty="0">
+                <a:ln>
+                  <a:noFill/>
+                </a:ln>
+                <a:solidFill>
+                  <a:prstClr val="white"/>
+                </a:solidFill>
+                <a:effectLst/>
+                <a:uLnTx/>
+                <a:uFillTx/>
+                <a:latin typeface="Helvetica Neue" panose="02000503000000020004" pitchFamily="2" charset="0"/>
+                <a:ea typeface="Helvetica Neue" panose="02000503000000020004" pitchFamily="2" charset="0"/>
+                <a:cs typeface="Helvetica Neue" panose="02000503000000020004" pitchFamily="2" charset="0"/>
+              </a:rPr>
+              <a:t>f</a:t>
             </a:r>
           </a:p>
         </p:txBody>
@@ -32204,7 +33359,7 @@
           <p:cNvPr id="36" name="TextBox 35">
             <a:extLst>
               <a:ext uri="{FF2B5EF4-FFF2-40B4-BE49-F238E27FC236}">
-                <a16:creationId xmlns:a16="http://schemas.microsoft.com/office/drawing/2014/main" id="{3A81A480-EF64-094E-825A-8592DAA4C672}"/>
+                <ns2:creationId id="{3A81A480-EF64-094E-825A-8592DAA4C672}"/>
               </a:ext>
             </a:extLst>
           </p:cNvPr>
@@ -32286,7 +33441,7 @@
           <p:cNvPr id="22" name="Straight Connector 21">
             <a:extLst>
               <a:ext uri="{FF2B5EF4-FFF2-40B4-BE49-F238E27FC236}">
-                <a16:creationId xmlns:a16="http://schemas.microsoft.com/office/drawing/2014/main" id="{0C67DA45-6876-7942-9996-48CA0A1696FE}"/>
+                <ns2:creationId id="{0C67DA45-6876-7942-9996-48CA0A1696FE}"/>
               </a:ext>
             </a:extLst>
           </p:cNvPr>
@@ -32329,7 +33484,7 @@
           <p:cNvPr id="2" name="TextBox 1">
             <a:extLst>
               <a:ext uri="{FF2B5EF4-FFF2-40B4-BE49-F238E27FC236}">
-                <a16:creationId xmlns:a16="http://schemas.microsoft.com/office/drawing/2014/main" id="{25B497FC-A4FB-6E22-82A5-ECE9FFBF1D45}"/>
+                <ns2:creationId id="{25B497FC-A4FB-6E22-82A5-ECE9FFBF1D45}"/>
               </a:ext>
             </a:extLst>
           </p:cNvPr>
@@ -32384,7 +33539,41 @@
                 <a:ea typeface="Helvetica Neue" panose="02000503000000020004" pitchFamily="2" charset="0"/>
                 <a:cs typeface="Helvetica Neue" panose="02000503000000020004" pitchFamily="2" charset="0"/>
               </a:rPr>
-              <a:t>Architrino on Linear Path with Velocity v &gt; c_f</a:t>
+              <a:t xml:space="preserve">Architrino on Linear Path with Velocity v &gt; </a:t>
+            </a:r>
+            <a:r>
+              <a:rPr kumimoji="0" lang="en-US" sz="3200" b="1" i="0" u="none" strike="noStrike" kern="1200" cap="none" spc="0" normalizeH="0" baseline="0" noProof="0" dirty="0">
+                <a:ln>
+                  <a:noFill/>
+                </a:ln>
+                <a:solidFill>
+                  <a:prstClr val="white"/>
+                </a:solidFill>
+                <a:effectLst/>
+                <a:uLnTx/>
+                <a:uFillTx/>
+                <a:latin typeface="Helvetica Neue" panose="02000503000000020004" pitchFamily="2" charset="0"/>
+                <a:ea typeface="Helvetica Neue" panose="02000503000000020004" pitchFamily="2" charset="0"/>
+                <a:cs typeface="Helvetica Neue" panose="02000503000000020004" pitchFamily="2" charset="0"/>
+              </a:rPr>
+              <a:t>c</a:t>
+            </a:r>
+            <a:r>
+              <a:rPr kumimoji="0" lang="en-US" sz="2240" b="1" i="0" u="none" strike="noStrike" kern="1200" cap="none" spc="0" normalizeH="0" baseline="-25000" noProof="0" dirty="0">
+                <a:ln>
+                  <a:noFill/>
+                </a:ln>
+                <a:solidFill>
+                  <a:prstClr val="white"/>
+                </a:solidFill>
+                <a:effectLst/>
+                <a:uLnTx/>
+                <a:uFillTx/>
+                <a:latin typeface="Helvetica Neue" panose="02000503000000020004" pitchFamily="2" charset="0"/>
+                <a:ea typeface="Helvetica Neue" panose="02000503000000020004" pitchFamily="2" charset="0"/>
+                <a:cs typeface="Helvetica Neue" panose="02000503000000020004" pitchFamily="2" charset="0"/>
+              </a:rPr>
+              <a:t>f</a:t>
             </a:r>
           </a:p>
         </p:txBody>
@@ -32394,7 +33583,7 @@
           <p:cNvPr id="6" name="Straight Arrow Connector 5">
             <a:extLst>
               <a:ext uri="{FF2B5EF4-FFF2-40B4-BE49-F238E27FC236}">
-                <a16:creationId xmlns:a16="http://schemas.microsoft.com/office/drawing/2014/main" id="{3B9C4884-FD04-1DA8-E9C2-C28549C7A16E}"/>
+                <ns2:creationId id="{3B9C4884-FD04-1DA8-E9C2-C28549C7A16E}"/>
               </a:ext>
             </a:extLst>
           </p:cNvPr>
@@ -32438,7 +33627,7 @@
           <p:cNvPr id="7" name="Straight Arrow Connector 6">
             <a:extLst>
               <a:ext uri="{FF2B5EF4-FFF2-40B4-BE49-F238E27FC236}">
-                <a16:creationId xmlns:a16="http://schemas.microsoft.com/office/drawing/2014/main" id="{A6FFF53F-C9D7-1557-FC42-A159BAC6A3AE}"/>
+                <ns2:creationId id="{A6FFF53F-C9D7-1557-FC42-A159BAC6A3AE}"/>
               </a:ext>
             </a:extLst>
           </p:cNvPr>
@@ -32482,7 +33671,7 @@
           <p:cNvPr id="9" name="TextBox 8">
             <a:extLst>
               <a:ext uri="{FF2B5EF4-FFF2-40B4-BE49-F238E27FC236}">
-                <a16:creationId xmlns:a16="http://schemas.microsoft.com/office/drawing/2014/main" id="{37A94EE7-D3B6-AC25-503E-E6C0EE1F179B}"/>
+                <ns2:creationId id="{37A94EE7-D3B6-AC25-503E-E6C0EE1F179B}"/>
               </a:ext>
             </a:extLst>
           </p:cNvPr>
@@ -32547,7 +33736,7 @@
           <p:cNvPr id="11" name="TextBox 10">
             <a:extLst>
               <a:ext uri="{FF2B5EF4-FFF2-40B4-BE49-F238E27FC236}">
-                <a16:creationId xmlns:a16="http://schemas.microsoft.com/office/drawing/2014/main" id="{C80380D5-790B-3854-4D6A-3811EF0E2829}"/>
+                <ns2:creationId id="{C80380D5-790B-3854-4D6A-3811EF0E2829}"/>
               </a:ext>
             </a:extLst>
           </p:cNvPr>
@@ -32646,7 +33835,7 @@
     </p:spTree>
     <p:extLst>
       <p:ext uri="{BB962C8B-B14F-4D97-AF65-F5344CB8AC3E}">
-        <p14:creationId xmlns:p14="http://schemas.microsoft.com/office/powerpoint/2010/main" val="2347082703"/>
+        <ns3:creationId val="2347082703"/>
       </p:ext>
     </p:extLst>
   </p:cSld>
@@ -32657,7 +33846,7 @@
 </file>
 
 <file path=ppt/slides/slide8.xml><?xml version="1.0" encoding="utf-8"?>
-<p:sld xmlns:a="http://schemas.openxmlformats.org/drawingml/2006/main" xmlns:r="http://schemas.openxmlformats.org/officeDocument/2006/relationships" xmlns:p="http://schemas.openxmlformats.org/presentationml/2006/main">
+<p:sld xmlns:a="http://schemas.openxmlformats.org/drawingml/2006/main" xmlns:ns2="http://schemas.microsoft.com/office/drawing/2014/main" xmlns:ns4="http://schemas.microsoft.com/office/powerpoint/2010/main" xmlns:p="http://schemas.openxmlformats.org/presentationml/2006/main" xmlns:r="http://schemas.openxmlformats.org/officeDocument/2006/relationships">
   <p:cSld>
     <p:bg>
       <p:bgPr>
@@ -32672,7 +33861,7 @@
         <p:cNvPr id="1" name="">
           <a:extLst>
             <a:ext uri="{FF2B5EF4-FFF2-40B4-BE49-F238E27FC236}">
-              <a16:creationId xmlns:a16="http://schemas.microsoft.com/office/drawing/2014/main" id="{0AB73162-F4FB-AD38-1F35-FA4B5AB487CE}"/>
+              <ns2:creationId id="{0AB73162-F4FB-AD38-1F35-FA4B5AB487CE}"/>
             </a:ext>
           </a:extLst>
         </p:cNvPr>
@@ -32692,7 +33881,7 @@
           <p:cNvPr id="5" name="Footer Placeholder 3">
             <a:extLst>
               <a:ext uri="{FF2B5EF4-FFF2-40B4-BE49-F238E27FC236}">
-                <a16:creationId xmlns:a16="http://schemas.microsoft.com/office/drawing/2014/main" id="{8949F10E-6D23-F0EA-2E56-92DD2DE28C2A}"/>
+                <ns2:creationId id="{8949F10E-6D23-F0EA-2E56-92DD2DE28C2A}"/>
               </a:ext>
             </a:extLst>
           </p:cNvPr>
@@ -32854,7 +34043,7 @@
           <p:cNvPr id="9" name="Group 8">
             <a:extLst>
               <a:ext uri="{FF2B5EF4-FFF2-40B4-BE49-F238E27FC236}">
-                <a16:creationId xmlns:a16="http://schemas.microsoft.com/office/drawing/2014/main" id="{E9850113-AB4C-1F87-EB30-16E25C586B5C}"/>
+                <ns2:creationId id="{E9850113-AB4C-1F87-EB30-16E25C586B5C}"/>
               </a:ext>
             </a:extLst>
           </p:cNvPr>
@@ -32874,7 +34063,7 @@
             <p:cNvPr id="3" name="Picture 2">
               <a:extLst>
                 <a:ext uri="{FF2B5EF4-FFF2-40B4-BE49-F238E27FC236}">
-                  <a16:creationId xmlns:a16="http://schemas.microsoft.com/office/drawing/2014/main" id="{9851A9B8-C2CC-C4AE-6C06-EB4B33725392}"/>
+                  <ns2:creationId id="{9851A9B8-C2CC-C4AE-6C06-EB4B33725392}"/>
                 </a:ext>
               </a:extLst>
             </p:cNvPr>
@@ -32911,7 +34100,7 @@
             <p:cNvPr id="4" name="Freeform 3">
               <a:extLst>
                 <a:ext uri="{FF2B5EF4-FFF2-40B4-BE49-F238E27FC236}">
-                  <a16:creationId xmlns:a16="http://schemas.microsoft.com/office/drawing/2014/main" id="{A6E4734A-F61C-B1B6-E09B-251407A8B0F9}"/>
+                  <ns2:creationId id="{A6E4734A-F61C-B1B6-E09B-251407A8B0F9}"/>
                 </a:ext>
               </a:extLst>
             </p:cNvPr>
@@ -33056,7 +34245,7 @@
             <p:cNvPr id="6" name="Freeform 5">
               <a:extLst>
                 <a:ext uri="{FF2B5EF4-FFF2-40B4-BE49-F238E27FC236}">
-                  <a16:creationId xmlns:a16="http://schemas.microsoft.com/office/drawing/2014/main" id="{AE9693B7-399D-4648-5934-BAF780F94BB8}"/>
+                  <ns2:creationId id="{AE9693B7-399D-4648-5934-BAF780F94BB8}"/>
                 </a:ext>
               </a:extLst>
             </p:cNvPr>
@@ -33242,7 +34431,7 @@
           <p:cNvPr id="7" name="Title 1">
             <a:extLst>
               <a:ext uri="{FF2B5EF4-FFF2-40B4-BE49-F238E27FC236}">
-                <a16:creationId xmlns:a16="http://schemas.microsoft.com/office/drawing/2014/main" id="{B4E061E7-B3BA-067C-8AC0-2AEC475558B3}"/>
+                <ns2:creationId id="{B4E061E7-B3BA-067C-8AC0-2AEC475558B3}"/>
               </a:ext>
             </a:extLst>
           </p:cNvPr>
@@ -33326,7 +34515,7 @@
           <p:cNvPr id="10" name="TextBox 9">
             <a:extLst>
               <a:ext uri="{FF2B5EF4-FFF2-40B4-BE49-F238E27FC236}">
-                <a16:creationId xmlns:a16="http://schemas.microsoft.com/office/drawing/2014/main" id="{FFF14DD8-B78C-E1D8-EB01-782F6700411F}"/>
+                <ns2:creationId id="{FFF14DD8-B78C-E1D8-EB01-782F6700411F}"/>
               </a:ext>
             </a:extLst>
           </p:cNvPr>
@@ -33547,7 +34736,7 @@
     </p:spTree>
     <p:extLst>
       <p:ext uri="{BB962C8B-B14F-4D97-AF65-F5344CB8AC3E}">
-        <p14:creationId xmlns:p14="http://schemas.microsoft.com/office/powerpoint/2010/main" val="3392406910"/>
+        <ns4:creationId val="3392406910"/>
       </p:ext>
     </p:extLst>
   </p:cSld>
@@ -33558,7 +34747,7 @@
 </file>
 
 <file path=ppt/slides/slide9.xml><?xml version="1.0" encoding="utf-8"?>
-<p:sld xmlns:a="http://schemas.openxmlformats.org/drawingml/2006/main" xmlns:r="http://schemas.openxmlformats.org/officeDocument/2006/relationships" xmlns:p="http://schemas.openxmlformats.org/presentationml/2006/main">
+<p:sld xmlns:a="http://schemas.openxmlformats.org/drawingml/2006/main" xmlns:ns2="http://schemas.microsoft.com/office/drawing/2014/main" xmlns:ns3="http://schemas.microsoft.com/office/powerpoint/2010/main" xmlns:p="http://schemas.openxmlformats.org/presentationml/2006/main">
   <p:cSld>
     <p:bg>
       <p:bgPr>
@@ -33587,7 +34776,7 @@
           <p:cNvPr id="11" name="Footer Placeholder 3">
             <a:extLst>
               <a:ext uri="{FF2B5EF4-FFF2-40B4-BE49-F238E27FC236}">
-                <a16:creationId xmlns:a16="http://schemas.microsoft.com/office/drawing/2014/main" id="{7C94C084-4476-0C4E-B896-CB3AC89A47F6}"/>
+                <ns2:creationId id="{7C94C084-4476-0C4E-B896-CB3AC89A47F6}"/>
               </a:ext>
             </a:extLst>
           </p:cNvPr>
@@ -33721,7 +34910,7 @@
           <p:cNvPr id="6" name="Freeform 5">
             <a:extLst>
               <a:ext uri="{FF2B5EF4-FFF2-40B4-BE49-F238E27FC236}">
-                <a16:creationId xmlns:a16="http://schemas.microsoft.com/office/drawing/2014/main" id="{A25DAE9F-BED8-3A57-CD97-EDBD9F0EDD69}"/>
+                <ns2:creationId id="{A25DAE9F-BED8-3A57-CD97-EDBD9F0EDD69}"/>
               </a:ext>
             </a:extLst>
           </p:cNvPr>
@@ -34317,7 +35506,7 @@
           <p:cNvPr id="7" name="Freeform 6">
             <a:extLst>
               <a:ext uri="{FF2B5EF4-FFF2-40B4-BE49-F238E27FC236}">
-                <a16:creationId xmlns:a16="http://schemas.microsoft.com/office/drawing/2014/main" id="{3F833B4A-7F30-F940-BD46-AAD4F1EC84C2}"/>
+                <ns2:creationId id="{3F833B4A-7F30-F940-BD46-AAD4F1EC84C2}"/>
               </a:ext>
             </a:extLst>
           </p:cNvPr>
@@ -35179,7 +36368,7 @@
           <p:cNvPr id="9" name="Oval 8">
             <a:extLst>
               <a:ext uri="{FF2B5EF4-FFF2-40B4-BE49-F238E27FC236}">
-                <a16:creationId xmlns:a16="http://schemas.microsoft.com/office/drawing/2014/main" id="{C1204F89-67E6-2520-9CB7-C11AD96E6395}"/>
+                <ns2:creationId id="{C1204F89-67E6-2520-9CB7-C11AD96E6395}"/>
               </a:ext>
             </a:extLst>
           </p:cNvPr>
@@ -35231,7 +36420,7 @@
           <p:cNvPr id="10" name="Oval 9">
             <a:extLst>
               <a:ext uri="{FF2B5EF4-FFF2-40B4-BE49-F238E27FC236}">
-                <a16:creationId xmlns:a16="http://schemas.microsoft.com/office/drawing/2014/main" id="{C20E3F99-5E93-DCB1-5438-4A8D42DA25E5}"/>
+                <ns2:creationId id="{C20E3F99-5E93-DCB1-5438-4A8D42DA25E5}"/>
               </a:ext>
             </a:extLst>
           </p:cNvPr>
@@ -35283,7 +36472,7 @@
           <p:cNvPr id="12" name="Straight Connector 11">
             <a:extLst>
               <a:ext uri="{FF2B5EF4-FFF2-40B4-BE49-F238E27FC236}">
-                <a16:creationId xmlns:a16="http://schemas.microsoft.com/office/drawing/2014/main" id="{981DDF22-4015-B62D-15E4-53D55BFB533D}"/>
+                <ns2:creationId id="{981DDF22-4015-B62D-15E4-53D55BFB533D}"/>
               </a:ext>
             </a:extLst>
           </p:cNvPr>
@@ -35329,7 +36518,7 @@
           <p:cNvPr id="13" name="Oval 12">
             <a:extLst>
               <a:ext uri="{FF2B5EF4-FFF2-40B4-BE49-F238E27FC236}">
-                <a16:creationId xmlns:a16="http://schemas.microsoft.com/office/drawing/2014/main" id="{54ADE077-5C44-29DF-0132-D3CEA80605F9}"/>
+                <ns2:creationId id="{54ADE077-5C44-29DF-0132-D3CEA80605F9}"/>
               </a:ext>
             </a:extLst>
           </p:cNvPr>
@@ -35384,7 +36573,7 @@
           <p:cNvPr id="14" name="Oval 13">
             <a:extLst>
               <a:ext uri="{FF2B5EF4-FFF2-40B4-BE49-F238E27FC236}">
-                <a16:creationId xmlns:a16="http://schemas.microsoft.com/office/drawing/2014/main" id="{00672CFA-7F0E-A719-10B0-29AE35096E30}"/>
+                <ns2:creationId id="{00672CFA-7F0E-A719-10B0-29AE35096E30}"/>
               </a:ext>
             </a:extLst>
           </p:cNvPr>
@@ -35436,7 +36625,7 @@
           <p:cNvPr id="15" name="TextBox 14">
             <a:extLst>
               <a:ext uri="{FF2B5EF4-FFF2-40B4-BE49-F238E27FC236}">
-                <a16:creationId xmlns:a16="http://schemas.microsoft.com/office/drawing/2014/main" id="{D484D63C-CCDB-0923-AC0F-BC6DCC85B056}"/>
+                <ns2:creationId id="{D484D63C-CCDB-0923-AC0F-BC6DCC85B056}"/>
               </a:ext>
             </a:extLst>
           </p:cNvPr>
@@ -35460,7 +36649,7 @@
           <a:lstStyle/>
           <a:p>
             <a:r>
-              <a:rPr lang="en-US" dirty="0">
+              <a:rPr lang="en-US" dirty="0" baseline="0">
                 <a:solidFill>
                   <a:srgbClr val="00B050"/>
                 </a:solidFill>
@@ -35468,7 +36657,40 @@
                 <a:ea typeface="Helvetica Neue" panose="02000503000000020004" pitchFamily="2" charset="0"/>
                 <a:cs typeface="Helvetica Neue" panose="02000503000000020004" pitchFamily="2" charset="0"/>
               </a:rPr>
-              <a:t>The causal wake emitted by architrino A at time t' expands at wake speed c_f.</a:t>
+              <a:t xml:space="preserve">The causal wake emitted by architrino A at time t' expands at wake speed </a:t>
+            </a:r>
+            <a:r>
+              <a:rPr lang="en-US" dirty="0" baseline="0">
+                <a:solidFill>
+                  <a:srgbClr val="00B050"/>
+                </a:solidFill>
+                <a:latin typeface="Helvetica Neue" panose="02000503000000020004" pitchFamily="2" charset="0"/>
+                <a:ea typeface="Helvetica Neue" panose="02000503000000020004" pitchFamily="2" charset="0"/>
+                <a:cs typeface="Helvetica Neue" panose="02000503000000020004" pitchFamily="2" charset="0"/>
+              </a:rPr>
+              <a:t>c</a:t>
+            </a:r>
+            <a:r>
+              <a:rPr lang="en-US" dirty="0" baseline="-25000" sz="1260">
+                <a:solidFill>
+                  <a:srgbClr val="00B050"/>
+                </a:solidFill>
+                <a:latin typeface="Helvetica Neue" panose="02000503000000020004" pitchFamily="2" charset="0"/>
+                <a:ea typeface="Helvetica Neue" panose="02000503000000020004" pitchFamily="2" charset="0"/>
+                <a:cs typeface="Helvetica Neue" panose="02000503000000020004" pitchFamily="2" charset="0"/>
+              </a:rPr>
+              <a:t>f</a:t>
+            </a:r>
+            <a:r>
+              <a:rPr lang="en-US" dirty="0" baseline="0">
+                <a:solidFill>
+                  <a:srgbClr val="00B050"/>
+                </a:solidFill>
+                <a:latin typeface="Helvetica Neue" panose="02000503000000020004" pitchFamily="2" charset="0"/>
+                <a:ea typeface="Helvetica Neue" panose="02000503000000020004" pitchFamily="2" charset="0"/>
+                <a:cs typeface="Helvetica Neue" panose="02000503000000020004" pitchFamily="2" charset="0"/>
+              </a:rPr>
+              <a:t>.</a:t>
             </a:r>
           </a:p>
           <a:p>
@@ -35496,7 +36718,7 @@
           <p:cNvPr id="16" name="TextBox 15">
             <a:extLst>
               <a:ext uri="{FF2B5EF4-FFF2-40B4-BE49-F238E27FC236}">
-                <a16:creationId xmlns:a16="http://schemas.microsoft.com/office/drawing/2014/main" id="{2FB06A3B-C8A7-7640-2EE9-203EA6BD717B}"/>
+                <ns2:creationId id="{2FB06A3B-C8A7-7640-2EE9-203EA6BD717B}"/>
               </a:ext>
             </a:extLst>
           </p:cNvPr>
@@ -35543,7 +36765,7 @@
           <p:cNvPr id="19" name="TextBox 18">
             <a:extLst>
               <a:ext uri="{FF2B5EF4-FFF2-40B4-BE49-F238E27FC236}">
-                <a16:creationId xmlns:a16="http://schemas.microsoft.com/office/drawing/2014/main" id="{499A2693-D878-2253-1439-ED993C1F2AD5}"/>
+                <ns2:creationId id="{499A2693-D878-2253-1439-ED993C1F2AD5}"/>
               </a:ext>
             </a:extLst>
           </p:cNvPr>
@@ -35590,7 +36812,7 @@
           <p:cNvPr id="20" name="TextBox 19">
             <a:extLst>
               <a:ext uri="{FF2B5EF4-FFF2-40B4-BE49-F238E27FC236}">
-                <a16:creationId xmlns:a16="http://schemas.microsoft.com/office/drawing/2014/main" id="{328F02D2-95BB-4767-7DBC-B06A0A6115E7}"/>
+                <ns2:creationId id="{328F02D2-95BB-4767-7DBC-B06A0A6115E7}"/>
               </a:ext>
             </a:extLst>
           </p:cNvPr>
@@ -35637,7 +36859,7 @@
           <p:cNvPr id="21" name="TextBox 20">
             <a:extLst>
               <a:ext uri="{FF2B5EF4-FFF2-40B4-BE49-F238E27FC236}">
-                <a16:creationId xmlns:a16="http://schemas.microsoft.com/office/drawing/2014/main" id="{5C915F9D-42F7-1C6D-E114-D633D6E4C109}"/>
+                <ns2:creationId id="{5C915F9D-42F7-1C6D-E114-D633D6E4C109}"/>
               </a:ext>
             </a:extLst>
           </p:cNvPr>
@@ -35684,7 +36906,7 @@
           <p:cNvPr id="22" name="TextBox 21">
             <a:extLst>
               <a:ext uri="{FF2B5EF4-FFF2-40B4-BE49-F238E27FC236}">
-                <a16:creationId xmlns:a16="http://schemas.microsoft.com/office/drawing/2014/main" id="{82FA558D-A9BC-01CE-74CD-F383AA8AFB6C}"/>
+                <ns2:creationId id="{82FA558D-A9BC-01CE-74CD-F383AA8AFB6C}"/>
               </a:ext>
             </a:extLst>
           </p:cNvPr>
@@ -35731,7 +36953,7 @@
           <p:cNvPr id="25" name="Rectangle 24">
             <a:extLst>
               <a:ext uri="{FF2B5EF4-FFF2-40B4-BE49-F238E27FC236}">
-                <a16:creationId xmlns:a16="http://schemas.microsoft.com/office/drawing/2014/main" id="{B4DF9014-6E71-4887-15FC-288C0BE2E472}"/>
+                <ns2:creationId id="{B4DF9014-6E71-4887-15FC-288C0BE2E472}"/>
               </a:ext>
             </a:extLst>
           </p:cNvPr>
@@ -35784,7 +37006,7 @@
           <p:cNvPr id="2" name="Group 1">
             <a:extLst>
               <a:ext uri="{FF2B5EF4-FFF2-40B4-BE49-F238E27FC236}">
-                <a16:creationId xmlns:a16="http://schemas.microsoft.com/office/drawing/2014/main" id="{8513F8A2-0C1C-FA83-EB1D-12942054ECC6}"/>
+                <ns2:creationId id="{8513F8A2-0C1C-FA83-EB1D-12942054ECC6}"/>
               </a:ext>
             </a:extLst>
           </p:cNvPr>
@@ -35804,7 +37026,7 @@
             <p:cNvPr id="3" name="Straight Arrow Connector 2">
               <a:extLst>
                 <a:ext uri="{FF2B5EF4-FFF2-40B4-BE49-F238E27FC236}">
-                  <a16:creationId xmlns:a16="http://schemas.microsoft.com/office/drawing/2014/main" id="{F0E8E829-2926-9AC8-8FBE-CD87D209F5BD}"/>
+                  <ns2:creationId id="{F0E8E829-2926-9AC8-8FBE-CD87D209F5BD}"/>
                 </a:ext>
               </a:extLst>
             </p:cNvPr>
@@ -35848,7 +37070,7 @@
             <p:cNvPr id="4" name="Straight Arrow Connector 3">
               <a:extLst>
                 <a:ext uri="{FF2B5EF4-FFF2-40B4-BE49-F238E27FC236}">
-                  <a16:creationId xmlns:a16="http://schemas.microsoft.com/office/drawing/2014/main" id="{D50F6F6C-E0DD-959D-833A-36F07808AC1D}"/>
+                  <ns2:creationId id="{D50F6F6C-E0DD-959D-833A-36F07808AC1D}"/>
                 </a:ext>
               </a:extLst>
             </p:cNvPr>
@@ -35892,7 +37114,7 @@
             <p:cNvPr id="5" name="TextBox 4">
               <a:extLst>
                 <a:ext uri="{FF2B5EF4-FFF2-40B4-BE49-F238E27FC236}">
-                  <a16:creationId xmlns:a16="http://schemas.microsoft.com/office/drawing/2014/main" id="{EDB020C7-9F2F-9DAE-DC6F-0F4AB0106806}"/>
+                  <ns2:creationId id="{EDB020C7-9F2F-9DAE-DC6F-0F4AB0106806}"/>
                 </a:ext>
               </a:extLst>
             </p:cNvPr>
@@ -35957,7 +37179,7 @@
             <p:cNvPr id="8" name="TextBox 7">
               <a:extLst>
                 <a:ext uri="{FF2B5EF4-FFF2-40B4-BE49-F238E27FC236}">
-                  <a16:creationId xmlns:a16="http://schemas.microsoft.com/office/drawing/2014/main" id="{9833DACC-1D55-AD72-1025-41BEFCBBEFC1}"/>
+                  <ns2:creationId id="{9833DACC-1D55-AD72-1025-41BEFCBBEFC1}"/>
                 </a:ext>
               </a:extLst>
             </p:cNvPr>
@@ -36057,7 +37279,7 @@
     </p:spTree>
     <p:extLst>
       <p:ext uri="{BB962C8B-B14F-4D97-AF65-F5344CB8AC3E}">
-        <p14:creationId xmlns:p14="http://schemas.microsoft.com/office/powerpoint/2010/main" val="2649229030"/>
+        <ns3:creationId val="2649229030"/>
       </p:ext>
     </p:extLst>
   </p:cSld>

</xml_diff>

<commit_message>
Rename dormant-deferred priority files and update references
</commit_message>
<xml_diff>
--- a/reference/archie/presentations/NPQG Fundamentals - Paths.pptx
+++ b/reference/archie/presentations/NPQG Fundamentals - Paths.pptx
@@ -5,7 +5,7 @@
     <p:sldMasterId id="2147483648" r:id="rId1"/>
   </p:sldMasterIdLst>
   <p:notesMasterIdLst>
-    <p:notesMasterId r:id="rId19"/>
+    <p:notesMasterId r:id="rId16"/>
   </p:notesMasterIdLst>
   <p:sldIdLst>
     <p:sldId id="890" r:id="rId2"/>
@@ -21,10 +21,7 @@
     <p:sldId id="767" r:id="rId12"/>
     <p:sldId id="812" r:id="rId13"/>
     <p:sldId id="889" r:id="rId14"/>
-    <p:sldId id="884" r:id="rId15"/>
-    <p:sldId id="885" r:id="rId16"/>
-    <p:sldId id="886" r:id="rId17"/>
-    <p:sldId id="887" r:id="rId18"/>
+    <p:sldId id="885" r:id="rId15"/>
   </p:sldIdLst>
   <p:sldSz cx="12192000" cy="6858000"/>
   <p:notesSz cx="6858000" cy="9144000"/>
@@ -797,6 +794,254 @@
               <a:cs typeface="Helvetica Neue" panose="02000503000000020004" pitchFamily="2" charset="0"/>
             </a:endParaRPr>
           </a:p>
+          <a:p>
+            <a:pPr marL="0" marR="0" indent="0" algn="l" defTabSz="914400" rtl="0" eaLnBrk="1" fontAlgn="auto" latinLnBrk="0" hangingPunct="1">
+              <a:lnSpc>
+                <a:spcPct val="200000"/>
+              </a:lnSpc>
+              <a:spcBef>
+                <a:spcPts val="0"/>
+              </a:spcBef>
+              <a:spcAft>
+                <a:spcPts val="0"/>
+              </a:spcAft>
+              <a:buClrTx/>
+              <a:buSzTx/>
+              <a:buFontTx/>
+              <a:buNone/>
+              <a:tabLst/>
+              <a:defRPr/>
+            </a:pPr>
+            <a:endParaRPr lang="en-US" sz="9600" b="1" dirty="0">
+              <a:latin typeface="Helvetica Neue" panose="02000503000000020004" pitchFamily="2" charset="0"/>
+              <a:ea typeface="Helvetica Neue" panose="02000503000000020004" pitchFamily="2" charset="0"/>
+              <a:cs typeface="Helvetica Neue" panose="02000503000000020004" pitchFamily="2" charset="0"/>
+            </a:endParaRPr>
+          </a:p>
+          <a:p>
+            <a:pPr marL="0" marR="0" indent="0" algn="l" defTabSz="914400" rtl="0" eaLnBrk="1" fontAlgn="auto" latinLnBrk="0" hangingPunct="1">
+              <a:lnSpc>
+                <a:spcPct val="200000"/>
+              </a:lnSpc>
+              <a:spcBef>
+                <a:spcPts val="0"/>
+              </a:spcBef>
+              <a:spcAft>
+                <a:spcPts val="0"/>
+              </a:spcAft>
+              <a:buClrTx/>
+              <a:buSzTx/>
+              <a:buFontTx/>
+              <a:buNone/>
+              <a:tabLst/>
+              <a:defRPr/>
+            </a:pPr>
+            <a:endParaRPr lang="en-US" sz="9600" b="1" dirty="0">
+              <a:latin typeface="Helvetica Neue" panose="02000503000000020004" pitchFamily="2" charset="0"/>
+              <a:ea typeface="Helvetica Neue" panose="02000503000000020004" pitchFamily="2" charset="0"/>
+              <a:cs typeface="Helvetica Neue" panose="02000503000000020004" pitchFamily="2" charset="0"/>
+            </a:endParaRPr>
+          </a:p>
+        </p:txBody>
+      </p:sp>
+      <p:sp>
+        <p:nvSpPr>
+          <p:cNvPr id="4" name="Slide Number Placeholder 3"/>
+          <p:cNvSpPr>
+            <a:spLocks noGrp="1"/>
+          </p:cNvSpPr>
+          <p:nvPr>
+            <p:ph type="sldNum" sz="quarter" idx="5"/>
+          </p:nvPr>
+        </p:nvSpPr>
+        <p:spPr/>
+        <p:txBody>
+          <a:bodyPr/>
+          <a:lstStyle/>
+          <a:p>
+            <a:pPr marL="0" marR="0" lvl="0" indent="0" algn="r" defTabSz="914400" rtl="0" eaLnBrk="1" fontAlgn="auto" latinLnBrk="0" hangingPunct="1">
+              <a:lnSpc>
+                <a:spcPct val="100000"/>
+              </a:lnSpc>
+              <a:spcBef>
+                <a:spcPts val="0"/>
+              </a:spcBef>
+              <a:spcAft>
+                <a:spcPts val="0"/>
+              </a:spcAft>
+              <a:buClrTx/>
+              <a:buSzTx/>
+              <a:buFontTx/>
+              <a:buNone/>
+              <a:tabLst/>
+              <a:defRPr/>
+            </a:pPr>
+            <a:fld id="{4DC398A3-AF21-A342-B6A8-6929C36BB1BF}" type="slidenum">
+              <a:rPr kumimoji="0" lang="en-US" sz="1200" b="0" i="0" u="none" strike="noStrike" kern="1200" cap="none" spc="0" normalizeH="0" baseline="0" noProof="0" smtClean="0">
+                <a:ln>
+                  <a:noFill/>
+                </a:ln>
+                <a:solidFill>
+                  <a:prstClr val="black"/>
+                </a:solidFill>
+                <a:effectLst/>
+                <a:uLnTx/>
+                <a:uFillTx/>
+                <a:latin typeface="Calibri" panose="020F0502020204030204"/>
+                <a:ea typeface="+mn-ea"/>
+                <a:cs typeface="+mn-cs"/>
+              </a:rPr>
+              <a:pPr marL="0" marR="0" lvl="0" indent="0" algn="r" defTabSz="914400" rtl="0" eaLnBrk="1" fontAlgn="auto" latinLnBrk="0" hangingPunct="1">
+                <a:lnSpc>
+                  <a:spcPct val="100000"/>
+                </a:lnSpc>
+                <a:spcBef>
+                  <a:spcPts val="0"/>
+                </a:spcBef>
+                <a:spcAft>
+                  <a:spcPts val="0"/>
+                </a:spcAft>
+                <a:buClrTx/>
+                <a:buSzTx/>
+                <a:buFontTx/>
+                <a:buNone/>
+                <a:tabLst/>
+                <a:defRPr/>
+              </a:pPr>
+              <a:t>10</a:t>
+            </a:fld>
+            <a:endParaRPr kumimoji="0" lang="en-US" sz="1200" b="0" i="0" u="none" strike="noStrike" kern="1200" cap="none" spc="0" normalizeH="0" baseline="0" noProof="0">
+              <a:ln>
+                <a:noFill/>
+              </a:ln>
+              <a:solidFill>
+                <a:prstClr val="black"/>
+              </a:solidFill>
+              <a:effectLst/>
+              <a:uLnTx/>
+              <a:uFillTx/>
+              <a:latin typeface="Calibri" panose="020F0502020204030204"/>
+              <a:ea typeface="+mn-ea"/>
+              <a:cs typeface="+mn-cs"/>
+            </a:endParaRPr>
+          </a:p>
+        </p:txBody>
+      </p:sp>
+    </p:spTree>
+    <p:extLst>
+      <p:ext uri="{BB962C8B-B14F-4D97-AF65-F5344CB8AC3E}">
+        <p14:creationId xmlns:p14="http://schemas.microsoft.com/office/powerpoint/2010/main" val="596825902"/>
+      </p:ext>
+    </p:extLst>
+  </p:cSld>
+  <p:clrMapOvr>
+    <a:masterClrMapping/>
+  </p:clrMapOvr>
+</p:notes>
+</file>
+
+<file path=ppt/notesSlides/notesSlide11.xml><?xml version="1.0" encoding="utf-8"?>
+<p:notes xmlns:a="http://schemas.openxmlformats.org/drawingml/2006/main" xmlns:r="http://schemas.openxmlformats.org/officeDocument/2006/relationships" xmlns:p="http://schemas.openxmlformats.org/presentationml/2006/main">
+  <p:cSld>
+    <p:spTree>
+      <p:nvGrpSpPr>
+        <p:cNvPr id="1" name=""/>
+        <p:cNvGrpSpPr/>
+        <p:nvPr/>
+      </p:nvGrpSpPr>
+      <p:grpSpPr>
+        <a:xfrm>
+          <a:off x="0" y="0"/>
+          <a:ext cx="0" cy="0"/>
+          <a:chOff x="0" y="0"/>
+          <a:chExt cx="0" cy="0"/>
+        </a:xfrm>
+      </p:grpSpPr>
+      <p:sp>
+        <p:nvSpPr>
+          <p:cNvPr id="2" name="Slide Image Placeholder 1"/>
+          <p:cNvSpPr>
+            <a:spLocks noGrp="1" noRot="1" noChangeAspect="1"/>
+          </p:cNvSpPr>
+          <p:nvPr>
+            <p:ph type="sldImg"/>
+          </p:nvPr>
+        </p:nvSpPr>
+        <p:spPr/>
+      </p:sp>
+      <p:sp>
+        <p:nvSpPr>
+          <p:cNvPr id="3" name="Notes Placeholder 2"/>
+          <p:cNvSpPr>
+            <a:spLocks noGrp="1"/>
+          </p:cNvSpPr>
+          <p:nvPr>
+            <p:ph type="body" idx="1"/>
+          </p:nvPr>
+        </p:nvSpPr>
+        <p:spPr/>
+        <p:txBody>
+          <a:bodyPr/>
+          <a:lstStyle/>
+          <a:p>
+            <a:pPr marL="0" marR="0" indent="0" algn="l" defTabSz="914400" rtl="0" eaLnBrk="1" fontAlgn="auto" latinLnBrk="0" hangingPunct="1">
+              <a:lnSpc>
+                <a:spcPct val="200000"/>
+              </a:lnSpc>
+              <a:spcBef>
+                <a:spcPts val="0"/>
+              </a:spcBef>
+              <a:spcAft>
+                <a:spcPts val="0"/>
+              </a:spcAft>
+              <a:buClrTx/>
+              <a:buSzTx/>
+              <a:buFontTx/>
+              <a:buNone/>
+              <a:tabLst/>
+              <a:defRPr/>
+            </a:pPr>
+            <a:br>
+              <a:rPr lang="en-US" sz="9600" b="1" dirty="0">
+                <a:latin typeface="Helvetica Neue" panose="02000503000000020004" pitchFamily="2" charset="0"/>
+                <a:ea typeface="Helvetica Neue" panose="02000503000000020004" pitchFamily="2" charset="0"/>
+                <a:cs typeface="Helvetica Neue" panose="02000503000000020004" pitchFamily="2" charset="0"/>
+              </a:rPr>
+            </a:br>
+            <a:br>
+              <a:rPr lang="en-US" sz="9600" b="1" dirty="0">
+                <a:latin typeface="Helvetica Neue" panose="02000503000000020004" pitchFamily="2" charset="0"/>
+                <a:ea typeface="Helvetica Neue" panose="02000503000000020004" pitchFamily="2" charset="0"/>
+                <a:cs typeface="Helvetica Neue" panose="02000503000000020004" pitchFamily="2" charset="0"/>
+              </a:rPr>
+            </a:br>
+            <a:br>
+              <a:rPr lang="en-US" sz="9600" b="1" dirty="0">
+                <a:latin typeface="Helvetica Neue" panose="02000503000000020004" pitchFamily="2" charset="0"/>
+                <a:ea typeface="Helvetica Neue" panose="02000503000000020004" pitchFamily="2" charset="0"/>
+                <a:cs typeface="Helvetica Neue" panose="02000503000000020004" pitchFamily="2" charset="0"/>
+              </a:rPr>
+            </a:br>
+            <a:br>
+              <a:rPr lang="en-US" sz="9600" b="1" dirty="0">
+                <a:latin typeface="Helvetica Neue" panose="02000503000000020004" pitchFamily="2" charset="0"/>
+                <a:ea typeface="Helvetica Neue" panose="02000503000000020004" pitchFamily="2" charset="0"/>
+                <a:cs typeface="Helvetica Neue" panose="02000503000000020004" pitchFamily="2" charset="0"/>
+              </a:rPr>
+            </a:br>
+            <a:br>
+              <a:rPr lang="en-US" sz="9600" b="1" dirty="0">
+                <a:latin typeface="Helvetica Neue" panose="02000503000000020004" pitchFamily="2" charset="0"/>
+                <a:ea typeface="Helvetica Neue" panose="02000503000000020004" pitchFamily="2" charset="0"/>
+                <a:cs typeface="Helvetica Neue" panose="02000503000000020004" pitchFamily="2" charset="0"/>
+              </a:rPr>
+            </a:br>
+            <a:endParaRPr lang="en-US" sz="9600" b="1" dirty="0">
+              <a:latin typeface="Helvetica Neue" panose="02000503000000020004" pitchFamily="2" charset="0"/>
+              <a:ea typeface="Helvetica Neue" panose="02000503000000020004" pitchFamily="2" charset="0"/>
+              <a:cs typeface="Helvetica Neue" panose="02000503000000020004" pitchFamily="2" charset="0"/>
+            </a:endParaRPr>
+          </a:p>
         </p:txBody>
       </p:sp>
       <p:sp>
@@ -895,7 +1140,7 @@
 </p:notes>
 </file>
 
-<file path=ppt/notesSlides/notesSlide11.xml><?xml version="1.0" encoding="utf-8"?>
+<file path=ppt/notesSlides/notesSlide12.xml><?xml version="1.0" encoding="utf-8"?>
 <p:notes xmlns:a="http://schemas.openxmlformats.org/drawingml/2006/main" xmlns:r="http://schemas.openxmlformats.org/officeDocument/2006/relationships" xmlns:p="http://schemas.openxmlformats.org/presentationml/2006/main">
   <p:cSld>
     <p:spTree>
@@ -1039,7 +1284,7 @@
 </p:notes>
 </file>
 
-<file path=ppt/notesSlides/notesSlide12.xml><?xml version="1.0" encoding="utf-8"?>
+<file path=ppt/notesSlides/notesSlide13.xml><?xml version="1.0" encoding="utf-8"?>
 <p:notes xmlns:a="http://schemas.openxmlformats.org/drawingml/2006/main" xmlns:r="http://schemas.openxmlformats.org/officeDocument/2006/relationships" xmlns:p="http://schemas.openxmlformats.org/presentationml/2006/main">
   <p:cSld>
     <p:spTree>
@@ -1457,210 +1702,6 @@
     <p:extLst>
       <p:ext uri="{BB962C8B-B14F-4D97-AF65-F5344CB8AC3E}">
         <p14:creationId xmlns:p14="http://schemas.microsoft.com/office/powerpoint/2010/main" val="1879055837"/>
-      </p:ext>
-    </p:extLst>
-  </p:cSld>
-  <p:clrMapOvr>
-    <a:masterClrMapping/>
-  </p:clrMapOvr>
-</p:notes>
-</file>
-
-<file path=ppt/notesSlides/notesSlide13.xml><?xml version="1.0" encoding="utf-8"?>
-<p:notes xmlns:a="http://schemas.openxmlformats.org/drawingml/2006/main" xmlns:r="http://schemas.openxmlformats.org/officeDocument/2006/relationships" xmlns:p="http://schemas.openxmlformats.org/presentationml/2006/main">
-  <p:cSld>
-    <p:spTree>
-      <p:nvGrpSpPr>
-        <p:cNvPr id="1" name="">
-          <a:extLst>
-            <a:ext uri="{FF2B5EF4-FFF2-40B4-BE49-F238E27FC236}">
-              <a16:creationId xmlns:a16="http://schemas.microsoft.com/office/drawing/2014/main" id="{F4B2594E-083A-33B0-1887-4D75961D8DFC}"/>
-            </a:ext>
-          </a:extLst>
-        </p:cNvPr>
-        <p:cNvGrpSpPr/>
-        <p:nvPr/>
-      </p:nvGrpSpPr>
-      <p:grpSpPr>
-        <a:xfrm>
-          <a:off x="0" y="0"/>
-          <a:ext cx="0" cy="0"/>
-          <a:chOff x="0" y="0"/>
-          <a:chExt cx="0" cy="0"/>
-        </a:xfrm>
-      </p:grpSpPr>
-      <p:sp>
-        <p:nvSpPr>
-          <p:cNvPr id="2" name="Slide Image Placeholder 1">
-            <a:extLst>
-              <a:ext uri="{FF2B5EF4-FFF2-40B4-BE49-F238E27FC236}">
-                <a16:creationId xmlns:a16="http://schemas.microsoft.com/office/drawing/2014/main" id="{649C972F-8115-0086-8D46-F43BA6CB6AFD}"/>
-              </a:ext>
-            </a:extLst>
-          </p:cNvPr>
-          <p:cNvSpPr>
-            <a:spLocks noGrp="1" noRot="1" noChangeAspect="1"/>
-          </p:cNvSpPr>
-          <p:nvPr>
-            <p:ph type="sldImg"/>
-          </p:nvPr>
-        </p:nvSpPr>
-        <p:spPr/>
-      </p:sp>
-      <p:sp>
-        <p:nvSpPr>
-          <p:cNvPr id="3" name="Notes Placeholder 2">
-            <a:extLst>
-              <a:ext uri="{FF2B5EF4-FFF2-40B4-BE49-F238E27FC236}">
-                <a16:creationId xmlns:a16="http://schemas.microsoft.com/office/drawing/2014/main" id="{7ECA05C0-C97B-9722-138D-940A0126F522}"/>
-              </a:ext>
-            </a:extLst>
-          </p:cNvPr>
-          <p:cNvSpPr>
-            <a:spLocks noGrp="1"/>
-          </p:cNvSpPr>
-          <p:nvPr>
-            <p:ph type="body" idx="1"/>
-          </p:nvPr>
-        </p:nvSpPr>
-        <p:spPr/>
-        <p:txBody>
-          <a:bodyPr/>
-          <a:lstStyle/>
-          <a:p>
-            <a:endParaRPr/>
-          </a:p>
-          <a:p>
-            <a:endParaRPr lang="en-US" dirty="0"/>
-          </a:p>
-          <a:p>
-            <a:endParaRPr lang="en-US" dirty="0"/>
-          </a:p>
-          <a:p>
-            <a:endParaRPr lang="en-US" dirty="0"/>
-          </a:p>
-          <a:p>
-            <a:endParaRPr lang="en-US" dirty="0"/>
-          </a:p>
-          <a:p>
-            <a:endParaRPr lang="en-US" dirty="0"/>
-          </a:p>
-          <a:p>
-            <a:endParaRPr lang="en-US" dirty="0"/>
-          </a:p>
-          <a:p>
-            <a:endParaRPr lang="en-US" dirty="0"/>
-          </a:p>
-          <a:p>
-            <a:endParaRPr lang="en-US" dirty="0"/>
-          </a:p>
-          <a:p>
-            <a:endParaRPr lang="en-US" dirty="0"/>
-          </a:p>
-          <a:p>
-            <a:endParaRPr lang="en-US" dirty="0"/>
-          </a:p>
-          <a:p>
-            <a:endParaRPr lang="en-US" dirty="0"/>
-          </a:p>
-          <a:p>
-            <a:endParaRPr lang="en-US" dirty="0"/>
-          </a:p>
-        </p:txBody>
-      </p:sp>
-      <p:sp>
-        <p:nvSpPr>
-          <p:cNvPr id="4" name="Slide Number Placeholder 3">
-            <a:extLst>
-              <a:ext uri="{FF2B5EF4-FFF2-40B4-BE49-F238E27FC236}">
-                <a16:creationId xmlns:a16="http://schemas.microsoft.com/office/drawing/2014/main" id="{49D93F59-9C10-56A8-29DB-C5BD61D5AF10}"/>
-              </a:ext>
-            </a:extLst>
-          </p:cNvPr>
-          <p:cNvSpPr>
-            <a:spLocks noGrp="1"/>
-          </p:cNvSpPr>
-          <p:nvPr>
-            <p:ph type="sldNum" sz="quarter" idx="5"/>
-          </p:nvPr>
-        </p:nvSpPr>
-        <p:spPr/>
-        <p:txBody>
-          <a:bodyPr/>
-          <a:lstStyle/>
-          <a:p>
-            <a:pPr marL="0" marR="0" lvl="0" indent="0" algn="r" defTabSz="914400" rtl="0" eaLnBrk="1" fontAlgn="auto" latinLnBrk="0" hangingPunct="1">
-              <a:lnSpc>
-                <a:spcPct val="100000"/>
-              </a:lnSpc>
-              <a:spcBef>
-                <a:spcPts val="0"/>
-              </a:spcBef>
-              <a:spcAft>
-                <a:spcPts val="0"/>
-              </a:spcAft>
-              <a:buClrTx/>
-              <a:buSzTx/>
-              <a:buFontTx/>
-              <a:buNone/>
-              <a:tabLst/>
-              <a:defRPr/>
-            </a:pPr>
-            <a:fld id="{4DC398A3-AF21-A342-B6A8-6929C36BB1BF}" type="slidenum">
-              <a:rPr kumimoji="0" lang="en-US" sz="1200" b="0" i="0" u="none" strike="noStrike" kern="1200" cap="none" spc="0" normalizeH="0" baseline="0" noProof="0" smtClean="0">
-                <a:ln>
-                  <a:noFill/>
-                </a:ln>
-                <a:solidFill>
-                  <a:prstClr val="black"/>
-                </a:solidFill>
-                <a:effectLst/>
-                <a:uLnTx/>
-                <a:uFillTx/>
-                <a:latin typeface="Calibri" panose="020F0502020204030204"/>
-                <a:ea typeface="+mn-ea"/>
-                <a:cs typeface="+mn-cs"/>
-              </a:rPr>
-              <a:pPr marL="0" marR="0" lvl="0" indent="0" algn="r" defTabSz="914400" rtl="0" eaLnBrk="1" fontAlgn="auto" latinLnBrk="0" hangingPunct="1">
-                <a:lnSpc>
-                  <a:spcPct val="100000"/>
-                </a:lnSpc>
-                <a:spcBef>
-                  <a:spcPts val="0"/>
-                </a:spcBef>
-                <a:spcAft>
-                  <a:spcPts val="0"/>
-                </a:spcAft>
-                <a:buClrTx/>
-                <a:buSzTx/>
-                <a:buFontTx/>
-                <a:buNone/>
-                <a:tabLst/>
-                <a:defRPr/>
-              </a:pPr>
-              <a:t>14</a:t>
-            </a:fld>
-            <a:endParaRPr kumimoji="0" lang="en-US" sz="1200" b="0" i="0" u="none" strike="noStrike" kern="1200" cap="none" spc="0" normalizeH="0" baseline="0" noProof="0">
-              <a:ln>
-                <a:noFill/>
-              </a:ln>
-              <a:solidFill>
-                <a:prstClr val="black"/>
-              </a:solidFill>
-              <a:effectLst/>
-              <a:uLnTx/>
-              <a:uFillTx/>
-              <a:latin typeface="Calibri" panose="020F0502020204030204"/>
-              <a:ea typeface="+mn-ea"/>
-              <a:cs typeface="+mn-cs"/>
-            </a:endParaRPr>
-          </a:p>
-        </p:txBody>
-      </p:sp>
-    </p:spTree>
-    <p:extLst>
-      <p:ext uri="{BB962C8B-B14F-4D97-AF65-F5344CB8AC3E}">
-        <p14:creationId xmlns:p14="http://schemas.microsoft.com/office/powerpoint/2010/main" val="1734577285"/>
       </p:ext>
     </p:extLst>
   </p:cSld>
@@ -2728,326 +2769,7 @@
           <a:bodyPr/>
           <a:lstStyle/>
           <a:p>
-            <a:pPr marL="0" marR="0" rtl="0">
-              <a:spcBef>
-                <a:spcPts val="0"/>
-              </a:spcBef>
-              <a:spcAft>
-                <a:spcPts val="0"/>
-              </a:spcAft>
-            </a:pPr>
-            <a:endParaRPr/>
-          </a:p>
-          <a:p>
-            <a:pPr marL="0" marR="0" rtl="0">
-              <a:spcBef>
-                <a:spcPts val="0"/>
-              </a:spcBef>
-              <a:spcAft>
-                <a:spcPts val="0"/>
-              </a:spcAft>
-            </a:pPr>
-            <a:endParaRPr/>
-          </a:p>
-          <a:p>
-            <a:pPr marL="0" marR="0" rtl="0">
-              <a:spcBef>
-                <a:spcPts val="0"/>
-              </a:spcBef>
-              <a:spcAft>
-                <a:spcPts val="0"/>
-              </a:spcAft>
-            </a:pPr>
-            <a:endParaRPr/>
-          </a:p>
-          <a:p>
-            <a:pPr marL="0" marR="0" rtl="0">
-              <a:spcBef>
-                <a:spcPts val="0"/>
-              </a:spcBef>
-              <a:spcAft>
-                <a:spcPts val="0"/>
-              </a:spcAft>
-            </a:pPr>
-            <a:endParaRPr/>
-          </a:p>
-          <a:p>
-            <a:pPr marL="0" marR="0" rtl="0">
-              <a:spcBef>
-                <a:spcPts val="0"/>
-              </a:spcBef>
-              <a:spcAft>
-                <a:spcPts val="0"/>
-              </a:spcAft>
-            </a:pPr>
-            <a:endParaRPr/>
-          </a:p>
-          <a:p>
-            <a:pPr marL="0" marR="0" rtl="0">
-              <a:spcBef>
-                <a:spcPts val="0"/>
-              </a:spcBef>
-              <a:spcAft>
-                <a:spcPts val="0"/>
-              </a:spcAft>
-            </a:pPr>
-            <a:endParaRPr/>
-          </a:p>
-          <a:p>
-            <a:pPr marL="0" marR="0" rtl="0">
-              <a:spcBef>
-                <a:spcPts val="0"/>
-              </a:spcBef>
-              <a:spcAft>
-                <a:spcPts val="0"/>
-              </a:spcAft>
-            </a:pPr>
-            <a:endParaRPr/>
-          </a:p>
-          <a:p>
-            <a:pPr marL="0" marR="0" rtl="0">
-              <a:spcBef>
-                <a:spcPts val="0"/>
-              </a:spcBef>
-              <a:spcAft>
-                <a:spcPts val="0"/>
-              </a:spcAft>
-            </a:pPr>
-            <a:endParaRPr/>
-          </a:p>
-          <a:p>
-            <a:pPr marL="0" marR="0" rtl="0">
-              <a:spcBef>
-                <a:spcPts val="0"/>
-              </a:spcBef>
-              <a:spcAft>
-                <a:spcPts val="0"/>
-              </a:spcAft>
-            </a:pPr>
-            <a:endParaRPr/>
-          </a:p>
-          <a:p>
-            <a:pPr marL="0" marR="0" rtl="0">
-              <a:spcBef>
-                <a:spcPts val="0"/>
-              </a:spcBef>
-              <a:spcAft>
-                <a:spcPts val="0"/>
-              </a:spcAft>
-            </a:pPr>
-            <a:endParaRPr/>
-          </a:p>
-          <a:p>
-            <a:pPr marL="0" marR="0" rtl="0">
-              <a:spcBef>
-                <a:spcPts val="0"/>
-              </a:spcBef>
-              <a:spcAft>
-                <a:spcPts val="0"/>
-              </a:spcAft>
-            </a:pPr>
-            <a:endParaRPr/>
-          </a:p>
-          <a:p>
-            <a:pPr marL="0" marR="0" rtl="0">
-              <a:spcBef>
-                <a:spcPts val="0"/>
-              </a:spcBef>
-              <a:spcAft>
-                <a:spcPts val="0"/>
-              </a:spcAft>
-            </a:pPr>
-            <a:endParaRPr/>
-          </a:p>
-          <a:p>
-            <a:pPr marL="0" marR="0" rtl="0">
-              <a:spcBef>
-                <a:spcPts val="0"/>
-              </a:spcBef>
-              <a:spcAft>
-                <a:spcPts val="0"/>
-              </a:spcAft>
-            </a:pPr>
-            <a:endParaRPr/>
-          </a:p>
-          <a:p>
-            <a:pPr marL="0" marR="0" rtl="0">
-              <a:spcBef>
-                <a:spcPts val="0"/>
-              </a:spcBef>
-              <a:spcAft>
-                <a:spcPts val="0"/>
-              </a:spcAft>
-            </a:pPr>
-            <a:endParaRPr/>
-          </a:p>
-          <a:p>
-            <a:pPr marL="0" marR="0" rtl="0">
-              <a:spcBef>
-                <a:spcPts val="0"/>
-              </a:spcBef>
-              <a:spcAft>
-                <a:spcPts val="0"/>
-              </a:spcAft>
-            </a:pPr>
-            <a:endParaRPr/>
-          </a:p>
-          <a:p>
-            <a:pPr marL="0" marR="0" rtl="0">
-              <a:spcBef>
-                <a:spcPts val="0"/>
-              </a:spcBef>
-              <a:spcAft>
-                <a:spcPts val="0"/>
-              </a:spcAft>
-            </a:pPr>
-            <a:endParaRPr/>
-          </a:p>
-          <a:p>
-            <a:pPr marL="0" marR="0" rtl="0">
-              <a:spcBef>
-                <a:spcPts val="0"/>
-              </a:spcBef>
-              <a:spcAft>
-                <a:spcPts val="0"/>
-              </a:spcAft>
-            </a:pPr>
-            <a:endParaRPr/>
-          </a:p>
-          <a:p>
-            <a:pPr marL="0" marR="0" rtl="0">
-              <a:spcBef>
-                <a:spcPts val="0"/>
-              </a:spcBef>
-              <a:spcAft>
-                <a:spcPts val="0"/>
-              </a:spcAft>
-            </a:pPr>
-            <a:endParaRPr/>
-          </a:p>
-          <a:p>
-            <a:pPr marL="0" marR="0" rtl="0">
-              <a:spcBef>
-                <a:spcPts val="0"/>
-              </a:spcBef>
-              <a:spcAft>
-                <a:spcPts val="0"/>
-              </a:spcAft>
-            </a:pPr>
-            <a:endParaRPr/>
-          </a:p>
-          <a:p>
-            <a:pPr marL="0" marR="0" rtl="0">
-              <a:spcBef>
-                <a:spcPts val="0"/>
-              </a:spcBef>
-              <a:spcAft>
-                <a:spcPts val="0"/>
-              </a:spcAft>
-            </a:pPr>
-            <a:endParaRPr/>
-          </a:p>
-          <a:p>
-            <a:pPr marL="0" marR="0" rtl="0">
-              <a:spcBef>
-                <a:spcPts val="0"/>
-              </a:spcBef>
-              <a:spcAft>
-                <a:spcPts val="0"/>
-              </a:spcAft>
-            </a:pPr>
-            <a:endParaRPr/>
-          </a:p>
-          <a:p>
-            <a:pPr marL="0" marR="0" rtl="0">
-              <a:spcBef>
-                <a:spcPts val="0"/>
-              </a:spcBef>
-              <a:spcAft>
-                <a:spcPts val="0"/>
-              </a:spcAft>
-            </a:pPr>
-            <a:endParaRPr/>
-          </a:p>
-          <a:p>
-            <a:pPr marL="0" marR="0" rtl="0">
-              <a:spcBef>
-                <a:spcPts val="0"/>
-              </a:spcBef>
-              <a:spcAft>
-                <a:spcPts val="0"/>
-              </a:spcAft>
-            </a:pPr>
-            <a:endParaRPr/>
-          </a:p>
-          <a:p>
-            <a:pPr marL="0" marR="0" rtl="0">
-              <a:spcBef>
-                <a:spcPts val="0"/>
-              </a:spcBef>
-              <a:spcAft>
-                <a:spcPts val="0"/>
-              </a:spcAft>
-            </a:pPr>
-            <a:endParaRPr/>
-          </a:p>
-          <a:p>
-            <a:pPr marL="0" marR="0" rtl="0">
-              <a:spcBef>
-                <a:spcPts val="0"/>
-              </a:spcBef>
-              <a:spcAft>
-                <a:spcPts val="0"/>
-              </a:spcAft>
-            </a:pPr>
-            <a:endParaRPr/>
-          </a:p>
-          <a:p>
-            <a:pPr marL="0" marR="0" rtl="0">
-              <a:spcBef>
-                <a:spcPts val="0"/>
-              </a:spcBef>
-              <a:spcAft>
-                <a:spcPts val="0"/>
-              </a:spcAft>
-            </a:pPr>
-            <a:endParaRPr/>
-          </a:p>
-          <a:p>
-            <a:pPr marL="0" marR="0" rtl="0">
-              <a:spcBef>
-                <a:spcPts val="0"/>
-              </a:spcBef>
-              <a:spcAft>
-                <a:spcPts val="0"/>
-              </a:spcAft>
-            </a:pPr>
-            <a:endParaRPr/>
-          </a:p>
-          <a:p>
-            <a:pPr marL="0" marR="0" rtl="0">
-              <a:spcBef>
-                <a:spcPts val="0"/>
-              </a:spcBef>
-              <a:spcAft>
-                <a:spcPts val="0"/>
-              </a:spcAft>
-            </a:pPr>
-            <a:endParaRPr/>
-          </a:p>
-          <a:p>
-            <a:pPr marL="0" marR="0" rtl="0">
-              <a:spcBef>
-                <a:spcPts val="0"/>
-              </a:spcBef>
-              <a:spcAft>
-                <a:spcPts val="0"/>
-              </a:spcAft>
-            </a:pPr>
-            <a:endParaRPr/>
-          </a:p>
-          <a:p>
-            <a:endParaRPr lang="en-US" dirty="0"/>
+            <a:endParaRPr lang="en-US"/>
           </a:p>
         </p:txBody>
       </p:sp>
@@ -3068,7 +2790,7 @@
           <a:p>
             <a:fld id="{4DC398A3-AF21-A342-B6A8-6929C36BB1BF}" type="slidenum">
               <a:rPr lang="en-US" smtClean="0"/>
-              <a:t>9</a:t>
+              <a:t>8</a:t>
             </a:fld>
             <a:endParaRPr lang="en-US"/>
           </a:p>
@@ -3077,7 +2799,7 @@
     </p:spTree>
     <p:extLst>
       <p:ext uri="{BB962C8B-B14F-4D97-AF65-F5344CB8AC3E}">
-        <p14:creationId xmlns:p14="http://schemas.microsoft.com/office/powerpoint/2010/main" val="1191104622"/>
+        <p14:creationId xmlns:p14="http://schemas.microsoft.com/office/powerpoint/2010/main" val="3869182022"/>
       </p:ext>
     </p:extLst>
   </p:cSld>
@@ -3131,111 +2853,326 @@
           <a:bodyPr/>
           <a:lstStyle/>
           <a:p>
-            <a:pPr marL="0" marR="0" indent="0" algn="l" defTabSz="914400" rtl="0" eaLnBrk="1" fontAlgn="auto" latinLnBrk="0" hangingPunct="1">
-              <a:lnSpc>
-                <a:spcPct val="200000"/>
-              </a:lnSpc>
+            <a:pPr marL="0" marR="0" rtl="0">
               <a:spcBef>
                 <a:spcPts val="0"/>
               </a:spcBef>
               <a:spcAft>
                 <a:spcPts val="0"/>
               </a:spcAft>
-              <a:buClrTx/>
-              <a:buSzTx/>
-              <a:buFontTx/>
-              <a:buNone/>
-              <a:tabLst/>
-              <a:defRPr/>
             </a:pPr>
-            <a:br>
-              <a:rPr lang="en-US" sz="9600" b="1" dirty="0">
-                <a:latin typeface="Helvetica Neue" panose="02000503000000020004" pitchFamily="2" charset="0"/>
-                <a:ea typeface="Helvetica Neue" panose="02000503000000020004" pitchFamily="2" charset="0"/>
-                <a:cs typeface="Helvetica Neue" panose="02000503000000020004" pitchFamily="2" charset="0"/>
-              </a:rPr>
-            </a:br>
-            <a:br>
-              <a:rPr lang="en-US" sz="9600" b="1" dirty="0">
-                <a:latin typeface="Helvetica Neue" panose="02000503000000020004" pitchFamily="2" charset="0"/>
-                <a:ea typeface="Helvetica Neue" panose="02000503000000020004" pitchFamily="2" charset="0"/>
-                <a:cs typeface="Helvetica Neue" panose="02000503000000020004" pitchFamily="2" charset="0"/>
-              </a:rPr>
-            </a:br>
-            <a:br>
-              <a:rPr lang="en-US" sz="9600" b="1" dirty="0">
-                <a:latin typeface="Helvetica Neue" panose="02000503000000020004" pitchFamily="2" charset="0"/>
-                <a:ea typeface="Helvetica Neue" panose="02000503000000020004" pitchFamily="2" charset="0"/>
-                <a:cs typeface="Helvetica Neue" panose="02000503000000020004" pitchFamily="2" charset="0"/>
-              </a:rPr>
-            </a:br>
-            <a:br>
-              <a:rPr lang="en-US" sz="9600" b="1" dirty="0">
-                <a:latin typeface="Helvetica Neue" panose="02000503000000020004" pitchFamily="2" charset="0"/>
-                <a:ea typeface="Helvetica Neue" panose="02000503000000020004" pitchFamily="2" charset="0"/>
-                <a:cs typeface="Helvetica Neue" panose="02000503000000020004" pitchFamily="2" charset="0"/>
-              </a:rPr>
-            </a:br>
-            <a:br>
-              <a:rPr lang="en-US" sz="9600" b="1" dirty="0">
-                <a:latin typeface="Helvetica Neue" panose="02000503000000020004" pitchFamily="2" charset="0"/>
-                <a:ea typeface="Helvetica Neue" panose="02000503000000020004" pitchFamily="2" charset="0"/>
-                <a:cs typeface="Helvetica Neue" panose="02000503000000020004" pitchFamily="2" charset="0"/>
-              </a:rPr>
-            </a:br>
-            <a:endParaRPr lang="en-US" sz="9600" b="1" dirty="0">
-              <a:latin typeface="Helvetica Neue" panose="02000503000000020004" pitchFamily="2" charset="0"/>
-              <a:ea typeface="Helvetica Neue" panose="02000503000000020004" pitchFamily="2" charset="0"/>
-              <a:cs typeface="Helvetica Neue" panose="02000503000000020004" pitchFamily="2" charset="0"/>
-            </a:endParaRPr>
-          </a:p>
-          <a:p>
-            <a:pPr marL="0" marR="0" indent="0" algn="l" defTabSz="914400" rtl="0" eaLnBrk="1" fontAlgn="auto" latinLnBrk="0" hangingPunct="1">
-              <a:lnSpc>
-                <a:spcPct val="200000"/>
-              </a:lnSpc>
+            <a:endParaRPr/>
+          </a:p>
+          <a:p>
+            <a:pPr marL="0" marR="0" rtl="0">
               <a:spcBef>
                 <a:spcPts val="0"/>
               </a:spcBef>
               <a:spcAft>
                 <a:spcPts val="0"/>
               </a:spcAft>
-              <a:buClrTx/>
-              <a:buSzTx/>
-              <a:buFontTx/>
-              <a:buNone/>
-              <a:tabLst/>
-              <a:defRPr/>
             </a:pPr>
-            <a:endParaRPr lang="en-US" sz="9600" b="1" dirty="0">
-              <a:latin typeface="Helvetica Neue" panose="02000503000000020004" pitchFamily="2" charset="0"/>
-              <a:ea typeface="Helvetica Neue" panose="02000503000000020004" pitchFamily="2" charset="0"/>
-              <a:cs typeface="Helvetica Neue" panose="02000503000000020004" pitchFamily="2" charset="0"/>
-            </a:endParaRPr>
-          </a:p>
-          <a:p>
-            <a:pPr marL="0" marR="0" indent="0" algn="l" defTabSz="914400" rtl="0" eaLnBrk="1" fontAlgn="auto" latinLnBrk="0" hangingPunct="1">
-              <a:lnSpc>
-                <a:spcPct val="200000"/>
-              </a:lnSpc>
+            <a:endParaRPr/>
+          </a:p>
+          <a:p>
+            <a:pPr marL="0" marR="0" rtl="0">
               <a:spcBef>
                 <a:spcPts val="0"/>
               </a:spcBef>
               <a:spcAft>
                 <a:spcPts val="0"/>
               </a:spcAft>
-              <a:buClrTx/>
-              <a:buSzTx/>
-              <a:buFontTx/>
-              <a:buNone/>
-              <a:tabLst/>
-              <a:defRPr/>
             </a:pPr>
-            <a:endParaRPr lang="en-US" sz="9600" b="1" dirty="0">
-              <a:latin typeface="Helvetica Neue" panose="02000503000000020004" pitchFamily="2" charset="0"/>
-              <a:ea typeface="Helvetica Neue" panose="02000503000000020004" pitchFamily="2" charset="0"/>
-              <a:cs typeface="Helvetica Neue" panose="02000503000000020004" pitchFamily="2" charset="0"/>
-            </a:endParaRPr>
+            <a:endParaRPr/>
+          </a:p>
+          <a:p>
+            <a:pPr marL="0" marR="0" rtl="0">
+              <a:spcBef>
+                <a:spcPts val="0"/>
+              </a:spcBef>
+              <a:spcAft>
+                <a:spcPts val="0"/>
+              </a:spcAft>
+            </a:pPr>
+            <a:endParaRPr/>
+          </a:p>
+          <a:p>
+            <a:pPr marL="0" marR="0" rtl="0">
+              <a:spcBef>
+                <a:spcPts val="0"/>
+              </a:spcBef>
+              <a:spcAft>
+                <a:spcPts val="0"/>
+              </a:spcAft>
+            </a:pPr>
+            <a:endParaRPr/>
+          </a:p>
+          <a:p>
+            <a:pPr marL="0" marR="0" rtl="0">
+              <a:spcBef>
+                <a:spcPts val="0"/>
+              </a:spcBef>
+              <a:spcAft>
+                <a:spcPts val="0"/>
+              </a:spcAft>
+            </a:pPr>
+            <a:endParaRPr/>
+          </a:p>
+          <a:p>
+            <a:pPr marL="0" marR="0" rtl="0">
+              <a:spcBef>
+                <a:spcPts val="0"/>
+              </a:spcBef>
+              <a:spcAft>
+                <a:spcPts val="0"/>
+              </a:spcAft>
+            </a:pPr>
+            <a:endParaRPr/>
+          </a:p>
+          <a:p>
+            <a:pPr marL="0" marR="0" rtl="0">
+              <a:spcBef>
+                <a:spcPts val="0"/>
+              </a:spcBef>
+              <a:spcAft>
+                <a:spcPts val="0"/>
+              </a:spcAft>
+            </a:pPr>
+            <a:endParaRPr/>
+          </a:p>
+          <a:p>
+            <a:pPr marL="0" marR="0" rtl="0">
+              <a:spcBef>
+                <a:spcPts val="0"/>
+              </a:spcBef>
+              <a:spcAft>
+                <a:spcPts val="0"/>
+              </a:spcAft>
+            </a:pPr>
+            <a:endParaRPr/>
+          </a:p>
+          <a:p>
+            <a:pPr marL="0" marR="0" rtl="0">
+              <a:spcBef>
+                <a:spcPts val="0"/>
+              </a:spcBef>
+              <a:spcAft>
+                <a:spcPts val="0"/>
+              </a:spcAft>
+            </a:pPr>
+            <a:endParaRPr/>
+          </a:p>
+          <a:p>
+            <a:pPr marL="0" marR="0" rtl="0">
+              <a:spcBef>
+                <a:spcPts val="0"/>
+              </a:spcBef>
+              <a:spcAft>
+                <a:spcPts val="0"/>
+              </a:spcAft>
+            </a:pPr>
+            <a:endParaRPr/>
+          </a:p>
+          <a:p>
+            <a:pPr marL="0" marR="0" rtl="0">
+              <a:spcBef>
+                <a:spcPts val="0"/>
+              </a:spcBef>
+              <a:spcAft>
+                <a:spcPts val="0"/>
+              </a:spcAft>
+            </a:pPr>
+            <a:endParaRPr/>
+          </a:p>
+          <a:p>
+            <a:pPr marL="0" marR="0" rtl="0">
+              <a:spcBef>
+                <a:spcPts val="0"/>
+              </a:spcBef>
+              <a:spcAft>
+                <a:spcPts val="0"/>
+              </a:spcAft>
+            </a:pPr>
+            <a:endParaRPr/>
+          </a:p>
+          <a:p>
+            <a:pPr marL="0" marR="0" rtl="0">
+              <a:spcBef>
+                <a:spcPts val="0"/>
+              </a:spcBef>
+              <a:spcAft>
+                <a:spcPts val="0"/>
+              </a:spcAft>
+            </a:pPr>
+            <a:endParaRPr/>
+          </a:p>
+          <a:p>
+            <a:pPr marL="0" marR="0" rtl="0">
+              <a:spcBef>
+                <a:spcPts val="0"/>
+              </a:spcBef>
+              <a:spcAft>
+                <a:spcPts val="0"/>
+              </a:spcAft>
+            </a:pPr>
+            <a:endParaRPr/>
+          </a:p>
+          <a:p>
+            <a:pPr marL="0" marR="0" rtl="0">
+              <a:spcBef>
+                <a:spcPts val="0"/>
+              </a:spcBef>
+              <a:spcAft>
+                <a:spcPts val="0"/>
+              </a:spcAft>
+            </a:pPr>
+            <a:endParaRPr/>
+          </a:p>
+          <a:p>
+            <a:pPr marL="0" marR="0" rtl="0">
+              <a:spcBef>
+                <a:spcPts val="0"/>
+              </a:spcBef>
+              <a:spcAft>
+                <a:spcPts val="0"/>
+              </a:spcAft>
+            </a:pPr>
+            <a:endParaRPr/>
+          </a:p>
+          <a:p>
+            <a:pPr marL="0" marR="0" rtl="0">
+              <a:spcBef>
+                <a:spcPts val="0"/>
+              </a:spcBef>
+              <a:spcAft>
+                <a:spcPts val="0"/>
+              </a:spcAft>
+            </a:pPr>
+            <a:endParaRPr/>
+          </a:p>
+          <a:p>
+            <a:pPr marL="0" marR="0" rtl="0">
+              <a:spcBef>
+                <a:spcPts val="0"/>
+              </a:spcBef>
+              <a:spcAft>
+                <a:spcPts val="0"/>
+              </a:spcAft>
+            </a:pPr>
+            <a:endParaRPr/>
+          </a:p>
+          <a:p>
+            <a:pPr marL="0" marR="0" rtl="0">
+              <a:spcBef>
+                <a:spcPts val="0"/>
+              </a:spcBef>
+              <a:spcAft>
+                <a:spcPts val="0"/>
+              </a:spcAft>
+            </a:pPr>
+            <a:endParaRPr/>
+          </a:p>
+          <a:p>
+            <a:pPr marL="0" marR="0" rtl="0">
+              <a:spcBef>
+                <a:spcPts val="0"/>
+              </a:spcBef>
+              <a:spcAft>
+                <a:spcPts val="0"/>
+              </a:spcAft>
+            </a:pPr>
+            <a:endParaRPr/>
+          </a:p>
+          <a:p>
+            <a:pPr marL="0" marR="0" rtl="0">
+              <a:spcBef>
+                <a:spcPts val="0"/>
+              </a:spcBef>
+              <a:spcAft>
+                <a:spcPts val="0"/>
+              </a:spcAft>
+            </a:pPr>
+            <a:endParaRPr/>
+          </a:p>
+          <a:p>
+            <a:pPr marL="0" marR="0" rtl="0">
+              <a:spcBef>
+                <a:spcPts val="0"/>
+              </a:spcBef>
+              <a:spcAft>
+                <a:spcPts val="0"/>
+              </a:spcAft>
+            </a:pPr>
+            <a:endParaRPr/>
+          </a:p>
+          <a:p>
+            <a:pPr marL="0" marR="0" rtl="0">
+              <a:spcBef>
+                <a:spcPts val="0"/>
+              </a:spcBef>
+              <a:spcAft>
+                <a:spcPts val="0"/>
+              </a:spcAft>
+            </a:pPr>
+            <a:endParaRPr/>
+          </a:p>
+          <a:p>
+            <a:pPr marL="0" marR="0" rtl="0">
+              <a:spcBef>
+                <a:spcPts val="0"/>
+              </a:spcBef>
+              <a:spcAft>
+                <a:spcPts val="0"/>
+              </a:spcAft>
+            </a:pPr>
+            <a:endParaRPr/>
+          </a:p>
+          <a:p>
+            <a:pPr marL="0" marR="0" rtl="0">
+              <a:spcBef>
+                <a:spcPts val="0"/>
+              </a:spcBef>
+              <a:spcAft>
+                <a:spcPts val="0"/>
+              </a:spcAft>
+            </a:pPr>
+            <a:endParaRPr/>
+          </a:p>
+          <a:p>
+            <a:pPr marL="0" marR="0" rtl="0">
+              <a:spcBef>
+                <a:spcPts val="0"/>
+              </a:spcBef>
+              <a:spcAft>
+                <a:spcPts val="0"/>
+              </a:spcAft>
+            </a:pPr>
+            <a:endParaRPr/>
+          </a:p>
+          <a:p>
+            <a:pPr marL="0" marR="0" rtl="0">
+              <a:spcBef>
+                <a:spcPts val="0"/>
+              </a:spcBef>
+              <a:spcAft>
+                <a:spcPts val="0"/>
+              </a:spcAft>
+            </a:pPr>
+            <a:endParaRPr/>
+          </a:p>
+          <a:p>
+            <a:pPr marL="0" marR="0" rtl="0">
+              <a:spcBef>
+                <a:spcPts val="0"/>
+              </a:spcBef>
+              <a:spcAft>
+                <a:spcPts val="0"/>
+              </a:spcAft>
+            </a:pPr>
+            <a:endParaRPr/>
+          </a:p>
+          <a:p>
+            <a:endParaRPr lang="en-US" dirty="0"/>
           </a:p>
         </p:txBody>
       </p:sp>
@@ -3254,78 +3191,18 @@
           <a:bodyPr/>
           <a:lstStyle/>
           <a:p>
-            <a:pPr marL="0" marR="0" lvl="0" indent="0" algn="r" defTabSz="914400" rtl="0" eaLnBrk="1" fontAlgn="auto" latinLnBrk="0" hangingPunct="1">
-              <a:lnSpc>
-                <a:spcPct val="100000"/>
-              </a:lnSpc>
-              <a:spcBef>
-                <a:spcPts val="0"/>
-              </a:spcBef>
-              <a:spcAft>
-                <a:spcPts val="0"/>
-              </a:spcAft>
-              <a:buClrTx/>
-              <a:buSzTx/>
-              <a:buFontTx/>
-              <a:buNone/>
-              <a:tabLst/>
-              <a:defRPr/>
-            </a:pPr>
             <a:fld id="{4DC398A3-AF21-A342-B6A8-6929C36BB1BF}" type="slidenum">
-              <a:rPr kumimoji="0" lang="en-US" sz="1200" b="0" i="0" u="none" strike="noStrike" kern="1200" cap="none" spc="0" normalizeH="0" baseline="0" noProof="0" smtClean="0">
-                <a:ln>
-                  <a:noFill/>
-                </a:ln>
-                <a:solidFill>
-                  <a:prstClr val="black"/>
-                </a:solidFill>
-                <a:effectLst/>
-                <a:uLnTx/>
-                <a:uFillTx/>
-                <a:latin typeface="Calibri" panose="020F0502020204030204"/>
-                <a:ea typeface="+mn-ea"/>
-                <a:cs typeface="+mn-cs"/>
-              </a:rPr>
-              <a:pPr marL="0" marR="0" lvl="0" indent="0" algn="r" defTabSz="914400" rtl="0" eaLnBrk="1" fontAlgn="auto" latinLnBrk="0" hangingPunct="1">
-                <a:lnSpc>
-                  <a:spcPct val="100000"/>
-                </a:lnSpc>
-                <a:spcBef>
-                  <a:spcPts val="0"/>
-                </a:spcBef>
-                <a:spcAft>
-                  <a:spcPts val="0"/>
-                </a:spcAft>
-                <a:buClrTx/>
-                <a:buSzTx/>
-                <a:buFontTx/>
-                <a:buNone/>
-                <a:tabLst/>
-                <a:defRPr/>
-              </a:pPr>
-              <a:t>10</a:t>
+              <a:rPr lang="en-US" smtClean="0"/>
+              <a:t>9</a:t>
             </a:fld>
-            <a:endParaRPr kumimoji="0" lang="en-US" sz="1200" b="0" i="0" u="none" strike="noStrike" kern="1200" cap="none" spc="0" normalizeH="0" baseline="0" noProof="0">
-              <a:ln>
-                <a:noFill/>
-              </a:ln>
-              <a:solidFill>
-                <a:prstClr val="black"/>
-              </a:solidFill>
-              <a:effectLst/>
-              <a:uLnTx/>
-              <a:uFillTx/>
-              <a:latin typeface="Calibri" panose="020F0502020204030204"/>
-              <a:ea typeface="+mn-ea"/>
-              <a:cs typeface="+mn-cs"/>
-            </a:endParaRPr>
+            <a:endParaRPr lang="en-US"/>
           </a:p>
         </p:txBody>
       </p:sp>
     </p:spTree>
     <p:extLst>
       <p:ext uri="{BB962C8B-B14F-4D97-AF65-F5344CB8AC3E}">
-        <p14:creationId xmlns:p14="http://schemas.microsoft.com/office/powerpoint/2010/main" val="596825902"/>
+        <p14:creationId xmlns:p14="http://schemas.microsoft.com/office/powerpoint/2010/main" val="1191104622"/>
       </p:ext>
     </p:extLst>
   </p:cSld>
@@ -6733,7 +6610,7 @@
     <p:bg>
       <p:bgPr>
         <a:solidFill>
-          <a:schemeClr val="tx1"/>
+          <a:srgbClr val="7030A0"/>
         </a:solidFill>
         <a:effectLst/>
       </p:bgPr>
@@ -7683,7 +7560,7 @@
           <a:noFill/>
           <a:ln w="38100">
             <a:solidFill>
-              <a:srgbClr val="7030A0"/>
+              <a:schemeClr val="bg1"/>
             </a:solidFill>
           </a:ln>
         </p:spPr>
@@ -8703,7 +8580,7 @@
           <a:noFill/>
           <a:ln w="38100">
             <a:solidFill>
-              <a:srgbClr val="7030A0"/>
+              <a:schemeClr val="bg1"/>
             </a:solidFill>
           </a:ln>
         </p:spPr>
@@ -9638,25 +9515,23 @@
         </p:nvSpPr>
         <p:spPr>
           <a:xfrm>
-            <a:off x="3306195" y="258919"/>
-            <a:ext cx="6849952" cy="523220"/>
+            <a:off x="0" y="0"/>
+            <a:ext cx="12192000" cy="585216"/>
           </a:xfrm>
           <a:prstGeom prst="rect">
             <a:avLst/>
           </a:prstGeom>
-          <a:solidFill>
-            <a:srgbClr val="7030A0"/>
-          </a:solidFill>
+          <a:noFill/>
         </p:spPr>
         <p:txBody>
-          <a:bodyPr wrap="none">
+          <a:bodyPr wrap="square">
             <a:spAutoFit/>
           </a:bodyPr>
           <a:lstStyle/>
           <a:p>
             <a:pPr algn="ctr"/>
             <a:r>
-              <a:rPr lang="en-US" sz="2800" b="1" dirty="0">
+              <a:rPr lang="en-US" sz="3200" b="1" dirty="0">
                 <a:solidFill>
                   <a:schemeClr val="bg1"/>
                 </a:solidFill>
@@ -9666,7 +9541,7 @@
               </a:rPr>
               <a:t>Architrino Path History and Wake Hits</a:t>
             </a:r>
-            <a:endParaRPr lang="en-US" sz="2800" b="1" baseline="30000" dirty="0">
+            <a:endParaRPr lang="en-US" sz="3200" b="1" baseline="30000" dirty="0">
               <a:solidFill>
                 <a:schemeClr val="bg1"/>
               </a:solidFill>
@@ -9931,7 +9806,7 @@
     <p:bg>
       <p:bgPr>
         <a:solidFill>
-          <a:schemeClr val="tx1"/>
+          <a:srgbClr val="7030A0"/>
         </a:solidFill>
         <a:effectLst/>
       </p:bgPr>
@@ -10656,7 +10531,7 @@
           <a:noFill/>
           <a:ln w="38100">
             <a:solidFill>
-              <a:srgbClr val="7030A0"/>
+              <a:schemeClr val="bg1"/>
             </a:solidFill>
           </a:ln>
         </p:spPr>
@@ -11539,7 +11414,7 @@
           <a:noFill/>
           <a:ln w="38100">
             <a:solidFill>
-              <a:srgbClr val="7030A0"/>
+              <a:schemeClr val="bg1"/>
             </a:solidFill>
           </a:ln>
         </p:spPr>
@@ -12694,25 +12569,23 @@
         </p:nvSpPr>
         <p:spPr>
           <a:xfrm>
-            <a:off x="2750180" y="307606"/>
-            <a:ext cx="6849952" cy="523220"/>
+            <a:off x="0" y="0"/>
+            <a:ext cx="12192000" cy="585216"/>
           </a:xfrm>
           <a:prstGeom prst="rect">
             <a:avLst/>
           </a:prstGeom>
-          <a:solidFill>
-            <a:srgbClr val="7030A0"/>
-          </a:solidFill>
+          <a:noFill/>
         </p:spPr>
         <p:txBody>
-          <a:bodyPr wrap="none">
+          <a:bodyPr wrap="square">
             <a:spAutoFit/>
           </a:bodyPr>
           <a:lstStyle/>
           <a:p>
             <a:pPr algn="ctr"/>
             <a:r>
-              <a:rPr lang="en-US" sz="2800" b="1" dirty="0">
+              <a:rPr lang="en-US" sz="3200" b="1" dirty="0">
                 <a:solidFill>
                   <a:schemeClr val="bg1"/>
                 </a:solidFill>
@@ -12722,7 +12595,7 @@
               </a:rPr>
               <a:t>Architrino Path History and Wake Hits</a:t>
             </a:r>
-            <a:endParaRPr lang="en-US" sz="2800" b="1" baseline="30000" dirty="0">
+            <a:endParaRPr lang="en-US" sz="3200" b="1" baseline="30000" dirty="0">
               <a:solidFill>
                 <a:schemeClr val="bg1"/>
               </a:solidFill>
@@ -13052,7 +12925,29 @@
                 <a:ea typeface="Helvetica Neue" panose="02000503000000020004" pitchFamily="2" charset="0"/>
                 <a:cs typeface="Helvetica Neue" panose="02000503000000020004" pitchFamily="2" charset="0"/>
               </a:rPr>
-              <a:t>The binary symmetry point occurs when architrino speed |v| = cf.</a:t>
+              <a:t>The binary symmetry point occurs when architrino speed |v| = c</a:t>
+            </a:r>
+            <a:r>
+              <a:rPr baseline="-25000">
+                <a:solidFill>
+                  <a:prstClr val="white"/>
+                </a:solidFill>
+                <a:latin typeface="Helvetica Neue" panose="02000503000000020004" pitchFamily="2" charset="0"/>
+                <a:ea typeface="Helvetica Neue" panose="02000503000000020004" pitchFamily="2" charset="0"/>
+                <a:cs typeface="Helvetica Neue" panose="02000503000000020004" pitchFamily="2" charset="0"/>
+              </a:rPr>
+              <a:t>f</a:t>
+            </a:r>
+            <a:r>
+              <a:rPr>
+                <a:solidFill>
+                  <a:prstClr val="white"/>
+                </a:solidFill>
+                <a:latin typeface="Helvetica Neue" panose="02000503000000020004" pitchFamily="2" charset="0"/>
+                <a:ea typeface="Helvetica Neue" panose="02000503000000020004" pitchFamily="2" charset="0"/>
+                <a:cs typeface="Helvetica Neue" panose="02000503000000020004" pitchFamily="2" charset="0"/>
+              </a:rPr>
+              <a:t>.</a:t>
             </a:r>
             <a:endParaRPr lang="en-US" dirty="0">
               <a:solidFill>
@@ -13544,8 +13439,8 @@
         </p:nvSpPr>
         <p:spPr>
           <a:xfrm>
-            <a:off x="796730" y="91586"/>
-            <a:ext cx="10854481" cy="777875"/>
+            <a:off x="0" y="0"/>
+            <a:ext cx="12192000" cy="585216"/>
           </a:xfrm>
           <a:prstGeom prst="rect">
             <a:avLst/>
@@ -13581,7 +13476,7 @@
             </a:lvl1pPr>
           </a:lstStyle>
           <a:p>
-            <a:pPr marL="0" marR="0" lvl="0" indent="0" algn="l" defTabSz="914400" rtl="0" eaLnBrk="1" fontAlgn="auto" latinLnBrk="0" hangingPunct="1">
+            <a:pPr marL="0" marR="0" lvl="0" indent="0" algn="ctr" defTabSz="914400" rtl="0" eaLnBrk="1" fontAlgn="auto" latinLnBrk="0" hangingPunct="1">
               <a:lnSpc>
                 <a:spcPct val="90000"/>
               </a:lnSpc>
@@ -13599,7 +13494,7 @@
               <a:defRPr/>
             </a:pPr>
             <a:r>
-              <a:rPr kumimoji="0" lang="en-US" sz="4400" b="1" i="0" u="none" strike="noStrike" kern="1200" cap="none" spc="0" normalizeH="0" baseline="0" noProof="0" dirty="0">
+              <a:rPr kumimoji="0" lang="en-US" sz="3200" b="1" i="0" u="none" strike="noStrike" kern="1200" cap="none" spc="0" normalizeH="0" baseline="0" noProof="0" dirty="0">
                 <a:ln>
                   <a:noFill/>
                 </a:ln>
@@ -14715,9 +14610,9 @@
           <p:nvPr/>
         </p:nvCxnSpPr>
         <p:spPr>
-          <a:xfrm>
-            <a:off x="7091183" y="0"/>
-            <a:ext cx="0" cy="6858000"/>
+          <a:xfrm flipH="1">
+            <a:off x="7072815" y="560599"/>
+            <a:ext cx="20662" cy="5641418"/>
           </a:xfrm>
           <a:prstGeom prst="line">
             <a:avLst/>
@@ -14727,8 +14622,8 @@
               <a:schemeClr val="bg1"/>
             </a:solidFill>
             <a:prstDash val="solid"/>
-            <a:headEnd type="triangle" w="lg" len="lg"/>
-            <a:tailEnd type="triangle" w="lg" len="lg"/>
+            <a:headEnd type="none" w="lg" len="lg"/>
+            <a:tailEnd type="none" w="lg" len="lg"/>
           </a:ln>
         </p:spPr>
         <p:style>
@@ -16460,8 +16355,8 @@
         </p:nvSpPr>
         <p:spPr>
           <a:xfrm>
-            <a:off x="2534264" y="52433"/>
-            <a:ext cx="3284810" cy="523220"/>
+            <a:off x="0" y="0"/>
+            <a:ext cx="12192000" cy="585216"/>
           </a:xfrm>
           <a:prstGeom prst="rect">
             <a:avLst/>
@@ -16471,14 +16366,14 @@
           </a:solidFill>
         </p:spPr>
         <p:txBody>
-          <a:bodyPr wrap="none">
+          <a:bodyPr wrap="square">
             <a:spAutoFit/>
           </a:bodyPr>
           <a:lstStyle/>
           <a:p>
             <a:pPr algn="ctr"/>
             <a:r>
-              <a:rPr lang="en-US" sz="2800" b="1" dirty="0">
+              <a:rPr lang="en-US" sz="3200" b="1" dirty="0">
                 <a:solidFill>
                   <a:schemeClr val="bg1"/>
                 </a:solidFill>
@@ -16488,7 +16383,7 @@
               </a:rPr>
               <a:t>Architrino Assembly Architecture</a:t>
             </a:r>
-            <a:endParaRPr lang="en-US" sz="2800" b="1" baseline="30000" dirty="0">
+            <a:endParaRPr lang="en-US" sz="3200" b="1" baseline="30000" dirty="0">
               <a:solidFill>
                 <a:schemeClr val="bg1"/>
               </a:solidFill>
@@ -16560,8 +16455,8 @@
         </p:nvCxnSpPr>
         <p:spPr>
           <a:xfrm flipV="1">
-            <a:off x="1249796" y="21500"/>
-            <a:ext cx="0" cy="6836500"/>
+            <a:off x="1249796" y="487017"/>
+            <a:ext cx="0" cy="5810383"/>
           </a:xfrm>
           <a:prstGeom prst="straightConnector1">
             <a:avLst/>
@@ -16570,7 +16465,7 @@
             <a:solidFill>
               <a:schemeClr val="bg1"/>
             </a:solidFill>
-            <a:headEnd type="triangle" w="lg" len="lg"/>
+            <a:headEnd type="none" w="lg" len="lg"/>
             <a:tailEnd type="triangle" w="lg" len="lg"/>
           </a:ln>
         </p:spPr>
@@ -16603,7 +16498,7 @@
         </p:nvSpPr>
         <p:spPr>
           <a:xfrm>
-            <a:off x="2050550" y="6388664"/>
+            <a:off x="4693208" y="6368139"/>
             <a:ext cx="4098238" cy="437428"/>
           </a:xfrm>
           <a:prstGeom prst="rect">
@@ -16668,7 +16563,7 @@
         </p:nvSpPr>
         <p:spPr>
           <a:xfrm>
-            <a:off x="42329" y="685956"/>
+            <a:off x="62494" y="846339"/>
             <a:ext cx="1093569" cy="646331"/>
           </a:xfrm>
           <a:prstGeom prst="rect">
@@ -16729,7 +16624,7 @@
         </p:nvSpPr>
         <p:spPr>
           <a:xfrm>
-            <a:off x="6187636" y="5392688"/>
+            <a:off x="6299738" y="5873111"/>
             <a:ext cx="885179" cy="369332"/>
           </a:xfrm>
           <a:prstGeom prst="rect">
@@ -17781,7 +17676,7 @@
         </p:nvSpPr>
         <p:spPr>
           <a:xfrm>
-            <a:off x="7766488" y="314043"/>
+            <a:off x="7756549" y="900593"/>
             <a:ext cx="4144429" cy="5078313"/>
           </a:xfrm>
           <a:prstGeom prst="rect">
@@ -18406,149 +18301,6 @@
 </file>
 
 <file path=ppt/slides/slide14.xml><?xml version="1.0" encoding="utf-8"?>
-<p:sld xmlns:a="http://schemas.openxmlformats.org/drawingml/2006/main" xmlns:r="http://schemas.openxmlformats.org/officeDocument/2006/relationships" xmlns:p="http://schemas.openxmlformats.org/presentationml/2006/main">
-  <p:cSld>
-    <p:bg>
-      <p:bgPr>
-        <a:solidFill>
-          <a:srgbClr val="7030A0"/>
-        </a:solidFill>
-        <a:effectLst/>
-      </p:bgPr>
-    </p:bg>
-    <p:spTree>
-      <p:nvGrpSpPr>
-        <p:cNvPr id="1" name="">
-          <a:extLst>
-            <a:ext uri="{FF2B5EF4-FFF2-40B4-BE49-F238E27FC236}">
-              <a16:creationId xmlns:a16="http://schemas.microsoft.com/office/drawing/2014/main" id="{804AC981-79ED-95B2-006C-1F07F7D1021C}"/>
-            </a:ext>
-          </a:extLst>
-        </p:cNvPr>
-        <p:cNvGrpSpPr/>
-        <p:nvPr/>
-      </p:nvGrpSpPr>
-      <p:grpSpPr>
-        <a:xfrm>
-          <a:off x="0" y="0"/>
-          <a:ext cx="0" cy="0"/>
-          <a:chOff x="0" y="0"/>
-          <a:chExt cx="0" cy="0"/>
-        </a:xfrm>
-      </p:grpSpPr>
-      <p:sp>
-        <p:nvSpPr>
-          <p:cNvPr id="2" name="TextBox 1">
-            <a:extLst>
-              <a:ext uri="{FF2B5EF4-FFF2-40B4-BE49-F238E27FC236}">
-                <a16:creationId xmlns:a16="http://schemas.microsoft.com/office/drawing/2014/main" id="{25D5C38C-76F4-C791-A566-84A8B395A016}"/>
-              </a:ext>
-            </a:extLst>
-          </p:cNvPr>
-          <p:cNvSpPr txBox="1"/>
-          <p:nvPr/>
-        </p:nvSpPr>
-        <p:spPr>
-          <a:xfrm>
-            <a:off x="0" y="358254"/>
-            <a:ext cx="12191999" cy="2785378"/>
-          </a:xfrm>
-          <a:prstGeom prst="rect">
-            <a:avLst/>
-          </a:prstGeom>
-          <a:noFill/>
-        </p:spPr>
-        <p:txBody>
-          <a:bodyPr wrap="square" rtlCol="0">
-            <a:spAutoFit/>
-          </a:bodyPr>
-          <a:lstStyle/>
-          <a:p>
-            <a:pPr marL="0" marR="0" lvl="0" indent="0" algn="ctr" defTabSz="914400" rtl="0" eaLnBrk="1" fontAlgn="auto" latinLnBrk="0" hangingPunct="1">
-              <a:lnSpc>
-                <a:spcPts val="11000"/>
-              </a:lnSpc>
-              <a:spcBef>
-                <a:spcPts val="0"/>
-              </a:spcBef>
-              <a:spcAft>
-                <a:spcPts val="0"/>
-              </a:spcAft>
-              <a:buClrTx/>
-              <a:buSzTx/>
-              <a:buFontTx/>
-              <a:buNone/>
-              <a:tabLst/>
-              <a:defRPr/>
-            </a:pPr>
-            <a:endParaRPr/>
-          </a:p>
-          <a:p>
-            <a:pPr marL="0" marR="0" lvl="0" indent="0" algn="ctr" defTabSz="914400" rtl="0" eaLnBrk="1" fontAlgn="auto" latinLnBrk="0" hangingPunct="1">
-              <a:lnSpc>
-                <a:spcPts val="10000"/>
-              </a:lnSpc>
-              <a:spcBef>
-                <a:spcPts val="0"/>
-              </a:spcBef>
-              <a:spcAft>
-                <a:spcPts val="0"/>
-              </a:spcAft>
-              <a:buClrTx/>
-              <a:buSzTx/>
-              <a:buFontTx/>
-              <a:buNone/>
-              <a:tabLst/>
-              <a:defRPr/>
-            </a:pPr>
-            <a:r>
-              <a:rPr kumimoji="0" lang="en-US" sz="9600" b="1" i="0" u="none" strike="noStrike" kern="1200" cap="none" spc="0" normalizeH="0" baseline="0" noProof="0" dirty="0">
-                <a:ln>
-                  <a:noFill/>
-                </a:ln>
-                <a:solidFill>
-                  <a:srgbClr val="FFC000"/>
-                </a:solidFill>
-                <a:effectLst/>
-                <a:uLnTx/>
-                <a:uFillTx/>
-                <a:latin typeface="Helvetica Neue Condensed Black" panose="02000503000000020004" pitchFamily="2" charset="0"/>
-                <a:ea typeface="Helvetica Neue Condensed Black" panose="02000503000000020004" pitchFamily="2" charset="0"/>
-                <a:cs typeface="Helvetica Neue Condensed Black" panose="02000503000000020004" pitchFamily="2" charset="0"/>
-              </a:rPr>
-              <a:t>Causal Wakes and Zeno's Paradox</a:t>
-            </a:r>
-            <a:endParaRPr kumimoji="0" lang="en-US" sz="8000" b="1" i="0" u="none" strike="noStrike" kern="1200" cap="none" spc="0" normalizeH="0" baseline="0" noProof="0" dirty="0">
-              <a:ln>
-                <a:noFill/>
-              </a:ln>
-              <a:solidFill>
-                <a:srgbClr val="FF8AD8"/>
-              </a:solidFill>
-              <a:effectLst/>
-              <a:uLnTx/>
-              <a:uFillTx/>
-              <a:latin typeface="Helvetica Neue Condensed Black" panose="02000503000000020004" pitchFamily="2" charset="0"/>
-              <a:ea typeface="Helvetica Neue Condensed Black" panose="02000503000000020004" pitchFamily="2" charset="0"/>
-              <a:cs typeface="Helvetica Neue Condensed Black" panose="02000503000000020004" pitchFamily="2" charset="0"/>
-            </a:endParaRPr>
-          </a:p>
-        </p:txBody>
-      </p:sp>
-    </p:spTree>
-    <p:extLst>
-      <p:ext uri="{BB962C8B-B14F-4D97-AF65-F5344CB8AC3E}">
-        <p14:creationId xmlns:p14="http://schemas.microsoft.com/office/powerpoint/2010/main" val="3464736619"/>
-      </p:ext>
-    </p:extLst>
-  </p:cSld>
-  <p:clrMapOvr>
-    <a:masterClrMapping/>
-  </p:clrMapOvr>
-</p:sld>
-</file>
-
-<file path=ppt/slides/slide15.xml><?xml version="1.0" encoding="utf-8"?>
 <p:sld xmlns:a="http://schemas.openxmlformats.org/drawingml/2006/main" xmlns:r="http://schemas.openxmlformats.org/officeDocument/2006/relationships" xmlns:p="http://schemas.openxmlformats.org/presentationml/2006/main">
   <p:cSld>
     <p:bg>
@@ -18755,8 +18507,8 @@
         </p:nvSpPr>
         <p:spPr>
           <a:xfrm>
-            <a:off x="680197" y="309028"/>
-            <a:ext cx="11009488" cy="523220"/>
+            <a:off x="0" y="0"/>
+            <a:ext cx="12192000" cy="585216"/>
           </a:xfrm>
           <a:prstGeom prst="rect">
             <a:avLst/>
@@ -18764,7 +18516,7 @@
           <a:noFill/>
         </p:spPr>
         <p:txBody>
-          <a:bodyPr wrap="none">
+          <a:bodyPr wrap="square">
             <a:spAutoFit/>
           </a:bodyPr>
           <a:lstStyle/>
@@ -18787,7 +18539,7 @@
               <a:defRPr/>
             </a:pPr>
             <a:r>
-              <a:rPr kumimoji="0" lang="en-US" sz="2800" b="1" i="0" u="none" strike="noStrike" kern="1200" cap="none" spc="0" normalizeH="0" baseline="0" noProof="0" dirty="0">
+              <a:rPr kumimoji="0" lang="en-US" sz="3200" b="1" i="0" u="none" strike="noStrike" kern="1200" cap="none" spc="0" normalizeH="0" baseline="0" noProof="0" dirty="0">
                 <a:ln>
                   <a:noFill/>
                 </a:ln>
@@ -18801,7 +18553,7 @@
                 <a:ea typeface="Helvetica Neue" panose="02000503000000020004" pitchFamily="2" charset="0"/>
                 <a:cs typeface="Helvetica Neue" panose="02000503000000020004" pitchFamily="2" charset="0"/>
               </a:rPr>
-              <a:t>Causal Wakes and the 1/r Curve</a:t>
+              <a:t>Zeno’s Paradox, Causal Wakes, and the 1/r Curve</a:t>
             </a:r>
           </a:p>
         </p:txBody>
@@ -18820,8 +18572,8 @@
         </p:nvSpPr>
         <p:spPr>
           <a:xfrm>
-            <a:off x="337206" y="907318"/>
-            <a:ext cx="11695463" cy="1815882"/>
+            <a:off x="371047" y="1354579"/>
+            <a:ext cx="11695463" cy="4062651"/>
           </a:xfrm>
           <a:prstGeom prst="rect">
             <a:avLst/>
@@ -18852,7 +18604,7 @@
               <a:defRPr/>
             </a:pPr>
             <a:r>
-              <a:rPr kumimoji="0" lang="en-US" sz="1600" b="0" i="0" u="none" strike="noStrike" kern="1200" cap="none" spc="0" normalizeH="0" baseline="0" noProof="0" dirty="0">
+              <a:rPr kumimoji="0" lang="en-US" sz="2000" b="0" i="0" u="none" strike="noStrike" kern="1200" cap="none" spc="0" normalizeH="0" baseline="0" noProof="0" dirty="0">
                 <a:ln>
                   <a:noFill/>
                 </a:ln>
@@ -18866,17 +18618,29 @@
                 <a:ea typeface="Helvetica Neue" panose="02000503000000020004" pitchFamily="2" charset="0"/>
                 <a:cs typeface="Helvetica Neue" panose="02000503000000020004" pitchFamily="2" charset="0"/>
               </a:rPr>
-              <a:t>Nature is modeled as geometry in absolute time and absolute space, populated by equal-and-opposite architrinos.</a:t>
+              <a:t>Zeno’s paradox becomes a causal-root problem</a:t>
             </a:r>
           </a:p>
           <a:p>
-            <a:pPr marL="457200" indent="-457200">
+            <a:pPr marL="457200" marR="0" lvl="0" indent="-457200" algn="l" defTabSz="914400" rtl="0" eaLnBrk="1" fontAlgn="auto" latinLnBrk="0" hangingPunct="1">
+              <a:lnSpc>
+                <a:spcPct val="100000"/>
+              </a:lnSpc>
+              <a:spcBef>
+                <a:spcPts val="0"/>
+              </a:spcBef>
+              <a:spcAft>
+                <a:spcPts val="0"/>
+              </a:spcAft>
+              <a:buClrTx/>
+              <a:buSzTx/>
               <a:buFont typeface="Arial" panose="020B0604020202020204" pitchFamily="34" charset="0"/>
               <a:buChar char="•"/>
+              <a:tabLst/>
               <a:defRPr/>
             </a:pPr>
             <a:r>
-              <a:rPr kumimoji="0" lang="en-US" sz="1600" b="0" i="0" u="none" strike="noStrike" kern="1200" cap="none" spc="0" normalizeH="0" baseline="0" noProof="0" dirty="0">
+              <a:rPr kumimoji="0" lang="en-US" sz="2000" b="0" i="0" u="none" strike="noStrike" kern="1200" cap="none" spc="0" normalizeH="0" baseline="0" noProof="0" dirty="0">
                 <a:ln>
                   <a:noFill/>
                 </a:ln>
@@ -18890,17 +18654,29 @@
                 <a:ea typeface="Helvetica Neue" panose="02000503000000020004" pitchFamily="2" charset="0"/>
                 <a:cs typeface="Helvetica Neue" panose="02000503000000020004" pitchFamily="2" charset="0"/>
               </a:rPr>
-              <a:t>Each architrino is a polarity-bearing emitter/receiver; its continuous path emits causal wake surfaces.</a:t>
+              <a:t>Zeno’s paradox asks how motion can ever complete if every trip can be divided into endlessly smaller remaining distances.</a:t>
             </a:r>
           </a:p>
           <a:p>
-            <a:pPr marL="914400" lvl="1" indent="-457200">
+            <a:pPr marL="457200" marR="0" lvl="0" indent="-457200" algn="l" defTabSz="914400" rtl="0" eaLnBrk="1" fontAlgn="auto" latinLnBrk="0" hangingPunct="1">
+              <a:lnSpc>
+                <a:spcPct val="100000"/>
+              </a:lnSpc>
+              <a:spcBef>
+                <a:spcPts val="0"/>
+              </a:spcBef>
+              <a:spcAft>
+                <a:spcPts val="0"/>
+              </a:spcAft>
+              <a:buClrTx/>
+              <a:buSzTx/>
               <a:buFont typeface="Arial" panose="020B0604020202020204" pitchFamily="34" charset="0"/>
               <a:buChar char="•"/>
+              <a:tabLst/>
               <a:defRPr/>
             </a:pPr>
             <a:r>
-              <a:rPr kumimoji="0" lang="en-US" sz="1600" b="0" i="0" u="none" strike="noStrike" kern="1200" cap="none" spc="0" normalizeH="0" baseline="0" noProof="0" dirty="0">
+              <a:rPr kumimoji="0" lang="en-US" sz="2000" b="0" i="0" u="none" strike="noStrike" kern="1200" cap="none" spc="0" normalizeH="0" baseline="0" noProof="0" dirty="0">
                 <a:ln>
                   <a:noFill/>
                 </a:ln>
@@ -18914,17 +18690,29 @@
                 <a:ea typeface="Helvetica Neue" panose="02000503000000020004" pitchFamily="2" charset="0"/>
                 <a:cs typeface="Helvetica Neue" panose="02000503000000020004" pitchFamily="2" charset="0"/>
               </a:rPr>
-              <a:t>A received hit occurs when a receiver intersects a causal wake surface; superposition determines the net response.</a:t>
+              <a:t>In AAA, a similar confusion appears near a 1/r curve. If r approaches 0, the curve seems to demand an infinite response.</a:t>
             </a:r>
           </a:p>
           <a:p>
-            <a:pPr marL="914400" lvl="1" indent="-457200">
+            <a:pPr marL="457200" marR="0" lvl="0" indent="-457200" algn="l" defTabSz="914400" rtl="0" eaLnBrk="1" fontAlgn="auto" latinLnBrk="0" hangingPunct="1">
+              <a:lnSpc>
+                <a:spcPct val="100000"/>
+              </a:lnSpc>
+              <a:spcBef>
+                <a:spcPts val="0"/>
+              </a:spcBef>
+              <a:spcAft>
+                <a:spcPts val="0"/>
+              </a:spcAft>
+              <a:buClrTx/>
+              <a:buSzTx/>
               <a:buFont typeface="Arial" panose="020B0604020202020204" pitchFamily="34" charset="0"/>
               <a:buChar char="•"/>
+              <a:tabLst/>
               <a:defRPr/>
             </a:pPr>
             <a:r>
-              <a:rPr kumimoji="0" lang="en-US" sz="1600" b="0" i="0" u="none" strike="noStrike" kern="1200" cap="none" spc="0" normalizeH="0" baseline="0" noProof="0" dirty="0">
+              <a:rPr kumimoji="0" lang="en-US" sz="2000" b="0" i="0" u="none" strike="noStrike" kern="1200" cap="none" spc="0" normalizeH="0" baseline="0" noProof="0" dirty="0">
                 <a:ln>
                   <a:noFill/>
                 </a:ln>
@@ -18938,10 +18726,46 @@
                 <a:ea typeface="Helvetica Neue" panose="02000503000000020004" pitchFamily="2" charset="0"/>
                 <a:cs typeface="Helvetica Neue" panose="02000503000000020004" pitchFamily="2" charset="0"/>
               </a:rPr>
-              <a:t>Because an architrino can move faster than wake speed, v = c</a:t>
+              <a:t>That static curve is not the primitive geometry.</a:t>
+            </a:r>
+          </a:p>
+          <a:p>
+            <a:pPr marL="457200" marR="0" lvl="0" indent="-457200" algn="l" defTabSz="914400" rtl="0" eaLnBrk="1" fontAlgn="auto" latinLnBrk="0" hangingPunct="1">
+              <a:lnSpc>
+                <a:spcPct val="100000"/>
+              </a:lnSpc>
+              <a:spcBef>
+                <a:spcPts val="0"/>
+              </a:spcBef>
+              <a:spcAft>
+                <a:spcPts val="0"/>
+              </a:spcAft>
+              <a:buClrTx/>
+              <a:buSzTx/>
+              <a:buFont typeface="Arial" panose="020B0604020202020204" pitchFamily="34" charset="0"/>
+              <a:buChar char="•"/>
+              <a:tabLst/>
+              <a:defRPr/>
+            </a:pPr>
+            <a:r>
+              <a:rPr kumimoji="0" lang="en-US" sz="2000" b="0" i="0" u="none" strike="noStrike" kern="1200" cap="none" spc="0" normalizeH="0" baseline="0" noProof="0" dirty="0">
+                <a:ln>
+                  <a:noFill/>
+                </a:ln>
+                <a:solidFill>
+                  <a:prstClr val="white"/>
+                </a:solidFill>
+                <a:effectLst/>
+                <a:uLnTx/>
+                <a:uFillTx/>
+                <a:latin typeface="Helvetica Neue" panose="02000503000000020004" pitchFamily="2" charset="0"/>
+                <a:ea typeface="Helvetica Neue" panose="02000503000000020004" pitchFamily="2" charset="0"/>
+                <a:cs typeface="Helvetica Neue" panose="02000503000000020004" pitchFamily="2" charset="0"/>
+              </a:rPr>
+              <a:t>An architrino follows a continuous path in absolute time and absolute space. Its causal wakes come from earlier path history and expand at finite wake speed c</a:t>
             </a:r>
             <a:r>
-              <a:rPr kumimoji="0" lang="en-US" sz="1120" b="0" i="0" u="none" strike="noStrike" kern="1200" cap="none" spc="0" normalizeH="0" baseline="-25000" noProof="0" dirty="0">
+              <a:rPr kumimoji="0" lang="en-US" sz="2000" b="0" i="0" u="none" strike="noStrike" kern="1200" cap="none" spc="0" normalizeH="0" baseline="-25000" noProof="0" dirty="0">
                 <a:ln>
                   <a:noFill/>
                 </a:ln>
@@ -18958,7 +18782,7 @@
               <a:t>f</a:t>
             </a:r>
             <a:r>
-              <a:rPr kumimoji="0" lang="en-US" sz="1600" b="0" i="0" u="none" strike="noStrike" kern="1200" cap="none" spc="0" normalizeH="0" baseline="0" noProof="0" dirty="0">
+              <a:rPr kumimoji="0" lang="en-US" sz="2000" b="0" i="0" u="none" strike="noStrike" kern="1200" cap="none" spc="0" normalizeH="0" baseline="0" noProof="0" dirty="0">
                 <a:ln>
                   <a:noFill/>
                 </a:ln>
@@ -18972,17 +18796,29 @@
                 <a:ea typeface="Helvetica Neue" panose="02000503000000020004" pitchFamily="2" charset="0"/>
                 <a:cs typeface="Helvetica Neue" panose="02000503000000020004" pitchFamily="2" charset="0"/>
               </a:rPr>
-              <a:t> marks a self-hit onset boundary rather than an observer-level speed limit.</a:t>
+              <a:t>.</a:t>
             </a:r>
           </a:p>
           <a:p>
-            <a:pPr marL="914400" lvl="1" indent="-457200">
+            <a:pPr marL="457200" marR="0" lvl="0" indent="-457200" algn="l" defTabSz="914400" rtl="0" eaLnBrk="1" fontAlgn="auto" latinLnBrk="0" hangingPunct="1">
+              <a:lnSpc>
+                <a:spcPct val="100000"/>
+              </a:lnSpc>
+              <a:spcBef>
+                <a:spcPts val="0"/>
+              </a:spcBef>
+              <a:spcAft>
+                <a:spcPts val="0"/>
+              </a:spcAft>
+              <a:buClrTx/>
+              <a:buSzTx/>
               <a:buFont typeface="Arial" panose="020B0604020202020204" pitchFamily="34" charset="0"/>
               <a:buChar char="•"/>
+              <a:tabLst/>
               <a:defRPr/>
             </a:pPr>
             <a:r>
-              <a:rPr kumimoji="0" lang="en-US" sz="1600" b="0" i="0" u="none" strike="noStrike" kern="1200" cap="none" spc="0" normalizeH="0" baseline="0" noProof="0" dirty="0">
+              <a:rPr kumimoji="0" lang="en-US" sz="2000" b="0" i="0" u="none" strike="noStrike" kern="1200" cap="none" spc="0" normalizeH="0" baseline="0" noProof="0" dirty="0">
                 <a:ln>
                   <a:noFill/>
                 </a:ln>
@@ -18996,179 +18832,11 @@
                 <a:ea typeface="Helvetica Neue" panose="02000503000000020004" pitchFamily="2" charset="0"/>
                 <a:cs typeface="Helvetica Neue" panose="02000503000000020004" pitchFamily="2" charset="0"/>
               </a:rPr>
-              <a:t>Ideal binaries must be tested through causal-root ledgers, path-history feedback, and branch stability, not through an instantaneous 1/r curve alone.</a:t>
+              <a:t>A received hit occurs only when a causal wake surface intersects a receiver.</a:t>
             </a:r>
           </a:p>
-        </p:txBody>
-      </p:sp>
-    </p:spTree>
-    <p:extLst>
-      <p:ext uri="{BB962C8B-B14F-4D97-AF65-F5344CB8AC3E}">
-        <p14:creationId xmlns:p14="http://schemas.microsoft.com/office/powerpoint/2010/main" val="3670680207"/>
-      </p:ext>
-    </p:extLst>
-  </p:cSld>
-  <p:clrMapOvr>
-    <a:masterClrMapping/>
-  </p:clrMapOvr>
-</p:sld>
-</file>
-
-<file path=ppt/slides/slide16.xml><?xml version="1.0" encoding="utf-8"?>
-<p:sld xmlns:a="http://schemas.openxmlformats.org/drawingml/2006/main" xmlns:r="http://schemas.openxmlformats.org/officeDocument/2006/relationships" xmlns:p="http://schemas.openxmlformats.org/presentationml/2006/main">
-  <p:cSld>
-    <p:bg>
-      <p:bgPr>
-        <a:solidFill>
-          <a:srgbClr val="7030A0"/>
-        </a:solidFill>
-        <a:effectLst/>
-      </p:bgPr>
-    </p:bg>
-    <p:spTree>
-      <p:nvGrpSpPr>
-        <p:cNvPr id="1" name="">
-          <a:extLst>
-            <a:ext uri="{FF2B5EF4-FFF2-40B4-BE49-F238E27FC236}">
-              <a16:creationId xmlns:a16="http://schemas.microsoft.com/office/drawing/2014/main" id="{8B3A6F17-EFE6-B51A-A63A-3B70333495A1}"/>
-            </a:ext>
-          </a:extLst>
-        </p:cNvPr>
-        <p:cNvGrpSpPr/>
-        <p:nvPr/>
-      </p:nvGrpSpPr>
-      <p:grpSpPr>
-        <a:xfrm>
-          <a:off x="0" y="0"/>
-          <a:ext cx="0" cy="0"/>
-          <a:chOff x="0" y="0"/>
-          <a:chExt cx="0" cy="0"/>
-        </a:xfrm>
-      </p:grpSpPr>
-      <p:sp>
-        <p:nvSpPr>
-          <p:cNvPr id="5" name="Footer Placeholder 3">
-            <a:extLst>
-              <a:ext uri="{FF2B5EF4-FFF2-40B4-BE49-F238E27FC236}">
-                <a16:creationId xmlns:a16="http://schemas.microsoft.com/office/drawing/2014/main" id="{68EB2D01-BE54-DC86-BCD1-1E32DA2C4000}"/>
-              </a:ext>
-            </a:extLst>
-          </p:cNvPr>
-          <p:cNvSpPr txBox="1">
-            <a:spLocks/>
-          </p:cNvSpPr>
-          <p:nvPr/>
-        </p:nvSpPr>
-        <p:spPr>
-          <a:xfrm>
-            <a:off x="10924248" y="6388602"/>
-            <a:ext cx="1142262" cy="365125"/>
-          </a:xfrm>
-          <a:prstGeom prst="rect">
-            <a:avLst/>
-          </a:prstGeom>
-        </p:spPr>
-        <p:txBody>
-          <a:bodyPr vert="horz" lIns="91440" tIns="45720" rIns="91440" bIns="45720" rtlCol="0" anchor="ctr"/>
-          <a:lstStyle>
-            <a:defPPr>
-              <a:defRPr lang="en-US"/>
-            </a:defPPr>
-            <a:lvl1pPr marL="0" algn="ctr" defTabSz="914400" rtl="0" eaLnBrk="1" latinLnBrk="0" hangingPunct="1">
-              <a:defRPr sz="1200" kern="1200">
-                <a:solidFill>
-                  <a:schemeClr val="tx1">
-                    <a:tint val="75000"/>
-                  </a:schemeClr>
-                </a:solidFill>
-                <a:latin typeface="+mn-lt"/>
-                <a:ea typeface="+mn-ea"/>
-                <a:cs typeface="+mn-cs"/>
-              </a:defRPr>
-            </a:lvl1pPr>
-            <a:lvl2pPr marL="457200" algn="l" defTabSz="914400" rtl="0" eaLnBrk="1" latinLnBrk="0" hangingPunct="1">
-              <a:defRPr sz="1800" kern="1200">
-                <a:solidFill>
-                  <a:schemeClr val="tx1"/>
-                </a:solidFill>
-                <a:latin typeface="+mn-lt"/>
-                <a:ea typeface="+mn-ea"/>
-                <a:cs typeface="+mn-cs"/>
-              </a:defRPr>
-            </a:lvl2pPr>
-            <a:lvl3pPr marL="914400" algn="l" defTabSz="914400" rtl="0" eaLnBrk="1" latinLnBrk="0" hangingPunct="1">
-              <a:defRPr sz="1800" kern="1200">
-                <a:solidFill>
-                  <a:schemeClr val="tx1"/>
-                </a:solidFill>
-                <a:latin typeface="+mn-lt"/>
-                <a:ea typeface="+mn-ea"/>
-                <a:cs typeface="+mn-cs"/>
-              </a:defRPr>
-            </a:lvl3pPr>
-            <a:lvl4pPr marL="1371600" algn="l" defTabSz="914400" rtl="0" eaLnBrk="1" latinLnBrk="0" hangingPunct="1">
-              <a:defRPr sz="1800" kern="1200">
-                <a:solidFill>
-                  <a:schemeClr val="tx1"/>
-                </a:solidFill>
-                <a:latin typeface="+mn-lt"/>
-                <a:ea typeface="+mn-ea"/>
-                <a:cs typeface="+mn-cs"/>
-              </a:defRPr>
-            </a:lvl4pPr>
-            <a:lvl5pPr marL="1828800" algn="l" defTabSz="914400" rtl="0" eaLnBrk="1" latinLnBrk="0" hangingPunct="1">
-              <a:defRPr sz="1800" kern="1200">
-                <a:solidFill>
-                  <a:schemeClr val="tx1"/>
-                </a:solidFill>
-                <a:latin typeface="+mn-lt"/>
-                <a:ea typeface="+mn-ea"/>
-                <a:cs typeface="+mn-cs"/>
-              </a:defRPr>
-            </a:lvl5pPr>
-            <a:lvl6pPr marL="2286000" algn="l" defTabSz="914400" rtl="0" eaLnBrk="1" latinLnBrk="0" hangingPunct="1">
-              <a:defRPr sz="1800" kern="1200">
-                <a:solidFill>
-                  <a:schemeClr val="tx1"/>
-                </a:solidFill>
-                <a:latin typeface="+mn-lt"/>
-                <a:ea typeface="+mn-ea"/>
-                <a:cs typeface="+mn-cs"/>
-              </a:defRPr>
-            </a:lvl6pPr>
-            <a:lvl7pPr marL="2743200" algn="l" defTabSz="914400" rtl="0" eaLnBrk="1" latinLnBrk="0" hangingPunct="1">
-              <a:defRPr sz="1800" kern="1200">
-                <a:solidFill>
-                  <a:schemeClr val="tx1"/>
-                </a:solidFill>
-                <a:latin typeface="+mn-lt"/>
-                <a:ea typeface="+mn-ea"/>
-                <a:cs typeface="+mn-cs"/>
-              </a:defRPr>
-            </a:lvl7pPr>
-            <a:lvl8pPr marL="3200400" algn="l" defTabSz="914400" rtl="0" eaLnBrk="1" latinLnBrk="0" hangingPunct="1">
-              <a:defRPr sz="1800" kern="1200">
-                <a:solidFill>
-                  <a:schemeClr val="tx1"/>
-                </a:solidFill>
-                <a:latin typeface="+mn-lt"/>
-                <a:ea typeface="+mn-ea"/>
-                <a:cs typeface="+mn-cs"/>
-              </a:defRPr>
-            </a:lvl8pPr>
-            <a:lvl9pPr marL="3657600" algn="l" defTabSz="914400" rtl="0" eaLnBrk="1" latinLnBrk="0" hangingPunct="1">
-              <a:defRPr sz="1800" kern="1200">
-                <a:solidFill>
-                  <a:schemeClr val="tx1"/>
-                </a:solidFill>
-                <a:latin typeface="+mn-lt"/>
-                <a:ea typeface="+mn-ea"/>
-                <a:cs typeface="+mn-cs"/>
-              </a:defRPr>
-            </a:lvl9pPr>
-          </a:lstStyle>
-          <a:p>
-            <a:pPr marL="0" marR="0" lvl="0" indent="0" algn="ctr" defTabSz="914400" rtl="0" eaLnBrk="1" fontAlgn="auto" latinLnBrk="0" hangingPunct="1">
+          <a:p>
+            <a:pPr marL="457200" marR="0" lvl="0" indent="-457200" algn="l" defTabSz="914400" rtl="0" eaLnBrk="1" fontAlgn="auto" latinLnBrk="0" hangingPunct="1">
               <a:lnSpc>
                 <a:spcPct val="100000"/>
               </a:lnSpc>
@@ -19180,80 +18848,13 @@
               </a:spcAft>
               <a:buClrTx/>
               <a:buSzTx/>
-              <a:buFontTx/>
-              <a:buNone/>
+              <a:buFont typeface="Arial" panose="020B0604020202020204" pitchFamily="34" charset="0"/>
+              <a:buChar char="•"/>
               <a:tabLst/>
               <a:defRPr/>
             </a:pPr>
             <a:r>
-              <a:rPr kumimoji="0" lang="en-US" sz="1200" b="0" i="0" u="none" strike="noStrike" kern="1200" cap="none" spc="0" normalizeH="0" baseline="0" noProof="0" dirty="0">
-                <a:ln>
-                  <a:noFill/>
-                </a:ln>
-                <a:solidFill>
-                  <a:prstClr val="black">
-                    <a:tint val="75000"/>
-                  </a:prstClr>
-                </a:solidFill>
-                <a:effectLst/>
-                <a:uLnTx/>
-                <a:uFillTx/>
-                <a:latin typeface="Helvetica Neue" panose="02000503000000020004" pitchFamily="2" charset="0"/>
-                <a:ea typeface="Helvetica Neue" panose="02000503000000020004" pitchFamily="2" charset="0"/>
-                <a:cs typeface="Helvetica Neue" panose="02000503000000020004" pitchFamily="2" charset="0"/>
-              </a:rPr>
-              <a:t>J Mark Morris</a:t>
-            </a:r>
-          </a:p>
-        </p:txBody>
-      </p:sp>
-      <p:sp>
-        <p:nvSpPr>
-          <p:cNvPr id="19" name="Rectangle 18">
-            <a:extLst>
-              <a:ext uri="{FF2B5EF4-FFF2-40B4-BE49-F238E27FC236}">
-                <a16:creationId xmlns:a16="http://schemas.microsoft.com/office/drawing/2014/main" id="{F2D335EE-90BE-310F-3F30-68D612074B92}"/>
-              </a:ext>
-            </a:extLst>
-          </p:cNvPr>
-          <p:cNvSpPr/>
-          <p:nvPr/>
-        </p:nvSpPr>
-        <p:spPr>
-          <a:xfrm>
-            <a:off x="680197" y="309028"/>
-            <a:ext cx="11009488" cy="523220"/>
-          </a:xfrm>
-          <a:prstGeom prst="rect">
-            <a:avLst/>
-          </a:prstGeom>
-          <a:noFill/>
-        </p:spPr>
-        <p:txBody>
-          <a:bodyPr wrap="none">
-            <a:spAutoFit/>
-          </a:bodyPr>
-          <a:lstStyle/>
-          <a:p>
-            <a:pPr marL="0" marR="0" lvl="0" indent="0" algn="ctr" defTabSz="914400" rtl="0" eaLnBrk="1" fontAlgn="auto" latinLnBrk="0" hangingPunct="1">
-              <a:lnSpc>
-                <a:spcPct val="100000"/>
-              </a:lnSpc>
-              <a:spcBef>
-                <a:spcPts val="0"/>
-              </a:spcBef>
-              <a:spcAft>
-                <a:spcPts val="0"/>
-              </a:spcAft>
-              <a:buClrTx/>
-              <a:buSzTx/>
-              <a:buFontTx/>
-              <a:buNone/>
-              <a:tabLst/>
-              <a:defRPr/>
-            </a:pPr>
-            <a:r>
-              <a:rPr kumimoji="0" lang="en-US" sz="2800" b="1" i="0" u="none" strike="noStrike" kern="1200" cap="none" spc="0" normalizeH="0" baseline="0" noProof="0" dirty="0">
+              <a:rPr kumimoji="0" lang="en-US" sz="2000" b="0" i="0" u="none" strike="noStrike" kern="1200" cap="none" spc="0" normalizeH="0" baseline="0" noProof="0" dirty="0">
                 <a:ln>
                   <a:noFill/>
                 </a:ln>
@@ -19267,554 +18868,30 @@
                 <a:ea typeface="Helvetica Neue" panose="02000503000000020004" pitchFamily="2" charset="0"/>
                 <a:cs typeface="Helvetica Neue" panose="02000503000000020004" pitchFamily="2" charset="0"/>
               </a:rPr>
-              <a:t>Causal Wakes and the 1/r Curve</a:t>
+              <a:t>So the real question near r = 0 is not what the curve does at zero. It is which causal roots exist, what hit sequence is received, and whether the feedback settles into a branch, diverges, or becomes invalid.</a:t>
             </a:r>
           </a:p>
-        </p:txBody>
-      </p:sp>
-      <p:sp>
-        <p:nvSpPr>
-          <p:cNvPr id="2" name="TextBox 1">
-            <a:extLst>
-              <a:ext uri="{FF2B5EF4-FFF2-40B4-BE49-F238E27FC236}">
-                <a16:creationId xmlns:a16="http://schemas.microsoft.com/office/drawing/2014/main" id="{CBF92790-EC27-682A-21D0-5C88069D4333}"/>
-              </a:ext>
-            </a:extLst>
-          </p:cNvPr>
-          <p:cNvSpPr txBox="1"/>
-          <p:nvPr/>
-        </p:nvSpPr>
-        <p:spPr>
-          <a:xfrm>
-            <a:off x="337206" y="907318"/>
-            <a:ext cx="11695463" cy="5109091"/>
-          </a:xfrm>
-          <a:prstGeom prst="rect">
-            <a:avLst/>
-          </a:prstGeom>
-          <a:noFill/>
-        </p:spPr>
-        <p:txBody>
-          <a:bodyPr wrap="square" rtlCol="0">
-            <a:spAutoFit/>
-          </a:bodyPr>
-          <a:lstStyle/>
-          <a:p>
-            <a:pPr marL="457200" marR="0" lvl="0" indent="-457200" algn="l" defTabSz="914400" rtl="0" eaLnBrk="1" fontAlgn="auto" latinLnBrk="0" hangingPunct="1">
-              <a:lnSpc>
-                <a:spcPct val="100000"/>
-              </a:lnSpc>
-              <a:spcBef>
-                <a:spcPts val="0"/>
-              </a:spcBef>
-              <a:spcAft>
-                <a:spcPts val="0"/>
-              </a:spcAft>
-              <a:buClrTx/>
-              <a:buSzTx/>
+          <a:p>
+            <a:pPr marL="914400" lvl="1" indent="-457200">
               <a:buFont typeface="Arial" panose="020B0604020202020204" pitchFamily="34" charset="0"/>
               <a:buChar char="•"/>
-              <a:tabLst/>
               <a:defRPr/>
             </a:pPr>
-            <a:r>
-              <a:rPr kumimoji="0" lang="en-US" sz="1600" b="0" i="0" u="none" strike="noStrike" kern="1200" cap="none" spc="0" normalizeH="0" baseline="0" noProof="0" dirty="0">
-                <a:ln>
-                  <a:noFill/>
-                </a:ln>
-                <a:solidFill>
-                  <a:prstClr val="white"/>
-                </a:solidFill>
-                <a:effectLst/>
-                <a:uLnTx/>
-                <a:uFillTx/>
-                <a:latin typeface="Helvetica Neue" panose="02000503000000020004" pitchFamily="2" charset="0"/>
-                <a:ea typeface="Helvetica Neue" panose="02000503000000020004" pitchFamily="2" charset="0"/>
-                <a:cs typeface="Helvetica Neue" panose="02000503000000020004" pitchFamily="2" charset="0"/>
-              </a:rPr>
-              <a:t>The 1/r curve is an effective trace of wake geometry, not a constraint that every architrino pair must remain on one static curve.</a:t>
-            </a:r>
-          </a:p>
-          <a:p>
-            <a:pPr marL="457200" marR="0" lvl="0" indent="-457200" algn="l" defTabSz="914400" rtl="0" eaLnBrk="1" fontAlgn="auto" latinLnBrk="0" hangingPunct="1">
-              <a:lnSpc>
-                <a:spcPct val="100000"/>
-              </a:lnSpc>
-              <a:spcBef>
-                <a:spcPts val="0"/>
-              </a:spcBef>
-              <a:spcAft>
-                <a:spcPts val="0"/>
-              </a:spcAft>
-              <a:buClrTx/>
-              <a:buSzTx/>
-              <a:buFont typeface="Arial" panose="020B0604020202020204" pitchFamily="34" charset="0"/>
-              <a:buChar char="•"/>
-              <a:tabLst/>
-              <a:defRPr/>
-            </a:pPr>
-            <a:r>
-              <a:rPr kumimoji="0" lang="en-US" sz="1600" b="0" i="0" u="none" strike="noStrike" kern="1200" cap="none" spc="0" normalizeH="0" baseline="0" noProof="0" dirty="0">
-                <a:ln>
-                  <a:noFill/>
-                </a:ln>
-                <a:solidFill>
-                  <a:prstClr val="white"/>
-                </a:solidFill>
-                <a:effectLst/>
-                <a:uLnTx/>
-                <a:uFillTx/>
-                <a:latin typeface="Helvetica Neue" panose="02000503000000020004" pitchFamily="2" charset="0"/>
-                <a:ea typeface="Helvetica Neue" panose="02000503000000020004" pitchFamily="2" charset="0"/>
-                <a:cs typeface="Helvetica Neue" panose="02000503000000020004" pitchFamily="2" charset="0"/>
-              </a:rPr>
-              <a:t>A receiver can pass through many wake surfaces while its path is determined by the superposed causal-root ledger.</a:t>
-            </a:r>
-          </a:p>
-          <a:p>
-            <a:pPr marL="457200" marR="0" lvl="0" indent="-457200" algn="l" defTabSz="914400" rtl="0" eaLnBrk="1" fontAlgn="auto" latinLnBrk="0" hangingPunct="1">
-              <a:lnSpc>
-                <a:spcPct val="100000"/>
-              </a:lnSpc>
-              <a:spcBef>
-                <a:spcPts val="0"/>
-              </a:spcBef>
-              <a:spcAft>
-                <a:spcPts val="0"/>
-              </a:spcAft>
-              <a:buClrTx/>
-              <a:buSzTx/>
-              <a:buFont typeface="Arial" panose="020B0604020202020204" pitchFamily="34" charset="0"/>
-              <a:buChar char="•"/>
-              <a:tabLst/>
-              <a:defRPr/>
-            </a:pPr>
-            <a:r>
-              <a:rPr kumimoji="0" lang="en-US" sz="1600" b="0" i="0" u="none" strike="noStrike" kern="1200" cap="none" spc="0" normalizeH="0" baseline="0" noProof="0" dirty="0">
-                <a:ln>
-                  <a:noFill/>
-                </a:ln>
-                <a:solidFill>
-                  <a:prstClr val="white"/>
-                </a:solidFill>
-                <a:effectLst/>
-                <a:uLnTx/>
-                <a:uFillTx/>
-                <a:latin typeface="Helvetica Neue" panose="02000503000000020004" pitchFamily="2" charset="0"/>
-                <a:ea typeface="Helvetica Neue" panose="02000503000000020004" pitchFamily="2" charset="0"/>
-                <a:cs typeface="Helvetica Neue" panose="02000503000000020004" pitchFamily="2" charset="0"/>
-              </a:rPr>
-              <a:t>In the super-field-speed regime, same-source roots can appear: an architrino may intercept its own earlier wake.</a:t>
-            </a:r>
-          </a:p>
-          <a:p>
-            <a:pPr marL="457200" marR="0" lvl="0" indent="-457200" algn="l" defTabSz="914400" rtl="0" eaLnBrk="1" fontAlgn="auto" latinLnBrk="0" hangingPunct="1">
-              <a:lnSpc>
-                <a:spcPct val="100000"/>
-              </a:lnSpc>
-              <a:spcBef>
-                <a:spcPts val="0"/>
-              </a:spcBef>
-              <a:spcAft>
-                <a:spcPts val="0"/>
-              </a:spcAft>
-              <a:buClrTx/>
-              <a:buSzTx/>
-              <a:buFont typeface="Arial" panose="020B0604020202020204" pitchFamily="34" charset="0"/>
-              <a:buChar char="•"/>
-              <a:tabLst/>
-              <a:defRPr/>
-            </a:pPr>
-            <a:r>
-              <a:rPr kumimoji="0" lang="en-US" sz="1600" b="0" i="0" u="none" strike="noStrike" kern="1200" cap="none" spc="0" normalizeH="0" baseline="0" noProof="0" dirty="0">
-                <a:ln>
-                  <a:noFill/>
-                </a:ln>
-                <a:solidFill>
-                  <a:prstClr val="white"/>
-                </a:solidFill>
-                <a:effectLst/>
-                <a:uLnTx/>
-                <a:uFillTx/>
-                <a:latin typeface="Helvetica Neue" panose="02000503000000020004" pitchFamily="2" charset="0"/>
-                <a:ea typeface="Helvetica Neue" panose="02000503000000020004" pitchFamily="2" charset="0"/>
-                <a:cs typeface="Helvetica Neue" panose="02000503000000020004" pitchFamily="2" charset="0"/>
-              </a:rPr>
-              <a:t>The open calculation is to integrate that self-hit feedback and determine whether it approaches a finite branch, a divergence, or a rejected chart.</a:t>
-            </a:r>
+            <a:endParaRPr lang="en-US" sz="2000" dirty="0">
+              <a:solidFill>
+                <a:prstClr val="white"/>
+              </a:solidFill>
+              <a:latin typeface="Helvetica Neue" panose="02000503000000020004" pitchFamily="2" charset="0"/>
+              <a:ea typeface="Helvetica Neue" panose="02000503000000020004" pitchFamily="2" charset="0"/>
+              <a:cs typeface="Helvetica Neue" panose="02000503000000020004" pitchFamily="2" charset="0"/>
+            </a:endParaRPr>
           </a:p>
         </p:txBody>
       </p:sp>
     </p:spTree>
     <p:extLst>
       <p:ext uri="{BB962C8B-B14F-4D97-AF65-F5344CB8AC3E}">
-        <p14:creationId xmlns:p14="http://schemas.microsoft.com/office/powerpoint/2010/main" val="653966555"/>
-      </p:ext>
-    </p:extLst>
-  </p:cSld>
-  <p:clrMapOvr>
-    <a:masterClrMapping/>
-  </p:clrMapOvr>
-</p:sld>
-</file>
-
-<file path=ppt/slides/slide17.xml><?xml version="1.0" encoding="utf-8"?>
-<p:sld xmlns:a="http://schemas.openxmlformats.org/drawingml/2006/main" xmlns:r="http://schemas.openxmlformats.org/officeDocument/2006/relationships" xmlns:p="http://schemas.openxmlformats.org/presentationml/2006/main">
-  <p:cSld>
-    <p:bg>
-      <p:bgPr>
-        <a:solidFill>
-          <a:srgbClr val="7030A0"/>
-        </a:solidFill>
-        <a:effectLst/>
-      </p:bgPr>
-    </p:bg>
-    <p:spTree>
-      <p:nvGrpSpPr>
-        <p:cNvPr id="1" name="">
-          <a:extLst>
-            <a:ext uri="{FF2B5EF4-FFF2-40B4-BE49-F238E27FC236}">
-              <a16:creationId xmlns:a16="http://schemas.microsoft.com/office/drawing/2014/main" id="{764AD85F-4248-DE78-FCB4-518C065121A3}"/>
-            </a:ext>
-          </a:extLst>
-        </p:cNvPr>
-        <p:cNvGrpSpPr/>
-        <p:nvPr/>
-      </p:nvGrpSpPr>
-      <p:grpSpPr>
-        <a:xfrm>
-          <a:off x="0" y="0"/>
-          <a:ext cx="0" cy="0"/>
-          <a:chOff x="0" y="0"/>
-          <a:chExt cx="0" cy="0"/>
-        </a:xfrm>
-      </p:grpSpPr>
-      <p:sp>
-        <p:nvSpPr>
-          <p:cNvPr id="5" name="Footer Placeholder 3">
-            <a:extLst>
-              <a:ext uri="{FF2B5EF4-FFF2-40B4-BE49-F238E27FC236}">
-                <a16:creationId xmlns:a16="http://schemas.microsoft.com/office/drawing/2014/main" id="{0464A0FC-8CE3-207B-0E49-C582E93BE77D}"/>
-              </a:ext>
-            </a:extLst>
-          </p:cNvPr>
-          <p:cNvSpPr txBox="1">
-            <a:spLocks/>
-          </p:cNvSpPr>
-          <p:nvPr/>
-        </p:nvSpPr>
-        <p:spPr>
-          <a:xfrm>
-            <a:off x="10924248" y="6388602"/>
-            <a:ext cx="1142262" cy="365125"/>
-          </a:xfrm>
-          <a:prstGeom prst="rect">
-            <a:avLst/>
-          </a:prstGeom>
-        </p:spPr>
-        <p:txBody>
-          <a:bodyPr vert="horz" lIns="91440" tIns="45720" rIns="91440" bIns="45720" rtlCol="0" anchor="ctr"/>
-          <a:lstStyle>
-            <a:defPPr>
-              <a:defRPr lang="en-US"/>
-            </a:defPPr>
-            <a:lvl1pPr marL="0" algn="ctr" defTabSz="914400" rtl="0" eaLnBrk="1" latinLnBrk="0" hangingPunct="1">
-              <a:defRPr sz="1200" kern="1200">
-                <a:solidFill>
-                  <a:schemeClr val="tx1">
-                    <a:tint val="75000"/>
-                  </a:schemeClr>
-                </a:solidFill>
-                <a:latin typeface="+mn-lt"/>
-                <a:ea typeface="+mn-ea"/>
-                <a:cs typeface="+mn-cs"/>
-              </a:defRPr>
-            </a:lvl1pPr>
-            <a:lvl2pPr marL="457200" algn="l" defTabSz="914400" rtl="0" eaLnBrk="1" latinLnBrk="0" hangingPunct="1">
-              <a:defRPr sz="1800" kern="1200">
-                <a:solidFill>
-                  <a:schemeClr val="tx1"/>
-                </a:solidFill>
-                <a:latin typeface="+mn-lt"/>
-                <a:ea typeface="+mn-ea"/>
-                <a:cs typeface="+mn-cs"/>
-              </a:defRPr>
-            </a:lvl2pPr>
-            <a:lvl3pPr marL="914400" algn="l" defTabSz="914400" rtl="0" eaLnBrk="1" latinLnBrk="0" hangingPunct="1">
-              <a:defRPr sz="1800" kern="1200">
-                <a:solidFill>
-                  <a:schemeClr val="tx1"/>
-                </a:solidFill>
-                <a:latin typeface="+mn-lt"/>
-                <a:ea typeface="+mn-ea"/>
-                <a:cs typeface="+mn-cs"/>
-              </a:defRPr>
-            </a:lvl3pPr>
-            <a:lvl4pPr marL="1371600" algn="l" defTabSz="914400" rtl="0" eaLnBrk="1" latinLnBrk="0" hangingPunct="1">
-              <a:defRPr sz="1800" kern="1200">
-                <a:solidFill>
-                  <a:schemeClr val="tx1"/>
-                </a:solidFill>
-                <a:latin typeface="+mn-lt"/>
-                <a:ea typeface="+mn-ea"/>
-                <a:cs typeface="+mn-cs"/>
-              </a:defRPr>
-            </a:lvl4pPr>
-            <a:lvl5pPr marL="1828800" algn="l" defTabSz="914400" rtl="0" eaLnBrk="1" latinLnBrk="0" hangingPunct="1">
-              <a:defRPr sz="1800" kern="1200">
-                <a:solidFill>
-                  <a:schemeClr val="tx1"/>
-                </a:solidFill>
-                <a:latin typeface="+mn-lt"/>
-                <a:ea typeface="+mn-ea"/>
-                <a:cs typeface="+mn-cs"/>
-              </a:defRPr>
-            </a:lvl5pPr>
-            <a:lvl6pPr marL="2286000" algn="l" defTabSz="914400" rtl="0" eaLnBrk="1" latinLnBrk="0" hangingPunct="1">
-              <a:defRPr sz="1800" kern="1200">
-                <a:solidFill>
-                  <a:schemeClr val="tx1"/>
-                </a:solidFill>
-                <a:latin typeface="+mn-lt"/>
-                <a:ea typeface="+mn-ea"/>
-                <a:cs typeface="+mn-cs"/>
-              </a:defRPr>
-            </a:lvl6pPr>
-            <a:lvl7pPr marL="2743200" algn="l" defTabSz="914400" rtl="0" eaLnBrk="1" latinLnBrk="0" hangingPunct="1">
-              <a:defRPr sz="1800" kern="1200">
-                <a:solidFill>
-                  <a:schemeClr val="tx1"/>
-                </a:solidFill>
-                <a:latin typeface="+mn-lt"/>
-                <a:ea typeface="+mn-ea"/>
-                <a:cs typeface="+mn-cs"/>
-              </a:defRPr>
-            </a:lvl7pPr>
-            <a:lvl8pPr marL="3200400" algn="l" defTabSz="914400" rtl="0" eaLnBrk="1" latinLnBrk="0" hangingPunct="1">
-              <a:defRPr sz="1800" kern="1200">
-                <a:solidFill>
-                  <a:schemeClr val="tx1"/>
-                </a:solidFill>
-                <a:latin typeface="+mn-lt"/>
-                <a:ea typeface="+mn-ea"/>
-                <a:cs typeface="+mn-cs"/>
-              </a:defRPr>
-            </a:lvl8pPr>
-            <a:lvl9pPr marL="3657600" algn="l" defTabSz="914400" rtl="0" eaLnBrk="1" latinLnBrk="0" hangingPunct="1">
-              <a:defRPr sz="1800" kern="1200">
-                <a:solidFill>
-                  <a:schemeClr val="tx1"/>
-                </a:solidFill>
-                <a:latin typeface="+mn-lt"/>
-                <a:ea typeface="+mn-ea"/>
-                <a:cs typeface="+mn-cs"/>
-              </a:defRPr>
-            </a:lvl9pPr>
-          </a:lstStyle>
-          <a:p>
-            <a:pPr marL="0" marR="0" lvl="0" indent="0" algn="ctr" defTabSz="914400" rtl="0" eaLnBrk="1" fontAlgn="auto" latinLnBrk="0" hangingPunct="1">
-              <a:lnSpc>
-                <a:spcPct val="100000"/>
-              </a:lnSpc>
-              <a:spcBef>
-                <a:spcPts val="0"/>
-              </a:spcBef>
-              <a:spcAft>
-                <a:spcPts val="0"/>
-              </a:spcAft>
-              <a:buClrTx/>
-              <a:buSzTx/>
-              <a:buFontTx/>
-              <a:buNone/>
-              <a:tabLst/>
-              <a:defRPr/>
-            </a:pPr>
-            <a:r>
-              <a:rPr kumimoji="0" lang="en-US" sz="1200" b="0" i="0" u="none" strike="noStrike" kern="1200" cap="none" spc="0" normalizeH="0" baseline="0" noProof="0" dirty="0">
-                <a:ln>
-                  <a:noFill/>
-                </a:ln>
-                <a:solidFill>
-                  <a:prstClr val="black">
-                    <a:tint val="75000"/>
-                  </a:prstClr>
-                </a:solidFill>
-                <a:effectLst/>
-                <a:uLnTx/>
-                <a:uFillTx/>
-                <a:latin typeface="Helvetica Neue" panose="02000503000000020004" pitchFamily="2" charset="0"/>
-                <a:ea typeface="Helvetica Neue" panose="02000503000000020004" pitchFamily="2" charset="0"/>
-                <a:cs typeface="Helvetica Neue" panose="02000503000000020004" pitchFamily="2" charset="0"/>
-              </a:rPr>
-              <a:t>J Mark Morris</a:t>
-            </a:r>
-          </a:p>
-        </p:txBody>
-      </p:sp>
-      <p:sp>
-        <p:nvSpPr>
-          <p:cNvPr id="19" name="Rectangle 18">
-            <a:extLst>
-              <a:ext uri="{FF2B5EF4-FFF2-40B4-BE49-F238E27FC236}">
-                <a16:creationId xmlns:a16="http://schemas.microsoft.com/office/drawing/2014/main" id="{59C47AE8-E40E-D333-CCEE-591287A99ACE}"/>
-              </a:ext>
-            </a:extLst>
-          </p:cNvPr>
-          <p:cNvSpPr/>
-          <p:nvPr/>
-        </p:nvSpPr>
-        <p:spPr>
-          <a:xfrm>
-            <a:off x="680197" y="309028"/>
-            <a:ext cx="11009488" cy="523220"/>
-          </a:xfrm>
-          <a:prstGeom prst="rect">
-            <a:avLst/>
-          </a:prstGeom>
-          <a:noFill/>
-        </p:spPr>
-        <p:txBody>
-          <a:bodyPr wrap="none">
-            <a:spAutoFit/>
-          </a:bodyPr>
-          <a:lstStyle/>
-          <a:p>
-            <a:pPr marL="0" marR="0" lvl="0" indent="0" algn="ctr" defTabSz="914400" rtl="0" eaLnBrk="1" fontAlgn="auto" latinLnBrk="0" hangingPunct="1">
-              <a:lnSpc>
-                <a:spcPct val="100000"/>
-              </a:lnSpc>
-              <a:spcBef>
-                <a:spcPts val="0"/>
-              </a:spcBef>
-              <a:spcAft>
-                <a:spcPts val="0"/>
-              </a:spcAft>
-              <a:buClrTx/>
-              <a:buSzTx/>
-              <a:buFontTx/>
-              <a:buNone/>
-              <a:tabLst/>
-              <a:defRPr/>
-            </a:pPr>
-            <a:r>
-              <a:rPr kumimoji="0" lang="en-US" sz="2800" b="1" i="0" u="none" strike="noStrike" kern="1200" cap="none" spc="0" normalizeH="0" baseline="0" noProof="0" dirty="0">
-                <a:ln>
-                  <a:noFill/>
-                </a:ln>
-                <a:solidFill>
-                  <a:prstClr val="white"/>
-                </a:solidFill>
-                <a:effectLst/>
-                <a:uLnTx/>
-                <a:uFillTx/>
-                <a:latin typeface="Helvetica Neue" panose="02000503000000020004" pitchFamily="2" charset="0"/>
-                <a:ea typeface="Helvetica Neue" panose="02000503000000020004" pitchFamily="2" charset="0"/>
-                <a:cs typeface="Helvetica Neue" panose="02000503000000020004" pitchFamily="2" charset="0"/>
-              </a:rPr>
-              <a:t>Causal Wakes and the 1/r Curve</a:t>
-            </a:r>
-          </a:p>
-        </p:txBody>
-      </p:sp>
-      <p:sp>
-        <p:nvSpPr>
-          <p:cNvPr id="2" name="TextBox 1">
-            <a:extLst>
-              <a:ext uri="{FF2B5EF4-FFF2-40B4-BE49-F238E27FC236}">
-                <a16:creationId xmlns:a16="http://schemas.microsoft.com/office/drawing/2014/main" id="{C4927378-5D67-46E3-234B-AEB36EE62C4E}"/>
-              </a:ext>
-            </a:extLst>
-          </p:cNvPr>
-          <p:cNvSpPr txBox="1"/>
-          <p:nvPr/>
-        </p:nvSpPr>
-        <p:spPr>
-          <a:xfrm>
-            <a:off x="337206" y="907318"/>
-            <a:ext cx="11695463" cy="923330"/>
-          </a:xfrm>
-          <a:prstGeom prst="rect">
-            <a:avLst/>
-          </a:prstGeom>
-          <a:noFill/>
-        </p:spPr>
-        <p:txBody>
-          <a:bodyPr wrap="square" rtlCol="0">
-            <a:spAutoFit/>
-          </a:bodyPr>
-          <a:lstStyle/>
-          <a:p>
-            <a:pPr marL="457200" marR="0" lvl="0" indent="-457200" algn="l" defTabSz="914400" rtl="0" eaLnBrk="1" fontAlgn="auto" latinLnBrk="0" hangingPunct="1">
-              <a:lnSpc>
-                <a:spcPct val="100000"/>
-              </a:lnSpc>
-              <a:spcBef>
-                <a:spcPts val="0"/>
-              </a:spcBef>
-              <a:spcAft>
-                <a:spcPts val="0"/>
-              </a:spcAft>
-              <a:buClrTx/>
-              <a:buSzTx/>
-              <a:buFont typeface="Arial" panose="020B0604020202020204" pitchFamily="34" charset="0"/>
-              <a:buChar char="•"/>
-              <a:tabLst/>
-              <a:defRPr/>
-            </a:pPr>
-            <a:r>
-              <a:rPr kumimoji="0" lang="en-US" sz="1600" b="0" i="0" u="none" strike="noStrike" kern="1200" cap="none" spc="0" normalizeH="0" baseline="0" noProof="0" dirty="0">
-                <a:ln>
-                  <a:noFill/>
-                </a:ln>
-                <a:solidFill>
-                  <a:prstClr val="white"/>
-                </a:solidFill>
-                <a:effectLst/>
-                <a:uLnTx/>
-                <a:uFillTx/>
-                <a:latin typeface="Helvetica Neue" panose="02000503000000020004" pitchFamily="2" charset="0"/>
-                <a:ea typeface="Helvetica Neue" panose="02000503000000020004" pitchFamily="2" charset="0"/>
-                <a:cs typeface="Helvetica Neue" panose="02000503000000020004" pitchFamily="2" charset="0"/>
-              </a:rPr>
-              <a:t>Zeno's paradox becomes a causal-root ledger problem: finite wake speed, continuous paths, and received hits replace infinite subdivision as the controlling geometry.</a:t>
-            </a:r>
-          </a:p>
-        </p:txBody>
-      </p:sp>
-      <p:pic>
-        <p:nvPicPr>
-          <p:cNvPr id="3" name="Picture 2">
-            <a:extLst>
-              <a:ext uri="{FF2B5EF4-FFF2-40B4-BE49-F238E27FC236}">
-                <a16:creationId xmlns:a16="http://schemas.microsoft.com/office/drawing/2014/main" id="{77DA6E5F-7441-6233-DACB-330BCC7593FF}"/>
-              </a:ext>
-            </a:extLst>
-          </p:cNvPr>
-          <p:cNvPicPr>
-            <a:picLocks noChangeAspect="1"/>
-          </p:cNvPicPr>
-          <p:nvPr/>
-        </p:nvPicPr>
-        <p:blipFill>
-          <a:blip r:embed="rId2"/>
-          <a:stretch>
-            <a:fillRect/>
-          </a:stretch>
-        </p:blipFill>
-        <p:spPr>
-          <a:xfrm>
-            <a:off x="3120632" y="1544892"/>
-            <a:ext cx="6572599" cy="5004080"/>
-          </a:xfrm>
-          <a:prstGeom prst="rect">
-            <a:avLst/>
-          </a:prstGeom>
-        </p:spPr>
-      </p:pic>
-    </p:spTree>
-    <p:extLst>
-      <p:ext uri="{BB962C8B-B14F-4D97-AF65-F5344CB8AC3E}">
-        <p14:creationId xmlns:p14="http://schemas.microsoft.com/office/powerpoint/2010/main" val="1428032534"/>
+        <p14:creationId xmlns:p14="http://schemas.microsoft.com/office/powerpoint/2010/main" val="3670680207"/>
       </p:ext>
     </p:extLst>
   </p:cSld>
@@ -21252,8 +20329,8 @@
         </p:nvSpPr>
         <p:spPr>
           <a:xfrm>
-            <a:off x="3509582" y="249416"/>
-            <a:ext cx="5717143" cy="584775"/>
+            <a:off x="0" y="0"/>
+            <a:ext cx="12192000" cy="585216"/>
           </a:xfrm>
           <a:prstGeom prst="rect">
             <a:avLst/>
@@ -21261,12 +20338,12 @@
           <a:noFill/>
         </p:spPr>
         <p:txBody>
-          <a:bodyPr wrap="none" rtlCol="0">
+          <a:bodyPr wrap="square" rtlCol="0">
             <a:spAutoFit/>
           </a:bodyPr>
           <a:lstStyle/>
           <a:p>
-            <a:pPr marL="0" marR="0" lvl="0" indent="0" algn="l" defTabSz="914400" rtl="0" eaLnBrk="1" fontAlgn="auto" latinLnBrk="0" hangingPunct="1">
+            <a:pPr marL="0" marR="0" lvl="0" indent="0" algn="ctr" defTabSz="914400" rtl="0" eaLnBrk="1" fontAlgn="auto" latinLnBrk="0" hangingPunct="1">
               <a:lnSpc>
                 <a:spcPct val="100000"/>
               </a:lnSpc>
@@ -23094,8 +22171,8 @@
         </p:nvSpPr>
         <p:spPr>
           <a:xfrm>
-            <a:off x="1473371" y="187251"/>
-            <a:ext cx="9724009" cy="584775"/>
+            <a:off x="0" y="0"/>
+            <a:ext cx="12192000" cy="585216"/>
           </a:xfrm>
           <a:prstGeom prst="rect">
             <a:avLst/>
@@ -23103,12 +22180,12 @@
           <a:noFill/>
         </p:spPr>
         <p:txBody>
-          <a:bodyPr wrap="none" rtlCol="0">
+          <a:bodyPr wrap="square" rtlCol="0">
             <a:spAutoFit/>
           </a:bodyPr>
           <a:lstStyle/>
           <a:p>
-            <a:pPr marL="0" marR="0" lvl="0" indent="0" algn="l" defTabSz="914400" rtl="0" eaLnBrk="1" fontAlgn="auto" latinLnBrk="0" hangingPunct="1">
+            <a:pPr marL="0" marR="0" lvl="0" indent="0" algn="ctr" defTabSz="914400" rtl="0" eaLnBrk="1" fontAlgn="auto" latinLnBrk="0" hangingPunct="1">
               <a:lnSpc>
                 <a:spcPct val="100000"/>
               </a:lnSpc>
@@ -23143,7 +22220,7 @@
               <a:t>Architrino on Linear Path with Velocity v &lt; c</a:t>
             </a:r>
             <a:r>
-              <a:rPr kumimoji="0" lang="en-US" sz="2240" b="1" i="0" u="none" strike="noStrike" kern="1200" cap="none" spc="0" normalizeH="0" baseline="-25000" noProof="0" dirty="0">
+              <a:rPr kumimoji="0" lang="en-US" sz="3200" b="1" i="0" u="none" strike="noStrike" kern="1200" cap="none" spc="0" normalizeH="0" baseline="-25000" noProof="0" dirty="0">
                 <a:ln>
                   <a:noFill/>
                 </a:ln>
@@ -24711,8 +23788,8 @@
         </p:nvSpPr>
         <p:spPr>
           <a:xfrm>
-            <a:off x="3296740" y="279249"/>
-            <a:ext cx="6201156" cy="777875"/>
+            <a:off x="0" y="0"/>
+            <a:ext cx="12192000" cy="585216"/>
           </a:xfrm>
           <a:prstGeom prst="rect">
             <a:avLst/>
@@ -24760,7 +23837,7 @@
               <a:defRPr/>
             </a:pPr>
             <a:r>
-              <a:rPr kumimoji="0" lang="en-US" sz="3600" b="1" i="0" u="none" strike="noStrike" kern="1200" cap="none" spc="0" normalizeH="0" baseline="0" noProof="0" dirty="0">
+              <a:rPr kumimoji="0" lang="en-US" sz="3200" b="1" i="0" u="none" strike="noStrike" kern="1200" cap="none" spc="0" normalizeH="0" baseline="0" noProof="0" dirty="0">
                 <a:ln>
                   <a:noFill/>
                 </a:ln>
@@ -24777,7 +23854,7 @@
               <a:t>Causal Wake Surfaces Expand at v = c</a:t>
             </a:r>
             <a:r>
-              <a:rPr kumimoji="0" lang="en-US" sz="2520" b="1" i="0" u="none" strike="noStrike" kern="1200" cap="none" spc="0" normalizeH="0" baseline="-25000" noProof="0" dirty="0">
+              <a:rPr kumimoji="0" lang="en-US" sz="3200" b="1" i="0" u="none" strike="noStrike" kern="1200" cap="none" spc="0" normalizeH="0" baseline="-25000" noProof="0" dirty="0">
                 <a:ln>
                   <a:noFill/>
                 </a:ln>
@@ -26581,15 +25658,15 @@
         </p:nvSpPr>
         <p:spPr>
           <a:xfrm>
-            <a:off x="328266" y="450303"/>
-            <a:ext cx="11535467" cy="523220"/>
+            <a:off x="0" y="0"/>
+            <a:ext cx="12192000" cy="584775"/>
           </a:xfrm>
           <a:prstGeom prst="rect">
             <a:avLst/>
           </a:prstGeom>
         </p:spPr>
         <p:txBody>
-          <a:bodyPr wrap="none">
+          <a:bodyPr wrap="square">
             <a:spAutoFit/>
           </a:bodyPr>
           <a:lstStyle/>
@@ -26612,7 +25689,7 @@
               <a:defRPr/>
             </a:pPr>
             <a:r>
-              <a:rPr kumimoji="0" lang="en-US" sz="2800" b="1" i="0" u="none" strike="noStrike" kern="1200" cap="none" spc="0" normalizeH="0" baseline="0" noProof="0" dirty="0">
+              <a:rPr kumimoji="0" lang="en-US" sz="3200" b="1" i="0" u="none" strike="noStrike" kern="1200" cap="none" spc="0" normalizeH="0" baseline="0" noProof="0" dirty="0">
                 <a:ln>
                   <a:noFill/>
                 </a:ln>
@@ -26626,7 +25703,7 @@
                 <a:ea typeface="Helvetica Neue" panose="02000503000000020004" pitchFamily="2" charset="0"/>
                 <a:cs typeface="Helvetica Neue" panose="02000503000000020004" pitchFamily="2" charset="0"/>
               </a:rPr>
-              <a:t>A Wake Hit Occurs when a Wake Surface Intersects an Architrino</a:t>
+              <a:t>A Wake Hit Occurs when a Wake Intersects an Architrino</a:t>
             </a:r>
           </a:p>
         </p:txBody>
@@ -28756,8 +27833,8 @@
         </p:nvSpPr>
         <p:spPr>
           <a:xfrm>
-            <a:off x="1473371" y="187251"/>
-            <a:ext cx="9724009" cy="584775"/>
+            <a:off x="0" y="0"/>
+            <a:ext cx="12192000" cy="585216"/>
           </a:xfrm>
           <a:prstGeom prst="rect">
             <a:avLst/>
@@ -28765,12 +27842,12 @@
           <a:noFill/>
         </p:spPr>
         <p:txBody>
-          <a:bodyPr wrap="none" rtlCol="0">
+          <a:bodyPr wrap="square" rtlCol="0">
             <a:spAutoFit/>
           </a:bodyPr>
           <a:lstStyle/>
           <a:p>
-            <a:pPr marL="0" marR="0" lvl="0" indent="0" algn="l" defTabSz="914400" rtl="0" eaLnBrk="1" fontAlgn="auto" latinLnBrk="0" hangingPunct="1">
+            <a:pPr marL="0" marR="0" lvl="0" indent="0" algn="ctr" defTabSz="914400" rtl="0" eaLnBrk="1" fontAlgn="auto" latinLnBrk="0" hangingPunct="1">
               <a:lnSpc>
                 <a:spcPct val="100000"/>
               </a:lnSpc>
@@ -28805,7 +27882,7 @@
               <a:t>Architrino on Linear Path with Velocity v = c</a:t>
             </a:r>
             <a:r>
-              <a:rPr kumimoji="0" lang="en-US" sz="2240" b="1" i="0" u="none" strike="noStrike" kern="1200" cap="none" spc="0" normalizeH="0" baseline="-25000" noProof="0" dirty="0">
+              <a:rPr kumimoji="0" lang="en-US" sz="3200" b="1" i="0" u="none" strike="noStrike" kern="1200" cap="none" spc="0" normalizeH="0" baseline="-25000" noProof="0" dirty="0">
                 <a:ln>
                   <a:noFill/>
                 </a:ln>
@@ -30555,8 +29632,8 @@
         </p:nvSpPr>
         <p:spPr>
           <a:xfrm>
-            <a:off x="1478847" y="228414"/>
-            <a:ext cx="9927030" cy="584775"/>
+            <a:off x="0" y="0"/>
+            <a:ext cx="12192000" cy="585216"/>
           </a:xfrm>
           <a:prstGeom prst="rect">
             <a:avLst/>
@@ -30569,7 +29646,7 @@
           </a:bodyPr>
           <a:lstStyle/>
           <a:p>
-            <a:pPr marL="0" marR="0" lvl="0" indent="0" algn="l" defTabSz="914400" rtl="0" eaLnBrk="1" fontAlgn="auto" latinLnBrk="0" hangingPunct="1">
+            <a:pPr marL="0" marR="0" lvl="0" indent="0" algn="ctr" defTabSz="914400" rtl="0" eaLnBrk="1" fontAlgn="auto" latinLnBrk="0" hangingPunct="1">
               <a:lnSpc>
                 <a:spcPct val="100000"/>
               </a:lnSpc>
@@ -30604,7 +29681,7 @@
               <a:t>Architrino on Linear Path with Velocity v &gt; c</a:t>
             </a:r>
             <a:r>
-              <a:rPr kumimoji="0" lang="en-US" sz="2240" b="1" i="0" u="none" strike="noStrike" kern="1200" cap="none" spc="0" normalizeH="0" baseline="-25000" noProof="0" dirty="0">
+              <a:rPr kumimoji="0" lang="en-US" sz="3200" b="1" i="0" u="none" strike="noStrike" kern="1200" cap="none" spc="0" normalizeH="0" baseline="-25000" noProof="0" dirty="0">
                 <a:ln>
                   <a:noFill/>
                 </a:ln>
@@ -31078,7 +30155,7 @@
             <p:nvPr/>
           </p:nvPicPr>
           <p:blipFill>
-            <a:blip r:embed="rId2"/>
+            <a:blip r:embed="rId3"/>
             <a:stretch>
               <a:fillRect/>
             </a:stretch>
@@ -31447,8 +30524,8 @@
         </p:nvSpPr>
         <p:spPr>
           <a:xfrm>
-            <a:off x="2845864" y="237369"/>
-            <a:ext cx="6201156" cy="777875"/>
+            <a:off x="0" y="0"/>
+            <a:ext cx="12192000" cy="585216"/>
           </a:xfrm>
           <a:prstGeom prst="rect">
             <a:avLst/>
@@ -31496,7 +30573,7 @@
               <a:defRPr/>
             </a:pPr>
             <a:r>
-              <a:rPr kumimoji="0" lang="en-US" sz="4800" b="1" i="0" u="none" strike="noStrike" kern="1200" cap="none" spc="0" normalizeH="0" baseline="0" noProof="0" dirty="0">
+              <a:rPr kumimoji="0" lang="en-US" sz="3200" b="1" i="0" u="none" strike="noStrike" kern="1200" cap="none" spc="0" normalizeH="0" baseline="0" noProof="0" dirty="0">
                 <a:ln>
                   <a:noFill/>
                 </a:ln>
@@ -31791,7 +30868,7 @@
     <p:bg>
       <p:bgPr>
         <a:solidFill>
-          <a:schemeClr val="tx1"/>
+          <a:srgbClr val="7030A0"/>
         </a:solidFill>
         <a:effectLst/>
       </p:bgPr>
@@ -32511,7 +31588,7 @@
           <a:noFill/>
           <a:ln w="38100">
             <a:solidFill>
-              <a:srgbClr val="7030A0"/>
+              <a:schemeClr val="bg1"/>
             </a:solidFill>
           </a:ln>
         </p:spPr>
@@ -33373,7 +32450,7 @@
           <a:noFill/>
           <a:ln w="38100">
             <a:solidFill>
-              <a:srgbClr val="7030A0"/>
+              <a:schemeClr val="bg1"/>
             </a:solidFill>
           </a:ln>
         </p:spPr>
@@ -33990,25 +33067,23 @@
         </p:nvSpPr>
         <p:spPr>
           <a:xfrm>
-            <a:off x="2750180" y="307606"/>
-            <a:ext cx="6849952" cy="523220"/>
+            <a:off x="0" y="0"/>
+            <a:ext cx="12192000" cy="585216"/>
           </a:xfrm>
           <a:prstGeom prst="rect">
             <a:avLst/>
           </a:prstGeom>
-          <a:solidFill>
-            <a:srgbClr val="7030A0"/>
-          </a:solidFill>
+          <a:noFill/>
         </p:spPr>
         <p:txBody>
-          <a:bodyPr wrap="none">
+          <a:bodyPr wrap="square">
             <a:spAutoFit/>
           </a:bodyPr>
           <a:lstStyle/>
           <a:p>
             <a:pPr algn="ctr"/>
             <a:r>
-              <a:rPr lang="en-US" sz="2800" b="1" dirty="0">
+              <a:rPr lang="en-US" sz="3200" b="1" dirty="0">
                 <a:solidFill>
                   <a:schemeClr val="bg1"/>
                 </a:solidFill>
@@ -34018,7 +33093,7 @@
               </a:rPr>
               <a:t>Architrino Path History and Wake Hits</a:t>
             </a:r>
-            <a:endParaRPr lang="en-US" sz="2800" b="1" baseline="30000" dirty="0">
+            <a:endParaRPr lang="en-US" sz="3200" b="1" baseline="30000" dirty="0">
               <a:solidFill>
                 <a:schemeClr val="bg1"/>
               </a:solidFill>

</xml_diff>

<commit_message>
Clarify generator write and drift handling
</commit_message>
<xml_diff>
--- a/reference/archie/presentations/NPQG Fundamentals - Paths.pptx
+++ b/reference/archie/presentations/NPQG Fundamentals - Paths.pptx
@@ -6410,7 +6410,7 @@
 </file>
 
 <file path=ppt/slides/slide1.xml><?xml version="1.0" encoding="utf-8"?>
-<p:sld xmlns:a="http://schemas.openxmlformats.org/drawingml/2006/main" xmlns:ns2="http://schemas.microsoft.com/office/drawing/2014/main" xmlns:ns3="http://schemas.microsoft.com/office/powerpoint/2010/main" xmlns:p="http://schemas.openxmlformats.org/presentationml/2006/main">
+<p:sld xmlns:a="http://schemas.openxmlformats.org/drawingml/2006/main" xmlns:r="http://schemas.openxmlformats.org/officeDocument/2006/relationships" xmlns:p="http://schemas.openxmlformats.org/presentationml/2006/main">
   <p:cSld>
     <p:bg>
       <p:bgPr>
@@ -6425,7 +6425,7 @@
         <p:cNvPr id="1" name="">
           <a:extLst>
             <a:ext uri="{FF2B5EF4-FFF2-40B4-BE49-F238E27FC236}">
-              <ns2:creationId id="{F12CB3D1-0CE0-632F-6109-64380C884133}"/>
+              <a16:creationId xmlns:a16="http://schemas.microsoft.com/office/drawing/2014/main" id="{F12CB3D1-0CE0-632F-6109-64380C884133}"/>
             </a:ext>
           </a:extLst>
         </p:cNvPr>
@@ -6445,7 +6445,7 @@
           <p:cNvPr id="2" name="TextBox 1">
             <a:extLst>
               <a:ext uri="{FF2B5EF4-FFF2-40B4-BE49-F238E27FC236}">
-                <ns2:creationId id="{4BD4ABB3-A2D3-D440-CAE2-3FE090A98AD7}"/>
+                <a16:creationId xmlns:a16="http://schemas.microsoft.com/office/drawing/2014/main" id="{4BD4ABB3-A2D3-D440-CAE2-3FE090A98AD7}"/>
               </a:ext>
             </a:extLst>
           </p:cNvPr>
@@ -6594,7 +6594,7 @@
     </p:spTree>
     <p:extLst>
       <p:ext uri="{BB962C8B-B14F-4D97-AF65-F5344CB8AC3E}">
-        <ns3:creationId val="3704261708"/>
+        <p14:creationId xmlns:p14="http://schemas.microsoft.com/office/powerpoint/2010/main" val="3704261708"/>
       </p:ext>
     </p:extLst>
   </p:cSld>
@@ -6605,7 +6605,7 @@
 </file>
 
 <file path=ppt/slides/slide10.xml><?xml version="1.0" encoding="utf-8"?>
-<p:sld xmlns:a="http://schemas.openxmlformats.org/drawingml/2006/main" xmlns:ns2="http://schemas.microsoft.com/office/drawing/2014/main" xmlns:p="http://schemas.openxmlformats.org/presentationml/2006/main" xmlns:p14="http://schemas.microsoft.com/office/powerpoint/2010/main">
+<p:sld xmlns:a="http://schemas.openxmlformats.org/drawingml/2006/main" xmlns:r="http://schemas.openxmlformats.org/officeDocument/2006/relationships" xmlns:p="http://schemas.openxmlformats.org/presentationml/2006/main">
   <p:cSld>
     <p:bg>
       <p:bgPr>
@@ -6634,7 +6634,7 @@
           <p:cNvPr id="4" name="Freeform 3">
             <a:extLst>
               <a:ext uri="{FF2B5EF4-FFF2-40B4-BE49-F238E27FC236}">
-                <ns2:creationId id="{557E8D0E-7530-B118-1DC6-82906B4F6D15}"/>
+                <a16:creationId xmlns:a16="http://schemas.microsoft.com/office/drawing/2014/main" id="{557E8D0E-7530-B118-1DC6-82906B4F6D15}"/>
               </a:ext>
             </a:extLst>
           </p:cNvPr>
@@ -7598,7 +7598,7 @@
           <p:cNvPr id="5" name="Footer Placeholder 3">
             <a:extLst>
               <a:ext uri="{FF2B5EF4-FFF2-40B4-BE49-F238E27FC236}">
-                <ns2:creationId id="{668F77D6-DFDA-5A46-8DF1-47F6A167C2B1}"/>
+                <a16:creationId xmlns:a16="http://schemas.microsoft.com/office/drawing/2014/main" id="{668F77D6-DFDA-5A46-8DF1-47F6A167C2B1}"/>
               </a:ext>
             </a:extLst>
           </p:cNvPr>
@@ -7760,7 +7760,7 @@
           <p:cNvPr id="16" name="Freeform 15">
             <a:extLst>
               <a:ext uri="{FF2B5EF4-FFF2-40B4-BE49-F238E27FC236}">
-                <ns2:creationId id="{226B2D26-F692-894E-9B09-F57FBB5CB2A3}"/>
+                <a16:creationId xmlns:a16="http://schemas.microsoft.com/office/drawing/2014/main" id="{226B2D26-F692-894E-9B09-F57FBB5CB2A3}"/>
               </a:ext>
             </a:extLst>
           </p:cNvPr>
@@ -8643,7 +8643,7 @@
           <p:cNvPr id="19" name="Oval 18">
             <a:extLst>
               <a:ext uri="{FF2B5EF4-FFF2-40B4-BE49-F238E27FC236}">
-                <ns2:creationId id="{0592434B-85D0-0A41-95DD-A29D1D3E92A7}"/>
+                <a16:creationId xmlns:a16="http://schemas.microsoft.com/office/drawing/2014/main" id="{0592434B-85D0-0A41-95DD-A29D1D3E92A7}"/>
               </a:ext>
             </a:extLst>
           </p:cNvPr>
@@ -8724,7 +8724,7 @@
           <p:cNvPr id="22" name="TextBox 21">
             <a:extLst>
               <a:ext uri="{FF2B5EF4-FFF2-40B4-BE49-F238E27FC236}">
-                <ns2:creationId id="{32F7BF73-EB2C-9D42-97FB-D39FDCC924EB}"/>
+                <a16:creationId xmlns:a16="http://schemas.microsoft.com/office/drawing/2014/main" id="{32F7BF73-EB2C-9D42-97FB-D39FDCC924EB}"/>
               </a:ext>
             </a:extLst>
           </p:cNvPr>
@@ -8803,7 +8803,7 @@
           <p:cNvPr id="32" name="Group 31">
             <a:extLst>
               <a:ext uri="{FF2B5EF4-FFF2-40B4-BE49-F238E27FC236}">
-                <ns2:creationId id="{A120AE69-6043-195E-40C7-43C019B9D3A9}"/>
+                <a16:creationId xmlns:a16="http://schemas.microsoft.com/office/drawing/2014/main" id="{A120AE69-6043-195E-40C7-43C019B9D3A9}"/>
               </a:ext>
             </a:extLst>
           </p:cNvPr>
@@ -8823,7 +8823,7 @@
             <p:cNvPr id="24" name="Straight Connector 23">
               <a:extLst>
                 <a:ext uri="{FF2B5EF4-FFF2-40B4-BE49-F238E27FC236}">
-                  <ns2:creationId id="{3A19E039-1667-254C-809A-972BBA46D65C}"/>
+                  <a16:creationId xmlns:a16="http://schemas.microsoft.com/office/drawing/2014/main" id="{3A19E039-1667-254C-809A-972BBA46D65C}"/>
                 </a:ext>
               </a:extLst>
             </p:cNvPr>
@@ -8869,7 +8869,7 @@
             <p:cNvPr id="2" name="Oval 1">
               <a:extLst>
                 <a:ext uri="{FF2B5EF4-FFF2-40B4-BE49-F238E27FC236}">
-                  <ns2:creationId id="{38418338-F1E6-81D9-6A8C-D7EB7AA9DDA2}"/>
+                  <a16:creationId xmlns:a16="http://schemas.microsoft.com/office/drawing/2014/main" id="{38418338-F1E6-81D9-6A8C-D7EB7AA9DDA2}"/>
                 </a:ext>
               </a:extLst>
             </p:cNvPr>
@@ -8954,7 +8954,7 @@
           <p:cNvPr id="29" name="TextBox 28">
             <a:extLst>
               <a:ext uri="{FF2B5EF4-FFF2-40B4-BE49-F238E27FC236}">
-                <ns2:creationId id="{2C329E1C-5E54-9E3C-A6FA-AE50E16EEB85}"/>
+                <a16:creationId xmlns:a16="http://schemas.microsoft.com/office/drawing/2014/main" id="{2C329E1C-5E54-9E3C-A6FA-AE50E16EEB85}"/>
               </a:ext>
             </a:extLst>
           </p:cNvPr>
@@ -9033,7 +9033,7 @@
           <p:cNvPr id="40" name="Group 39">
             <a:extLst>
               <a:ext uri="{FF2B5EF4-FFF2-40B4-BE49-F238E27FC236}">
-                <ns2:creationId id="{C105AAA1-FA00-79D8-70E9-DB832351B5E2}"/>
+                <a16:creationId xmlns:a16="http://schemas.microsoft.com/office/drawing/2014/main" id="{C105AAA1-FA00-79D8-70E9-DB832351B5E2}"/>
               </a:ext>
             </a:extLst>
           </p:cNvPr>
@@ -9053,7 +9053,7 @@
             <p:cNvPr id="41" name="Straight Connector 40">
               <a:extLst>
                 <a:ext uri="{FF2B5EF4-FFF2-40B4-BE49-F238E27FC236}">
-                  <ns2:creationId id="{48D05E5C-4059-6EC7-1299-E52A65F46E3D}"/>
+                  <a16:creationId xmlns:a16="http://schemas.microsoft.com/office/drawing/2014/main" id="{48D05E5C-4059-6EC7-1299-E52A65F46E3D}"/>
                 </a:ext>
               </a:extLst>
             </p:cNvPr>
@@ -9099,7 +9099,7 @@
             <p:cNvPr id="42" name="Oval 41">
               <a:extLst>
                 <a:ext uri="{FF2B5EF4-FFF2-40B4-BE49-F238E27FC236}">
-                  <ns2:creationId id="{8174E055-9EC2-40B6-B317-43A23011EC49}"/>
+                  <a16:creationId xmlns:a16="http://schemas.microsoft.com/office/drawing/2014/main" id="{8174E055-9EC2-40B6-B317-43A23011EC49}"/>
                 </a:ext>
               </a:extLst>
             </p:cNvPr>
@@ -9184,7 +9184,7 @@
           <p:cNvPr id="28" name="TextBox 27">
             <a:extLst>
               <a:ext uri="{FF2B5EF4-FFF2-40B4-BE49-F238E27FC236}">
-                <ns2:creationId id="{B86BBAD0-86F6-0D58-180C-6EA1BDCC33FE}"/>
+                <a16:creationId xmlns:a16="http://schemas.microsoft.com/office/drawing/2014/main" id="{B86BBAD0-86F6-0D58-180C-6EA1BDCC33FE}"/>
               </a:ext>
             </a:extLst>
           </p:cNvPr>
@@ -9313,7 +9313,7 @@
           <p:cNvPr id="6" name="Oval 5">
             <a:extLst>
               <a:ext uri="{FF2B5EF4-FFF2-40B4-BE49-F238E27FC236}">
-                <ns2:creationId id="{AC0CFD16-199C-C379-61A7-C2D95EDE2034}"/>
+                <a16:creationId xmlns:a16="http://schemas.microsoft.com/office/drawing/2014/main" id="{AC0CFD16-199C-C379-61A7-C2D95EDE2034}"/>
               </a:ext>
             </a:extLst>
           </p:cNvPr>
@@ -9365,7 +9365,7 @@
           <p:cNvPr id="7" name="TextBox 6">
             <a:extLst>
               <a:ext uri="{FF2B5EF4-FFF2-40B4-BE49-F238E27FC236}">
-                <ns2:creationId id="{74832E6C-887E-D39B-AAC8-6B87F8F0377B}"/>
+                <a16:creationId xmlns:a16="http://schemas.microsoft.com/office/drawing/2014/main" id="{74832E6C-887E-D39B-AAC8-6B87F8F0377B}"/>
               </a:ext>
             </a:extLst>
           </p:cNvPr>
@@ -9412,7 +9412,7 @@
           <p:cNvPr id="9" name="TextBox 8">
             <a:extLst>
               <a:ext uri="{FF2B5EF4-FFF2-40B4-BE49-F238E27FC236}">
-                <ns2:creationId id="{3FBBB3C0-9EF9-2269-F804-566738A12135}"/>
+                <a16:creationId xmlns:a16="http://schemas.microsoft.com/office/drawing/2014/main" id="{3FBBB3C0-9EF9-2269-F804-566738A12135}"/>
               </a:ext>
             </a:extLst>
           </p:cNvPr>
@@ -9459,7 +9459,7 @@
           <p:cNvPr id="10" name="TextBox 9">
             <a:extLst>
               <a:ext uri="{FF2B5EF4-FFF2-40B4-BE49-F238E27FC236}">
-                <ns2:creationId id="{5AD88C91-2B9D-6C66-4521-C91A0EBE16F1}"/>
+                <a16:creationId xmlns:a16="http://schemas.microsoft.com/office/drawing/2014/main" id="{5AD88C91-2B9D-6C66-4521-C91A0EBE16F1}"/>
               </a:ext>
             </a:extLst>
           </p:cNvPr>
@@ -9506,7 +9506,7 @@
           <p:cNvPr id="11" name="Rectangle 10">
             <a:extLst>
               <a:ext uri="{FF2B5EF4-FFF2-40B4-BE49-F238E27FC236}">
-                <ns2:creationId id="{408E88E8-1AC1-3859-ED6E-998C354C18AF}"/>
+                <a16:creationId xmlns:a16="http://schemas.microsoft.com/office/drawing/2014/main" id="{408E88E8-1AC1-3859-ED6E-998C354C18AF}"/>
               </a:ext>
             </a:extLst>
           </p:cNvPr>
@@ -9557,7 +9557,7 @@
           <p:cNvPr id="14" name="Group 13">
             <a:extLst>
               <a:ext uri="{FF2B5EF4-FFF2-40B4-BE49-F238E27FC236}">
-                <ns2:creationId id="{7A05C4D2-699B-5F84-92AE-09238BDBF4E8}"/>
+                <a16:creationId xmlns:a16="http://schemas.microsoft.com/office/drawing/2014/main" id="{7A05C4D2-699B-5F84-92AE-09238BDBF4E8}"/>
               </a:ext>
             </a:extLst>
           </p:cNvPr>
@@ -9577,7 +9577,7 @@
             <p:cNvPr id="15" name="Straight Arrow Connector 14">
               <a:extLst>
                 <a:ext uri="{FF2B5EF4-FFF2-40B4-BE49-F238E27FC236}">
-                  <ns2:creationId id="{6F7FA685-0220-0300-5C81-7977AB43778D}"/>
+                  <a16:creationId xmlns:a16="http://schemas.microsoft.com/office/drawing/2014/main" id="{6F7FA685-0220-0300-5C81-7977AB43778D}"/>
                 </a:ext>
               </a:extLst>
             </p:cNvPr>
@@ -9621,7 +9621,7 @@
             <p:cNvPr id="17" name="Straight Arrow Connector 16">
               <a:extLst>
                 <a:ext uri="{FF2B5EF4-FFF2-40B4-BE49-F238E27FC236}">
-                  <ns2:creationId id="{8DAAADDE-3685-65B3-881A-0143943C0267}"/>
+                  <a16:creationId xmlns:a16="http://schemas.microsoft.com/office/drawing/2014/main" id="{8DAAADDE-3685-65B3-881A-0143943C0267}"/>
                 </a:ext>
               </a:extLst>
             </p:cNvPr>
@@ -9665,7 +9665,7 @@
             <p:cNvPr id="18" name="TextBox 17">
               <a:extLst>
                 <a:ext uri="{FF2B5EF4-FFF2-40B4-BE49-F238E27FC236}">
-                  <ns2:creationId id="{BAA0C0F5-147D-A6B2-DBB6-6DCB0FFF6BAE}"/>
+                  <a16:creationId xmlns:a16="http://schemas.microsoft.com/office/drawing/2014/main" id="{BAA0C0F5-147D-A6B2-DBB6-6DCB0FFF6BAE}"/>
                 </a:ext>
               </a:extLst>
             </p:cNvPr>
@@ -9730,7 +9730,7 @@
             <p:cNvPr id="20" name="TextBox 19">
               <a:extLst>
                 <a:ext uri="{FF2B5EF4-FFF2-40B4-BE49-F238E27FC236}">
-                  <ns2:creationId id="{84C36D57-9425-3680-6F8D-295F2518BF54}"/>
+                  <a16:creationId xmlns:a16="http://schemas.microsoft.com/office/drawing/2014/main" id="{84C36D57-9425-3680-6F8D-295F2518BF54}"/>
                 </a:ext>
               </a:extLst>
             </p:cNvPr>
@@ -9790,7 +9790,7 @@
     </p:spTree>
     <p:extLst>
       <p:ext uri="{BB962C8B-B14F-4D97-AF65-F5344CB8AC3E}">
-        <p14:creationId val="1541260098"/>
+        <p14:creationId xmlns:p14="http://schemas.microsoft.com/office/powerpoint/2010/main" val="1541260098"/>
       </p:ext>
     </p:extLst>
   </p:cSld>
@@ -9801,7 +9801,7 @@
 </file>
 
 <file path=ppt/slides/slide11.xml><?xml version="1.0" encoding="utf-8"?>
-<p:sld xmlns:a="http://schemas.openxmlformats.org/drawingml/2006/main" xmlns:ns2="http://schemas.microsoft.com/office/drawing/2014/main" xmlns:p="http://schemas.openxmlformats.org/presentationml/2006/main" xmlns:p14="http://schemas.microsoft.com/office/powerpoint/2010/main">
+<p:sld xmlns:a="http://schemas.openxmlformats.org/drawingml/2006/main" xmlns:r="http://schemas.openxmlformats.org/officeDocument/2006/relationships" xmlns:p="http://schemas.openxmlformats.org/presentationml/2006/main">
   <p:cSld>
     <p:bg>
       <p:bgPr>
@@ -9830,7 +9830,7 @@
           <p:cNvPr id="5" name="Footer Placeholder 3">
             <a:extLst>
               <a:ext uri="{FF2B5EF4-FFF2-40B4-BE49-F238E27FC236}">
-                <ns2:creationId id="{668F77D6-DFDA-5A46-8DF1-47F6A167C2B1}"/>
+                <a16:creationId xmlns:a16="http://schemas.microsoft.com/office/drawing/2014/main" id="{668F77D6-DFDA-5A46-8DF1-47F6A167C2B1}"/>
               </a:ext>
             </a:extLst>
           </p:cNvPr>
@@ -9992,7 +9992,7 @@
           <p:cNvPr id="13" name="TextBox 12">
             <a:extLst>
               <a:ext uri="{FF2B5EF4-FFF2-40B4-BE49-F238E27FC236}">
-                <ns2:creationId id="{2C3F4604-6C2F-0E4E-9DD3-4F5C89FF51AB}"/>
+                <a16:creationId xmlns:a16="http://schemas.microsoft.com/office/drawing/2014/main" id="{2C3F4604-6C2F-0E4E-9DD3-4F5C89FF51AB}"/>
               </a:ext>
             </a:extLst>
           </p:cNvPr>
@@ -10053,7 +10053,7 @@
           <p:cNvPr id="14" name="Freeform 13">
             <a:extLst>
               <a:ext uri="{FF2B5EF4-FFF2-40B4-BE49-F238E27FC236}">
-                <ns2:creationId id="{6D478F86-6608-8240-A60F-2B5B4B14CE42}"/>
+                <a16:creationId xmlns:a16="http://schemas.microsoft.com/office/drawing/2014/main" id="{6D478F86-6608-8240-A60F-2B5B4B14CE42}"/>
               </a:ext>
             </a:extLst>
           </p:cNvPr>
@@ -10594,7 +10594,7 @@
           <p:cNvPr id="16" name="Freeform 15">
             <a:extLst>
               <a:ext uri="{FF2B5EF4-FFF2-40B4-BE49-F238E27FC236}">
-                <ns2:creationId id="{226B2D26-F692-894E-9B09-F57FBB5CB2A3}"/>
+                <a16:creationId xmlns:a16="http://schemas.microsoft.com/office/drawing/2014/main" id="{226B2D26-F692-894E-9B09-F57FBB5CB2A3}"/>
               </a:ext>
             </a:extLst>
           </p:cNvPr>
@@ -11477,7 +11477,7 @@
           <p:cNvPr id="18" name="Oval 17">
             <a:extLst>
               <a:ext uri="{FF2B5EF4-FFF2-40B4-BE49-F238E27FC236}">
-                <ns2:creationId id="{BE4CDC90-4B2E-BE41-BB9D-A84675F3A2FE}"/>
+                <a16:creationId xmlns:a16="http://schemas.microsoft.com/office/drawing/2014/main" id="{BE4CDC90-4B2E-BE41-BB9D-A84675F3A2FE}"/>
               </a:ext>
             </a:extLst>
           </p:cNvPr>
@@ -11558,7 +11558,7 @@
           <p:cNvPr id="19" name="Oval 18">
             <a:extLst>
               <a:ext uri="{FF2B5EF4-FFF2-40B4-BE49-F238E27FC236}">
-                <ns2:creationId id="{0592434B-85D0-0A41-95DD-A29D1D3E92A7}"/>
+                <a16:creationId xmlns:a16="http://schemas.microsoft.com/office/drawing/2014/main" id="{0592434B-85D0-0A41-95DD-A29D1D3E92A7}"/>
               </a:ext>
             </a:extLst>
           </p:cNvPr>
@@ -11639,7 +11639,7 @@
           <p:cNvPr id="21" name="TextBox 20">
             <a:extLst>
               <a:ext uri="{FF2B5EF4-FFF2-40B4-BE49-F238E27FC236}">
-                <ns2:creationId id="{7B549753-C2CD-8744-8435-2E08FD32BDEB}"/>
+                <a16:creationId xmlns:a16="http://schemas.microsoft.com/office/drawing/2014/main" id="{7B549753-C2CD-8744-8435-2E08FD32BDEB}"/>
               </a:ext>
             </a:extLst>
           </p:cNvPr>
@@ -11718,7 +11718,7 @@
           <p:cNvPr id="22" name="TextBox 21">
             <a:extLst>
               <a:ext uri="{FF2B5EF4-FFF2-40B4-BE49-F238E27FC236}">
-                <ns2:creationId id="{32F7BF73-EB2C-9D42-97FB-D39FDCC924EB}"/>
+                <a16:creationId xmlns:a16="http://schemas.microsoft.com/office/drawing/2014/main" id="{32F7BF73-EB2C-9D42-97FB-D39FDCC924EB}"/>
               </a:ext>
             </a:extLst>
           </p:cNvPr>
@@ -11797,7 +11797,7 @@
           <p:cNvPr id="32" name="Group 31">
             <a:extLst>
               <a:ext uri="{FF2B5EF4-FFF2-40B4-BE49-F238E27FC236}">
-                <ns2:creationId id="{A120AE69-6043-195E-40C7-43C019B9D3A9}"/>
+                <a16:creationId xmlns:a16="http://schemas.microsoft.com/office/drawing/2014/main" id="{A120AE69-6043-195E-40C7-43C019B9D3A9}"/>
               </a:ext>
             </a:extLst>
           </p:cNvPr>
@@ -11817,7 +11817,7 @@
             <p:cNvPr id="24" name="Straight Connector 23">
               <a:extLst>
                 <a:ext uri="{FF2B5EF4-FFF2-40B4-BE49-F238E27FC236}">
-                  <ns2:creationId id="{3A19E039-1667-254C-809A-972BBA46D65C}"/>
+                  <a16:creationId xmlns:a16="http://schemas.microsoft.com/office/drawing/2014/main" id="{3A19E039-1667-254C-809A-972BBA46D65C}"/>
                 </a:ext>
               </a:extLst>
             </p:cNvPr>
@@ -11864,7 +11864,7 @@
             <p:cNvPr id="2" name="Oval 1">
               <a:extLst>
                 <a:ext uri="{FF2B5EF4-FFF2-40B4-BE49-F238E27FC236}">
-                  <ns2:creationId id="{38418338-F1E6-81D9-6A8C-D7EB7AA9DDA2}"/>
+                  <a16:creationId xmlns:a16="http://schemas.microsoft.com/office/drawing/2014/main" id="{38418338-F1E6-81D9-6A8C-D7EB7AA9DDA2}"/>
                 </a:ext>
               </a:extLst>
             </p:cNvPr>
@@ -11949,7 +11949,7 @@
           <p:cNvPr id="28" name="TextBox 27">
             <a:extLst>
               <a:ext uri="{FF2B5EF4-FFF2-40B4-BE49-F238E27FC236}">
-                <ns2:creationId id="{B86BBAD0-86F6-0D58-180C-6EA1BDCC33FE}"/>
+                <a16:creationId xmlns:a16="http://schemas.microsoft.com/office/drawing/2014/main" id="{B86BBAD0-86F6-0D58-180C-6EA1BDCC33FE}"/>
               </a:ext>
             </a:extLst>
           </p:cNvPr>
@@ -12028,7 +12028,7 @@
           <p:cNvPr id="29" name="TextBox 28">
             <a:extLst>
               <a:ext uri="{FF2B5EF4-FFF2-40B4-BE49-F238E27FC236}">
-                <ns2:creationId id="{2C329E1C-5E54-9E3C-A6FA-AE50E16EEB85}"/>
+                <a16:creationId xmlns:a16="http://schemas.microsoft.com/office/drawing/2014/main" id="{2C329E1C-5E54-9E3C-A6FA-AE50E16EEB85}"/>
               </a:ext>
             </a:extLst>
           </p:cNvPr>
@@ -12107,7 +12107,7 @@
           <p:cNvPr id="33" name="Group 32">
             <a:extLst>
               <a:ext uri="{FF2B5EF4-FFF2-40B4-BE49-F238E27FC236}">
-                <ns2:creationId id="{1D286D70-C171-9F97-4EF6-3BE92F6BF451}"/>
+                <a16:creationId xmlns:a16="http://schemas.microsoft.com/office/drawing/2014/main" id="{1D286D70-C171-9F97-4EF6-3BE92F6BF451}"/>
               </a:ext>
             </a:extLst>
           </p:cNvPr>
@@ -12127,7 +12127,7 @@
             <p:cNvPr id="34" name="Straight Connector 33">
               <a:extLst>
                 <a:ext uri="{FF2B5EF4-FFF2-40B4-BE49-F238E27FC236}">
-                  <ns2:creationId id="{8592FA4B-D9A7-6E33-AB7A-56BCD3E75DEC}"/>
+                  <a16:creationId xmlns:a16="http://schemas.microsoft.com/office/drawing/2014/main" id="{8592FA4B-D9A7-6E33-AB7A-56BCD3E75DEC}"/>
                 </a:ext>
               </a:extLst>
             </p:cNvPr>
@@ -12173,7 +12173,7 @@
             <p:cNvPr id="35" name="Oval 34">
               <a:extLst>
                 <a:ext uri="{FF2B5EF4-FFF2-40B4-BE49-F238E27FC236}">
-                  <ns2:creationId id="{D1C61822-C414-6D43-5771-23FAB0629304}"/>
+                  <a16:creationId xmlns:a16="http://schemas.microsoft.com/office/drawing/2014/main" id="{D1C61822-C414-6D43-5771-23FAB0629304}"/>
                 </a:ext>
               </a:extLst>
             </p:cNvPr>
@@ -12258,7 +12258,7 @@
           <p:cNvPr id="36" name="Group 35">
             <a:extLst>
               <a:ext uri="{FF2B5EF4-FFF2-40B4-BE49-F238E27FC236}">
-                <ns2:creationId id="{C03937C6-921F-C709-6C11-E769E0AA1568}"/>
+                <a16:creationId xmlns:a16="http://schemas.microsoft.com/office/drawing/2014/main" id="{C03937C6-921F-C709-6C11-E769E0AA1568}"/>
               </a:ext>
             </a:extLst>
           </p:cNvPr>
@@ -12278,7 +12278,7 @@
             <p:cNvPr id="37" name="Straight Connector 36">
               <a:extLst>
                 <a:ext uri="{FF2B5EF4-FFF2-40B4-BE49-F238E27FC236}">
-                  <ns2:creationId id="{BA8BF2BD-3FCE-A586-601D-1E4026152CB6}"/>
+                  <a16:creationId xmlns:a16="http://schemas.microsoft.com/office/drawing/2014/main" id="{BA8BF2BD-3FCE-A586-601D-1E4026152CB6}"/>
                 </a:ext>
               </a:extLst>
             </p:cNvPr>
@@ -12324,7 +12324,7 @@
             <p:cNvPr id="38" name="Oval 37">
               <a:extLst>
                 <a:ext uri="{FF2B5EF4-FFF2-40B4-BE49-F238E27FC236}">
-                  <ns2:creationId id="{9DC53165-740B-C795-C0DF-F1A1A73F6F36}"/>
+                  <a16:creationId xmlns:a16="http://schemas.microsoft.com/office/drawing/2014/main" id="{9DC53165-740B-C795-C0DF-F1A1A73F6F36}"/>
                 </a:ext>
               </a:extLst>
             </p:cNvPr>
@@ -12409,7 +12409,7 @@
           <p:cNvPr id="40" name="Group 39">
             <a:extLst>
               <a:ext uri="{FF2B5EF4-FFF2-40B4-BE49-F238E27FC236}">
-                <ns2:creationId id="{C105AAA1-FA00-79D8-70E9-DB832351B5E2}"/>
+                <a16:creationId xmlns:a16="http://schemas.microsoft.com/office/drawing/2014/main" id="{C105AAA1-FA00-79D8-70E9-DB832351B5E2}"/>
               </a:ext>
             </a:extLst>
           </p:cNvPr>
@@ -12429,7 +12429,7 @@
             <p:cNvPr id="41" name="Straight Connector 40">
               <a:extLst>
                 <a:ext uri="{FF2B5EF4-FFF2-40B4-BE49-F238E27FC236}">
-                  <ns2:creationId id="{48D05E5C-4059-6EC7-1299-E52A65F46E3D}"/>
+                  <a16:creationId xmlns:a16="http://schemas.microsoft.com/office/drawing/2014/main" id="{48D05E5C-4059-6EC7-1299-E52A65F46E3D}"/>
                 </a:ext>
               </a:extLst>
             </p:cNvPr>
@@ -12475,7 +12475,7 @@
             <p:cNvPr id="42" name="Oval 41">
               <a:extLst>
                 <a:ext uri="{FF2B5EF4-FFF2-40B4-BE49-F238E27FC236}">
-                  <ns2:creationId id="{8174E055-9EC2-40B6-B317-43A23011EC49}"/>
+                  <a16:creationId xmlns:a16="http://schemas.microsoft.com/office/drawing/2014/main" id="{8174E055-9EC2-40B6-B317-43A23011EC49}"/>
                 </a:ext>
               </a:extLst>
             </p:cNvPr>
@@ -12560,7 +12560,7 @@
           <p:cNvPr id="4" name="Rectangle 3">
             <a:extLst>
               <a:ext uri="{FF2B5EF4-FFF2-40B4-BE49-F238E27FC236}">
-                <ns2:creationId id="{ADBBA491-EC7F-B7A8-024F-1F1EB3434C26}"/>
+                <a16:creationId xmlns:a16="http://schemas.microsoft.com/office/drawing/2014/main" id="{ADBBA491-EC7F-B7A8-024F-1F1EB3434C26}"/>
               </a:ext>
             </a:extLst>
           </p:cNvPr>
@@ -12611,7 +12611,7 @@
           <p:cNvPr id="6" name="Group 5">
             <a:extLst>
               <a:ext uri="{FF2B5EF4-FFF2-40B4-BE49-F238E27FC236}">
-                <ns2:creationId id="{99AA8219-E43E-724C-056B-B18383E44D07}"/>
+                <a16:creationId xmlns:a16="http://schemas.microsoft.com/office/drawing/2014/main" id="{99AA8219-E43E-724C-056B-B18383E44D07}"/>
               </a:ext>
             </a:extLst>
           </p:cNvPr>
@@ -12631,7 +12631,7 @@
             <p:cNvPr id="7" name="Straight Arrow Connector 6">
               <a:extLst>
                 <a:ext uri="{FF2B5EF4-FFF2-40B4-BE49-F238E27FC236}">
-                  <ns2:creationId id="{D656FE40-D181-9F96-4B12-1D4A1600D94D}"/>
+                  <a16:creationId xmlns:a16="http://schemas.microsoft.com/office/drawing/2014/main" id="{D656FE40-D181-9F96-4B12-1D4A1600D94D}"/>
                 </a:ext>
               </a:extLst>
             </p:cNvPr>
@@ -12675,7 +12675,7 @@
             <p:cNvPr id="9" name="Straight Arrow Connector 8">
               <a:extLst>
                 <a:ext uri="{FF2B5EF4-FFF2-40B4-BE49-F238E27FC236}">
-                  <ns2:creationId id="{A8B296C3-B87D-78ED-4E26-EC9E5A291FD0}"/>
+                  <a16:creationId xmlns:a16="http://schemas.microsoft.com/office/drawing/2014/main" id="{A8B296C3-B87D-78ED-4E26-EC9E5A291FD0}"/>
                 </a:ext>
               </a:extLst>
             </p:cNvPr>
@@ -12719,7 +12719,7 @@
             <p:cNvPr id="10" name="TextBox 9">
               <a:extLst>
                 <a:ext uri="{FF2B5EF4-FFF2-40B4-BE49-F238E27FC236}">
-                  <ns2:creationId id="{F49CBD38-2A34-BF6B-7AF0-E9DF4ADD0FDF}"/>
+                  <a16:creationId xmlns:a16="http://schemas.microsoft.com/office/drawing/2014/main" id="{F49CBD38-2A34-BF6B-7AF0-E9DF4ADD0FDF}"/>
                 </a:ext>
               </a:extLst>
             </p:cNvPr>
@@ -12783,7 +12783,7 @@
     </p:spTree>
     <p:extLst>
       <p:ext uri="{BB962C8B-B14F-4D97-AF65-F5344CB8AC3E}">
-        <p14:creationId val="3036832815"/>
+        <p14:creationId xmlns:p14="http://schemas.microsoft.com/office/powerpoint/2010/main" val="3036832815"/>
       </p:ext>
     </p:extLst>
   </p:cSld>
@@ -12794,7 +12794,7 @@
 </file>
 
 <file path=ppt/slides/slide12.xml><?xml version="1.0" encoding="utf-8"?>
-<p:sld xmlns:a="http://schemas.openxmlformats.org/drawingml/2006/main" xmlns:ns2="http://schemas.microsoft.com/office/drawing/2014/main" xmlns:p="http://schemas.openxmlformats.org/presentationml/2006/main" xmlns:p14="http://schemas.microsoft.com/office/powerpoint/2010/main">
+<p:sld xmlns:a="http://schemas.openxmlformats.org/drawingml/2006/main" xmlns:r="http://schemas.openxmlformats.org/officeDocument/2006/relationships" xmlns:p="http://schemas.openxmlformats.org/presentationml/2006/main">
   <p:cSld>
     <p:bg>
       <p:bgPr>
@@ -12809,7 +12809,7 @@
         <p:cNvPr id="1" name="">
           <a:extLst>
             <a:ext uri="{FF2B5EF4-FFF2-40B4-BE49-F238E27FC236}">
-              <ns2:creationId id="{96E919E2-812D-C716-7A6E-78657A604D1E}"/>
+              <a16:creationId xmlns:a16="http://schemas.microsoft.com/office/drawing/2014/main" id="{96E919E2-812D-C716-7A6E-78657A604D1E}"/>
             </a:ext>
           </a:extLst>
         </p:cNvPr>
@@ -12829,7 +12829,7 @@
           <p:cNvPr id="34" name="Freeform 33">
             <a:extLst>
               <a:ext uri="{FF2B5EF4-FFF2-40B4-BE49-F238E27FC236}">
-                <ns2:creationId id="{9FEB1C17-EE9E-6374-14E0-DF4B04BB34CC}"/>
+                <a16:creationId xmlns:a16="http://schemas.microsoft.com/office/drawing/2014/main" id="{9FEB1C17-EE9E-6374-14E0-DF4B04BB34CC}"/>
               </a:ext>
             </a:extLst>
           </p:cNvPr>
@@ -13867,7 +13867,7 @@
           <p:cNvPr id="23" name="Straight Connector 22">
             <a:extLst>
               <a:ext uri="{FF2B5EF4-FFF2-40B4-BE49-F238E27FC236}">
-                <ns2:creationId id="{33DF3D55-999F-17C8-E647-A925ABFD4B29}"/>
+                <a16:creationId xmlns:a16="http://schemas.microsoft.com/office/drawing/2014/main" id="{33DF3D55-999F-17C8-E647-A925ABFD4B29}"/>
               </a:ext>
             </a:extLst>
           </p:cNvPr>
@@ -13913,7 +13913,7 @@
           <p:cNvPr id="11" name="Footer Placeholder 3">
             <a:extLst>
               <a:ext uri="{FF2B5EF4-FFF2-40B4-BE49-F238E27FC236}">
-                <ns2:creationId id="{27AA374C-C403-AE7C-8C5A-C9260FD31350}"/>
+                <a16:creationId xmlns:a16="http://schemas.microsoft.com/office/drawing/2014/main" id="{27AA374C-C403-AE7C-8C5A-C9260FD31350}"/>
               </a:ext>
             </a:extLst>
           </p:cNvPr>
@@ -14047,7 +14047,7 @@
           <p:cNvPr id="6" name="Freeform 5">
             <a:extLst>
               <a:ext uri="{FF2B5EF4-FFF2-40B4-BE49-F238E27FC236}">
-                <ns2:creationId id="{58C91A8E-32A3-E6C9-3B21-6258314CE1E0}"/>
+                <a16:creationId xmlns:a16="http://schemas.microsoft.com/office/drawing/2014/main" id="{58C91A8E-32A3-E6C9-3B21-6258314CE1E0}"/>
               </a:ext>
             </a:extLst>
           </p:cNvPr>
@@ -14643,7 +14643,7 @@
           <p:cNvPr id="7" name="Freeform 6">
             <a:extLst>
               <a:ext uri="{FF2B5EF4-FFF2-40B4-BE49-F238E27FC236}">
-                <ns2:creationId id="{510BA2CB-DE8D-42AC-CE1A-16118C17D521}"/>
+                <a16:creationId xmlns:a16="http://schemas.microsoft.com/office/drawing/2014/main" id="{510BA2CB-DE8D-42AC-CE1A-16118C17D521}"/>
               </a:ext>
             </a:extLst>
           </p:cNvPr>
@@ -15505,7 +15505,7 @@
           <p:cNvPr id="9" name="Oval 8">
             <a:extLst>
               <a:ext uri="{FF2B5EF4-FFF2-40B4-BE49-F238E27FC236}">
-                <ns2:creationId id="{568F11F0-CD68-B68F-145C-42747F6BA3CB}"/>
+                <a16:creationId xmlns:a16="http://schemas.microsoft.com/office/drawing/2014/main" id="{568F11F0-CD68-B68F-145C-42747F6BA3CB}"/>
               </a:ext>
             </a:extLst>
           </p:cNvPr>
@@ -15559,7 +15559,7 @@
           <p:cNvPr id="10" name="Oval 9">
             <a:extLst>
               <a:ext uri="{FF2B5EF4-FFF2-40B4-BE49-F238E27FC236}">
-                <ns2:creationId id="{6BC2B4CC-1274-7B5E-9B1C-D914D507A56F}"/>
+                <a16:creationId xmlns:a16="http://schemas.microsoft.com/office/drawing/2014/main" id="{6BC2B4CC-1274-7B5E-9B1C-D914D507A56F}"/>
               </a:ext>
             </a:extLst>
           </p:cNvPr>
@@ -15613,7 +15613,7 @@
           <p:cNvPr id="25" name="Rectangle 24">
             <a:extLst>
               <a:ext uri="{FF2B5EF4-FFF2-40B4-BE49-F238E27FC236}">
-                <ns2:creationId id="{79427490-B6E9-7801-97EB-47C4A21F9FE6}"/>
+                <a16:creationId xmlns:a16="http://schemas.microsoft.com/office/drawing/2014/main" id="{79427490-B6E9-7801-97EB-47C4A21F9FE6}"/>
               </a:ext>
             </a:extLst>
           </p:cNvPr>
@@ -15666,7 +15666,7 @@
           <p:cNvPr id="3" name="Straight Arrow Connector 2">
             <a:extLst>
               <a:ext uri="{FF2B5EF4-FFF2-40B4-BE49-F238E27FC236}">
-                <ns2:creationId id="{EB763B1F-F575-913F-DB72-76ED511A0D0B}"/>
+                <a16:creationId xmlns:a16="http://schemas.microsoft.com/office/drawing/2014/main" id="{EB763B1F-F575-913F-DB72-76ED511A0D0B}"/>
               </a:ext>
             </a:extLst>
           </p:cNvPr>
@@ -15711,7 +15711,7 @@
           <p:cNvPr id="4" name="Straight Arrow Connector 3">
             <a:extLst>
               <a:ext uri="{FF2B5EF4-FFF2-40B4-BE49-F238E27FC236}">
-                <ns2:creationId id="{A90A4078-7CAB-D43F-FE11-DE676579B333}"/>
+                <a16:creationId xmlns:a16="http://schemas.microsoft.com/office/drawing/2014/main" id="{A90A4078-7CAB-D43F-FE11-DE676579B333}"/>
               </a:ext>
             </a:extLst>
           </p:cNvPr>
@@ -15756,7 +15756,7 @@
           <p:cNvPr id="5" name="TextBox 4">
             <a:extLst>
               <a:ext uri="{FF2B5EF4-FFF2-40B4-BE49-F238E27FC236}">
-                <ns2:creationId id="{93EE6640-E2D5-2697-152F-1AC92ACF6299}"/>
+                <a16:creationId xmlns:a16="http://schemas.microsoft.com/office/drawing/2014/main" id="{93EE6640-E2D5-2697-152F-1AC92ACF6299}"/>
               </a:ext>
             </a:extLst>
           </p:cNvPr>
@@ -15821,7 +15821,7 @@
           <p:cNvPr id="8" name="TextBox 7">
             <a:extLst>
               <a:ext uri="{FF2B5EF4-FFF2-40B4-BE49-F238E27FC236}">
-                <ns2:creationId id="{C7F4CB60-409A-DA93-8D6D-DBB74A32F30C}"/>
+                <a16:creationId xmlns:a16="http://schemas.microsoft.com/office/drawing/2014/main" id="{C7F4CB60-409A-DA93-8D6D-DBB74A32F30C}"/>
               </a:ext>
             </a:extLst>
           </p:cNvPr>
@@ -15882,7 +15882,7 @@
           <p:cNvPr id="17" name="TextBox 16">
             <a:extLst>
               <a:ext uri="{FF2B5EF4-FFF2-40B4-BE49-F238E27FC236}">
-                <ns2:creationId id="{F4E68F9E-0E13-E904-E4B5-DEC42C339288}"/>
+                <a16:creationId xmlns:a16="http://schemas.microsoft.com/office/drawing/2014/main" id="{F4E68F9E-0E13-E904-E4B5-DEC42C339288}"/>
               </a:ext>
             </a:extLst>
           </p:cNvPr>
@@ -15966,7 +15966,7 @@
           <p:cNvPr id="31" name="Freeform 30">
             <a:extLst>
               <a:ext uri="{FF2B5EF4-FFF2-40B4-BE49-F238E27FC236}">
-                <ns2:creationId id="{EBDD718E-B038-498A-81E1-4720CA22C4E4}"/>
+                <a16:creationId xmlns:a16="http://schemas.microsoft.com/office/drawing/2014/main" id="{EBDD718E-B038-498A-81E1-4720CA22C4E4}"/>
               </a:ext>
             </a:extLst>
           </p:cNvPr>
@@ -16826,7 +16826,7 @@
           <p:cNvPr id="32" name="Oval 31">
             <a:extLst>
               <a:ext uri="{FF2B5EF4-FFF2-40B4-BE49-F238E27FC236}">
-                <ns2:creationId id="{852BC428-A99B-91EE-DF01-3864DEC4D4BF}"/>
+                <a16:creationId xmlns:a16="http://schemas.microsoft.com/office/drawing/2014/main" id="{852BC428-A99B-91EE-DF01-3864DEC4D4BF}"/>
               </a:ext>
             </a:extLst>
           </p:cNvPr>
@@ -16880,7 +16880,7 @@
           <p:cNvPr id="33" name="Oval 32">
             <a:extLst>
               <a:ext uri="{FF2B5EF4-FFF2-40B4-BE49-F238E27FC236}">
-                <ns2:creationId id="{EFBFF3EA-59F3-C535-EFC4-37E6E9B87AAA}"/>
+                <a16:creationId xmlns:a16="http://schemas.microsoft.com/office/drawing/2014/main" id="{EFBFF3EA-59F3-C535-EFC4-37E6E9B87AAA}"/>
               </a:ext>
             </a:extLst>
           </p:cNvPr>
@@ -16934,7 +16934,7 @@
           <p:cNvPr id="35" name="TextBox 34">
             <a:extLst>
               <a:ext uri="{FF2B5EF4-FFF2-40B4-BE49-F238E27FC236}">
-                <ns2:creationId id="{2A61F73B-4578-41C1-C8EB-DAA0E81D6643}"/>
+                <a16:creationId xmlns:a16="http://schemas.microsoft.com/office/drawing/2014/main" id="{2A61F73B-4578-41C1-C8EB-DAA0E81D6643}"/>
               </a:ext>
             </a:extLst>
           </p:cNvPr>
@@ -16943,8 +16943,8 @@
         </p:nvSpPr>
         <p:spPr>
           <a:xfrm>
-            <a:off x="7756549" y="900593"/>
-            <a:ext cx="4144429" cy="5078313"/>
+            <a:off x="7276358" y="764020"/>
+            <a:ext cx="4853148" cy="5262979"/>
           </a:xfrm>
           <a:prstGeom prst="rect">
             <a:avLst/>
@@ -16957,7 +16957,7 @@
           </a:bodyPr>
           <a:lstStyle/>
           <a:p>
-            <a:pPr marR="0" lvl="0" defTabSz="914400" rtl="0" eaLnBrk="1" fontAlgn="auto" latinLnBrk="0" hangingPunct="1">
+            <a:pPr marL="171450" marR="0" lvl="0" indent="-171450" defTabSz="914400" rtl="0" eaLnBrk="1" fontAlgn="auto" latinLnBrk="0" hangingPunct="1">
               <a:lnSpc>
                 <a:spcPct val="100000"/>
               </a:lnSpc>
@@ -16969,11 +16969,13 @@
               </a:spcAft>
               <a:buClrTx/>
               <a:buSzTx/>
+              <a:buFont typeface="Arial" panose="020B0604020202020204" pitchFamily="34" charset="0"/>
+              <a:buChar char="•"/>
               <a:tabLst/>
               <a:defRPr/>
             </a:pPr>
             <a:r>
-              <a:rPr kumimoji="0" lang="en-US" sz="1200" b="1" u="none" strike="noStrike" kern="1200" cap="none" spc="0" normalizeH="0" baseline="0" noProof="0" dirty="0">
+              <a:rPr kumimoji="0" lang="en-US" sz="1400" b="1" u="none" strike="noStrike" kern="1200" cap="none" spc="0" normalizeH="0" baseline="0" noProof="0" dirty="0">
                 <a:ln>
                   <a:noFill/>
                 </a:ln>
@@ -16991,14 +16993,22 @@
             </a:r>
           </a:p>
           <a:p>
-            <a:pPr lvl="1">
+            <a:pPr marL="628650" lvl="1" indent="-171450">
+              <a:buFont typeface="Arial" panose="020B0604020202020204" pitchFamily="34" charset="0"/>
+              <a:buChar char="•"/>
               <a:defRPr/>
             </a:pPr>
             <a:r>
-              <a:rPr lang="en-US" sz="1200" dirty="0">
+              <a:rPr kumimoji="0" lang="en-US" sz="1400" b="1" u="none" strike="noStrike" kern="1200" cap="none" spc="0" normalizeH="0" baseline="0" noProof="0" dirty="0">
+                <a:ln>
+                  <a:noFill/>
+                </a:ln>
                 <a:solidFill>
                   <a:prstClr val="white"/>
                 </a:solidFill>
+                <a:effectLst/>
+                <a:uLnTx/>
+                <a:uFillTx/>
                 <a:latin typeface="Helvetica Neue" panose="02000503000000020004" pitchFamily="2" charset="0"/>
                 <a:ea typeface="Helvetica Neue" panose="02000503000000020004" pitchFamily="2" charset="0"/>
                 <a:cs typeface="Helvetica Neue" panose="02000503000000020004" pitchFamily="2" charset="0"/>
@@ -17007,14 +17017,34 @@
             </a:r>
           </a:p>
           <a:p>
-            <a:pPr lvl="1">
+            <a:pPr marL="171450" marR="0" lvl="0" indent="-171450" defTabSz="914400" rtl="0" eaLnBrk="1" fontAlgn="auto" latinLnBrk="0" hangingPunct="1">
+              <a:lnSpc>
+                <a:spcPct val="100000"/>
+              </a:lnSpc>
+              <a:spcBef>
+                <a:spcPts val="0"/>
+              </a:spcBef>
+              <a:spcAft>
+                <a:spcPts val="0"/>
+              </a:spcAft>
+              <a:buClrTx/>
+              <a:buSzTx/>
+              <a:buFont typeface="Arial" panose="020B0604020202020204" pitchFamily="34" charset="0"/>
+              <a:buChar char="•"/>
+              <a:tabLst/>
               <a:defRPr/>
             </a:pPr>
             <a:r>
-              <a:rPr lang="en-US" sz="1200" dirty="0">
+              <a:rPr kumimoji="0" lang="en-US" sz="1400" b="1" u="none" strike="noStrike" kern="1200" cap="none" spc="0" normalizeH="0" baseline="0" noProof="0" dirty="0">
+                <a:ln>
+                  <a:noFill/>
+                </a:ln>
                 <a:solidFill>
                   <a:prstClr val="white"/>
                 </a:solidFill>
+                <a:effectLst/>
+                <a:uLnTx/>
+                <a:uFillTx/>
                 <a:latin typeface="Helvetica Neue" panose="02000503000000020004" pitchFamily="2" charset="0"/>
                 <a:ea typeface="Helvetica Neue" panose="02000503000000020004" pitchFamily="2" charset="0"/>
                 <a:cs typeface="Helvetica Neue" panose="02000503000000020004" pitchFamily="2" charset="0"/>
@@ -17023,7 +17053,31 @@
             </a:r>
           </a:p>
           <a:p>
-            <a:pPr marR="0" lvl="0" defTabSz="914400" rtl="0" eaLnBrk="1" fontAlgn="auto" latinLnBrk="0" hangingPunct="1">
+            <a:pPr marL="628650" lvl="1" indent="-171450">
+              <a:buFont typeface="Arial" panose="020B0604020202020204" pitchFamily="34" charset="0"/>
+              <a:buChar char="•"/>
+              <a:defRPr/>
+            </a:pPr>
+            <a:r>
+              <a:rPr kumimoji="0" lang="en-US" sz="1400" b="1" u="none" strike="noStrike" kern="1200" cap="none" spc="0" normalizeH="0" baseline="0" noProof="0" dirty="0">
+                <a:ln>
+                  <a:noFill/>
+                </a:ln>
+                <a:solidFill>
+                  <a:prstClr val="white"/>
+                </a:solidFill>
+                <a:effectLst/>
+                <a:uLnTx/>
+                <a:uFillTx/>
+                <a:latin typeface="Helvetica Neue" panose="02000503000000020004" pitchFamily="2" charset="0"/>
+                <a:ea typeface="Helvetica Neue" panose="02000503000000020004" pitchFamily="2" charset="0"/>
+                <a:cs typeface="Helvetica Neue" panose="02000503000000020004" pitchFamily="2" charset="0"/>
+              </a:rPr>
+              <a:t>fixed 3D space with no preferred origin or direction</a:t>
+            </a:r>
+          </a:p>
+          <a:p>
+            <a:pPr marL="171450" marR="0" lvl="0" indent="-171450" defTabSz="914400" rtl="0" eaLnBrk="1" fontAlgn="auto" latinLnBrk="0" hangingPunct="1">
               <a:lnSpc>
                 <a:spcPct val="100000"/>
               </a:lnSpc>
@@ -17035,46 +17089,22 @@
               </a:spcAft>
               <a:buClrTx/>
               <a:buSzTx/>
+              <a:buFont typeface="Arial" panose="020B0604020202020204" pitchFamily="34" charset="0"/>
+              <a:buChar char="•"/>
               <a:tabLst/>
               <a:defRPr/>
             </a:pPr>
             <a:r>
-              <a:rPr lang="en-US" sz="1200" b="1" dirty="0">
+              <a:rPr kumimoji="0" lang="en-US" sz="1400" b="1" u="none" strike="noStrike" kern="1200" cap="none" spc="0" normalizeH="0" baseline="0" noProof="0" dirty="0">
+                <a:ln>
+                  <a:noFill/>
+                </a:ln>
                 <a:solidFill>
                   <a:prstClr val="white"/>
                 </a:solidFill>
-                <a:latin typeface="Helvetica Neue" panose="02000503000000020004" pitchFamily="2" charset="0"/>
-                <a:ea typeface="Helvetica Neue" panose="02000503000000020004" pitchFamily="2" charset="0"/>
-                <a:cs typeface="Helvetica Neue" panose="02000503000000020004" pitchFamily="2" charset="0"/>
-              </a:rPr>
-              <a:t>fixed 3D space</a:t>
-            </a:r>
-          </a:p>
-          <a:p>
-            <a:pPr lvl="1">
-              <a:defRPr/>
-            </a:pPr>
-            <a:r>
-              <a:rPr lang="en-US" sz="1200" dirty="0">
-                <a:solidFill>
-                  <a:prstClr val="white"/>
-                </a:solidFill>
-                <a:latin typeface="Helvetica Neue" panose="02000503000000020004" pitchFamily="2" charset="0"/>
-                <a:ea typeface="Helvetica Neue" panose="02000503000000020004" pitchFamily="2" charset="0"/>
-                <a:cs typeface="Helvetica Neue" panose="02000503000000020004" pitchFamily="2" charset="0"/>
-              </a:rPr>
-              <a:t>no preferred origin or direction</a:t>
-            </a:r>
-          </a:p>
-          <a:p>
-            <a:pPr lvl="1">
-              <a:defRPr/>
-            </a:pPr>
-            <a:r>
-              <a:rPr lang="en-US" sz="1200" dirty="0">
-                <a:solidFill>
-                  <a:prstClr val="white"/>
-                </a:solidFill>
+                <a:effectLst/>
+                <a:uLnTx/>
+                <a:uFillTx/>
                 <a:latin typeface="Helvetica Neue" panose="02000503000000020004" pitchFamily="2" charset="0"/>
                 <a:ea typeface="Helvetica Neue" panose="02000503000000020004" pitchFamily="2" charset="0"/>
                 <a:cs typeface="Helvetica Neue" panose="02000503000000020004" pitchFamily="2" charset="0"/>
@@ -17083,26 +17113,22 @@
             </a:r>
           </a:p>
           <a:p>
-            <a:pPr marR="0" lvl="0" defTabSz="914400" rtl="0" eaLnBrk="1" fontAlgn="auto" latinLnBrk="0" hangingPunct="1">
-              <a:lnSpc>
-                <a:spcPct val="100000"/>
-              </a:lnSpc>
-              <a:spcBef>
-                <a:spcPts val="0"/>
-              </a:spcBef>
-              <a:spcAft>
-                <a:spcPts val="0"/>
-              </a:spcAft>
-              <a:buClrTx/>
-              <a:buSzTx/>
-              <a:tabLst/>
+            <a:pPr marL="628650" lvl="1" indent="-171450">
+              <a:buFont typeface="Arial" panose="020B0604020202020204" pitchFamily="34" charset="0"/>
+              <a:buChar char="•"/>
               <a:defRPr/>
             </a:pPr>
             <a:r>
-              <a:rPr lang="en-US" sz="1200" b="1" dirty="0">
+              <a:rPr kumimoji="0" lang="en-US" sz="1400" b="1" u="none" strike="noStrike" kern="1200" cap="none" spc="0" normalizeH="0" baseline="0" noProof="0" dirty="0">
+                <a:ln>
+                  <a:noFill/>
+                </a:ln>
                 <a:solidFill>
                   <a:prstClr val="white"/>
                 </a:solidFill>
+                <a:effectLst/>
+                <a:uLnTx/>
+                <a:uFillTx/>
                 <a:latin typeface="Helvetica Neue" panose="02000503000000020004" pitchFamily="2" charset="0"/>
                 <a:ea typeface="Helvetica Neue" panose="02000503000000020004" pitchFamily="2" charset="0"/>
                 <a:cs typeface="Helvetica Neue" panose="02000503000000020004" pitchFamily="2" charset="0"/>
@@ -17111,14 +17137,22 @@
             </a:r>
           </a:p>
           <a:p>
-            <a:pPr lvl="1">
+            <a:pPr marL="628650" lvl="1" indent="-171450">
+              <a:buFont typeface="Arial" panose="020B0604020202020204" pitchFamily="34" charset="0"/>
+              <a:buChar char="•"/>
               <a:defRPr/>
             </a:pPr>
             <a:r>
-              <a:rPr lang="en-US" sz="1200" dirty="0">
+              <a:rPr kumimoji="0" lang="en-US" sz="1400" b="1" u="none" strike="noStrike" kern="1200" cap="none" spc="0" normalizeH="0" baseline="0" noProof="0" dirty="0">
+                <a:ln>
+                  <a:noFill/>
+                </a:ln>
                 <a:solidFill>
                   <a:prstClr val="white"/>
                 </a:solidFill>
+                <a:effectLst/>
+                <a:uLnTx/>
+                <a:uFillTx/>
                 <a:latin typeface="Helvetica Neue" panose="02000503000000020004" pitchFamily="2" charset="0"/>
                 <a:ea typeface="Helvetica Neue" panose="02000503000000020004" pitchFamily="2" charset="0"/>
                 <a:cs typeface="Helvetica Neue" panose="02000503000000020004" pitchFamily="2" charset="0"/>
@@ -17127,46 +17161,58 @@
             </a:r>
           </a:p>
           <a:p>
-            <a:pPr lvl="1">
+            <a:pPr marL="628650" lvl="1" indent="-171450">
+              <a:buFont typeface="Arial" panose="020B0604020202020204" pitchFamily="34" charset="0"/>
+              <a:buChar char="•"/>
               <a:defRPr/>
             </a:pPr>
             <a:r>
-              <a:rPr lang="en-US" sz="1200" dirty="0">
+              <a:rPr kumimoji="0" lang="en-US" sz="1400" b="1" u="none" strike="noStrike" kern="1200" cap="none" spc="0" normalizeH="0" baseline="0" noProof="0" dirty="0">
+                <a:ln>
+                  <a:noFill/>
+                </a:ln>
                 <a:solidFill>
                   <a:prstClr val="white"/>
                 </a:solidFill>
+                <a:effectLst/>
+                <a:uLnTx/>
+                <a:uFillTx/>
                 <a:latin typeface="Helvetica Neue" panose="02000503000000020004" pitchFamily="2" charset="0"/>
                 <a:ea typeface="Helvetica Neue" panose="02000503000000020004" pitchFamily="2" charset="0"/>
                 <a:cs typeface="Helvetica Neue" panose="02000503000000020004" pitchFamily="2" charset="0"/>
               </a:rPr>
-              <a:t>carry path history in absolute time and space</a:t>
+              <a:t>carry path history and can move faster than wake speed</a:t>
             </a:r>
           </a:p>
           <a:p>
-            <a:pPr lvl="1">
+            <a:pPr marL="171450" marR="0" lvl="0" indent="-171450" defTabSz="914400" rtl="0" eaLnBrk="1" fontAlgn="auto" latinLnBrk="0" hangingPunct="1">
+              <a:lnSpc>
+                <a:spcPct val="100000"/>
+              </a:lnSpc>
+              <a:spcBef>
+                <a:spcPts val="0"/>
+              </a:spcBef>
+              <a:spcAft>
+                <a:spcPts val="0"/>
+              </a:spcAft>
+              <a:buClrTx/>
+              <a:buSzTx/>
+              <a:buFont typeface="Arial" panose="020B0604020202020204" pitchFamily="34" charset="0"/>
+              <a:buChar char="•"/>
+              <a:tabLst/>
               <a:defRPr/>
             </a:pPr>
             <a:r>
-              <a:rPr lang="en-US" sz="1200" dirty="0">
+              <a:rPr kumimoji="0" lang="en-US" sz="1400" b="1" u="none" strike="noStrike" kern="1200" cap="none" spc="0" normalizeH="0" baseline="0" noProof="0" dirty="0">
+                <a:ln>
+                  <a:noFill/>
+                </a:ln>
                 <a:solidFill>
                   <a:prstClr val="white"/>
                 </a:solidFill>
-                <a:latin typeface="Helvetica Neue" panose="02000503000000020004" pitchFamily="2" charset="0"/>
-                <a:ea typeface="Helvetica Neue" panose="02000503000000020004" pitchFamily="2" charset="0"/>
-                <a:cs typeface="Helvetica Neue" panose="02000503000000020004" pitchFamily="2" charset="0"/>
-              </a:rPr>
-              <a:t>can move faster than wake speed</a:t>
-            </a:r>
-          </a:p>
-          <a:p>
-            <a:pPr lvl="1">
-              <a:defRPr/>
-            </a:pPr>
-            <a:r>
-              <a:rPr lang="en-US" sz="1200" dirty="0">
-                <a:solidFill>
-                  <a:prstClr val="white"/>
-                </a:solidFill>
+                <a:effectLst/>
+                <a:uLnTx/>
+                <a:uFillTx/>
                 <a:latin typeface="Helvetica Neue" panose="02000503000000020004" pitchFamily="2" charset="0"/>
                 <a:ea typeface="Helvetica Neue" panose="02000503000000020004" pitchFamily="2" charset="0"/>
                 <a:cs typeface="Helvetica Neue" panose="02000503000000020004" pitchFamily="2" charset="0"/>
@@ -17175,23 +17221,31 @@
             </a:r>
           </a:p>
           <a:p>
-            <a:pPr lvl="1">
+            <a:pPr marL="628650" lvl="1" indent="-171450">
+              <a:buFont typeface="Arial" panose="020B0604020202020204" pitchFamily="34" charset="0"/>
+              <a:buChar char="•"/>
               <a:defRPr/>
             </a:pPr>
             <a:r>
-              <a:rPr lang="en-US" sz="1200" dirty="0">
+              <a:rPr kumimoji="0" lang="en-US" sz="1400" b="1" u="none" strike="noStrike" kern="1200" cap="none" spc="0" normalizeH="0" baseline="0" noProof="0" dirty="0">
+                <a:ln>
+                  <a:noFill/>
+                </a:ln>
                 <a:solidFill>
                   <a:prstClr val="white"/>
                 </a:solidFill>
+                <a:effectLst/>
+                <a:uLnTx/>
+                <a:uFillTx/>
                 <a:latin typeface="Helvetica Neue" panose="02000503000000020004" pitchFamily="2" charset="0"/>
                 <a:ea typeface="Helvetica Neue" panose="02000503000000020004" pitchFamily="2" charset="0"/>
                 <a:cs typeface="Helvetica Neue" panose="02000503000000020004" pitchFamily="2" charset="0"/>
               </a:rPr>
-              <a:t>continuous history through time and space</a:t>
+              <a:t>continuous record of polarity, time, position, and velocity</a:t>
             </a:r>
           </a:p>
           <a:p>
-            <a:pPr marR="0" lvl="0" defTabSz="914400" rtl="0" eaLnBrk="1" fontAlgn="auto" latinLnBrk="0" hangingPunct="1">
+            <a:pPr marL="171450" marR="0" lvl="0" indent="-171450" defTabSz="914400" rtl="0" eaLnBrk="1" fontAlgn="auto" latinLnBrk="0" hangingPunct="1">
               <a:lnSpc>
                 <a:spcPct val="100000"/>
               </a:lnSpc>
@@ -17203,30 +17257,22 @@
               </a:spcAft>
               <a:buClrTx/>
               <a:buSzTx/>
+              <a:buFont typeface="Arial" panose="020B0604020202020204" pitchFamily="34" charset="0"/>
+              <a:buChar char="•"/>
               <a:tabLst/>
               <a:defRPr/>
             </a:pPr>
             <a:r>
-              <a:rPr lang="en-US" sz="1200" b="1" baseline="0" dirty="0">
+              <a:rPr kumimoji="0" lang="en-US" sz="1400" b="1" u="none" strike="noStrike" kern="1200" cap="none" spc="0" normalizeH="0" baseline="0" noProof="0" dirty="0">
+                <a:ln>
+                  <a:noFill/>
+                </a:ln>
                 <a:solidFill>
                   <a:prstClr val="white"/>
                 </a:solidFill>
-                <a:latin typeface="Helvetica Neue" panose="02000503000000020004" pitchFamily="2" charset="0"/>
-                <a:ea typeface="Helvetica Neue" panose="02000503000000020004" pitchFamily="2" charset="0"/>
-                <a:cs typeface="Helvetica Neue" panose="02000503000000020004" pitchFamily="2" charset="0"/>
-              </a:rPr>
-              <a:t>record polarity, time, position, and velocity</a:t>
-            </a:r>
-          </a:p>
-          <a:p>
-            <a:pPr lvl="1">
-              <a:defRPr/>
-            </a:pPr>
-            <a:r>
-              <a:rPr lang="en-US" sz="1200" dirty="0">
-                <a:solidFill>
-                  <a:prstClr val="white"/>
-                </a:solidFill>
+                <a:effectLst/>
+                <a:uLnTx/>
+                <a:uFillTx/>
                 <a:latin typeface="Helvetica Neue" panose="02000503000000020004" pitchFamily="2" charset="0"/>
                 <a:ea typeface="Helvetica Neue" panose="02000503000000020004" pitchFamily="2" charset="0"/>
                 <a:cs typeface="Helvetica Neue" panose="02000503000000020004" pitchFamily="2" charset="0"/>
@@ -17235,78 +17281,82 @@
             </a:r>
           </a:p>
           <a:p>
-            <a:pPr lvl="1">
+            <a:pPr marL="628650" lvl="1" indent="-171450">
+              <a:buFont typeface="Arial" panose="020B0604020202020204" pitchFamily="34" charset="0"/>
+              <a:buChar char="•"/>
               <a:defRPr/>
             </a:pPr>
             <a:r>
-              <a:rPr lang="en-US" sz="1200" dirty="0">
+              <a:rPr kumimoji="0" lang="en-US" sz="1400" b="1" u="none" strike="noStrike" kern="1200" cap="none" spc="0" normalizeH="0" baseline="0" noProof="0" dirty="0">
+                <a:ln>
+                  <a:noFill/>
+                </a:ln>
                 <a:solidFill>
                   <a:prstClr val="white"/>
                 </a:solidFill>
+                <a:effectLst/>
+                <a:uLnTx/>
+                <a:uFillTx/>
                 <a:latin typeface="Helvetica Neue" panose="02000503000000020004" pitchFamily="2" charset="0"/>
                 <a:ea typeface="Helvetica Neue" panose="02000503000000020004" pitchFamily="2" charset="0"/>
                 <a:cs typeface="Helvetica Neue" panose="02000503000000020004" pitchFamily="2" charset="0"/>
               </a:rPr>
-              <a:t>emitted along the path</a:t>
+              <a:t>emitted along the path at a steady polarity-source rate</a:t>
             </a:r>
           </a:p>
           <a:p>
-            <a:pPr>
+            <a:pPr marL="628650" lvl="1" indent="-171450">
+              <a:buFont typeface="Arial" panose="020B0604020202020204" pitchFamily="34" charset="0"/>
+              <a:buChar char="•"/>
               <a:defRPr/>
             </a:pPr>
             <a:r>
-              <a:rPr lang="en-US" sz="1200" b="1" dirty="0">
+              <a:rPr kumimoji="0" lang="en-US" sz="1400" b="1" u="none" strike="noStrike" kern="1200" cap="none" spc="0" normalizeH="0" baseline="0" noProof="0" dirty="0">
+                <a:ln>
+                  <a:noFill/>
+                </a:ln>
                 <a:solidFill>
                   <a:prstClr val="white"/>
                 </a:solidFill>
+                <a:effectLst/>
+                <a:uLnTx/>
+                <a:uFillTx/>
                 <a:latin typeface="Helvetica Neue" panose="02000503000000020004" pitchFamily="2" charset="0"/>
                 <a:ea typeface="Helvetica Neue" panose="02000503000000020004" pitchFamily="2" charset="0"/>
                 <a:cs typeface="Helvetica Neue" panose="02000503000000020004" pitchFamily="2" charset="0"/>
               </a:rPr>
-              <a:t>steady polarity-source rate</a:t>
+              <a:t>wake surfaces grow at wake speed</a:t>
             </a:r>
           </a:p>
           <a:p>
-            <a:pPr lvl="1">
+            <a:pPr marL="171450" marR="0" lvl="0" indent="-171450" defTabSz="914400" rtl="0" eaLnBrk="1" fontAlgn="auto" latinLnBrk="0" hangingPunct="1">
+              <a:lnSpc>
+                <a:spcPct val="100000"/>
+              </a:lnSpc>
+              <a:spcBef>
+                <a:spcPts val="0"/>
+              </a:spcBef>
+              <a:spcAft>
+                <a:spcPts val="0"/>
+              </a:spcAft>
+              <a:buClrTx/>
+              <a:buSzTx/>
+              <a:buFont typeface="Arial" panose="020B0604020202020204" pitchFamily="34" charset="0"/>
+              <a:buChar char="•"/>
+              <a:tabLst/>
               <a:defRPr/>
             </a:pPr>
             <a:r>
-              <a:rPr lang="en-US" sz="1200" dirty="0">
+              <a:rPr kumimoji="0" lang="en-US" sz="1400" b="1" u="none" strike="noStrike" kern="1200" cap="none" spc="0" normalizeH="0" baseline="0" noProof="0" dirty="0">
+                <a:ln>
+                  <a:noFill/>
+                </a:ln>
                 <a:solidFill>
                   <a:prstClr val="white"/>
                 </a:solidFill>
-                <a:latin typeface="Helvetica Neue" panose="02000503000000020004" pitchFamily="2" charset="0"/>
-                <a:ea typeface="Helvetica Neue" panose="02000503000000020004" pitchFamily="2" charset="0"/>
-                <a:cs typeface="Helvetica Neue" panose="02000503000000020004" pitchFamily="2" charset="0"/>
-              </a:rPr>
-              <a:t>wake surface</a:t>
-            </a:r>
-          </a:p>
-          <a:p>
-            <a:pPr lvl="1">
-              <a:defRPr/>
-            </a:pPr>
-            <a:r>
-              <a:rPr lang="en-US" sz="1200" baseline="0" dirty="0">
-                <a:solidFill>
-                  <a:prstClr val="white"/>
-                </a:solidFill>
-                <a:latin typeface="Helvetica Neue" panose="02000503000000020004" pitchFamily="2" charset="0"/>
-                <a:ea typeface="Helvetica Neue" panose="02000503000000020004" pitchFamily="2" charset="0"/>
-                <a:cs typeface="Helvetica Neue" panose="02000503000000020004" pitchFamily="2" charset="0"/>
-              </a:rPr>
-              <a:t>grows at wake speed</a:t>
-            </a:r>
-          </a:p>
-          <a:p>
-            <a:pPr lvl="1">
-              <a:defRPr/>
-            </a:pPr>
-            <a:r>
-              <a:rPr lang="en-US" sz="1200" dirty="0">
-                <a:solidFill>
-                  <a:prstClr val="white"/>
-                </a:solidFill>
+                <a:effectLst/>
+                <a:uLnTx/>
+                <a:uFillTx/>
                 <a:latin typeface="Helvetica Neue" panose="02000503000000020004" pitchFamily="2" charset="0"/>
                 <a:ea typeface="Helvetica Neue" panose="02000503000000020004" pitchFamily="2" charset="0"/>
                 <a:cs typeface="Helvetica Neue" panose="02000503000000020004" pitchFamily="2" charset="0"/>
@@ -17315,89 +17365,73 @@
             </a:r>
           </a:p>
           <a:p>
-            <a:pPr lvl="1">
+            <a:pPr marL="628650" lvl="1" indent="-171450">
+              <a:buFont typeface="Arial" panose="020B0604020202020204" pitchFamily="34" charset="0"/>
+              <a:buChar char="•"/>
               <a:defRPr/>
             </a:pPr>
             <a:r>
-              <a:rPr lang="en-US" sz="1200" baseline="0" dirty="0">
+              <a:rPr kumimoji="0" lang="en-US" sz="1400" b="1" u="none" strike="noStrike" kern="1200" cap="none" spc="0" normalizeH="0" baseline="0" noProof="0" dirty="0">
+                <a:ln>
+                  <a:noFill/>
+                </a:ln>
                 <a:solidFill>
                   <a:prstClr val="white"/>
                 </a:solidFill>
+                <a:effectLst/>
+                <a:uLnTx/>
+                <a:uFillTx/>
                 <a:latin typeface="Helvetica Neue" panose="02000503000000020004" pitchFamily="2" charset="0"/>
                 <a:ea typeface="Helvetica Neue" panose="02000503000000020004" pitchFamily="2" charset="0"/>
                 <a:cs typeface="Helvetica Neue" panose="02000503000000020004" pitchFamily="2" charset="0"/>
               </a:rPr>
-              <a:t>received at the current time</a:t>
+              <a:t>received when a receiver meets a wake surface</a:t>
             </a:r>
           </a:p>
           <a:p>
-            <a:pPr lvl="1">
+            <a:pPr marL="628650" lvl="1" indent="-171450">
+              <a:buFont typeface="Arial" panose="020B0604020202020204" pitchFamily="34" charset="0"/>
+              <a:buChar char="•"/>
               <a:defRPr/>
             </a:pPr>
             <a:r>
-              <a:rPr lang="en-US" sz="1200" dirty="0">
+              <a:rPr kumimoji="0" lang="en-US" sz="1400" b="1" u="none" strike="noStrike" kern="1200" cap="none" spc="0" normalizeH="0" baseline="0" noProof="0" dirty="0">
+                <a:ln>
+                  <a:noFill/>
+                </a:ln>
                 <a:solidFill>
                   <a:prstClr val="white"/>
                 </a:solidFill>
+                <a:effectLst/>
+                <a:uLnTx/>
+                <a:uFillTx/>
                 <a:latin typeface="Helvetica Neue" panose="02000503000000020004" pitchFamily="2" charset="0"/>
                 <a:ea typeface="Helvetica Neue" panose="02000503000000020004" pitchFamily="2" charset="0"/>
                 <a:cs typeface="Helvetica Neue" panose="02000503000000020004" pitchFamily="2" charset="0"/>
               </a:rPr>
-              <a:t>where a receiver meets a wake surface</a:t>
+              <a:t>many hits add together, and the net response changes the path</a:t>
             </a:r>
           </a:p>
           <a:p>
-            <a:pPr>
+            <a:pPr marL="171450" marR="0" lvl="0" indent="-171450" defTabSz="914400" rtl="0" eaLnBrk="1" fontAlgn="auto" latinLnBrk="0" hangingPunct="1">
+              <a:lnSpc>
+                <a:spcPct val="100000"/>
+              </a:lnSpc>
+              <a:spcBef>
+                <a:spcPts val="0"/>
+              </a:spcBef>
+              <a:spcAft>
+                <a:spcPts val="0"/>
+              </a:spcAft>
+              <a:buClrTx/>
+              <a:buSzTx/>
+              <a:buFont typeface="Arial" panose="020B0604020202020204" pitchFamily="34" charset="0"/>
+              <a:buChar char="•"/>
+              <a:tabLst/>
               <a:defRPr/>
             </a:pPr>
             <a:r>
-              <a:rPr lang="en-US" sz="1200" b="1" dirty="0">
-                <a:solidFill>
-                  <a:prstClr val="white"/>
-                </a:solidFill>
-                <a:latin typeface="Helvetica Neue" panose="02000503000000020004" pitchFamily="2" charset="0"/>
-                <a:ea typeface="Helvetica Neue" panose="02000503000000020004" pitchFamily="2" charset="0"/>
-                <a:cs typeface="Helvetica Neue" panose="02000503000000020004" pitchFamily="2" charset="0"/>
-              </a:rPr>
-              <a:t>many hits add together</a:t>
-            </a:r>
-          </a:p>
-          <a:p>
-            <a:pPr lvl="1">
-              <a:defRPr/>
-            </a:pPr>
-            <a:r>
-              <a:rPr lang="en-US" sz="1200" dirty="0">
-                <a:solidFill>
-                  <a:prstClr val="white"/>
-                </a:solidFill>
-                <a:latin typeface="Helvetica Neue" panose="02000503000000020004" pitchFamily="2" charset="0"/>
-                <a:ea typeface="Helvetica Neue" panose="02000503000000020004" pitchFamily="2" charset="0"/>
-                <a:cs typeface="Helvetica Neue" panose="02000503000000020004" pitchFamily="2" charset="0"/>
-              </a:rPr>
-              <a:t>net response changes the path</a:t>
-            </a:r>
-            <a:endParaRPr kumimoji="0" lang="en-US" sz="1200" u="none" strike="noStrike" kern="1200" cap="none" spc="0" normalizeH="0" baseline="-25000" noProof="0" dirty="0">
-              <a:ln>
-                <a:noFill/>
-              </a:ln>
-              <a:solidFill>
-                <a:prstClr val="white"/>
-              </a:solidFill>
-              <a:effectLst/>
-              <a:uLnTx/>
-              <a:uFillTx/>
-              <a:latin typeface="Helvetica Neue" panose="02000503000000020004" pitchFamily="2" charset="0"/>
-              <a:ea typeface="Helvetica Neue" panose="02000503000000020004" pitchFamily="2" charset="0"/>
-              <a:cs typeface="Helvetica Neue" panose="02000503000000020004" pitchFamily="2" charset="0"/>
-            </a:endParaRPr>
-          </a:p>
-          <a:p>
-            <a:pPr lvl="1">
-              <a:defRPr/>
-            </a:pPr>
-            <a:r>
-              <a:rPr kumimoji="0" lang="en-US" sz="1200" u="none" strike="noStrike" kern="1200" cap="none" spc="0" normalizeH="0" baseline="0" noProof="0" dirty="0">
+              <a:rPr kumimoji="0" lang="en-US" sz="1400" b="1" u="none" strike="noStrike" kern="1200" cap="none" spc="0" normalizeH="0" baseline="0" noProof="0" dirty="0">
                 <a:ln>
                   <a:noFill/>
                 </a:ln>
@@ -17415,27 +17449,13 @@
             </a:r>
           </a:p>
           <a:p>
-            <a:pPr lvl="1">
+            <a:pPr marL="628650" lvl="1" indent="-171450">
+              <a:buFont typeface="Arial" panose="020B0604020202020204" pitchFamily="34" charset="0"/>
+              <a:buChar char="•"/>
               <a:defRPr/>
             </a:pPr>
             <a:r>
-              <a:rPr lang="en-US" sz="1200" dirty="0">
-                <a:solidFill>
-                  <a:prstClr val="white"/>
-                </a:solidFill>
-                <a:latin typeface="Helvetica Neue" panose="02000503000000020004" pitchFamily="2" charset="0"/>
-                <a:ea typeface="Helvetica Neue" panose="02000503000000020004" pitchFamily="2" charset="0"/>
-                <a:cs typeface="Helvetica Neue" panose="02000503000000020004" pitchFamily="2" charset="0"/>
-              </a:rPr>
-              <a:t>population density</a:t>
-            </a:r>
-          </a:p>
-          <a:p>
-            <a:pPr lvl="1">
-              <a:defRPr/>
-            </a:pPr>
-            <a:r>
-              <a:rPr kumimoji="0" lang="en-US" sz="1200" u="none" strike="noStrike" kern="1200" cap="none" spc="0" normalizeH="0" baseline="0" noProof="0" dirty="0">
+              <a:rPr kumimoji="0" lang="en-US" sz="1400" b="1" u="none" strike="noStrike" kern="1200" cap="none" spc="0" normalizeH="0" baseline="0" noProof="0" dirty="0">
                 <a:ln>
                   <a:noFill/>
                 </a:ln>
@@ -17449,41 +17469,7 @@
                 <a:ea typeface="Helvetica Neue" panose="02000503000000020004" pitchFamily="2" charset="0"/>
                 <a:cs typeface="Helvetica Neue" panose="02000503000000020004" pitchFamily="2" charset="0"/>
               </a:rPr>
-              <a:t>energy carried by architrino assemblies</a:t>
-            </a:r>
-          </a:p>
-          <a:p>
-            <a:pPr marR="0" lvl="0" defTabSz="914400" rtl="0" eaLnBrk="1" fontAlgn="auto" latinLnBrk="0" hangingPunct="1">
-              <a:lnSpc>
-                <a:spcPct val="100000"/>
-              </a:lnSpc>
-              <a:spcBef>
-                <a:spcPts val="0"/>
-              </a:spcBef>
-              <a:spcAft>
-                <a:spcPts val="0"/>
-              </a:spcAft>
-              <a:buClrTx/>
-              <a:buSzTx/>
-              <a:tabLst/>
-              <a:defRPr/>
-            </a:pPr>
-            <a:r>
-              <a:rPr kumimoji="0" lang="en-US" sz="1200" b="1" u="none" strike="noStrike" kern="1200" cap="none" spc="0" normalizeH="0" baseline="0" noProof="0" dirty="0">
-                <a:ln>
-                  <a:noFill/>
-                </a:ln>
-                <a:solidFill>
-                  <a:prstClr val="white"/>
-                </a:solidFill>
-                <a:effectLst/>
-                <a:uLnTx/>
-                <a:uFillTx/>
-                <a:latin typeface="Helvetica Neue" panose="02000503000000020004" pitchFamily="2" charset="0"/>
-                <a:ea typeface="Helvetica Neue" panose="02000503000000020004" pitchFamily="2" charset="0"/>
-                <a:cs typeface="Helvetica Neue" panose="02000503000000020004" pitchFamily="2" charset="0"/>
-              </a:rPr>
-              <a:t>locally balanced polarity distribution</a:t>
+              <a:t>population density, assembly energy, and locally balanced polarity</a:t>
             </a:r>
           </a:p>
         </p:txBody>
@@ -17491,7 +17477,7 @@
     </p:spTree>
     <p:extLst>
       <p:ext uri="{BB962C8B-B14F-4D97-AF65-F5344CB8AC3E}">
-        <p14:creationId val="3144987668"/>
+        <p14:creationId xmlns:p14="http://schemas.microsoft.com/office/powerpoint/2010/main" val="3144987668"/>
       </p:ext>
     </p:extLst>
   </p:cSld>
@@ -17502,7 +17488,7 @@
 </file>
 
 <file path=ppt/slides/slide13.xml><?xml version="1.0" encoding="utf-8"?>
-<p:sld xmlns:a="http://schemas.openxmlformats.org/drawingml/2006/main" xmlns:ns2="http://schemas.microsoft.com/office/drawing/2014/main" xmlns:p="http://schemas.openxmlformats.org/presentationml/2006/main" xmlns:p14="http://schemas.microsoft.com/office/powerpoint/2010/main" xmlns:r="http://schemas.openxmlformats.org/officeDocument/2006/relationships">
+<p:sld xmlns:a="http://schemas.openxmlformats.org/drawingml/2006/main" xmlns:r="http://schemas.openxmlformats.org/officeDocument/2006/relationships" xmlns:p="http://schemas.openxmlformats.org/presentationml/2006/main">
   <p:cSld>
     <p:bg>
       <p:bgPr>
@@ -17531,7 +17517,7 @@
           <p:cNvPr id="4" name="TextBox 3">
             <a:extLst>
               <a:ext uri="{FF2B5EF4-FFF2-40B4-BE49-F238E27FC236}">
-                <ns2:creationId id="{04089B0C-3E0D-1D7D-7623-E8C4B9A7F9B0}"/>
+                <a16:creationId xmlns:a16="http://schemas.microsoft.com/office/drawing/2014/main" id="{04089B0C-3E0D-1D7D-7623-E8C4B9A7F9B0}"/>
               </a:ext>
             </a:extLst>
           </p:cNvPr>
@@ -17586,32 +17572,11 @@
                 <a:ea typeface="Helvetica Neue" panose="02000503000000020004" pitchFamily="2" charset="0"/>
                 <a:cs typeface="Helvetica Neue" panose="02000503000000020004" pitchFamily="2" charset="0"/>
               </a:rPr>
-              <a:t>Use a 1D test case with two architrino emitters and wake speed.</a:t>
+              <a:t>Use a 1D two-body test: two architrinos and one wake speed.</a:t>
             </a:r>
           </a:p>
           <a:p>
-            <a:r>
-              <a:rPr>
-                <a:solidFill>
-                  <a:prstClr val="white"/>
-                </a:solidFill>
-                <a:latin typeface="Helvetica Neue" panose="02000503000000020004" pitchFamily="2" charset="0"/>
-                <a:ea typeface="Helvetica Neue" panose="02000503000000020004" pitchFamily="2" charset="0"/>
-                <a:cs typeface="Helvetica Neue" panose="02000503000000020004" pitchFamily="2" charset="0"/>
-              </a:rPr>
-              <a:t>The key speed is |v| = wake speed.</a:t>
-            </a:r>
-            <a:endParaRPr lang="en-US" dirty="0">
-              <a:solidFill>
-                <a:prstClr val="white"/>
-              </a:solidFill>
-              <a:latin typeface="Helvetica Neue" panose="02000503000000020004" pitchFamily="2" charset="0"/>
-              <a:ea typeface="Helvetica Neue" panose="02000503000000020004" pitchFamily="2" charset="0"/>
-              <a:cs typeface="Helvetica Neue" panose="02000503000000020004" pitchFamily="2" charset="0"/>
-            </a:endParaRPr>
-          </a:p>
-          <a:p>
-            <a:pPr marL="285750" marR="0" lvl="0" indent="-285750" algn="l" defTabSz="914400" rtl="0" eaLnBrk="1" fontAlgn="auto" latinLnBrk="0" hangingPunct="1">
+            <a:pPr marL="0" marR="0" lvl="0" indent="0" algn="l" defTabSz="914400" rtl="0" eaLnBrk="1" fontAlgn="auto" latinLnBrk="0" hangingPunct="1">
               <a:lnSpc>
                 <a:spcPct val="100000"/>
               </a:lnSpc>
@@ -17623,8 +17588,8 @@
               </a:spcAft>
               <a:buClrTx/>
               <a:buSzTx/>
-              <a:buFont typeface="Arial" panose="020B0604020202020204" pitchFamily="34" charset="0"/>
-              <a:buChar char="•"/>
+              <a:buFontTx/>
+              <a:buNone/>
               <a:tabLst/>
               <a:defRPr/>
             </a:pPr>
@@ -17643,25 +17608,11 @@
                 <a:ea typeface="Helvetica Neue" panose="02000503000000020004" pitchFamily="2" charset="0"/>
                 <a:cs typeface="Helvetica Neue" panose="02000503000000020004" pitchFamily="2" charset="0"/>
               </a:rPr>
-              <a:t>Open question: does that speed line up with the special point r = 1 on the 1/r curve?</a:t>
+              <a:t>The key threshold is |v| = wake speed.</a:t>
             </a:r>
-            <a:endParaRPr kumimoji="0" lang="en-US" sz="1800" b="1" i="1" u="none" strike="noStrike" kern="1200" cap="none" spc="0" normalizeH="0" baseline="0" noProof="0" dirty="0">
-              <a:ln>
-                <a:noFill/>
-              </a:ln>
-              <a:solidFill>
-                <a:prstClr val="white"/>
-              </a:solidFill>
-              <a:effectLst/>
-              <a:uLnTx/>
-              <a:uFillTx/>
-              <a:latin typeface="Helvetica Neue" panose="02000503000000020004" pitchFamily="2" charset="0"/>
-              <a:ea typeface="Helvetica Neue" panose="02000503000000020004" pitchFamily="2" charset="0"/>
-              <a:cs typeface="Helvetica Neue" panose="02000503000000020004" pitchFamily="2" charset="0"/>
-            </a:endParaRPr>
-          </a:p>
-          <a:p>
-            <a:pPr marL="742950" marR="0" lvl="1" indent="-285750" algn="l" defTabSz="914400" rtl="0" eaLnBrk="1" fontAlgn="auto" latinLnBrk="0" hangingPunct="1">
+          </a:p>
+          <a:p>
+            <a:pPr marL="0" marR="0" lvl="0" indent="0" algn="l" defTabSz="914400" rtl="0" eaLnBrk="1" fontAlgn="auto" latinLnBrk="0" hangingPunct="1">
               <a:lnSpc>
                 <a:spcPct val="100000"/>
               </a:lnSpc>
@@ -17673,8 +17624,8 @@
               </a:spcAft>
               <a:buClrTx/>
               <a:buSzTx/>
-              <a:buFont typeface="Arial" panose="020B0604020202020204" pitchFamily="34" charset="0"/>
-              <a:buChar char="•"/>
+              <a:buFontTx/>
+              <a:buNone/>
               <a:tabLst/>
               <a:defRPr/>
             </a:pPr>
@@ -17693,11 +17644,11 @@
                 <a:ea typeface="Helvetica Neue" panose="02000503000000020004" pitchFamily="2" charset="0"/>
                 <a:cs typeface="Helvetica Neue" panose="02000503000000020004" pitchFamily="2" charset="0"/>
               </a:rPr>
-              <a:t>In this toy picture, the area on each side of r = 1 looks balanced.</a:t>
+              <a:t>Open question: does that threshold line up with r = 1 on the 1/r curve?</a:t>
             </a:r>
           </a:p>
           <a:p>
-            <a:pPr marL="742950" marR="0" lvl="1" indent="-285750" algn="l" defTabSz="914400" rtl="0" eaLnBrk="1" fontAlgn="auto" latinLnBrk="0" hangingPunct="1">
+            <a:pPr marL="0" marR="0" lvl="0" indent="0" algn="l" defTabSz="914400" rtl="0" eaLnBrk="1" fontAlgn="auto" latinLnBrk="0" hangingPunct="1">
               <a:lnSpc>
                 <a:spcPct val="100000"/>
               </a:lnSpc>
@@ -17709,8 +17660,8 @@
               </a:spcAft>
               <a:buClrTx/>
               <a:buSzTx/>
-              <a:buFont typeface="Arial" panose="020B0604020202020204" pitchFamily="34" charset="0"/>
-              <a:buChar char="•"/>
+              <a:buFontTx/>
+              <a:buNone/>
               <a:tabLst/>
               <a:defRPr/>
             </a:pPr>
@@ -17729,11 +17680,11 @@
                 <a:ea typeface="Helvetica Neue" panose="02000503000000020004" pitchFamily="2" charset="0"/>
                 <a:cs typeface="Helvetica Neue" panose="02000503000000020004" pitchFamily="2" charset="0"/>
               </a:rPr>
-              <a:t>That may be why orbit equations link speed and radius.</a:t>
+              <a:t>The toy picture suggests the two sides of r = 1 balance, which may link orbit speed and radius.</a:t>
             </a:r>
           </a:p>
           <a:p>
-            <a:pPr marL="742950" marR="0" lvl="1" indent="-285750" algn="l" defTabSz="914400" rtl="0" eaLnBrk="1" fontAlgn="auto" latinLnBrk="0" hangingPunct="1">
+            <a:pPr marL="0" marR="0" lvl="0" indent="0" algn="l" defTabSz="914400" rtl="0" eaLnBrk="1" fontAlgn="auto" latinLnBrk="0" hangingPunct="1">
               <a:lnSpc>
                 <a:spcPct val="100000"/>
               </a:lnSpc>
@@ -17745,13 +17696,13 @@
               </a:spcAft>
               <a:buClrTx/>
               <a:buSzTx/>
-              <a:buFont typeface="Arial" panose="020B0604020202020204" pitchFamily="34" charset="0"/>
-              <a:buChar char="•"/>
+              <a:buFontTx/>
+              <a:buNone/>
               <a:tabLst/>
               <a:defRPr/>
             </a:pPr>
             <a:r>
-              <a:rPr kumimoji="0" lang="en-US" sz="1800" b="0" i="1" u="none" strike="noStrike" kern="1200" cap="none" spc="0" normalizeH="0" baseline="0" noProof="0" dirty="0">
+              <a:rPr kumimoji="0" lang="en-US" sz="1800" b="0" i="0" u="none" strike="noStrike" kern="1200" cap="none" spc="0" normalizeH="0" baseline="0" noProof="0" dirty="0">
                 <a:ln>
                   <a:noFill/>
                 </a:ln>
@@ -17769,7 +17720,7 @@
             </a:r>
           </a:p>
           <a:p>
-            <a:pPr marL="285750" marR="0" lvl="0" indent="-285750" algn="l" defTabSz="914400" rtl="0" eaLnBrk="1" fontAlgn="auto" latinLnBrk="0" hangingPunct="1">
+            <a:pPr marL="0" marR="0" lvl="0" indent="0" algn="l" defTabSz="914400" rtl="0" eaLnBrk="1" fontAlgn="auto" latinLnBrk="0" hangingPunct="1">
               <a:lnSpc>
                 <a:spcPct val="100000"/>
               </a:lnSpc>
@@ -17781,8 +17732,44 @@
               </a:spcAft>
               <a:buClrTx/>
               <a:buSzTx/>
-              <a:buFont typeface="Arial" panose="020B0604020202020204" pitchFamily="34" charset="0"/>
-              <a:buChar char="•"/>
+              <a:buFontTx/>
+              <a:buNone/>
+              <a:tabLst/>
+              <a:defRPr/>
+            </a:pPr>
+            <a:r>
+              <a:rPr kumimoji="0" lang="en-US" sz="1800" b="0" i="0" u="none" strike="noStrike" kern="1200" cap="none" spc="0" normalizeH="0" baseline="0" noProof="0" dirty="0">
+                <a:ln>
+                  <a:noFill/>
+                </a:ln>
+                <a:solidFill>
+                  <a:prstClr val="white"/>
+                </a:solidFill>
+                <a:effectLst/>
+                <a:uLnTx/>
+                <a:uFillTx/>
+                <a:latin typeface="Helvetica Neue" panose="02000503000000020004" pitchFamily="2" charset="0"/>
+                <a:ea typeface="Helvetica Neue" panose="02000503000000020004" pitchFamily="2" charset="0"/>
+                <a:cs typeface="Helvetica Neue" panose="02000503000000020004" pitchFamily="2" charset="0"/>
+              </a:rPr>
+              <a:t>Same-polarity pairs may reverse or cross, depending on the starting offset.</a:t>
+            </a:r>
+          </a:p>
+          <a:p>
+            <a:pPr marL="0" marR="0" lvl="0" indent="0" algn="l" defTabSz="914400" rtl="0" eaLnBrk="1" fontAlgn="auto" latinLnBrk="0" hangingPunct="1">
+              <a:lnSpc>
+                <a:spcPct val="100000"/>
+              </a:lnSpc>
+              <a:spcBef>
+                <a:spcPts val="0"/>
+              </a:spcBef>
+              <a:spcAft>
+                <a:spcPts val="0"/>
+              </a:spcAft>
+              <a:buClrTx/>
+              <a:buSzTx/>
+              <a:buFontTx/>
+              <a:buNone/>
               <a:tabLst/>
               <a:defRPr/>
             </a:pPr>
@@ -17805,7 +17792,7 @@
             </a:r>
           </a:p>
           <a:p>
-            <a:pPr marL="742950" marR="0" lvl="1" indent="-285750" algn="l" defTabSz="914400" rtl="0" eaLnBrk="1" fontAlgn="auto" latinLnBrk="0" hangingPunct="1">
+            <a:pPr marL="0" marR="0" lvl="0" indent="0" algn="l" defTabSz="914400" rtl="0" eaLnBrk="1" fontAlgn="auto" latinLnBrk="0" hangingPunct="1">
               <a:lnSpc>
                 <a:spcPct val="100000"/>
               </a:lnSpc>
@@ -17817,80 +17804,8 @@
               </a:spcAft>
               <a:buClrTx/>
               <a:buSzTx/>
-              <a:buFont typeface="Arial" panose="020B0604020202020204" pitchFamily="34" charset="0"/>
-              <a:buChar char="•"/>
-              <a:tabLst/>
-              <a:defRPr/>
-            </a:pPr>
-            <a:r>
-              <a:rPr kumimoji="0" lang="en-US" sz="1800" b="0" i="0" u="none" strike="noStrike" kern="1200" cap="none" spc="0" normalizeH="0" baseline="0" noProof="0" dirty="0">
-                <a:ln>
-                  <a:noFill/>
-                </a:ln>
-                <a:solidFill>
-                  <a:prstClr val="white"/>
-                </a:solidFill>
-                <a:effectLst/>
-                <a:uLnTx/>
-                <a:uFillTx/>
-                <a:latin typeface="Helvetica Neue" panose="02000503000000020004" pitchFamily="2" charset="0"/>
-                <a:ea typeface="Helvetica Neue" panose="02000503000000020004" pitchFamily="2" charset="0"/>
-                <a:cs typeface="Helvetica Neue" panose="02000503000000020004" pitchFamily="2" charset="0"/>
-              </a:rPr>
-              <a:t>Same-polarity pairs moving toward each other above wake speed may reverse or cross, depending on the starting offset.</a:t>
-            </a:r>
-          </a:p>
-          <a:p>
-            <a:pPr marL="742950" marR="0" lvl="1" indent="-285750" algn="l" defTabSz="914400" rtl="0" eaLnBrk="1" fontAlgn="auto" latinLnBrk="0" hangingPunct="1">
-              <a:lnSpc>
-                <a:spcPct val="100000"/>
-              </a:lnSpc>
-              <a:spcBef>
-                <a:spcPts val="0"/>
-              </a:spcBef>
-              <a:spcAft>
-                <a:spcPts val="0"/>
-              </a:spcAft>
-              <a:buClrTx/>
-              <a:buSzTx/>
-              <a:buFont typeface="Arial" panose="020B0604020202020204" pitchFamily="34" charset="0"/>
-              <a:buChar char="•"/>
-              <a:tabLst/>
-              <a:defRPr/>
-            </a:pPr>
-            <a:r>
-              <a:rPr kumimoji="0" lang="en-US" sz="1800" b="0" i="0" u="none" strike="noStrike" kern="1200" cap="none" spc="0" normalizeH="0" baseline="0" noProof="0" dirty="0">
-                <a:ln>
-                  <a:noFill/>
-                </a:ln>
-                <a:solidFill>
-                  <a:prstClr val="white"/>
-                </a:solidFill>
-                <a:effectLst/>
-                <a:uLnTx/>
-                <a:uFillTx/>
-                <a:latin typeface="Helvetica Neue" panose="02000503000000020004" pitchFamily="2" charset="0"/>
-                <a:ea typeface="Helvetica Neue" panose="02000503000000020004" pitchFamily="2" charset="0"/>
-                <a:cs typeface="Helvetica Neue" panose="02000503000000020004" pitchFamily="2" charset="0"/>
-              </a:rPr>
-              <a:t>Same-polarity and opposite-polarity pairs are not just mirror copies.</a:t>
-            </a:r>
-          </a:p>
-          <a:p>
-            <a:pPr marL="1200150" marR="0" lvl="2" indent="-285750" algn="l" defTabSz="914400" rtl="0" eaLnBrk="1" fontAlgn="auto" latinLnBrk="0" hangingPunct="1">
-              <a:lnSpc>
-                <a:spcPct val="100000"/>
-              </a:lnSpc>
-              <a:spcBef>
-                <a:spcPts val="0"/>
-              </a:spcBef>
-              <a:spcAft>
-                <a:spcPts val="0"/>
-              </a:spcAft>
-              <a:buClrTx/>
-              <a:buSzTx/>
-              <a:buFont typeface="Arial" panose="020B0604020202020204" pitchFamily="34" charset="0"/>
-              <a:buChar char="•"/>
+              <a:buFontTx/>
+              <a:buNone/>
               <a:tabLst/>
               <a:defRPr/>
             </a:pPr>
@@ -17919,7 +17834,7 @@
           <p:cNvPr id="5" name="Group 4">
             <a:extLst>
               <a:ext uri="{FF2B5EF4-FFF2-40B4-BE49-F238E27FC236}">
-                <ns2:creationId id="{28EB18A8-8B6A-033D-A4AD-86FBADCB4D4A}"/>
+                <a16:creationId xmlns:a16="http://schemas.microsoft.com/office/drawing/2014/main" id="{28EB18A8-8B6A-033D-A4AD-86FBADCB4D4A}"/>
               </a:ext>
             </a:extLst>
           </p:cNvPr>
@@ -17939,7 +17854,7 @@
             <p:cNvPr id="3" name="Picture 2">
               <a:extLst>
                 <a:ext uri="{FF2B5EF4-FFF2-40B4-BE49-F238E27FC236}">
-                  <ns2:creationId id="{13746C96-5BF1-B22B-CA42-106D1B63333F}"/>
+                  <a16:creationId xmlns:a16="http://schemas.microsoft.com/office/drawing/2014/main" id="{13746C96-5BF1-B22B-CA42-106D1B63333F}"/>
                 </a:ext>
               </a:extLst>
             </p:cNvPr>
@@ -17969,7 +17884,7 @@
             <p:cNvPr id="6" name="Straight Connector 5">
               <a:extLst>
                 <a:ext uri="{FF2B5EF4-FFF2-40B4-BE49-F238E27FC236}">
-                  <ns2:creationId id="{EE364915-3AF3-C9A5-4E25-440B57D56073}"/>
+                  <a16:creationId xmlns:a16="http://schemas.microsoft.com/office/drawing/2014/main" id="{EE364915-3AF3-C9A5-4E25-440B57D56073}"/>
                 </a:ext>
               </a:extLst>
             </p:cNvPr>
@@ -18012,7 +17927,7 @@
           <p:cNvPr id="7" name="Title 4">
             <a:extLst>
               <a:ext uri="{FF2B5EF4-FFF2-40B4-BE49-F238E27FC236}">
-                <ns2:creationId id="{82AADF08-A238-0E6D-347B-D5A2BAE919D0}"/>
+                <a16:creationId xmlns:a16="http://schemas.microsoft.com/office/drawing/2014/main" id="{82AADF08-A238-0E6D-347B-D5A2BAE919D0}"/>
               </a:ext>
             </a:extLst>
           </p:cNvPr>
@@ -18102,7 +18017,7 @@
           <p:cNvPr id="2" name="Footer Placeholder 3">
             <a:extLst>
               <a:ext uri="{FF2B5EF4-FFF2-40B4-BE49-F238E27FC236}">
-                <ns2:creationId id="{D74AEA6F-1F62-494C-BFCD-404180B7B064}"/>
+                <a16:creationId xmlns:a16="http://schemas.microsoft.com/office/drawing/2014/main" id="{D74AEA6F-1F62-494C-BFCD-404180B7B064}"/>
               </a:ext>
             </a:extLst>
           </p:cNvPr>
@@ -18262,7 +18177,7 @@
     </p:spTree>
     <p:extLst>
       <p:ext uri="{BB962C8B-B14F-4D97-AF65-F5344CB8AC3E}">
-        <p14:creationId val="3190063365"/>
+        <p14:creationId xmlns:p14="http://schemas.microsoft.com/office/powerpoint/2010/main" val="3190063365"/>
       </p:ext>
     </p:extLst>
   </p:cSld>
@@ -18273,7 +18188,7 @@
 </file>
 
 <file path=ppt/slides/slide14.xml><?xml version="1.0" encoding="utf-8"?>
-<p:sld xmlns:a="http://schemas.openxmlformats.org/drawingml/2006/main" xmlns:ns2="http://schemas.microsoft.com/office/drawing/2014/main" xmlns:p="http://schemas.openxmlformats.org/presentationml/2006/main" xmlns:p14="http://schemas.microsoft.com/office/powerpoint/2010/main">
+<p:sld xmlns:a="http://schemas.openxmlformats.org/drawingml/2006/main" xmlns:r="http://schemas.openxmlformats.org/officeDocument/2006/relationships" xmlns:p="http://schemas.openxmlformats.org/presentationml/2006/main">
   <p:cSld>
     <p:bg>
       <p:bgPr>
@@ -18288,7 +18203,7 @@
         <p:cNvPr id="1" name="">
           <a:extLst>
             <a:ext uri="{FF2B5EF4-FFF2-40B4-BE49-F238E27FC236}">
-              <ns2:creationId id="{2CB0C588-8647-6C8C-8DC7-F162DDF8BF26}"/>
+              <a16:creationId xmlns:a16="http://schemas.microsoft.com/office/drawing/2014/main" id="{2CB0C588-8647-6C8C-8DC7-F162DDF8BF26}"/>
             </a:ext>
           </a:extLst>
         </p:cNvPr>
@@ -18308,7 +18223,7 @@
           <p:cNvPr id="5" name="Footer Placeholder 3">
             <a:extLst>
               <a:ext uri="{FF2B5EF4-FFF2-40B4-BE49-F238E27FC236}">
-                <ns2:creationId id="{D8055493-6465-E03D-4E0E-CA86B923D2DB}"/>
+                <a16:creationId xmlns:a16="http://schemas.microsoft.com/office/drawing/2014/main" id="{D8055493-6465-E03D-4E0E-CA86B923D2DB}"/>
               </a:ext>
             </a:extLst>
           </p:cNvPr>
@@ -18470,7 +18385,7 @@
           <p:cNvPr id="19" name="Rectangle 18">
             <a:extLst>
               <a:ext uri="{FF2B5EF4-FFF2-40B4-BE49-F238E27FC236}">
-                <ns2:creationId id="{232D04D3-E71C-CAE2-097F-314B5E11C0F3}"/>
+                <a16:creationId xmlns:a16="http://schemas.microsoft.com/office/drawing/2014/main" id="{232D04D3-E71C-CAE2-097F-314B5E11C0F3}"/>
               </a:ext>
             </a:extLst>
           </p:cNvPr>
@@ -18535,7 +18450,7 @@
           <p:cNvPr id="2" name="TextBox 1">
             <a:extLst>
               <a:ext uri="{FF2B5EF4-FFF2-40B4-BE49-F238E27FC236}">
-                <ns2:creationId id="{5B66C1A2-52BD-EA60-BE8F-C5D3C8F732D2}"/>
+                <a16:creationId xmlns:a16="http://schemas.microsoft.com/office/drawing/2014/main" id="{5B66C1A2-52BD-EA60-BE8F-C5D3C8F732D2}"/>
               </a:ext>
             </a:extLst>
           </p:cNvPr>
@@ -18829,7 +18744,7 @@
     </p:spTree>
     <p:extLst>
       <p:ext uri="{BB962C8B-B14F-4D97-AF65-F5344CB8AC3E}">
-        <p14:creationId val="3670680207"/>
+        <p14:creationId xmlns:p14="http://schemas.microsoft.com/office/powerpoint/2010/main" val="3670680207"/>
       </p:ext>
     </p:extLst>
   </p:cSld>
@@ -18840,7 +18755,7 @@
 </file>
 
 <file path=ppt/slides/slide2.xml><?xml version="1.0" encoding="utf-8"?>
-<p:sld xmlns:a="http://schemas.openxmlformats.org/drawingml/2006/main" xmlns:ns2="http://schemas.microsoft.com/office/drawing/2014/main" xmlns:p="http://schemas.openxmlformats.org/presentationml/2006/main" xmlns:p14="http://schemas.microsoft.com/office/powerpoint/2010/main">
+<p:sld xmlns:a="http://schemas.openxmlformats.org/drawingml/2006/main" xmlns:r="http://schemas.openxmlformats.org/officeDocument/2006/relationships" xmlns:p="http://schemas.openxmlformats.org/presentationml/2006/main">
   <p:cSld>
     <p:bg>
       <p:bgPr>
@@ -18855,7 +18770,7 @@
         <p:cNvPr id="1" name="">
           <a:extLst>
             <a:ext uri="{FF2B5EF4-FFF2-40B4-BE49-F238E27FC236}">
-              <ns2:creationId id="{14568406-B066-AEBE-C74B-068160974652}"/>
+              <a16:creationId xmlns:a16="http://schemas.microsoft.com/office/drawing/2014/main" id="{14568406-B066-AEBE-C74B-068160974652}"/>
             </a:ext>
           </a:extLst>
         </p:cNvPr>
@@ -18875,7 +18790,7 @@
           <p:cNvPr id="5" name="Footer Placeholder 3">
             <a:extLst>
               <a:ext uri="{FF2B5EF4-FFF2-40B4-BE49-F238E27FC236}">
-                <ns2:creationId id="{27CEA6F2-4AF1-97D8-38AC-41B557BE51CF}"/>
+                <a16:creationId xmlns:a16="http://schemas.microsoft.com/office/drawing/2014/main" id="{27CEA6F2-4AF1-97D8-38AC-41B557BE51CF}"/>
               </a:ext>
             </a:extLst>
           </p:cNvPr>
@@ -19037,7 +18952,7 @@
           <p:cNvPr id="6" name="Group 5">
             <a:extLst>
               <a:ext uri="{FF2B5EF4-FFF2-40B4-BE49-F238E27FC236}">
-                <ns2:creationId id="{C81263DC-661D-BD50-5933-E8227696F8DE}"/>
+                <a16:creationId xmlns:a16="http://schemas.microsoft.com/office/drawing/2014/main" id="{C81263DC-661D-BD50-5933-E8227696F8DE}"/>
               </a:ext>
             </a:extLst>
           </p:cNvPr>
@@ -19057,7 +18972,7 @@
             <p:cNvPr id="3" name="Straight Arrow Connector 2">
               <a:extLst>
                 <a:ext uri="{FF2B5EF4-FFF2-40B4-BE49-F238E27FC236}">
-                  <ns2:creationId id="{8B149F79-E249-261E-9112-BF1D70D76419}"/>
+                  <a16:creationId xmlns:a16="http://schemas.microsoft.com/office/drawing/2014/main" id="{8B149F79-E249-261E-9112-BF1D70D76419}"/>
                 </a:ext>
               </a:extLst>
             </p:cNvPr>
@@ -19101,7 +19016,7 @@
             <p:cNvPr id="8" name="Straight Arrow Connector 7">
               <a:extLst>
                 <a:ext uri="{FF2B5EF4-FFF2-40B4-BE49-F238E27FC236}">
-                  <ns2:creationId id="{259C9B9C-0329-E856-17CB-C966D0778D39}"/>
+                  <a16:creationId xmlns:a16="http://schemas.microsoft.com/office/drawing/2014/main" id="{259C9B9C-0329-E856-17CB-C966D0778D39}"/>
                 </a:ext>
               </a:extLst>
             </p:cNvPr>
@@ -19145,7 +19060,7 @@
             <p:cNvPr id="12" name="TextBox 11">
               <a:extLst>
                 <a:ext uri="{FF2B5EF4-FFF2-40B4-BE49-F238E27FC236}">
-                  <ns2:creationId id="{7C27133D-1A03-8C4F-53C4-564B9AE5C189}"/>
+                  <a16:creationId xmlns:a16="http://schemas.microsoft.com/office/drawing/2014/main" id="{7C27133D-1A03-8C4F-53C4-564B9AE5C189}"/>
                 </a:ext>
               </a:extLst>
             </p:cNvPr>
@@ -19210,7 +19125,7 @@
             <p:cNvPr id="13" name="TextBox 12">
               <a:extLst>
                 <a:ext uri="{FF2B5EF4-FFF2-40B4-BE49-F238E27FC236}">
-                  <ns2:creationId id="{0F3C3A2E-72E6-5B26-7E8C-2A2E59D8C3F6}"/>
+                  <a16:creationId xmlns:a16="http://schemas.microsoft.com/office/drawing/2014/main" id="{0F3C3A2E-72E6-5B26-7E8C-2A2E59D8C3F6}"/>
                 </a:ext>
               </a:extLst>
             </p:cNvPr>
@@ -19272,7 +19187,7 @@
           <p:cNvPr id="23" name="Oval 22">
             <a:extLst>
               <a:ext uri="{FF2B5EF4-FFF2-40B4-BE49-F238E27FC236}">
-                <ns2:creationId id="{F069ACCF-49B1-2004-B9BA-C32EA1E82492}"/>
+                <a16:creationId xmlns:a16="http://schemas.microsoft.com/office/drawing/2014/main" id="{F069ACCF-49B1-2004-B9BA-C32EA1E82492}"/>
               </a:ext>
             </a:extLst>
           </p:cNvPr>
@@ -19356,7 +19271,7 @@
           <p:cNvPr id="27" name="Oval 26">
             <a:extLst>
               <a:ext uri="{FF2B5EF4-FFF2-40B4-BE49-F238E27FC236}">
-                <ns2:creationId id="{A2120CF2-66F6-E863-1722-E1EBC99EB320}"/>
+                <a16:creationId xmlns:a16="http://schemas.microsoft.com/office/drawing/2014/main" id="{A2120CF2-66F6-E863-1722-E1EBC99EB320}"/>
               </a:ext>
             </a:extLst>
           </p:cNvPr>
@@ -19440,7 +19355,7 @@
           <p:cNvPr id="28" name="Oval 27">
             <a:extLst>
               <a:ext uri="{FF2B5EF4-FFF2-40B4-BE49-F238E27FC236}">
-                <ns2:creationId id="{2CF23E24-ED96-772A-8248-1491441DB146}"/>
+                <a16:creationId xmlns:a16="http://schemas.microsoft.com/office/drawing/2014/main" id="{2CF23E24-ED96-772A-8248-1491441DB146}"/>
               </a:ext>
             </a:extLst>
           </p:cNvPr>
@@ -19524,7 +19439,7 @@
           <p:cNvPr id="29" name="Oval 28">
             <a:extLst>
               <a:ext uri="{FF2B5EF4-FFF2-40B4-BE49-F238E27FC236}">
-                <ns2:creationId id="{25A0A0B3-E20A-4CC2-79D9-E97020D601A7}"/>
+                <a16:creationId xmlns:a16="http://schemas.microsoft.com/office/drawing/2014/main" id="{25A0A0B3-E20A-4CC2-79D9-E97020D601A7}"/>
               </a:ext>
             </a:extLst>
           </p:cNvPr>
@@ -19608,7 +19523,7 @@
           <p:cNvPr id="30" name="Oval 29">
             <a:extLst>
               <a:ext uri="{FF2B5EF4-FFF2-40B4-BE49-F238E27FC236}">
-                <ns2:creationId id="{7969DEBF-EEB6-634C-020A-385E24FBF8E1}"/>
+                <a16:creationId xmlns:a16="http://schemas.microsoft.com/office/drawing/2014/main" id="{7969DEBF-EEB6-634C-020A-385E24FBF8E1}"/>
               </a:ext>
             </a:extLst>
           </p:cNvPr>
@@ -19692,7 +19607,7 @@
           <p:cNvPr id="4" name="Straight Connector 3">
             <a:extLst>
               <a:ext uri="{FF2B5EF4-FFF2-40B4-BE49-F238E27FC236}">
-                <ns2:creationId id="{2C66513A-9085-17C4-C9C2-3742BE2C33D7}"/>
+                <a16:creationId xmlns:a16="http://schemas.microsoft.com/office/drawing/2014/main" id="{2C66513A-9085-17C4-C9C2-3742BE2C33D7}"/>
               </a:ext>
             </a:extLst>
           </p:cNvPr>
@@ -19735,7 +19650,7 @@
           <p:cNvPr id="18" name="Oval 17">
             <a:extLst>
               <a:ext uri="{FF2B5EF4-FFF2-40B4-BE49-F238E27FC236}">
-                <ns2:creationId id="{9E30E225-012D-EE67-96E9-8843E769C6E1}"/>
+                <a16:creationId xmlns:a16="http://schemas.microsoft.com/office/drawing/2014/main" id="{9E30E225-012D-EE67-96E9-8843E769C6E1}"/>
               </a:ext>
             </a:extLst>
           </p:cNvPr>
@@ -19818,7 +19733,7 @@
           <p:cNvPr id="11" name="Group 10">
             <a:extLst>
               <a:ext uri="{FF2B5EF4-FFF2-40B4-BE49-F238E27FC236}">
-                <ns2:creationId id="{CE7A3B85-FDA3-45E2-9BB3-D32BED764091}"/>
+                <a16:creationId xmlns:a16="http://schemas.microsoft.com/office/drawing/2014/main" id="{CE7A3B85-FDA3-45E2-9BB3-D32BED764091}"/>
               </a:ext>
             </a:extLst>
           </p:cNvPr>
@@ -19838,7 +19753,7 @@
             <p:cNvPr id="24" name="Straight Arrow Connector 23">
               <a:extLst>
                 <a:ext uri="{FF2B5EF4-FFF2-40B4-BE49-F238E27FC236}">
-                  <ns2:creationId id="{5AAF8464-4AF0-1ED4-EC84-883D9DCBAE2E}"/>
+                  <a16:creationId xmlns:a16="http://schemas.microsoft.com/office/drawing/2014/main" id="{5AAF8464-4AF0-1ED4-EC84-883D9DCBAE2E}"/>
                 </a:ext>
               </a:extLst>
             </p:cNvPr>
@@ -19883,7 +19798,7 @@
             <p:cNvPr id="10" name="TextBox 9">
               <a:extLst>
                 <a:ext uri="{FF2B5EF4-FFF2-40B4-BE49-F238E27FC236}">
-                  <ns2:creationId id="{D4526506-8D04-242E-625D-A7D78BFFEE82}"/>
+                  <a16:creationId xmlns:a16="http://schemas.microsoft.com/office/drawing/2014/main" id="{D4526506-8D04-242E-625D-A7D78BFFEE82}"/>
                 </a:ext>
               </a:extLst>
             </p:cNvPr>
@@ -19966,7 +19881,7 @@
           <p:cNvPr id="31" name="TextBox 30">
             <a:extLst>
               <a:ext uri="{FF2B5EF4-FFF2-40B4-BE49-F238E27FC236}">
-                <ns2:creationId id="{0715B65B-EE48-6433-EFA6-8AFF4BF52B13}"/>
+                <a16:creationId xmlns:a16="http://schemas.microsoft.com/office/drawing/2014/main" id="{0715B65B-EE48-6433-EFA6-8AFF4BF52B13}"/>
               </a:ext>
             </a:extLst>
           </p:cNvPr>
@@ -20068,7 +19983,7 @@
           <p:cNvPr id="36" name="TextBox 35">
             <a:extLst>
               <a:ext uri="{FF2B5EF4-FFF2-40B4-BE49-F238E27FC236}">
-                <ns2:creationId id="{2639C71E-8510-A47A-CB6E-BD88DBD2D9D2}"/>
+                <a16:creationId xmlns:a16="http://schemas.microsoft.com/office/drawing/2014/main" id="{2639C71E-8510-A47A-CB6E-BD88DBD2D9D2}"/>
               </a:ext>
             </a:extLst>
           </p:cNvPr>
@@ -20150,7 +20065,7 @@
           <p:cNvPr id="22" name="Straight Connector 21">
             <a:extLst>
               <a:ext uri="{FF2B5EF4-FFF2-40B4-BE49-F238E27FC236}">
-                <ns2:creationId id="{48D6CF27-A191-E604-D02B-B71D144C595B}"/>
+                <a16:creationId xmlns:a16="http://schemas.microsoft.com/office/drawing/2014/main" id="{48D6CF27-A191-E604-D02B-B71D144C595B}"/>
               </a:ext>
             </a:extLst>
           </p:cNvPr>
@@ -20193,7 +20108,7 @@
           <p:cNvPr id="2" name="Title 1">
             <a:extLst>
               <a:ext uri="{FF2B5EF4-FFF2-40B4-BE49-F238E27FC236}">
-                <ns2:creationId id="{62407ED0-1A7F-69F0-224E-34E3BAB4AEB7}"/>
+                <a16:creationId xmlns:a16="http://schemas.microsoft.com/office/drawing/2014/main" id="{62407ED0-1A7F-69F0-224E-34E3BAB4AEB7}"/>
               </a:ext>
             </a:extLst>
           </p:cNvPr>
@@ -20277,7 +20192,7 @@
           <p:cNvPr id="7" name="Rectangle 6">
             <a:extLst>
               <a:ext uri="{FF2B5EF4-FFF2-40B4-BE49-F238E27FC236}">
-                <ns2:creationId id="{E63833BB-E257-5DD8-D2DC-4EDC10C1D9B0}"/>
+                <a16:creationId xmlns:a16="http://schemas.microsoft.com/office/drawing/2014/main" id="{E63833BB-E257-5DD8-D2DC-4EDC10C1D9B0}"/>
               </a:ext>
             </a:extLst>
           </p:cNvPr>
@@ -20286,15 +20201,15 @@
         </p:nvSpPr>
         <p:spPr>
           <a:xfrm>
-            <a:off x="1717056" y="1050303"/>
-            <a:ext cx="9576532" cy="523220"/>
+            <a:off x="0" y="512381"/>
+            <a:ext cx="12191999" cy="523220"/>
           </a:xfrm>
           <a:prstGeom prst="rect">
             <a:avLst/>
           </a:prstGeom>
         </p:spPr>
         <p:txBody>
-          <a:bodyPr wrap="none">
+          <a:bodyPr wrap="square">
             <a:spAutoFit/>
           </a:bodyPr>
           <a:lstStyle/>
@@ -20341,7 +20256,7 @@
           <p:cNvPr id="15" name="Straight Arrow Connector 14">
             <a:extLst>
               <a:ext uri="{FF2B5EF4-FFF2-40B4-BE49-F238E27FC236}">
-                <ns2:creationId id="{F4A7F80E-6EB4-D3A1-C496-DA676D8B14B8}"/>
+                <a16:creationId xmlns:a16="http://schemas.microsoft.com/office/drawing/2014/main" id="{F4A7F80E-6EB4-D3A1-C496-DA676D8B14B8}"/>
               </a:ext>
             </a:extLst>
           </p:cNvPr>
@@ -20387,7 +20302,7 @@
           <p:cNvPr id="32" name="Straight Arrow Connector 31">
             <a:extLst>
               <a:ext uri="{FF2B5EF4-FFF2-40B4-BE49-F238E27FC236}">
-                <ns2:creationId id="{E4BBFD59-613F-87DB-D8CE-C4CD0658E65A}"/>
+                <a16:creationId xmlns:a16="http://schemas.microsoft.com/office/drawing/2014/main" id="{E4BBFD59-613F-87DB-D8CE-C4CD0658E65A}"/>
               </a:ext>
             </a:extLst>
           </p:cNvPr>
@@ -20433,7 +20348,7 @@
           <p:cNvPr id="35" name="Straight Arrow Connector 34">
             <a:extLst>
               <a:ext uri="{FF2B5EF4-FFF2-40B4-BE49-F238E27FC236}">
-                <ns2:creationId id="{6170C482-A85C-519C-1C68-E52F3D321552}"/>
+                <a16:creationId xmlns:a16="http://schemas.microsoft.com/office/drawing/2014/main" id="{6170C482-A85C-519C-1C68-E52F3D321552}"/>
               </a:ext>
             </a:extLst>
           </p:cNvPr>
@@ -20479,7 +20394,7 @@
           <p:cNvPr id="39" name="Straight Arrow Connector 38">
             <a:extLst>
               <a:ext uri="{FF2B5EF4-FFF2-40B4-BE49-F238E27FC236}">
-                <ns2:creationId id="{4230761A-8EDF-2FA3-7DBE-AF384628B09E}"/>
+                <a16:creationId xmlns:a16="http://schemas.microsoft.com/office/drawing/2014/main" id="{4230761A-8EDF-2FA3-7DBE-AF384628B09E}"/>
               </a:ext>
             </a:extLst>
           </p:cNvPr>
@@ -20525,7 +20440,7 @@
           <p:cNvPr id="47" name="Straight Arrow Connector 46">
             <a:extLst>
               <a:ext uri="{FF2B5EF4-FFF2-40B4-BE49-F238E27FC236}">
-                <ns2:creationId id="{D3EF506B-E81E-4405-B45C-DFB8F9DA0D65}"/>
+                <a16:creationId xmlns:a16="http://schemas.microsoft.com/office/drawing/2014/main" id="{D3EF506B-E81E-4405-B45C-DFB8F9DA0D65}"/>
               </a:ext>
             </a:extLst>
           </p:cNvPr>
@@ -20571,7 +20486,7 @@
           <p:cNvPr id="9" name="TextBox 8">
             <a:extLst>
               <a:ext uri="{FF2B5EF4-FFF2-40B4-BE49-F238E27FC236}">
-                <ns2:creationId id="{9B5DCDDF-276B-4F6E-7066-014AE9A59CCC}"/>
+                <a16:creationId xmlns:a16="http://schemas.microsoft.com/office/drawing/2014/main" id="{9B5DCDDF-276B-4F6E-7066-014AE9A59CCC}"/>
               </a:ext>
             </a:extLst>
           </p:cNvPr>
@@ -20653,7 +20568,7 @@
           <p:cNvPr id="14" name="Rectangle 13">
             <a:extLst>
               <a:ext uri="{FF2B5EF4-FFF2-40B4-BE49-F238E27FC236}">
-                <ns2:creationId id="{99560D5F-868F-8968-4ED0-12355714D7FF}"/>
+                <a16:creationId xmlns:a16="http://schemas.microsoft.com/office/drawing/2014/main" id="{99560D5F-868F-8968-4ED0-12355714D7FF}"/>
               </a:ext>
             </a:extLst>
           </p:cNvPr>
@@ -20720,7 +20635,7 @@
     </p:spTree>
     <p:extLst>
       <p:ext uri="{BB962C8B-B14F-4D97-AF65-F5344CB8AC3E}">
-        <p14:creationId val="3801198229"/>
+        <p14:creationId xmlns:p14="http://schemas.microsoft.com/office/powerpoint/2010/main" val="3801198229"/>
       </p:ext>
     </p:extLst>
   </p:cSld>
@@ -20731,7 +20646,7 @@
 </file>
 
 <file path=ppt/slides/slide3.xml><?xml version="1.0" encoding="utf-8"?>
-<p:sld xmlns:a="http://schemas.openxmlformats.org/drawingml/2006/main" xmlns:ns2="http://schemas.microsoft.com/office/drawing/2014/main" xmlns:p="http://schemas.openxmlformats.org/presentationml/2006/main" xmlns:p14="http://schemas.microsoft.com/office/powerpoint/2010/main">
+<p:sld xmlns:a="http://schemas.openxmlformats.org/drawingml/2006/main" xmlns:r="http://schemas.openxmlformats.org/officeDocument/2006/relationships" xmlns:p="http://schemas.openxmlformats.org/presentationml/2006/main">
   <p:cSld>
     <p:bg>
       <p:bgPr>
@@ -20760,7 +20675,7 @@
           <p:cNvPr id="5" name="Footer Placeholder 3">
             <a:extLst>
               <a:ext uri="{FF2B5EF4-FFF2-40B4-BE49-F238E27FC236}">
-                <ns2:creationId id="{668F77D6-DFDA-5A46-8DF1-47F6A167C2B1}"/>
+                <a16:creationId xmlns:a16="http://schemas.microsoft.com/office/drawing/2014/main" id="{668F77D6-DFDA-5A46-8DF1-47F6A167C2B1}"/>
               </a:ext>
             </a:extLst>
           </p:cNvPr>
@@ -20922,7 +20837,7 @@
           <p:cNvPr id="6" name="Group 5">
             <a:extLst>
               <a:ext uri="{FF2B5EF4-FFF2-40B4-BE49-F238E27FC236}">
-                <ns2:creationId id="{CB214E5A-63A5-5C6B-3D5B-75FF74FA3E5A}"/>
+                <a16:creationId xmlns:a16="http://schemas.microsoft.com/office/drawing/2014/main" id="{CB214E5A-63A5-5C6B-3D5B-75FF74FA3E5A}"/>
               </a:ext>
             </a:extLst>
           </p:cNvPr>
@@ -20942,7 +20857,7 @@
             <p:cNvPr id="3" name="Straight Arrow Connector 2">
               <a:extLst>
                 <a:ext uri="{FF2B5EF4-FFF2-40B4-BE49-F238E27FC236}">
-                  <ns2:creationId id="{2EF0199F-22F4-BA42-9B75-8A8183BCDA9B}"/>
+                  <a16:creationId xmlns:a16="http://schemas.microsoft.com/office/drawing/2014/main" id="{2EF0199F-22F4-BA42-9B75-8A8183BCDA9B}"/>
                 </a:ext>
               </a:extLst>
             </p:cNvPr>
@@ -20986,7 +20901,7 @@
             <p:cNvPr id="8" name="Straight Arrow Connector 7">
               <a:extLst>
                 <a:ext uri="{FF2B5EF4-FFF2-40B4-BE49-F238E27FC236}">
-                  <ns2:creationId id="{49AB5343-55D0-6041-8627-E08A73F83930}"/>
+                  <a16:creationId xmlns:a16="http://schemas.microsoft.com/office/drawing/2014/main" id="{49AB5343-55D0-6041-8627-E08A73F83930}"/>
                 </a:ext>
               </a:extLst>
             </p:cNvPr>
@@ -21030,7 +20945,7 @@
             <p:cNvPr id="12" name="TextBox 11">
               <a:extLst>
                 <a:ext uri="{FF2B5EF4-FFF2-40B4-BE49-F238E27FC236}">
-                  <ns2:creationId id="{BF8D86A2-D083-024A-BC90-6BD938C23243}"/>
+                  <a16:creationId xmlns:a16="http://schemas.microsoft.com/office/drawing/2014/main" id="{BF8D86A2-D083-024A-BC90-6BD938C23243}"/>
                 </a:ext>
               </a:extLst>
             </p:cNvPr>
@@ -21095,7 +21010,7 @@
             <p:cNvPr id="13" name="TextBox 12">
               <a:extLst>
                 <a:ext uri="{FF2B5EF4-FFF2-40B4-BE49-F238E27FC236}">
-                  <ns2:creationId id="{2C3F4604-6C2F-0E4E-9DD3-4F5C89FF51AB}"/>
+                  <a16:creationId xmlns:a16="http://schemas.microsoft.com/office/drawing/2014/main" id="{2C3F4604-6C2F-0E4E-9DD3-4F5C89FF51AB}"/>
                 </a:ext>
               </a:extLst>
             </p:cNvPr>
@@ -21205,7 +21120,7 @@
           <p:cNvPr id="23" name="Oval 22">
             <a:extLst>
               <a:ext uri="{FF2B5EF4-FFF2-40B4-BE49-F238E27FC236}">
-                <ns2:creationId id="{0112617B-A1D5-1E41-BF92-E67D4E046E39}"/>
+                <a16:creationId xmlns:a16="http://schemas.microsoft.com/office/drawing/2014/main" id="{0112617B-A1D5-1E41-BF92-E67D4E046E39}"/>
               </a:ext>
             </a:extLst>
           </p:cNvPr>
@@ -21289,7 +21204,7 @@
           <p:cNvPr id="27" name="Oval 26">
             <a:extLst>
               <a:ext uri="{FF2B5EF4-FFF2-40B4-BE49-F238E27FC236}">
-                <ns2:creationId id="{6EF0F7DA-5E70-8348-A200-F59A10FF7C55}"/>
+                <a16:creationId xmlns:a16="http://schemas.microsoft.com/office/drawing/2014/main" id="{6EF0F7DA-5E70-8348-A200-F59A10FF7C55}"/>
               </a:ext>
             </a:extLst>
           </p:cNvPr>
@@ -21373,7 +21288,7 @@
           <p:cNvPr id="28" name="Oval 27">
             <a:extLst>
               <a:ext uri="{FF2B5EF4-FFF2-40B4-BE49-F238E27FC236}">
-                <ns2:creationId id="{552F58D0-F613-674A-B294-C894E5FB1683}"/>
+                <a16:creationId xmlns:a16="http://schemas.microsoft.com/office/drawing/2014/main" id="{552F58D0-F613-674A-B294-C894E5FB1683}"/>
               </a:ext>
             </a:extLst>
           </p:cNvPr>
@@ -21457,7 +21372,7 @@
           <p:cNvPr id="29" name="Oval 28">
             <a:extLst>
               <a:ext uri="{FF2B5EF4-FFF2-40B4-BE49-F238E27FC236}">
-                <ns2:creationId id="{9CA7A721-D3BD-744E-9306-85BBED5F74BC}"/>
+                <a16:creationId xmlns:a16="http://schemas.microsoft.com/office/drawing/2014/main" id="{9CA7A721-D3BD-744E-9306-85BBED5F74BC}"/>
               </a:ext>
             </a:extLst>
           </p:cNvPr>
@@ -21541,7 +21456,7 @@
           <p:cNvPr id="30" name="Oval 29">
             <a:extLst>
               <a:ext uri="{FF2B5EF4-FFF2-40B4-BE49-F238E27FC236}">
-                <ns2:creationId id="{F97F1A02-C0C7-3C45-9790-847C152D159A}"/>
+                <a16:creationId xmlns:a16="http://schemas.microsoft.com/office/drawing/2014/main" id="{F97F1A02-C0C7-3C45-9790-847C152D159A}"/>
               </a:ext>
             </a:extLst>
           </p:cNvPr>
@@ -21625,7 +21540,7 @@
           <p:cNvPr id="18" name="Oval 17">
             <a:extLst>
               <a:ext uri="{FF2B5EF4-FFF2-40B4-BE49-F238E27FC236}">
-                <ns2:creationId id="{BE4CDC90-4B2E-BE41-BB9D-A84675F3A2FE}"/>
+                <a16:creationId xmlns:a16="http://schemas.microsoft.com/office/drawing/2014/main" id="{BE4CDC90-4B2E-BE41-BB9D-A84675F3A2FE}"/>
               </a:ext>
             </a:extLst>
           </p:cNvPr>
@@ -21708,7 +21623,7 @@
           <p:cNvPr id="31" name="TextBox 30">
             <a:extLst>
               <a:ext uri="{FF2B5EF4-FFF2-40B4-BE49-F238E27FC236}">
-                <ns2:creationId id="{713B9ACE-B673-2D48-BEF2-2A133C31B527}"/>
+                <a16:creationId xmlns:a16="http://schemas.microsoft.com/office/drawing/2014/main" id="{713B9ACE-B673-2D48-BEF2-2A133C31B527}"/>
               </a:ext>
             </a:extLst>
           </p:cNvPr>
@@ -21810,7 +21725,7 @@
           <p:cNvPr id="36" name="TextBox 35">
             <a:extLst>
               <a:ext uri="{FF2B5EF4-FFF2-40B4-BE49-F238E27FC236}">
-                <ns2:creationId id="{3A81A480-EF64-094E-825A-8592DAA4C672}"/>
+                <a16:creationId xmlns:a16="http://schemas.microsoft.com/office/drawing/2014/main" id="{3A81A480-EF64-094E-825A-8592DAA4C672}"/>
               </a:ext>
             </a:extLst>
           </p:cNvPr>
@@ -21892,7 +21807,7 @@
           <p:cNvPr id="22" name="Straight Connector 21">
             <a:extLst>
               <a:ext uri="{FF2B5EF4-FFF2-40B4-BE49-F238E27FC236}">
-                <ns2:creationId id="{0C67DA45-6876-7942-9996-48CA0A1696FE}"/>
+                <a16:creationId xmlns:a16="http://schemas.microsoft.com/office/drawing/2014/main" id="{0C67DA45-6876-7942-9996-48CA0A1696FE}"/>
               </a:ext>
             </a:extLst>
           </p:cNvPr>
@@ -21935,7 +21850,7 @@
           <p:cNvPr id="15" name="Straight Arrow Connector 14">
             <a:extLst>
               <a:ext uri="{FF2B5EF4-FFF2-40B4-BE49-F238E27FC236}">
-                <ns2:creationId id="{05289ED1-4679-6543-A669-B23443FD0CD8}"/>
+                <a16:creationId xmlns:a16="http://schemas.microsoft.com/office/drawing/2014/main" id="{05289ED1-4679-6543-A669-B23443FD0CD8}"/>
               </a:ext>
             </a:extLst>
           </p:cNvPr>
@@ -21981,7 +21896,7 @@
           <p:cNvPr id="14" name="Rectangle 13">
             <a:extLst>
               <a:ext uri="{FF2B5EF4-FFF2-40B4-BE49-F238E27FC236}">
-                <ns2:creationId id="{24DFEA8B-B2CC-4557-5832-83CBF458C62D}"/>
+                <a16:creationId xmlns:a16="http://schemas.microsoft.com/office/drawing/2014/main" id="{24DFEA8B-B2CC-4557-5832-83CBF458C62D}"/>
               </a:ext>
             </a:extLst>
           </p:cNvPr>
@@ -22050,7 +21965,7 @@
           <p:cNvPr id="17" name="TextBox 16">
             <a:extLst>
               <a:ext uri="{FF2B5EF4-FFF2-40B4-BE49-F238E27FC236}">
-                <ns2:creationId id="{F6A93B37-78E4-125D-E0BF-C1EC32C24D2E}"/>
+                <a16:creationId xmlns:a16="http://schemas.microsoft.com/office/drawing/2014/main" id="{F6A93B37-78E4-125D-E0BF-C1EC32C24D2E}"/>
               </a:ext>
             </a:extLst>
           </p:cNvPr>
@@ -22059,8 +21974,8 @@
         </p:nvSpPr>
         <p:spPr>
           <a:xfrm>
-            <a:off x="2368330" y="5253265"/>
-            <a:ext cx="9220186" cy="338554"/>
+            <a:off x="3314814" y="5245329"/>
+            <a:ext cx="6597142" cy="369332"/>
           </a:xfrm>
           <a:prstGeom prst="rect">
             <a:avLst/>
@@ -22073,7 +21988,7 @@
           </a:bodyPr>
           <a:lstStyle/>
           <a:p>
-            <a:pPr marL="285750" marR="0" lvl="0" indent="-285750" algn="l" defTabSz="914400" rtl="0" eaLnBrk="1" fontAlgn="auto" latinLnBrk="0" hangingPunct="1">
+            <a:pPr marR="0" lvl="0" algn="ctr" defTabSz="914400" rtl="0" eaLnBrk="1" fontAlgn="auto" latinLnBrk="0" hangingPunct="1">
               <a:lnSpc>
                 <a:spcPct val="100000"/>
               </a:lnSpc>
@@ -22085,13 +22000,11 @@
               </a:spcAft>
               <a:buClrTx/>
               <a:buSzTx/>
-              <a:buFont typeface="Arial" panose="020B0604020202020204" pitchFamily="34" charset="0"/>
-              <a:buChar char="•"/>
               <a:tabLst/>
               <a:defRPr/>
             </a:pPr>
             <a:r>
-              <a:rPr kumimoji="0" lang="en-US" sz="1600" b="0" i="0" u="none" strike="noStrike" kern="1200" cap="none" spc="0" normalizeH="0" baseline="0" noProof="0" dirty="0">
+              <a:rPr kumimoji="0" lang="en-US" b="0" i="0" u="none" strike="noStrike" kern="1200" cap="none" spc="0" normalizeH="0" baseline="0" noProof="0" dirty="0">
                 <a:ln>
                   <a:noFill/>
                 </a:ln>
@@ -22115,7 +22028,7 @@
           <p:cNvPr id="19" name="TextBox 18">
             <a:extLst>
               <a:ext uri="{FF2B5EF4-FFF2-40B4-BE49-F238E27FC236}">
-                <ns2:creationId id="{D1F40738-506F-EAAF-7EBE-CFC9B4FE4D03}"/>
+                <a16:creationId xmlns:a16="http://schemas.microsoft.com/office/drawing/2014/main" id="{D1F40738-506F-EAAF-7EBE-CFC9B4FE4D03}"/>
               </a:ext>
             </a:extLst>
           </p:cNvPr>
@@ -22178,7 +22091,7 @@
     </p:spTree>
     <p:extLst>
       <p:ext uri="{BB962C8B-B14F-4D97-AF65-F5344CB8AC3E}">
-        <p14:creationId val="4241975687"/>
+        <p14:creationId xmlns:p14="http://schemas.microsoft.com/office/powerpoint/2010/main" val="4241975687"/>
       </p:ext>
     </p:extLst>
   </p:cSld>
@@ -22189,7 +22102,7 @@
 </file>
 
 <file path=ppt/slides/slide4.xml><?xml version="1.0" encoding="utf-8"?>
-<p:sld xmlns:a="http://schemas.openxmlformats.org/drawingml/2006/main" xmlns:ns2="http://schemas.microsoft.com/office/drawing/2014/main" xmlns:p="http://schemas.openxmlformats.org/presentationml/2006/main" xmlns:p14="http://schemas.microsoft.com/office/powerpoint/2010/main">
+<p:sld xmlns:a="http://schemas.openxmlformats.org/drawingml/2006/main" xmlns:r="http://schemas.openxmlformats.org/officeDocument/2006/relationships" xmlns:p="http://schemas.openxmlformats.org/presentationml/2006/main">
   <p:cSld>
     <p:bg>
       <p:bgPr>
@@ -22204,7 +22117,7 @@
         <p:cNvPr id="1" name="">
           <a:extLst>
             <a:ext uri="{FF2B5EF4-FFF2-40B4-BE49-F238E27FC236}">
-              <ns2:creationId id="{618D555D-7286-B241-E144-DDEC77AD45E3}"/>
+              <a16:creationId xmlns:a16="http://schemas.microsoft.com/office/drawing/2014/main" id="{618D555D-7286-B241-E144-DDEC77AD45E3}"/>
             </a:ext>
           </a:extLst>
         </p:cNvPr>
@@ -22224,7 +22137,7 @@
           <p:cNvPr id="5" name="Footer Placeholder 3">
             <a:extLst>
               <a:ext uri="{FF2B5EF4-FFF2-40B4-BE49-F238E27FC236}">
-                <ns2:creationId id="{614DBC08-8858-F579-1B95-86C501AB042B}"/>
+                <a16:creationId xmlns:a16="http://schemas.microsoft.com/office/drawing/2014/main" id="{614DBC08-8858-F579-1B95-86C501AB042B}"/>
               </a:ext>
             </a:extLst>
           </p:cNvPr>
@@ -22386,7 +22299,7 @@
           <p:cNvPr id="6" name="Group 5">
             <a:extLst>
               <a:ext uri="{FF2B5EF4-FFF2-40B4-BE49-F238E27FC236}">
-                <ns2:creationId id="{17811428-EDBA-0366-BE63-E3E25023C8EC}"/>
+                <a16:creationId xmlns:a16="http://schemas.microsoft.com/office/drawing/2014/main" id="{17811428-EDBA-0366-BE63-E3E25023C8EC}"/>
               </a:ext>
             </a:extLst>
           </p:cNvPr>
@@ -22406,7 +22319,7 @@
             <p:cNvPr id="3" name="Straight Arrow Connector 2">
               <a:extLst>
                 <a:ext uri="{FF2B5EF4-FFF2-40B4-BE49-F238E27FC236}">
-                  <ns2:creationId id="{D482C6FD-3801-AF2C-0D9C-BDC9F781A9F9}"/>
+                  <a16:creationId xmlns:a16="http://schemas.microsoft.com/office/drawing/2014/main" id="{D482C6FD-3801-AF2C-0D9C-BDC9F781A9F9}"/>
                 </a:ext>
               </a:extLst>
             </p:cNvPr>
@@ -22450,7 +22363,7 @@
             <p:cNvPr id="8" name="Straight Arrow Connector 7">
               <a:extLst>
                 <a:ext uri="{FF2B5EF4-FFF2-40B4-BE49-F238E27FC236}">
-                  <ns2:creationId id="{F8DD0551-F57F-FC8B-CDFA-54E4DF3D076B}"/>
+                  <a16:creationId xmlns:a16="http://schemas.microsoft.com/office/drawing/2014/main" id="{F8DD0551-F57F-FC8B-CDFA-54E4DF3D076B}"/>
                 </a:ext>
               </a:extLst>
             </p:cNvPr>
@@ -22494,7 +22407,7 @@
             <p:cNvPr id="12" name="TextBox 11">
               <a:extLst>
                 <a:ext uri="{FF2B5EF4-FFF2-40B4-BE49-F238E27FC236}">
-                  <ns2:creationId id="{2419E9DF-2DD3-3506-BE3B-E485BF80EDAC}"/>
+                  <a16:creationId xmlns:a16="http://schemas.microsoft.com/office/drawing/2014/main" id="{2419E9DF-2DD3-3506-BE3B-E485BF80EDAC}"/>
                 </a:ext>
               </a:extLst>
             </p:cNvPr>
@@ -22559,7 +22472,7 @@
             <p:cNvPr id="13" name="TextBox 12">
               <a:extLst>
                 <a:ext uri="{FF2B5EF4-FFF2-40B4-BE49-F238E27FC236}">
-                  <ns2:creationId id="{93B24559-A789-4B90-E180-1E0D72CE317E}"/>
+                  <a16:creationId xmlns:a16="http://schemas.microsoft.com/office/drawing/2014/main" id="{93B24559-A789-4B90-E180-1E0D72CE317E}"/>
                 </a:ext>
               </a:extLst>
             </p:cNvPr>
@@ -22621,7 +22534,7 @@
           <p:cNvPr id="23" name="Oval 22">
             <a:extLst>
               <a:ext uri="{FF2B5EF4-FFF2-40B4-BE49-F238E27FC236}">
-                <ns2:creationId id="{61A13369-24B9-E21B-05B9-329B5FF74DB7}"/>
+                <a16:creationId xmlns:a16="http://schemas.microsoft.com/office/drawing/2014/main" id="{61A13369-24B9-E21B-05B9-329B5FF74DB7}"/>
               </a:ext>
             </a:extLst>
           </p:cNvPr>
@@ -22705,7 +22618,7 @@
           <p:cNvPr id="27" name="Oval 26">
             <a:extLst>
               <a:ext uri="{FF2B5EF4-FFF2-40B4-BE49-F238E27FC236}">
-                <ns2:creationId id="{F2B3E963-4F4B-8173-AE7C-E7942A9E266B}"/>
+                <a16:creationId xmlns:a16="http://schemas.microsoft.com/office/drawing/2014/main" id="{F2B3E963-4F4B-8173-AE7C-E7942A9E266B}"/>
               </a:ext>
             </a:extLst>
           </p:cNvPr>
@@ -22789,7 +22702,7 @@
           <p:cNvPr id="28" name="Oval 27">
             <a:extLst>
               <a:ext uri="{FF2B5EF4-FFF2-40B4-BE49-F238E27FC236}">
-                <ns2:creationId id="{9ADB633C-4072-1C73-DADA-398777D0A7CD}"/>
+                <a16:creationId xmlns:a16="http://schemas.microsoft.com/office/drawing/2014/main" id="{9ADB633C-4072-1C73-DADA-398777D0A7CD}"/>
               </a:ext>
             </a:extLst>
           </p:cNvPr>
@@ -22873,7 +22786,7 @@
           <p:cNvPr id="29" name="Oval 28">
             <a:extLst>
               <a:ext uri="{FF2B5EF4-FFF2-40B4-BE49-F238E27FC236}">
-                <ns2:creationId id="{F82B7B38-EA39-2CF9-201C-54B73DBBD4EA}"/>
+                <a16:creationId xmlns:a16="http://schemas.microsoft.com/office/drawing/2014/main" id="{F82B7B38-EA39-2CF9-201C-54B73DBBD4EA}"/>
               </a:ext>
             </a:extLst>
           </p:cNvPr>
@@ -22957,7 +22870,7 @@
           <p:cNvPr id="30" name="Oval 29">
             <a:extLst>
               <a:ext uri="{FF2B5EF4-FFF2-40B4-BE49-F238E27FC236}">
-                <ns2:creationId id="{686BDBE9-0138-6C28-BFAF-00EA8DCD973D}"/>
+                <a16:creationId xmlns:a16="http://schemas.microsoft.com/office/drawing/2014/main" id="{686BDBE9-0138-6C28-BFAF-00EA8DCD973D}"/>
               </a:ext>
             </a:extLst>
           </p:cNvPr>
@@ -23041,7 +22954,7 @@
           <p:cNvPr id="4" name="Straight Connector 3">
             <a:extLst>
               <a:ext uri="{FF2B5EF4-FFF2-40B4-BE49-F238E27FC236}">
-                <ns2:creationId id="{D0AC705D-BF37-4542-CD33-8265C0D398AC}"/>
+                <a16:creationId xmlns:a16="http://schemas.microsoft.com/office/drawing/2014/main" id="{D0AC705D-BF37-4542-CD33-8265C0D398AC}"/>
               </a:ext>
             </a:extLst>
           </p:cNvPr>
@@ -23084,7 +22997,7 @@
           <p:cNvPr id="18" name="Oval 17">
             <a:extLst>
               <a:ext uri="{FF2B5EF4-FFF2-40B4-BE49-F238E27FC236}">
-                <ns2:creationId id="{5CEE4D57-2D48-3E46-8211-494134A5C094}"/>
+                <a16:creationId xmlns:a16="http://schemas.microsoft.com/office/drawing/2014/main" id="{5CEE4D57-2D48-3E46-8211-494134A5C094}"/>
               </a:ext>
             </a:extLst>
           </p:cNvPr>
@@ -23167,7 +23080,7 @@
           <p:cNvPr id="11" name="Group 10">
             <a:extLst>
               <a:ext uri="{FF2B5EF4-FFF2-40B4-BE49-F238E27FC236}">
-                <ns2:creationId id="{D24EBF2A-B7A3-E7EB-6313-BB50CF2D3A83}"/>
+                <a16:creationId xmlns:a16="http://schemas.microsoft.com/office/drawing/2014/main" id="{D24EBF2A-B7A3-E7EB-6313-BB50CF2D3A83}"/>
               </a:ext>
             </a:extLst>
           </p:cNvPr>
@@ -23187,7 +23100,7 @@
             <p:cNvPr id="24" name="Straight Arrow Connector 23">
               <a:extLst>
                 <a:ext uri="{FF2B5EF4-FFF2-40B4-BE49-F238E27FC236}">
-                  <ns2:creationId id="{9C627068-AD0C-E2DC-60AF-7257BB046983}"/>
+                  <a16:creationId xmlns:a16="http://schemas.microsoft.com/office/drawing/2014/main" id="{9C627068-AD0C-E2DC-60AF-7257BB046983}"/>
                 </a:ext>
               </a:extLst>
             </p:cNvPr>
@@ -23232,7 +23145,7 @@
             <p:cNvPr id="10" name="TextBox 9">
               <a:extLst>
                 <a:ext uri="{FF2B5EF4-FFF2-40B4-BE49-F238E27FC236}">
-                  <ns2:creationId id="{D692B828-D19F-3AA3-05F9-AF2DE3D5C9FC}"/>
+                  <a16:creationId xmlns:a16="http://schemas.microsoft.com/office/drawing/2014/main" id="{D692B828-D19F-3AA3-05F9-AF2DE3D5C9FC}"/>
                 </a:ext>
               </a:extLst>
             </p:cNvPr>
@@ -23315,7 +23228,7 @@
           <p:cNvPr id="31" name="TextBox 30">
             <a:extLst>
               <a:ext uri="{FF2B5EF4-FFF2-40B4-BE49-F238E27FC236}">
-                <ns2:creationId id="{12D2397C-9CE3-3A8A-1558-56A5A0738C36}"/>
+                <a16:creationId xmlns:a16="http://schemas.microsoft.com/office/drawing/2014/main" id="{12D2397C-9CE3-3A8A-1558-56A5A0738C36}"/>
               </a:ext>
             </a:extLst>
           </p:cNvPr>
@@ -23417,7 +23330,7 @@
           <p:cNvPr id="36" name="TextBox 35">
             <a:extLst>
               <a:ext uri="{FF2B5EF4-FFF2-40B4-BE49-F238E27FC236}">
-                <ns2:creationId id="{2FFE4CF6-AAAC-06EA-8AB8-998E05647728}"/>
+                <a16:creationId xmlns:a16="http://schemas.microsoft.com/office/drawing/2014/main" id="{2FFE4CF6-AAAC-06EA-8AB8-998E05647728}"/>
               </a:ext>
             </a:extLst>
           </p:cNvPr>
@@ -23499,7 +23412,7 @@
           <p:cNvPr id="22" name="Straight Connector 21">
             <a:extLst>
               <a:ext uri="{FF2B5EF4-FFF2-40B4-BE49-F238E27FC236}">
-                <ns2:creationId id="{2F9013F0-6C27-F3C3-FDE3-FF0AA12CA620}"/>
+                <a16:creationId xmlns:a16="http://schemas.microsoft.com/office/drawing/2014/main" id="{2F9013F0-6C27-F3C3-FDE3-FF0AA12CA620}"/>
               </a:ext>
             </a:extLst>
           </p:cNvPr>
@@ -23542,7 +23455,7 @@
           <p:cNvPr id="15" name="Straight Arrow Connector 14">
             <a:extLst>
               <a:ext uri="{FF2B5EF4-FFF2-40B4-BE49-F238E27FC236}">
-                <ns2:creationId id="{59CD0CED-2A06-8AB7-8A69-21FAC5EC4A4F}"/>
+                <a16:creationId xmlns:a16="http://schemas.microsoft.com/office/drawing/2014/main" id="{59CD0CED-2A06-8AB7-8A69-21FAC5EC4A4F}"/>
               </a:ext>
             </a:extLst>
           </p:cNvPr>
@@ -23588,7 +23501,7 @@
           <p:cNvPr id="32" name="Straight Arrow Connector 31">
             <a:extLst>
               <a:ext uri="{FF2B5EF4-FFF2-40B4-BE49-F238E27FC236}">
-                <ns2:creationId id="{BCC5A9F1-9339-0CF6-A18E-4B7BE46AB529}"/>
+                <a16:creationId xmlns:a16="http://schemas.microsoft.com/office/drawing/2014/main" id="{BCC5A9F1-9339-0CF6-A18E-4B7BE46AB529}"/>
               </a:ext>
             </a:extLst>
           </p:cNvPr>
@@ -23634,7 +23547,7 @@
           <p:cNvPr id="35" name="Straight Arrow Connector 34">
             <a:extLst>
               <a:ext uri="{FF2B5EF4-FFF2-40B4-BE49-F238E27FC236}">
-                <ns2:creationId id="{8E4A4C4F-C09E-5B89-67FD-259D584337FE}"/>
+                <a16:creationId xmlns:a16="http://schemas.microsoft.com/office/drawing/2014/main" id="{8E4A4C4F-C09E-5B89-67FD-259D584337FE}"/>
               </a:ext>
             </a:extLst>
           </p:cNvPr>
@@ -23680,7 +23593,7 @@
           <p:cNvPr id="39" name="Straight Arrow Connector 38">
             <a:extLst>
               <a:ext uri="{FF2B5EF4-FFF2-40B4-BE49-F238E27FC236}">
-                <ns2:creationId id="{D4742DE8-0901-2B65-C6B7-3A1BE131F28D}"/>
+                <a16:creationId xmlns:a16="http://schemas.microsoft.com/office/drawing/2014/main" id="{D4742DE8-0901-2B65-C6B7-3A1BE131F28D}"/>
               </a:ext>
             </a:extLst>
           </p:cNvPr>
@@ -23726,7 +23639,7 @@
           <p:cNvPr id="47" name="Straight Arrow Connector 46">
             <a:extLst>
               <a:ext uri="{FF2B5EF4-FFF2-40B4-BE49-F238E27FC236}">
-                <ns2:creationId id="{1D9F791F-D5A7-688F-041A-11963370907B}"/>
+                <a16:creationId xmlns:a16="http://schemas.microsoft.com/office/drawing/2014/main" id="{1D9F791F-D5A7-688F-041A-11963370907B}"/>
               </a:ext>
             </a:extLst>
           </p:cNvPr>
@@ -23772,7 +23685,7 @@
           <p:cNvPr id="9" name="TextBox 8">
             <a:extLst>
               <a:ext uri="{FF2B5EF4-FFF2-40B4-BE49-F238E27FC236}">
-                <ns2:creationId id="{349C01A4-7FD7-1FD3-430A-5950B62E2AB0}"/>
+                <a16:creationId xmlns:a16="http://schemas.microsoft.com/office/drawing/2014/main" id="{349C01A4-7FD7-1FD3-430A-5950B62E2AB0}"/>
               </a:ext>
             </a:extLst>
           </p:cNvPr>
@@ -23854,7 +23767,7 @@
           <p:cNvPr id="14" name="Rectangle 13">
             <a:extLst>
               <a:ext uri="{FF2B5EF4-FFF2-40B4-BE49-F238E27FC236}">
-                <ns2:creationId id="{55CC6FCD-E4CC-D5E1-7E8F-917869655222}"/>
+                <a16:creationId xmlns:a16="http://schemas.microsoft.com/office/drawing/2014/main" id="{55CC6FCD-E4CC-D5E1-7E8F-917869655222}"/>
               </a:ext>
             </a:extLst>
           </p:cNvPr>
@@ -23923,7 +23836,7 @@
           <p:cNvPr id="16" name="TextBox 15">
             <a:extLst>
               <a:ext uri="{FF2B5EF4-FFF2-40B4-BE49-F238E27FC236}">
-                <ns2:creationId id="{165EF7AF-4C2A-3413-7653-A4678D7A12B0}"/>
+                <a16:creationId xmlns:a16="http://schemas.microsoft.com/office/drawing/2014/main" id="{165EF7AF-4C2A-3413-7653-A4678D7A12B0}"/>
               </a:ext>
             </a:extLst>
           </p:cNvPr>
@@ -23988,7 +23901,7 @@
           <p:cNvPr id="17" name="TextBox 16">
             <a:extLst>
               <a:ext uri="{FF2B5EF4-FFF2-40B4-BE49-F238E27FC236}">
-                <ns2:creationId id="{8221C174-AABC-987E-E052-795F476EAF22}"/>
+                <a16:creationId xmlns:a16="http://schemas.microsoft.com/office/drawing/2014/main" id="{8221C174-AABC-987E-E052-795F476EAF22}"/>
               </a:ext>
             </a:extLst>
           </p:cNvPr>
@@ -24079,7 +23992,41 @@
                 <a:ea typeface="Helvetica Neue" panose="02000503000000020004" pitchFamily="2" charset="0"/>
                 <a:cs typeface="Helvetica Neue" panose="02000503000000020004" pitchFamily="2" charset="0"/>
               </a:rPr>
-              <a:t>The wake comes from polarity and spreads outward; its density falls like 1/r^2.</a:t>
+              <a:t>The wake comes from polarity and spreads outward; its density falls like 1/r</a:t>
+            </a:r>
+            <a:r>
+              <a:rPr kumimoji="0" lang="en-US" sz="1600" b="0" i="0" u="none" strike="noStrike" kern="1200" cap="none" spc="0" normalizeH="0" baseline="30000" noProof="0" dirty="0">
+                <a:ln>
+                  <a:noFill/>
+                </a:ln>
+                <a:solidFill>
+                  <a:prstClr val="white"/>
+                </a:solidFill>
+                <a:effectLst/>
+                <a:uLnTx/>
+                <a:uFillTx/>
+                <a:latin typeface="Helvetica Neue" panose="02000503000000020004" pitchFamily="2" charset="0"/>
+                <a:ea typeface="Helvetica Neue" panose="02000503000000020004" pitchFamily="2" charset="0"/>
+                <a:cs typeface="Helvetica Neue" panose="02000503000000020004" pitchFamily="2" charset="0"/>
+              </a:rPr>
+              <a:t>2</a:t>
+            </a:r>
+            <a:r>
+              <a:rPr kumimoji="0" lang="en-US" sz="1600" b="0" i="0" u="none" strike="noStrike" kern="1200" cap="none" spc="0" normalizeH="0" baseline="0" noProof="0" dirty="0">
+                <a:ln>
+                  <a:noFill/>
+                </a:ln>
+                <a:solidFill>
+                  <a:prstClr val="white"/>
+                </a:solidFill>
+                <a:effectLst/>
+                <a:uLnTx/>
+                <a:uFillTx/>
+                <a:latin typeface="Helvetica Neue" panose="02000503000000020004" pitchFamily="2" charset="0"/>
+                <a:ea typeface="Helvetica Neue" panose="02000503000000020004" pitchFamily="2" charset="0"/>
+                <a:cs typeface="Helvetica Neue" panose="02000503000000020004" pitchFamily="2" charset="0"/>
+              </a:rPr>
+              <a:t>.</a:t>
             </a:r>
           </a:p>
           <a:p>
@@ -24123,7 +24070,7 @@
     </p:spTree>
     <p:extLst>
       <p:ext uri="{BB962C8B-B14F-4D97-AF65-F5344CB8AC3E}">
-        <p14:creationId val="1156335298"/>
+        <p14:creationId xmlns:p14="http://schemas.microsoft.com/office/powerpoint/2010/main" val="1156335298"/>
       </p:ext>
     </p:extLst>
   </p:cSld>
@@ -24134,7 +24081,7 @@
 </file>
 
 <file path=ppt/slides/slide5.xml><?xml version="1.0" encoding="utf-8"?>
-<p:sld xmlns:a="http://schemas.openxmlformats.org/drawingml/2006/main" xmlns:ns2="http://schemas.microsoft.com/office/drawing/2014/main" xmlns:p="http://schemas.openxmlformats.org/presentationml/2006/main" xmlns:p14="http://schemas.microsoft.com/office/powerpoint/2010/main">
+<p:sld xmlns:a="http://schemas.openxmlformats.org/drawingml/2006/main" xmlns:r="http://schemas.openxmlformats.org/officeDocument/2006/relationships" xmlns:p="http://schemas.openxmlformats.org/presentationml/2006/main">
   <p:cSld>
     <p:bg>
       <p:bgPr>
@@ -24163,7 +24110,7 @@
           <p:cNvPr id="5" name="Footer Placeholder 3">
             <a:extLst>
               <a:ext uri="{FF2B5EF4-FFF2-40B4-BE49-F238E27FC236}">
-                <ns2:creationId id="{668F77D6-DFDA-5A46-8DF1-47F6A167C2B1}"/>
+                <a16:creationId xmlns:a16="http://schemas.microsoft.com/office/drawing/2014/main" id="{668F77D6-DFDA-5A46-8DF1-47F6A167C2B1}"/>
               </a:ext>
             </a:extLst>
           </p:cNvPr>
@@ -24325,7 +24272,7 @@
           <p:cNvPr id="3" name="Straight Arrow Connector 2">
             <a:extLst>
               <a:ext uri="{FF2B5EF4-FFF2-40B4-BE49-F238E27FC236}">
-                <ns2:creationId id="{2EF0199F-22F4-BA42-9B75-8A8183BCDA9B}"/>
+                <a16:creationId xmlns:a16="http://schemas.microsoft.com/office/drawing/2014/main" id="{2EF0199F-22F4-BA42-9B75-8A8183BCDA9B}"/>
               </a:ext>
             </a:extLst>
           </p:cNvPr>
@@ -24369,7 +24316,7 @@
           <p:cNvPr id="8" name="Straight Arrow Connector 7">
             <a:extLst>
               <a:ext uri="{FF2B5EF4-FFF2-40B4-BE49-F238E27FC236}">
-                <ns2:creationId id="{49AB5343-55D0-6041-8627-E08A73F83930}"/>
+                <a16:creationId xmlns:a16="http://schemas.microsoft.com/office/drawing/2014/main" id="{49AB5343-55D0-6041-8627-E08A73F83930}"/>
               </a:ext>
             </a:extLst>
           </p:cNvPr>
@@ -24413,7 +24360,7 @@
           <p:cNvPr id="12" name="TextBox 11">
             <a:extLst>
               <a:ext uri="{FF2B5EF4-FFF2-40B4-BE49-F238E27FC236}">
-                <ns2:creationId id="{BF8D86A2-D083-024A-BC90-6BD938C23243}"/>
+                <a16:creationId xmlns:a16="http://schemas.microsoft.com/office/drawing/2014/main" id="{BF8D86A2-D083-024A-BC90-6BD938C23243}"/>
               </a:ext>
             </a:extLst>
           </p:cNvPr>
@@ -24478,7 +24425,7 @@
           <p:cNvPr id="13" name="TextBox 12">
             <a:extLst>
               <a:ext uri="{FF2B5EF4-FFF2-40B4-BE49-F238E27FC236}">
-                <ns2:creationId id="{2C3F4604-6C2F-0E4E-9DD3-4F5C89FF51AB}"/>
+                <a16:creationId xmlns:a16="http://schemas.microsoft.com/office/drawing/2014/main" id="{2C3F4604-6C2F-0E4E-9DD3-4F5C89FF51AB}"/>
               </a:ext>
             </a:extLst>
           </p:cNvPr>
@@ -24539,7 +24486,7 @@
           <p:cNvPr id="23" name="Oval 22">
             <a:extLst>
               <a:ext uri="{FF2B5EF4-FFF2-40B4-BE49-F238E27FC236}">
-                <ns2:creationId id="{0112617B-A1D5-1E41-BF92-E67D4E046E39}"/>
+                <a16:creationId xmlns:a16="http://schemas.microsoft.com/office/drawing/2014/main" id="{0112617B-A1D5-1E41-BF92-E67D4E046E39}"/>
               </a:ext>
             </a:extLst>
           </p:cNvPr>
@@ -24623,7 +24570,7 @@
           <p:cNvPr id="27" name="Oval 26">
             <a:extLst>
               <a:ext uri="{FF2B5EF4-FFF2-40B4-BE49-F238E27FC236}">
-                <ns2:creationId id="{6EF0F7DA-5E70-8348-A200-F59A10FF7C55}"/>
+                <a16:creationId xmlns:a16="http://schemas.microsoft.com/office/drawing/2014/main" id="{6EF0F7DA-5E70-8348-A200-F59A10FF7C55}"/>
               </a:ext>
             </a:extLst>
           </p:cNvPr>
@@ -24707,7 +24654,7 @@
           <p:cNvPr id="28" name="Oval 27">
             <a:extLst>
               <a:ext uri="{FF2B5EF4-FFF2-40B4-BE49-F238E27FC236}">
-                <ns2:creationId id="{552F58D0-F613-674A-B294-C894E5FB1683}"/>
+                <a16:creationId xmlns:a16="http://schemas.microsoft.com/office/drawing/2014/main" id="{552F58D0-F613-674A-B294-C894E5FB1683}"/>
               </a:ext>
             </a:extLst>
           </p:cNvPr>
@@ -24791,7 +24738,7 @@
           <p:cNvPr id="29" name="Oval 28">
             <a:extLst>
               <a:ext uri="{FF2B5EF4-FFF2-40B4-BE49-F238E27FC236}">
-                <ns2:creationId id="{9CA7A721-D3BD-744E-9306-85BBED5F74BC}"/>
+                <a16:creationId xmlns:a16="http://schemas.microsoft.com/office/drawing/2014/main" id="{9CA7A721-D3BD-744E-9306-85BBED5F74BC}"/>
               </a:ext>
             </a:extLst>
           </p:cNvPr>
@@ -24875,7 +24822,7 @@
           <p:cNvPr id="30" name="Oval 29">
             <a:extLst>
               <a:ext uri="{FF2B5EF4-FFF2-40B4-BE49-F238E27FC236}">
-                <ns2:creationId id="{F97F1A02-C0C7-3C45-9790-847C152D159A}"/>
+                <a16:creationId xmlns:a16="http://schemas.microsoft.com/office/drawing/2014/main" id="{F97F1A02-C0C7-3C45-9790-847C152D159A}"/>
               </a:ext>
             </a:extLst>
           </p:cNvPr>
@@ -24959,7 +24906,7 @@
           <p:cNvPr id="4" name="Straight Connector 3">
             <a:extLst>
               <a:ext uri="{FF2B5EF4-FFF2-40B4-BE49-F238E27FC236}">
-                <ns2:creationId id="{9890CC23-4ADC-D744-AF2D-1C8A936F07FC}"/>
+                <a16:creationId xmlns:a16="http://schemas.microsoft.com/office/drawing/2014/main" id="{9890CC23-4ADC-D744-AF2D-1C8A936F07FC}"/>
               </a:ext>
             </a:extLst>
           </p:cNvPr>
@@ -25002,7 +24949,7 @@
           <p:cNvPr id="18" name="Oval 17">
             <a:extLst>
               <a:ext uri="{FF2B5EF4-FFF2-40B4-BE49-F238E27FC236}">
-                <ns2:creationId id="{BE4CDC90-4B2E-BE41-BB9D-A84675F3A2FE}"/>
+                <a16:creationId xmlns:a16="http://schemas.microsoft.com/office/drawing/2014/main" id="{BE4CDC90-4B2E-BE41-BB9D-A84675F3A2FE}"/>
               </a:ext>
             </a:extLst>
           </p:cNvPr>
@@ -25085,7 +25032,7 @@
           <p:cNvPr id="11" name="Group 10">
             <a:extLst>
               <a:ext uri="{FF2B5EF4-FFF2-40B4-BE49-F238E27FC236}">
-                <ns2:creationId id="{33483591-0E05-544C-B822-43CF81B12E63}"/>
+                <a16:creationId xmlns:a16="http://schemas.microsoft.com/office/drawing/2014/main" id="{33483591-0E05-544C-B822-43CF81B12E63}"/>
               </a:ext>
             </a:extLst>
           </p:cNvPr>
@@ -25105,7 +25052,7 @@
             <p:cNvPr id="24" name="Straight Arrow Connector 23">
               <a:extLst>
                 <a:ext uri="{FF2B5EF4-FFF2-40B4-BE49-F238E27FC236}">
-                  <ns2:creationId id="{7BCF22C9-C9AE-324D-B157-A9536FCAF3B6}"/>
+                  <a16:creationId xmlns:a16="http://schemas.microsoft.com/office/drawing/2014/main" id="{7BCF22C9-C9AE-324D-B157-A9536FCAF3B6}"/>
                 </a:ext>
               </a:extLst>
             </p:cNvPr>
@@ -25150,7 +25097,7 @@
             <p:cNvPr id="10" name="TextBox 9">
               <a:extLst>
                 <a:ext uri="{FF2B5EF4-FFF2-40B4-BE49-F238E27FC236}">
-                  <ns2:creationId id="{01A59953-657F-C641-8F36-E48E8EDB0DF1}"/>
+                  <a16:creationId xmlns:a16="http://schemas.microsoft.com/office/drawing/2014/main" id="{01A59953-657F-C641-8F36-E48E8EDB0DF1}"/>
                 </a:ext>
               </a:extLst>
             </p:cNvPr>
@@ -25233,7 +25180,7 @@
           <p:cNvPr id="31" name="TextBox 30">
             <a:extLst>
               <a:ext uri="{FF2B5EF4-FFF2-40B4-BE49-F238E27FC236}">
-                <ns2:creationId id="{713B9ACE-B673-2D48-BEF2-2A133C31B527}"/>
+                <a16:creationId xmlns:a16="http://schemas.microsoft.com/office/drawing/2014/main" id="{713B9ACE-B673-2D48-BEF2-2A133C31B527}"/>
               </a:ext>
             </a:extLst>
           </p:cNvPr>
@@ -25335,7 +25282,7 @@
           <p:cNvPr id="36" name="TextBox 35">
             <a:extLst>
               <a:ext uri="{FF2B5EF4-FFF2-40B4-BE49-F238E27FC236}">
-                <ns2:creationId id="{3A81A480-EF64-094E-825A-8592DAA4C672}"/>
+                <a16:creationId xmlns:a16="http://schemas.microsoft.com/office/drawing/2014/main" id="{3A81A480-EF64-094E-825A-8592DAA4C672}"/>
               </a:ext>
             </a:extLst>
           </p:cNvPr>
@@ -25417,7 +25364,7 @@
           <p:cNvPr id="7" name="Rectangle 6">
             <a:extLst>
               <a:ext uri="{FF2B5EF4-FFF2-40B4-BE49-F238E27FC236}">
-                <ns2:creationId id="{BED67AD4-F230-35A0-28FB-DE984573A446}"/>
+                <a16:creationId xmlns:a16="http://schemas.microsoft.com/office/drawing/2014/main" id="{BED67AD4-F230-35A0-28FB-DE984573A446}"/>
               </a:ext>
             </a:extLst>
           </p:cNvPr>
@@ -25481,7 +25428,7 @@
           <p:cNvPr id="15" name="Straight Arrow Connector 14">
             <a:extLst>
               <a:ext uri="{FF2B5EF4-FFF2-40B4-BE49-F238E27FC236}">
-                <ns2:creationId id="{05289ED1-4679-6543-A669-B23443FD0CD8}"/>
+                <a16:creationId xmlns:a16="http://schemas.microsoft.com/office/drawing/2014/main" id="{05289ED1-4679-6543-A669-B23443FD0CD8}"/>
               </a:ext>
             </a:extLst>
           </p:cNvPr>
@@ -25527,7 +25474,7 @@
           <p:cNvPr id="32" name="Straight Arrow Connector 31">
             <a:extLst>
               <a:ext uri="{FF2B5EF4-FFF2-40B4-BE49-F238E27FC236}">
-                <ns2:creationId id="{A9F8BF55-7F79-854D-84AD-A730BF43B39C}"/>
+                <a16:creationId xmlns:a16="http://schemas.microsoft.com/office/drawing/2014/main" id="{A9F8BF55-7F79-854D-84AD-A730BF43B39C}"/>
               </a:ext>
             </a:extLst>
           </p:cNvPr>
@@ -25573,7 +25520,7 @@
           <p:cNvPr id="35" name="Straight Arrow Connector 34">
             <a:extLst>
               <a:ext uri="{FF2B5EF4-FFF2-40B4-BE49-F238E27FC236}">
-                <ns2:creationId id="{0415B495-590C-0049-92E6-8AE7464CC78A}"/>
+                <a16:creationId xmlns:a16="http://schemas.microsoft.com/office/drawing/2014/main" id="{0415B495-590C-0049-92E6-8AE7464CC78A}"/>
               </a:ext>
             </a:extLst>
           </p:cNvPr>
@@ -25619,7 +25566,7 @@
           <p:cNvPr id="39" name="Straight Arrow Connector 38">
             <a:extLst>
               <a:ext uri="{FF2B5EF4-FFF2-40B4-BE49-F238E27FC236}">
-                <ns2:creationId id="{E4879E96-726B-4F42-BD7C-09F8D0B14E9A}"/>
+                <a16:creationId xmlns:a16="http://schemas.microsoft.com/office/drawing/2014/main" id="{E4879E96-726B-4F42-BD7C-09F8D0B14E9A}"/>
               </a:ext>
             </a:extLst>
           </p:cNvPr>
@@ -25665,7 +25612,7 @@
           <p:cNvPr id="47" name="Straight Arrow Connector 46">
             <a:extLst>
               <a:ext uri="{FF2B5EF4-FFF2-40B4-BE49-F238E27FC236}">
-                <ns2:creationId id="{0F119609-4333-414A-B8E4-E2447D7E1C10}"/>
+                <a16:creationId xmlns:a16="http://schemas.microsoft.com/office/drawing/2014/main" id="{0F119609-4333-414A-B8E4-E2447D7E1C10}"/>
               </a:ext>
             </a:extLst>
           </p:cNvPr>
@@ -25711,7 +25658,7 @@
           <p:cNvPr id="9" name="TextBox 8">
             <a:extLst>
               <a:ext uri="{FF2B5EF4-FFF2-40B4-BE49-F238E27FC236}">
-                <ns2:creationId id="{F869BF73-0970-4AD4-4DCD-712A77055671}"/>
+                <a16:creationId xmlns:a16="http://schemas.microsoft.com/office/drawing/2014/main" id="{F869BF73-0970-4AD4-4DCD-712A77055671}"/>
               </a:ext>
             </a:extLst>
           </p:cNvPr>
@@ -25793,7 +25740,7 @@
           <p:cNvPr id="16" name="Oval 15">
             <a:extLst>
               <a:ext uri="{FF2B5EF4-FFF2-40B4-BE49-F238E27FC236}">
-                <ns2:creationId id="{47B844F6-2777-F09D-48E3-752AD4A1C08E}"/>
+                <a16:creationId xmlns:a16="http://schemas.microsoft.com/office/drawing/2014/main" id="{47B844F6-2777-F09D-48E3-752AD4A1C08E}"/>
               </a:ext>
             </a:extLst>
           </p:cNvPr>
@@ -25876,7 +25823,7 @@
           <p:cNvPr id="17" name="Straight Connector 16">
             <a:extLst>
               <a:ext uri="{FF2B5EF4-FFF2-40B4-BE49-F238E27FC236}">
-                <ns2:creationId id="{7AC80066-19A2-40E6-CB32-8D867099AEC0}"/>
+                <a16:creationId xmlns:a16="http://schemas.microsoft.com/office/drawing/2014/main" id="{7AC80066-19A2-40E6-CB32-8D867099AEC0}"/>
               </a:ext>
             </a:extLst>
           </p:cNvPr>
@@ -25921,7 +25868,7 @@
           <p:cNvPr id="33" name="Oval 32">
             <a:extLst>
               <a:ext uri="{FF2B5EF4-FFF2-40B4-BE49-F238E27FC236}">
-                <ns2:creationId id="{E44B2491-CAC8-31F5-74F1-2F5E82758D29}"/>
+                <a16:creationId xmlns:a16="http://schemas.microsoft.com/office/drawing/2014/main" id="{E44B2491-CAC8-31F5-74F1-2F5E82758D29}"/>
               </a:ext>
             </a:extLst>
           </p:cNvPr>
@@ -26004,7 +25951,7 @@
           <p:cNvPr id="34" name="Straight Connector 33">
             <a:extLst>
               <a:ext uri="{FF2B5EF4-FFF2-40B4-BE49-F238E27FC236}">
-                <ns2:creationId id="{39925079-57E3-C749-66BE-49320C7E84EA}"/>
+                <a16:creationId xmlns:a16="http://schemas.microsoft.com/office/drawing/2014/main" id="{39925079-57E3-C749-66BE-49320C7E84EA}"/>
               </a:ext>
             </a:extLst>
           </p:cNvPr>
@@ -26047,7 +25994,7 @@
     </p:spTree>
     <p:extLst>
       <p:ext uri="{BB962C8B-B14F-4D97-AF65-F5344CB8AC3E}">
-        <p14:creationId val="155428920"/>
+        <p14:creationId xmlns:p14="http://schemas.microsoft.com/office/powerpoint/2010/main" val="155428920"/>
       </p:ext>
     </p:extLst>
   </p:cSld>
@@ -26058,7 +26005,7 @@
 </file>
 
 <file path=ppt/slides/slide6.xml><?xml version="1.0" encoding="utf-8"?>
-<p:sld xmlns:a="http://schemas.openxmlformats.org/drawingml/2006/main" xmlns:ns2="http://schemas.microsoft.com/office/drawing/2014/main" xmlns:p="http://schemas.openxmlformats.org/presentationml/2006/main" xmlns:p14="http://schemas.microsoft.com/office/powerpoint/2010/main">
+<p:sld xmlns:a="http://schemas.openxmlformats.org/drawingml/2006/main" xmlns:r="http://schemas.openxmlformats.org/officeDocument/2006/relationships" xmlns:p="http://schemas.openxmlformats.org/presentationml/2006/main">
   <p:cSld>
     <p:bg>
       <p:bgPr>
@@ -26087,7 +26034,7 @@
           <p:cNvPr id="5" name="Footer Placeholder 3">
             <a:extLst>
               <a:ext uri="{FF2B5EF4-FFF2-40B4-BE49-F238E27FC236}">
-                <ns2:creationId id="{668F77D6-DFDA-5A46-8DF1-47F6A167C2B1}"/>
+                <a16:creationId xmlns:a16="http://schemas.microsoft.com/office/drawing/2014/main" id="{668F77D6-DFDA-5A46-8DF1-47F6A167C2B1}"/>
               </a:ext>
             </a:extLst>
           </p:cNvPr>
@@ -26249,7 +26196,7 @@
           <p:cNvPr id="26" name="TextBox 25">
             <a:extLst>
               <a:ext uri="{FF2B5EF4-FFF2-40B4-BE49-F238E27FC236}">
-                <ns2:creationId id="{FA5E13D2-A15E-F54D-9507-CAD768919361}"/>
+                <a16:creationId xmlns:a16="http://schemas.microsoft.com/office/drawing/2014/main" id="{FA5E13D2-A15E-F54D-9507-CAD768919361}"/>
               </a:ext>
             </a:extLst>
           </p:cNvPr>
@@ -26258,7 +26205,7 @@
         </p:nvSpPr>
         <p:spPr>
           <a:xfrm>
-            <a:off x="1788936" y="4683408"/>
+            <a:off x="2767504" y="4701784"/>
             <a:ext cx="9598423" cy="1477328"/>
           </a:xfrm>
           <a:prstGeom prst="rect">
@@ -26458,7 +26405,7 @@
           <p:cNvPr id="23" name="Oval 22">
             <a:extLst>
               <a:ext uri="{FF2B5EF4-FFF2-40B4-BE49-F238E27FC236}">
-                <ns2:creationId id="{0112617B-A1D5-1E41-BF92-E67D4E046E39}"/>
+                <a16:creationId xmlns:a16="http://schemas.microsoft.com/office/drawing/2014/main" id="{0112617B-A1D5-1E41-BF92-E67D4E046E39}"/>
               </a:ext>
             </a:extLst>
           </p:cNvPr>
@@ -26542,7 +26489,7 @@
           <p:cNvPr id="27" name="Oval 26">
             <a:extLst>
               <a:ext uri="{FF2B5EF4-FFF2-40B4-BE49-F238E27FC236}">
-                <ns2:creationId id="{6EF0F7DA-5E70-8348-A200-F59A10FF7C55}"/>
+                <a16:creationId xmlns:a16="http://schemas.microsoft.com/office/drawing/2014/main" id="{6EF0F7DA-5E70-8348-A200-F59A10FF7C55}"/>
               </a:ext>
             </a:extLst>
           </p:cNvPr>
@@ -26626,7 +26573,7 @@
           <p:cNvPr id="28" name="Oval 27">
             <a:extLst>
               <a:ext uri="{FF2B5EF4-FFF2-40B4-BE49-F238E27FC236}">
-                <ns2:creationId id="{552F58D0-F613-674A-B294-C894E5FB1683}"/>
+                <a16:creationId xmlns:a16="http://schemas.microsoft.com/office/drawing/2014/main" id="{552F58D0-F613-674A-B294-C894E5FB1683}"/>
               </a:ext>
             </a:extLst>
           </p:cNvPr>
@@ -26710,7 +26657,7 @@
           <p:cNvPr id="29" name="Oval 28">
             <a:extLst>
               <a:ext uri="{FF2B5EF4-FFF2-40B4-BE49-F238E27FC236}">
-                <ns2:creationId id="{9CA7A721-D3BD-744E-9306-85BBED5F74BC}"/>
+                <a16:creationId xmlns:a16="http://schemas.microsoft.com/office/drawing/2014/main" id="{9CA7A721-D3BD-744E-9306-85BBED5F74BC}"/>
               </a:ext>
             </a:extLst>
           </p:cNvPr>
@@ -26794,7 +26741,7 @@
           <p:cNvPr id="30" name="Oval 29">
             <a:extLst>
               <a:ext uri="{FF2B5EF4-FFF2-40B4-BE49-F238E27FC236}">
-                <ns2:creationId id="{F97F1A02-C0C7-3C45-9790-847C152D159A}"/>
+                <a16:creationId xmlns:a16="http://schemas.microsoft.com/office/drawing/2014/main" id="{F97F1A02-C0C7-3C45-9790-847C152D159A}"/>
               </a:ext>
             </a:extLst>
           </p:cNvPr>
@@ -26878,7 +26825,7 @@
           <p:cNvPr id="15" name="Straight Arrow Connector 14">
             <a:extLst>
               <a:ext uri="{FF2B5EF4-FFF2-40B4-BE49-F238E27FC236}">
-                <ns2:creationId id="{05289ED1-4679-6543-A669-B23443FD0CD8}"/>
+                <a16:creationId xmlns:a16="http://schemas.microsoft.com/office/drawing/2014/main" id="{05289ED1-4679-6543-A669-B23443FD0CD8}"/>
               </a:ext>
             </a:extLst>
           </p:cNvPr>
@@ -26923,7 +26870,7 @@
           <p:cNvPr id="32" name="Straight Arrow Connector 31">
             <a:extLst>
               <a:ext uri="{FF2B5EF4-FFF2-40B4-BE49-F238E27FC236}">
-                <ns2:creationId id="{A9F8BF55-7F79-854D-84AD-A730BF43B39C}"/>
+                <a16:creationId xmlns:a16="http://schemas.microsoft.com/office/drawing/2014/main" id="{A9F8BF55-7F79-854D-84AD-A730BF43B39C}"/>
               </a:ext>
             </a:extLst>
           </p:cNvPr>
@@ -26968,7 +26915,7 @@
           <p:cNvPr id="35" name="Straight Arrow Connector 34">
             <a:extLst>
               <a:ext uri="{FF2B5EF4-FFF2-40B4-BE49-F238E27FC236}">
-                <ns2:creationId id="{0415B495-590C-0049-92E6-8AE7464CC78A}"/>
+                <a16:creationId xmlns:a16="http://schemas.microsoft.com/office/drawing/2014/main" id="{0415B495-590C-0049-92E6-8AE7464CC78A}"/>
               </a:ext>
             </a:extLst>
           </p:cNvPr>
@@ -27013,7 +26960,7 @@
           <p:cNvPr id="39" name="Straight Arrow Connector 38">
             <a:extLst>
               <a:ext uri="{FF2B5EF4-FFF2-40B4-BE49-F238E27FC236}">
-                <ns2:creationId id="{E4879E96-726B-4F42-BD7C-09F8D0B14E9A}"/>
+                <a16:creationId xmlns:a16="http://schemas.microsoft.com/office/drawing/2014/main" id="{E4879E96-726B-4F42-BD7C-09F8D0B14E9A}"/>
               </a:ext>
             </a:extLst>
           </p:cNvPr>
@@ -27058,7 +27005,7 @@
           <p:cNvPr id="47" name="Straight Arrow Connector 46">
             <a:extLst>
               <a:ext uri="{FF2B5EF4-FFF2-40B4-BE49-F238E27FC236}">
-                <ns2:creationId id="{0F119609-4333-414A-B8E4-E2447D7E1C10}"/>
+                <a16:creationId xmlns:a16="http://schemas.microsoft.com/office/drawing/2014/main" id="{0F119609-4333-414A-B8E4-E2447D7E1C10}"/>
               </a:ext>
             </a:extLst>
           </p:cNvPr>
@@ -27103,7 +27050,7 @@
           <p:cNvPr id="4" name="Straight Connector 3">
             <a:extLst>
               <a:ext uri="{FF2B5EF4-FFF2-40B4-BE49-F238E27FC236}">
-                <ns2:creationId id="{9890CC23-4ADC-D744-AF2D-1C8A936F07FC}"/>
+                <a16:creationId xmlns:a16="http://schemas.microsoft.com/office/drawing/2014/main" id="{9890CC23-4ADC-D744-AF2D-1C8A936F07FC}"/>
               </a:ext>
             </a:extLst>
           </p:cNvPr>
@@ -27146,7 +27093,7 @@
           <p:cNvPr id="18" name="Oval 17">
             <a:extLst>
               <a:ext uri="{FF2B5EF4-FFF2-40B4-BE49-F238E27FC236}">
-                <ns2:creationId id="{BE4CDC90-4B2E-BE41-BB9D-A84675F3A2FE}"/>
+                <a16:creationId xmlns:a16="http://schemas.microsoft.com/office/drawing/2014/main" id="{BE4CDC90-4B2E-BE41-BB9D-A84675F3A2FE}"/>
               </a:ext>
             </a:extLst>
           </p:cNvPr>
@@ -27227,7 +27174,7 @@
           <p:cNvPr id="24" name="Straight Arrow Connector 23">
             <a:extLst>
               <a:ext uri="{FF2B5EF4-FFF2-40B4-BE49-F238E27FC236}">
-                <ns2:creationId id="{7BCF22C9-C9AE-324D-B157-A9536FCAF3B6}"/>
+                <a16:creationId xmlns:a16="http://schemas.microsoft.com/office/drawing/2014/main" id="{7BCF22C9-C9AE-324D-B157-A9536FCAF3B6}"/>
               </a:ext>
             </a:extLst>
           </p:cNvPr>
@@ -27272,7 +27219,7 @@
           <p:cNvPr id="10" name="TextBox 9">
             <a:extLst>
               <a:ext uri="{FF2B5EF4-FFF2-40B4-BE49-F238E27FC236}">
-                <ns2:creationId id="{01A59953-657F-C641-8F36-E48E8EDB0DF1}"/>
+                <a16:creationId xmlns:a16="http://schemas.microsoft.com/office/drawing/2014/main" id="{01A59953-657F-C641-8F36-E48E8EDB0DF1}"/>
               </a:ext>
             </a:extLst>
           </p:cNvPr>
@@ -27354,7 +27301,7 @@
           <p:cNvPr id="31" name="TextBox 30">
             <a:extLst>
               <a:ext uri="{FF2B5EF4-FFF2-40B4-BE49-F238E27FC236}">
-                <ns2:creationId id="{713B9ACE-B673-2D48-BEF2-2A133C31B527}"/>
+                <a16:creationId xmlns:a16="http://schemas.microsoft.com/office/drawing/2014/main" id="{713B9ACE-B673-2D48-BEF2-2A133C31B527}"/>
               </a:ext>
             </a:extLst>
           </p:cNvPr>
@@ -27436,7 +27383,7 @@
           <p:cNvPr id="36" name="TextBox 35">
             <a:extLst>
               <a:ext uri="{FF2B5EF4-FFF2-40B4-BE49-F238E27FC236}">
-                <ns2:creationId id="{3A81A480-EF64-094E-825A-8592DAA4C672}"/>
+                <a16:creationId xmlns:a16="http://schemas.microsoft.com/office/drawing/2014/main" id="{3A81A480-EF64-094E-825A-8592DAA4C672}"/>
               </a:ext>
             </a:extLst>
           </p:cNvPr>
@@ -27515,7 +27462,7 @@
           <p:cNvPr id="22" name="Straight Connector 21">
             <a:extLst>
               <a:ext uri="{FF2B5EF4-FFF2-40B4-BE49-F238E27FC236}">
-                <ns2:creationId id="{0C67DA45-6876-7942-9996-48CA0A1696FE}"/>
+                <a16:creationId xmlns:a16="http://schemas.microsoft.com/office/drawing/2014/main" id="{0C67DA45-6876-7942-9996-48CA0A1696FE}"/>
               </a:ext>
             </a:extLst>
           </p:cNvPr>
@@ -27558,7 +27505,7 @@
           <p:cNvPr id="7" name="TextBox 6">
             <a:extLst>
               <a:ext uri="{FF2B5EF4-FFF2-40B4-BE49-F238E27FC236}">
-                <ns2:creationId id="{FE7A6F30-9D38-0B1B-2076-531827EE9F50}"/>
+                <a16:creationId xmlns:a16="http://schemas.microsoft.com/office/drawing/2014/main" id="{FE7A6F30-9D38-0B1B-2076-531827EE9F50}"/>
               </a:ext>
             </a:extLst>
           </p:cNvPr>
@@ -27623,7 +27570,7 @@
           <p:cNvPr id="2" name="Group 1">
             <a:extLst>
               <a:ext uri="{FF2B5EF4-FFF2-40B4-BE49-F238E27FC236}">
-                <ns2:creationId id="{B98AD1F2-987D-71EB-A470-E4A41A905EDF}"/>
+                <a16:creationId xmlns:a16="http://schemas.microsoft.com/office/drawing/2014/main" id="{B98AD1F2-987D-71EB-A470-E4A41A905EDF}"/>
               </a:ext>
             </a:extLst>
           </p:cNvPr>
@@ -27643,7 +27590,7 @@
             <p:cNvPr id="6" name="Straight Arrow Connector 5">
               <a:extLst>
                 <a:ext uri="{FF2B5EF4-FFF2-40B4-BE49-F238E27FC236}">
-                  <ns2:creationId id="{836C1A95-A13A-0EE6-733B-6B2D96A15332}"/>
+                  <a16:creationId xmlns:a16="http://schemas.microsoft.com/office/drawing/2014/main" id="{836C1A95-A13A-0EE6-733B-6B2D96A15332}"/>
                 </a:ext>
               </a:extLst>
             </p:cNvPr>
@@ -27687,7 +27634,7 @@
             <p:cNvPr id="9" name="Straight Arrow Connector 8">
               <a:extLst>
                 <a:ext uri="{FF2B5EF4-FFF2-40B4-BE49-F238E27FC236}">
-                  <ns2:creationId id="{8AA9E325-051B-BE4A-55F2-7CFF0AFD3797}"/>
+                  <a16:creationId xmlns:a16="http://schemas.microsoft.com/office/drawing/2014/main" id="{8AA9E325-051B-BE4A-55F2-7CFF0AFD3797}"/>
                 </a:ext>
               </a:extLst>
             </p:cNvPr>
@@ -27731,7 +27678,7 @@
             <p:cNvPr id="11" name="TextBox 10">
               <a:extLst>
                 <a:ext uri="{FF2B5EF4-FFF2-40B4-BE49-F238E27FC236}">
-                  <ns2:creationId id="{DF6E9CDB-4ADF-E626-B2A4-DEA60E4A02F0}"/>
+                  <a16:creationId xmlns:a16="http://schemas.microsoft.com/office/drawing/2014/main" id="{DF6E9CDB-4ADF-E626-B2A4-DEA60E4A02F0}"/>
                 </a:ext>
               </a:extLst>
             </p:cNvPr>
@@ -27796,7 +27743,7 @@
             <p:cNvPr id="14" name="TextBox 13">
               <a:extLst>
                 <a:ext uri="{FF2B5EF4-FFF2-40B4-BE49-F238E27FC236}">
-                  <ns2:creationId id="{01E78D1F-323F-0A4F-4B30-4CE146D0EB63}"/>
+                  <a16:creationId xmlns:a16="http://schemas.microsoft.com/office/drawing/2014/main" id="{01E78D1F-323F-0A4F-4B30-4CE146D0EB63}"/>
                 </a:ext>
               </a:extLst>
             </p:cNvPr>
@@ -27856,7 +27803,7 @@
     </p:spTree>
     <p:extLst>
       <p:ext uri="{BB962C8B-B14F-4D97-AF65-F5344CB8AC3E}">
-        <p14:creationId val="4081239535"/>
+        <p14:creationId xmlns:p14="http://schemas.microsoft.com/office/powerpoint/2010/main" val="4081239535"/>
       </p:ext>
     </p:extLst>
   </p:cSld>
@@ -27867,7 +27814,7 @@
 </file>
 
 <file path=ppt/slides/slide7.xml><?xml version="1.0" encoding="utf-8"?>
-<p:sld xmlns:a="http://schemas.openxmlformats.org/drawingml/2006/main" xmlns:ns2="http://schemas.microsoft.com/office/drawing/2014/main" xmlns:p="http://schemas.openxmlformats.org/presentationml/2006/main" xmlns:p14="http://schemas.microsoft.com/office/powerpoint/2010/main">
+<p:sld xmlns:a="http://schemas.openxmlformats.org/drawingml/2006/main" xmlns:r="http://schemas.openxmlformats.org/officeDocument/2006/relationships" xmlns:p="http://schemas.openxmlformats.org/presentationml/2006/main">
   <p:cSld>
     <p:bg>
       <p:bgPr>
@@ -27896,7 +27843,7 @@
           <p:cNvPr id="5" name="Footer Placeholder 3">
             <a:extLst>
               <a:ext uri="{FF2B5EF4-FFF2-40B4-BE49-F238E27FC236}">
-                <ns2:creationId id="{668F77D6-DFDA-5A46-8DF1-47F6A167C2B1}"/>
+                <a16:creationId xmlns:a16="http://schemas.microsoft.com/office/drawing/2014/main" id="{668F77D6-DFDA-5A46-8DF1-47F6A167C2B1}"/>
               </a:ext>
             </a:extLst>
           </p:cNvPr>
@@ -28058,7 +28005,7 @@
           <p:cNvPr id="26" name="TextBox 25">
             <a:extLst>
               <a:ext uri="{FF2B5EF4-FFF2-40B4-BE49-F238E27FC236}">
-                <ns2:creationId id="{FA5E13D2-A15E-F54D-9507-CAD768919361}"/>
+                <a16:creationId xmlns:a16="http://schemas.microsoft.com/office/drawing/2014/main" id="{FA5E13D2-A15E-F54D-9507-CAD768919361}"/>
               </a:ext>
             </a:extLst>
           </p:cNvPr>
@@ -28195,7 +28142,7 @@
           <p:cNvPr id="23" name="Oval 22">
             <a:extLst>
               <a:ext uri="{FF2B5EF4-FFF2-40B4-BE49-F238E27FC236}">
-                <ns2:creationId id="{0112617B-A1D5-1E41-BF92-E67D4E046E39}"/>
+                <a16:creationId xmlns:a16="http://schemas.microsoft.com/office/drawing/2014/main" id="{0112617B-A1D5-1E41-BF92-E67D4E046E39}"/>
               </a:ext>
             </a:extLst>
           </p:cNvPr>
@@ -28279,7 +28226,7 @@
           <p:cNvPr id="27" name="Oval 26">
             <a:extLst>
               <a:ext uri="{FF2B5EF4-FFF2-40B4-BE49-F238E27FC236}">
-                <ns2:creationId id="{6EF0F7DA-5E70-8348-A200-F59A10FF7C55}"/>
+                <a16:creationId xmlns:a16="http://schemas.microsoft.com/office/drawing/2014/main" id="{6EF0F7DA-5E70-8348-A200-F59A10FF7C55}"/>
               </a:ext>
             </a:extLst>
           </p:cNvPr>
@@ -28363,7 +28310,7 @@
           <p:cNvPr id="28" name="Oval 27">
             <a:extLst>
               <a:ext uri="{FF2B5EF4-FFF2-40B4-BE49-F238E27FC236}">
-                <ns2:creationId id="{552F58D0-F613-674A-B294-C894E5FB1683}"/>
+                <a16:creationId xmlns:a16="http://schemas.microsoft.com/office/drawing/2014/main" id="{552F58D0-F613-674A-B294-C894E5FB1683}"/>
               </a:ext>
             </a:extLst>
           </p:cNvPr>
@@ -28447,7 +28394,7 @@
           <p:cNvPr id="29" name="Oval 28">
             <a:extLst>
               <a:ext uri="{FF2B5EF4-FFF2-40B4-BE49-F238E27FC236}">
-                <ns2:creationId id="{9CA7A721-D3BD-744E-9306-85BBED5F74BC}"/>
+                <a16:creationId xmlns:a16="http://schemas.microsoft.com/office/drawing/2014/main" id="{9CA7A721-D3BD-744E-9306-85BBED5F74BC}"/>
               </a:ext>
             </a:extLst>
           </p:cNvPr>
@@ -28531,7 +28478,7 @@
           <p:cNvPr id="30" name="Oval 29">
             <a:extLst>
               <a:ext uri="{FF2B5EF4-FFF2-40B4-BE49-F238E27FC236}">
-                <ns2:creationId id="{F97F1A02-C0C7-3C45-9790-847C152D159A}"/>
+                <a16:creationId xmlns:a16="http://schemas.microsoft.com/office/drawing/2014/main" id="{F97F1A02-C0C7-3C45-9790-847C152D159A}"/>
               </a:ext>
             </a:extLst>
           </p:cNvPr>
@@ -28615,7 +28562,7 @@
           <p:cNvPr id="15" name="Straight Arrow Connector 14">
             <a:extLst>
               <a:ext uri="{FF2B5EF4-FFF2-40B4-BE49-F238E27FC236}">
-                <ns2:creationId id="{05289ED1-4679-6543-A669-B23443FD0CD8}"/>
+                <a16:creationId xmlns:a16="http://schemas.microsoft.com/office/drawing/2014/main" id="{05289ED1-4679-6543-A669-B23443FD0CD8}"/>
               </a:ext>
             </a:extLst>
           </p:cNvPr>
@@ -28660,7 +28607,7 @@
           <p:cNvPr id="32" name="Straight Arrow Connector 31">
             <a:extLst>
               <a:ext uri="{FF2B5EF4-FFF2-40B4-BE49-F238E27FC236}">
-                <ns2:creationId id="{A9F8BF55-7F79-854D-84AD-A730BF43B39C}"/>
+                <a16:creationId xmlns:a16="http://schemas.microsoft.com/office/drawing/2014/main" id="{A9F8BF55-7F79-854D-84AD-A730BF43B39C}"/>
               </a:ext>
             </a:extLst>
           </p:cNvPr>
@@ -28705,7 +28652,7 @@
           <p:cNvPr id="35" name="Straight Arrow Connector 34">
             <a:extLst>
               <a:ext uri="{FF2B5EF4-FFF2-40B4-BE49-F238E27FC236}">
-                <ns2:creationId id="{0415B495-590C-0049-92E6-8AE7464CC78A}"/>
+                <a16:creationId xmlns:a16="http://schemas.microsoft.com/office/drawing/2014/main" id="{0415B495-590C-0049-92E6-8AE7464CC78A}"/>
               </a:ext>
             </a:extLst>
           </p:cNvPr>
@@ -28750,7 +28697,7 @@
           <p:cNvPr id="39" name="Straight Arrow Connector 38">
             <a:extLst>
               <a:ext uri="{FF2B5EF4-FFF2-40B4-BE49-F238E27FC236}">
-                <ns2:creationId id="{E4879E96-726B-4F42-BD7C-09F8D0B14E9A}"/>
+                <a16:creationId xmlns:a16="http://schemas.microsoft.com/office/drawing/2014/main" id="{E4879E96-726B-4F42-BD7C-09F8D0B14E9A}"/>
               </a:ext>
             </a:extLst>
           </p:cNvPr>
@@ -28795,7 +28742,7 @@
           <p:cNvPr id="47" name="Straight Arrow Connector 46">
             <a:extLst>
               <a:ext uri="{FF2B5EF4-FFF2-40B4-BE49-F238E27FC236}">
-                <ns2:creationId id="{0F119609-4333-414A-B8E4-E2447D7E1C10}"/>
+                <a16:creationId xmlns:a16="http://schemas.microsoft.com/office/drawing/2014/main" id="{0F119609-4333-414A-B8E4-E2447D7E1C10}"/>
               </a:ext>
             </a:extLst>
           </p:cNvPr>
@@ -28840,7 +28787,7 @@
           <p:cNvPr id="4" name="Straight Connector 3">
             <a:extLst>
               <a:ext uri="{FF2B5EF4-FFF2-40B4-BE49-F238E27FC236}">
-                <ns2:creationId id="{9890CC23-4ADC-D744-AF2D-1C8A936F07FC}"/>
+                <a16:creationId xmlns:a16="http://schemas.microsoft.com/office/drawing/2014/main" id="{9890CC23-4ADC-D744-AF2D-1C8A936F07FC}"/>
               </a:ext>
             </a:extLst>
           </p:cNvPr>
@@ -28883,7 +28830,7 @@
           <p:cNvPr id="18" name="Oval 17">
             <a:extLst>
               <a:ext uri="{FF2B5EF4-FFF2-40B4-BE49-F238E27FC236}">
-                <ns2:creationId id="{BE4CDC90-4B2E-BE41-BB9D-A84675F3A2FE}"/>
+                <a16:creationId xmlns:a16="http://schemas.microsoft.com/office/drawing/2014/main" id="{BE4CDC90-4B2E-BE41-BB9D-A84675F3A2FE}"/>
               </a:ext>
             </a:extLst>
           </p:cNvPr>
@@ -28966,7 +28913,7 @@
           <p:cNvPr id="24" name="Straight Arrow Connector 23">
             <a:extLst>
               <a:ext uri="{FF2B5EF4-FFF2-40B4-BE49-F238E27FC236}">
-                <ns2:creationId id="{7BCF22C9-C9AE-324D-B157-A9536FCAF3B6}"/>
+                <a16:creationId xmlns:a16="http://schemas.microsoft.com/office/drawing/2014/main" id="{7BCF22C9-C9AE-324D-B157-A9536FCAF3B6}"/>
               </a:ext>
             </a:extLst>
           </p:cNvPr>
@@ -29011,7 +28958,7 @@
           <p:cNvPr id="10" name="TextBox 9">
             <a:extLst>
               <a:ext uri="{FF2B5EF4-FFF2-40B4-BE49-F238E27FC236}">
-                <ns2:creationId id="{01A59953-657F-C641-8F36-E48E8EDB0DF1}"/>
+                <a16:creationId xmlns:a16="http://schemas.microsoft.com/office/drawing/2014/main" id="{01A59953-657F-C641-8F36-E48E8EDB0DF1}"/>
               </a:ext>
             </a:extLst>
           </p:cNvPr>
@@ -29096,7 +29043,7 @@
           <p:cNvPr id="31" name="TextBox 30">
             <a:extLst>
               <a:ext uri="{FF2B5EF4-FFF2-40B4-BE49-F238E27FC236}">
-                <ns2:creationId id="{713B9ACE-B673-2D48-BEF2-2A133C31B527}"/>
+                <a16:creationId xmlns:a16="http://schemas.microsoft.com/office/drawing/2014/main" id="{713B9ACE-B673-2D48-BEF2-2A133C31B527}"/>
               </a:ext>
             </a:extLst>
           </p:cNvPr>
@@ -29181,7 +29128,7 @@
           <p:cNvPr id="36" name="TextBox 35">
             <a:extLst>
               <a:ext uri="{FF2B5EF4-FFF2-40B4-BE49-F238E27FC236}">
-                <ns2:creationId id="{3A81A480-EF64-094E-825A-8592DAA4C672}"/>
+                <a16:creationId xmlns:a16="http://schemas.microsoft.com/office/drawing/2014/main" id="{3A81A480-EF64-094E-825A-8592DAA4C672}"/>
               </a:ext>
             </a:extLst>
           </p:cNvPr>
@@ -29263,7 +29210,7 @@
           <p:cNvPr id="22" name="Straight Connector 21">
             <a:extLst>
               <a:ext uri="{FF2B5EF4-FFF2-40B4-BE49-F238E27FC236}">
-                <ns2:creationId id="{0C67DA45-6876-7942-9996-48CA0A1696FE}"/>
+                <a16:creationId xmlns:a16="http://schemas.microsoft.com/office/drawing/2014/main" id="{0C67DA45-6876-7942-9996-48CA0A1696FE}"/>
               </a:ext>
             </a:extLst>
           </p:cNvPr>
@@ -29306,7 +29253,7 @@
           <p:cNvPr id="2" name="TextBox 1">
             <a:extLst>
               <a:ext uri="{FF2B5EF4-FFF2-40B4-BE49-F238E27FC236}">
-                <ns2:creationId id="{25B497FC-A4FB-6E22-82A5-ECE9FFBF1D45}"/>
+                <a16:creationId xmlns:a16="http://schemas.microsoft.com/office/drawing/2014/main" id="{25B497FC-A4FB-6E22-82A5-ECE9FFBF1D45}"/>
               </a:ext>
             </a:extLst>
           </p:cNvPr>
@@ -29371,7 +29318,7 @@
           <p:cNvPr id="6" name="Straight Arrow Connector 5">
             <a:extLst>
               <a:ext uri="{FF2B5EF4-FFF2-40B4-BE49-F238E27FC236}">
-                <ns2:creationId id="{3B9C4884-FD04-1DA8-E9C2-C28549C7A16E}"/>
+                <a16:creationId xmlns:a16="http://schemas.microsoft.com/office/drawing/2014/main" id="{3B9C4884-FD04-1DA8-E9C2-C28549C7A16E}"/>
               </a:ext>
             </a:extLst>
           </p:cNvPr>
@@ -29415,7 +29362,7 @@
           <p:cNvPr id="7" name="Straight Arrow Connector 6">
             <a:extLst>
               <a:ext uri="{FF2B5EF4-FFF2-40B4-BE49-F238E27FC236}">
-                <ns2:creationId id="{A6FFF53F-C9D7-1557-FC42-A159BAC6A3AE}"/>
+                <a16:creationId xmlns:a16="http://schemas.microsoft.com/office/drawing/2014/main" id="{A6FFF53F-C9D7-1557-FC42-A159BAC6A3AE}"/>
               </a:ext>
             </a:extLst>
           </p:cNvPr>
@@ -29459,7 +29406,7 @@
           <p:cNvPr id="9" name="TextBox 8">
             <a:extLst>
               <a:ext uri="{FF2B5EF4-FFF2-40B4-BE49-F238E27FC236}">
-                <ns2:creationId id="{37A94EE7-D3B6-AC25-503E-E6C0EE1F179B}"/>
+                <a16:creationId xmlns:a16="http://schemas.microsoft.com/office/drawing/2014/main" id="{37A94EE7-D3B6-AC25-503E-E6C0EE1F179B}"/>
               </a:ext>
             </a:extLst>
           </p:cNvPr>
@@ -29524,7 +29471,7 @@
           <p:cNvPr id="11" name="TextBox 10">
             <a:extLst>
               <a:ext uri="{FF2B5EF4-FFF2-40B4-BE49-F238E27FC236}">
-                <ns2:creationId id="{C80380D5-790B-3854-4D6A-3811EF0E2829}"/>
+                <a16:creationId xmlns:a16="http://schemas.microsoft.com/office/drawing/2014/main" id="{C80380D5-790B-3854-4D6A-3811EF0E2829}"/>
               </a:ext>
             </a:extLst>
           </p:cNvPr>
@@ -29583,7 +29530,7 @@
     </p:spTree>
     <p:extLst>
       <p:ext uri="{BB962C8B-B14F-4D97-AF65-F5344CB8AC3E}">
-        <p14:creationId val="2347082703"/>
+        <p14:creationId xmlns:p14="http://schemas.microsoft.com/office/powerpoint/2010/main" val="2347082703"/>
       </p:ext>
     </p:extLst>
   </p:cSld>
@@ -29594,7 +29541,7 @@
 </file>
 
 <file path=ppt/slides/slide8.xml><?xml version="1.0" encoding="utf-8"?>
-<p:sld xmlns:a="http://schemas.openxmlformats.org/drawingml/2006/main" xmlns:ns2="http://schemas.microsoft.com/office/drawing/2014/main" xmlns:p="http://schemas.openxmlformats.org/presentationml/2006/main" xmlns:p14="http://schemas.microsoft.com/office/powerpoint/2010/main" xmlns:r="http://schemas.openxmlformats.org/officeDocument/2006/relationships">
+<p:sld xmlns:a="http://schemas.openxmlformats.org/drawingml/2006/main" xmlns:r="http://schemas.openxmlformats.org/officeDocument/2006/relationships" xmlns:p="http://schemas.openxmlformats.org/presentationml/2006/main">
   <p:cSld>
     <p:bg>
       <p:bgPr>
@@ -29609,7 +29556,7 @@
         <p:cNvPr id="1" name="">
           <a:extLst>
             <a:ext uri="{FF2B5EF4-FFF2-40B4-BE49-F238E27FC236}">
-              <ns2:creationId id="{0AB73162-F4FB-AD38-1F35-FA4B5AB487CE}"/>
+              <a16:creationId xmlns:a16="http://schemas.microsoft.com/office/drawing/2014/main" id="{0AB73162-F4FB-AD38-1F35-FA4B5AB487CE}"/>
             </a:ext>
           </a:extLst>
         </p:cNvPr>
@@ -29629,7 +29576,7 @@
           <p:cNvPr id="5" name="Footer Placeholder 3">
             <a:extLst>
               <a:ext uri="{FF2B5EF4-FFF2-40B4-BE49-F238E27FC236}">
-                <ns2:creationId id="{8949F10E-6D23-F0EA-2E56-92DD2DE28C2A}"/>
+                <a16:creationId xmlns:a16="http://schemas.microsoft.com/office/drawing/2014/main" id="{8949F10E-6D23-F0EA-2E56-92DD2DE28C2A}"/>
               </a:ext>
             </a:extLst>
           </p:cNvPr>
@@ -29791,7 +29738,7 @@
           <p:cNvPr id="9" name="Group 8">
             <a:extLst>
               <a:ext uri="{FF2B5EF4-FFF2-40B4-BE49-F238E27FC236}">
-                <ns2:creationId id="{E9850113-AB4C-1F87-EB30-16E25C586B5C}"/>
+                <a16:creationId xmlns:a16="http://schemas.microsoft.com/office/drawing/2014/main" id="{E9850113-AB4C-1F87-EB30-16E25C586B5C}"/>
               </a:ext>
             </a:extLst>
           </p:cNvPr>
@@ -29800,8 +29747,8 @@
         </p:nvGrpSpPr>
         <p:grpSpPr>
           <a:xfrm>
-            <a:off x="664625" y="1173522"/>
-            <a:ext cx="5475154" cy="5405229"/>
+            <a:off x="664625" y="1173523"/>
+            <a:ext cx="3915396" cy="4312878"/>
             <a:chOff x="3484605" y="1083438"/>
             <a:chExt cx="5475154" cy="5405229"/>
           </a:xfrm>
@@ -29811,7 +29758,7 @@
             <p:cNvPr id="3" name="Picture 2">
               <a:extLst>
                 <a:ext uri="{FF2B5EF4-FFF2-40B4-BE49-F238E27FC236}">
-                  <ns2:creationId id="{9851A9B8-C2CC-C4AE-6C06-EB4B33725392}"/>
+                  <a16:creationId xmlns:a16="http://schemas.microsoft.com/office/drawing/2014/main" id="{9851A9B8-C2CC-C4AE-6C06-EB4B33725392}"/>
                 </a:ext>
               </a:extLst>
             </p:cNvPr>
@@ -29848,7 +29795,7 @@
             <p:cNvPr id="4" name="Freeform 3">
               <a:extLst>
                 <a:ext uri="{FF2B5EF4-FFF2-40B4-BE49-F238E27FC236}">
-                  <ns2:creationId id="{A6E4734A-F61C-B1B6-E09B-251407A8B0F9}"/>
+                  <a16:creationId xmlns:a16="http://schemas.microsoft.com/office/drawing/2014/main" id="{A6E4734A-F61C-B1B6-E09B-251407A8B0F9}"/>
                 </a:ext>
               </a:extLst>
             </p:cNvPr>
@@ -29993,7 +29940,7 @@
             <p:cNvPr id="6" name="Freeform 5">
               <a:extLst>
                 <a:ext uri="{FF2B5EF4-FFF2-40B4-BE49-F238E27FC236}">
-                  <ns2:creationId id="{AE9693B7-399D-4648-5934-BAF780F94BB8}"/>
+                  <a16:creationId xmlns:a16="http://schemas.microsoft.com/office/drawing/2014/main" id="{AE9693B7-399D-4648-5934-BAF780F94BB8}"/>
                 </a:ext>
               </a:extLst>
             </p:cNvPr>
@@ -30179,7 +30126,7 @@
           <p:cNvPr id="7" name="Title 1">
             <a:extLst>
               <a:ext uri="{FF2B5EF4-FFF2-40B4-BE49-F238E27FC236}">
-                <ns2:creationId id="{B4E061E7-B3BA-067C-8AC0-2AEC475558B3}"/>
+                <a16:creationId xmlns:a16="http://schemas.microsoft.com/office/drawing/2014/main" id="{B4E061E7-B3BA-067C-8AC0-2AEC475558B3}"/>
               </a:ext>
             </a:extLst>
           </p:cNvPr>
@@ -30263,7 +30210,7 @@
           <p:cNvPr id="10" name="TextBox 9">
             <a:extLst>
               <a:ext uri="{FF2B5EF4-FFF2-40B4-BE49-F238E27FC236}">
-                <ns2:creationId id="{FFF14DD8-B78C-E1D8-EB01-782F6700411F}"/>
+                <a16:creationId xmlns:a16="http://schemas.microsoft.com/office/drawing/2014/main" id="{FFF14DD8-B78C-E1D8-EB01-782F6700411F}"/>
               </a:ext>
             </a:extLst>
           </p:cNvPr>
@@ -30272,8 +30219,8 @@
         </p:nvSpPr>
         <p:spPr>
           <a:xfrm>
-            <a:off x="6358919" y="1651553"/>
-            <a:ext cx="5639963" cy="3778342"/>
+            <a:off x="5382127" y="1651553"/>
+            <a:ext cx="6616756" cy="2532103"/>
           </a:xfrm>
           <a:prstGeom prst="rect">
             <a:avLst/>
@@ -30304,7 +30251,7 @@
               <a:defRPr/>
             </a:pPr>
             <a:r>
-              <a:rPr kumimoji="0" lang="en-US" sz="1800" b="1" i="0" u="none" strike="noStrike" kern="1200" cap="none" spc="0" normalizeH="0" baseline="0" noProof="0" dirty="0">
+              <a:rPr kumimoji="0" lang="en-US" sz="1800" i="0" u="none" strike="noStrike" kern="1200" cap="none" spc="0" normalizeH="0" baseline="0" noProof="0" dirty="0">
                 <a:ln>
                   <a:noFill/>
                 </a:ln>
@@ -30340,7 +30287,7 @@
               <a:defRPr/>
             </a:pPr>
             <a:r>
-              <a:rPr kumimoji="0" lang="en-US" sz="1800" b="1" i="0" u="none" strike="noStrike" kern="1200" cap="none" spc="0" normalizeH="0" baseline="0" noProof="0" dirty="0">
+              <a:rPr kumimoji="0" lang="en-US" sz="1800" i="0" u="none" strike="noStrike" kern="1200" cap="none" spc="0" normalizeH="0" baseline="0" noProof="0" dirty="0">
                 <a:ln>
                   <a:noFill/>
                 </a:ln>
@@ -30376,7 +30323,7 @@
               <a:defRPr/>
             </a:pPr>
             <a:r>
-              <a:rPr kumimoji="0" lang="en-US" sz="1800" b="1" i="0" u="none" strike="noStrike" kern="1200" cap="none" spc="0" normalizeH="0" baseline="0" noProof="0" dirty="0">
+              <a:rPr kumimoji="0" lang="en-US" sz="1800" i="0" u="none" strike="noStrike" kern="1200" cap="none" spc="0" normalizeH="0" baseline="0" noProof="0" dirty="0">
                 <a:ln>
                   <a:noFill/>
                 </a:ln>
@@ -30412,7 +30359,7 @@
               <a:defRPr/>
             </a:pPr>
             <a:r>
-              <a:rPr kumimoji="0" lang="en-US" sz="1800" b="1" i="0" u="none" strike="noStrike" kern="1200" cap="none" spc="0" normalizeH="0" baseline="0" noProof="0" dirty="0">
+              <a:rPr kumimoji="0" lang="en-US" sz="1800" i="0" u="none" strike="noStrike" kern="1200" cap="none" spc="0" normalizeH="0" baseline="0" noProof="0" dirty="0">
                 <a:ln>
                   <a:noFill/>
                 </a:ln>
@@ -30448,7 +30395,7 @@
               <a:defRPr/>
             </a:pPr>
             <a:r>
-              <a:rPr kumimoji="0" lang="en-US" sz="1800" b="1" i="0" u="none" strike="noStrike" kern="1200" cap="none" spc="0" normalizeH="0" baseline="0" noProof="0" dirty="0">
+              <a:rPr kumimoji="0" lang="en-US" sz="1800" i="0" u="none" strike="noStrike" kern="1200" cap="none" spc="0" normalizeH="0" baseline="0" noProof="0" dirty="0">
                 <a:ln>
                   <a:noFill/>
                 </a:ln>
@@ -30462,9 +30409,43 @@
                 <a:ea typeface="Helvetica Neue" panose="02000503000000020004" pitchFamily="2" charset="0"/>
                 <a:cs typeface="Helvetica Neue" panose="02000503000000020004" pitchFamily="2" charset="0"/>
               </a:rPr>
-              <a:t>Wake density falls with distance, like 1/r^2.</a:t>
+              <a:t>Wake density falls with distance, like 1/r</a:t>
             </a:r>
-            <a:endParaRPr kumimoji="0" lang="en-US" sz="1800" b="1" i="0" u="none" strike="noStrike" kern="1200" cap="none" spc="0" normalizeH="0" baseline="30000" noProof="0" dirty="0">
+            <a:r>
+              <a:rPr kumimoji="0" lang="en-US" sz="1800" i="0" u="none" strike="noStrike" kern="1200" cap="none" spc="0" normalizeH="0" baseline="30000" noProof="0" dirty="0">
+                <a:ln>
+                  <a:noFill/>
+                </a:ln>
+                <a:solidFill>
+                  <a:prstClr val="white"/>
+                </a:solidFill>
+                <a:effectLst/>
+                <a:uLnTx/>
+                <a:uFillTx/>
+                <a:latin typeface="Helvetica Neue" panose="02000503000000020004" pitchFamily="2" charset="0"/>
+                <a:ea typeface="Helvetica Neue" panose="02000503000000020004" pitchFamily="2" charset="0"/>
+                <a:cs typeface="Helvetica Neue" panose="02000503000000020004" pitchFamily="2" charset="0"/>
+              </a:rPr>
+              <a:t>2</a:t>
+            </a:r>
+            <a:r>
+              <a:rPr kumimoji="0" lang="en-US" sz="1800" i="0" u="none" strike="noStrike" kern="1200" cap="none" spc="0" normalizeH="0" baseline="0" noProof="0" dirty="0">
+                <a:ln>
+                  <a:noFill/>
+                </a:ln>
+                <a:solidFill>
+                  <a:prstClr val="white"/>
+                </a:solidFill>
+                <a:effectLst/>
+                <a:uLnTx/>
+                <a:uFillTx/>
+                <a:latin typeface="Helvetica Neue" panose="02000503000000020004" pitchFamily="2" charset="0"/>
+                <a:ea typeface="Helvetica Neue" panose="02000503000000020004" pitchFamily="2" charset="0"/>
+                <a:cs typeface="Helvetica Neue" panose="02000503000000020004" pitchFamily="2" charset="0"/>
+              </a:rPr>
+              <a:t>.</a:t>
+            </a:r>
+            <a:endParaRPr kumimoji="0" lang="en-US" sz="1800" i="0" u="none" strike="noStrike" kern="1200" cap="none" spc="0" normalizeH="0" baseline="30000" noProof="0" dirty="0">
               <a:ln>
                 <a:noFill/>
               </a:ln>
@@ -30484,7 +30465,7 @@
     </p:spTree>
     <p:extLst>
       <p:ext uri="{BB962C8B-B14F-4D97-AF65-F5344CB8AC3E}">
-        <p14:creationId val="3392406910"/>
+        <p14:creationId xmlns:p14="http://schemas.microsoft.com/office/powerpoint/2010/main" val="3392406910"/>
       </p:ext>
     </p:extLst>
   </p:cSld>
@@ -30495,7 +30476,7 @@
 </file>
 
 <file path=ppt/slides/slide9.xml><?xml version="1.0" encoding="utf-8"?>
-<p:sld xmlns:a="http://schemas.openxmlformats.org/drawingml/2006/main" xmlns:ns2="http://schemas.microsoft.com/office/drawing/2014/main" xmlns:p="http://schemas.openxmlformats.org/presentationml/2006/main" xmlns:p14="http://schemas.microsoft.com/office/powerpoint/2010/main">
+<p:sld xmlns:a="http://schemas.openxmlformats.org/drawingml/2006/main" xmlns:r="http://schemas.openxmlformats.org/officeDocument/2006/relationships" xmlns:p="http://schemas.openxmlformats.org/presentationml/2006/main">
   <p:cSld>
     <p:bg>
       <p:bgPr>
@@ -30524,7 +30505,7 @@
           <p:cNvPr id="11" name="Footer Placeholder 3">
             <a:extLst>
               <a:ext uri="{FF2B5EF4-FFF2-40B4-BE49-F238E27FC236}">
-                <ns2:creationId id="{7C94C084-4476-0C4E-B896-CB3AC89A47F6}"/>
+                <a16:creationId xmlns:a16="http://schemas.microsoft.com/office/drawing/2014/main" id="{7C94C084-4476-0C4E-B896-CB3AC89A47F6}"/>
               </a:ext>
             </a:extLst>
           </p:cNvPr>
@@ -30658,7 +30639,7 @@
           <p:cNvPr id="6" name="Freeform 5">
             <a:extLst>
               <a:ext uri="{FF2B5EF4-FFF2-40B4-BE49-F238E27FC236}">
-                <ns2:creationId id="{A25DAE9F-BED8-3A57-CD97-EDBD9F0EDD69}"/>
+                <a16:creationId xmlns:a16="http://schemas.microsoft.com/office/drawing/2014/main" id="{A25DAE9F-BED8-3A57-CD97-EDBD9F0EDD69}"/>
               </a:ext>
             </a:extLst>
           </p:cNvPr>
@@ -31254,7 +31235,7 @@
           <p:cNvPr id="7" name="Freeform 6">
             <a:extLst>
               <a:ext uri="{FF2B5EF4-FFF2-40B4-BE49-F238E27FC236}">
-                <ns2:creationId id="{3F833B4A-7F30-F940-BD46-AAD4F1EC84C2}"/>
+                <a16:creationId xmlns:a16="http://schemas.microsoft.com/office/drawing/2014/main" id="{3F833B4A-7F30-F940-BD46-AAD4F1EC84C2}"/>
               </a:ext>
             </a:extLst>
           </p:cNvPr>
@@ -32116,7 +32097,7 @@
           <p:cNvPr id="9" name="Oval 8">
             <a:extLst>
               <a:ext uri="{FF2B5EF4-FFF2-40B4-BE49-F238E27FC236}">
-                <ns2:creationId id="{C1204F89-67E6-2520-9CB7-C11AD96E6395}"/>
+                <a16:creationId xmlns:a16="http://schemas.microsoft.com/office/drawing/2014/main" id="{C1204F89-67E6-2520-9CB7-C11AD96E6395}"/>
               </a:ext>
             </a:extLst>
           </p:cNvPr>
@@ -32168,7 +32149,7 @@
           <p:cNvPr id="10" name="Oval 9">
             <a:extLst>
               <a:ext uri="{FF2B5EF4-FFF2-40B4-BE49-F238E27FC236}">
-                <ns2:creationId id="{C20E3F99-5E93-DCB1-5438-4A8D42DA25E5}"/>
+                <a16:creationId xmlns:a16="http://schemas.microsoft.com/office/drawing/2014/main" id="{C20E3F99-5E93-DCB1-5438-4A8D42DA25E5}"/>
               </a:ext>
             </a:extLst>
           </p:cNvPr>
@@ -32220,7 +32201,7 @@
           <p:cNvPr id="12" name="Straight Connector 11">
             <a:extLst>
               <a:ext uri="{FF2B5EF4-FFF2-40B4-BE49-F238E27FC236}">
-                <ns2:creationId id="{981DDF22-4015-B62D-15E4-53D55BFB533D}"/>
+                <a16:creationId xmlns:a16="http://schemas.microsoft.com/office/drawing/2014/main" id="{981DDF22-4015-B62D-15E4-53D55BFB533D}"/>
               </a:ext>
             </a:extLst>
           </p:cNvPr>
@@ -32266,7 +32247,7 @@
           <p:cNvPr id="13" name="Oval 12">
             <a:extLst>
               <a:ext uri="{FF2B5EF4-FFF2-40B4-BE49-F238E27FC236}">
-                <ns2:creationId id="{54ADE077-5C44-29DF-0132-D3CEA80605F9}"/>
+                <a16:creationId xmlns:a16="http://schemas.microsoft.com/office/drawing/2014/main" id="{54ADE077-5C44-29DF-0132-D3CEA80605F9}"/>
               </a:ext>
             </a:extLst>
           </p:cNvPr>
@@ -32321,7 +32302,7 @@
           <p:cNvPr id="14" name="Oval 13">
             <a:extLst>
               <a:ext uri="{FF2B5EF4-FFF2-40B4-BE49-F238E27FC236}">
-                <ns2:creationId id="{00672CFA-7F0E-A719-10B0-29AE35096E30}"/>
+                <a16:creationId xmlns:a16="http://schemas.microsoft.com/office/drawing/2014/main" id="{00672CFA-7F0E-A719-10B0-29AE35096E30}"/>
               </a:ext>
             </a:extLst>
           </p:cNvPr>
@@ -32373,7 +32354,7 @@
           <p:cNvPr id="15" name="TextBox 14">
             <a:extLst>
               <a:ext uri="{FF2B5EF4-FFF2-40B4-BE49-F238E27FC236}">
-                <ns2:creationId id="{D484D63C-CCDB-0923-AC0F-BC6DCC85B056}"/>
+                <a16:creationId xmlns:a16="http://schemas.microsoft.com/office/drawing/2014/main" id="{D484D63C-CCDB-0923-AC0F-BC6DCC85B056}"/>
               </a:ext>
             </a:extLst>
           </p:cNvPr>
@@ -32433,7 +32414,7 @@
           <p:cNvPr id="16" name="TextBox 15">
             <a:extLst>
               <a:ext uri="{FF2B5EF4-FFF2-40B4-BE49-F238E27FC236}">
-                <ns2:creationId id="{2FB06A3B-C8A7-7640-2EE9-203EA6BD717B}"/>
+                <a16:creationId xmlns:a16="http://schemas.microsoft.com/office/drawing/2014/main" id="{2FB06A3B-C8A7-7640-2EE9-203EA6BD717B}"/>
               </a:ext>
             </a:extLst>
           </p:cNvPr>
@@ -32480,7 +32461,7 @@
           <p:cNvPr id="19" name="TextBox 18">
             <a:extLst>
               <a:ext uri="{FF2B5EF4-FFF2-40B4-BE49-F238E27FC236}">
-                <ns2:creationId id="{499A2693-D878-2253-1439-ED993C1F2AD5}"/>
+                <a16:creationId xmlns:a16="http://schemas.microsoft.com/office/drawing/2014/main" id="{499A2693-D878-2253-1439-ED993C1F2AD5}"/>
               </a:ext>
             </a:extLst>
           </p:cNvPr>
@@ -32527,7 +32508,7 @@
           <p:cNvPr id="20" name="TextBox 19">
             <a:extLst>
               <a:ext uri="{FF2B5EF4-FFF2-40B4-BE49-F238E27FC236}">
-                <ns2:creationId id="{328F02D2-95BB-4767-7DBC-B06A0A6115E7}"/>
+                <a16:creationId xmlns:a16="http://schemas.microsoft.com/office/drawing/2014/main" id="{328F02D2-95BB-4767-7DBC-B06A0A6115E7}"/>
               </a:ext>
             </a:extLst>
           </p:cNvPr>
@@ -32574,7 +32555,7 @@
           <p:cNvPr id="21" name="TextBox 20">
             <a:extLst>
               <a:ext uri="{FF2B5EF4-FFF2-40B4-BE49-F238E27FC236}">
-                <ns2:creationId id="{5C915F9D-42F7-1C6D-E114-D633D6E4C109}"/>
+                <a16:creationId xmlns:a16="http://schemas.microsoft.com/office/drawing/2014/main" id="{5C915F9D-42F7-1C6D-E114-D633D6E4C109}"/>
               </a:ext>
             </a:extLst>
           </p:cNvPr>
@@ -32621,7 +32602,7 @@
           <p:cNvPr id="22" name="TextBox 21">
             <a:extLst>
               <a:ext uri="{FF2B5EF4-FFF2-40B4-BE49-F238E27FC236}">
-                <ns2:creationId id="{82FA558D-A9BC-01CE-74CD-F383AA8AFB6C}"/>
+                <a16:creationId xmlns:a16="http://schemas.microsoft.com/office/drawing/2014/main" id="{82FA558D-A9BC-01CE-74CD-F383AA8AFB6C}"/>
               </a:ext>
             </a:extLst>
           </p:cNvPr>
@@ -32668,7 +32649,7 @@
           <p:cNvPr id="25" name="Rectangle 24">
             <a:extLst>
               <a:ext uri="{FF2B5EF4-FFF2-40B4-BE49-F238E27FC236}">
-                <ns2:creationId id="{B4DF9014-6E71-4887-15FC-288C0BE2E472}"/>
+                <a16:creationId xmlns:a16="http://schemas.microsoft.com/office/drawing/2014/main" id="{B4DF9014-6E71-4887-15FC-288C0BE2E472}"/>
               </a:ext>
             </a:extLst>
           </p:cNvPr>
@@ -32719,7 +32700,7 @@
           <p:cNvPr id="2" name="Group 1">
             <a:extLst>
               <a:ext uri="{FF2B5EF4-FFF2-40B4-BE49-F238E27FC236}">
-                <ns2:creationId id="{8513F8A2-0C1C-FA83-EB1D-12942054ECC6}"/>
+                <a16:creationId xmlns:a16="http://schemas.microsoft.com/office/drawing/2014/main" id="{8513F8A2-0C1C-FA83-EB1D-12942054ECC6}"/>
               </a:ext>
             </a:extLst>
           </p:cNvPr>
@@ -32739,7 +32720,7 @@
             <p:cNvPr id="3" name="Straight Arrow Connector 2">
               <a:extLst>
                 <a:ext uri="{FF2B5EF4-FFF2-40B4-BE49-F238E27FC236}">
-                  <ns2:creationId id="{F0E8E829-2926-9AC8-8FBE-CD87D209F5BD}"/>
+                  <a16:creationId xmlns:a16="http://schemas.microsoft.com/office/drawing/2014/main" id="{F0E8E829-2926-9AC8-8FBE-CD87D209F5BD}"/>
                 </a:ext>
               </a:extLst>
             </p:cNvPr>
@@ -32783,7 +32764,7 @@
             <p:cNvPr id="4" name="Straight Arrow Connector 3">
               <a:extLst>
                 <a:ext uri="{FF2B5EF4-FFF2-40B4-BE49-F238E27FC236}">
-                  <ns2:creationId id="{D50F6F6C-E0DD-959D-833A-36F07808AC1D}"/>
+                  <a16:creationId xmlns:a16="http://schemas.microsoft.com/office/drawing/2014/main" id="{D50F6F6C-E0DD-959D-833A-36F07808AC1D}"/>
                 </a:ext>
               </a:extLst>
             </p:cNvPr>
@@ -32827,7 +32808,7 @@
             <p:cNvPr id="5" name="TextBox 4">
               <a:extLst>
                 <a:ext uri="{FF2B5EF4-FFF2-40B4-BE49-F238E27FC236}">
-                  <ns2:creationId id="{EDB020C7-9F2F-9DAE-DC6F-0F4AB0106806}"/>
+                  <a16:creationId xmlns:a16="http://schemas.microsoft.com/office/drawing/2014/main" id="{EDB020C7-9F2F-9DAE-DC6F-0F4AB0106806}"/>
                 </a:ext>
               </a:extLst>
             </p:cNvPr>
@@ -32892,7 +32873,7 @@
             <p:cNvPr id="8" name="TextBox 7">
               <a:extLst>
                 <a:ext uri="{FF2B5EF4-FFF2-40B4-BE49-F238E27FC236}">
-                  <ns2:creationId id="{9833DACC-1D55-AD72-1025-41BEFCBBEFC1}"/>
+                  <a16:creationId xmlns:a16="http://schemas.microsoft.com/office/drawing/2014/main" id="{9833DACC-1D55-AD72-1025-41BEFCBBEFC1}"/>
                 </a:ext>
               </a:extLst>
             </p:cNvPr>
@@ -32952,7 +32933,7 @@
     </p:spTree>
     <p:extLst>
       <p:ext uri="{BB962C8B-B14F-4D97-AF65-F5344CB8AC3E}">
-        <p14:creationId val="2649229030"/>
+        <p14:creationId xmlns:p14="http://schemas.microsoft.com/office/powerpoint/2010/main" val="2649229030"/>
       </p:ext>
     </p:extLst>
   </p:cSld>

</xml_diff>